<commit_message>
Add browser drawing demo
</commit_message>
<xml_diff>
--- a/slides/LeNet5_MNIST_Final_Presentation.pptx
+++ b/slides/LeNet5_MNIST_Final_Presentation.pptx
@@ -2,25 +2,25 @@
 <file path=ppt/presentation.xml><?xml version="1.0" encoding="utf-8"?>
 <p:presentation xmlns:p="http://schemas.openxmlformats.org/presentationml/2006/main">
   <p:sldMasterIdLst>
-    <p:sldMasterId xmlns:r="http://schemas.openxmlformats.org/officeDocument/2006/relationships" id="2147483648" r:id="Rcc7e70377ee14718"/>
+    <p:sldMasterId xmlns:r="http://schemas.openxmlformats.org/officeDocument/2006/relationships" id="2147483648" r:id="Rada07523e85c457e"/>
   </p:sldMasterIdLst>
   <p:notesMasterIdLst>
-    <p:notesMasterId xmlns:r="http://schemas.openxmlformats.org/officeDocument/2006/relationships" r:id="Rc7ad4b66c07d48fc"/>
+    <p:notesMasterId xmlns:r="http://schemas.openxmlformats.org/officeDocument/2006/relationships" r:id="R9550e05fa7b64054"/>
   </p:notesMasterIdLst>
   <p:sldIdLst>
-    <p:sldId xmlns:r="http://schemas.openxmlformats.org/officeDocument/2006/relationships" id="256" r:id="R1b1f351ef2914bae"/>
-    <p:sldId xmlns:r="http://schemas.openxmlformats.org/officeDocument/2006/relationships" id="257" r:id="R48757925cba94c8f"/>
-    <p:sldId xmlns:r="http://schemas.openxmlformats.org/officeDocument/2006/relationships" id="258" r:id="R3d5b03e4079a4658"/>
-    <p:sldId xmlns:r="http://schemas.openxmlformats.org/officeDocument/2006/relationships" id="259" r:id="Raa1cc82abcae4a2e"/>
-    <p:sldId xmlns:r="http://schemas.openxmlformats.org/officeDocument/2006/relationships" id="260" r:id="R8482e4594a85487f"/>
-    <p:sldId xmlns:r="http://schemas.openxmlformats.org/officeDocument/2006/relationships" id="261" r:id="R4b8d3f3d88f04e90"/>
-    <p:sldId xmlns:r="http://schemas.openxmlformats.org/officeDocument/2006/relationships" id="262" r:id="R001421b68e95499e"/>
-    <p:sldId xmlns:r="http://schemas.openxmlformats.org/officeDocument/2006/relationships" id="263" r:id="R7d15c38258094f09"/>
-    <p:sldId xmlns:r="http://schemas.openxmlformats.org/officeDocument/2006/relationships" id="264" r:id="Rc5525b87f0084924"/>
-    <p:sldId xmlns:r="http://schemas.openxmlformats.org/officeDocument/2006/relationships" id="265" r:id="R3e9a32c13157492e"/>
-    <p:sldId xmlns:r="http://schemas.openxmlformats.org/officeDocument/2006/relationships" id="266" r:id="R7422282205c4442a"/>
-    <p:sldId xmlns:r="http://schemas.openxmlformats.org/officeDocument/2006/relationships" id="267" r:id="Ra9d84917ffe8418a"/>
-    <p:sldId xmlns:r="http://schemas.openxmlformats.org/officeDocument/2006/relationships" id="268" r:id="Rcd0e25d576024b0d"/>
+    <p:sldId xmlns:r="http://schemas.openxmlformats.org/officeDocument/2006/relationships" id="256" r:id="R246ce7b8331a4d55"/>
+    <p:sldId xmlns:r="http://schemas.openxmlformats.org/officeDocument/2006/relationships" id="257" r:id="R71c82db463d74fcb"/>
+    <p:sldId xmlns:r="http://schemas.openxmlformats.org/officeDocument/2006/relationships" id="258" r:id="R76a26f3823fe4a54"/>
+    <p:sldId xmlns:r="http://schemas.openxmlformats.org/officeDocument/2006/relationships" id="259" r:id="R7fe94bd2aa0449a0"/>
+    <p:sldId xmlns:r="http://schemas.openxmlformats.org/officeDocument/2006/relationships" id="260" r:id="Rd8ea24512a694285"/>
+    <p:sldId xmlns:r="http://schemas.openxmlformats.org/officeDocument/2006/relationships" id="261" r:id="Rde0bcd43d6a1446a"/>
+    <p:sldId xmlns:r="http://schemas.openxmlformats.org/officeDocument/2006/relationships" id="262" r:id="Rb1b36087e6104589"/>
+    <p:sldId xmlns:r="http://schemas.openxmlformats.org/officeDocument/2006/relationships" id="263" r:id="R4ac8299bb3af4579"/>
+    <p:sldId xmlns:r="http://schemas.openxmlformats.org/officeDocument/2006/relationships" id="264" r:id="R5cf8043fd6c34d19"/>
+    <p:sldId xmlns:r="http://schemas.openxmlformats.org/officeDocument/2006/relationships" id="265" r:id="R13cf87e8607d4b08"/>
+    <p:sldId xmlns:r="http://schemas.openxmlformats.org/officeDocument/2006/relationships" id="266" r:id="R8f61fdeade7a4d16"/>
+    <p:sldId xmlns:r="http://schemas.openxmlformats.org/officeDocument/2006/relationships" id="267" r:id="R68f5fe851a2f4d3e"/>
+    <p:sldId xmlns:r="http://schemas.openxmlformats.org/officeDocument/2006/relationships" id="268" r:id="R18d46bd81bad463c"/>
   </p:sldIdLst>
   <p:sldSz cx="12192000" cy="6858000"/>
   <p:notesSz cx="6858000" cy="9144000"/>
@@ -1405,7 +1405,7 @@
   </p:cSld>
   <p:clrMap bg1="lt1" tx1="dk1" bg2="lt2" tx2="dk2" accent1="accent1" accent2="accent2" accent3="accent3" accent4="accent4" accent5="accent5" accent6="accent6" hlink="hlink" folHlink="folHlink"/>
   <p:sldLayoutIdLst>
-    <p:sldLayoutId xmlns:r="http://schemas.openxmlformats.org/officeDocument/2006/relationships" id="2147483649" r:id="R9332254041c846af"/>
+    <p:sldLayoutId xmlns:r="http://schemas.openxmlformats.org/officeDocument/2006/relationships" id="2147483649" r:id="R6c4d625774c14951"/>
   </p:sldLayoutIdLst>
   <p:txStyles>
     <p:titleStyle>
@@ -1956,7 +1956,7 @@
           <p:cNvPr id="1" name="">
             <a:extLst xmlns:a="http://schemas.openxmlformats.org/drawingml/2006/main">
               <a:ext uri="{FF2B5EF4-FFF2-40B4-BE49-F238E27FC236}">
-                <a16:creationId xmlns:a16="http://schemas.microsoft.com/office/drawing/2014/main" id="{1255CD0A-D5A9-4B85-B7B3-12E94A22DD34}"/>
+                <a16:creationId xmlns:a16="http://schemas.microsoft.com/office/drawing/2014/main" id="{CA321EB7-462F-4768-9990-A65D8A440CC1}"/>
               </a:ext>
             </a:extLst>
           </p:cNvPr>
@@ -2006,7 +2006,7 @@
           <p:cNvPr id="2" name="">
             <a:extLst xmlns:a="http://schemas.openxmlformats.org/drawingml/2006/main">
               <a:ext uri="{FF2B5EF4-FFF2-40B4-BE49-F238E27FC236}">
-                <a16:creationId xmlns:a16="http://schemas.microsoft.com/office/drawing/2014/main" id="{ABF9D10A-1153-470C-9988-E6CFEB7CD0D4}"/>
+                <a16:creationId xmlns:a16="http://schemas.microsoft.com/office/drawing/2014/main" id="{EEEF2243-34CB-4693-A0C6-8BAC557A5A21}"/>
               </a:ext>
             </a:extLst>
           </p:cNvPr>
@@ -2056,7 +2056,7 @@
           <p:cNvPr id="3" name="">
             <a:extLst xmlns:a="http://schemas.openxmlformats.org/drawingml/2006/main">
               <a:ext uri="{FF2B5EF4-FFF2-40B4-BE49-F238E27FC236}">
-                <a16:creationId xmlns:a16="http://schemas.microsoft.com/office/drawing/2014/main" id="{B583FEFC-7D6A-4DD8-AEAE-1C2F0ABA4287}"/>
+                <a16:creationId xmlns:a16="http://schemas.microsoft.com/office/drawing/2014/main" id="{8D549F43-AA45-4187-8B98-8B13772DD3FE}"/>
               </a:ext>
             </a:extLst>
           </p:cNvPr>
@@ -2089,7 +2089,7 @@
           <p:cNvPr id="4" name="">
             <a:extLst xmlns:a="http://schemas.openxmlformats.org/drawingml/2006/main">
               <a:ext uri="{FF2B5EF4-FFF2-40B4-BE49-F238E27FC236}">
-                <a16:creationId xmlns:a16="http://schemas.microsoft.com/office/drawing/2014/main" id="{1D20D7F7-E8E7-4D4F-A1C4-8569BEA85FAC}"/>
+                <a16:creationId xmlns:a16="http://schemas.microsoft.com/office/drawing/2014/main" id="{FBD8B44B-7852-4F43-9AAC-2DA24368C333}"/>
               </a:ext>
             </a:extLst>
           </p:cNvPr>
@@ -2139,7 +2139,7 @@
           <p:cNvPr id="5" name="">
             <a:extLst xmlns:a="http://schemas.openxmlformats.org/drawingml/2006/main">
               <a:ext uri="{FF2B5EF4-FFF2-40B4-BE49-F238E27FC236}">
-                <a16:creationId xmlns:a16="http://schemas.microsoft.com/office/drawing/2014/main" id="{8066533B-330E-4EF1-A560-BCF6B773290F}"/>
+                <a16:creationId xmlns:a16="http://schemas.microsoft.com/office/drawing/2014/main" id="{CB84E18B-3D87-4462-A543-9CF61B7963A7}"/>
               </a:ext>
             </a:extLst>
           </p:cNvPr>
@@ -2189,7 +2189,7 @@
           <p:cNvPr id="6" name="">
             <a:extLst xmlns:a="http://schemas.openxmlformats.org/drawingml/2006/main">
               <a:ext uri="{FF2B5EF4-FFF2-40B4-BE49-F238E27FC236}">
-                <a16:creationId xmlns:a16="http://schemas.microsoft.com/office/drawing/2014/main" id="{953710D4-AE2B-4D07-B78D-25DE28A85886}"/>
+                <a16:creationId xmlns:a16="http://schemas.microsoft.com/office/drawing/2014/main" id="{0FC98980-7F45-49E7-95A7-6A1B5ABEA8AE}"/>
               </a:ext>
             </a:extLst>
           </p:cNvPr>
@@ -2222,7 +2222,7 @@
           <p:cNvPr id="7" name="">
             <a:extLst xmlns:a="http://schemas.openxmlformats.org/drawingml/2006/main">
               <a:ext uri="{FF2B5EF4-FFF2-40B4-BE49-F238E27FC236}">
-                <a16:creationId xmlns:a16="http://schemas.microsoft.com/office/drawing/2014/main" id="{ACCCE256-0E07-43B0-97EA-F21979B59A56}"/>
+                <a16:creationId xmlns:a16="http://schemas.microsoft.com/office/drawing/2014/main" id="{79C5819F-30D2-4C46-9267-CFAA56ABFD25}"/>
               </a:ext>
             </a:extLst>
           </p:cNvPr>
@@ -2272,7 +2272,7 @@
           <p:cNvPr id="8" name="">
             <a:extLst xmlns:a="http://schemas.openxmlformats.org/drawingml/2006/main">
               <a:ext uri="{FF2B5EF4-FFF2-40B4-BE49-F238E27FC236}">
-                <a16:creationId xmlns:a16="http://schemas.microsoft.com/office/drawing/2014/main" id="{53ACCF64-3ADF-42C5-8579-ECA4309AFBAE}"/>
+                <a16:creationId xmlns:a16="http://schemas.microsoft.com/office/drawing/2014/main" id="{68734BCA-AE56-47B9-8AAF-6EF722360B62}"/>
               </a:ext>
             </a:extLst>
           </p:cNvPr>
@@ -2322,7 +2322,7 @@
           <p:cNvPr id="9" name="">
             <a:extLst xmlns:a="http://schemas.openxmlformats.org/drawingml/2006/main">
               <a:ext uri="{FF2B5EF4-FFF2-40B4-BE49-F238E27FC236}">
-                <a16:creationId xmlns:a16="http://schemas.microsoft.com/office/drawing/2014/main" id="{9EBF6197-9107-4B88-8D10-E61C4597EE20}"/>
+                <a16:creationId xmlns:a16="http://schemas.microsoft.com/office/drawing/2014/main" id="{71E24105-876B-41CF-B33A-CFB0BA96D3BF}"/>
               </a:ext>
             </a:extLst>
           </p:cNvPr>
@@ -2355,7 +2355,7 @@
           <p:cNvPr id="10" name="">
             <a:extLst xmlns:a="http://schemas.openxmlformats.org/drawingml/2006/main">
               <a:ext uri="{FF2B5EF4-FFF2-40B4-BE49-F238E27FC236}">
-                <a16:creationId xmlns:a16="http://schemas.microsoft.com/office/drawing/2014/main" id="{360A067E-8BA4-4CF5-8D5C-46FE13F1D8F4}"/>
+                <a16:creationId xmlns:a16="http://schemas.microsoft.com/office/drawing/2014/main" id="{81EA7C61-BA57-42E1-9543-815F90C79EB9}"/>
               </a:ext>
             </a:extLst>
           </p:cNvPr>
@@ -2405,7 +2405,7 @@
           <p:cNvPr id="11" name="">
             <a:extLst xmlns:a="http://schemas.openxmlformats.org/drawingml/2006/main">
               <a:ext uri="{FF2B5EF4-FFF2-40B4-BE49-F238E27FC236}">
-                <a16:creationId xmlns:a16="http://schemas.microsoft.com/office/drawing/2014/main" id="{042D885D-0E06-449B-B6D2-FFC8EBE7AA29}"/>
+                <a16:creationId xmlns:a16="http://schemas.microsoft.com/office/drawing/2014/main" id="{06CE18B3-5174-424D-A2C4-DE186D570030}"/>
               </a:ext>
             </a:extLst>
           </p:cNvPr>
@@ -2455,7 +2455,7 @@
           <p:cNvPr id="12" name="">
             <a:extLst xmlns:a="http://schemas.openxmlformats.org/drawingml/2006/main">
               <a:ext uri="{FF2B5EF4-FFF2-40B4-BE49-F238E27FC236}">
-                <a16:creationId xmlns:a16="http://schemas.microsoft.com/office/drawing/2014/main" id="{0C9EA5EF-7039-4937-AEEA-71CEAFDE309D}"/>
+                <a16:creationId xmlns:a16="http://schemas.microsoft.com/office/drawing/2014/main" id="{C5B8FEDF-F995-4B3C-B70E-51A0B16F6B4C}"/>
               </a:ext>
             </a:extLst>
           </p:cNvPr>
@@ -2505,7 +2505,7 @@
           <p:cNvPr id="13" name="">
             <a:extLst xmlns:a="http://schemas.openxmlformats.org/drawingml/2006/main">
               <a:ext uri="{FF2B5EF4-FFF2-40B4-BE49-F238E27FC236}">
-                <a16:creationId xmlns:a16="http://schemas.microsoft.com/office/drawing/2014/main" id="{88FDA5A0-348C-41F3-A32D-FA1A9452FE44}"/>
+                <a16:creationId xmlns:a16="http://schemas.microsoft.com/office/drawing/2014/main" id="{C71D19BF-2B95-4A26-9C57-F37BA022A1A8}"/>
               </a:ext>
             </a:extLst>
           </p:cNvPr>
@@ -2553,7 +2553,7 @@
     </p:spTree>
     <p:extLst>
       <p:ext uri="{BB962C8B-B14F-4D97-AF65-F5344CB8AC3E}">
-        <p14:creationId xmlns:p14="http://schemas.microsoft.com/office/powerpoint/2010/main" val="1254854177"/>
+        <p14:creationId xmlns:p14="http://schemas.microsoft.com/office/powerpoint/2010/main" val="1520206390"/>
       </p:ext>
     </p:extLst>
   </p:cSld>
@@ -2584,7 +2584,7 @@
           <p:cNvPr id="1" name="">
             <a:extLst xmlns:a="http://schemas.openxmlformats.org/drawingml/2006/main">
               <a:ext uri="{FF2B5EF4-FFF2-40B4-BE49-F238E27FC236}">
-                <a16:creationId xmlns:a16="http://schemas.microsoft.com/office/drawing/2014/main" id="{35F009A5-0C8A-4B17-82BE-091A143C7757}"/>
+                <a16:creationId xmlns:a16="http://schemas.microsoft.com/office/drawing/2014/main" id="{CF974068-6E18-42F1-96EB-16DDFF53D610}"/>
               </a:ext>
             </a:extLst>
           </p:cNvPr>
@@ -2634,7 +2634,7 @@
           <p:cNvPr id="2" name="">
             <a:extLst xmlns:a="http://schemas.openxmlformats.org/drawingml/2006/main">
               <a:ext uri="{FF2B5EF4-FFF2-40B4-BE49-F238E27FC236}">
-                <a16:creationId xmlns:a16="http://schemas.microsoft.com/office/drawing/2014/main" id="{C2678B91-A519-43B7-9AEB-11912CBB9A77}"/>
+                <a16:creationId xmlns:a16="http://schemas.microsoft.com/office/drawing/2014/main" id="{21D73B57-D949-48A4-B8BD-B92E7D3514DE}"/>
               </a:ext>
             </a:extLst>
           </p:cNvPr>
@@ -2684,7 +2684,7 @@
           <p:cNvPr id="3" name="">
             <a:extLst xmlns:a="http://schemas.openxmlformats.org/drawingml/2006/main">
               <a:ext uri="{FF2B5EF4-FFF2-40B4-BE49-F238E27FC236}">
-                <a16:creationId xmlns:a16="http://schemas.microsoft.com/office/drawing/2014/main" id="{D38D92CB-14B2-44C6-B72B-C556C0E65FEB}"/>
+                <a16:creationId xmlns:a16="http://schemas.microsoft.com/office/drawing/2014/main" id="{114F0850-5F44-4A49-938F-F971F8645877}"/>
               </a:ext>
             </a:extLst>
           </p:cNvPr>
@@ -2717,7 +2717,7 @@
           <p:cNvPr id="4" name="">
             <a:extLst xmlns:a="http://schemas.openxmlformats.org/drawingml/2006/main">
               <a:ext uri="{FF2B5EF4-FFF2-40B4-BE49-F238E27FC236}">
-                <a16:creationId xmlns:a16="http://schemas.microsoft.com/office/drawing/2014/main" id="{812959AB-D89F-4640-8379-705B95A998C6}"/>
+                <a16:creationId xmlns:a16="http://schemas.microsoft.com/office/drawing/2014/main" id="{58602F05-0786-4F40-A3A6-7489A967B4D1}"/>
               </a:ext>
             </a:extLst>
           </p:cNvPr>
@@ -2750,7 +2750,7 @@
           <p:cNvPr id="5" name="">
             <a:extLst xmlns:a="http://schemas.openxmlformats.org/drawingml/2006/main">
               <a:ext uri="{FF2B5EF4-FFF2-40B4-BE49-F238E27FC236}">
-                <a16:creationId xmlns:a16="http://schemas.microsoft.com/office/drawing/2014/main" id="{A15ED9CD-D64B-4679-B0FA-6E17761B7876}"/>
+                <a16:creationId xmlns:a16="http://schemas.microsoft.com/office/drawing/2014/main" id="{33474942-66D0-41AA-ADF1-7602A41B12A0}"/>
               </a:ext>
             </a:extLst>
           </p:cNvPr>
@@ -2800,7 +2800,7 @@
           <p:cNvPr id="6" name="">
             <a:extLst xmlns:a="http://schemas.openxmlformats.org/drawingml/2006/main">
               <a:ext uri="{FF2B5EF4-FFF2-40B4-BE49-F238E27FC236}">
-                <a16:creationId xmlns:a16="http://schemas.microsoft.com/office/drawing/2014/main" id="{84C29A45-365F-497E-A3B5-4B35249DD206}"/>
+                <a16:creationId xmlns:a16="http://schemas.microsoft.com/office/drawing/2014/main" id="{94D75A44-6620-4CCC-9239-6097664C72E7}"/>
               </a:ext>
             </a:extLst>
           </p:cNvPr>
@@ -2850,7 +2850,7 @@
           <p:cNvPr id="7" name="">
             <a:extLst xmlns:a="http://schemas.openxmlformats.org/drawingml/2006/main">
               <a:ext uri="{FF2B5EF4-FFF2-40B4-BE49-F238E27FC236}">
-                <a16:creationId xmlns:a16="http://schemas.microsoft.com/office/drawing/2014/main" id="{1BFE01EF-6059-4A98-BC3D-CFA01951BCE5}"/>
+                <a16:creationId xmlns:a16="http://schemas.microsoft.com/office/drawing/2014/main" id="{5EA16E75-C39F-4844-B45B-A18E31B97900}"/>
               </a:ext>
             </a:extLst>
           </p:cNvPr>
@@ -2883,7 +2883,7 @@
           <p:cNvPr id="8" name="">
             <a:extLst xmlns:a="http://schemas.openxmlformats.org/drawingml/2006/main">
               <a:ext uri="{FF2B5EF4-FFF2-40B4-BE49-F238E27FC236}">
-                <a16:creationId xmlns:a16="http://schemas.microsoft.com/office/drawing/2014/main" id="{51162231-88A1-4933-94CE-6F4769B6B321}"/>
+                <a16:creationId xmlns:a16="http://schemas.microsoft.com/office/drawing/2014/main" id="{7E63044A-EC9E-4821-909A-046EB5CA53E0}"/>
               </a:ext>
             </a:extLst>
           </p:cNvPr>
@@ -2933,7 +2933,7 @@
           <p:cNvPr id="9" name="">
             <a:extLst xmlns:a="http://schemas.openxmlformats.org/drawingml/2006/main">
               <a:ext uri="{FF2B5EF4-FFF2-40B4-BE49-F238E27FC236}">
-                <a16:creationId xmlns:a16="http://schemas.microsoft.com/office/drawing/2014/main" id="{6192DF83-05F9-49F2-AD7F-37AB943D2C7B}"/>
+                <a16:creationId xmlns:a16="http://schemas.microsoft.com/office/drawing/2014/main" id="{86BD3D12-FC48-4505-992F-93DEFAE666E6}"/>
               </a:ext>
             </a:extLst>
           </p:cNvPr>
@@ -2983,7 +2983,7 @@
           <p:cNvPr id="10" name="">
             <a:extLst xmlns:a="http://schemas.openxmlformats.org/drawingml/2006/main">
               <a:ext uri="{FF2B5EF4-FFF2-40B4-BE49-F238E27FC236}">
-                <a16:creationId xmlns:a16="http://schemas.microsoft.com/office/drawing/2014/main" id="{22497BED-20E3-4F69-8814-FD4BD7BF8F88}"/>
+                <a16:creationId xmlns:a16="http://schemas.microsoft.com/office/drawing/2014/main" id="{7DCC5B4C-85B1-475B-825A-D21544875ADA}"/>
               </a:ext>
             </a:extLst>
           </p:cNvPr>
@@ -3033,7 +3033,7 @@
           <p:cNvPr id="11" name="">
             <a:extLst xmlns:a="http://schemas.openxmlformats.org/drawingml/2006/main">
               <a:ext uri="{FF2B5EF4-FFF2-40B4-BE49-F238E27FC236}">
-                <a16:creationId xmlns:a16="http://schemas.microsoft.com/office/drawing/2014/main" id="{DF7D7B92-F0D9-4D8B-BFEA-BFCD459038D1}"/>
+                <a16:creationId xmlns:a16="http://schemas.microsoft.com/office/drawing/2014/main" id="{3A1B3767-2091-45BD-9844-4151905591B2}"/>
               </a:ext>
             </a:extLst>
           </p:cNvPr>
@@ -3081,7 +3081,7 @@
     </p:spTree>
     <p:extLst>
       <p:ext uri="{BB962C8B-B14F-4D97-AF65-F5344CB8AC3E}">
-        <p14:creationId xmlns:p14="http://schemas.microsoft.com/office/powerpoint/2010/main" val="1898789556"/>
+        <p14:creationId xmlns:p14="http://schemas.microsoft.com/office/powerpoint/2010/main" val="622159740"/>
       </p:ext>
     </p:extLst>
   </p:cSld>
@@ -3112,7 +3112,7 @@
           <p:cNvPr id="1" name="">
             <a:extLst xmlns:a="http://schemas.openxmlformats.org/drawingml/2006/main">
               <a:ext uri="{FF2B5EF4-FFF2-40B4-BE49-F238E27FC236}">
-                <a16:creationId xmlns:a16="http://schemas.microsoft.com/office/drawing/2014/main" id="{CB97E1FD-06C5-4AE1-AEEC-7C3B37340B0A}"/>
+                <a16:creationId xmlns:a16="http://schemas.microsoft.com/office/drawing/2014/main" id="{B0B9A5F5-CD8F-4247-B34B-23EB393F1CD3}"/>
               </a:ext>
             </a:extLst>
           </p:cNvPr>
@@ -3162,7 +3162,7 @@
           <p:cNvPr id="2" name="">
             <a:extLst xmlns:a="http://schemas.openxmlformats.org/drawingml/2006/main">
               <a:ext uri="{FF2B5EF4-FFF2-40B4-BE49-F238E27FC236}">
-                <a16:creationId xmlns:a16="http://schemas.microsoft.com/office/drawing/2014/main" id="{36FCA902-E7D7-47F4-A1C3-8AEA79C63C0F}"/>
+                <a16:creationId xmlns:a16="http://schemas.microsoft.com/office/drawing/2014/main" id="{EA06590F-7474-4A2A-B727-63BE696697B5}"/>
               </a:ext>
             </a:extLst>
           </p:cNvPr>
@@ -3212,7 +3212,7 @@
           <p:cNvPr id="3" name="">
             <a:extLst xmlns:a="http://schemas.openxmlformats.org/drawingml/2006/main">
               <a:ext uri="{FF2B5EF4-FFF2-40B4-BE49-F238E27FC236}">
-                <a16:creationId xmlns:a16="http://schemas.microsoft.com/office/drawing/2014/main" id="{7D35B2AC-45C7-4314-A9B4-6D63D6A1B10A}"/>
+                <a16:creationId xmlns:a16="http://schemas.microsoft.com/office/drawing/2014/main" id="{A7A71BCA-409A-4587-8CDA-4A828FBC455B}"/>
               </a:ext>
             </a:extLst>
           </p:cNvPr>
@@ -3245,7 +3245,7 @@
           <p:cNvPr id="4" name="">
             <a:extLst xmlns:a="http://schemas.openxmlformats.org/drawingml/2006/main">
               <a:ext uri="{FF2B5EF4-FFF2-40B4-BE49-F238E27FC236}">
-                <a16:creationId xmlns:a16="http://schemas.microsoft.com/office/drawing/2014/main" id="{80C1C19D-4F47-4693-9743-82644475760B}"/>
+                <a16:creationId xmlns:a16="http://schemas.microsoft.com/office/drawing/2014/main" id="{9E5415E8-4817-47B8-8180-6ECAE7A02F1B}"/>
               </a:ext>
             </a:extLst>
           </p:cNvPr>
@@ -3278,7 +3278,7 @@
           <p:cNvPr id="5" name="">
             <a:extLst xmlns:a="http://schemas.openxmlformats.org/drawingml/2006/main">
               <a:ext uri="{FF2B5EF4-FFF2-40B4-BE49-F238E27FC236}">
-                <a16:creationId xmlns:a16="http://schemas.microsoft.com/office/drawing/2014/main" id="{4CF7C7D6-A167-4070-92CA-F1D551C91BCB}"/>
+                <a16:creationId xmlns:a16="http://schemas.microsoft.com/office/drawing/2014/main" id="{2D7E14B8-3C6A-4453-B9F3-8DDF66BFD24F}"/>
               </a:ext>
             </a:extLst>
           </p:cNvPr>
@@ -3328,7 +3328,7 @@
           <p:cNvPr id="6" name="">
             <a:extLst xmlns:a="http://schemas.openxmlformats.org/drawingml/2006/main">
               <a:ext uri="{FF2B5EF4-FFF2-40B4-BE49-F238E27FC236}">
-                <a16:creationId xmlns:a16="http://schemas.microsoft.com/office/drawing/2014/main" id="{75A8AFDB-3385-4F3B-8120-52623B5E9248}"/>
+                <a16:creationId xmlns:a16="http://schemas.microsoft.com/office/drawing/2014/main" id="{B4A80107-CBB4-4423-AA67-5036FD6E3D62}"/>
               </a:ext>
             </a:extLst>
           </p:cNvPr>
@@ -3446,7 +3446,7 @@
           <p:cNvPr id="7" name="">
             <a:extLst xmlns:a="http://schemas.openxmlformats.org/drawingml/2006/main">
               <a:ext uri="{FF2B5EF4-FFF2-40B4-BE49-F238E27FC236}">
-                <a16:creationId xmlns:a16="http://schemas.microsoft.com/office/drawing/2014/main" id="{AF2B0D3F-60CB-4F5C-8C19-CD1DDD0C2A96}"/>
+                <a16:creationId xmlns:a16="http://schemas.microsoft.com/office/drawing/2014/main" id="{556F457D-C87F-45F4-8151-FE0BA5A3C2FD}"/>
               </a:ext>
             </a:extLst>
           </p:cNvPr>
@@ -3479,7 +3479,7 @@
           <p:cNvPr id="8" name="">
             <a:extLst xmlns:a="http://schemas.openxmlformats.org/drawingml/2006/main">
               <a:ext uri="{FF2B5EF4-FFF2-40B4-BE49-F238E27FC236}">
-                <a16:creationId xmlns:a16="http://schemas.microsoft.com/office/drawing/2014/main" id="{8DBE3D7D-22DD-4EFF-B9DD-AD817D036149}"/>
+                <a16:creationId xmlns:a16="http://schemas.microsoft.com/office/drawing/2014/main" id="{94412DD7-6FA3-43A3-B5CA-9AF1ABBD558B}"/>
               </a:ext>
             </a:extLst>
           </p:cNvPr>
@@ -3529,7 +3529,7 @@
           <p:cNvPr id="9" name="">
             <a:extLst xmlns:a="http://schemas.openxmlformats.org/drawingml/2006/main">
               <a:ext uri="{FF2B5EF4-FFF2-40B4-BE49-F238E27FC236}">
-                <a16:creationId xmlns:a16="http://schemas.microsoft.com/office/drawing/2014/main" id="{A42D839A-1718-4C99-B065-2A3F0188B186}"/>
+                <a16:creationId xmlns:a16="http://schemas.microsoft.com/office/drawing/2014/main" id="{B62A897D-E7AE-41A5-9408-32F3D00DE7E6}"/>
               </a:ext>
             </a:extLst>
           </p:cNvPr>
@@ -3647,7 +3647,7 @@
           <p:cNvPr id="10" name="">
             <a:extLst xmlns:a="http://schemas.openxmlformats.org/drawingml/2006/main">
               <a:ext uri="{FF2B5EF4-FFF2-40B4-BE49-F238E27FC236}">
-                <a16:creationId xmlns:a16="http://schemas.microsoft.com/office/drawing/2014/main" id="{A6A7E8B2-3380-40F6-9F38-305D18677C11}"/>
+                <a16:creationId xmlns:a16="http://schemas.microsoft.com/office/drawing/2014/main" id="{CC2DA818-9538-4453-8470-A954D3A90204}"/>
               </a:ext>
             </a:extLst>
           </p:cNvPr>
@@ -3680,7 +3680,7 @@
           <p:cNvPr id="11" name="">
             <a:extLst xmlns:a="http://schemas.openxmlformats.org/drawingml/2006/main">
               <a:ext uri="{FF2B5EF4-FFF2-40B4-BE49-F238E27FC236}">
-                <a16:creationId xmlns:a16="http://schemas.microsoft.com/office/drawing/2014/main" id="{485D6B50-E826-4469-B51E-4568A3CA9577}"/>
+                <a16:creationId xmlns:a16="http://schemas.microsoft.com/office/drawing/2014/main" id="{DF1CC17A-204A-4F54-BC35-B7A4967B03B7}"/>
               </a:ext>
             </a:extLst>
           </p:cNvPr>
@@ -3730,7 +3730,7 @@
           <p:cNvPr id="12" name="">
             <a:extLst xmlns:a="http://schemas.openxmlformats.org/drawingml/2006/main">
               <a:ext uri="{FF2B5EF4-FFF2-40B4-BE49-F238E27FC236}">
-                <a16:creationId xmlns:a16="http://schemas.microsoft.com/office/drawing/2014/main" id="{21F80330-8BCA-4F82-A3E9-0A5D9FAD1E55}"/>
+                <a16:creationId xmlns:a16="http://schemas.microsoft.com/office/drawing/2014/main" id="{197F8E9B-02E7-41B3-BDFC-F212815C9467}"/>
               </a:ext>
             </a:extLst>
           </p:cNvPr>
@@ -3848,7 +3848,7 @@
           <p:cNvPr id="13" name="">
             <a:extLst xmlns:a="http://schemas.openxmlformats.org/drawingml/2006/main">
               <a:ext uri="{FF2B5EF4-FFF2-40B4-BE49-F238E27FC236}">
-                <a16:creationId xmlns:a16="http://schemas.microsoft.com/office/drawing/2014/main" id="{3C6044E8-0EC7-4662-B6D7-02284AE81463}"/>
+                <a16:creationId xmlns:a16="http://schemas.microsoft.com/office/drawing/2014/main" id="{26E756B2-2F4F-45AF-B55B-7367B2D8A18D}"/>
               </a:ext>
             </a:extLst>
           </p:cNvPr>
@@ -3896,7 +3896,7 @@
     </p:spTree>
     <p:extLst>
       <p:ext uri="{BB962C8B-B14F-4D97-AF65-F5344CB8AC3E}">
-        <p14:creationId xmlns:p14="http://schemas.microsoft.com/office/powerpoint/2010/main" val="168129881"/>
+        <p14:creationId xmlns:p14="http://schemas.microsoft.com/office/powerpoint/2010/main" val="283246761"/>
       </p:ext>
     </p:extLst>
   </p:cSld>
@@ -3927,7 +3927,7 @@
           <p:cNvPr id="1" name="">
             <a:extLst xmlns:a="http://schemas.openxmlformats.org/drawingml/2006/main">
               <a:ext uri="{FF2B5EF4-FFF2-40B4-BE49-F238E27FC236}">
-                <a16:creationId xmlns:a16="http://schemas.microsoft.com/office/drawing/2014/main" id="{01BBD31E-00C1-4745-82C9-388ED3EEDA92}"/>
+                <a16:creationId xmlns:a16="http://schemas.microsoft.com/office/drawing/2014/main" id="{9E2E138F-D710-4C90-9BD0-D1AC031AFD45}"/>
               </a:ext>
             </a:extLst>
           </p:cNvPr>
@@ -3977,7 +3977,7 @@
           <p:cNvPr id="2" name="">
             <a:extLst xmlns:a="http://schemas.openxmlformats.org/drawingml/2006/main">
               <a:ext uri="{FF2B5EF4-FFF2-40B4-BE49-F238E27FC236}">
-                <a16:creationId xmlns:a16="http://schemas.microsoft.com/office/drawing/2014/main" id="{090B8951-974C-481D-96F7-0F7270F96A70}"/>
+                <a16:creationId xmlns:a16="http://schemas.microsoft.com/office/drawing/2014/main" id="{A19B7634-0B0E-4F5A-99A8-B0ADDD6CE34A}"/>
               </a:ext>
             </a:extLst>
           </p:cNvPr>
@@ -4027,7 +4027,7 @@
           <p:cNvPr id="3" name="">
             <a:extLst xmlns:a="http://schemas.openxmlformats.org/drawingml/2006/main">
               <a:ext uri="{FF2B5EF4-FFF2-40B4-BE49-F238E27FC236}">
-                <a16:creationId xmlns:a16="http://schemas.microsoft.com/office/drawing/2014/main" id="{988D5822-B4C6-4C01-A918-7B4833B1C92F}"/>
+                <a16:creationId xmlns:a16="http://schemas.microsoft.com/office/drawing/2014/main" id="{32E528A2-A933-45BB-8722-B5E705B7C00F}"/>
               </a:ext>
             </a:extLst>
           </p:cNvPr>
@@ -4060,7 +4060,7 @@
           <p:cNvPr id="4" name="">
             <a:extLst xmlns:a="http://schemas.openxmlformats.org/drawingml/2006/main">
               <a:ext uri="{FF2B5EF4-FFF2-40B4-BE49-F238E27FC236}">
-                <a16:creationId xmlns:a16="http://schemas.microsoft.com/office/drawing/2014/main" id="{F8DFEA1E-29C1-4009-8255-0A82F473FF66}"/>
+                <a16:creationId xmlns:a16="http://schemas.microsoft.com/office/drawing/2014/main" id="{DA49C6DA-6508-4DB9-95FD-2C8469AFACE5}"/>
               </a:ext>
             </a:extLst>
           </p:cNvPr>
@@ -4093,7 +4093,7 @@
           <p:cNvPr id="5" name="">
             <a:extLst xmlns:a="http://schemas.openxmlformats.org/drawingml/2006/main">
               <a:ext uri="{FF2B5EF4-FFF2-40B4-BE49-F238E27FC236}">
-                <a16:creationId xmlns:a16="http://schemas.microsoft.com/office/drawing/2014/main" id="{3011FF77-70D5-4B22-ABBD-BD2B7536AA82}"/>
+                <a16:creationId xmlns:a16="http://schemas.microsoft.com/office/drawing/2014/main" id="{C9B5AE81-1975-478D-865F-548BC078C14C}"/>
               </a:ext>
             </a:extLst>
           </p:cNvPr>
@@ -4143,7 +4143,7 @@
           <p:cNvPr id="6" name="">
             <a:extLst xmlns:a="http://schemas.openxmlformats.org/drawingml/2006/main">
               <a:ext uri="{FF2B5EF4-FFF2-40B4-BE49-F238E27FC236}">
-                <a16:creationId xmlns:a16="http://schemas.microsoft.com/office/drawing/2014/main" id="{A84D9A3E-D0D5-48A3-9EEA-796CE7066F58}"/>
+                <a16:creationId xmlns:a16="http://schemas.microsoft.com/office/drawing/2014/main" id="{DB5555DB-8823-47FD-A96B-00FE14BEAADC}"/>
               </a:ext>
             </a:extLst>
           </p:cNvPr>
@@ -4176,7 +4176,7 @@
           <p:cNvPr id="7" name="">
             <a:extLst xmlns:a="http://schemas.openxmlformats.org/drawingml/2006/main">
               <a:ext uri="{FF2B5EF4-FFF2-40B4-BE49-F238E27FC236}">
-                <a16:creationId xmlns:a16="http://schemas.microsoft.com/office/drawing/2014/main" id="{8648F2FC-F80F-4B58-92E8-EA283E1A7F24}"/>
+                <a16:creationId xmlns:a16="http://schemas.microsoft.com/office/drawing/2014/main" id="{0B6E9A61-D018-400D-A587-3EF201F01BDC}"/>
               </a:ext>
             </a:extLst>
           </p:cNvPr>
@@ -4226,7 +4226,7 @@
           <p:cNvPr id="8" name="">
             <a:extLst xmlns:a="http://schemas.openxmlformats.org/drawingml/2006/main">
               <a:ext uri="{FF2B5EF4-FFF2-40B4-BE49-F238E27FC236}">
-                <a16:creationId xmlns:a16="http://schemas.microsoft.com/office/drawing/2014/main" id="{7EBF9A03-8F16-46D1-BE2C-4AE2965F1246}"/>
+                <a16:creationId xmlns:a16="http://schemas.microsoft.com/office/drawing/2014/main" id="{333F4F27-4539-43F5-BE97-8C485D31332E}"/>
               </a:ext>
             </a:extLst>
           </p:cNvPr>
@@ -4259,7 +4259,7 @@
           <p:cNvPr id="9" name="">
             <a:extLst xmlns:a="http://schemas.openxmlformats.org/drawingml/2006/main">
               <a:ext uri="{FF2B5EF4-FFF2-40B4-BE49-F238E27FC236}">
-                <a16:creationId xmlns:a16="http://schemas.microsoft.com/office/drawing/2014/main" id="{7D6EE0B2-7EF4-42D0-898C-EC059E0E0A61}"/>
+                <a16:creationId xmlns:a16="http://schemas.microsoft.com/office/drawing/2014/main" id="{7D9EBE74-8BC7-443E-8D57-957E69FF9D62}"/>
               </a:ext>
             </a:extLst>
           </p:cNvPr>
@@ -4309,7 +4309,7 @@
           <p:cNvPr id="10" name="">
             <a:extLst xmlns:a="http://schemas.openxmlformats.org/drawingml/2006/main">
               <a:ext uri="{FF2B5EF4-FFF2-40B4-BE49-F238E27FC236}">
-                <a16:creationId xmlns:a16="http://schemas.microsoft.com/office/drawing/2014/main" id="{D168C72D-FCFB-40F4-9532-791526BA6E81}"/>
+                <a16:creationId xmlns:a16="http://schemas.microsoft.com/office/drawing/2014/main" id="{F8F84E13-A817-4E35-BC09-BD986686DB6F}"/>
               </a:ext>
             </a:extLst>
           </p:cNvPr>
@@ -4342,7 +4342,7 @@
           <p:cNvPr id="11" name="">
             <a:extLst xmlns:a="http://schemas.openxmlformats.org/drawingml/2006/main">
               <a:ext uri="{FF2B5EF4-FFF2-40B4-BE49-F238E27FC236}">
-                <a16:creationId xmlns:a16="http://schemas.microsoft.com/office/drawing/2014/main" id="{E92B2A79-7021-4B5F-9D5E-ACE97863AD09}"/>
+                <a16:creationId xmlns:a16="http://schemas.microsoft.com/office/drawing/2014/main" id="{775455E4-39BE-4B69-9F48-B56FD87DB4D7}"/>
               </a:ext>
             </a:extLst>
           </p:cNvPr>
@@ -4392,7 +4392,7 @@
           <p:cNvPr id="12" name="">
             <a:extLst xmlns:a="http://schemas.openxmlformats.org/drawingml/2006/main">
               <a:ext uri="{FF2B5EF4-FFF2-40B4-BE49-F238E27FC236}">
-                <a16:creationId xmlns:a16="http://schemas.microsoft.com/office/drawing/2014/main" id="{F97DE2FA-3E80-4004-AFC3-F8A43F1FAEBA}"/>
+                <a16:creationId xmlns:a16="http://schemas.microsoft.com/office/drawing/2014/main" id="{EDC9B4DA-9331-4004-BF32-A5CFC614E2AA}"/>
               </a:ext>
             </a:extLst>
           </p:cNvPr>
@@ -4425,7 +4425,7 @@
           <p:cNvPr id="13" name="">
             <a:extLst xmlns:a="http://schemas.openxmlformats.org/drawingml/2006/main">
               <a:ext uri="{FF2B5EF4-FFF2-40B4-BE49-F238E27FC236}">
-                <a16:creationId xmlns:a16="http://schemas.microsoft.com/office/drawing/2014/main" id="{C5BBEE8A-F5CC-4038-98E0-FF6D92C8DD92}"/>
+                <a16:creationId xmlns:a16="http://schemas.microsoft.com/office/drawing/2014/main" id="{FE3C2172-3952-46DE-8E1D-F2D68213D484}"/>
               </a:ext>
             </a:extLst>
           </p:cNvPr>
@@ -4475,7 +4475,7 @@
           <p:cNvPr id="14" name="">
             <a:extLst xmlns:a="http://schemas.openxmlformats.org/drawingml/2006/main">
               <a:ext uri="{FF2B5EF4-FFF2-40B4-BE49-F238E27FC236}">
-                <a16:creationId xmlns:a16="http://schemas.microsoft.com/office/drawing/2014/main" id="{46B0AA30-F5EB-4210-A8F0-F47899EA6489}"/>
+                <a16:creationId xmlns:a16="http://schemas.microsoft.com/office/drawing/2014/main" id="{7B72EB7C-CF2D-4C34-9937-E866AE1DE80E}"/>
               </a:ext>
             </a:extLst>
           </p:cNvPr>
@@ -4508,7 +4508,7 @@
           <p:cNvPr id="15" name="">
             <a:extLst xmlns:a="http://schemas.openxmlformats.org/drawingml/2006/main">
               <a:ext uri="{FF2B5EF4-FFF2-40B4-BE49-F238E27FC236}">
-                <a16:creationId xmlns:a16="http://schemas.microsoft.com/office/drawing/2014/main" id="{705A6217-C861-460F-930B-E142DE944AB1}"/>
+                <a16:creationId xmlns:a16="http://schemas.microsoft.com/office/drawing/2014/main" id="{89ED3887-FC93-4D5B-9222-DE4DCD811DB1}"/>
               </a:ext>
             </a:extLst>
           </p:cNvPr>
@@ -4558,7 +4558,7 @@
           <p:cNvPr id="16" name="">
             <a:extLst xmlns:a="http://schemas.openxmlformats.org/drawingml/2006/main">
               <a:ext uri="{FF2B5EF4-FFF2-40B4-BE49-F238E27FC236}">
-                <a16:creationId xmlns:a16="http://schemas.microsoft.com/office/drawing/2014/main" id="{10AB0B29-76A8-4A9E-8B89-FB27629C19F1}"/>
+                <a16:creationId xmlns:a16="http://schemas.microsoft.com/office/drawing/2014/main" id="{906FEAE9-2490-4ED3-A852-60972F4FE5AC}"/>
               </a:ext>
             </a:extLst>
           </p:cNvPr>
@@ -4591,7 +4591,7 @@
           <p:cNvPr id="17" name="">
             <a:extLst xmlns:a="http://schemas.openxmlformats.org/drawingml/2006/main">
               <a:ext uri="{FF2B5EF4-FFF2-40B4-BE49-F238E27FC236}">
-                <a16:creationId xmlns:a16="http://schemas.microsoft.com/office/drawing/2014/main" id="{88D5CA2F-3937-4A14-A8DA-EE7DA8906212}"/>
+                <a16:creationId xmlns:a16="http://schemas.microsoft.com/office/drawing/2014/main" id="{916D6AD4-65C7-4297-BEE3-EAADBB7BC1E9}"/>
               </a:ext>
             </a:extLst>
           </p:cNvPr>
@@ -4641,7 +4641,7 @@
           <p:cNvPr id="18" name="">
             <a:extLst xmlns:a="http://schemas.openxmlformats.org/drawingml/2006/main">
               <a:ext uri="{FF2B5EF4-FFF2-40B4-BE49-F238E27FC236}">
-                <a16:creationId xmlns:a16="http://schemas.microsoft.com/office/drawing/2014/main" id="{FF17ADC9-A5AA-48B2-8697-BA101C1F58D7}"/>
+                <a16:creationId xmlns:a16="http://schemas.microsoft.com/office/drawing/2014/main" id="{00CC6CB7-7316-4D6F-B935-DA7926BF94BD}"/>
               </a:ext>
             </a:extLst>
           </p:cNvPr>
@@ -4674,7 +4674,7 @@
           <p:cNvPr id="19" name="">
             <a:extLst xmlns:a="http://schemas.openxmlformats.org/drawingml/2006/main">
               <a:ext uri="{FF2B5EF4-FFF2-40B4-BE49-F238E27FC236}">
-                <a16:creationId xmlns:a16="http://schemas.microsoft.com/office/drawing/2014/main" id="{F9433388-D520-45ED-9B41-3570BD058061}"/>
+                <a16:creationId xmlns:a16="http://schemas.microsoft.com/office/drawing/2014/main" id="{20069FA2-1C54-46C1-AB4D-DEF100C8AB97}"/>
               </a:ext>
             </a:extLst>
           </p:cNvPr>
@@ -4724,7 +4724,7 @@
           <p:cNvPr id="20" name="">
             <a:extLst xmlns:a="http://schemas.openxmlformats.org/drawingml/2006/main">
               <a:ext uri="{FF2B5EF4-FFF2-40B4-BE49-F238E27FC236}">
-                <a16:creationId xmlns:a16="http://schemas.microsoft.com/office/drawing/2014/main" id="{14877C97-CEBE-45BC-882C-228CB2A6F16A}"/>
+                <a16:creationId xmlns:a16="http://schemas.microsoft.com/office/drawing/2014/main" id="{3F42D6EC-5AAF-4506-B82B-A34259CE700B}"/>
               </a:ext>
             </a:extLst>
           </p:cNvPr>
@@ -4774,7 +4774,7 @@
           <p:cNvPr id="21" name="">
             <a:extLst xmlns:a="http://schemas.openxmlformats.org/drawingml/2006/main">
               <a:ext uri="{FF2B5EF4-FFF2-40B4-BE49-F238E27FC236}">
-                <a16:creationId xmlns:a16="http://schemas.microsoft.com/office/drawing/2014/main" id="{C7312E07-3ED7-4770-B4B2-EE7722CAC882}"/>
+                <a16:creationId xmlns:a16="http://schemas.microsoft.com/office/drawing/2014/main" id="{9CD6ACE6-4793-4014-8015-6758B8CCCC78}"/>
               </a:ext>
             </a:extLst>
           </p:cNvPr>
@@ -4822,7 +4822,7 @@
     </p:spTree>
     <p:extLst>
       <p:ext uri="{BB962C8B-B14F-4D97-AF65-F5344CB8AC3E}">
-        <p14:creationId xmlns:p14="http://schemas.microsoft.com/office/powerpoint/2010/main" val="504519882"/>
+        <p14:creationId xmlns:p14="http://schemas.microsoft.com/office/powerpoint/2010/main" val="94459232"/>
       </p:ext>
     </p:extLst>
   </p:cSld>
@@ -4853,7 +4853,7 @@
           <p:cNvPr id="1" name="">
             <a:extLst xmlns:a="http://schemas.openxmlformats.org/drawingml/2006/main">
               <a:ext uri="{FF2B5EF4-FFF2-40B4-BE49-F238E27FC236}">
-                <a16:creationId xmlns:a16="http://schemas.microsoft.com/office/drawing/2014/main" id="{3DEE970B-3E41-4D45-BB8B-184FCC0922C9}"/>
+                <a16:creationId xmlns:a16="http://schemas.microsoft.com/office/drawing/2014/main" id="{E373A58B-2D86-4051-ADFB-505ADF1A2313}"/>
               </a:ext>
             </a:extLst>
           </p:cNvPr>
@@ -4903,7 +4903,7 @@
           <p:cNvPr id="2" name="">
             <a:extLst xmlns:a="http://schemas.openxmlformats.org/drawingml/2006/main">
               <a:ext uri="{FF2B5EF4-FFF2-40B4-BE49-F238E27FC236}">
-                <a16:creationId xmlns:a16="http://schemas.microsoft.com/office/drawing/2014/main" id="{79519E72-C27B-4725-819E-BD86583E4964}"/>
+                <a16:creationId xmlns:a16="http://schemas.microsoft.com/office/drawing/2014/main" id="{8D35F664-B14F-4361-A927-76A77FAE4B78}"/>
               </a:ext>
             </a:extLst>
           </p:cNvPr>
@@ -4953,7 +4953,7 @@
           <p:cNvPr id="3" name="">
             <a:extLst xmlns:a="http://schemas.openxmlformats.org/drawingml/2006/main">
               <a:ext uri="{FF2B5EF4-FFF2-40B4-BE49-F238E27FC236}">
-                <a16:creationId xmlns:a16="http://schemas.microsoft.com/office/drawing/2014/main" id="{FC0DAFCE-962B-4936-B97D-C7676EA264AF}"/>
+                <a16:creationId xmlns:a16="http://schemas.microsoft.com/office/drawing/2014/main" id="{13BEC01E-5F3E-49C8-8D7D-666AEABA24A7}"/>
               </a:ext>
             </a:extLst>
           </p:cNvPr>
@@ -4986,7 +4986,7 @@
           <p:cNvPr id="4" name="">
             <a:extLst xmlns:a="http://schemas.openxmlformats.org/drawingml/2006/main">
               <a:ext uri="{FF2B5EF4-FFF2-40B4-BE49-F238E27FC236}">
-                <a16:creationId xmlns:a16="http://schemas.microsoft.com/office/drawing/2014/main" id="{7A7BDB0A-6C98-49F5-BDC4-61FAB399E7C5}"/>
+                <a16:creationId xmlns:a16="http://schemas.microsoft.com/office/drawing/2014/main" id="{0E87D5B2-EB86-4463-B63D-705CEA3E99F0}"/>
               </a:ext>
             </a:extLst>
           </p:cNvPr>
@@ -5019,7 +5019,7 @@
           <p:cNvPr id="5" name="">
             <a:extLst xmlns:a="http://schemas.openxmlformats.org/drawingml/2006/main">
               <a:ext uri="{FF2B5EF4-FFF2-40B4-BE49-F238E27FC236}">
-                <a16:creationId xmlns:a16="http://schemas.microsoft.com/office/drawing/2014/main" id="{E4871063-46AC-4ADC-B9DB-F73ECA11328C}"/>
+                <a16:creationId xmlns:a16="http://schemas.microsoft.com/office/drawing/2014/main" id="{5D42813C-97C1-4EFB-B823-C9FCBA012636}"/>
               </a:ext>
             </a:extLst>
           </p:cNvPr>
@@ -5069,7 +5069,7 @@
           <p:cNvPr id="6" name="">
             <a:extLst xmlns:a="http://schemas.openxmlformats.org/drawingml/2006/main">
               <a:ext uri="{FF2B5EF4-FFF2-40B4-BE49-F238E27FC236}">
-                <a16:creationId xmlns:a16="http://schemas.microsoft.com/office/drawing/2014/main" id="{5E3A8C8E-CA6A-4DCD-BDD8-6594428D0B9F}"/>
+                <a16:creationId xmlns:a16="http://schemas.microsoft.com/office/drawing/2014/main" id="{B6FFC5E6-FD58-4881-A856-9255934DBDD1}"/>
               </a:ext>
             </a:extLst>
           </p:cNvPr>
@@ -5102,7 +5102,7 @@
           <p:cNvPr id="7" name="">
             <a:extLst xmlns:a="http://schemas.openxmlformats.org/drawingml/2006/main">
               <a:ext uri="{FF2B5EF4-FFF2-40B4-BE49-F238E27FC236}">
-                <a16:creationId xmlns:a16="http://schemas.microsoft.com/office/drawing/2014/main" id="{E7F136C6-5FDA-4F4E-92CE-EBFF7036D2F7}"/>
+                <a16:creationId xmlns:a16="http://schemas.microsoft.com/office/drawing/2014/main" id="{CF19FA09-66E2-4C8B-BA9B-5A5FD122210C}"/>
               </a:ext>
             </a:extLst>
           </p:cNvPr>
@@ -5152,7 +5152,7 @@
           <p:cNvPr id="8" name="">
             <a:extLst xmlns:a="http://schemas.openxmlformats.org/drawingml/2006/main">
               <a:ext uri="{FF2B5EF4-FFF2-40B4-BE49-F238E27FC236}">
-                <a16:creationId xmlns:a16="http://schemas.microsoft.com/office/drawing/2014/main" id="{1B7E8EC1-C984-4F9F-82CF-9B25C03228AF}"/>
+                <a16:creationId xmlns:a16="http://schemas.microsoft.com/office/drawing/2014/main" id="{2D6C37EB-90BC-44F3-ADD9-5480F6D193DC}"/>
               </a:ext>
             </a:extLst>
           </p:cNvPr>
@@ -5185,7 +5185,7 @@
           <p:cNvPr id="9" name="">
             <a:extLst xmlns:a="http://schemas.openxmlformats.org/drawingml/2006/main">
               <a:ext uri="{FF2B5EF4-FFF2-40B4-BE49-F238E27FC236}">
-                <a16:creationId xmlns:a16="http://schemas.microsoft.com/office/drawing/2014/main" id="{84EAA1DA-C39D-40C0-B423-CBBA3E09D0A2}"/>
+                <a16:creationId xmlns:a16="http://schemas.microsoft.com/office/drawing/2014/main" id="{C13E6DE6-A630-499F-881A-F181F27009FE}"/>
               </a:ext>
             </a:extLst>
           </p:cNvPr>
@@ -5235,7 +5235,7 @@
           <p:cNvPr id="10" name="">
             <a:extLst xmlns:a="http://schemas.openxmlformats.org/drawingml/2006/main">
               <a:ext uri="{FF2B5EF4-FFF2-40B4-BE49-F238E27FC236}">
-                <a16:creationId xmlns:a16="http://schemas.microsoft.com/office/drawing/2014/main" id="{71CB3461-03FC-46D7-A3C7-6606A6982056}"/>
+                <a16:creationId xmlns:a16="http://schemas.microsoft.com/office/drawing/2014/main" id="{C369281C-0B5D-426A-9EE7-5E4389C36902}"/>
               </a:ext>
             </a:extLst>
           </p:cNvPr>
@@ -5268,7 +5268,7 @@
           <p:cNvPr id="11" name="">
             <a:extLst xmlns:a="http://schemas.openxmlformats.org/drawingml/2006/main">
               <a:ext uri="{FF2B5EF4-FFF2-40B4-BE49-F238E27FC236}">
-                <a16:creationId xmlns:a16="http://schemas.microsoft.com/office/drawing/2014/main" id="{A7C3CD42-1021-4BE0-860A-EA37DFB33223}"/>
+                <a16:creationId xmlns:a16="http://schemas.microsoft.com/office/drawing/2014/main" id="{54DBFC58-E425-40A9-B97D-05C9173167F5}"/>
               </a:ext>
             </a:extLst>
           </p:cNvPr>
@@ -5318,7 +5318,7 @@
           <p:cNvPr id="12" name="">
             <a:extLst xmlns:a="http://schemas.openxmlformats.org/drawingml/2006/main">
               <a:ext uri="{FF2B5EF4-FFF2-40B4-BE49-F238E27FC236}">
-                <a16:creationId xmlns:a16="http://schemas.microsoft.com/office/drawing/2014/main" id="{5D1534BE-9872-4A47-9EA4-6094A731BD7F}"/>
+                <a16:creationId xmlns:a16="http://schemas.microsoft.com/office/drawing/2014/main" id="{EDE668DB-3B48-4686-93D9-47CDF6F0C88D}"/>
               </a:ext>
             </a:extLst>
           </p:cNvPr>
@@ -5351,7 +5351,7 @@
           <p:cNvPr id="13" name="">
             <a:extLst xmlns:a="http://schemas.openxmlformats.org/drawingml/2006/main">
               <a:ext uri="{FF2B5EF4-FFF2-40B4-BE49-F238E27FC236}">
-                <a16:creationId xmlns:a16="http://schemas.microsoft.com/office/drawing/2014/main" id="{400DE792-DE9E-4421-A384-BF4F677BA558}"/>
+                <a16:creationId xmlns:a16="http://schemas.microsoft.com/office/drawing/2014/main" id="{D62A30D6-0D26-4008-A1FA-65FC952E7D1A}"/>
               </a:ext>
             </a:extLst>
           </p:cNvPr>
@@ -5401,7 +5401,7 @@
           <p:cNvPr id="14" name="">
             <a:extLst xmlns:a="http://schemas.openxmlformats.org/drawingml/2006/main">
               <a:ext uri="{FF2B5EF4-FFF2-40B4-BE49-F238E27FC236}">
-                <a16:creationId xmlns:a16="http://schemas.microsoft.com/office/drawing/2014/main" id="{5DCEA553-E09F-4BFF-BD52-8F73341CC434}"/>
+                <a16:creationId xmlns:a16="http://schemas.microsoft.com/office/drawing/2014/main" id="{A6840892-898A-4E78-9192-0E2E5629AAC9}"/>
               </a:ext>
             </a:extLst>
           </p:cNvPr>
@@ -5451,7 +5451,7 @@
           <p:cNvPr id="15" name="">
             <a:extLst xmlns:a="http://schemas.openxmlformats.org/drawingml/2006/main">
               <a:ext uri="{FF2B5EF4-FFF2-40B4-BE49-F238E27FC236}">
-                <a16:creationId xmlns:a16="http://schemas.microsoft.com/office/drawing/2014/main" id="{8FA09CC5-C681-4B26-A2EA-53702341A0BE}"/>
+                <a16:creationId xmlns:a16="http://schemas.microsoft.com/office/drawing/2014/main" id="{1E55205C-168C-4FEF-AC23-6540E5AA5FF0}"/>
               </a:ext>
             </a:extLst>
           </p:cNvPr>
@@ -5499,7 +5499,7 @@
     </p:spTree>
     <p:extLst>
       <p:ext uri="{BB962C8B-B14F-4D97-AF65-F5344CB8AC3E}">
-        <p14:creationId xmlns:p14="http://schemas.microsoft.com/office/powerpoint/2010/main" val="1950124991"/>
+        <p14:creationId xmlns:p14="http://schemas.microsoft.com/office/powerpoint/2010/main" val="1859198966"/>
       </p:ext>
     </p:extLst>
   </p:cSld>
@@ -5530,7 +5530,7 @@
           <p:cNvPr id="1" name="">
             <a:extLst xmlns:a="http://schemas.openxmlformats.org/drawingml/2006/main">
               <a:ext uri="{FF2B5EF4-FFF2-40B4-BE49-F238E27FC236}">
-                <a16:creationId xmlns:a16="http://schemas.microsoft.com/office/drawing/2014/main" id="{E61CED8B-DB99-4855-994F-88244EFA5441}"/>
+                <a16:creationId xmlns:a16="http://schemas.microsoft.com/office/drawing/2014/main" id="{C24ED749-CD81-468C-99B1-44DE3D159B70}"/>
               </a:ext>
             </a:extLst>
           </p:cNvPr>
@@ -5580,7 +5580,7 @@
           <p:cNvPr id="2" name="">
             <a:extLst xmlns:a="http://schemas.openxmlformats.org/drawingml/2006/main">
               <a:ext uri="{FF2B5EF4-FFF2-40B4-BE49-F238E27FC236}">
-                <a16:creationId xmlns:a16="http://schemas.microsoft.com/office/drawing/2014/main" id="{738F153C-4417-4667-810B-B76716A88634}"/>
+                <a16:creationId xmlns:a16="http://schemas.microsoft.com/office/drawing/2014/main" id="{6187FE8D-50D5-4F3B-AED9-D7657D70E9AA}"/>
               </a:ext>
             </a:extLst>
           </p:cNvPr>
@@ -5630,7 +5630,7 @@
           <p:cNvPr id="3" name="">
             <a:extLst xmlns:a="http://schemas.openxmlformats.org/drawingml/2006/main">
               <a:ext uri="{FF2B5EF4-FFF2-40B4-BE49-F238E27FC236}">
-                <a16:creationId xmlns:a16="http://schemas.microsoft.com/office/drawing/2014/main" id="{4A869339-8A9C-4F81-AE25-B5A037924323}"/>
+                <a16:creationId xmlns:a16="http://schemas.microsoft.com/office/drawing/2014/main" id="{24FDE3C8-A19C-41BE-8C37-A71805AA48A1}"/>
               </a:ext>
             </a:extLst>
           </p:cNvPr>
@@ -5663,7 +5663,7 @@
           <p:cNvPr id="4" name="">
             <a:extLst xmlns:a="http://schemas.openxmlformats.org/drawingml/2006/main">
               <a:ext uri="{FF2B5EF4-FFF2-40B4-BE49-F238E27FC236}">
-                <a16:creationId xmlns:a16="http://schemas.microsoft.com/office/drawing/2014/main" id="{291E5015-7075-499C-8EC1-BE4EBE43B8DD}"/>
+                <a16:creationId xmlns:a16="http://schemas.microsoft.com/office/drawing/2014/main" id="{FEFFF92A-E7E1-42B5-B5C8-FCE25A341F3C}"/>
               </a:ext>
             </a:extLst>
           </p:cNvPr>
@@ -5696,7 +5696,7 @@
           <p:cNvPr id="5" name="">
             <a:extLst xmlns:a="http://schemas.openxmlformats.org/drawingml/2006/main">
               <a:ext uri="{FF2B5EF4-FFF2-40B4-BE49-F238E27FC236}">
-                <a16:creationId xmlns:a16="http://schemas.microsoft.com/office/drawing/2014/main" id="{4CA3EE13-4162-4A64-B713-BB6ED0B273E9}"/>
+                <a16:creationId xmlns:a16="http://schemas.microsoft.com/office/drawing/2014/main" id="{AA6F4CC3-C72D-4A33-9D03-CE11EC1C01ED}"/>
               </a:ext>
             </a:extLst>
           </p:cNvPr>
@@ -5746,7 +5746,7 @@
           <p:cNvPr id="6" name="">
             <a:extLst xmlns:a="http://schemas.openxmlformats.org/drawingml/2006/main">
               <a:ext uri="{FF2B5EF4-FFF2-40B4-BE49-F238E27FC236}">
-                <a16:creationId xmlns:a16="http://schemas.microsoft.com/office/drawing/2014/main" id="{F61967BC-9F47-471B-9B92-69DB8E766922}"/>
+                <a16:creationId xmlns:a16="http://schemas.microsoft.com/office/drawing/2014/main" id="{52CB3DD6-DC6C-4166-978C-7AA319D9CC83}"/>
               </a:ext>
             </a:extLst>
           </p:cNvPr>
@@ -5779,7 +5779,7 @@
           <p:cNvPr id="7" name="">
             <a:extLst xmlns:a="http://schemas.openxmlformats.org/drawingml/2006/main">
               <a:ext uri="{FF2B5EF4-FFF2-40B4-BE49-F238E27FC236}">
-                <a16:creationId xmlns:a16="http://schemas.microsoft.com/office/drawing/2014/main" id="{747383C2-96B5-465A-AA30-2ACBD105B9C2}"/>
+                <a16:creationId xmlns:a16="http://schemas.microsoft.com/office/drawing/2014/main" id="{482C8B8E-A407-47FF-9DFB-D81C2C07C804}"/>
               </a:ext>
             </a:extLst>
           </p:cNvPr>
@@ -5829,7 +5829,7 @@
           <p:cNvPr id="8" name="">
             <a:extLst xmlns:a="http://schemas.openxmlformats.org/drawingml/2006/main">
               <a:ext uri="{FF2B5EF4-FFF2-40B4-BE49-F238E27FC236}">
-                <a16:creationId xmlns:a16="http://schemas.microsoft.com/office/drawing/2014/main" id="{7180C404-BADA-47DB-A7D6-A1DF8781BEEC}"/>
+                <a16:creationId xmlns:a16="http://schemas.microsoft.com/office/drawing/2014/main" id="{6B8A1A7D-E5D5-4B2B-A664-93288C1C7438}"/>
               </a:ext>
             </a:extLst>
           </p:cNvPr>
@@ -5862,7 +5862,7 @@
           <p:cNvPr id="9" name="">
             <a:extLst xmlns:a="http://schemas.openxmlformats.org/drawingml/2006/main">
               <a:ext uri="{FF2B5EF4-FFF2-40B4-BE49-F238E27FC236}">
-                <a16:creationId xmlns:a16="http://schemas.microsoft.com/office/drawing/2014/main" id="{09806EAD-5337-4DBD-A37D-CB4DBB069B1A}"/>
+                <a16:creationId xmlns:a16="http://schemas.microsoft.com/office/drawing/2014/main" id="{5659308D-6641-4C6C-9966-A49BB830C6B0}"/>
               </a:ext>
             </a:extLst>
           </p:cNvPr>
@@ -5912,7 +5912,7 @@
           <p:cNvPr id="10" name="">
             <a:extLst xmlns:a="http://schemas.openxmlformats.org/drawingml/2006/main">
               <a:ext uri="{FF2B5EF4-FFF2-40B4-BE49-F238E27FC236}">
-                <a16:creationId xmlns:a16="http://schemas.microsoft.com/office/drawing/2014/main" id="{D28A3A4D-EC4B-4333-A786-AF7941CAA891}"/>
+                <a16:creationId xmlns:a16="http://schemas.microsoft.com/office/drawing/2014/main" id="{B8454C23-CFCA-477D-9703-DF08F2DE12FF}"/>
               </a:ext>
             </a:extLst>
           </p:cNvPr>
@@ -5945,7 +5945,7 @@
           <p:cNvPr id="11" name="">
             <a:extLst xmlns:a="http://schemas.openxmlformats.org/drawingml/2006/main">
               <a:ext uri="{FF2B5EF4-FFF2-40B4-BE49-F238E27FC236}">
-                <a16:creationId xmlns:a16="http://schemas.microsoft.com/office/drawing/2014/main" id="{044BDC4F-3610-43D9-8B75-C1CF0CFB8F81}"/>
+                <a16:creationId xmlns:a16="http://schemas.microsoft.com/office/drawing/2014/main" id="{4DD704DA-9CAC-4B1F-BA7B-8E4FCF7F5E0D}"/>
               </a:ext>
             </a:extLst>
           </p:cNvPr>
@@ -5999,7 +5999,7 @@
           <p:nvPr/>
         </p:nvPicPr>
         <p:blipFill>
-          <a:blip xmlns:r="http://schemas.openxmlformats.org/officeDocument/2006/relationships" xmlns:a="http://schemas.openxmlformats.org/drawingml/2006/main" r:embed="Re59c0154d43141eb"/>
+          <a:blip xmlns:r="http://schemas.openxmlformats.org/officeDocument/2006/relationships" xmlns:a="http://schemas.openxmlformats.org/drawingml/2006/main" r:embed="R9238b60243cf4b09"/>
           <a:stretch xmlns:a="http://schemas.openxmlformats.org/drawingml/2006/main"/>
         </p:blipFill>
         <p:spPr>
@@ -6017,7 +6017,7 @@
           <p:cNvPr id="13" name="">
             <a:extLst xmlns:a="http://schemas.openxmlformats.org/drawingml/2006/main">
               <a:ext uri="{FF2B5EF4-FFF2-40B4-BE49-F238E27FC236}">
-                <a16:creationId xmlns:a16="http://schemas.microsoft.com/office/drawing/2014/main" id="{90E716EC-C205-477D-B977-4DE1D5A83CB4}"/>
+                <a16:creationId xmlns:a16="http://schemas.microsoft.com/office/drawing/2014/main" id="{9093D92B-E32F-431E-B4B5-6988A0AC78F3}"/>
               </a:ext>
             </a:extLst>
           </p:cNvPr>
@@ -6067,7 +6067,7 @@
           <p:cNvPr id="14" name="">
             <a:extLst xmlns:a="http://schemas.openxmlformats.org/drawingml/2006/main">
               <a:ext uri="{FF2B5EF4-FFF2-40B4-BE49-F238E27FC236}">
-                <a16:creationId xmlns:a16="http://schemas.microsoft.com/office/drawing/2014/main" id="{8734CCCF-DD09-4A48-968F-08FEF3F0DE10}"/>
+                <a16:creationId xmlns:a16="http://schemas.microsoft.com/office/drawing/2014/main" id="{DBD944A6-F384-4A06-9344-754C462EB350}"/>
               </a:ext>
             </a:extLst>
           </p:cNvPr>
@@ -6115,7 +6115,7 @@
     </p:spTree>
     <p:extLst>
       <p:ext uri="{BB962C8B-B14F-4D97-AF65-F5344CB8AC3E}">
-        <p14:creationId xmlns:p14="http://schemas.microsoft.com/office/powerpoint/2010/main" val="1297525505"/>
+        <p14:creationId xmlns:p14="http://schemas.microsoft.com/office/powerpoint/2010/main" val="850297931"/>
       </p:ext>
     </p:extLst>
   </p:cSld>
@@ -6146,7 +6146,7 @@
           <p:cNvPr id="1" name="">
             <a:extLst xmlns:a="http://schemas.openxmlformats.org/drawingml/2006/main">
               <a:ext uri="{FF2B5EF4-FFF2-40B4-BE49-F238E27FC236}">
-                <a16:creationId xmlns:a16="http://schemas.microsoft.com/office/drawing/2014/main" id="{25084E85-ADCC-469C-B115-C1EA8AA085B3}"/>
+                <a16:creationId xmlns:a16="http://schemas.microsoft.com/office/drawing/2014/main" id="{F913BB0D-E0ED-4A3C-92FA-DD431778CD03}"/>
               </a:ext>
             </a:extLst>
           </p:cNvPr>
@@ -6196,7 +6196,7 @@
           <p:cNvPr id="2" name="">
             <a:extLst xmlns:a="http://schemas.openxmlformats.org/drawingml/2006/main">
               <a:ext uri="{FF2B5EF4-FFF2-40B4-BE49-F238E27FC236}">
-                <a16:creationId xmlns:a16="http://schemas.microsoft.com/office/drawing/2014/main" id="{4358C8AD-8BB8-4768-BC19-24CCC2E292E2}"/>
+                <a16:creationId xmlns:a16="http://schemas.microsoft.com/office/drawing/2014/main" id="{5F0EEEFC-C5F1-49DD-970D-4F95721E44AA}"/>
               </a:ext>
             </a:extLst>
           </p:cNvPr>
@@ -6246,7 +6246,7 @@
           <p:cNvPr id="3" name="">
             <a:extLst xmlns:a="http://schemas.openxmlformats.org/drawingml/2006/main">
               <a:ext uri="{FF2B5EF4-FFF2-40B4-BE49-F238E27FC236}">
-                <a16:creationId xmlns:a16="http://schemas.microsoft.com/office/drawing/2014/main" id="{8F26FC14-47F1-43F5-9478-BA06E7D384F9}"/>
+                <a16:creationId xmlns:a16="http://schemas.microsoft.com/office/drawing/2014/main" id="{5BE401B6-76D4-42CB-AC27-4A85E53E8CBC}"/>
               </a:ext>
             </a:extLst>
           </p:cNvPr>
@@ -6279,7 +6279,7 @@
           <p:cNvPr id="4" name="">
             <a:extLst xmlns:a="http://schemas.openxmlformats.org/drawingml/2006/main">
               <a:ext uri="{FF2B5EF4-FFF2-40B4-BE49-F238E27FC236}">
-                <a16:creationId xmlns:a16="http://schemas.microsoft.com/office/drawing/2014/main" id="{18841C74-5A9E-44EA-9B7C-32A49BE59D32}"/>
+                <a16:creationId xmlns:a16="http://schemas.microsoft.com/office/drawing/2014/main" id="{F6E0A22E-A698-4BA0-8C01-397A693D555D}"/>
               </a:ext>
             </a:extLst>
           </p:cNvPr>
@@ -6312,7 +6312,7 @@
           <p:cNvPr id="5" name="">
             <a:extLst xmlns:a="http://schemas.openxmlformats.org/drawingml/2006/main">
               <a:ext uri="{FF2B5EF4-FFF2-40B4-BE49-F238E27FC236}">
-                <a16:creationId xmlns:a16="http://schemas.microsoft.com/office/drawing/2014/main" id="{1E16E893-BE4A-44A8-8BD8-1FD52118F74A}"/>
+                <a16:creationId xmlns:a16="http://schemas.microsoft.com/office/drawing/2014/main" id="{20D85031-BC3D-4BB7-9F2C-E2EFC264D55C}"/>
               </a:ext>
             </a:extLst>
           </p:cNvPr>
@@ -6362,7 +6362,7 @@
           <p:cNvPr id="6" name="">
             <a:extLst xmlns:a="http://schemas.openxmlformats.org/drawingml/2006/main">
               <a:ext uri="{FF2B5EF4-FFF2-40B4-BE49-F238E27FC236}">
-                <a16:creationId xmlns:a16="http://schemas.microsoft.com/office/drawing/2014/main" id="{E5A8C239-B4EF-417B-A885-C3BEC293CE90}"/>
+                <a16:creationId xmlns:a16="http://schemas.microsoft.com/office/drawing/2014/main" id="{B630FEC1-A10A-435F-BB2B-ECE12C0B377E}"/>
               </a:ext>
             </a:extLst>
           </p:cNvPr>
@@ -6412,7 +6412,7 @@
           <p:cNvPr id="7" name="">
             <a:extLst xmlns:a="http://schemas.openxmlformats.org/drawingml/2006/main">
               <a:ext uri="{FF2B5EF4-FFF2-40B4-BE49-F238E27FC236}">
-                <a16:creationId xmlns:a16="http://schemas.microsoft.com/office/drawing/2014/main" id="{FFC0EF12-1821-4A8B-84F6-1DAC357E836D}"/>
+                <a16:creationId xmlns:a16="http://schemas.microsoft.com/office/drawing/2014/main" id="{2D1151AA-1CCF-41AB-9612-E24DECCC2362}"/>
               </a:ext>
             </a:extLst>
           </p:cNvPr>
@@ -6445,7 +6445,7 @@
           <p:cNvPr id="8" name="">
             <a:extLst xmlns:a="http://schemas.openxmlformats.org/drawingml/2006/main">
               <a:ext uri="{FF2B5EF4-FFF2-40B4-BE49-F238E27FC236}">
-                <a16:creationId xmlns:a16="http://schemas.microsoft.com/office/drawing/2014/main" id="{3425740F-7669-4AF9-A33B-F6BC464409FA}"/>
+                <a16:creationId xmlns:a16="http://schemas.microsoft.com/office/drawing/2014/main" id="{67136D3C-2958-4CDB-9413-19CF82B54010}"/>
               </a:ext>
             </a:extLst>
           </p:cNvPr>
@@ -6478,7 +6478,7 @@
           <p:cNvPr id="9" name="">
             <a:extLst xmlns:a="http://schemas.openxmlformats.org/drawingml/2006/main">
               <a:ext uri="{FF2B5EF4-FFF2-40B4-BE49-F238E27FC236}">
-                <a16:creationId xmlns:a16="http://schemas.microsoft.com/office/drawing/2014/main" id="{A6B07CE9-29CA-4D7F-98D3-32AA9DC08E30}"/>
+                <a16:creationId xmlns:a16="http://schemas.microsoft.com/office/drawing/2014/main" id="{7FFC8708-92A6-4A03-83F8-62E12D66FAB8}"/>
               </a:ext>
             </a:extLst>
           </p:cNvPr>
@@ -6528,7 +6528,7 @@
           <p:cNvPr id="10" name="">
             <a:extLst xmlns:a="http://schemas.openxmlformats.org/drawingml/2006/main">
               <a:ext uri="{FF2B5EF4-FFF2-40B4-BE49-F238E27FC236}">
-                <a16:creationId xmlns:a16="http://schemas.microsoft.com/office/drawing/2014/main" id="{C371F691-46EE-4142-984D-8DCDD628278A}"/>
+                <a16:creationId xmlns:a16="http://schemas.microsoft.com/office/drawing/2014/main" id="{BF5F0403-5EC4-4593-85EB-6579731C5588}"/>
               </a:ext>
             </a:extLst>
           </p:cNvPr>
@@ -6578,7 +6578,7 @@
           <p:cNvPr id="11" name="">
             <a:extLst xmlns:a="http://schemas.openxmlformats.org/drawingml/2006/main">
               <a:ext uri="{FF2B5EF4-FFF2-40B4-BE49-F238E27FC236}">
-                <a16:creationId xmlns:a16="http://schemas.microsoft.com/office/drawing/2014/main" id="{9A7D542F-0E5D-4DCE-95A6-5DEEBE29E81A}"/>
+                <a16:creationId xmlns:a16="http://schemas.microsoft.com/office/drawing/2014/main" id="{8A6E4A21-6927-4A3B-9E44-31F9BAC72FA9}"/>
               </a:ext>
             </a:extLst>
           </p:cNvPr>
@@ -6611,7 +6611,7 @@
           <p:cNvPr id="12" name="">
             <a:extLst xmlns:a="http://schemas.openxmlformats.org/drawingml/2006/main">
               <a:ext uri="{FF2B5EF4-FFF2-40B4-BE49-F238E27FC236}">
-                <a16:creationId xmlns:a16="http://schemas.microsoft.com/office/drawing/2014/main" id="{485A6A34-D9F0-4BC8-889A-EBDDCAF28E5A}"/>
+                <a16:creationId xmlns:a16="http://schemas.microsoft.com/office/drawing/2014/main" id="{693C57B6-ACB5-4A8D-A393-20C893170269}"/>
               </a:ext>
             </a:extLst>
           </p:cNvPr>
@@ -6644,7 +6644,7 @@
           <p:cNvPr id="13" name="">
             <a:extLst xmlns:a="http://schemas.openxmlformats.org/drawingml/2006/main">
               <a:ext uri="{FF2B5EF4-FFF2-40B4-BE49-F238E27FC236}">
-                <a16:creationId xmlns:a16="http://schemas.microsoft.com/office/drawing/2014/main" id="{06824B07-3952-4041-A6A3-FD3A0A6A146D}"/>
+                <a16:creationId xmlns:a16="http://schemas.microsoft.com/office/drawing/2014/main" id="{279B5927-1293-4036-8F78-AE4ED8AD8C65}"/>
               </a:ext>
             </a:extLst>
           </p:cNvPr>
@@ -6694,7 +6694,7 @@
           <p:cNvPr id="14" name="">
             <a:extLst xmlns:a="http://schemas.openxmlformats.org/drawingml/2006/main">
               <a:ext uri="{FF2B5EF4-FFF2-40B4-BE49-F238E27FC236}">
-                <a16:creationId xmlns:a16="http://schemas.microsoft.com/office/drawing/2014/main" id="{95799D41-CF6A-434D-8DCC-24802CA790CB}"/>
+                <a16:creationId xmlns:a16="http://schemas.microsoft.com/office/drawing/2014/main" id="{F4A760F0-C5FD-4E7D-97CD-9956672ADC20}"/>
               </a:ext>
             </a:extLst>
           </p:cNvPr>
@@ -6744,7 +6744,7 @@
           <p:cNvPr id="15" name="">
             <a:extLst xmlns:a="http://schemas.openxmlformats.org/drawingml/2006/main">
               <a:ext uri="{FF2B5EF4-FFF2-40B4-BE49-F238E27FC236}">
-                <a16:creationId xmlns:a16="http://schemas.microsoft.com/office/drawing/2014/main" id="{DF74C823-56E7-4DAD-93AE-552CF8187F84}"/>
+                <a16:creationId xmlns:a16="http://schemas.microsoft.com/office/drawing/2014/main" id="{9F49FEF7-BF3C-4F3C-ADB0-ECC9C011C6D2}"/>
               </a:ext>
             </a:extLst>
           </p:cNvPr>
@@ -6777,7 +6777,7 @@
           <p:cNvPr id="16" name="">
             <a:extLst xmlns:a="http://schemas.openxmlformats.org/drawingml/2006/main">
               <a:ext uri="{FF2B5EF4-FFF2-40B4-BE49-F238E27FC236}">
-                <a16:creationId xmlns:a16="http://schemas.microsoft.com/office/drawing/2014/main" id="{2E9887E9-006D-4671-BDF6-CFE4A7133A50}"/>
+                <a16:creationId xmlns:a16="http://schemas.microsoft.com/office/drawing/2014/main" id="{EAE220B7-E25D-4FC3-89C8-F3AACDDBF6D7}"/>
               </a:ext>
             </a:extLst>
           </p:cNvPr>
@@ -6810,7 +6810,7 @@
           <p:cNvPr id="17" name="">
             <a:extLst xmlns:a="http://schemas.openxmlformats.org/drawingml/2006/main">
               <a:ext uri="{FF2B5EF4-FFF2-40B4-BE49-F238E27FC236}">
-                <a16:creationId xmlns:a16="http://schemas.microsoft.com/office/drawing/2014/main" id="{264C8774-EA24-4AF0-8322-9D194A78B96C}"/>
+                <a16:creationId xmlns:a16="http://schemas.microsoft.com/office/drawing/2014/main" id="{5B0BD141-AFE9-4640-8DBC-F6DD8B276382}"/>
               </a:ext>
             </a:extLst>
           </p:cNvPr>
@@ -6860,7 +6860,7 @@
           <p:cNvPr id="18" name="">
             <a:extLst xmlns:a="http://schemas.openxmlformats.org/drawingml/2006/main">
               <a:ext uri="{FF2B5EF4-FFF2-40B4-BE49-F238E27FC236}">
-                <a16:creationId xmlns:a16="http://schemas.microsoft.com/office/drawing/2014/main" id="{DD76CDED-2AA5-4CD7-9F75-EC4460904CF1}"/>
+                <a16:creationId xmlns:a16="http://schemas.microsoft.com/office/drawing/2014/main" id="{91000C8F-0E75-41EA-9BE4-087D41C1E699}"/>
               </a:ext>
             </a:extLst>
           </p:cNvPr>
@@ -6910,7 +6910,7 @@
           <p:cNvPr id="19" name="">
             <a:extLst xmlns:a="http://schemas.openxmlformats.org/drawingml/2006/main">
               <a:ext uri="{FF2B5EF4-FFF2-40B4-BE49-F238E27FC236}">
-                <a16:creationId xmlns:a16="http://schemas.microsoft.com/office/drawing/2014/main" id="{9963C4A0-C6DC-48F9-AE36-2F14169FAD95}"/>
+                <a16:creationId xmlns:a16="http://schemas.microsoft.com/office/drawing/2014/main" id="{D02E0417-AF36-4A4E-93A3-50D19C4D1C8B}"/>
               </a:ext>
             </a:extLst>
           </p:cNvPr>
@@ -6943,7 +6943,7 @@
           <p:cNvPr id="20" name="">
             <a:extLst xmlns:a="http://schemas.openxmlformats.org/drawingml/2006/main">
               <a:ext uri="{FF2B5EF4-FFF2-40B4-BE49-F238E27FC236}">
-                <a16:creationId xmlns:a16="http://schemas.microsoft.com/office/drawing/2014/main" id="{27DC94F8-76A6-4648-8FEC-87569110FFED}"/>
+                <a16:creationId xmlns:a16="http://schemas.microsoft.com/office/drawing/2014/main" id="{7604F927-E77B-4235-A25C-E0A66F99D2DC}"/>
               </a:ext>
             </a:extLst>
           </p:cNvPr>
@@ -6976,7 +6976,7 @@
           <p:cNvPr id="21" name="">
             <a:extLst xmlns:a="http://schemas.openxmlformats.org/drawingml/2006/main">
               <a:ext uri="{FF2B5EF4-FFF2-40B4-BE49-F238E27FC236}">
-                <a16:creationId xmlns:a16="http://schemas.microsoft.com/office/drawing/2014/main" id="{B1998A16-B5BE-4E5F-8F99-9553E6465035}"/>
+                <a16:creationId xmlns:a16="http://schemas.microsoft.com/office/drawing/2014/main" id="{C234BAB3-7FBD-4891-A055-94B59AAA9AE4}"/>
               </a:ext>
             </a:extLst>
           </p:cNvPr>
@@ -7026,7 +7026,7 @@
           <p:cNvPr id="22" name="">
             <a:extLst xmlns:a="http://schemas.openxmlformats.org/drawingml/2006/main">
               <a:ext uri="{FF2B5EF4-FFF2-40B4-BE49-F238E27FC236}">
-                <a16:creationId xmlns:a16="http://schemas.microsoft.com/office/drawing/2014/main" id="{99F7930F-3E12-4575-A36F-FB3884168C3C}"/>
+                <a16:creationId xmlns:a16="http://schemas.microsoft.com/office/drawing/2014/main" id="{B4D80166-3171-4B7C-986B-78409C9DA86F}"/>
               </a:ext>
             </a:extLst>
           </p:cNvPr>
@@ -7076,7 +7076,7 @@
           <p:cNvPr id="23" name="">
             <a:extLst xmlns:a="http://schemas.openxmlformats.org/drawingml/2006/main">
               <a:ext uri="{FF2B5EF4-FFF2-40B4-BE49-F238E27FC236}">
-                <a16:creationId xmlns:a16="http://schemas.microsoft.com/office/drawing/2014/main" id="{476A76E9-3359-4A13-AD9C-2833214127BA}"/>
+                <a16:creationId xmlns:a16="http://schemas.microsoft.com/office/drawing/2014/main" id="{DAB26E36-B9EA-450F-90B7-93CD5C8766D0}"/>
               </a:ext>
             </a:extLst>
           </p:cNvPr>
@@ -7109,7 +7109,7 @@
           <p:cNvPr id="24" name="">
             <a:extLst xmlns:a="http://schemas.openxmlformats.org/drawingml/2006/main">
               <a:ext uri="{FF2B5EF4-FFF2-40B4-BE49-F238E27FC236}">
-                <a16:creationId xmlns:a16="http://schemas.microsoft.com/office/drawing/2014/main" id="{B2B96162-4F81-4CBF-8D36-EAA8F126C324}"/>
+                <a16:creationId xmlns:a16="http://schemas.microsoft.com/office/drawing/2014/main" id="{B1562913-9CC5-4053-85F9-7E703DC5B3A2}"/>
               </a:ext>
             </a:extLst>
           </p:cNvPr>
@@ -7142,7 +7142,7 @@
           <p:cNvPr id="25" name="">
             <a:extLst xmlns:a="http://schemas.openxmlformats.org/drawingml/2006/main">
               <a:ext uri="{FF2B5EF4-FFF2-40B4-BE49-F238E27FC236}">
-                <a16:creationId xmlns:a16="http://schemas.microsoft.com/office/drawing/2014/main" id="{D121505B-C229-460E-B2C5-C43F0BA65640}"/>
+                <a16:creationId xmlns:a16="http://schemas.microsoft.com/office/drawing/2014/main" id="{24366621-F01C-426D-AFDE-599367844A34}"/>
               </a:ext>
             </a:extLst>
           </p:cNvPr>
@@ -7192,7 +7192,7 @@
           <p:cNvPr id="26" name="">
             <a:extLst xmlns:a="http://schemas.openxmlformats.org/drawingml/2006/main">
               <a:ext uri="{FF2B5EF4-FFF2-40B4-BE49-F238E27FC236}">
-                <a16:creationId xmlns:a16="http://schemas.microsoft.com/office/drawing/2014/main" id="{34866392-2E0D-4365-8C5A-ACB41C94AA39}"/>
+                <a16:creationId xmlns:a16="http://schemas.microsoft.com/office/drawing/2014/main" id="{C7F27C49-CECC-40A6-B644-15B66D4B426D}"/>
               </a:ext>
             </a:extLst>
           </p:cNvPr>
@@ -7242,7 +7242,7 @@
           <p:cNvPr id="27" name="">
             <a:extLst xmlns:a="http://schemas.openxmlformats.org/drawingml/2006/main">
               <a:ext uri="{FF2B5EF4-FFF2-40B4-BE49-F238E27FC236}">
-                <a16:creationId xmlns:a16="http://schemas.microsoft.com/office/drawing/2014/main" id="{C4117AC6-3538-41AF-890C-89B32BBAEF02}"/>
+                <a16:creationId xmlns:a16="http://schemas.microsoft.com/office/drawing/2014/main" id="{89914D55-34ED-47FC-A041-24F2FD9D5165}"/>
               </a:ext>
             </a:extLst>
           </p:cNvPr>
@@ -7275,7 +7275,7 @@
           <p:cNvPr id="28" name="">
             <a:extLst xmlns:a="http://schemas.openxmlformats.org/drawingml/2006/main">
               <a:ext uri="{FF2B5EF4-FFF2-40B4-BE49-F238E27FC236}">
-                <a16:creationId xmlns:a16="http://schemas.microsoft.com/office/drawing/2014/main" id="{C2AAEC1E-57E1-4C3A-93B9-BF01A1E71619}"/>
+                <a16:creationId xmlns:a16="http://schemas.microsoft.com/office/drawing/2014/main" id="{68E63B8F-EE78-408F-B20B-9C4022E04E5B}"/>
               </a:ext>
             </a:extLst>
           </p:cNvPr>
@@ -7308,7 +7308,7 @@
           <p:cNvPr id="29" name="">
             <a:extLst xmlns:a="http://schemas.openxmlformats.org/drawingml/2006/main">
               <a:ext uri="{FF2B5EF4-FFF2-40B4-BE49-F238E27FC236}">
-                <a16:creationId xmlns:a16="http://schemas.microsoft.com/office/drawing/2014/main" id="{6748D4A9-6F0D-4F0F-8B87-26659E83875A}"/>
+                <a16:creationId xmlns:a16="http://schemas.microsoft.com/office/drawing/2014/main" id="{65CB6BB8-563B-472D-B6AE-05966634AD77}"/>
               </a:ext>
             </a:extLst>
           </p:cNvPr>
@@ -7358,7 +7358,7 @@
           <p:cNvPr id="30" name="">
             <a:extLst xmlns:a="http://schemas.openxmlformats.org/drawingml/2006/main">
               <a:ext uri="{FF2B5EF4-FFF2-40B4-BE49-F238E27FC236}">
-                <a16:creationId xmlns:a16="http://schemas.microsoft.com/office/drawing/2014/main" id="{E250AE8E-D1CC-4CBB-9B7B-08F00E5AAC4D}"/>
+                <a16:creationId xmlns:a16="http://schemas.microsoft.com/office/drawing/2014/main" id="{9C9E28AD-ACE8-4788-9DE1-4F75E17C234B}"/>
               </a:ext>
             </a:extLst>
           </p:cNvPr>
@@ -7408,7 +7408,7 @@
           <p:cNvPr id="31" name="">
             <a:extLst xmlns:a="http://schemas.openxmlformats.org/drawingml/2006/main">
               <a:ext uri="{FF2B5EF4-FFF2-40B4-BE49-F238E27FC236}">
-                <a16:creationId xmlns:a16="http://schemas.microsoft.com/office/drawing/2014/main" id="{931C36F3-AB35-438B-94AF-9A4598473142}"/>
+                <a16:creationId xmlns:a16="http://schemas.microsoft.com/office/drawing/2014/main" id="{27C85C6F-8B6E-40A9-B9A2-D7F38ECA1809}"/>
               </a:ext>
             </a:extLst>
           </p:cNvPr>
@@ -7458,7 +7458,7 @@
           <p:cNvPr id="32" name="">
             <a:extLst xmlns:a="http://schemas.openxmlformats.org/drawingml/2006/main">
               <a:ext uri="{FF2B5EF4-FFF2-40B4-BE49-F238E27FC236}">
-                <a16:creationId xmlns:a16="http://schemas.microsoft.com/office/drawing/2014/main" id="{F65C9984-4958-4F91-90DE-0F0E47D794B6}"/>
+                <a16:creationId xmlns:a16="http://schemas.microsoft.com/office/drawing/2014/main" id="{DD1E2CEE-5E58-4070-ABE7-FF098FF0C221}"/>
               </a:ext>
             </a:extLst>
           </p:cNvPr>
@@ -7506,7 +7506,7 @@
     </p:spTree>
     <p:extLst>
       <p:ext uri="{BB962C8B-B14F-4D97-AF65-F5344CB8AC3E}">
-        <p14:creationId xmlns:p14="http://schemas.microsoft.com/office/powerpoint/2010/main" val="1937458152"/>
+        <p14:creationId xmlns:p14="http://schemas.microsoft.com/office/powerpoint/2010/main" val="2050201379"/>
       </p:ext>
     </p:extLst>
   </p:cSld>
@@ -7537,7 +7537,7 @@
           <p:cNvPr id="1" name="">
             <a:extLst xmlns:a="http://schemas.openxmlformats.org/drawingml/2006/main">
               <a:ext uri="{FF2B5EF4-FFF2-40B4-BE49-F238E27FC236}">
-                <a16:creationId xmlns:a16="http://schemas.microsoft.com/office/drawing/2014/main" id="{3146F629-46AD-497F-8415-4FF3E5505E53}"/>
+                <a16:creationId xmlns:a16="http://schemas.microsoft.com/office/drawing/2014/main" id="{F8AE34B7-81CF-48C5-8D77-22ABAF685A53}"/>
               </a:ext>
             </a:extLst>
           </p:cNvPr>
@@ -7587,7 +7587,7 @@
           <p:cNvPr id="2" name="">
             <a:extLst xmlns:a="http://schemas.openxmlformats.org/drawingml/2006/main">
               <a:ext uri="{FF2B5EF4-FFF2-40B4-BE49-F238E27FC236}">
-                <a16:creationId xmlns:a16="http://schemas.microsoft.com/office/drawing/2014/main" id="{2B0C536D-0D7F-4015-A215-E673AA6E0A73}"/>
+                <a16:creationId xmlns:a16="http://schemas.microsoft.com/office/drawing/2014/main" id="{A768115E-710E-4502-8BC8-701FBFD0B229}"/>
               </a:ext>
             </a:extLst>
           </p:cNvPr>
@@ -7637,7 +7637,7 @@
           <p:cNvPr id="3" name="">
             <a:extLst xmlns:a="http://schemas.openxmlformats.org/drawingml/2006/main">
               <a:ext uri="{FF2B5EF4-FFF2-40B4-BE49-F238E27FC236}">
-                <a16:creationId xmlns:a16="http://schemas.microsoft.com/office/drawing/2014/main" id="{C3B8B126-B107-4C12-88BA-3A7097C9B20F}"/>
+                <a16:creationId xmlns:a16="http://schemas.microsoft.com/office/drawing/2014/main" id="{333F13BE-9923-42C6-AE14-1FA440CC2913}"/>
               </a:ext>
             </a:extLst>
           </p:cNvPr>
@@ -7670,7 +7670,7 @@
           <p:cNvPr id="4" name="">
             <a:extLst xmlns:a="http://schemas.openxmlformats.org/drawingml/2006/main">
               <a:ext uri="{FF2B5EF4-FFF2-40B4-BE49-F238E27FC236}">
-                <a16:creationId xmlns:a16="http://schemas.microsoft.com/office/drawing/2014/main" id="{244C33BD-DC52-404E-9432-53BCD0AEE34A}"/>
+                <a16:creationId xmlns:a16="http://schemas.microsoft.com/office/drawing/2014/main" id="{658BFA19-E119-477E-9C97-9C2C54D3B3EF}"/>
               </a:ext>
             </a:extLst>
           </p:cNvPr>
@@ -7703,7 +7703,7 @@
           <p:cNvPr id="5" name="">
             <a:extLst xmlns:a="http://schemas.openxmlformats.org/drawingml/2006/main">
               <a:ext uri="{FF2B5EF4-FFF2-40B4-BE49-F238E27FC236}">
-                <a16:creationId xmlns:a16="http://schemas.microsoft.com/office/drawing/2014/main" id="{C9133EFA-42D0-43D0-A5C1-CFD8BC0EDCFD}"/>
+                <a16:creationId xmlns:a16="http://schemas.microsoft.com/office/drawing/2014/main" id="{B825862A-5DAD-46E4-A49C-E22819B67CA6}"/>
               </a:ext>
             </a:extLst>
           </p:cNvPr>
@@ -7753,7 +7753,7 @@
           <p:cNvPr id="6" name="">
             <a:extLst xmlns:a="http://schemas.openxmlformats.org/drawingml/2006/main">
               <a:ext uri="{FF2B5EF4-FFF2-40B4-BE49-F238E27FC236}">
-                <a16:creationId xmlns:a16="http://schemas.microsoft.com/office/drawing/2014/main" id="{53FAFCE1-2A6B-44CF-8B81-6DAB5FDD4CEC}"/>
+                <a16:creationId xmlns:a16="http://schemas.microsoft.com/office/drawing/2014/main" id="{B8FC8BE2-9F4E-4118-A68C-0563A5BC0E85}"/>
               </a:ext>
             </a:extLst>
           </p:cNvPr>
@@ -7803,7 +7803,7 @@
           <p:cNvPr id="7" name="">
             <a:extLst xmlns:a="http://schemas.openxmlformats.org/drawingml/2006/main">
               <a:ext uri="{FF2B5EF4-FFF2-40B4-BE49-F238E27FC236}">
-                <a16:creationId xmlns:a16="http://schemas.microsoft.com/office/drawing/2014/main" id="{FA7DD550-9024-4837-A6E6-2854EAC0A640}"/>
+                <a16:creationId xmlns:a16="http://schemas.microsoft.com/office/drawing/2014/main" id="{21F0D848-D79F-4708-9962-4078F6042996}"/>
               </a:ext>
             </a:extLst>
           </p:cNvPr>
@@ -7836,7 +7836,7 @@
           <p:cNvPr id="8" name="">
             <a:extLst xmlns:a="http://schemas.openxmlformats.org/drawingml/2006/main">
               <a:ext uri="{FF2B5EF4-FFF2-40B4-BE49-F238E27FC236}">
-                <a16:creationId xmlns:a16="http://schemas.microsoft.com/office/drawing/2014/main" id="{740549DF-82A5-4BDF-8B32-049E0513AAA8}"/>
+                <a16:creationId xmlns:a16="http://schemas.microsoft.com/office/drawing/2014/main" id="{7AAD732D-A2E4-4FFB-A97A-825C305F700E}"/>
               </a:ext>
             </a:extLst>
           </p:cNvPr>
@@ -7886,7 +7886,7 @@
           <p:cNvPr id="9" name="">
             <a:extLst xmlns:a="http://schemas.openxmlformats.org/drawingml/2006/main">
               <a:ext uri="{FF2B5EF4-FFF2-40B4-BE49-F238E27FC236}">
-                <a16:creationId xmlns:a16="http://schemas.microsoft.com/office/drawing/2014/main" id="{A7D2DDD0-A3AC-4E3A-8BE9-C1C85BA3E575}"/>
+                <a16:creationId xmlns:a16="http://schemas.microsoft.com/office/drawing/2014/main" id="{89950BAF-3E6C-4D10-BB5C-90FDDB53A3B8}"/>
               </a:ext>
             </a:extLst>
           </p:cNvPr>
@@ -7936,7 +7936,7 @@
           <p:cNvPr id="10" name="">
             <a:extLst xmlns:a="http://schemas.openxmlformats.org/drawingml/2006/main">
               <a:ext uri="{FF2B5EF4-FFF2-40B4-BE49-F238E27FC236}">
-                <a16:creationId xmlns:a16="http://schemas.microsoft.com/office/drawing/2014/main" id="{89D7E70E-7F32-46B5-B830-CE7215C91169}"/>
+                <a16:creationId xmlns:a16="http://schemas.microsoft.com/office/drawing/2014/main" id="{CDFBAA94-4E74-47D2-B1ED-C88C16115CCA}"/>
               </a:ext>
             </a:extLst>
           </p:cNvPr>
@@ -7969,7 +7969,7 @@
           <p:cNvPr id="11" name="">
             <a:extLst xmlns:a="http://schemas.openxmlformats.org/drawingml/2006/main">
               <a:ext uri="{FF2B5EF4-FFF2-40B4-BE49-F238E27FC236}">
-                <a16:creationId xmlns:a16="http://schemas.microsoft.com/office/drawing/2014/main" id="{C8DF4C0E-297C-4A77-92BF-888144115ACD}"/>
+                <a16:creationId xmlns:a16="http://schemas.microsoft.com/office/drawing/2014/main" id="{C71CADC0-362F-4D60-B445-55B68EB8A8D1}"/>
               </a:ext>
             </a:extLst>
           </p:cNvPr>
@@ -8019,7 +8019,7 @@
           <p:cNvPr id="12" name="">
             <a:extLst xmlns:a="http://schemas.openxmlformats.org/drawingml/2006/main">
               <a:ext uri="{FF2B5EF4-FFF2-40B4-BE49-F238E27FC236}">
-                <a16:creationId xmlns:a16="http://schemas.microsoft.com/office/drawing/2014/main" id="{52FF4E6D-0E93-4B22-893A-AD352D91BEB2}"/>
+                <a16:creationId xmlns:a16="http://schemas.microsoft.com/office/drawing/2014/main" id="{ED4C034E-01AD-41E2-A11C-F3C41B1A65C3}"/>
               </a:ext>
             </a:extLst>
           </p:cNvPr>
@@ -8069,7 +8069,7 @@
           <p:cNvPr id="13" name="">
             <a:extLst xmlns:a="http://schemas.openxmlformats.org/drawingml/2006/main">
               <a:ext uri="{FF2B5EF4-FFF2-40B4-BE49-F238E27FC236}">
-                <a16:creationId xmlns:a16="http://schemas.microsoft.com/office/drawing/2014/main" id="{1C53060C-F71E-4B2B-94F1-8AD3F7EA335E}"/>
+                <a16:creationId xmlns:a16="http://schemas.microsoft.com/office/drawing/2014/main" id="{55683160-1554-4E74-93EE-5E0F1C395238}"/>
               </a:ext>
             </a:extLst>
           </p:cNvPr>
@@ -8117,7 +8117,7 @@
     </p:spTree>
     <p:extLst>
       <p:ext uri="{BB962C8B-B14F-4D97-AF65-F5344CB8AC3E}">
-        <p14:creationId xmlns:p14="http://schemas.microsoft.com/office/powerpoint/2010/main" val="784325152"/>
+        <p14:creationId xmlns:p14="http://schemas.microsoft.com/office/powerpoint/2010/main" val="618480344"/>
       </p:ext>
     </p:extLst>
   </p:cSld>
@@ -8148,7 +8148,7 @@
           <p:cNvPr id="1" name="">
             <a:extLst xmlns:a="http://schemas.openxmlformats.org/drawingml/2006/main">
               <a:ext uri="{FF2B5EF4-FFF2-40B4-BE49-F238E27FC236}">
-                <a16:creationId xmlns:a16="http://schemas.microsoft.com/office/drawing/2014/main" id="{B2905FC2-EF76-4EFE-B965-EA306C379509}"/>
+                <a16:creationId xmlns:a16="http://schemas.microsoft.com/office/drawing/2014/main" id="{F07673F9-B61A-404F-A2BE-AAA8281862C7}"/>
               </a:ext>
             </a:extLst>
           </p:cNvPr>
@@ -8198,7 +8198,7 @@
           <p:cNvPr id="2" name="">
             <a:extLst xmlns:a="http://schemas.openxmlformats.org/drawingml/2006/main">
               <a:ext uri="{FF2B5EF4-FFF2-40B4-BE49-F238E27FC236}">
-                <a16:creationId xmlns:a16="http://schemas.microsoft.com/office/drawing/2014/main" id="{D360B68D-D341-4AC7-9714-E8E279A63A26}"/>
+                <a16:creationId xmlns:a16="http://schemas.microsoft.com/office/drawing/2014/main" id="{3DE00957-3D0C-468B-8D2E-FEA49D1FE613}"/>
               </a:ext>
             </a:extLst>
           </p:cNvPr>
@@ -8248,7 +8248,7 @@
           <p:cNvPr id="3" name="">
             <a:extLst xmlns:a="http://schemas.openxmlformats.org/drawingml/2006/main">
               <a:ext uri="{FF2B5EF4-FFF2-40B4-BE49-F238E27FC236}">
-                <a16:creationId xmlns:a16="http://schemas.microsoft.com/office/drawing/2014/main" id="{52E4E4DF-5CA9-43F0-B9CF-778B3F3B520E}"/>
+                <a16:creationId xmlns:a16="http://schemas.microsoft.com/office/drawing/2014/main" id="{9DC7206B-7E57-4030-B865-D32089C09E90}"/>
               </a:ext>
             </a:extLst>
           </p:cNvPr>
@@ -8281,7 +8281,7 @@
           <p:cNvPr id="4" name="">
             <a:extLst xmlns:a="http://schemas.openxmlformats.org/drawingml/2006/main">
               <a:ext uri="{FF2B5EF4-FFF2-40B4-BE49-F238E27FC236}">
-                <a16:creationId xmlns:a16="http://schemas.microsoft.com/office/drawing/2014/main" id="{68A61725-8310-4270-B3DB-4B60C5E5F4BD}"/>
+                <a16:creationId xmlns:a16="http://schemas.microsoft.com/office/drawing/2014/main" id="{C9C8F5C2-1B70-49FC-8F4E-19A477155B02}"/>
               </a:ext>
             </a:extLst>
           </p:cNvPr>
@@ -8314,7 +8314,7 @@
           <p:cNvPr id="5" name="">
             <a:extLst xmlns:a="http://schemas.openxmlformats.org/drawingml/2006/main">
               <a:ext uri="{FF2B5EF4-FFF2-40B4-BE49-F238E27FC236}">
-                <a16:creationId xmlns:a16="http://schemas.microsoft.com/office/drawing/2014/main" id="{1A716822-CA1D-4F65-877B-0E1A6418C990}"/>
+                <a16:creationId xmlns:a16="http://schemas.microsoft.com/office/drawing/2014/main" id="{EDC3F07A-08DE-4158-B7A9-6220CDB06593}"/>
               </a:ext>
             </a:extLst>
           </p:cNvPr>
@@ -8364,7 +8364,7 @@
           <p:cNvPr id="6" name="">
             <a:extLst xmlns:a="http://schemas.openxmlformats.org/drawingml/2006/main">
               <a:ext uri="{FF2B5EF4-FFF2-40B4-BE49-F238E27FC236}">
-                <a16:creationId xmlns:a16="http://schemas.microsoft.com/office/drawing/2014/main" id="{FCD34FA2-9DDF-49D0-880B-B8BF4D338DA8}"/>
+                <a16:creationId xmlns:a16="http://schemas.microsoft.com/office/drawing/2014/main" id="{4F5DB496-C98D-4C33-AF4C-341DD66C3734}"/>
               </a:ext>
             </a:extLst>
           </p:cNvPr>
@@ -8414,7 +8414,7 @@
           <p:cNvPr id="7" name="">
             <a:extLst xmlns:a="http://schemas.openxmlformats.org/drawingml/2006/main">
               <a:ext uri="{FF2B5EF4-FFF2-40B4-BE49-F238E27FC236}">
-                <a16:creationId xmlns:a16="http://schemas.microsoft.com/office/drawing/2014/main" id="{C29F7CE2-CDB7-4A4A-AEF7-893BD8F1D945}"/>
+                <a16:creationId xmlns:a16="http://schemas.microsoft.com/office/drawing/2014/main" id="{4CED350B-B0D9-45A2-B9B0-F7271D1404B6}"/>
               </a:ext>
             </a:extLst>
           </p:cNvPr>
@@ -8464,7 +8464,7 @@
           <p:cNvPr id="8" name="">
             <a:extLst xmlns:a="http://schemas.openxmlformats.org/drawingml/2006/main">
               <a:ext uri="{FF2B5EF4-FFF2-40B4-BE49-F238E27FC236}">
-                <a16:creationId xmlns:a16="http://schemas.microsoft.com/office/drawing/2014/main" id="{F35148A1-7B29-4250-AB8D-FCDF5C6B1DD9}"/>
+                <a16:creationId xmlns:a16="http://schemas.microsoft.com/office/drawing/2014/main" id="{DCE180DF-207E-4874-B8A3-AC0CE0BB02A5}"/>
               </a:ext>
             </a:extLst>
           </p:cNvPr>
@@ -8514,7 +8514,7 @@
           <p:cNvPr id="9" name="">
             <a:extLst xmlns:a="http://schemas.openxmlformats.org/drawingml/2006/main">
               <a:ext uri="{FF2B5EF4-FFF2-40B4-BE49-F238E27FC236}">
-                <a16:creationId xmlns:a16="http://schemas.microsoft.com/office/drawing/2014/main" id="{B3640971-71ED-401D-9C9A-FE9AB6AA58BF}"/>
+                <a16:creationId xmlns:a16="http://schemas.microsoft.com/office/drawing/2014/main" id="{D9F1D54B-10D2-479F-8391-185048388997}"/>
               </a:ext>
             </a:extLst>
           </p:cNvPr>
@@ -8564,7 +8564,7 @@
           <p:cNvPr id="10" name="">
             <a:extLst xmlns:a="http://schemas.openxmlformats.org/drawingml/2006/main">
               <a:ext uri="{FF2B5EF4-FFF2-40B4-BE49-F238E27FC236}">
-                <a16:creationId xmlns:a16="http://schemas.microsoft.com/office/drawing/2014/main" id="{193AAB38-8D02-4E5B-A7C8-FD1C0AB0941B}"/>
+                <a16:creationId xmlns:a16="http://schemas.microsoft.com/office/drawing/2014/main" id="{DD592EB8-3347-4DE8-9498-1CF8A706CF36}"/>
               </a:ext>
             </a:extLst>
           </p:cNvPr>
@@ -8614,7 +8614,7 @@
           <p:cNvPr id="11" name="">
             <a:extLst xmlns:a="http://schemas.openxmlformats.org/drawingml/2006/main">
               <a:ext uri="{FF2B5EF4-FFF2-40B4-BE49-F238E27FC236}">
-                <a16:creationId xmlns:a16="http://schemas.microsoft.com/office/drawing/2014/main" id="{27C91DC0-B60A-4D7D-B5DA-21C19FA6EB8F}"/>
+                <a16:creationId xmlns:a16="http://schemas.microsoft.com/office/drawing/2014/main" id="{248ECC49-84E7-42E3-AE48-863A5D9B49FC}"/>
               </a:ext>
             </a:extLst>
           </p:cNvPr>
@@ -8664,7 +8664,7 @@
           <p:cNvPr id="12" name="">
             <a:extLst xmlns:a="http://schemas.openxmlformats.org/drawingml/2006/main">
               <a:ext uri="{FF2B5EF4-FFF2-40B4-BE49-F238E27FC236}">
-                <a16:creationId xmlns:a16="http://schemas.microsoft.com/office/drawing/2014/main" id="{956B2216-20C8-497C-B9A2-ED99BCB482D6}"/>
+                <a16:creationId xmlns:a16="http://schemas.microsoft.com/office/drawing/2014/main" id="{6C131826-CC7E-4059-99AD-53D94AED7CEC}"/>
               </a:ext>
             </a:extLst>
           </p:cNvPr>
@@ -8714,7 +8714,7 @@
           <p:cNvPr id="13" name="">
             <a:extLst xmlns:a="http://schemas.openxmlformats.org/drawingml/2006/main">
               <a:ext uri="{FF2B5EF4-FFF2-40B4-BE49-F238E27FC236}">
-                <a16:creationId xmlns:a16="http://schemas.microsoft.com/office/drawing/2014/main" id="{2BE15BC1-F0A9-4BAA-A56A-F6EA1E4A7455}"/>
+                <a16:creationId xmlns:a16="http://schemas.microsoft.com/office/drawing/2014/main" id="{682FC44E-2A97-4A51-B429-4BB7060AE189}"/>
               </a:ext>
             </a:extLst>
           </p:cNvPr>
@@ -8764,7 +8764,7 @@
           <p:cNvPr id="14" name="">
             <a:extLst xmlns:a="http://schemas.openxmlformats.org/drawingml/2006/main">
               <a:ext uri="{FF2B5EF4-FFF2-40B4-BE49-F238E27FC236}">
-                <a16:creationId xmlns:a16="http://schemas.microsoft.com/office/drawing/2014/main" id="{BA482017-FAC5-46E6-93F5-189CD89745A6}"/>
+                <a16:creationId xmlns:a16="http://schemas.microsoft.com/office/drawing/2014/main" id="{2854837C-56DE-485C-B515-D6604B4EEA19}"/>
               </a:ext>
             </a:extLst>
           </p:cNvPr>
@@ -8812,7 +8812,7 @@
     </p:spTree>
     <p:extLst>
       <p:ext uri="{BB962C8B-B14F-4D97-AF65-F5344CB8AC3E}">
-        <p14:creationId xmlns:p14="http://schemas.microsoft.com/office/powerpoint/2010/main" val="650054902"/>
+        <p14:creationId xmlns:p14="http://schemas.microsoft.com/office/powerpoint/2010/main" val="1056604863"/>
       </p:ext>
     </p:extLst>
   </p:cSld>
@@ -8843,7 +8843,7 @@
           <p:cNvPr id="1" name="">
             <a:extLst xmlns:a="http://schemas.openxmlformats.org/drawingml/2006/main">
               <a:ext uri="{FF2B5EF4-FFF2-40B4-BE49-F238E27FC236}">
-                <a16:creationId xmlns:a16="http://schemas.microsoft.com/office/drawing/2014/main" id="{7CC4CADE-CE36-41DA-9A63-17B459AD4D56}"/>
+                <a16:creationId xmlns:a16="http://schemas.microsoft.com/office/drawing/2014/main" id="{BA79D2E9-9D4A-43A7-B377-1632D599A130}"/>
               </a:ext>
             </a:extLst>
           </p:cNvPr>
@@ -8893,7 +8893,7 @@
           <p:cNvPr id="2" name="">
             <a:extLst xmlns:a="http://schemas.openxmlformats.org/drawingml/2006/main">
               <a:ext uri="{FF2B5EF4-FFF2-40B4-BE49-F238E27FC236}">
-                <a16:creationId xmlns:a16="http://schemas.microsoft.com/office/drawing/2014/main" id="{F4716DE7-5080-4E30-80E3-CE1402E5EFAA}"/>
+                <a16:creationId xmlns:a16="http://schemas.microsoft.com/office/drawing/2014/main" id="{C98100F3-3031-4A15-AE53-E5B5761972EE}"/>
               </a:ext>
             </a:extLst>
           </p:cNvPr>
@@ -8943,7 +8943,7 @@
           <p:cNvPr id="3" name="">
             <a:extLst xmlns:a="http://schemas.openxmlformats.org/drawingml/2006/main">
               <a:ext uri="{FF2B5EF4-FFF2-40B4-BE49-F238E27FC236}">
-                <a16:creationId xmlns:a16="http://schemas.microsoft.com/office/drawing/2014/main" id="{2E451FD3-589B-4629-9A64-FFAD59B599EA}"/>
+                <a16:creationId xmlns:a16="http://schemas.microsoft.com/office/drawing/2014/main" id="{DCC72EA7-CD1B-45B6-BD64-B206D1970C04}"/>
               </a:ext>
             </a:extLst>
           </p:cNvPr>
@@ -8976,7 +8976,7 @@
           <p:cNvPr id="4" name="">
             <a:extLst xmlns:a="http://schemas.openxmlformats.org/drawingml/2006/main">
               <a:ext uri="{FF2B5EF4-FFF2-40B4-BE49-F238E27FC236}">
-                <a16:creationId xmlns:a16="http://schemas.microsoft.com/office/drawing/2014/main" id="{A1221721-5289-446B-97A5-1B2392B7A074}"/>
+                <a16:creationId xmlns:a16="http://schemas.microsoft.com/office/drawing/2014/main" id="{D4EE5462-F50B-4C00-8CAB-8CD44CCC7E96}"/>
               </a:ext>
             </a:extLst>
           </p:cNvPr>
@@ -9026,7 +9026,7 @@
           <p:cNvPr id="5" name="">
             <a:extLst xmlns:a="http://schemas.openxmlformats.org/drawingml/2006/main">
               <a:ext uri="{FF2B5EF4-FFF2-40B4-BE49-F238E27FC236}">
-                <a16:creationId xmlns:a16="http://schemas.microsoft.com/office/drawing/2014/main" id="{A8EE5C8A-E1BF-4D2B-8538-FE534E0B043E}"/>
+                <a16:creationId xmlns:a16="http://schemas.microsoft.com/office/drawing/2014/main" id="{F794D36E-0C22-4E99-9CDE-93D53DB5F980}"/>
               </a:ext>
             </a:extLst>
           </p:cNvPr>
@@ -9076,7 +9076,7 @@
           <p:cNvPr id="6" name="">
             <a:extLst xmlns:a="http://schemas.openxmlformats.org/drawingml/2006/main">
               <a:ext uri="{FF2B5EF4-FFF2-40B4-BE49-F238E27FC236}">
-                <a16:creationId xmlns:a16="http://schemas.microsoft.com/office/drawing/2014/main" id="{96676800-50EE-43E3-818E-E4A6ECDC09A7}"/>
+                <a16:creationId xmlns:a16="http://schemas.microsoft.com/office/drawing/2014/main" id="{FE36CBBE-4D17-4CE7-A846-BD25966F0DD8}"/>
               </a:ext>
             </a:extLst>
           </p:cNvPr>
@@ -9126,7 +9126,7 @@
           <p:cNvPr id="7" name="">
             <a:extLst xmlns:a="http://schemas.openxmlformats.org/drawingml/2006/main">
               <a:ext uri="{FF2B5EF4-FFF2-40B4-BE49-F238E27FC236}">
-                <a16:creationId xmlns:a16="http://schemas.microsoft.com/office/drawing/2014/main" id="{D11F6D88-C4A3-4279-B493-625DCC750923}"/>
+                <a16:creationId xmlns:a16="http://schemas.microsoft.com/office/drawing/2014/main" id="{D7A68E51-2C05-42ED-8697-111D167936B8}"/>
               </a:ext>
             </a:extLst>
           </p:cNvPr>
@@ -9176,7 +9176,7 @@
           <p:cNvPr id="8" name="">
             <a:extLst xmlns:a="http://schemas.openxmlformats.org/drawingml/2006/main">
               <a:ext uri="{FF2B5EF4-FFF2-40B4-BE49-F238E27FC236}">
-                <a16:creationId xmlns:a16="http://schemas.microsoft.com/office/drawing/2014/main" id="{BC0A54F1-BA30-4D1B-89C9-50E8176551C7}"/>
+                <a16:creationId xmlns:a16="http://schemas.microsoft.com/office/drawing/2014/main" id="{A6954B70-C95B-45A6-B007-C2F3630543C4}"/>
               </a:ext>
             </a:extLst>
           </p:cNvPr>
@@ -9226,7 +9226,7 @@
           <p:cNvPr id="9" name="">
             <a:extLst xmlns:a="http://schemas.openxmlformats.org/drawingml/2006/main">
               <a:ext uri="{FF2B5EF4-FFF2-40B4-BE49-F238E27FC236}">
-                <a16:creationId xmlns:a16="http://schemas.microsoft.com/office/drawing/2014/main" id="{4BBF4A5E-710D-4B9A-8C4F-320E10B7BE1F}"/>
+                <a16:creationId xmlns:a16="http://schemas.microsoft.com/office/drawing/2014/main" id="{75C620A0-CE54-4084-B6B2-51DA7E98E27D}"/>
               </a:ext>
             </a:extLst>
           </p:cNvPr>
@@ -9276,7 +9276,7 @@
           <p:cNvPr id="10" name="">
             <a:extLst xmlns:a="http://schemas.openxmlformats.org/drawingml/2006/main">
               <a:ext uri="{FF2B5EF4-FFF2-40B4-BE49-F238E27FC236}">
-                <a16:creationId xmlns:a16="http://schemas.microsoft.com/office/drawing/2014/main" id="{56E5A499-C00E-4A40-9A46-5B7C92383335}"/>
+                <a16:creationId xmlns:a16="http://schemas.microsoft.com/office/drawing/2014/main" id="{317A2837-D3D9-4169-A85F-92E0B1E62B8B}"/>
               </a:ext>
             </a:extLst>
           </p:cNvPr>
@@ -9309,7 +9309,7 @@
           <p:cNvPr id="11" name="">
             <a:extLst xmlns:a="http://schemas.openxmlformats.org/drawingml/2006/main">
               <a:ext uri="{FF2B5EF4-FFF2-40B4-BE49-F238E27FC236}">
-                <a16:creationId xmlns:a16="http://schemas.microsoft.com/office/drawing/2014/main" id="{0E5938CC-A002-444F-A718-EAB5A5D9610E}"/>
+                <a16:creationId xmlns:a16="http://schemas.microsoft.com/office/drawing/2014/main" id="{2A55D1DE-40CD-449F-A749-AE70BBB789AB}"/>
               </a:ext>
             </a:extLst>
           </p:cNvPr>
@@ -9359,7 +9359,7 @@
           <p:cNvPr id="12" name="">
             <a:extLst xmlns:a="http://schemas.openxmlformats.org/drawingml/2006/main">
               <a:ext uri="{FF2B5EF4-FFF2-40B4-BE49-F238E27FC236}">
-                <a16:creationId xmlns:a16="http://schemas.microsoft.com/office/drawing/2014/main" id="{46FB59CE-2A5F-4C96-BBF1-FCCECA66E134}"/>
+                <a16:creationId xmlns:a16="http://schemas.microsoft.com/office/drawing/2014/main" id="{1488D620-5CF9-427F-8541-3C9D9D2465ED}"/>
               </a:ext>
             </a:extLst>
           </p:cNvPr>
@@ -9407,7 +9407,7 @@
     </p:spTree>
     <p:extLst>
       <p:ext uri="{BB962C8B-B14F-4D97-AF65-F5344CB8AC3E}">
-        <p14:creationId xmlns:p14="http://schemas.microsoft.com/office/powerpoint/2010/main" val="1628140241"/>
+        <p14:creationId xmlns:p14="http://schemas.microsoft.com/office/powerpoint/2010/main" val="2024501700"/>
       </p:ext>
     </p:extLst>
   </p:cSld>
@@ -9438,7 +9438,7 @@
           <p:cNvPr id="1" name="">
             <a:extLst xmlns:a="http://schemas.openxmlformats.org/drawingml/2006/main">
               <a:ext uri="{FF2B5EF4-FFF2-40B4-BE49-F238E27FC236}">
-                <a16:creationId xmlns:a16="http://schemas.microsoft.com/office/drawing/2014/main" id="{FCEB1CBC-C6B3-4CEA-9648-1A46E8A5371D}"/>
+                <a16:creationId xmlns:a16="http://schemas.microsoft.com/office/drawing/2014/main" id="{A770D647-1CFD-4044-B54B-25E134FFC6E6}"/>
               </a:ext>
             </a:extLst>
           </p:cNvPr>
@@ -9488,7 +9488,7 @@
           <p:cNvPr id="2" name="">
             <a:extLst xmlns:a="http://schemas.openxmlformats.org/drawingml/2006/main">
               <a:ext uri="{FF2B5EF4-FFF2-40B4-BE49-F238E27FC236}">
-                <a16:creationId xmlns:a16="http://schemas.microsoft.com/office/drawing/2014/main" id="{BDE26AD3-01DB-48F9-9508-19DA4B612442}"/>
+                <a16:creationId xmlns:a16="http://schemas.microsoft.com/office/drawing/2014/main" id="{69FBB758-FD4D-4DB1-BE91-B388153D8C8A}"/>
               </a:ext>
             </a:extLst>
           </p:cNvPr>
@@ -9538,7 +9538,7 @@
           <p:cNvPr id="3" name="">
             <a:extLst xmlns:a="http://schemas.openxmlformats.org/drawingml/2006/main">
               <a:ext uri="{FF2B5EF4-FFF2-40B4-BE49-F238E27FC236}">
-                <a16:creationId xmlns:a16="http://schemas.microsoft.com/office/drawing/2014/main" id="{FB73DBD6-4DCA-4A23-AEF3-64CA75E29A31}"/>
+                <a16:creationId xmlns:a16="http://schemas.microsoft.com/office/drawing/2014/main" id="{B005CFA3-BC03-46D1-9C9C-69CE6E869D97}"/>
               </a:ext>
             </a:extLst>
           </p:cNvPr>
@@ -9575,7 +9575,7 @@
           <p:nvPr/>
         </p:nvPicPr>
         <p:blipFill>
-          <a:blip xmlns:r="http://schemas.openxmlformats.org/officeDocument/2006/relationships" xmlns:a="http://schemas.openxmlformats.org/drawingml/2006/main" r:embed="Rbd22ba7118294e99"/>
+          <a:blip xmlns:r="http://schemas.openxmlformats.org/officeDocument/2006/relationships" xmlns:a="http://schemas.openxmlformats.org/drawingml/2006/main" r:embed="Rcb0aa4bbea08452b"/>
           <a:stretch xmlns:a="http://schemas.openxmlformats.org/drawingml/2006/main"/>
         </p:blipFill>
         <p:spPr>
@@ -9593,7 +9593,7 @@
           <p:cNvPr id="5" name="">
             <a:extLst xmlns:a="http://schemas.openxmlformats.org/drawingml/2006/main">
               <a:ext uri="{FF2B5EF4-FFF2-40B4-BE49-F238E27FC236}">
-                <a16:creationId xmlns:a16="http://schemas.microsoft.com/office/drawing/2014/main" id="{0682E8C0-2525-4B55-85BB-0D17D272F2FA}"/>
+                <a16:creationId xmlns:a16="http://schemas.microsoft.com/office/drawing/2014/main" id="{9036B87B-BC10-45DB-993B-D1E98D518427}"/>
               </a:ext>
             </a:extLst>
           </p:cNvPr>
@@ -9641,7 +9641,7 @@
     </p:spTree>
     <p:extLst>
       <p:ext uri="{BB962C8B-B14F-4D97-AF65-F5344CB8AC3E}">
-        <p14:creationId xmlns:p14="http://schemas.microsoft.com/office/powerpoint/2010/main" val="631542211"/>
+        <p14:creationId xmlns:p14="http://schemas.microsoft.com/office/powerpoint/2010/main" val="2081715827"/>
       </p:ext>
     </p:extLst>
   </p:cSld>
@@ -9672,7 +9672,7 @@
           <p:cNvPr id="1" name="">
             <a:extLst xmlns:a="http://schemas.openxmlformats.org/drawingml/2006/main">
               <a:ext uri="{FF2B5EF4-FFF2-40B4-BE49-F238E27FC236}">
-                <a16:creationId xmlns:a16="http://schemas.microsoft.com/office/drawing/2014/main" id="{75AF008F-CA67-46D2-8C1E-43B2BFC7313F}"/>
+                <a16:creationId xmlns:a16="http://schemas.microsoft.com/office/drawing/2014/main" id="{A6252752-9CAD-4D6A-B80B-906048239374}"/>
               </a:ext>
             </a:extLst>
           </p:cNvPr>
@@ -9722,7 +9722,7 @@
           <p:cNvPr id="2" name="">
             <a:extLst xmlns:a="http://schemas.openxmlformats.org/drawingml/2006/main">
               <a:ext uri="{FF2B5EF4-FFF2-40B4-BE49-F238E27FC236}">
-                <a16:creationId xmlns:a16="http://schemas.microsoft.com/office/drawing/2014/main" id="{D6500749-1849-4F0A-BD28-AC0F54DCEF07}"/>
+                <a16:creationId xmlns:a16="http://schemas.microsoft.com/office/drawing/2014/main" id="{902C3908-E1E5-438A-9B8C-9621431203BD}"/>
               </a:ext>
             </a:extLst>
           </p:cNvPr>
@@ -9772,7 +9772,7 @@
           <p:cNvPr id="3" name="">
             <a:extLst xmlns:a="http://schemas.openxmlformats.org/drawingml/2006/main">
               <a:ext uri="{FF2B5EF4-FFF2-40B4-BE49-F238E27FC236}">
-                <a16:creationId xmlns:a16="http://schemas.microsoft.com/office/drawing/2014/main" id="{39700B97-C5A2-4775-A8E1-8EDC2747E22B}"/>
+                <a16:creationId xmlns:a16="http://schemas.microsoft.com/office/drawing/2014/main" id="{63F370FE-C1DE-4ABE-9B88-F6B022B63EBA}"/>
               </a:ext>
             </a:extLst>
           </p:cNvPr>
@@ -9809,7 +9809,7 @@
           <p:nvPr/>
         </p:nvPicPr>
         <p:blipFill>
-          <a:blip xmlns:r="http://schemas.openxmlformats.org/officeDocument/2006/relationships" xmlns:a="http://schemas.openxmlformats.org/drawingml/2006/main" r:embed="R22b215d1aa344534"/>
+          <a:blip xmlns:r="http://schemas.openxmlformats.org/officeDocument/2006/relationships" xmlns:a="http://schemas.openxmlformats.org/drawingml/2006/main" r:embed="Raadc0b3714644202"/>
           <a:stretch xmlns:a="http://schemas.openxmlformats.org/drawingml/2006/main"/>
         </p:blipFill>
         <p:spPr>
@@ -9827,7 +9827,7 @@
           <p:cNvPr id="5" name="">
             <a:extLst xmlns:a="http://schemas.openxmlformats.org/drawingml/2006/main">
               <a:ext uri="{FF2B5EF4-FFF2-40B4-BE49-F238E27FC236}">
-                <a16:creationId xmlns:a16="http://schemas.microsoft.com/office/drawing/2014/main" id="{E45B0C9A-E0E8-4A10-9E57-0A56FE6D2EAD}"/>
+                <a16:creationId xmlns:a16="http://schemas.microsoft.com/office/drawing/2014/main" id="{5C33E4A1-F095-48B4-BF95-01873EAE38C0}"/>
               </a:ext>
             </a:extLst>
           </p:cNvPr>
@@ -9860,7 +9860,7 @@
           <p:cNvPr id="6" name="">
             <a:extLst xmlns:a="http://schemas.openxmlformats.org/drawingml/2006/main">
               <a:ext uri="{FF2B5EF4-FFF2-40B4-BE49-F238E27FC236}">
-                <a16:creationId xmlns:a16="http://schemas.microsoft.com/office/drawing/2014/main" id="{9C5F2C23-4B12-44B7-AF15-C51E9F95C315}"/>
+                <a16:creationId xmlns:a16="http://schemas.microsoft.com/office/drawing/2014/main" id="{54722793-4501-4E2B-AC49-9325CAFF6950}"/>
               </a:ext>
             </a:extLst>
           </p:cNvPr>
@@ -9910,7 +9910,7 @@
           <p:cNvPr id="7" name="">
             <a:extLst xmlns:a="http://schemas.openxmlformats.org/drawingml/2006/main">
               <a:ext uri="{FF2B5EF4-FFF2-40B4-BE49-F238E27FC236}">
-                <a16:creationId xmlns:a16="http://schemas.microsoft.com/office/drawing/2014/main" id="{46411D6D-F761-4709-8193-37A8617CF2F0}"/>
+                <a16:creationId xmlns:a16="http://schemas.microsoft.com/office/drawing/2014/main" id="{FA663217-C362-4825-B6E6-22126DC64776}"/>
               </a:ext>
             </a:extLst>
           </p:cNvPr>
@@ -9943,7 +9943,7 @@
           <p:cNvPr id="8" name="">
             <a:extLst xmlns:a="http://schemas.openxmlformats.org/drawingml/2006/main">
               <a:ext uri="{FF2B5EF4-FFF2-40B4-BE49-F238E27FC236}">
-                <a16:creationId xmlns:a16="http://schemas.microsoft.com/office/drawing/2014/main" id="{F27A0EDB-F965-437F-8368-422E24F45988}"/>
+                <a16:creationId xmlns:a16="http://schemas.microsoft.com/office/drawing/2014/main" id="{273B2FD5-B6A3-498C-89FD-E0CCD40761E2}"/>
               </a:ext>
             </a:extLst>
           </p:cNvPr>
@@ -9993,7 +9993,7 @@
           <p:cNvPr id="9" name="">
             <a:extLst xmlns:a="http://schemas.openxmlformats.org/drawingml/2006/main">
               <a:ext uri="{FF2B5EF4-FFF2-40B4-BE49-F238E27FC236}">
-                <a16:creationId xmlns:a16="http://schemas.microsoft.com/office/drawing/2014/main" id="{4ACD7169-F497-45EA-A999-D8CEC9BCE5E0}"/>
+                <a16:creationId xmlns:a16="http://schemas.microsoft.com/office/drawing/2014/main" id="{4637CDB5-1162-42F8-9873-73B45DE3B762}"/>
               </a:ext>
             </a:extLst>
           </p:cNvPr>
@@ -10026,7 +10026,7 @@
           <p:cNvPr id="10" name="">
             <a:extLst xmlns:a="http://schemas.openxmlformats.org/drawingml/2006/main">
               <a:ext uri="{FF2B5EF4-FFF2-40B4-BE49-F238E27FC236}">
-                <a16:creationId xmlns:a16="http://schemas.microsoft.com/office/drawing/2014/main" id="{CEA063BB-C583-446C-BF87-73ADFD58987F}"/>
+                <a16:creationId xmlns:a16="http://schemas.microsoft.com/office/drawing/2014/main" id="{E689DEB2-E85C-49D5-AEEF-903608F5CC7D}"/>
               </a:ext>
             </a:extLst>
           </p:cNvPr>
@@ -10076,7 +10076,7 @@
           <p:cNvPr id="11" name="">
             <a:extLst xmlns:a="http://schemas.openxmlformats.org/drawingml/2006/main">
               <a:ext uri="{FF2B5EF4-FFF2-40B4-BE49-F238E27FC236}">
-                <a16:creationId xmlns:a16="http://schemas.microsoft.com/office/drawing/2014/main" id="{0BB7D1FC-97D7-40C0-8082-AFC9E2169782}"/>
+                <a16:creationId xmlns:a16="http://schemas.microsoft.com/office/drawing/2014/main" id="{94FB85D9-3ED7-4634-9B04-7828891795CA}"/>
               </a:ext>
             </a:extLst>
           </p:cNvPr>
@@ -10109,7 +10109,7 @@
           <p:cNvPr id="12" name="">
             <a:extLst xmlns:a="http://schemas.openxmlformats.org/drawingml/2006/main">
               <a:ext uri="{FF2B5EF4-FFF2-40B4-BE49-F238E27FC236}">
-                <a16:creationId xmlns:a16="http://schemas.microsoft.com/office/drawing/2014/main" id="{D6ECEE2F-FDF4-4FA5-9335-7E9D9C9BE2DA}"/>
+                <a16:creationId xmlns:a16="http://schemas.microsoft.com/office/drawing/2014/main" id="{8A5E2E42-7D78-4B0A-BC73-206219243DB5}"/>
               </a:ext>
             </a:extLst>
           </p:cNvPr>
@@ -10159,7 +10159,7 @@
           <p:cNvPr id="13" name="">
             <a:extLst xmlns:a="http://schemas.openxmlformats.org/drawingml/2006/main">
               <a:ext uri="{FF2B5EF4-FFF2-40B4-BE49-F238E27FC236}">
-                <a16:creationId xmlns:a16="http://schemas.microsoft.com/office/drawing/2014/main" id="{C8146A87-713A-4FBE-BB7A-573A6916D191}"/>
+                <a16:creationId xmlns:a16="http://schemas.microsoft.com/office/drawing/2014/main" id="{44222D68-8A0D-488A-812E-17E80E2FCDA0}"/>
               </a:ext>
             </a:extLst>
           </p:cNvPr>
@@ -10207,7 +10207,7 @@
     </p:spTree>
     <p:extLst>
       <p:ext uri="{BB962C8B-B14F-4D97-AF65-F5344CB8AC3E}">
-        <p14:creationId xmlns:p14="http://schemas.microsoft.com/office/powerpoint/2010/main" val="2081344880"/>
+        <p14:creationId xmlns:p14="http://schemas.microsoft.com/office/powerpoint/2010/main" val="2056252923"/>
       </p:ext>
     </p:extLst>
   </p:cSld>
@@ -10238,7 +10238,7 @@
           <p:cNvPr id="1" name="">
             <a:extLst xmlns:a="http://schemas.openxmlformats.org/drawingml/2006/main">
               <a:ext uri="{FF2B5EF4-FFF2-40B4-BE49-F238E27FC236}">
-                <a16:creationId xmlns:a16="http://schemas.microsoft.com/office/drawing/2014/main" id="{6F2329DD-E2C4-4F73-8EA6-FC48E9AD3879}"/>
+                <a16:creationId xmlns:a16="http://schemas.microsoft.com/office/drawing/2014/main" id="{24B97CFC-3A3E-4BC9-B296-EADD206CCE6E}"/>
               </a:ext>
             </a:extLst>
           </p:cNvPr>
@@ -10278,7 +10278,7 @@
                   <a:srgbClr val="0A0A0A"/>
                 </a:solidFill>
               </a:rPr>
-              <a:t>The failure cases are visually plausible</a:t>
+              <a:t>The wow demo classifies a digit drawn live</a:t>
             </a:r>
           </a:p>
         </p:txBody>
@@ -10288,7 +10288,7 @@
           <p:cNvPr id="2" name="">
             <a:extLst xmlns:a="http://schemas.openxmlformats.org/drawingml/2006/main">
               <a:ext uri="{FF2B5EF4-FFF2-40B4-BE49-F238E27FC236}">
-                <a16:creationId xmlns:a16="http://schemas.microsoft.com/office/drawing/2014/main" id="{A1EF3A26-2D28-4BF6-B260-06D3A1659368}"/>
+                <a16:creationId xmlns:a16="http://schemas.microsoft.com/office/drawing/2014/main" id="{C0A0409F-EEEA-44F2-A714-C15ED291FBBD}"/>
               </a:ext>
             </a:extLst>
           </p:cNvPr>
@@ -10328,7 +10328,7 @@
                   <a:srgbClr val="555555"/>
                 </a:solidFill>
               </a:rPr>
-              <a:t>Misclassified examples usually have ambiguous strokes, unusual centering, or digit shapes close to another class.</a:t>
+              <a:t>A browser canvas sends the drawing to the trained PyTorch checkpoint and returns class probabilities.</a:t>
             </a:r>
           </a:p>
         </p:txBody>
@@ -10338,7 +10338,7 @@
           <p:cNvPr id="3" name="">
             <a:extLst xmlns:a="http://schemas.openxmlformats.org/drawingml/2006/main">
               <a:ext uri="{FF2B5EF4-FFF2-40B4-BE49-F238E27FC236}">
-                <a16:creationId xmlns:a16="http://schemas.microsoft.com/office/drawing/2014/main" id="{2B1AFC8F-6C4E-4D0D-BF8F-0AA05AD975CA}"/>
+                <a16:creationId xmlns:a16="http://schemas.microsoft.com/office/drawing/2014/main" id="{0F2E8850-7DB8-46E6-ADC5-F4E3CDDAC9DE}"/>
               </a:ext>
             </a:extLst>
           </p:cNvPr>
@@ -10366,46 +10366,107 @@
           </a:ln>
         </p:spPr>
       </p:sp>
-      <p:pic>
-        <p:nvPicPr>
-          <p:cNvPr id="10" name=""/>
-          <p:cNvPicPr>
-            <a:picLocks xmlns:a="http://schemas.openxmlformats.org/drawingml/2006/main" noChangeAspect="1"/>
-          </p:cNvPicPr>
-          <p:nvPr/>
-        </p:nvPicPr>
-        <p:blipFill>
-          <a:blip xmlns:r="http://schemas.openxmlformats.org/officeDocument/2006/relationships" xmlns:a="http://schemas.openxmlformats.org/drawingml/2006/main" r:embed="R19d2d0dc8a5d4fdb"/>
-          <a:stretch xmlns:a="http://schemas.openxmlformats.org/drawingml/2006/main"/>
-        </p:blipFill>
-        <p:spPr>
-          <a:xfrm xmlns:a="http://schemas.openxmlformats.org/drawingml/2006/main">
-            <a:off x="1775069" y="2038350"/>
-            <a:ext cx="5250962" cy="4095750"/>
-          </a:xfrm>
-          <a:prstGeom xmlns:a="http://schemas.openxmlformats.org/drawingml/2006/main" prst="rect">
-            <a:avLst/>
-          </a:prstGeom>
-        </p:spPr>
-      </p:pic>
+      <p:sp>
+        <p:nvSpPr>
+          <p:cNvPr id="4" name="">
+            <a:extLst xmlns:a="http://schemas.openxmlformats.org/drawingml/2006/main">
+              <a:ext uri="{FF2B5EF4-FFF2-40B4-BE49-F238E27FC236}">
+                <a16:creationId xmlns:a16="http://schemas.microsoft.com/office/drawing/2014/main" id="{FE7CBC2C-B33A-45BC-973A-108A16D16473}"/>
+              </a:ext>
+            </a:extLst>
+          </p:cNvPr>
+          <p:cNvSpPr>
+            <a:spLocks xmlns:a="http://schemas.openxmlformats.org/drawingml/2006/main" noGrp="1"/>
+          </p:cNvSpPr>
+          <p:nvPr/>
+        </p:nvSpPr>
+        <p:spPr>
+          <a:xfrm xmlns:a="http://schemas.openxmlformats.org/drawingml/2006/main">
+            <a:off x="876300" y="2266950"/>
+            <a:ext cx="3733800" cy="3009900"/>
+          </a:xfrm>
+          <a:prstGeom xmlns:a="http://schemas.openxmlformats.org/drawingml/2006/main" prst="rect">
+            <a:avLst/>
+          </a:prstGeom>
+          <a:solidFill xmlns:a="http://schemas.openxmlformats.org/drawingml/2006/main">
+            <a:srgbClr val="111111"/>
+          </a:solidFill>
+          <a:ln xmlns:a="http://schemas.openxmlformats.org/drawingml/2006/main" w="9525">
+            <a:solidFill>
+              <a:srgbClr val="B8BCC4"/>
+            </a:solidFill>
+            <a:prstDash val="solid"/>
+          </a:ln>
+        </p:spPr>
+      </p:sp>
       <p:sp>
         <p:nvSpPr>
           <p:cNvPr id="5" name="">
             <a:extLst xmlns:a="http://schemas.openxmlformats.org/drawingml/2006/main">
               <a:ext uri="{FF2B5EF4-FFF2-40B4-BE49-F238E27FC236}">
-                <a16:creationId xmlns:a16="http://schemas.microsoft.com/office/drawing/2014/main" id="{EF09F0A1-CE43-4E80-A37B-8249310200A0}"/>
-              </a:ext>
-            </a:extLst>
-          </p:cNvPr>
-          <p:cNvSpPr>
-            <a:spLocks xmlns:a="http://schemas.openxmlformats.org/drawingml/2006/main" noGrp="1"/>
-          </p:cNvSpPr>
-          <p:nvPr/>
-        </p:nvSpPr>
-        <p:spPr>
-          <a:xfrm xmlns:a="http://schemas.openxmlformats.org/drawingml/2006/main">
-            <a:off x="8382000" y="2876550"/>
-            <a:ext cx="2857500" cy="1524000"/>
+                <a16:creationId xmlns:a16="http://schemas.microsoft.com/office/drawing/2014/main" id="{5BDAD095-4DAC-48AC-A5D0-C7A97B4E1A3B}"/>
+              </a:ext>
+            </a:extLst>
+          </p:cNvPr>
+          <p:cNvSpPr>
+            <a:spLocks xmlns:a="http://schemas.openxmlformats.org/drawingml/2006/main" noGrp="1"/>
+          </p:cNvSpPr>
+          <p:nvPr/>
+        </p:nvSpPr>
+        <p:spPr>
+          <a:xfrm xmlns:a="http://schemas.openxmlformats.org/drawingml/2006/main">
+            <a:off x="1638300" y="2457450"/>
+            <a:ext cx="2209800" cy="2324100"/>
+          </a:xfrm>
+          <a:prstGeom xmlns:a="http://schemas.openxmlformats.org/drawingml/2006/main" prst="rect">
+            <a:avLst/>
+          </a:prstGeom>
+          <a:noFill xmlns:a="http://schemas.openxmlformats.org/drawingml/2006/main"/>
+          <a:ln xmlns:a="http://schemas.openxmlformats.org/drawingml/2006/main" w="0">
+            <a:noFill/>
+            <a:prstDash val="solid"/>
+          </a:ln>
+        </p:spPr>
+        <p:txBody>
+          <a:bodyPr xmlns:a="http://schemas.openxmlformats.org/drawingml/2006/main"/>
+          <a:lstStyle xmlns:a="http://schemas.openxmlformats.org/drawingml/2006/main"/>
+          <a:p xmlns:a="http://schemas.openxmlformats.org/drawingml/2006/main">
+            <a:pPr algn="ctr">
+              <a:defRPr sz="13350" b="1">
+                <a:solidFill>
+                  <a:srgbClr val="FFFFFF"/>
+                </a:solidFill>
+              </a:defRPr>
+            </a:pPr>
+            <a:r>
+              <a:rPr sz="13350" b="1">
+                <a:solidFill>
+                  <a:srgbClr val="FFFFFF"/>
+                </a:solidFill>
+              </a:rPr>
+              <a:t>7</a:t>
+            </a:r>
+          </a:p>
+        </p:txBody>
+      </p:sp>
+      <p:sp>
+        <p:nvSpPr>
+          <p:cNvPr id="6" name="">
+            <a:extLst xmlns:a="http://schemas.openxmlformats.org/drawingml/2006/main">
+              <a:ext uri="{FF2B5EF4-FFF2-40B4-BE49-F238E27FC236}">
+                <a16:creationId xmlns:a16="http://schemas.microsoft.com/office/drawing/2014/main" id="{6AB1AE5C-4FDA-4F0F-8FD2-611BFEA74BEC}"/>
+              </a:ext>
+            </a:extLst>
+          </p:cNvPr>
+          <p:cNvSpPr>
+            <a:spLocks xmlns:a="http://schemas.openxmlformats.org/drawingml/2006/main" noGrp="1"/>
+          </p:cNvSpPr>
+          <p:nvPr/>
+        </p:nvSpPr>
+        <p:spPr>
+          <a:xfrm xmlns:a="http://schemas.openxmlformats.org/drawingml/2006/main">
+            <a:off x="5353050" y="2419350"/>
+            <a:ext cx="5334000" cy="438150"/>
           </a:xfrm>
           <a:prstGeom xmlns:a="http://schemas.openxmlformats.org/drawingml/2006/main" prst="rect">
             <a:avLst/>
@@ -10421,29 +10482,411 @@
           <a:lstStyle xmlns:a="http://schemas.openxmlformats.org/drawingml/2006/main"/>
           <a:p xmlns:a="http://schemas.openxmlformats.org/drawingml/2006/main">
             <a:pPr algn="l">
-              <a:defRPr sz="2025" b="1">
-                <a:solidFill>
-                  <a:srgbClr val="0A0A0A"/>
-                </a:solidFill>
-              </a:defRPr>
-            </a:pPr>
-            <a:r>
-              <a:rPr sz="2025" b="1">
-                <a:solidFill>
-                  <a:srgbClr val="0A0A0A"/>
-                </a:solidFill>
-              </a:rPr>
-              <a:t>This is the most honest part of the demo: the model works well, but its mistakes are understandable and should be discussed.</a:t>
-            </a:r>
-          </a:p>
-        </p:txBody>
-      </p:sp>
-      <p:sp>
-        <p:nvSpPr>
-          <p:cNvPr id="6" name="">
-            <a:extLst xmlns:a="http://schemas.openxmlformats.org/drawingml/2006/main">
-              <a:ext uri="{FF2B5EF4-FFF2-40B4-BE49-F238E27FC236}">
-                <a16:creationId xmlns:a16="http://schemas.microsoft.com/office/drawing/2014/main" id="{A8B850A9-8B06-4780-8AF4-A6DE578C09AA}"/>
+              <a:defRPr sz="2550" b="1">
+                <a:solidFill>
+                  <a:srgbClr val="0A0A0A"/>
+                </a:solidFill>
+              </a:defRPr>
+            </a:pPr>
+            <a:r>
+              <a:rPr sz="2550" b="1">
+                <a:solidFill>
+                  <a:srgbClr val="0A0A0A"/>
+                </a:solidFill>
+              </a:rPr>
+              <a:t>python app.py</a:t>
+            </a:r>
+          </a:p>
+        </p:txBody>
+      </p:sp>
+      <p:sp>
+        <p:nvSpPr>
+          <p:cNvPr id="7" name="">
+            <a:extLst xmlns:a="http://schemas.openxmlformats.org/drawingml/2006/main">
+              <a:ext uri="{FF2B5EF4-FFF2-40B4-BE49-F238E27FC236}">
+                <a16:creationId xmlns:a16="http://schemas.microsoft.com/office/drawing/2014/main" id="{081F701F-DA21-404F-ACCC-7EE3D7C16472}"/>
+              </a:ext>
+            </a:extLst>
+          </p:cNvPr>
+          <p:cNvSpPr>
+            <a:spLocks xmlns:a="http://schemas.openxmlformats.org/drawingml/2006/main" noGrp="1"/>
+          </p:cNvSpPr>
+          <p:nvPr/>
+        </p:nvSpPr>
+        <p:spPr>
+          <a:xfrm xmlns:a="http://schemas.openxmlformats.org/drawingml/2006/main">
+            <a:off x="5353050" y="3028950"/>
+            <a:ext cx="5334000" cy="742950"/>
+          </a:xfrm>
+          <a:prstGeom xmlns:a="http://schemas.openxmlformats.org/drawingml/2006/main" prst="rect">
+            <a:avLst/>
+          </a:prstGeom>
+          <a:noFill xmlns:a="http://schemas.openxmlformats.org/drawingml/2006/main"/>
+          <a:ln xmlns:a="http://schemas.openxmlformats.org/drawingml/2006/main" w="0">
+            <a:noFill/>
+            <a:prstDash val="solid"/>
+          </a:ln>
+        </p:spPr>
+        <p:txBody>
+          <a:bodyPr xmlns:a="http://schemas.openxmlformats.org/drawingml/2006/main"/>
+          <a:lstStyle xmlns:a="http://schemas.openxmlformats.org/drawingml/2006/main"/>
+          <a:p xmlns:a="http://schemas.openxmlformats.org/drawingml/2006/main">
+            <a:pPr algn="l">
+              <a:defRPr sz="2100" b="0">
+                <a:solidFill>
+                  <a:srgbClr val="0A0A0A"/>
+                </a:solidFill>
+              </a:defRPr>
+            </a:pPr>
+            <a:r>
+              <a:rPr sz="2100" b="0">
+                <a:solidFill>
+                  <a:srgbClr val="0A0A0A"/>
+                </a:solidFill>
+              </a:rPr>
+              <a:t>Open http://127.0.0.1:5000, draw a digit, and click Classify.</a:t>
+            </a:r>
+          </a:p>
+        </p:txBody>
+      </p:sp>
+      <p:sp>
+        <p:nvSpPr>
+          <p:cNvPr id="8" name="">
+            <a:extLst xmlns:a="http://schemas.openxmlformats.org/drawingml/2006/main">
+              <a:ext uri="{FF2B5EF4-FFF2-40B4-BE49-F238E27FC236}">
+                <a16:creationId xmlns:a16="http://schemas.microsoft.com/office/drawing/2014/main" id="{5EB24579-243F-4D8D-AC95-031D378AAEBB}"/>
+              </a:ext>
+            </a:extLst>
+          </p:cNvPr>
+          <p:cNvSpPr>
+            <a:spLocks xmlns:a="http://schemas.openxmlformats.org/drawingml/2006/main" noGrp="1"/>
+          </p:cNvSpPr>
+          <p:nvPr/>
+        </p:nvSpPr>
+        <p:spPr>
+          <a:xfrm xmlns:a="http://schemas.openxmlformats.org/drawingml/2006/main">
+            <a:off x="5353050" y="4133850"/>
+            <a:ext cx="66675" cy="66675"/>
+          </a:xfrm>
+          <a:prstGeom xmlns:a="http://schemas.openxmlformats.org/drawingml/2006/main" prst="rect">
+            <a:avLst/>
+          </a:prstGeom>
+          <a:solidFill xmlns:a="http://schemas.openxmlformats.org/drawingml/2006/main">
+            <a:srgbClr val="FF6B35"/>
+          </a:solidFill>
+          <a:ln xmlns:a="http://schemas.openxmlformats.org/drawingml/2006/main" w="0">
+            <a:solidFill>
+              <a:srgbClr val="FF6B35"/>
+            </a:solidFill>
+            <a:prstDash val="solid"/>
+          </a:ln>
+        </p:spPr>
+      </p:sp>
+      <p:sp>
+        <p:nvSpPr>
+          <p:cNvPr id="9" name="">
+            <a:extLst xmlns:a="http://schemas.openxmlformats.org/drawingml/2006/main">
+              <a:ext uri="{FF2B5EF4-FFF2-40B4-BE49-F238E27FC236}">
+                <a16:creationId xmlns:a16="http://schemas.microsoft.com/office/drawing/2014/main" id="{63EEF438-ADA5-4E6F-BA48-E45EA26EAC6C}"/>
+              </a:ext>
+            </a:extLst>
+          </p:cNvPr>
+          <p:cNvSpPr>
+            <a:spLocks xmlns:a="http://schemas.openxmlformats.org/drawingml/2006/main" noGrp="1"/>
+          </p:cNvSpPr>
+          <p:nvPr/>
+        </p:nvSpPr>
+        <p:spPr>
+          <a:xfrm xmlns:a="http://schemas.openxmlformats.org/drawingml/2006/main">
+            <a:off x="5581650" y="4038600"/>
+            <a:ext cx="5105400" cy="400050"/>
+          </a:xfrm>
+          <a:prstGeom xmlns:a="http://schemas.openxmlformats.org/drawingml/2006/main" prst="rect">
+            <a:avLst/>
+          </a:prstGeom>
+          <a:noFill xmlns:a="http://schemas.openxmlformats.org/drawingml/2006/main"/>
+          <a:ln xmlns:a="http://schemas.openxmlformats.org/drawingml/2006/main" w="0">
+            <a:noFill/>
+            <a:prstDash val="solid"/>
+          </a:ln>
+        </p:spPr>
+        <p:txBody>
+          <a:bodyPr xmlns:a="http://schemas.openxmlformats.org/drawingml/2006/main"/>
+          <a:lstStyle xmlns:a="http://schemas.openxmlformats.org/drawingml/2006/main"/>
+          <a:p xmlns:a="http://schemas.openxmlformats.org/drawingml/2006/main">
+            <a:pPr algn="l">
+              <a:defRPr sz="1650" b="0">
+                <a:solidFill>
+                  <a:srgbClr val="0A0A0A"/>
+                </a:solidFill>
+              </a:defRPr>
+            </a:pPr>
+            <a:r>
+              <a:rPr sz="1650" b="0">
+                <a:solidFill>
+                  <a:srgbClr val="0A0A0A"/>
+                </a:solidFill>
+              </a:rPr>
+              <a:t>Uses the committed checkpoint</a:t>
+            </a:r>
+          </a:p>
+        </p:txBody>
+      </p:sp>
+      <p:sp>
+        <p:nvSpPr>
+          <p:cNvPr id="10" name="">
+            <a:extLst xmlns:a="http://schemas.openxmlformats.org/drawingml/2006/main">
+              <a:ext uri="{FF2B5EF4-FFF2-40B4-BE49-F238E27FC236}">
+                <a16:creationId xmlns:a16="http://schemas.microsoft.com/office/drawing/2014/main" id="{0B6135FD-2CFC-443E-B222-F5458ABB4946}"/>
+              </a:ext>
+            </a:extLst>
+          </p:cNvPr>
+          <p:cNvSpPr>
+            <a:spLocks xmlns:a="http://schemas.openxmlformats.org/drawingml/2006/main" noGrp="1"/>
+          </p:cNvSpPr>
+          <p:nvPr/>
+        </p:nvSpPr>
+        <p:spPr>
+          <a:xfrm xmlns:a="http://schemas.openxmlformats.org/drawingml/2006/main">
+            <a:off x="5353050" y="4552950"/>
+            <a:ext cx="66675" cy="66675"/>
+          </a:xfrm>
+          <a:prstGeom xmlns:a="http://schemas.openxmlformats.org/drawingml/2006/main" prst="rect">
+            <a:avLst/>
+          </a:prstGeom>
+          <a:solidFill xmlns:a="http://schemas.openxmlformats.org/drawingml/2006/main">
+            <a:srgbClr val="FF6B35"/>
+          </a:solidFill>
+          <a:ln xmlns:a="http://schemas.openxmlformats.org/drawingml/2006/main" w="0">
+            <a:solidFill>
+              <a:srgbClr val="FF6B35"/>
+            </a:solidFill>
+            <a:prstDash val="solid"/>
+          </a:ln>
+        </p:spPr>
+      </p:sp>
+      <p:sp>
+        <p:nvSpPr>
+          <p:cNvPr id="11" name="">
+            <a:extLst xmlns:a="http://schemas.openxmlformats.org/drawingml/2006/main">
+              <a:ext uri="{FF2B5EF4-FFF2-40B4-BE49-F238E27FC236}">
+                <a16:creationId xmlns:a16="http://schemas.microsoft.com/office/drawing/2014/main" id="{69ABD169-7BF0-403D-A883-04616C401D2A}"/>
+              </a:ext>
+            </a:extLst>
+          </p:cNvPr>
+          <p:cNvSpPr>
+            <a:spLocks xmlns:a="http://schemas.openxmlformats.org/drawingml/2006/main" noGrp="1"/>
+          </p:cNvSpPr>
+          <p:nvPr/>
+        </p:nvSpPr>
+        <p:spPr>
+          <a:xfrm xmlns:a="http://schemas.openxmlformats.org/drawingml/2006/main">
+            <a:off x="5581650" y="4457700"/>
+            <a:ext cx="5105400" cy="400050"/>
+          </a:xfrm>
+          <a:prstGeom xmlns:a="http://schemas.openxmlformats.org/drawingml/2006/main" prst="rect">
+            <a:avLst/>
+          </a:prstGeom>
+          <a:noFill xmlns:a="http://schemas.openxmlformats.org/drawingml/2006/main"/>
+          <a:ln xmlns:a="http://schemas.openxmlformats.org/drawingml/2006/main" w="0">
+            <a:noFill/>
+            <a:prstDash val="solid"/>
+          </a:ln>
+        </p:spPr>
+        <p:txBody>
+          <a:bodyPr xmlns:a="http://schemas.openxmlformats.org/drawingml/2006/main"/>
+          <a:lstStyle xmlns:a="http://schemas.openxmlformats.org/drawingml/2006/main"/>
+          <a:p xmlns:a="http://schemas.openxmlformats.org/drawingml/2006/main">
+            <a:pPr algn="l">
+              <a:defRPr sz="1650" b="0">
+                <a:solidFill>
+                  <a:srgbClr val="0A0A0A"/>
+                </a:solidFill>
+              </a:defRPr>
+            </a:pPr>
+            <a:r>
+              <a:rPr sz="1650" b="0">
+                <a:solidFill>
+                  <a:srgbClr val="0A0A0A"/>
+                </a:solidFill>
+              </a:rPr>
+              <a:t>Crops and rescales the browser drawing</a:t>
+            </a:r>
+          </a:p>
+        </p:txBody>
+      </p:sp>
+      <p:sp>
+        <p:nvSpPr>
+          <p:cNvPr id="12" name="">
+            <a:extLst xmlns:a="http://schemas.openxmlformats.org/drawingml/2006/main">
+              <a:ext uri="{FF2B5EF4-FFF2-40B4-BE49-F238E27FC236}">
+                <a16:creationId xmlns:a16="http://schemas.microsoft.com/office/drawing/2014/main" id="{D0B8F65D-ACFF-4690-96F8-CC9C6079DDE4}"/>
+              </a:ext>
+            </a:extLst>
+          </p:cNvPr>
+          <p:cNvSpPr>
+            <a:spLocks xmlns:a="http://schemas.openxmlformats.org/drawingml/2006/main" noGrp="1"/>
+          </p:cNvSpPr>
+          <p:nvPr/>
+        </p:nvSpPr>
+        <p:spPr>
+          <a:xfrm xmlns:a="http://schemas.openxmlformats.org/drawingml/2006/main">
+            <a:off x="5353050" y="4972050"/>
+            <a:ext cx="66675" cy="66675"/>
+          </a:xfrm>
+          <a:prstGeom xmlns:a="http://schemas.openxmlformats.org/drawingml/2006/main" prst="rect">
+            <a:avLst/>
+          </a:prstGeom>
+          <a:solidFill xmlns:a="http://schemas.openxmlformats.org/drawingml/2006/main">
+            <a:srgbClr val="FF6B35"/>
+          </a:solidFill>
+          <a:ln xmlns:a="http://schemas.openxmlformats.org/drawingml/2006/main" w="0">
+            <a:solidFill>
+              <a:srgbClr val="FF6B35"/>
+            </a:solidFill>
+            <a:prstDash val="solid"/>
+          </a:ln>
+        </p:spPr>
+      </p:sp>
+      <p:sp>
+        <p:nvSpPr>
+          <p:cNvPr id="13" name="">
+            <a:extLst xmlns:a="http://schemas.openxmlformats.org/drawingml/2006/main">
+              <a:ext uri="{FF2B5EF4-FFF2-40B4-BE49-F238E27FC236}">
+                <a16:creationId xmlns:a16="http://schemas.microsoft.com/office/drawing/2014/main" id="{5AEBDE11-23B3-46D8-A3FC-97493CE5643B}"/>
+              </a:ext>
+            </a:extLst>
+          </p:cNvPr>
+          <p:cNvSpPr>
+            <a:spLocks xmlns:a="http://schemas.openxmlformats.org/drawingml/2006/main" noGrp="1"/>
+          </p:cNvSpPr>
+          <p:nvPr/>
+        </p:nvSpPr>
+        <p:spPr>
+          <a:xfrm xmlns:a="http://schemas.openxmlformats.org/drawingml/2006/main">
+            <a:off x="5581650" y="4876800"/>
+            <a:ext cx="5105400" cy="400050"/>
+          </a:xfrm>
+          <a:prstGeom xmlns:a="http://schemas.openxmlformats.org/drawingml/2006/main" prst="rect">
+            <a:avLst/>
+          </a:prstGeom>
+          <a:noFill xmlns:a="http://schemas.openxmlformats.org/drawingml/2006/main"/>
+          <a:ln xmlns:a="http://schemas.openxmlformats.org/drawingml/2006/main" w="0">
+            <a:noFill/>
+            <a:prstDash val="solid"/>
+          </a:ln>
+        </p:spPr>
+        <p:txBody>
+          <a:bodyPr xmlns:a="http://schemas.openxmlformats.org/drawingml/2006/main"/>
+          <a:lstStyle xmlns:a="http://schemas.openxmlformats.org/drawingml/2006/main"/>
+          <a:p xmlns:a="http://schemas.openxmlformats.org/drawingml/2006/main">
+            <a:pPr algn="l">
+              <a:defRPr sz="1650" b="0">
+                <a:solidFill>
+                  <a:srgbClr val="0A0A0A"/>
+                </a:solidFill>
+              </a:defRPr>
+            </a:pPr>
+            <a:r>
+              <a:rPr sz="1650" b="0">
+                <a:solidFill>
+                  <a:srgbClr val="0A0A0A"/>
+                </a:solidFill>
+              </a:rPr>
+              <a:t>Shows prediction plus probability bars</a:t>
+            </a:r>
+          </a:p>
+        </p:txBody>
+      </p:sp>
+      <p:sp>
+        <p:nvSpPr>
+          <p:cNvPr id="14" name="">
+            <a:extLst xmlns:a="http://schemas.openxmlformats.org/drawingml/2006/main">
+              <a:ext uri="{FF2B5EF4-FFF2-40B4-BE49-F238E27FC236}">
+                <a16:creationId xmlns:a16="http://schemas.microsoft.com/office/drawing/2014/main" id="{6333AF7B-7F6B-4619-853E-E2BB42066A1F}"/>
+              </a:ext>
+            </a:extLst>
+          </p:cNvPr>
+          <p:cNvSpPr>
+            <a:spLocks xmlns:a="http://schemas.openxmlformats.org/drawingml/2006/main" noGrp="1"/>
+          </p:cNvSpPr>
+          <p:nvPr/>
+        </p:nvSpPr>
+        <p:spPr>
+          <a:xfrm xmlns:a="http://schemas.openxmlformats.org/drawingml/2006/main">
+            <a:off x="5353050" y="5391150"/>
+            <a:ext cx="66675" cy="66675"/>
+          </a:xfrm>
+          <a:prstGeom xmlns:a="http://schemas.openxmlformats.org/drawingml/2006/main" prst="rect">
+            <a:avLst/>
+          </a:prstGeom>
+          <a:solidFill xmlns:a="http://schemas.openxmlformats.org/drawingml/2006/main">
+            <a:srgbClr val="FF6B35"/>
+          </a:solidFill>
+          <a:ln xmlns:a="http://schemas.openxmlformats.org/drawingml/2006/main" w="0">
+            <a:solidFill>
+              <a:srgbClr val="FF6B35"/>
+            </a:solidFill>
+            <a:prstDash val="solid"/>
+          </a:ln>
+        </p:spPr>
+      </p:sp>
+      <p:sp>
+        <p:nvSpPr>
+          <p:cNvPr id="15" name="">
+            <a:extLst xmlns:a="http://schemas.openxmlformats.org/drawingml/2006/main">
+              <a:ext uri="{FF2B5EF4-FFF2-40B4-BE49-F238E27FC236}">
+                <a16:creationId xmlns:a16="http://schemas.microsoft.com/office/drawing/2014/main" id="{348559E8-2625-468A-BD28-D293178E87C3}"/>
+              </a:ext>
+            </a:extLst>
+          </p:cNvPr>
+          <p:cNvSpPr>
+            <a:spLocks xmlns:a="http://schemas.openxmlformats.org/drawingml/2006/main" noGrp="1"/>
+          </p:cNvSpPr>
+          <p:nvPr/>
+        </p:nvSpPr>
+        <p:spPr>
+          <a:xfrm xmlns:a="http://schemas.openxmlformats.org/drawingml/2006/main">
+            <a:off x="5581650" y="5295900"/>
+            <a:ext cx="5105400" cy="400050"/>
+          </a:xfrm>
+          <a:prstGeom xmlns:a="http://schemas.openxmlformats.org/drawingml/2006/main" prst="rect">
+            <a:avLst/>
+          </a:prstGeom>
+          <a:noFill xmlns:a="http://schemas.openxmlformats.org/drawingml/2006/main"/>
+          <a:ln xmlns:a="http://schemas.openxmlformats.org/drawingml/2006/main" w="0">
+            <a:noFill/>
+            <a:prstDash val="solid"/>
+          </a:ln>
+        </p:spPr>
+        <p:txBody>
+          <a:bodyPr xmlns:a="http://schemas.openxmlformats.org/drawingml/2006/main"/>
+          <a:lstStyle xmlns:a="http://schemas.openxmlformats.org/drawingml/2006/main"/>
+          <a:p xmlns:a="http://schemas.openxmlformats.org/drawingml/2006/main">
+            <a:pPr algn="l">
+              <a:defRPr sz="1650" b="0">
+                <a:solidFill>
+                  <a:srgbClr val="0A0A0A"/>
+                </a:solidFill>
+              </a:defRPr>
+            </a:pPr>
+            <a:r>
+              <a:rPr sz="1650" b="0">
+                <a:solidFill>
+                  <a:srgbClr val="0A0A0A"/>
+                </a:solidFill>
+              </a:rPr>
+              <a:t>Backup: python demo.py --sample-index 7</a:t>
+            </a:r>
+          </a:p>
+        </p:txBody>
+      </p:sp>
+      <p:sp>
+        <p:nvSpPr>
+          <p:cNvPr id="16" name="">
+            <a:extLst xmlns:a="http://schemas.openxmlformats.org/drawingml/2006/main">
+              <a:ext uri="{FF2B5EF4-FFF2-40B4-BE49-F238E27FC236}">
+                <a16:creationId xmlns:a16="http://schemas.microsoft.com/office/drawing/2014/main" id="{DC2DC48F-A318-4098-A405-5FE2536ABA6D}"/>
               </a:ext>
             </a:extLst>
           </p:cNvPr>
@@ -10491,7 +10934,7 @@
     </p:spTree>
     <p:extLst>
       <p:ext uri="{BB962C8B-B14F-4D97-AF65-F5344CB8AC3E}">
-        <p14:creationId xmlns:p14="http://schemas.microsoft.com/office/powerpoint/2010/main" val="1471919643"/>
+        <p14:creationId xmlns:p14="http://schemas.microsoft.com/office/powerpoint/2010/main" val="1631083982"/>
       </p:ext>
     </p:extLst>
   </p:cSld>

</xml_diff>

<commit_message>
Update ResNet baseline comparison
</commit_message>
<xml_diff>
--- a/slides/LeNet5_MNIST_Final_Presentation.pptx
+++ b/slides/LeNet5_MNIST_Final_Presentation.pptx
@@ -2,25 +2,25 @@
 <file path=ppt/presentation.xml><?xml version="1.0" encoding="utf-8"?>
 <p:presentation xmlns:p="http://schemas.openxmlformats.org/presentationml/2006/main">
   <p:sldMasterIdLst>
-    <p:sldMasterId xmlns:r="http://schemas.openxmlformats.org/officeDocument/2006/relationships" id="2147483648" r:id="Rada07523e85c457e"/>
+    <p:sldMasterId xmlns:r="http://schemas.openxmlformats.org/officeDocument/2006/relationships" id="2147483648" r:id="R10a958a769c148b8"/>
   </p:sldMasterIdLst>
   <p:notesMasterIdLst>
-    <p:notesMasterId xmlns:r="http://schemas.openxmlformats.org/officeDocument/2006/relationships" r:id="R9550e05fa7b64054"/>
+    <p:notesMasterId xmlns:r="http://schemas.openxmlformats.org/officeDocument/2006/relationships" r:id="R0c9d581a40404b7c"/>
   </p:notesMasterIdLst>
   <p:sldIdLst>
-    <p:sldId xmlns:r="http://schemas.openxmlformats.org/officeDocument/2006/relationships" id="256" r:id="R246ce7b8331a4d55"/>
-    <p:sldId xmlns:r="http://schemas.openxmlformats.org/officeDocument/2006/relationships" id="257" r:id="R71c82db463d74fcb"/>
-    <p:sldId xmlns:r="http://schemas.openxmlformats.org/officeDocument/2006/relationships" id="258" r:id="R76a26f3823fe4a54"/>
-    <p:sldId xmlns:r="http://schemas.openxmlformats.org/officeDocument/2006/relationships" id="259" r:id="R7fe94bd2aa0449a0"/>
-    <p:sldId xmlns:r="http://schemas.openxmlformats.org/officeDocument/2006/relationships" id="260" r:id="Rd8ea24512a694285"/>
-    <p:sldId xmlns:r="http://schemas.openxmlformats.org/officeDocument/2006/relationships" id="261" r:id="Rde0bcd43d6a1446a"/>
-    <p:sldId xmlns:r="http://schemas.openxmlformats.org/officeDocument/2006/relationships" id="262" r:id="Rb1b36087e6104589"/>
-    <p:sldId xmlns:r="http://schemas.openxmlformats.org/officeDocument/2006/relationships" id="263" r:id="R4ac8299bb3af4579"/>
-    <p:sldId xmlns:r="http://schemas.openxmlformats.org/officeDocument/2006/relationships" id="264" r:id="R5cf8043fd6c34d19"/>
-    <p:sldId xmlns:r="http://schemas.openxmlformats.org/officeDocument/2006/relationships" id="265" r:id="R13cf87e8607d4b08"/>
-    <p:sldId xmlns:r="http://schemas.openxmlformats.org/officeDocument/2006/relationships" id="266" r:id="R8f61fdeade7a4d16"/>
-    <p:sldId xmlns:r="http://schemas.openxmlformats.org/officeDocument/2006/relationships" id="267" r:id="R68f5fe851a2f4d3e"/>
-    <p:sldId xmlns:r="http://schemas.openxmlformats.org/officeDocument/2006/relationships" id="268" r:id="R18d46bd81bad463c"/>
+    <p:sldId xmlns:r="http://schemas.openxmlformats.org/officeDocument/2006/relationships" id="256" r:id="Rec394f8fae72442d"/>
+    <p:sldId xmlns:r="http://schemas.openxmlformats.org/officeDocument/2006/relationships" id="257" r:id="R667002b794614105"/>
+    <p:sldId xmlns:r="http://schemas.openxmlformats.org/officeDocument/2006/relationships" id="258" r:id="R11b05f11f85e4ea6"/>
+    <p:sldId xmlns:r="http://schemas.openxmlformats.org/officeDocument/2006/relationships" id="259" r:id="Rdb92c9b2de4a4983"/>
+    <p:sldId xmlns:r="http://schemas.openxmlformats.org/officeDocument/2006/relationships" id="260" r:id="R61c508e92189480c"/>
+    <p:sldId xmlns:r="http://schemas.openxmlformats.org/officeDocument/2006/relationships" id="261" r:id="R275ef321836a43e1"/>
+    <p:sldId xmlns:r="http://schemas.openxmlformats.org/officeDocument/2006/relationships" id="262" r:id="R5f37e5742fa2463f"/>
+    <p:sldId xmlns:r="http://schemas.openxmlformats.org/officeDocument/2006/relationships" id="263" r:id="R5316c2e640fe4994"/>
+    <p:sldId xmlns:r="http://schemas.openxmlformats.org/officeDocument/2006/relationships" id="264" r:id="R5cd74636e71d4f88"/>
+    <p:sldId xmlns:r="http://schemas.openxmlformats.org/officeDocument/2006/relationships" id="265" r:id="R73de9f88b01244f2"/>
+    <p:sldId xmlns:r="http://schemas.openxmlformats.org/officeDocument/2006/relationships" id="266" r:id="Ra140f2dc546b4d24"/>
+    <p:sldId xmlns:r="http://schemas.openxmlformats.org/officeDocument/2006/relationships" id="267" r:id="Rc3b53cc3a80043b3"/>
+    <p:sldId xmlns:r="http://schemas.openxmlformats.org/officeDocument/2006/relationships" id="268" r:id="R9358c59c84084761"/>
   </p:sldIdLst>
   <p:sldSz cx="12192000" cy="6858000"/>
   <p:notesSz cx="6858000" cy="9144000"/>
@@ -1405,7 +1405,7 @@
   </p:cSld>
   <p:clrMap bg1="lt1" tx1="dk1" bg2="lt2" tx2="dk2" accent1="accent1" accent2="accent2" accent3="accent3" accent4="accent4" accent5="accent5" accent6="accent6" hlink="hlink" folHlink="folHlink"/>
   <p:sldLayoutIdLst>
-    <p:sldLayoutId xmlns:r="http://schemas.openxmlformats.org/officeDocument/2006/relationships" id="2147483649" r:id="R6c4d625774c14951"/>
+    <p:sldLayoutId xmlns:r="http://schemas.openxmlformats.org/officeDocument/2006/relationships" id="2147483649" r:id="Rc256343576fa4f1b"/>
   </p:sldLayoutIdLst>
   <p:txStyles>
     <p:titleStyle>
@@ -1956,7 +1956,7 @@
           <p:cNvPr id="1" name="">
             <a:extLst xmlns:a="http://schemas.openxmlformats.org/drawingml/2006/main">
               <a:ext uri="{FF2B5EF4-FFF2-40B4-BE49-F238E27FC236}">
-                <a16:creationId xmlns:a16="http://schemas.microsoft.com/office/drawing/2014/main" id="{CA321EB7-462F-4768-9990-A65D8A440CC1}"/>
+                <a16:creationId xmlns:a16="http://schemas.microsoft.com/office/drawing/2014/main" id="{CD7432BB-FAFD-488F-B5EF-FA91C73C864E}"/>
               </a:ext>
             </a:extLst>
           </p:cNvPr>
@@ -2006,7 +2006,7 @@
           <p:cNvPr id="2" name="">
             <a:extLst xmlns:a="http://schemas.openxmlformats.org/drawingml/2006/main">
               <a:ext uri="{FF2B5EF4-FFF2-40B4-BE49-F238E27FC236}">
-                <a16:creationId xmlns:a16="http://schemas.microsoft.com/office/drawing/2014/main" id="{EEEF2243-34CB-4693-A0C6-8BAC557A5A21}"/>
+                <a16:creationId xmlns:a16="http://schemas.microsoft.com/office/drawing/2014/main" id="{78EB7A2C-26E9-4EE0-8595-D70FB2191E93}"/>
               </a:ext>
             </a:extLst>
           </p:cNvPr>
@@ -2056,7 +2056,7 @@
           <p:cNvPr id="3" name="">
             <a:extLst xmlns:a="http://schemas.openxmlformats.org/drawingml/2006/main">
               <a:ext uri="{FF2B5EF4-FFF2-40B4-BE49-F238E27FC236}">
-                <a16:creationId xmlns:a16="http://schemas.microsoft.com/office/drawing/2014/main" id="{8D549F43-AA45-4187-8B98-8B13772DD3FE}"/>
+                <a16:creationId xmlns:a16="http://schemas.microsoft.com/office/drawing/2014/main" id="{CC424796-013C-49C5-9538-B151831C53D1}"/>
               </a:ext>
             </a:extLst>
           </p:cNvPr>
@@ -2089,7 +2089,7 @@
           <p:cNvPr id="4" name="">
             <a:extLst xmlns:a="http://schemas.openxmlformats.org/drawingml/2006/main">
               <a:ext uri="{FF2B5EF4-FFF2-40B4-BE49-F238E27FC236}">
-                <a16:creationId xmlns:a16="http://schemas.microsoft.com/office/drawing/2014/main" id="{FBD8B44B-7852-4F43-9AAC-2DA24368C333}"/>
+                <a16:creationId xmlns:a16="http://schemas.microsoft.com/office/drawing/2014/main" id="{731CB27F-6569-4565-A119-0B104E31A74D}"/>
               </a:ext>
             </a:extLst>
           </p:cNvPr>
@@ -2139,7 +2139,7 @@
           <p:cNvPr id="5" name="">
             <a:extLst xmlns:a="http://schemas.openxmlformats.org/drawingml/2006/main">
               <a:ext uri="{FF2B5EF4-FFF2-40B4-BE49-F238E27FC236}">
-                <a16:creationId xmlns:a16="http://schemas.microsoft.com/office/drawing/2014/main" id="{CB84E18B-3D87-4462-A543-9CF61B7963A7}"/>
+                <a16:creationId xmlns:a16="http://schemas.microsoft.com/office/drawing/2014/main" id="{FDD97C79-E101-4811-A082-9B8E258F1644}"/>
               </a:ext>
             </a:extLst>
           </p:cNvPr>
@@ -2189,7 +2189,7 @@
           <p:cNvPr id="6" name="">
             <a:extLst xmlns:a="http://schemas.openxmlformats.org/drawingml/2006/main">
               <a:ext uri="{FF2B5EF4-FFF2-40B4-BE49-F238E27FC236}">
-                <a16:creationId xmlns:a16="http://schemas.microsoft.com/office/drawing/2014/main" id="{0FC98980-7F45-49E7-95A7-6A1B5ABEA8AE}"/>
+                <a16:creationId xmlns:a16="http://schemas.microsoft.com/office/drawing/2014/main" id="{30040D29-DD1C-4077-A1E8-1AA461358125}"/>
               </a:ext>
             </a:extLst>
           </p:cNvPr>
@@ -2222,7 +2222,7 @@
           <p:cNvPr id="7" name="">
             <a:extLst xmlns:a="http://schemas.openxmlformats.org/drawingml/2006/main">
               <a:ext uri="{FF2B5EF4-FFF2-40B4-BE49-F238E27FC236}">
-                <a16:creationId xmlns:a16="http://schemas.microsoft.com/office/drawing/2014/main" id="{79C5819F-30D2-4C46-9267-CFAA56ABFD25}"/>
+                <a16:creationId xmlns:a16="http://schemas.microsoft.com/office/drawing/2014/main" id="{3D381DD9-0638-4BCD-AC37-86CFBF959622}"/>
               </a:ext>
             </a:extLst>
           </p:cNvPr>
@@ -2272,7 +2272,7 @@
           <p:cNvPr id="8" name="">
             <a:extLst xmlns:a="http://schemas.openxmlformats.org/drawingml/2006/main">
               <a:ext uri="{FF2B5EF4-FFF2-40B4-BE49-F238E27FC236}">
-                <a16:creationId xmlns:a16="http://schemas.microsoft.com/office/drawing/2014/main" id="{68734BCA-AE56-47B9-8AAF-6EF722360B62}"/>
+                <a16:creationId xmlns:a16="http://schemas.microsoft.com/office/drawing/2014/main" id="{D296B756-7B09-4163-9336-14B521875A04}"/>
               </a:ext>
             </a:extLst>
           </p:cNvPr>
@@ -2322,7 +2322,7 @@
           <p:cNvPr id="9" name="">
             <a:extLst xmlns:a="http://schemas.openxmlformats.org/drawingml/2006/main">
               <a:ext uri="{FF2B5EF4-FFF2-40B4-BE49-F238E27FC236}">
-                <a16:creationId xmlns:a16="http://schemas.microsoft.com/office/drawing/2014/main" id="{71E24105-876B-41CF-B33A-CFB0BA96D3BF}"/>
+                <a16:creationId xmlns:a16="http://schemas.microsoft.com/office/drawing/2014/main" id="{FD68A3CC-4661-42CC-8A42-714A4FE76779}"/>
               </a:ext>
             </a:extLst>
           </p:cNvPr>
@@ -2355,7 +2355,7 @@
           <p:cNvPr id="10" name="">
             <a:extLst xmlns:a="http://schemas.openxmlformats.org/drawingml/2006/main">
               <a:ext uri="{FF2B5EF4-FFF2-40B4-BE49-F238E27FC236}">
-                <a16:creationId xmlns:a16="http://schemas.microsoft.com/office/drawing/2014/main" id="{81EA7C61-BA57-42E1-9543-815F90C79EB9}"/>
+                <a16:creationId xmlns:a16="http://schemas.microsoft.com/office/drawing/2014/main" id="{915D1B19-A382-4EED-B2BF-6A6589A221E3}"/>
               </a:ext>
             </a:extLst>
           </p:cNvPr>
@@ -2405,7 +2405,7 @@
           <p:cNvPr id="11" name="">
             <a:extLst xmlns:a="http://schemas.openxmlformats.org/drawingml/2006/main">
               <a:ext uri="{FF2B5EF4-FFF2-40B4-BE49-F238E27FC236}">
-                <a16:creationId xmlns:a16="http://schemas.microsoft.com/office/drawing/2014/main" id="{06CE18B3-5174-424D-A2C4-DE186D570030}"/>
+                <a16:creationId xmlns:a16="http://schemas.microsoft.com/office/drawing/2014/main" id="{6E5C1090-9605-483E-BBB7-9F82376D34D4}"/>
               </a:ext>
             </a:extLst>
           </p:cNvPr>
@@ -2455,7 +2455,7 @@
           <p:cNvPr id="12" name="">
             <a:extLst xmlns:a="http://schemas.openxmlformats.org/drawingml/2006/main">
               <a:ext uri="{FF2B5EF4-FFF2-40B4-BE49-F238E27FC236}">
-                <a16:creationId xmlns:a16="http://schemas.microsoft.com/office/drawing/2014/main" id="{C5B8FEDF-F995-4B3C-B70E-51A0B16F6B4C}"/>
+                <a16:creationId xmlns:a16="http://schemas.microsoft.com/office/drawing/2014/main" id="{1EC4443C-D12F-40A4-B922-45A8A9AC9E18}"/>
               </a:ext>
             </a:extLst>
           </p:cNvPr>
@@ -2505,7 +2505,7 @@
           <p:cNvPr id="13" name="">
             <a:extLst xmlns:a="http://schemas.openxmlformats.org/drawingml/2006/main">
               <a:ext uri="{FF2B5EF4-FFF2-40B4-BE49-F238E27FC236}">
-                <a16:creationId xmlns:a16="http://schemas.microsoft.com/office/drawing/2014/main" id="{C71D19BF-2B95-4A26-9C57-F37BA022A1A8}"/>
+                <a16:creationId xmlns:a16="http://schemas.microsoft.com/office/drawing/2014/main" id="{B0C5DEFA-DEBE-4F78-B263-95776FF530FF}"/>
               </a:ext>
             </a:extLst>
           </p:cNvPr>
@@ -2553,7 +2553,7 @@
     </p:spTree>
     <p:extLst>
       <p:ext uri="{BB962C8B-B14F-4D97-AF65-F5344CB8AC3E}">
-        <p14:creationId xmlns:p14="http://schemas.microsoft.com/office/powerpoint/2010/main" val="1520206390"/>
+        <p14:creationId xmlns:p14="http://schemas.microsoft.com/office/powerpoint/2010/main" val="592592796"/>
       </p:ext>
     </p:extLst>
   </p:cSld>
@@ -2584,7 +2584,7 @@
           <p:cNvPr id="1" name="">
             <a:extLst xmlns:a="http://schemas.openxmlformats.org/drawingml/2006/main">
               <a:ext uri="{FF2B5EF4-FFF2-40B4-BE49-F238E27FC236}">
-                <a16:creationId xmlns:a16="http://schemas.microsoft.com/office/drawing/2014/main" id="{CF974068-6E18-42F1-96EB-16DDFF53D610}"/>
+                <a16:creationId xmlns:a16="http://schemas.microsoft.com/office/drawing/2014/main" id="{5D4AA5D5-9FE0-4FF6-8171-92154E09DE02}"/>
               </a:ext>
             </a:extLst>
           </p:cNvPr>
@@ -2634,7 +2634,7 @@
           <p:cNvPr id="2" name="">
             <a:extLst xmlns:a="http://schemas.openxmlformats.org/drawingml/2006/main">
               <a:ext uri="{FF2B5EF4-FFF2-40B4-BE49-F238E27FC236}">
-                <a16:creationId xmlns:a16="http://schemas.microsoft.com/office/drawing/2014/main" id="{21D73B57-D949-48A4-B8BD-B92E7D3514DE}"/>
+                <a16:creationId xmlns:a16="http://schemas.microsoft.com/office/drawing/2014/main" id="{1F654D07-C103-4A15-B247-2326207C3016}"/>
               </a:ext>
             </a:extLst>
           </p:cNvPr>
@@ -2684,7 +2684,7 @@
           <p:cNvPr id="3" name="">
             <a:extLst xmlns:a="http://schemas.openxmlformats.org/drawingml/2006/main">
               <a:ext uri="{FF2B5EF4-FFF2-40B4-BE49-F238E27FC236}">
-                <a16:creationId xmlns:a16="http://schemas.microsoft.com/office/drawing/2014/main" id="{114F0850-5F44-4A49-938F-F971F8645877}"/>
+                <a16:creationId xmlns:a16="http://schemas.microsoft.com/office/drawing/2014/main" id="{4F4F561E-9A59-4444-8A2A-6E782BE76668}"/>
               </a:ext>
             </a:extLst>
           </p:cNvPr>
@@ -2717,7 +2717,7 @@
           <p:cNvPr id="4" name="">
             <a:extLst xmlns:a="http://schemas.openxmlformats.org/drawingml/2006/main">
               <a:ext uri="{FF2B5EF4-FFF2-40B4-BE49-F238E27FC236}">
-                <a16:creationId xmlns:a16="http://schemas.microsoft.com/office/drawing/2014/main" id="{58602F05-0786-4F40-A3A6-7489A967B4D1}"/>
+                <a16:creationId xmlns:a16="http://schemas.microsoft.com/office/drawing/2014/main" id="{618564DD-61AC-4AB4-9C60-8B8F98ACD570}"/>
               </a:ext>
             </a:extLst>
           </p:cNvPr>
@@ -2750,7 +2750,7 @@
           <p:cNvPr id="5" name="">
             <a:extLst xmlns:a="http://schemas.openxmlformats.org/drawingml/2006/main">
               <a:ext uri="{FF2B5EF4-FFF2-40B4-BE49-F238E27FC236}">
-                <a16:creationId xmlns:a16="http://schemas.microsoft.com/office/drawing/2014/main" id="{33474942-66D0-41AA-ADF1-7602A41B12A0}"/>
+                <a16:creationId xmlns:a16="http://schemas.microsoft.com/office/drawing/2014/main" id="{F0D73012-0047-4AF1-857C-298F3F20D642}"/>
               </a:ext>
             </a:extLst>
           </p:cNvPr>
@@ -2800,7 +2800,7 @@
           <p:cNvPr id="6" name="">
             <a:extLst xmlns:a="http://schemas.openxmlformats.org/drawingml/2006/main">
               <a:ext uri="{FF2B5EF4-FFF2-40B4-BE49-F238E27FC236}">
-                <a16:creationId xmlns:a16="http://schemas.microsoft.com/office/drawing/2014/main" id="{94D75A44-6620-4CCC-9239-6097664C72E7}"/>
+                <a16:creationId xmlns:a16="http://schemas.microsoft.com/office/drawing/2014/main" id="{A023A619-4CF7-4D24-8C1D-64908FE6F5E1}"/>
               </a:ext>
             </a:extLst>
           </p:cNvPr>
@@ -2850,7 +2850,7 @@
           <p:cNvPr id="7" name="">
             <a:extLst xmlns:a="http://schemas.openxmlformats.org/drawingml/2006/main">
               <a:ext uri="{FF2B5EF4-FFF2-40B4-BE49-F238E27FC236}">
-                <a16:creationId xmlns:a16="http://schemas.microsoft.com/office/drawing/2014/main" id="{5EA16E75-C39F-4844-B45B-A18E31B97900}"/>
+                <a16:creationId xmlns:a16="http://schemas.microsoft.com/office/drawing/2014/main" id="{88BD807B-0D08-496F-90DF-82E909D9E01A}"/>
               </a:ext>
             </a:extLst>
           </p:cNvPr>
@@ -2883,7 +2883,7 @@
           <p:cNvPr id="8" name="">
             <a:extLst xmlns:a="http://schemas.openxmlformats.org/drawingml/2006/main">
               <a:ext uri="{FF2B5EF4-FFF2-40B4-BE49-F238E27FC236}">
-                <a16:creationId xmlns:a16="http://schemas.microsoft.com/office/drawing/2014/main" id="{7E63044A-EC9E-4821-909A-046EB5CA53E0}"/>
+                <a16:creationId xmlns:a16="http://schemas.microsoft.com/office/drawing/2014/main" id="{FD4EA7B7-C30D-4B9C-9552-D190E855B88F}"/>
               </a:ext>
             </a:extLst>
           </p:cNvPr>
@@ -2933,7 +2933,7 @@
           <p:cNvPr id="9" name="">
             <a:extLst xmlns:a="http://schemas.openxmlformats.org/drawingml/2006/main">
               <a:ext uri="{FF2B5EF4-FFF2-40B4-BE49-F238E27FC236}">
-                <a16:creationId xmlns:a16="http://schemas.microsoft.com/office/drawing/2014/main" id="{86BD3D12-FC48-4505-992F-93DEFAE666E6}"/>
+                <a16:creationId xmlns:a16="http://schemas.microsoft.com/office/drawing/2014/main" id="{E75C82B8-23F3-4E18-ADA2-613E1101F2B0}"/>
               </a:ext>
             </a:extLst>
           </p:cNvPr>
@@ -2983,7 +2983,7 @@
           <p:cNvPr id="10" name="">
             <a:extLst xmlns:a="http://schemas.openxmlformats.org/drawingml/2006/main">
               <a:ext uri="{FF2B5EF4-FFF2-40B4-BE49-F238E27FC236}">
-                <a16:creationId xmlns:a16="http://schemas.microsoft.com/office/drawing/2014/main" id="{7DCC5B4C-85B1-475B-825A-D21544875ADA}"/>
+                <a16:creationId xmlns:a16="http://schemas.microsoft.com/office/drawing/2014/main" id="{98313D57-2BAF-4801-BAE9-02B05F668D76}"/>
               </a:ext>
             </a:extLst>
           </p:cNvPr>
@@ -3033,7 +3033,7 @@
           <p:cNvPr id="11" name="">
             <a:extLst xmlns:a="http://schemas.openxmlformats.org/drawingml/2006/main">
               <a:ext uri="{FF2B5EF4-FFF2-40B4-BE49-F238E27FC236}">
-                <a16:creationId xmlns:a16="http://schemas.microsoft.com/office/drawing/2014/main" id="{3A1B3767-2091-45BD-9844-4151905591B2}"/>
+                <a16:creationId xmlns:a16="http://schemas.microsoft.com/office/drawing/2014/main" id="{6AA11D44-9575-4DAD-AE45-CB4FAE652121}"/>
               </a:ext>
             </a:extLst>
           </p:cNvPr>
@@ -3081,7 +3081,7 @@
     </p:spTree>
     <p:extLst>
       <p:ext uri="{BB962C8B-B14F-4D97-AF65-F5344CB8AC3E}">
-        <p14:creationId xmlns:p14="http://schemas.microsoft.com/office/powerpoint/2010/main" val="622159740"/>
+        <p14:creationId xmlns:p14="http://schemas.microsoft.com/office/powerpoint/2010/main" val="238525974"/>
       </p:ext>
     </p:extLst>
   </p:cSld>
@@ -3112,7 +3112,7 @@
           <p:cNvPr id="1" name="">
             <a:extLst xmlns:a="http://schemas.openxmlformats.org/drawingml/2006/main">
               <a:ext uri="{FF2B5EF4-FFF2-40B4-BE49-F238E27FC236}">
-                <a16:creationId xmlns:a16="http://schemas.microsoft.com/office/drawing/2014/main" id="{B0B9A5F5-CD8F-4247-B34B-23EB393F1CD3}"/>
+                <a16:creationId xmlns:a16="http://schemas.microsoft.com/office/drawing/2014/main" id="{7A4FE5B1-639F-4E93-BBC3-84F2204AE5CE}"/>
               </a:ext>
             </a:extLst>
           </p:cNvPr>
@@ -3162,7 +3162,7 @@
           <p:cNvPr id="2" name="">
             <a:extLst xmlns:a="http://schemas.openxmlformats.org/drawingml/2006/main">
               <a:ext uri="{FF2B5EF4-FFF2-40B4-BE49-F238E27FC236}">
-                <a16:creationId xmlns:a16="http://schemas.microsoft.com/office/drawing/2014/main" id="{EA06590F-7474-4A2A-B727-63BE696697B5}"/>
+                <a16:creationId xmlns:a16="http://schemas.microsoft.com/office/drawing/2014/main" id="{B86070C6-5B78-42BE-A638-170CB67D28D1}"/>
               </a:ext>
             </a:extLst>
           </p:cNvPr>
@@ -3212,7 +3212,7 @@
           <p:cNvPr id="3" name="">
             <a:extLst xmlns:a="http://schemas.openxmlformats.org/drawingml/2006/main">
               <a:ext uri="{FF2B5EF4-FFF2-40B4-BE49-F238E27FC236}">
-                <a16:creationId xmlns:a16="http://schemas.microsoft.com/office/drawing/2014/main" id="{A7A71BCA-409A-4587-8CDA-4A828FBC455B}"/>
+                <a16:creationId xmlns:a16="http://schemas.microsoft.com/office/drawing/2014/main" id="{7E73C6AC-4716-42A0-AFD2-D7242C1FFB15}"/>
               </a:ext>
             </a:extLst>
           </p:cNvPr>
@@ -3245,7 +3245,7 @@
           <p:cNvPr id="4" name="">
             <a:extLst xmlns:a="http://schemas.openxmlformats.org/drawingml/2006/main">
               <a:ext uri="{FF2B5EF4-FFF2-40B4-BE49-F238E27FC236}">
-                <a16:creationId xmlns:a16="http://schemas.microsoft.com/office/drawing/2014/main" id="{9E5415E8-4817-47B8-8180-6ECAE7A02F1B}"/>
+                <a16:creationId xmlns:a16="http://schemas.microsoft.com/office/drawing/2014/main" id="{5AD56D7C-5BAA-467C-AD4C-8CA06CF81334}"/>
               </a:ext>
             </a:extLst>
           </p:cNvPr>
@@ -3278,7 +3278,7 @@
           <p:cNvPr id="5" name="">
             <a:extLst xmlns:a="http://schemas.openxmlformats.org/drawingml/2006/main">
               <a:ext uri="{FF2B5EF4-FFF2-40B4-BE49-F238E27FC236}">
-                <a16:creationId xmlns:a16="http://schemas.microsoft.com/office/drawing/2014/main" id="{2D7E14B8-3C6A-4453-B9F3-8DDF66BFD24F}"/>
+                <a16:creationId xmlns:a16="http://schemas.microsoft.com/office/drawing/2014/main" id="{4E50C9C3-C68F-474C-875C-6DD0D72172A2}"/>
               </a:ext>
             </a:extLst>
           </p:cNvPr>
@@ -3328,7 +3328,7 @@
           <p:cNvPr id="6" name="">
             <a:extLst xmlns:a="http://schemas.openxmlformats.org/drawingml/2006/main">
               <a:ext uri="{FF2B5EF4-FFF2-40B4-BE49-F238E27FC236}">
-                <a16:creationId xmlns:a16="http://schemas.microsoft.com/office/drawing/2014/main" id="{B4A80107-CBB4-4423-AA67-5036FD6E3D62}"/>
+                <a16:creationId xmlns:a16="http://schemas.microsoft.com/office/drawing/2014/main" id="{B3B9DB16-F9B5-41B1-8A40-E543AB150092}"/>
               </a:ext>
             </a:extLst>
           </p:cNvPr>
@@ -3446,7 +3446,7 @@
           <p:cNvPr id="7" name="">
             <a:extLst xmlns:a="http://schemas.openxmlformats.org/drawingml/2006/main">
               <a:ext uri="{FF2B5EF4-FFF2-40B4-BE49-F238E27FC236}">
-                <a16:creationId xmlns:a16="http://schemas.microsoft.com/office/drawing/2014/main" id="{556F457D-C87F-45F4-8151-FE0BA5A3C2FD}"/>
+                <a16:creationId xmlns:a16="http://schemas.microsoft.com/office/drawing/2014/main" id="{615E81DA-58CD-4709-AB31-F5297FD07B92}"/>
               </a:ext>
             </a:extLst>
           </p:cNvPr>
@@ -3479,7 +3479,7 @@
           <p:cNvPr id="8" name="">
             <a:extLst xmlns:a="http://schemas.openxmlformats.org/drawingml/2006/main">
               <a:ext uri="{FF2B5EF4-FFF2-40B4-BE49-F238E27FC236}">
-                <a16:creationId xmlns:a16="http://schemas.microsoft.com/office/drawing/2014/main" id="{94412DD7-6FA3-43A3-B5CA-9AF1ABBD558B}"/>
+                <a16:creationId xmlns:a16="http://schemas.microsoft.com/office/drawing/2014/main" id="{538FE84F-A392-4736-979A-AE4B920A1994}"/>
               </a:ext>
             </a:extLst>
           </p:cNvPr>
@@ -3529,7 +3529,7 @@
           <p:cNvPr id="9" name="">
             <a:extLst xmlns:a="http://schemas.openxmlformats.org/drawingml/2006/main">
               <a:ext uri="{FF2B5EF4-FFF2-40B4-BE49-F238E27FC236}">
-                <a16:creationId xmlns:a16="http://schemas.microsoft.com/office/drawing/2014/main" id="{B62A897D-E7AE-41A5-9408-32F3D00DE7E6}"/>
+                <a16:creationId xmlns:a16="http://schemas.microsoft.com/office/drawing/2014/main" id="{3FC64E7C-84BF-4319-B710-B71BB9E9A73D}"/>
               </a:ext>
             </a:extLst>
           </p:cNvPr>
@@ -3647,7 +3647,7 @@
           <p:cNvPr id="10" name="">
             <a:extLst xmlns:a="http://schemas.openxmlformats.org/drawingml/2006/main">
               <a:ext uri="{FF2B5EF4-FFF2-40B4-BE49-F238E27FC236}">
-                <a16:creationId xmlns:a16="http://schemas.microsoft.com/office/drawing/2014/main" id="{CC2DA818-9538-4453-8470-A954D3A90204}"/>
+                <a16:creationId xmlns:a16="http://schemas.microsoft.com/office/drawing/2014/main" id="{DECD5900-9A5B-496C-925C-3AB42EEB5375}"/>
               </a:ext>
             </a:extLst>
           </p:cNvPr>
@@ -3680,7 +3680,7 @@
           <p:cNvPr id="11" name="">
             <a:extLst xmlns:a="http://schemas.openxmlformats.org/drawingml/2006/main">
               <a:ext uri="{FF2B5EF4-FFF2-40B4-BE49-F238E27FC236}">
-                <a16:creationId xmlns:a16="http://schemas.microsoft.com/office/drawing/2014/main" id="{DF1CC17A-204A-4F54-BC35-B7A4967B03B7}"/>
+                <a16:creationId xmlns:a16="http://schemas.microsoft.com/office/drawing/2014/main" id="{F243C587-73FE-4234-BD09-BC812A0D21E2}"/>
               </a:ext>
             </a:extLst>
           </p:cNvPr>
@@ -3730,7 +3730,7 @@
           <p:cNvPr id="12" name="">
             <a:extLst xmlns:a="http://schemas.openxmlformats.org/drawingml/2006/main">
               <a:ext uri="{FF2B5EF4-FFF2-40B4-BE49-F238E27FC236}">
-                <a16:creationId xmlns:a16="http://schemas.microsoft.com/office/drawing/2014/main" id="{197F8E9B-02E7-41B3-BDFC-F212815C9467}"/>
+                <a16:creationId xmlns:a16="http://schemas.microsoft.com/office/drawing/2014/main" id="{3FC863E8-0C33-4542-9CC3-A2959A337CC9}"/>
               </a:ext>
             </a:extLst>
           </p:cNvPr>
@@ -3848,7 +3848,7 @@
           <p:cNvPr id="13" name="">
             <a:extLst xmlns:a="http://schemas.openxmlformats.org/drawingml/2006/main">
               <a:ext uri="{FF2B5EF4-FFF2-40B4-BE49-F238E27FC236}">
-                <a16:creationId xmlns:a16="http://schemas.microsoft.com/office/drawing/2014/main" id="{26E756B2-2F4F-45AF-B55B-7367B2D8A18D}"/>
+                <a16:creationId xmlns:a16="http://schemas.microsoft.com/office/drawing/2014/main" id="{0D33FB3D-4F09-47CA-BAF9-8A8D49131943}"/>
               </a:ext>
             </a:extLst>
           </p:cNvPr>
@@ -3896,7 +3896,7 @@
     </p:spTree>
     <p:extLst>
       <p:ext uri="{BB962C8B-B14F-4D97-AF65-F5344CB8AC3E}">
-        <p14:creationId xmlns:p14="http://schemas.microsoft.com/office/powerpoint/2010/main" val="283246761"/>
+        <p14:creationId xmlns:p14="http://schemas.microsoft.com/office/powerpoint/2010/main" val="320219404"/>
       </p:ext>
     </p:extLst>
   </p:cSld>
@@ -3927,7 +3927,7 @@
           <p:cNvPr id="1" name="">
             <a:extLst xmlns:a="http://schemas.openxmlformats.org/drawingml/2006/main">
               <a:ext uri="{FF2B5EF4-FFF2-40B4-BE49-F238E27FC236}">
-                <a16:creationId xmlns:a16="http://schemas.microsoft.com/office/drawing/2014/main" id="{9E2E138F-D710-4C90-9BD0-D1AC031AFD45}"/>
+                <a16:creationId xmlns:a16="http://schemas.microsoft.com/office/drawing/2014/main" id="{FF7A541E-B94B-4C94-92DA-897FA08D0E43}"/>
               </a:ext>
             </a:extLst>
           </p:cNvPr>
@@ -3967,7 +3967,7 @@
                   <a:srgbClr val="0A0A0A"/>
                 </a:solidFill>
               </a:rPr>
-              <a:t>A ResNet-18 baseline is included as the modern comparison</a:t>
+              <a:t>ResNet-18 is more accurate but far less efficient</a:t>
             </a:r>
           </a:p>
         </p:txBody>
@@ -3977,7 +3977,7 @@
           <p:cNvPr id="2" name="">
             <a:extLst xmlns:a="http://schemas.openxmlformats.org/drawingml/2006/main">
               <a:ext uri="{FF2B5EF4-FFF2-40B4-BE49-F238E27FC236}">
-                <a16:creationId xmlns:a16="http://schemas.microsoft.com/office/drawing/2014/main" id="{A19B7634-0B0E-4F5A-99A8-B0ADDD6CE34A}"/>
+                <a16:creationId xmlns:a16="http://schemas.microsoft.com/office/drawing/2014/main" id="{8E702319-ABF2-460E-9DAE-84E306A36DE5}"/>
               </a:ext>
             </a:extLst>
           </p:cNvPr>
@@ -4017,7 +4017,7 @@
                   <a:srgbClr val="555555"/>
                 </a:solidFill>
               </a:rPr>
-              <a:t>For today's toolkit, residual blocks and batch normalization are the natural contrast to LeNet.</a:t>
+              <a:t>The modern baseline improves accuracy by 0.35 percentage points, but with a much larger model.</a:t>
             </a:r>
           </a:p>
         </p:txBody>
@@ -4027,7 +4027,7 @@
           <p:cNvPr id="3" name="">
             <a:extLst xmlns:a="http://schemas.openxmlformats.org/drawingml/2006/main">
               <a:ext uri="{FF2B5EF4-FFF2-40B4-BE49-F238E27FC236}">
-                <a16:creationId xmlns:a16="http://schemas.microsoft.com/office/drawing/2014/main" id="{32E528A2-A933-45BB-8722-B5E705B7C00F}"/>
+                <a16:creationId xmlns:a16="http://schemas.microsoft.com/office/drawing/2014/main" id="{BC21D88C-10A7-4A91-B3A9-6A2AFBCB3FA0}"/>
               </a:ext>
             </a:extLst>
           </p:cNvPr>
@@ -4060,7 +4060,7 @@
           <p:cNvPr id="4" name="">
             <a:extLst xmlns:a="http://schemas.openxmlformats.org/drawingml/2006/main">
               <a:ext uri="{FF2B5EF4-FFF2-40B4-BE49-F238E27FC236}">
-                <a16:creationId xmlns:a16="http://schemas.microsoft.com/office/drawing/2014/main" id="{DA49C6DA-6508-4DB9-95FD-2C8469AFACE5}"/>
+                <a16:creationId xmlns:a16="http://schemas.microsoft.com/office/drawing/2014/main" id="{DB202C17-7A71-4C2B-A72E-A26738641BB2}"/>
               </a:ext>
             </a:extLst>
           </p:cNvPr>
@@ -4093,7 +4093,7 @@
           <p:cNvPr id="5" name="">
             <a:extLst xmlns:a="http://schemas.openxmlformats.org/drawingml/2006/main">
               <a:ext uri="{FF2B5EF4-FFF2-40B4-BE49-F238E27FC236}">
-                <a16:creationId xmlns:a16="http://schemas.microsoft.com/office/drawing/2014/main" id="{C9B5AE81-1975-478D-865F-548BC078C14C}"/>
+                <a16:creationId xmlns:a16="http://schemas.microsoft.com/office/drawing/2014/main" id="{E6F67CF2-4EB1-461D-BD5A-4EBFB821FBC9}"/>
               </a:ext>
             </a:extLst>
           </p:cNvPr>
@@ -4143,18 +4143,18 @@
           <p:cNvPr id="6" name="">
             <a:extLst xmlns:a="http://schemas.openxmlformats.org/drawingml/2006/main">
               <a:ext uri="{FF2B5EF4-FFF2-40B4-BE49-F238E27FC236}">
-                <a16:creationId xmlns:a16="http://schemas.microsoft.com/office/drawing/2014/main" id="{DB5555DB-8823-47FD-A96B-00FE14BEAADC}"/>
-              </a:ext>
-            </a:extLst>
-          </p:cNvPr>
-          <p:cNvSpPr>
-            <a:spLocks xmlns:a="http://schemas.openxmlformats.org/drawingml/2006/main" noGrp="1"/>
-          </p:cNvSpPr>
-          <p:nvPr/>
-        </p:nvSpPr>
-        <p:spPr>
-          <a:xfrm xmlns:a="http://schemas.openxmlformats.org/drawingml/2006/main">
-            <a:off x="1200150" y="3505200"/>
+                <a16:creationId xmlns:a16="http://schemas.microsoft.com/office/drawing/2014/main" id="{A8552979-1015-4C48-A400-F6B2BCF840C0}"/>
+              </a:ext>
+            </a:extLst>
+          </p:cNvPr>
+          <p:cNvSpPr>
+            <a:spLocks xmlns:a="http://schemas.openxmlformats.org/drawingml/2006/main" noGrp="1"/>
+          </p:cNvSpPr>
+          <p:nvPr/>
+        </p:nvSpPr>
+        <p:spPr>
+          <a:xfrm xmlns:a="http://schemas.openxmlformats.org/drawingml/2006/main">
+            <a:off x="1200150" y="3429000"/>
             <a:ext cx="66675" cy="66675"/>
           </a:xfrm>
           <a:prstGeom xmlns:a="http://schemas.openxmlformats.org/drawingml/2006/main" prst="rect">
@@ -4176,19 +4176,19 @@
           <p:cNvPr id="7" name="">
             <a:extLst xmlns:a="http://schemas.openxmlformats.org/drawingml/2006/main">
               <a:ext uri="{FF2B5EF4-FFF2-40B4-BE49-F238E27FC236}">
-                <a16:creationId xmlns:a16="http://schemas.microsoft.com/office/drawing/2014/main" id="{0B6E9A61-D018-400D-A587-3EF201F01BDC}"/>
-              </a:ext>
-            </a:extLst>
-          </p:cNvPr>
-          <p:cNvSpPr>
-            <a:spLocks xmlns:a="http://schemas.openxmlformats.org/drawingml/2006/main" noGrp="1"/>
-          </p:cNvSpPr>
-          <p:nvPr/>
-        </p:nvSpPr>
-        <p:spPr>
-          <a:xfrm xmlns:a="http://schemas.openxmlformats.org/drawingml/2006/main">
-            <a:off x="1428750" y="3409950"/>
-            <a:ext cx="3486150" cy="381000"/>
+                <a16:creationId xmlns:a16="http://schemas.microsoft.com/office/drawing/2014/main" id="{52720059-A0F5-4496-895A-1E9DA5281168}"/>
+              </a:ext>
+            </a:extLst>
+          </p:cNvPr>
+          <p:cNvSpPr>
+            <a:spLocks xmlns:a="http://schemas.openxmlformats.org/drawingml/2006/main" noGrp="1"/>
+          </p:cNvSpPr>
+          <p:nvPr/>
+        </p:nvSpPr>
+        <p:spPr>
+          <a:xfrm xmlns:a="http://schemas.openxmlformats.org/drawingml/2006/main">
+            <a:off x="1428750" y="3333750"/>
+            <a:ext cx="3486150" cy="342900"/>
           </a:xfrm>
           <a:prstGeom xmlns:a="http://schemas.openxmlformats.org/drawingml/2006/main" prst="rect">
             <a:avLst/>
@@ -4204,19 +4204,19 @@
           <a:lstStyle xmlns:a="http://schemas.openxmlformats.org/drawingml/2006/main"/>
           <a:p xmlns:a="http://schemas.openxmlformats.org/drawingml/2006/main">
             <a:pPr algn="l">
-              <a:defRPr sz="1650" b="0">
-                <a:solidFill>
-                  <a:srgbClr val="0A0A0A"/>
-                </a:solidFill>
-              </a:defRPr>
-            </a:pPr>
-            <a:r>
-              <a:rPr sz="1650" b="0">
-                <a:solidFill>
-                  <a:srgbClr val="0A0A0A"/>
-                </a:solidFill>
-              </a:rPr>
-              <a:t>61k parameters</a:t>
+              <a:defRPr sz="1575" b="0">
+                <a:solidFill>
+                  <a:srgbClr val="0A0A0A"/>
+                </a:solidFill>
+              </a:defRPr>
+            </a:pPr>
+            <a:r>
+              <a:rPr sz="1575" b="0">
+                <a:solidFill>
+                  <a:srgbClr val="0A0A0A"/>
+                </a:solidFill>
+              </a:rPr>
+              <a:t>98.83% test accuracy</a:t>
             </a:r>
           </a:p>
         </p:txBody>
@@ -4226,18 +4226,18 @@
           <p:cNvPr id="8" name="">
             <a:extLst xmlns:a="http://schemas.openxmlformats.org/drawingml/2006/main">
               <a:ext uri="{FF2B5EF4-FFF2-40B4-BE49-F238E27FC236}">
-                <a16:creationId xmlns:a16="http://schemas.microsoft.com/office/drawing/2014/main" id="{333F4F27-4539-43F5-BE97-8C485D31332E}"/>
-              </a:ext>
-            </a:extLst>
-          </p:cNvPr>
-          <p:cNvSpPr>
-            <a:spLocks xmlns:a="http://schemas.openxmlformats.org/drawingml/2006/main" noGrp="1"/>
-          </p:cNvSpPr>
-          <p:nvPr/>
-        </p:nvSpPr>
-        <p:spPr>
-          <a:xfrm xmlns:a="http://schemas.openxmlformats.org/drawingml/2006/main">
-            <a:off x="1200150" y="3905250"/>
+                <a16:creationId xmlns:a16="http://schemas.microsoft.com/office/drawing/2014/main" id="{BBCCEDBE-E498-43F3-9940-E174658ECEC6}"/>
+              </a:ext>
+            </a:extLst>
+          </p:cNvPr>
+          <p:cNvSpPr>
+            <a:spLocks xmlns:a="http://schemas.openxmlformats.org/drawingml/2006/main" noGrp="1"/>
+          </p:cNvSpPr>
+          <p:nvPr/>
+        </p:nvSpPr>
+        <p:spPr>
+          <a:xfrm xmlns:a="http://schemas.openxmlformats.org/drawingml/2006/main">
+            <a:off x="1200150" y="3790950"/>
             <a:ext cx="66675" cy="66675"/>
           </a:xfrm>
           <a:prstGeom xmlns:a="http://schemas.openxmlformats.org/drawingml/2006/main" prst="rect">
@@ -4259,19 +4259,19 @@
           <p:cNvPr id="9" name="">
             <a:extLst xmlns:a="http://schemas.openxmlformats.org/drawingml/2006/main">
               <a:ext uri="{FF2B5EF4-FFF2-40B4-BE49-F238E27FC236}">
-                <a16:creationId xmlns:a16="http://schemas.microsoft.com/office/drawing/2014/main" id="{7D9EBE74-8BC7-443E-8D57-957E69FF9D62}"/>
-              </a:ext>
-            </a:extLst>
-          </p:cNvPr>
-          <p:cNvSpPr>
-            <a:spLocks xmlns:a="http://schemas.openxmlformats.org/drawingml/2006/main" noGrp="1"/>
-          </p:cNvSpPr>
-          <p:nvPr/>
-        </p:nvSpPr>
-        <p:spPr>
-          <a:xfrm xmlns:a="http://schemas.openxmlformats.org/drawingml/2006/main">
-            <a:off x="1428750" y="3810000"/>
-            <a:ext cx="3486150" cy="381000"/>
+                <a16:creationId xmlns:a16="http://schemas.microsoft.com/office/drawing/2014/main" id="{5FB68104-FE8F-4D39-942D-495A4BFF73A3}"/>
+              </a:ext>
+            </a:extLst>
+          </p:cNvPr>
+          <p:cNvSpPr>
+            <a:spLocks xmlns:a="http://schemas.openxmlformats.org/drawingml/2006/main" noGrp="1"/>
+          </p:cNvSpPr>
+          <p:nvPr/>
+        </p:nvSpPr>
+        <p:spPr>
+          <a:xfrm xmlns:a="http://schemas.openxmlformats.org/drawingml/2006/main">
+            <a:off x="1428750" y="3695700"/>
+            <a:ext cx="3486150" cy="342900"/>
           </a:xfrm>
           <a:prstGeom xmlns:a="http://schemas.openxmlformats.org/drawingml/2006/main" prst="rect">
             <a:avLst/>
@@ -4287,19 +4287,19 @@
           <a:lstStyle xmlns:a="http://schemas.openxmlformats.org/drawingml/2006/main"/>
           <a:p xmlns:a="http://schemas.openxmlformats.org/drawingml/2006/main">
             <a:pPr algn="l">
-              <a:defRPr sz="1650" b="0">
-                <a:solidFill>
-                  <a:srgbClr val="0A0A0A"/>
-                </a:solidFill>
-              </a:defRPr>
-            </a:pPr>
-            <a:r>
-              <a:rPr sz="1650" b="0">
-                <a:solidFill>
-                  <a:srgbClr val="0A0A0A"/>
-                </a:solidFill>
-              </a:rPr>
-              <a:t>Tanh + average pooling</a:t>
+              <a:defRPr sz="1575" b="0">
+                <a:solidFill>
+                  <a:srgbClr val="0A0A0A"/>
+                </a:solidFill>
+              </a:defRPr>
+            </a:pPr>
+            <a:r>
+              <a:rPr sz="1575" b="0">
+                <a:solidFill>
+                  <a:srgbClr val="0A0A0A"/>
+                </a:solidFill>
+              </a:rPr>
+              <a:t>61,706 parameters</a:t>
             </a:r>
           </a:p>
         </p:txBody>
@@ -4309,18 +4309,18 @@
           <p:cNvPr id="10" name="">
             <a:extLst xmlns:a="http://schemas.openxmlformats.org/drawingml/2006/main">
               <a:ext uri="{FF2B5EF4-FFF2-40B4-BE49-F238E27FC236}">
-                <a16:creationId xmlns:a16="http://schemas.microsoft.com/office/drawing/2014/main" id="{F8F84E13-A817-4E35-BC09-BD986686DB6F}"/>
-              </a:ext>
-            </a:extLst>
-          </p:cNvPr>
-          <p:cNvSpPr>
-            <a:spLocks xmlns:a="http://schemas.openxmlformats.org/drawingml/2006/main" noGrp="1"/>
-          </p:cNvSpPr>
-          <p:nvPr/>
-        </p:nvSpPr>
-        <p:spPr>
-          <a:xfrm xmlns:a="http://schemas.openxmlformats.org/drawingml/2006/main">
-            <a:off x="1200150" y="4305300"/>
+                <a16:creationId xmlns:a16="http://schemas.microsoft.com/office/drawing/2014/main" id="{E5C899B6-9C6E-4FA3-A8AD-7352E7BF3B7B}"/>
+              </a:ext>
+            </a:extLst>
+          </p:cNvPr>
+          <p:cNvSpPr>
+            <a:spLocks xmlns:a="http://schemas.openxmlformats.org/drawingml/2006/main" noGrp="1"/>
+          </p:cNvSpPr>
+          <p:nvPr/>
+        </p:nvSpPr>
+        <p:spPr>
+          <a:xfrm xmlns:a="http://schemas.openxmlformats.org/drawingml/2006/main">
+            <a:off x="1200150" y="4152900"/>
             <a:ext cx="66675" cy="66675"/>
           </a:xfrm>
           <a:prstGeom xmlns:a="http://schemas.openxmlformats.org/drawingml/2006/main" prst="rect">
@@ -4342,19 +4342,19 @@
           <p:cNvPr id="11" name="">
             <a:extLst xmlns:a="http://schemas.openxmlformats.org/drawingml/2006/main">
               <a:ext uri="{FF2B5EF4-FFF2-40B4-BE49-F238E27FC236}">
-                <a16:creationId xmlns:a16="http://schemas.microsoft.com/office/drawing/2014/main" id="{775455E4-39BE-4B69-9F48-B56FD87DB4D7}"/>
-              </a:ext>
-            </a:extLst>
-          </p:cNvPr>
-          <p:cNvSpPr>
-            <a:spLocks xmlns:a="http://schemas.openxmlformats.org/drawingml/2006/main" noGrp="1"/>
-          </p:cNvSpPr>
-          <p:nvPr/>
-        </p:nvSpPr>
-        <p:spPr>
-          <a:xfrm xmlns:a="http://schemas.openxmlformats.org/drawingml/2006/main">
-            <a:off x="1428750" y="4210050"/>
-            <a:ext cx="3486150" cy="381000"/>
+                <a16:creationId xmlns:a16="http://schemas.microsoft.com/office/drawing/2014/main" id="{429A4947-EBDC-4A6C-81C1-435946DB40C7}"/>
+              </a:ext>
+            </a:extLst>
+          </p:cNvPr>
+          <p:cNvSpPr>
+            <a:spLocks xmlns:a="http://schemas.openxmlformats.org/drawingml/2006/main" noGrp="1"/>
+          </p:cNvSpPr>
+          <p:nvPr/>
+        </p:nvSpPr>
+        <p:spPr>
+          <a:xfrm xmlns:a="http://schemas.openxmlformats.org/drawingml/2006/main">
+            <a:off x="1428750" y="4057650"/>
+            <a:ext cx="3486150" cy="342900"/>
           </a:xfrm>
           <a:prstGeom xmlns:a="http://schemas.openxmlformats.org/drawingml/2006/main" prst="rect">
             <a:avLst/>
@@ -4370,19 +4370,19 @@
           <a:lstStyle xmlns:a="http://schemas.openxmlformats.org/drawingml/2006/main"/>
           <a:p xmlns:a="http://schemas.openxmlformats.org/drawingml/2006/main">
             <a:pPr algn="l">
-              <a:defRPr sz="1650" b="0">
-                <a:solidFill>
-                  <a:srgbClr val="0A0A0A"/>
-                </a:solidFill>
-              </a:defRPr>
-            </a:pPr>
-            <a:r>
-              <a:rPr sz="1650" b="0">
-                <a:solidFill>
-                  <a:srgbClr val="0A0A0A"/>
-                </a:solidFill>
-              </a:rPr>
-              <a:t>Designed for small digit images</a:t>
+              <a:defRPr sz="1575" b="0">
+                <a:solidFill>
+                  <a:srgbClr val="0A0A0A"/>
+                </a:solidFill>
+              </a:defRPr>
+            </a:pPr>
+            <a:r>
+              <a:rPr sz="1575" b="0">
+                <a:solidFill>
+                  <a:srgbClr val="0A0A0A"/>
+                </a:solidFill>
+              </a:rPr>
+              <a:t>16.81 s CPU training</a:t>
             </a:r>
           </a:p>
         </p:txBody>
@@ -4392,7 +4392,90 @@
           <p:cNvPr id="12" name="">
             <a:extLst xmlns:a="http://schemas.openxmlformats.org/drawingml/2006/main">
               <a:ext uri="{FF2B5EF4-FFF2-40B4-BE49-F238E27FC236}">
-                <a16:creationId xmlns:a16="http://schemas.microsoft.com/office/drawing/2014/main" id="{EDC9B4DA-9331-4004-BF32-A5CFC614E2AA}"/>
+                <a16:creationId xmlns:a16="http://schemas.microsoft.com/office/drawing/2014/main" id="{82106F29-3D96-47C4-A825-DAAB70FF0BB8}"/>
+              </a:ext>
+            </a:extLst>
+          </p:cNvPr>
+          <p:cNvSpPr>
+            <a:spLocks xmlns:a="http://schemas.openxmlformats.org/drawingml/2006/main" noGrp="1"/>
+          </p:cNvSpPr>
+          <p:nvPr/>
+        </p:nvSpPr>
+        <p:spPr>
+          <a:xfrm xmlns:a="http://schemas.openxmlformats.org/drawingml/2006/main">
+            <a:off x="1200150" y="4514850"/>
+            <a:ext cx="66675" cy="66675"/>
+          </a:xfrm>
+          <a:prstGeom xmlns:a="http://schemas.openxmlformats.org/drawingml/2006/main" prst="rect">
+            <a:avLst/>
+          </a:prstGeom>
+          <a:solidFill xmlns:a="http://schemas.openxmlformats.org/drawingml/2006/main">
+            <a:srgbClr val="FF6B35"/>
+          </a:solidFill>
+          <a:ln xmlns:a="http://schemas.openxmlformats.org/drawingml/2006/main" w="0">
+            <a:solidFill>
+              <a:srgbClr val="FF6B35"/>
+            </a:solidFill>
+            <a:prstDash val="solid"/>
+          </a:ln>
+        </p:spPr>
+      </p:sp>
+      <p:sp>
+        <p:nvSpPr>
+          <p:cNvPr id="13" name="">
+            <a:extLst xmlns:a="http://schemas.openxmlformats.org/drawingml/2006/main">
+              <a:ext uri="{FF2B5EF4-FFF2-40B4-BE49-F238E27FC236}">
+                <a16:creationId xmlns:a16="http://schemas.microsoft.com/office/drawing/2014/main" id="{0F61CC76-CF0A-4A62-B118-68479110B40D}"/>
+              </a:ext>
+            </a:extLst>
+          </p:cNvPr>
+          <p:cNvSpPr>
+            <a:spLocks xmlns:a="http://schemas.openxmlformats.org/drawingml/2006/main" noGrp="1"/>
+          </p:cNvSpPr>
+          <p:nvPr/>
+        </p:nvSpPr>
+        <p:spPr>
+          <a:xfrm xmlns:a="http://schemas.openxmlformats.org/drawingml/2006/main">
+            <a:off x="1428750" y="4419600"/>
+            <a:ext cx="3486150" cy="342900"/>
+          </a:xfrm>
+          <a:prstGeom xmlns:a="http://schemas.openxmlformats.org/drawingml/2006/main" prst="rect">
+            <a:avLst/>
+          </a:prstGeom>
+          <a:noFill xmlns:a="http://schemas.openxmlformats.org/drawingml/2006/main"/>
+          <a:ln xmlns:a="http://schemas.openxmlformats.org/drawingml/2006/main" w="0">
+            <a:noFill/>
+            <a:prstDash val="solid"/>
+          </a:ln>
+        </p:spPr>
+        <p:txBody>
+          <a:bodyPr xmlns:a="http://schemas.openxmlformats.org/drawingml/2006/main"/>
+          <a:lstStyle xmlns:a="http://schemas.openxmlformats.org/drawingml/2006/main"/>
+          <a:p xmlns:a="http://schemas.openxmlformats.org/drawingml/2006/main">
+            <a:pPr algn="l">
+              <a:defRPr sz="1575" b="0">
+                <a:solidFill>
+                  <a:srgbClr val="0A0A0A"/>
+                </a:solidFill>
+              </a:defRPr>
+            </a:pPr>
+            <a:r>
+              <a:rPr sz="1575" b="0">
+                <a:solidFill>
+                  <a:srgbClr val="0A0A0A"/>
+                </a:solidFill>
+              </a:rPr>
+              <a:t>0.25 MB checkpoint</a:t>
+            </a:r>
+          </a:p>
+        </p:txBody>
+      </p:sp>
+      <p:sp>
+        <p:nvSpPr>
+          <p:cNvPr id="14" name="">
+            <a:extLst xmlns:a="http://schemas.openxmlformats.org/drawingml/2006/main">
+              <a:ext uri="{FF2B5EF4-FFF2-40B4-BE49-F238E27FC236}">
+                <a16:creationId xmlns:a16="http://schemas.microsoft.com/office/drawing/2014/main" id="{F210F14B-6536-45CA-8968-D0245C4E83D7}"/>
               </a:ext>
             </a:extLst>
           </p:cNvPr>
@@ -4422,10 +4505,10 @@
       </p:sp>
       <p:sp>
         <p:nvSpPr>
-          <p:cNvPr id="13" name="">
-            <a:extLst xmlns:a="http://schemas.openxmlformats.org/drawingml/2006/main">
-              <a:ext uri="{FF2B5EF4-FFF2-40B4-BE49-F238E27FC236}">
-                <a16:creationId xmlns:a16="http://schemas.microsoft.com/office/drawing/2014/main" id="{FE3C2172-3952-46DE-8E1D-F2D68213D484}"/>
+          <p:cNvPr id="15" name="">
+            <a:extLst xmlns:a="http://schemas.openxmlformats.org/drawingml/2006/main">
+              <a:ext uri="{FF2B5EF4-FFF2-40B4-BE49-F238E27FC236}">
+                <a16:creationId xmlns:a16="http://schemas.microsoft.com/office/drawing/2014/main" id="{49E28945-3628-4745-A105-C8F28B09BAEC}"/>
               </a:ext>
             </a:extLst>
           </p:cNvPr>
@@ -4472,21 +4555,21 @@
       </p:sp>
       <p:sp>
         <p:nvSpPr>
-          <p:cNvPr id="14" name="">
-            <a:extLst xmlns:a="http://schemas.openxmlformats.org/drawingml/2006/main">
-              <a:ext uri="{FF2B5EF4-FFF2-40B4-BE49-F238E27FC236}">
-                <a16:creationId xmlns:a16="http://schemas.microsoft.com/office/drawing/2014/main" id="{7B72EB7C-CF2D-4C34-9937-E866AE1DE80E}"/>
-              </a:ext>
-            </a:extLst>
-          </p:cNvPr>
-          <p:cNvSpPr>
-            <a:spLocks xmlns:a="http://schemas.openxmlformats.org/drawingml/2006/main" noGrp="1"/>
-          </p:cNvSpPr>
-          <p:nvPr/>
-        </p:nvSpPr>
-        <p:spPr>
-          <a:xfrm xmlns:a="http://schemas.openxmlformats.org/drawingml/2006/main">
-            <a:off x="6800850" y="3505200"/>
+          <p:cNvPr id="16" name="">
+            <a:extLst xmlns:a="http://schemas.openxmlformats.org/drawingml/2006/main">
+              <a:ext uri="{FF2B5EF4-FFF2-40B4-BE49-F238E27FC236}">
+                <a16:creationId xmlns:a16="http://schemas.microsoft.com/office/drawing/2014/main" id="{AD5CED1B-21E2-4080-8CE9-14699224056A}"/>
+              </a:ext>
+            </a:extLst>
+          </p:cNvPr>
+          <p:cNvSpPr>
+            <a:spLocks xmlns:a="http://schemas.openxmlformats.org/drawingml/2006/main" noGrp="1"/>
+          </p:cNvSpPr>
+          <p:nvPr/>
+        </p:nvSpPr>
+        <p:spPr>
+          <a:xfrm xmlns:a="http://schemas.openxmlformats.org/drawingml/2006/main">
+            <a:off x="6800850" y="3429000"/>
             <a:ext cx="66675" cy="66675"/>
           </a:xfrm>
           <a:prstGeom xmlns:a="http://schemas.openxmlformats.org/drawingml/2006/main" prst="rect">
@@ -4505,22 +4588,22 @@
       </p:sp>
       <p:sp>
         <p:nvSpPr>
-          <p:cNvPr id="15" name="">
-            <a:extLst xmlns:a="http://schemas.openxmlformats.org/drawingml/2006/main">
-              <a:ext uri="{FF2B5EF4-FFF2-40B4-BE49-F238E27FC236}">
-                <a16:creationId xmlns:a16="http://schemas.microsoft.com/office/drawing/2014/main" id="{89ED3887-FC93-4D5B-9222-DE4DCD811DB1}"/>
-              </a:ext>
-            </a:extLst>
-          </p:cNvPr>
-          <p:cNvSpPr>
-            <a:spLocks xmlns:a="http://schemas.openxmlformats.org/drawingml/2006/main" noGrp="1"/>
-          </p:cNvSpPr>
-          <p:nvPr/>
-        </p:nvSpPr>
-        <p:spPr>
-          <a:xfrm xmlns:a="http://schemas.openxmlformats.org/drawingml/2006/main">
-            <a:off x="7029450" y="3409950"/>
-            <a:ext cx="3486150" cy="381000"/>
+          <p:cNvPr id="17" name="">
+            <a:extLst xmlns:a="http://schemas.openxmlformats.org/drawingml/2006/main">
+              <a:ext uri="{FF2B5EF4-FFF2-40B4-BE49-F238E27FC236}">
+                <a16:creationId xmlns:a16="http://schemas.microsoft.com/office/drawing/2014/main" id="{CDA10C8F-1FA4-4851-B39B-B229CDC9A8A1}"/>
+              </a:ext>
+            </a:extLst>
+          </p:cNvPr>
+          <p:cNvSpPr>
+            <a:spLocks xmlns:a="http://schemas.openxmlformats.org/drawingml/2006/main" noGrp="1"/>
+          </p:cNvSpPr>
+          <p:nvPr/>
+        </p:nvSpPr>
+        <p:spPr>
+          <a:xfrm xmlns:a="http://schemas.openxmlformats.org/drawingml/2006/main">
+            <a:off x="7029450" y="3333750"/>
+            <a:ext cx="3486150" cy="342900"/>
           </a:xfrm>
           <a:prstGeom xmlns:a="http://schemas.openxmlformats.org/drawingml/2006/main" prst="rect">
             <a:avLst/>
@@ -4536,40 +4619,40 @@
           <a:lstStyle xmlns:a="http://schemas.openxmlformats.org/drawingml/2006/main"/>
           <a:p xmlns:a="http://schemas.openxmlformats.org/drawingml/2006/main">
             <a:pPr algn="l">
-              <a:defRPr sz="1650" b="0">
-                <a:solidFill>
-                  <a:srgbClr val="0A0A0A"/>
-                </a:solidFill>
-              </a:defRPr>
-            </a:pPr>
-            <a:r>
-              <a:rPr sz="1650" b="0">
-                <a:solidFill>
-                  <a:srgbClr val="0A0A0A"/>
-                </a:solidFill>
-              </a:rPr>
-              <a:t>Residual blocks</a:t>
-            </a:r>
-          </a:p>
-        </p:txBody>
-      </p:sp>
-      <p:sp>
-        <p:nvSpPr>
-          <p:cNvPr id="16" name="">
-            <a:extLst xmlns:a="http://schemas.openxmlformats.org/drawingml/2006/main">
-              <a:ext uri="{FF2B5EF4-FFF2-40B4-BE49-F238E27FC236}">
-                <a16:creationId xmlns:a16="http://schemas.microsoft.com/office/drawing/2014/main" id="{906FEAE9-2490-4ED3-A852-60972F4FE5AC}"/>
-              </a:ext>
-            </a:extLst>
-          </p:cNvPr>
-          <p:cNvSpPr>
-            <a:spLocks xmlns:a="http://schemas.openxmlformats.org/drawingml/2006/main" noGrp="1"/>
-          </p:cNvSpPr>
-          <p:nvPr/>
-        </p:nvSpPr>
-        <p:spPr>
-          <a:xfrm xmlns:a="http://schemas.openxmlformats.org/drawingml/2006/main">
-            <a:off x="6800850" y="3905250"/>
+              <a:defRPr sz="1575" b="0">
+                <a:solidFill>
+                  <a:srgbClr val="0A0A0A"/>
+                </a:solidFill>
+              </a:defRPr>
+            </a:pPr>
+            <a:r>
+              <a:rPr sz="1575" b="0">
+                <a:solidFill>
+                  <a:srgbClr val="0A0A0A"/>
+                </a:solidFill>
+              </a:rPr>
+              <a:t>99.18% test accuracy</a:t>
+            </a:r>
+          </a:p>
+        </p:txBody>
+      </p:sp>
+      <p:sp>
+        <p:nvSpPr>
+          <p:cNvPr id="18" name="">
+            <a:extLst xmlns:a="http://schemas.openxmlformats.org/drawingml/2006/main">
+              <a:ext uri="{FF2B5EF4-FFF2-40B4-BE49-F238E27FC236}">
+                <a16:creationId xmlns:a16="http://schemas.microsoft.com/office/drawing/2014/main" id="{77153771-B2EA-48EC-9644-D17BEB397803}"/>
+              </a:ext>
+            </a:extLst>
+          </p:cNvPr>
+          <p:cNvSpPr>
+            <a:spLocks xmlns:a="http://schemas.openxmlformats.org/drawingml/2006/main" noGrp="1"/>
+          </p:cNvSpPr>
+          <p:nvPr/>
+        </p:nvSpPr>
+        <p:spPr>
+          <a:xfrm xmlns:a="http://schemas.openxmlformats.org/drawingml/2006/main">
+            <a:off x="6800850" y="3790950"/>
             <a:ext cx="66675" cy="66675"/>
           </a:xfrm>
           <a:prstGeom xmlns:a="http://schemas.openxmlformats.org/drawingml/2006/main" prst="rect">
@@ -4588,22 +4671,22 @@
       </p:sp>
       <p:sp>
         <p:nvSpPr>
-          <p:cNvPr id="17" name="">
-            <a:extLst xmlns:a="http://schemas.openxmlformats.org/drawingml/2006/main">
-              <a:ext uri="{FF2B5EF4-FFF2-40B4-BE49-F238E27FC236}">
-                <a16:creationId xmlns:a16="http://schemas.microsoft.com/office/drawing/2014/main" id="{916D6AD4-65C7-4297-BEE3-EAADBB7BC1E9}"/>
-              </a:ext>
-            </a:extLst>
-          </p:cNvPr>
-          <p:cNvSpPr>
-            <a:spLocks xmlns:a="http://schemas.openxmlformats.org/drawingml/2006/main" noGrp="1"/>
-          </p:cNvSpPr>
-          <p:nvPr/>
-        </p:nvSpPr>
-        <p:spPr>
-          <a:xfrm xmlns:a="http://schemas.openxmlformats.org/drawingml/2006/main">
-            <a:off x="7029450" y="3810000"/>
-            <a:ext cx="3486150" cy="381000"/>
+          <p:cNvPr id="19" name="">
+            <a:extLst xmlns:a="http://schemas.openxmlformats.org/drawingml/2006/main">
+              <a:ext uri="{FF2B5EF4-FFF2-40B4-BE49-F238E27FC236}">
+                <a16:creationId xmlns:a16="http://schemas.microsoft.com/office/drawing/2014/main" id="{EAB20544-D7C7-4EA5-B975-83560F9C11F6}"/>
+              </a:ext>
+            </a:extLst>
+          </p:cNvPr>
+          <p:cNvSpPr>
+            <a:spLocks xmlns:a="http://schemas.openxmlformats.org/drawingml/2006/main" noGrp="1"/>
+          </p:cNvSpPr>
+          <p:nvPr/>
+        </p:nvSpPr>
+        <p:spPr>
+          <a:xfrm xmlns:a="http://schemas.openxmlformats.org/drawingml/2006/main">
+            <a:off x="7029450" y="3695700"/>
+            <a:ext cx="3486150" cy="342900"/>
           </a:xfrm>
           <a:prstGeom xmlns:a="http://schemas.openxmlformats.org/drawingml/2006/main" prst="rect">
             <a:avLst/>
@@ -4619,40 +4702,40 @@
           <a:lstStyle xmlns:a="http://schemas.openxmlformats.org/drawingml/2006/main"/>
           <a:p xmlns:a="http://schemas.openxmlformats.org/drawingml/2006/main">
             <a:pPr algn="l">
-              <a:defRPr sz="1650" b="0">
-                <a:solidFill>
-                  <a:srgbClr val="0A0A0A"/>
-                </a:solidFill>
-              </a:defRPr>
-            </a:pPr>
-            <a:r>
-              <a:rPr sz="1650" b="0">
-                <a:solidFill>
-                  <a:srgbClr val="0A0A0A"/>
-                </a:solidFill>
-              </a:rPr>
-              <a:t>Batch normalization</a:t>
-            </a:r>
-          </a:p>
-        </p:txBody>
-      </p:sp>
-      <p:sp>
-        <p:nvSpPr>
-          <p:cNvPr id="18" name="">
-            <a:extLst xmlns:a="http://schemas.openxmlformats.org/drawingml/2006/main">
-              <a:ext uri="{FF2B5EF4-FFF2-40B4-BE49-F238E27FC236}">
-                <a16:creationId xmlns:a16="http://schemas.microsoft.com/office/drawing/2014/main" id="{00CC6CB7-7316-4D6F-B935-DA7926BF94BD}"/>
-              </a:ext>
-            </a:extLst>
-          </p:cNvPr>
-          <p:cNvSpPr>
-            <a:spLocks xmlns:a="http://schemas.openxmlformats.org/drawingml/2006/main" noGrp="1"/>
-          </p:cNvSpPr>
-          <p:nvPr/>
-        </p:nvSpPr>
-        <p:spPr>
-          <a:xfrm xmlns:a="http://schemas.openxmlformats.org/drawingml/2006/main">
-            <a:off x="6800850" y="4305300"/>
+              <a:defRPr sz="1575" b="0">
+                <a:solidFill>
+                  <a:srgbClr val="0A0A0A"/>
+                </a:solidFill>
+              </a:defRPr>
+            </a:pPr>
+            <a:r>
+              <a:rPr sz="1575" b="0">
+                <a:solidFill>
+                  <a:srgbClr val="0A0A0A"/>
+                </a:solidFill>
+              </a:rPr>
+              <a:t>11,172,810 parameters</a:t>
+            </a:r>
+          </a:p>
+        </p:txBody>
+      </p:sp>
+      <p:sp>
+        <p:nvSpPr>
+          <p:cNvPr id="20" name="">
+            <a:extLst xmlns:a="http://schemas.openxmlformats.org/drawingml/2006/main">
+              <a:ext uri="{FF2B5EF4-FFF2-40B4-BE49-F238E27FC236}">
+                <a16:creationId xmlns:a16="http://schemas.microsoft.com/office/drawing/2014/main" id="{26FB0ABC-8ED3-4515-9E3E-795715EC15C3}"/>
+              </a:ext>
+            </a:extLst>
+          </p:cNvPr>
+          <p:cNvSpPr>
+            <a:spLocks xmlns:a="http://schemas.openxmlformats.org/drawingml/2006/main" noGrp="1"/>
+          </p:cNvSpPr>
+          <p:nvPr/>
+        </p:nvSpPr>
+        <p:spPr>
+          <a:xfrm xmlns:a="http://schemas.openxmlformats.org/drawingml/2006/main">
+            <a:off x="6800850" y="4152900"/>
             <a:ext cx="66675" cy="66675"/>
           </a:xfrm>
           <a:prstGeom xmlns:a="http://schemas.openxmlformats.org/drawingml/2006/main" prst="rect">
@@ -4671,22 +4754,22 @@
       </p:sp>
       <p:sp>
         <p:nvSpPr>
-          <p:cNvPr id="19" name="">
-            <a:extLst xmlns:a="http://schemas.openxmlformats.org/drawingml/2006/main">
-              <a:ext uri="{FF2B5EF4-FFF2-40B4-BE49-F238E27FC236}">
-                <a16:creationId xmlns:a16="http://schemas.microsoft.com/office/drawing/2014/main" id="{20069FA2-1C54-46C1-AB4D-DEF100C8AB97}"/>
-              </a:ext>
-            </a:extLst>
-          </p:cNvPr>
-          <p:cNvSpPr>
-            <a:spLocks xmlns:a="http://schemas.openxmlformats.org/drawingml/2006/main" noGrp="1"/>
-          </p:cNvSpPr>
-          <p:nvPr/>
-        </p:nvSpPr>
-        <p:spPr>
-          <a:xfrm xmlns:a="http://schemas.openxmlformats.org/drawingml/2006/main">
-            <a:off x="7029450" y="4210050"/>
-            <a:ext cx="3486150" cy="381000"/>
+          <p:cNvPr id="21" name="">
+            <a:extLst xmlns:a="http://schemas.openxmlformats.org/drawingml/2006/main">
+              <a:ext uri="{FF2B5EF4-FFF2-40B4-BE49-F238E27FC236}">
+                <a16:creationId xmlns:a16="http://schemas.microsoft.com/office/drawing/2014/main" id="{86EE6662-A44D-4B1E-B15B-D9E439CAEFDC}"/>
+              </a:ext>
+            </a:extLst>
+          </p:cNvPr>
+          <p:cNvSpPr>
+            <a:spLocks xmlns:a="http://schemas.openxmlformats.org/drawingml/2006/main" noGrp="1"/>
+          </p:cNvSpPr>
+          <p:nvPr/>
+        </p:nvSpPr>
+        <p:spPr>
+          <a:xfrm xmlns:a="http://schemas.openxmlformats.org/drawingml/2006/main">
+            <a:off x="7029450" y="4057650"/>
+            <a:ext cx="3486150" cy="342900"/>
           </a:xfrm>
           <a:prstGeom xmlns:a="http://schemas.openxmlformats.org/drawingml/2006/main" prst="rect">
             <a:avLst/>
@@ -4702,41 +4785,124 @@
           <a:lstStyle xmlns:a="http://schemas.openxmlformats.org/drawingml/2006/main"/>
           <a:p xmlns:a="http://schemas.openxmlformats.org/drawingml/2006/main">
             <a:pPr algn="l">
-              <a:defRPr sz="1650" b="0">
-                <a:solidFill>
-                  <a:srgbClr val="0A0A0A"/>
-                </a:solidFill>
-              </a:defRPr>
-            </a:pPr>
-            <a:r>
-              <a:rPr sz="1650" b="0">
-                <a:solidFill>
-                  <a:srgbClr val="0A0A0A"/>
-                </a:solidFill>
-              </a:rPr>
-              <a:t>Adapted 1-channel MNIST stem</a:t>
-            </a:r>
-          </a:p>
-        </p:txBody>
-      </p:sp>
-      <p:sp>
-        <p:nvSpPr>
-          <p:cNvPr id="20" name="">
-            <a:extLst xmlns:a="http://schemas.openxmlformats.org/drawingml/2006/main">
-              <a:ext uri="{FF2B5EF4-FFF2-40B4-BE49-F238E27FC236}">
-                <a16:creationId xmlns:a16="http://schemas.microsoft.com/office/drawing/2014/main" id="{3F42D6EC-5AAF-4506-B82B-A34259CE700B}"/>
-              </a:ext>
-            </a:extLst>
-          </p:cNvPr>
-          <p:cNvSpPr>
-            <a:spLocks xmlns:a="http://schemas.openxmlformats.org/drawingml/2006/main" noGrp="1"/>
-          </p:cNvSpPr>
-          <p:nvPr/>
-        </p:nvSpPr>
-        <p:spPr>
-          <a:xfrm xmlns:a="http://schemas.openxmlformats.org/drawingml/2006/main">
-            <a:off x="1104900" y="5676900"/>
-            <a:ext cx="9906000" cy="304800"/>
+              <a:defRPr sz="1575" b="0">
+                <a:solidFill>
+                  <a:srgbClr val="0A0A0A"/>
+                </a:solidFill>
+              </a:defRPr>
+            </a:pPr>
+            <a:r>
+              <a:rPr sz="1575" b="0">
+                <a:solidFill>
+                  <a:srgbClr val="0A0A0A"/>
+                </a:solidFill>
+              </a:rPr>
+              <a:t>726.28 s CPU training</a:t>
+            </a:r>
+          </a:p>
+        </p:txBody>
+      </p:sp>
+      <p:sp>
+        <p:nvSpPr>
+          <p:cNvPr id="22" name="">
+            <a:extLst xmlns:a="http://schemas.openxmlformats.org/drawingml/2006/main">
+              <a:ext uri="{FF2B5EF4-FFF2-40B4-BE49-F238E27FC236}">
+                <a16:creationId xmlns:a16="http://schemas.microsoft.com/office/drawing/2014/main" id="{C36970EC-72FB-4D17-9941-E6324BEA7BFA}"/>
+              </a:ext>
+            </a:extLst>
+          </p:cNvPr>
+          <p:cNvSpPr>
+            <a:spLocks xmlns:a="http://schemas.openxmlformats.org/drawingml/2006/main" noGrp="1"/>
+          </p:cNvSpPr>
+          <p:nvPr/>
+        </p:nvSpPr>
+        <p:spPr>
+          <a:xfrm xmlns:a="http://schemas.openxmlformats.org/drawingml/2006/main">
+            <a:off x="6800850" y="4514850"/>
+            <a:ext cx="66675" cy="66675"/>
+          </a:xfrm>
+          <a:prstGeom xmlns:a="http://schemas.openxmlformats.org/drawingml/2006/main" prst="rect">
+            <a:avLst/>
+          </a:prstGeom>
+          <a:solidFill xmlns:a="http://schemas.openxmlformats.org/drawingml/2006/main">
+            <a:srgbClr val="FF6B35"/>
+          </a:solidFill>
+          <a:ln xmlns:a="http://schemas.openxmlformats.org/drawingml/2006/main" w="0">
+            <a:solidFill>
+              <a:srgbClr val="FF6B35"/>
+            </a:solidFill>
+            <a:prstDash val="solid"/>
+          </a:ln>
+        </p:spPr>
+      </p:sp>
+      <p:sp>
+        <p:nvSpPr>
+          <p:cNvPr id="23" name="">
+            <a:extLst xmlns:a="http://schemas.openxmlformats.org/drawingml/2006/main">
+              <a:ext uri="{FF2B5EF4-FFF2-40B4-BE49-F238E27FC236}">
+                <a16:creationId xmlns:a16="http://schemas.microsoft.com/office/drawing/2014/main" id="{38410224-A04B-42E8-BD65-D94DD269C90D}"/>
+              </a:ext>
+            </a:extLst>
+          </p:cNvPr>
+          <p:cNvSpPr>
+            <a:spLocks xmlns:a="http://schemas.openxmlformats.org/drawingml/2006/main" noGrp="1"/>
+          </p:cNvSpPr>
+          <p:nvPr/>
+        </p:nvSpPr>
+        <p:spPr>
+          <a:xfrm xmlns:a="http://schemas.openxmlformats.org/drawingml/2006/main">
+            <a:off x="7029450" y="4419600"/>
+            <a:ext cx="3486150" cy="342900"/>
+          </a:xfrm>
+          <a:prstGeom xmlns:a="http://schemas.openxmlformats.org/drawingml/2006/main" prst="rect">
+            <a:avLst/>
+          </a:prstGeom>
+          <a:noFill xmlns:a="http://schemas.openxmlformats.org/drawingml/2006/main"/>
+          <a:ln xmlns:a="http://schemas.openxmlformats.org/drawingml/2006/main" w="0">
+            <a:noFill/>
+            <a:prstDash val="solid"/>
+          </a:ln>
+        </p:spPr>
+        <p:txBody>
+          <a:bodyPr xmlns:a="http://schemas.openxmlformats.org/drawingml/2006/main"/>
+          <a:lstStyle xmlns:a="http://schemas.openxmlformats.org/drawingml/2006/main"/>
+          <a:p xmlns:a="http://schemas.openxmlformats.org/drawingml/2006/main">
+            <a:pPr algn="l">
+              <a:defRPr sz="1575" b="0">
+                <a:solidFill>
+                  <a:srgbClr val="0A0A0A"/>
+                </a:solidFill>
+              </a:defRPr>
+            </a:pPr>
+            <a:r>
+              <a:rPr sz="1575" b="0">
+                <a:solidFill>
+                  <a:srgbClr val="0A0A0A"/>
+                </a:solidFill>
+              </a:rPr>
+              <a:t>44.77 MB checkpoint</a:t>
+            </a:r>
+          </a:p>
+        </p:txBody>
+      </p:sp>
+      <p:sp>
+        <p:nvSpPr>
+          <p:cNvPr id="24" name="">
+            <a:extLst xmlns:a="http://schemas.openxmlformats.org/drawingml/2006/main">
+              <a:ext uri="{FF2B5EF4-FFF2-40B4-BE49-F238E27FC236}">
+                <a16:creationId xmlns:a16="http://schemas.microsoft.com/office/drawing/2014/main" id="{8E100381-B505-4D30-B67D-7201B209A30F}"/>
+              </a:ext>
+            </a:extLst>
+          </p:cNvPr>
+          <p:cNvSpPr>
+            <a:spLocks xmlns:a="http://schemas.openxmlformats.org/drawingml/2006/main" noGrp="1"/>
+          </p:cNvSpPr>
+          <p:nvPr/>
+        </p:nvSpPr>
+        <p:spPr>
+          <a:xfrm xmlns:a="http://schemas.openxmlformats.org/drawingml/2006/main">
+            <a:off x="1104900" y="5600700"/>
+            <a:ext cx="9906000" cy="419100"/>
           </a:xfrm>
           <a:prstGeom xmlns:a="http://schemas.openxmlformats.org/drawingml/2006/main" prst="rect">
             <a:avLst/>
@@ -4752,29 +4918,29 @@
           <a:lstStyle xmlns:a="http://schemas.openxmlformats.org/drawingml/2006/main"/>
           <a:p xmlns:a="http://schemas.openxmlformats.org/drawingml/2006/main">
             <a:pPr algn="ctr">
-              <a:defRPr sz="1800" b="0">
+              <a:defRPr sz="1875" b="0">
                 <a:solidFill>
                   <a:srgbClr val="555555"/>
                 </a:solidFill>
               </a:defRPr>
             </a:pPr>
             <a:r>
-              <a:rPr sz="1800" b="0">
+              <a:rPr sz="1875" b="0">
                 <a:solidFill>
                   <a:srgbClr val="555555"/>
                 </a:solidFill>
               </a:rPr>
-              <a:t>Run with: python train.py --model resnet18</a:t>
-            </a:r>
-          </a:p>
-        </p:txBody>
-      </p:sp>
-      <p:sp>
-        <p:nvSpPr>
-          <p:cNvPr id="21" name="">
-            <a:extLst xmlns:a="http://schemas.openxmlformats.org/drawingml/2006/main">
-              <a:ext uri="{FF2B5EF4-FFF2-40B4-BE49-F238E27FC236}">
-                <a16:creationId xmlns:a16="http://schemas.microsoft.com/office/drawing/2014/main" id="{9CD6ACE6-4793-4014-8015-6758B8CCCC78}"/>
+              <a:t>For MNIST, ResNet wins on accuracy; LeNet wins on simplicity, speed, and explainability.</a:t>
+            </a:r>
+          </a:p>
+        </p:txBody>
+      </p:sp>
+      <p:sp>
+        <p:nvSpPr>
+          <p:cNvPr id="25" name="">
+            <a:extLst xmlns:a="http://schemas.openxmlformats.org/drawingml/2006/main">
+              <a:ext uri="{FF2B5EF4-FFF2-40B4-BE49-F238E27FC236}">
+                <a16:creationId xmlns:a16="http://schemas.microsoft.com/office/drawing/2014/main" id="{A2E5C6A3-8CA2-4254-B938-BC05707BF770}"/>
               </a:ext>
             </a:extLst>
           </p:cNvPr>
@@ -4822,7 +4988,7 @@
     </p:spTree>
     <p:extLst>
       <p:ext uri="{BB962C8B-B14F-4D97-AF65-F5344CB8AC3E}">
-        <p14:creationId xmlns:p14="http://schemas.microsoft.com/office/powerpoint/2010/main" val="94459232"/>
+        <p14:creationId xmlns:p14="http://schemas.microsoft.com/office/powerpoint/2010/main" val="1559928962"/>
       </p:ext>
     </p:extLst>
   </p:cSld>
@@ -4853,7 +5019,7 @@
           <p:cNvPr id="1" name="">
             <a:extLst xmlns:a="http://schemas.openxmlformats.org/drawingml/2006/main">
               <a:ext uri="{FF2B5EF4-FFF2-40B4-BE49-F238E27FC236}">
-                <a16:creationId xmlns:a16="http://schemas.microsoft.com/office/drawing/2014/main" id="{E373A58B-2D86-4051-ADFB-505ADF1A2313}"/>
+                <a16:creationId xmlns:a16="http://schemas.microsoft.com/office/drawing/2014/main" id="{C2E7AFEF-1FD8-4C95-932A-4DC8849393D0}"/>
               </a:ext>
             </a:extLst>
           </p:cNvPr>
@@ -4903,7 +5069,7 @@
           <p:cNvPr id="2" name="">
             <a:extLst xmlns:a="http://schemas.openxmlformats.org/drawingml/2006/main">
               <a:ext uri="{FF2B5EF4-FFF2-40B4-BE49-F238E27FC236}">
-                <a16:creationId xmlns:a16="http://schemas.microsoft.com/office/drawing/2014/main" id="{8D35F664-B14F-4361-A927-76A77FAE4B78}"/>
+                <a16:creationId xmlns:a16="http://schemas.microsoft.com/office/drawing/2014/main" id="{5BEADC5B-0EC8-466D-85EB-C0C8701671D4}"/>
               </a:ext>
             </a:extLst>
           </p:cNvPr>
@@ -4953,7 +5119,7 @@
           <p:cNvPr id="3" name="">
             <a:extLst xmlns:a="http://schemas.openxmlformats.org/drawingml/2006/main">
               <a:ext uri="{FF2B5EF4-FFF2-40B4-BE49-F238E27FC236}">
-                <a16:creationId xmlns:a16="http://schemas.microsoft.com/office/drawing/2014/main" id="{13BEC01E-5F3E-49C8-8D7D-666AEABA24A7}"/>
+                <a16:creationId xmlns:a16="http://schemas.microsoft.com/office/drawing/2014/main" id="{219AC064-DB86-488C-85BA-82029F264E69}"/>
               </a:ext>
             </a:extLst>
           </p:cNvPr>
@@ -4986,7 +5152,7 @@
           <p:cNvPr id="4" name="">
             <a:extLst xmlns:a="http://schemas.openxmlformats.org/drawingml/2006/main">
               <a:ext uri="{FF2B5EF4-FFF2-40B4-BE49-F238E27FC236}">
-                <a16:creationId xmlns:a16="http://schemas.microsoft.com/office/drawing/2014/main" id="{0E87D5B2-EB86-4463-B63D-705CEA3E99F0}"/>
+                <a16:creationId xmlns:a16="http://schemas.microsoft.com/office/drawing/2014/main" id="{0749F49B-83D5-47A5-8EF0-D2B40B11A8A0}"/>
               </a:ext>
             </a:extLst>
           </p:cNvPr>
@@ -5019,7 +5185,7 @@
           <p:cNvPr id="5" name="">
             <a:extLst xmlns:a="http://schemas.openxmlformats.org/drawingml/2006/main">
               <a:ext uri="{FF2B5EF4-FFF2-40B4-BE49-F238E27FC236}">
-                <a16:creationId xmlns:a16="http://schemas.microsoft.com/office/drawing/2014/main" id="{5D42813C-97C1-4EFB-B823-C9FCBA012636}"/>
+                <a16:creationId xmlns:a16="http://schemas.microsoft.com/office/drawing/2014/main" id="{1431D810-A177-4B44-A8A3-C8A949254FE9}"/>
               </a:ext>
             </a:extLst>
           </p:cNvPr>
@@ -5069,7 +5235,7 @@
           <p:cNvPr id="6" name="">
             <a:extLst xmlns:a="http://schemas.openxmlformats.org/drawingml/2006/main">
               <a:ext uri="{FF2B5EF4-FFF2-40B4-BE49-F238E27FC236}">
-                <a16:creationId xmlns:a16="http://schemas.microsoft.com/office/drawing/2014/main" id="{B6FFC5E6-FD58-4881-A856-9255934DBDD1}"/>
+                <a16:creationId xmlns:a16="http://schemas.microsoft.com/office/drawing/2014/main" id="{44B0357A-904F-4301-81BB-EBB797E2E01C}"/>
               </a:ext>
             </a:extLst>
           </p:cNvPr>
@@ -5102,7 +5268,7 @@
           <p:cNvPr id="7" name="">
             <a:extLst xmlns:a="http://schemas.openxmlformats.org/drawingml/2006/main">
               <a:ext uri="{FF2B5EF4-FFF2-40B4-BE49-F238E27FC236}">
-                <a16:creationId xmlns:a16="http://schemas.microsoft.com/office/drawing/2014/main" id="{CF19FA09-66E2-4C8B-BA9B-5A5FD122210C}"/>
+                <a16:creationId xmlns:a16="http://schemas.microsoft.com/office/drawing/2014/main" id="{EC2FB9DC-84FE-4DF1-84F4-AA26D04B478D}"/>
               </a:ext>
             </a:extLst>
           </p:cNvPr>
@@ -5152,7 +5318,7 @@
           <p:cNvPr id="8" name="">
             <a:extLst xmlns:a="http://schemas.openxmlformats.org/drawingml/2006/main">
               <a:ext uri="{FF2B5EF4-FFF2-40B4-BE49-F238E27FC236}">
-                <a16:creationId xmlns:a16="http://schemas.microsoft.com/office/drawing/2014/main" id="{2D6C37EB-90BC-44F3-ADD9-5480F6D193DC}"/>
+                <a16:creationId xmlns:a16="http://schemas.microsoft.com/office/drawing/2014/main" id="{009E6767-7833-4D23-8EE8-55533A059C62}"/>
               </a:ext>
             </a:extLst>
           </p:cNvPr>
@@ -5185,7 +5351,7 @@
           <p:cNvPr id="9" name="">
             <a:extLst xmlns:a="http://schemas.openxmlformats.org/drawingml/2006/main">
               <a:ext uri="{FF2B5EF4-FFF2-40B4-BE49-F238E27FC236}">
-                <a16:creationId xmlns:a16="http://schemas.microsoft.com/office/drawing/2014/main" id="{C13E6DE6-A630-499F-881A-F181F27009FE}"/>
+                <a16:creationId xmlns:a16="http://schemas.microsoft.com/office/drawing/2014/main" id="{E8037D6C-BC25-4A84-8F07-25288C6852F9}"/>
               </a:ext>
             </a:extLst>
           </p:cNvPr>
@@ -5235,7 +5401,7 @@
           <p:cNvPr id="10" name="">
             <a:extLst xmlns:a="http://schemas.openxmlformats.org/drawingml/2006/main">
               <a:ext uri="{FF2B5EF4-FFF2-40B4-BE49-F238E27FC236}">
-                <a16:creationId xmlns:a16="http://schemas.microsoft.com/office/drawing/2014/main" id="{C369281C-0B5D-426A-9EE7-5E4389C36902}"/>
+                <a16:creationId xmlns:a16="http://schemas.microsoft.com/office/drawing/2014/main" id="{C3A24B9A-B99F-4898-B64C-4C4EAD5A6C76}"/>
               </a:ext>
             </a:extLst>
           </p:cNvPr>
@@ -5268,7 +5434,7 @@
           <p:cNvPr id="11" name="">
             <a:extLst xmlns:a="http://schemas.openxmlformats.org/drawingml/2006/main">
               <a:ext uri="{FF2B5EF4-FFF2-40B4-BE49-F238E27FC236}">
-                <a16:creationId xmlns:a16="http://schemas.microsoft.com/office/drawing/2014/main" id="{54DBFC58-E425-40A9-B97D-05C9173167F5}"/>
+                <a16:creationId xmlns:a16="http://schemas.microsoft.com/office/drawing/2014/main" id="{89C786DF-2A2F-4B80-8FB8-8C2FBEAEE12D}"/>
               </a:ext>
             </a:extLst>
           </p:cNvPr>
@@ -5318,7 +5484,7 @@
           <p:cNvPr id="12" name="">
             <a:extLst xmlns:a="http://schemas.openxmlformats.org/drawingml/2006/main">
               <a:ext uri="{FF2B5EF4-FFF2-40B4-BE49-F238E27FC236}">
-                <a16:creationId xmlns:a16="http://schemas.microsoft.com/office/drawing/2014/main" id="{EDE668DB-3B48-4686-93D9-47CDF6F0C88D}"/>
+                <a16:creationId xmlns:a16="http://schemas.microsoft.com/office/drawing/2014/main" id="{767B6A0D-4A4B-48B9-BED3-95666AD42132}"/>
               </a:ext>
             </a:extLst>
           </p:cNvPr>
@@ -5351,7 +5517,7 @@
           <p:cNvPr id="13" name="">
             <a:extLst xmlns:a="http://schemas.openxmlformats.org/drawingml/2006/main">
               <a:ext uri="{FF2B5EF4-FFF2-40B4-BE49-F238E27FC236}">
-                <a16:creationId xmlns:a16="http://schemas.microsoft.com/office/drawing/2014/main" id="{D62A30D6-0D26-4008-A1FA-65FC952E7D1A}"/>
+                <a16:creationId xmlns:a16="http://schemas.microsoft.com/office/drawing/2014/main" id="{00BC1A82-DF04-4963-AF8B-F291FE420C34}"/>
               </a:ext>
             </a:extLst>
           </p:cNvPr>
@@ -5401,7 +5567,7 @@
           <p:cNvPr id="14" name="">
             <a:extLst xmlns:a="http://schemas.openxmlformats.org/drawingml/2006/main">
               <a:ext uri="{FF2B5EF4-FFF2-40B4-BE49-F238E27FC236}">
-                <a16:creationId xmlns:a16="http://schemas.microsoft.com/office/drawing/2014/main" id="{A6840892-898A-4E78-9192-0E2E5629AAC9}"/>
+                <a16:creationId xmlns:a16="http://schemas.microsoft.com/office/drawing/2014/main" id="{2513A090-E1EC-47A3-9B08-66624D62F57F}"/>
               </a:ext>
             </a:extLst>
           </p:cNvPr>
@@ -5451,7 +5617,7 @@
           <p:cNvPr id="15" name="">
             <a:extLst xmlns:a="http://schemas.openxmlformats.org/drawingml/2006/main">
               <a:ext uri="{FF2B5EF4-FFF2-40B4-BE49-F238E27FC236}">
-                <a16:creationId xmlns:a16="http://schemas.microsoft.com/office/drawing/2014/main" id="{1E55205C-168C-4FEF-AC23-6540E5AA5FF0}"/>
+                <a16:creationId xmlns:a16="http://schemas.microsoft.com/office/drawing/2014/main" id="{FD229A63-6E39-4001-BACC-F3458D0EAEE3}"/>
               </a:ext>
             </a:extLst>
           </p:cNvPr>
@@ -5499,7 +5665,7 @@
     </p:spTree>
     <p:extLst>
       <p:ext uri="{BB962C8B-B14F-4D97-AF65-F5344CB8AC3E}">
-        <p14:creationId xmlns:p14="http://schemas.microsoft.com/office/powerpoint/2010/main" val="1859198966"/>
+        <p14:creationId xmlns:p14="http://schemas.microsoft.com/office/powerpoint/2010/main" val="2056925545"/>
       </p:ext>
     </p:extLst>
   </p:cSld>
@@ -5530,7 +5696,7 @@
           <p:cNvPr id="1" name="">
             <a:extLst xmlns:a="http://schemas.openxmlformats.org/drawingml/2006/main">
               <a:ext uri="{FF2B5EF4-FFF2-40B4-BE49-F238E27FC236}">
-                <a16:creationId xmlns:a16="http://schemas.microsoft.com/office/drawing/2014/main" id="{C24ED749-CD81-468C-99B1-44DE3D159B70}"/>
+                <a16:creationId xmlns:a16="http://schemas.microsoft.com/office/drawing/2014/main" id="{F33A78AE-2097-43A1-BC46-A736EEEBAC05}"/>
               </a:ext>
             </a:extLst>
           </p:cNvPr>
@@ -5580,7 +5746,7 @@
           <p:cNvPr id="2" name="">
             <a:extLst xmlns:a="http://schemas.openxmlformats.org/drawingml/2006/main">
               <a:ext uri="{FF2B5EF4-FFF2-40B4-BE49-F238E27FC236}">
-                <a16:creationId xmlns:a16="http://schemas.microsoft.com/office/drawing/2014/main" id="{6187FE8D-50D5-4F3B-AED9-D7657D70E9AA}"/>
+                <a16:creationId xmlns:a16="http://schemas.microsoft.com/office/drawing/2014/main" id="{9BEC3DE7-0C34-446E-8840-9329A64DA06C}"/>
               </a:ext>
             </a:extLst>
           </p:cNvPr>
@@ -5630,7 +5796,7 @@
           <p:cNvPr id="3" name="">
             <a:extLst xmlns:a="http://schemas.openxmlformats.org/drawingml/2006/main">
               <a:ext uri="{FF2B5EF4-FFF2-40B4-BE49-F238E27FC236}">
-                <a16:creationId xmlns:a16="http://schemas.microsoft.com/office/drawing/2014/main" id="{24FDE3C8-A19C-41BE-8C37-A71805AA48A1}"/>
+                <a16:creationId xmlns:a16="http://schemas.microsoft.com/office/drawing/2014/main" id="{CA54C906-5801-43F4-A24E-F958F577DD9F}"/>
               </a:ext>
             </a:extLst>
           </p:cNvPr>
@@ -5663,7 +5829,7 @@
           <p:cNvPr id="4" name="">
             <a:extLst xmlns:a="http://schemas.openxmlformats.org/drawingml/2006/main">
               <a:ext uri="{FF2B5EF4-FFF2-40B4-BE49-F238E27FC236}">
-                <a16:creationId xmlns:a16="http://schemas.microsoft.com/office/drawing/2014/main" id="{FEFFF92A-E7E1-42B5-B5C8-FCE25A341F3C}"/>
+                <a16:creationId xmlns:a16="http://schemas.microsoft.com/office/drawing/2014/main" id="{49CF4760-DD2E-4CFD-AA88-1D011CBE3E49}"/>
               </a:ext>
             </a:extLst>
           </p:cNvPr>
@@ -5696,7 +5862,7 @@
           <p:cNvPr id="5" name="">
             <a:extLst xmlns:a="http://schemas.openxmlformats.org/drawingml/2006/main">
               <a:ext uri="{FF2B5EF4-FFF2-40B4-BE49-F238E27FC236}">
-                <a16:creationId xmlns:a16="http://schemas.microsoft.com/office/drawing/2014/main" id="{AA6F4CC3-C72D-4A33-9D03-CE11EC1C01ED}"/>
+                <a16:creationId xmlns:a16="http://schemas.microsoft.com/office/drawing/2014/main" id="{D2605147-0DD9-492C-98BB-6A0D4785E9F5}"/>
               </a:ext>
             </a:extLst>
           </p:cNvPr>
@@ -5746,7 +5912,7 @@
           <p:cNvPr id="6" name="">
             <a:extLst xmlns:a="http://schemas.openxmlformats.org/drawingml/2006/main">
               <a:ext uri="{FF2B5EF4-FFF2-40B4-BE49-F238E27FC236}">
-                <a16:creationId xmlns:a16="http://schemas.microsoft.com/office/drawing/2014/main" id="{52CB3DD6-DC6C-4166-978C-7AA319D9CC83}"/>
+                <a16:creationId xmlns:a16="http://schemas.microsoft.com/office/drawing/2014/main" id="{E39A7689-9AAC-4204-8020-C609AEC7CBC6}"/>
               </a:ext>
             </a:extLst>
           </p:cNvPr>
@@ -5779,7 +5945,7 @@
           <p:cNvPr id="7" name="">
             <a:extLst xmlns:a="http://schemas.openxmlformats.org/drawingml/2006/main">
               <a:ext uri="{FF2B5EF4-FFF2-40B4-BE49-F238E27FC236}">
-                <a16:creationId xmlns:a16="http://schemas.microsoft.com/office/drawing/2014/main" id="{482C8B8E-A407-47FF-9DFB-D81C2C07C804}"/>
+                <a16:creationId xmlns:a16="http://schemas.microsoft.com/office/drawing/2014/main" id="{C533AB3B-D500-4D0D-AFE4-BE8C2989DF95}"/>
               </a:ext>
             </a:extLst>
           </p:cNvPr>
@@ -5829,7 +5995,7 @@
           <p:cNvPr id="8" name="">
             <a:extLst xmlns:a="http://schemas.openxmlformats.org/drawingml/2006/main">
               <a:ext uri="{FF2B5EF4-FFF2-40B4-BE49-F238E27FC236}">
-                <a16:creationId xmlns:a16="http://schemas.microsoft.com/office/drawing/2014/main" id="{6B8A1A7D-E5D5-4B2B-A664-93288C1C7438}"/>
+                <a16:creationId xmlns:a16="http://schemas.microsoft.com/office/drawing/2014/main" id="{62FA8D1F-A93F-419C-B1CD-1F9FFACA8172}"/>
               </a:ext>
             </a:extLst>
           </p:cNvPr>
@@ -5862,7 +6028,7 @@
           <p:cNvPr id="9" name="">
             <a:extLst xmlns:a="http://schemas.openxmlformats.org/drawingml/2006/main">
               <a:ext uri="{FF2B5EF4-FFF2-40B4-BE49-F238E27FC236}">
-                <a16:creationId xmlns:a16="http://schemas.microsoft.com/office/drawing/2014/main" id="{5659308D-6641-4C6C-9966-A49BB830C6B0}"/>
+                <a16:creationId xmlns:a16="http://schemas.microsoft.com/office/drawing/2014/main" id="{18E305B7-7550-479C-BB87-7691E1AB510C}"/>
               </a:ext>
             </a:extLst>
           </p:cNvPr>
@@ -5912,7 +6078,7 @@
           <p:cNvPr id="10" name="">
             <a:extLst xmlns:a="http://schemas.openxmlformats.org/drawingml/2006/main">
               <a:ext uri="{FF2B5EF4-FFF2-40B4-BE49-F238E27FC236}">
-                <a16:creationId xmlns:a16="http://schemas.microsoft.com/office/drawing/2014/main" id="{B8454C23-CFCA-477D-9703-DF08F2DE12FF}"/>
+                <a16:creationId xmlns:a16="http://schemas.microsoft.com/office/drawing/2014/main" id="{25E38790-4336-478C-9682-1F494A10CE9D}"/>
               </a:ext>
             </a:extLst>
           </p:cNvPr>
@@ -5945,7 +6111,7 @@
           <p:cNvPr id="11" name="">
             <a:extLst xmlns:a="http://schemas.openxmlformats.org/drawingml/2006/main">
               <a:ext uri="{FF2B5EF4-FFF2-40B4-BE49-F238E27FC236}">
-                <a16:creationId xmlns:a16="http://schemas.microsoft.com/office/drawing/2014/main" id="{4DD704DA-9CAC-4B1F-BA7B-8E4FCF7F5E0D}"/>
+                <a16:creationId xmlns:a16="http://schemas.microsoft.com/office/drawing/2014/main" id="{D14B8B3E-B99A-4224-9B69-BC2BD9F0251A}"/>
               </a:ext>
             </a:extLst>
           </p:cNvPr>
@@ -5999,7 +6165,7 @@
           <p:nvPr/>
         </p:nvPicPr>
         <p:blipFill>
-          <a:blip xmlns:r="http://schemas.openxmlformats.org/officeDocument/2006/relationships" xmlns:a="http://schemas.openxmlformats.org/drawingml/2006/main" r:embed="R9238b60243cf4b09"/>
+          <a:blip xmlns:r="http://schemas.openxmlformats.org/officeDocument/2006/relationships" xmlns:a="http://schemas.openxmlformats.org/drawingml/2006/main" r:embed="Rec1316c08bdb4150"/>
           <a:stretch xmlns:a="http://schemas.openxmlformats.org/drawingml/2006/main"/>
         </p:blipFill>
         <p:spPr>
@@ -6017,7 +6183,7 @@
           <p:cNvPr id="13" name="">
             <a:extLst xmlns:a="http://schemas.openxmlformats.org/drawingml/2006/main">
               <a:ext uri="{FF2B5EF4-FFF2-40B4-BE49-F238E27FC236}">
-                <a16:creationId xmlns:a16="http://schemas.microsoft.com/office/drawing/2014/main" id="{9093D92B-E32F-431E-B4B5-6988A0AC78F3}"/>
+                <a16:creationId xmlns:a16="http://schemas.microsoft.com/office/drawing/2014/main" id="{2836325E-9853-43E7-A04B-5FC73EF3E9C9}"/>
               </a:ext>
             </a:extLst>
           </p:cNvPr>
@@ -6067,7 +6233,7 @@
           <p:cNvPr id="14" name="">
             <a:extLst xmlns:a="http://schemas.openxmlformats.org/drawingml/2006/main">
               <a:ext uri="{FF2B5EF4-FFF2-40B4-BE49-F238E27FC236}">
-                <a16:creationId xmlns:a16="http://schemas.microsoft.com/office/drawing/2014/main" id="{DBD944A6-F384-4A06-9344-754C462EB350}"/>
+                <a16:creationId xmlns:a16="http://schemas.microsoft.com/office/drawing/2014/main" id="{0235B807-A0E2-437D-B937-84F0F4EC2CA6}"/>
               </a:ext>
             </a:extLst>
           </p:cNvPr>
@@ -6115,7 +6281,7 @@
     </p:spTree>
     <p:extLst>
       <p:ext uri="{BB962C8B-B14F-4D97-AF65-F5344CB8AC3E}">
-        <p14:creationId xmlns:p14="http://schemas.microsoft.com/office/powerpoint/2010/main" val="850297931"/>
+        <p14:creationId xmlns:p14="http://schemas.microsoft.com/office/powerpoint/2010/main" val="287931312"/>
       </p:ext>
     </p:extLst>
   </p:cSld>
@@ -6146,7 +6312,7 @@
           <p:cNvPr id="1" name="">
             <a:extLst xmlns:a="http://schemas.openxmlformats.org/drawingml/2006/main">
               <a:ext uri="{FF2B5EF4-FFF2-40B4-BE49-F238E27FC236}">
-                <a16:creationId xmlns:a16="http://schemas.microsoft.com/office/drawing/2014/main" id="{F913BB0D-E0ED-4A3C-92FA-DD431778CD03}"/>
+                <a16:creationId xmlns:a16="http://schemas.microsoft.com/office/drawing/2014/main" id="{0A7544A9-2154-42B0-A3FB-AD30D73025C1}"/>
               </a:ext>
             </a:extLst>
           </p:cNvPr>
@@ -6196,7 +6362,7 @@
           <p:cNvPr id="2" name="">
             <a:extLst xmlns:a="http://schemas.openxmlformats.org/drawingml/2006/main">
               <a:ext uri="{FF2B5EF4-FFF2-40B4-BE49-F238E27FC236}">
-                <a16:creationId xmlns:a16="http://schemas.microsoft.com/office/drawing/2014/main" id="{5F0EEEFC-C5F1-49DD-970D-4F95721E44AA}"/>
+                <a16:creationId xmlns:a16="http://schemas.microsoft.com/office/drawing/2014/main" id="{050175BB-1680-44D7-9B73-9117D141B0E8}"/>
               </a:ext>
             </a:extLst>
           </p:cNvPr>
@@ -6246,7 +6412,7 @@
           <p:cNvPr id="3" name="">
             <a:extLst xmlns:a="http://schemas.openxmlformats.org/drawingml/2006/main">
               <a:ext uri="{FF2B5EF4-FFF2-40B4-BE49-F238E27FC236}">
-                <a16:creationId xmlns:a16="http://schemas.microsoft.com/office/drawing/2014/main" id="{5BE401B6-76D4-42CB-AC27-4A85E53E8CBC}"/>
+                <a16:creationId xmlns:a16="http://schemas.microsoft.com/office/drawing/2014/main" id="{271945B6-0B6E-41B6-B82A-A880E19978B6}"/>
               </a:ext>
             </a:extLst>
           </p:cNvPr>
@@ -6279,7 +6445,7 @@
           <p:cNvPr id="4" name="">
             <a:extLst xmlns:a="http://schemas.openxmlformats.org/drawingml/2006/main">
               <a:ext uri="{FF2B5EF4-FFF2-40B4-BE49-F238E27FC236}">
-                <a16:creationId xmlns:a16="http://schemas.microsoft.com/office/drawing/2014/main" id="{F6E0A22E-A698-4BA0-8C01-397A693D555D}"/>
+                <a16:creationId xmlns:a16="http://schemas.microsoft.com/office/drawing/2014/main" id="{26BA0079-8DA1-4C9A-8C5A-E45E421894E4}"/>
               </a:ext>
             </a:extLst>
           </p:cNvPr>
@@ -6312,7 +6478,7 @@
           <p:cNvPr id="5" name="">
             <a:extLst xmlns:a="http://schemas.openxmlformats.org/drawingml/2006/main">
               <a:ext uri="{FF2B5EF4-FFF2-40B4-BE49-F238E27FC236}">
-                <a16:creationId xmlns:a16="http://schemas.microsoft.com/office/drawing/2014/main" id="{20D85031-BC3D-4BB7-9F2C-E2EFC264D55C}"/>
+                <a16:creationId xmlns:a16="http://schemas.microsoft.com/office/drawing/2014/main" id="{AFD1A9B5-7EAB-4613-901B-BFFC15DFAB58}"/>
               </a:ext>
             </a:extLst>
           </p:cNvPr>
@@ -6362,7 +6528,7 @@
           <p:cNvPr id="6" name="">
             <a:extLst xmlns:a="http://schemas.openxmlformats.org/drawingml/2006/main">
               <a:ext uri="{FF2B5EF4-FFF2-40B4-BE49-F238E27FC236}">
-                <a16:creationId xmlns:a16="http://schemas.microsoft.com/office/drawing/2014/main" id="{B630FEC1-A10A-435F-BB2B-ECE12C0B377E}"/>
+                <a16:creationId xmlns:a16="http://schemas.microsoft.com/office/drawing/2014/main" id="{15AFC294-EB8C-474B-A0B3-31DA6391510B}"/>
               </a:ext>
             </a:extLst>
           </p:cNvPr>
@@ -6412,7 +6578,7 @@
           <p:cNvPr id="7" name="">
             <a:extLst xmlns:a="http://schemas.openxmlformats.org/drawingml/2006/main">
               <a:ext uri="{FF2B5EF4-FFF2-40B4-BE49-F238E27FC236}">
-                <a16:creationId xmlns:a16="http://schemas.microsoft.com/office/drawing/2014/main" id="{2D1151AA-1CCF-41AB-9612-E24DECCC2362}"/>
+                <a16:creationId xmlns:a16="http://schemas.microsoft.com/office/drawing/2014/main" id="{379DD60A-402B-48C9-87EA-D8816E36E6FA}"/>
               </a:ext>
             </a:extLst>
           </p:cNvPr>
@@ -6445,7 +6611,7 @@
           <p:cNvPr id="8" name="">
             <a:extLst xmlns:a="http://schemas.openxmlformats.org/drawingml/2006/main">
               <a:ext uri="{FF2B5EF4-FFF2-40B4-BE49-F238E27FC236}">
-                <a16:creationId xmlns:a16="http://schemas.microsoft.com/office/drawing/2014/main" id="{67136D3C-2958-4CDB-9413-19CF82B54010}"/>
+                <a16:creationId xmlns:a16="http://schemas.microsoft.com/office/drawing/2014/main" id="{5E399983-8B59-41EF-A7B0-D16DFBBF6DAC}"/>
               </a:ext>
             </a:extLst>
           </p:cNvPr>
@@ -6478,7 +6644,7 @@
           <p:cNvPr id="9" name="">
             <a:extLst xmlns:a="http://schemas.openxmlformats.org/drawingml/2006/main">
               <a:ext uri="{FF2B5EF4-FFF2-40B4-BE49-F238E27FC236}">
-                <a16:creationId xmlns:a16="http://schemas.microsoft.com/office/drawing/2014/main" id="{7FFC8708-92A6-4A03-83F8-62E12D66FAB8}"/>
+                <a16:creationId xmlns:a16="http://schemas.microsoft.com/office/drawing/2014/main" id="{DA2939B3-6263-4548-8C9A-D78CA68275D1}"/>
               </a:ext>
             </a:extLst>
           </p:cNvPr>
@@ -6528,7 +6694,7 @@
           <p:cNvPr id="10" name="">
             <a:extLst xmlns:a="http://schemas.openxmlformats.org/drawingml/2006/main">
               <a:ext uri="{FF2B5EF4-FFF2-40B4-BE49-F238E27FC236}">
-                <a16:creationId xmlns:a16="http://schemas.microsoft.com/office/drawing/2014/main" id="{BF5F0403-5EC4-4593-85EB-6579731C5588}"/>
+                <a16:creationId xmlns:a16="http://schemas.microsoft.com/office/drawing/2014/main" id="{ACF59B5A-37E6-4E30-9058-3EE3631F6F4E}"/>
               </a:ext>
             </a:extLst>
           </p:cNvPr>
@@ -6578,7 +6744,7 @@
           <p:cNvPr id="11" name="">
             <a:extLst xmlns:a="http://schemas.openxmlformats.org/drawingml/2006/main">
               <a:ext uri="{FF2B5EF4-FFF2-40B4-BE49-F238E27FC236}">
-                <a16:creationId xmlns:a16="http://schemas.microsoft.com/office/drawing/2014/main" id="{8A6E4A21-6927-4A3B-9E44-31F9BAC72FA9}"/>
+                <a16:creationId xmlns:a16="http://schemas.microsoft.com/office/drawing/2014/main" id="{54C73AC8-CD29-4B8A-83A1-A1A0DFA3E938}"/>
               </a:ext>
             </a:extLst>
           </p:cNvPr>
@@ -6611,7 +6777,7 @@
           <p:cNvPr id="12" name="">
             <a:extLst xmlns:a="http://schemas.openxmlformats.org/drawingml/2006/main">
               <a:ext uri="{FF2B5EF4-FFF2-40B4-BE49-F238E27FC236}">
-                <a16:creationId xmlns:a16="http://schemas.microsoft.com/office/drawing/2014/main" id="{693C57B6-ACB5-4A8D-A393-20C893170269}"/>
+                <a16:creationId xmlns:a16="http://schemas.microsoft.com/office/drawing/2014/main" id="{D602B239-EB56-4C85-821E-8930CE1EC1BE}"/>
               </a:ext>
             </a:extLst>
           </p:cNvPr>
@@ -6644,7 +6810,7 @@
           <p:cNvPr id="13" name="">
             <a:extLst xmlns:a="http://schemas.openxmlformats.org/drawingml/2006/main">
               <a:ext uri="{FF2B5EF4-FFF2-40B4-BE49-F238E27FC236}">
-                <a16:creationId xmlns:a16="http://schemas.microsoft.com/office/drawing/2014/main" id="{279B5927-1293-4036-8F78-AE4ED8AD8C65}"/>
+                <a16:creationId xmlns:a16="http://schemas.microsoft.com/office/drawing/2014/main" id="{8F5CF85F-D9AE-4374-9CDF-5A542F28C2F7}"/>
               </a:ext>
             </a:extLst>
           </p:cNvPr>
@@ -6694,7 +6860,7 @@
           <p:cNvPr id="14" name="">
             <a:extLst xmlns:a="http://schemas.openxmlformats.org/drawingml/2006/main">
               <a:ext uri="{FF2B5EF4-FFF2-40B4-BE49-F238E27FC236}">
-                <a16:creationId xmlns:a16="http://schemas.microsoft.com/office/drawing/2014/main" id="{F4A760F0-C5FD-4E7D-97CD-9956672ADC20}"/>
+                <a16:creationId xmlns:a16="http://schemas.microsoft.com/office/drawing/2014/main" id="{87685AC9-7963-4BA2-864C-29CB99029A5C}"/>
               </a:ext>
             </a:extLst>
           </p:cNvPr>
@@ -6744,7 +6910,7 @@
           <p:cNvPr id="15" name="">
             <a:extLst xmlns:a="http://schemas.openxmlformats.org/drawingml/2006/main">
               <a:ext uri="{FF2B5EF4-FFF2-40B4-BE49-F238E27FC236}">
-                <a16:creationId xmlns:a16="http://schemas.microsoft.com/office/drawing/2014/main" id="{9F49FEF7-BF3C-4F3C-ADB0-ECC9C011C6D2}"/>
+                <a16:creationId xmlns:a16="http://schemas.microsoft.com/office/drawing/2014/main" id="{13379DD5-8744-49BE-96CC-E5A91FE0FA35}"/>
               </a:ext>
             </a:extLst>
           </p:cNvPr>
@@ -6777,7 +6943,7 @@
           <p:cNvPr id="16" name="">
             <a:extLst xmlns:a="http://schemas.openxmlformats.org/drawingml/2006/main">
               <a:ext uri="{FF2B5EF4-FFF2-40B4-BE49-F238E27FC236}">
-                <a16:creationId xmlns:a16="http://schemas.microsoft.com/office/drawing/2014/main" id="{EAE220B7-E25D-4FC3-89C8-F3AACDDBF6D7}"/>
+                <a16:creationId xmlns:a16="http://schemas.microsoft.com/office/drawing/2014/main" id="{93B7BB23-2132-4441-9047-5BB2298C11A8}"/>
               </a:ext>
             </a:extLst>
           </p:cNvPr>
@@ -6810,7 +6976,7 @@
           <p:cNvPr id="17" name="">
             <a:extLst xmlns:a="http://schemas.openxmlformats.org/drawingml/2006/main">
               <a:ext uri="{FF2B5EF4-FFF2-40B4-BE49-F238E27FC236}">
-                <a16:creationId xmlns:a16="http://schemas.microsoft.com/office/drawing/2014/main" id="{5B0BD141-AFE9-4640-8DBC-F6DD8B276382}"/>
+                <a16:creationId xmlns:a16="http://schemas.microsoft.com/office/drawing/2014/main" id="{6B5B6C3E-6A48-44E7-82F6-4DB292663A52}"/>
               </a:ext>
             </a:extLst>
           </p:cNvPr>
@@ -6860,7 +7026,7 @@
           <p:cNvPr id="18" name="">
             <a:extLst xmlns:a="http://schemas.openxmlformats.org/drawingml/2006/main">
               <a:ext uri="{FF2B5EF4-FFF2-40B4-BE49-F238E27FC236}">
-                <a16:creationId xmlns:a16="http://schemas.microsoft.com/office/drawing/2014/main" id="{91000C8F-0E75-41EA-9BE4-087D41C1E699}"/>
+                <a16:creationId xmlns:a16="http://schemas.microsoft.com/office/drawing/2014/main" id="{9ECB4CB0-8FB4-4638-A2D0-3168F3F40498}"/>
               </a:ext>
             </a:extLst>
           </p:cNvPr>
@@ -6910,7 +7076,7 @@
           <p:cNvPr id="19" name="">
             <a:extLst xmlns:a="http://schemas.openxmlformats.org/drawingml/2006/main">
               <a:ext uri="{FF2B5EF4-FFF2-40B4-BE49-F238E27FC236}">
-                <a16:creationId xmlns:a16="http://schemas.microsoft.com/office/drawing/2014/main" id="{D02E0417-AF36-4A4E-93A3-50D19C4D1C8B}"/>
+                <a16:creationId xmlns:a16="http://schemas.microsoft.com/office/drawing/2014/main" id="{94AF0872-29EF-4085-810E-37ADE79ED438}"/>
               </a:ext>
             </a:extLst>
           </p:cNvPr>
@@ -6943,7 +7109,7 @@
           <p:cNvPr id="20" name="">
             <a:extLst xmlns:a="http://schemas.openxmlformats.org/drawingml/2006/main">
               <a:ext uri="{FF2B5EF4-FFF2-40B4-BE49-F238E27FC236}">
-                <a16:creationId xmlns:a16="http://schemas.microsoft.com/office/drawing/2014/main" id="{7604F927-E77B-4235-A25C-E0A66F99D2DC}"/>
+                <a16:creationId xmlns:a16="http://schemas.microsoft.com/office/drawing/2014/main" id="{434955F0-5A88-43E0-B33E-F26C74AEAA32}"/>
               </a:ext>
             </a:extLst>
           </p:cNvPr>
@@ -6976,7 +7142,7 @@
           <p:cNvPr id="21" name="">
             <a:extLst xmlns:a="http://schemas.openxmlformats.org/drawingml/2006/main">
               <a:ext uri="{FF2B5EF4-FFF2-40B4-BE49-F238E27FC236}">
-                <a16:creationId xmlns:a16="http://schemas.microsoft.com/office/drawing/2014/main" id="{C234BAB3-7FBD-4891-A055-94B59AAA9AE4}"/>
+                <a16:creationId xmlns:a16="http://schemas.microsoft.com/office/drawing/2014/main" id="{004D6947-E8BB-43F4-83E6-AAAB41847EE9}"/>
               </a:ext>
             </a:extLst>
           </p:cNvPr>
@@ -7026,7 +7192,7 @@
           <p:cNvPr id="22" name="">
             <a:extLst xmlns:a="http://schemas.openxmlformats.org/drawingml/2006/main">
               <a:ext uri="{FF2B5EF4-FFF2-40B4-BE49-F238E27FC236}">
-                <a16:creationId xmlns:a16="http://schemas.microsoft.com/office/drawing/2014/main" id="{B4D80166-3171-4B7C-986B-78409C9DA86F}"/>
+                <a16:creationId xmlns:a16="http://schemas.microsoft.com/office/drawing/2014/main" id="{B50ECA52-7422-4EC4-9F91-92C04789466A}"/>
               </a:ext>
             </a:extLst>
           </p:cNvPr>
@@ -7076,7 +7242,7 @@
           <p:cNvPr id="23" name="">
             <a:extLst xmlns:a="http://schemas.openxmlformats.org/drawingml/2006/main">
               <a:ext uri="{FF2B5EF4-FFF2-40B4-BE49-F238E27FC236}">
-                <a16:creationId xmlns:a16="http://schemas.microsoft.com/office/drawing/2014/main" id="{DAB26E36-B9EA-450F-90B7-93CD5C8766D0}"/>
+                <a16:creationId xmlns:a16="http://schemas.microsoft.com/office/drawing/2014/main" id="{9A533EF7-5968-4AC9-A698-12118BA6E9EC}"/>
               </a:ext>
             </a:extLst>
           </p:cNvPr>
@@ -7109,7 +7275,7 @@
           <p:cNvPr id="24" name="">
             <a:extLst xmlns:a="http://schemas.openxmlformats.org/drawingml/2006/main">
               <a:ext uri="{FF2B5EF4-FFF2-40B4-BE49-F238E27FC236}">
-                <a16:creationId xmlns:a16="http://schemas.microsoft.com/office/drawing/2014/main" id="{B1562913-9CC5-4053-85F9-7E703DC5B3A2}"/>
+                <a16:creationId xmlns:a16="http://schemas.microsoft.com/office/drawing/2014/main" id="{80D3717E-CBCC-49DC-B1A5-FC8266382769}"/>
               </a:ext>
             </a:extLst>
           </p:cNvPr>
@@ -7142,7 +7308,7 @@
           <p:cNvPr id="25" name="">
             <a:extLst xmlns:a="http://schemas.openxmlformats.org/drawingml/2006/main">
               <a:ext uri="{FF2B5EF4-FFF2-40B4-BE49-F238E27FC236}">
-                <a16:creationId xmlns:a16="http://schemas.microsoft.com/office/drawing/2014/main" id="{24366621-F01C-426D-AFDE-599367844A34}"/>
+                <a16:creationId xmlns:a16="http://schemas.microsoft.com/office/drawing/2014/main" id="{7B6BB8B4-A374-4D06-B43B-D139F1499607}"/>
               </a:ext>
             </a:extLst>
           </p:cNvPr>
@@ -7192,7 +7358,7 @@
           <p:cNvPr id="26" name="">
             <a:extLst xmlns:a="http://schemas.openxmlformats.org/drawingml/2006/main">
               <a:ext uri="{FF2B5EF4-FFF2-40B4-BE49-F238E27FC236}">
-                <a16:creationId xmlns:a16="http://schemas.microsoft.com/office/drawing/2014/main" id="{C7F27C49-CECC-40A6-B644-15B66D4B426D}"/>
+                <a16:creationId xmlns:a16="http://schemas.microsoft.com/office/drawing/2014/main" id="{F2B0B063-FF62-4B6E-8BF3-F8C35470BD00}"/>
               </a:ext>
             </a:extLst>
           </p:cNvPr>
@@ -7242,7 +7408,7 @@
           <p:cNvPr id="27" name="">
             <a:extLst xmlns:a="http://schemas.openxmlformats.org/drawingml/2006/main">
               <a:ext uri="{FF2B5EF4-FFF2-40B4-BE49-F238E27FC236}">
-                <a16:creationId xmlns:a16="http://schemas.microsoft.com/office/drawing/2014/main" id="{89914D55-34ED-47FC-A041-24F2FD9D5165}"/>
+                <a16:creationId xmlns:a16="http://schemas.microsoft.com/office/drawing/2014/main" id="{613D6DDA-0EF8-4F56-8EE0-19CBB7254C99}"/>
               </a:ext>
             </a:extLst>
           </p:cNvPr>
@@ -7275,7 +7441,7 @@
           <p:cNvPr id="28" name="">
             <a:extLst xmlns:a="http://schemas.openxmlformats.org/drawingml/2006/main">
               <a:ext uri="{FF2B5EF4-FFF2-40B4-BE49-F238E27FC236}">
-                <a16:creationId xmlns:a16="http://schemas.microsoft.com/office/drawing/2014/main" id="{68E63B8F-EE78-408F-B20B-9C4022E04E5B}"/>
+                <a16:creationId xmlns:a16="http://schemas.microsoft.com/office/drawing/2014/main" id="{D7C9D4F3-F030-4641-AEF6-27235E58BA94}"/>
               </a:ext>
             </a:extLst>
           </p:cNvPr>
@@ -7308,7 +7474,7 @@
           <p:cNvPr id="29" name="">
             <a:extLst xmlns:a="http://schemas.openxmlformats.org/drawingml/2006/main">
               <a:ext uri="{FF2B5EF4-FFF2-40B4-BE49-F238E27FC236}">
-                <a16:creationId xmlns:a16="http://schemas.microsoft.com/office/drawing/2014/main" id="{65CB6BB8-563B-472D-B6AE-05966634AD77}"/>
+                <a16:creationId xmlns:a16="http://schemas.microsoft.com/office/drawing/2014/main" id="{BD920FC4-487F-4501-AE9D-4A67F907814B}"/>
               </a:ext>
             </a:extLst>
           </p:cNvPr>
@@ -7358,7 +7524,7 @@
           <p:cNvPr id="30" name="">
             <a:extLst xmlns:a="http://schemas.openxmlformats.org/drawingml/2006/main">
               <a:ext uri="{FF2B5EF4-FFF2-40B4-BE49-F238E27FC236}">
-                <a16:creationId xmlns:a16="http://schemas.microsoft.com/office/drawing/2014/main" id="{9C9E28AD-ACE8-4788-9DE1-4F75E17C234B}"/>
+                <a16:creationId xmlns:a16="http://schemas.microsoft.com/office/drawing/2014/main" id="{E244898B-0476-4A7B-A338-4356F749399A}"/>
               </a:ext>
             </a:extLst>
           </p:cNvPr>
@@ -7408,7 +7574,7 @@
           <p:cNvPr id="31" name="">
             <a:extLst xmlns:a="http://schemas.openxmlformats.org/drawingml/2006/main">
               <a:ext uri="{FF2B5EF4-FFF2-40B4-BE49-F238E27FC236}">
-                <a16:creationId xmlns:a16="http://schemas.microsoft.com/office/drawing/2014/main" id="{27C85C6F-8B6E-40A9-B9A2-D7F38ECA1809}"/>
+                <a16:creationId xmlns:a16="http://schemas.microsoft.com/office/drawing/2014/main" id="{0DADE5ED-76F1-420C-81BE-EDAFB12A4B54}"/>
               </a:ext>
             </a:extLst>
           </p:cNvPr>
@@ -7458,7 +7624,7 @@
           <p:cNvPr id="32" name="">
             <a:extLst xmlns:a="http://schemas.openxmlformats.org/drawingml/2006/main">
               <a:ext uri="{FF2B5EF4-FFF2-40B4-BE49-F238E27FC236}">
-                <a16:creationId xmlns:a16="http://schemas.microsoft.com/office/drawing/2014/main" id="{DD1E2CEE-5E58-4070-ABE7-FF098FF0C221}"/>
+                <a16:creationId xmlns:a16="http://schemas.microsoft.com/office/drawing/2014/main" id="{5C908BC7-A300-4A32-BDDC-AD00630C3619}"/>
               </a:ext>
             </a:extLst>
           </p:cNvPr>
@@ -7506,7 +7672,7 @@
     </p:spTree>
     <p:extLst>
       <p:ext uri="{BB962C8B-B14F-4D97-AF65-F5344CB8AC3E}">
-        <p14:creationId xmlns:p14="http://schemas.microsoft.com/office/powerpoint/2010/main" val="2050201379"/>
+        <p14:creationId xmlns:p14="http://schemas.microsoft.com/office/powerpoint/2010/main" val="575742752"/>
       </p:ext>
     </p:extLst>
   </p:cSld>
@@ -7537,7 +7703,7 @@
           <p:cNvPr id="1" name="">
             <a:extLst xmlns:a="http://schemas.openxmlformats.org/drawingml/2006/main">
               <a:ext uri="{FF2B5EF4-FFF2-40B4-BE49-F238E27FC236}">
-                <a16:creationId xmlns:a16="http://schemas.microsoft.com/office/drawing/2014/main" id="{F8AE34B7-81CF-48C5-8D77-22ABAF685A53}"/>
+                <a16:creationId xmlns:a16="http://schemas.microsoft.com/office/drawing/2014/main" id="{CE97F2F4-5823-4B13-9CC0-161415AD0117}"/>
               </a:ext>
             </a:extLst>
           </p:cNvPr>
@@ -7587,7 +7753,7 @@
           <p:cNvPr id="2" name="">
             <a:extLst xmlns:a="http://schemas.openxmlformats.org/drawingml/2006/main">
               <a:ext uri="{FF2B5EF4-FFF2-40B4-BE49-F238E27FC236}">
-                <a16:creationId xmlns:a16="http://schemas.microsoft.com/office/drawing/2014/main" id="{A768115E-710E-4502-8BC8-701FBFD0B229}"/>
+                <a16:creationId xmlns:a16="http://schemas.microsoft.com/office/drawing/2014/main" id="{FB40ED29-4893-494C-9746-454E5865CC9A}"/>
               </a:ext>
             </a:extLst>
           </p:cNvPr>
@@ -7637,7 +7803,7 @@
           <p:cNvPr id="3" name="">
             <a:extLst xmlns:a="http://schemas.openxmlformats.org/drawingml/2006/main">
               <a:ext uri="{FF2B5EF4-FFF2-40B4-BE49-F238E27FC236}">
-                <a16:creationId xmlns:a16="http://schemas.microsoft.com/office/drawing/2014/main" id="{333F13BE-9923-42C6-AE14-1FA440CC2913}"/>
+                <a16:creationId xmlns:a16="http://schemas.microsoft.com/office/drawing/2014/main" id="{986EF57A-6F47-482A-A88F-8323B9C430EB}"/>
               </a:ext>
             </a:extLst>
           </p:cNvPr>
@@ -7670,7 +7836,7 @@
           <p:cNvPr id="4" name="">
             <a:extLst xmlns:a="http://schemas.openxmlformats.org/drawingml/2006/main">
               <a:ext uri="{FF2B5EF4-FFF2-40B4-BE49-F238E27FC236}">
-                <a16:creationId xmlns:a16="http://schemas.microsoft.com/office/drawing/2014/main" id="{658BFA19-E119-477E-9C97-9C2C54D3B3EF}"/>
+                <a16:creationId xmlns:a16="http://schemas.microsoft.com/office/drawing/2014/main" id="{0B3CB6A1-3509-4C60-A213-2ED9D658BB17}"/>
               </a:ext>
             </a:extLst>
           </p:cNvPr>
@@ -7703,7 +7869,7 @@
           <p:cNvPr id="5" name="">
             <a:extLst xmlns:a="http://schemas.openxmlformats.org/drawingml/2006/main">
               <a:ext uri="{FF2B5EF4-FFF2-40B4-BE49-F238E27FC236}">
-                <a16:creationId xmlns:a16="http://schemas.microsoft.com/office/drawing/2014/main" id="{B825862A-5DAD-46E4-A49C-E22819B67CA6}"/>
+                <a16:creationId xmlns:a16="http://schemas.microsoft.com/office/drawing/2014/main" id="{E9EE81D0-61D7-4CA4-B876-BAD4B45BD9AC}"/>
               </a:ext>
             </a:extLst>
           </p:cNvPr>
@@ -7753,7 +7919,7 @@
           <p:cNvPr id="6" name="">
             <a:extLst xmlns:a="http://schemas.openxmlformats.org/drawingml/2006/main">
               <a:ext uri="{FF2B5EF4-FFF2-40B4-BE49-F238E27FC236}">
-                <a16:creationId xmlns:a16="http://schemas.microsoft.com/office/drawing/2014/main" id="{B8FC8BE2-9F4E-4118-A68C-0563A5BC0E85}"/>
+                <a16:creationId xmlns:a16="http://schemas.microsoft.com/office/drawing/2014/main" id="{3705E05E-9EF1-4B38-BFAB-CFF173B091B1}"/>
               </a:ext>
             </a:extLst>
           </p:cNvPr>
@@ -7803,7 +7969,7 @@
           <p:cNvPr id="7" name="">
             <a:extLst xmlns:a="http://schemas.openxmlformats.org/drawingml/2006/main">
               <a:ext uri="{FF2B5EF4-FFF2-40B4-BE49-F238E27FC236}">
-                <a16:creationId xmlns:a16="http://schemas.microsoft.com/office/drawing/2014/main" id="{21F0D848-D79F-4708-9962-4078F6042996}"/>
+                <a16:creationId xmlns:a16="http://schemas.microsoft.com/office/drawing/2014/main" id="{71A3DB81-ACAC-4696-A6DD-7AEF67C0D416}"/>
               </a:ext>
             </a:extLst>
           </p:cNvPr>
@@ -7836,7 +8002,7 @@
           <p:cNvPr id="8" name="">
             <a:extLst xmlns:a="http://schemas.openxmlformats.org/drawingml/2006/main">
               <a:ext uri="{FF2B5EF4-FFF2-40B4-BE49-F238E27FC236}">
-                <a16:creationId xmlns:a16="http://schemas.microsoft.com/office/drawing/2014/main" id="{7AAD732D-A2E4-4FFB-A97A-825C305F700E}"/>
+                <a16:creationId xmlns:a16="http://schemas.microsoft.com/office/drawing/2014/main" id="{25F837C0-8D4B-4E95-A3DE-27991C12ED3B}"/>
               </a:ext>
             </a:extLst>
           </p:cNvPr>
@@ -7886,7 +8052,7 @@
           <p:cNvPr id="9" name="">
             <a:extLst xmlns:a="http://schemas.openxmlformats.org/drawingml/2006/main">
               <a:ext uri="{FF2B5EF4-FFF2-40B4-BE49-F238E27FC236}">
-                <a16:creationId xmlns:a16="http://schemas.microsoft.com/office/drawing/2014/main" id="{89950BAF-3E6C-4D10-BB5C-90FDDB53A3B8}"/>
+                <a16:creationId xmlns:a16="http://schemas.microsoft.com/office/drawing/2014/main" id="{9E581B9B-EAB9-4FD5-8EB6-1EF8C58AF609}"/>
               </a:ext>
             </a:extLst>
           </p:cNvPr>
@@ -7936,7 +8102,7 @@
           <p:cNvPr id="10" name="">
             <a:extLst xmlns:a="http://schemas.openxmlformats.org/drawingml/2006/main">
               <a:ext uri="{FF2B5EF4-FFF2-40B4-BE49-F238E27FC236}">
-                <a16:creationId xmlns:a16="http://schemas.microsoft.com/office/drawing/2014/main" id="{CDFBAA94-4E74-47D2-B1ED-C88C16115CCA}"/>
+                <a16:creationId xmlns:a16="http://schemas.microsoft.com/office/drawing/2014/main" id="{4F2733FA-EA7B-4FC8-9487-1B700DB0D616}"/>
               </a:ext>
             </a:extLst>
           </p:cNvPr>
@@ -7969,7 +8135,7 @@
           <p:cNvPr id="11" name="">
             <a:extLst xmlns:a="http://schemas.openxmlformats.org/drawingml/2006/main">
               <a:ext uri="{FF2B5EF4-FFF2-40B4-BE49-F238E27FC236}">
-                <a16:creationId xmlns:a16="http://schemas.microsoft.com/office/drawing/2014/main" id="{C71CADC0-362F-4D60-B445-55B68EB8A8D1}"/>
+                <a16:creationId xmlns:a16="http://schemas.microsoft.com/office/drawing/2014/main" id="{02208B22-96EE-4969-AB59-B8AF95E16C41}"/>
               </a:ext>
             </a:extLst>
           </p:cNvPr>
@@ -8019,7 +8185,7 @@
           <p:cNvPr id="12" name="">
             <a:extLst xmlns:a="http://schemas.openxmlformats.org/drawingml/2006/main">
               <a:ext uri="{FF2B5EF4-FFF2-40B4-BE49-F238E27FC236}">
-                <a16:creationId xmlns:a16="http://schemas.microsoft.com/office/drawing/2014/main" id="{ED4C034E-01AD-41E2-A11C-F3C41B1A65C3}"/>
+                <a16:creationId xmlns:a16="http://schemas.microsoft.com/office/drawing/2014/main" id="{E69905EA-2650-4C10-823C-948E01439BDB}"/>
               </a:ext>
             </a:extLst>
           </p:cNvPr>
@@ -8069,7 +8235,7 @@
           <p:cNvPr id="13" name="">
             <a:extLst xmlns:a="http://schemas.openxmlformats.org/drawingml/2006/main">
               <a:ext uri="{FF2B5EF4-FFF2-40B4-BE49-F238E27FC236}">
-                <a16:creationId xmlns:a16="http://schemas.microsoft.com/office/drawing/2014/main" id="{55683160-1554-4E74-93EE-5E0F1C395238}"/>
+                <a16:creationId xmlns:a16="http://schemas.microsoft.com/office/drawing/2014/main" id="{9BC83230-47FF-4DA8-A063-308D6EE3794F}"/>
               </a:ext>
             </a:extLst>
           </p:cNvPr>
@@ -8117,7 +8283,7 @@
     </p:spTree>
     <p:extLst>
       <p:ext uri="{BB962C8B-B14F-4D97-AF65-F5344CB8AC3E}">
-        <p14:creationId xmlns:p14="http://schemas.microsoft.com/office/powerpoint/2010/main" val="618480344"/>
+        <p14:creationId xmlns:p14="http://schemas.microsoft.com/office/powerpoint/2010/main" val="977513746"/>
       </p:ext>
     </p:extLst>
   </p:cSld>
@@ -8148,7 +8314,7 @@
           <p:cNvPr id="1" name="">
             <a:extLst xmlns:a="http://schemas.openxmlformats.org/drawingml/2006/main">
               <a:ext uri="{FF2B5EF4-FFF2-40B4-BE49-F238E27FC236}">
-                <a16:creationId xmlns:a16="http://schemas.microsoft.com/office/drawing/2014/main" id="{F07673F9-B61A-404F-A2BE-AAA8281862C7}"/>
+                <a16:creationId xmlns:a16="http://schemas.microsoft.com/office/drawing/2014/main" id="{706C35B1-5358-43CF-BEB3-36B875D72700}"/>
               </a:ext>
             </a:extLst>
           </p:cNvPr>
@@ -8198,7 +8364,7 @@
           <p:cNvPr id="2" name="">
             <a:extLst xmlns:a="http://schemas.openxmlformats.org/drawingml/2006/main">
               <a:ext uri="{FF2B5EF4-FFF2-40B4-BE49-F238E27FC236}">
-                <a16:creationId xmlns:a16="http://schemas.microsoft.com/office/drawing/2014/main" id="{3DE00957-3D0C-468B-8D2E-FEA49D1FE613}"/>
+                <a16:creationId xmlns:a16="http://schemas.microsoft.com/office/drawing/2014/main" id="{C5A46C39-9223-49B8-A5B4-2C3BF39FF9A8}"/>
               </a:ext>
             </a:extLst>
           </p:cNvPr>
@@ -8248,7 +8414,7 @@
           <p:cNvPr id="3" name="">
             <a:extLst xmlns:a="http://schemas.openxmlformats.org/drawingml/2006/main">
               <a:ext uri="{FF2B5EF4-FFF2-40B4-BE49-F238E27FC236}">
-                <a16:creationId xmlns:a16="http://schemas.microsoft.com/office/drawing/2014/main" id="{9DC7206B-7E57-4030-B865-D32089C09E90}"/>
+                <a16:creationId xmlns:a16="http://schemas.microsoft.com/office/drawing/2014/main" id="{901F9B4A-4898-446D-BCEF-8146C9396782}"/>
               </a:ext>
             </a:extLst>
           </p:cNvPr>
@@ -8281,7 +8447,7 @@
           <p:cNvPr id="4" name="">
             <a:extLst xmlns:a="http://schemas.openxmlformats.org/drawingml/2006/main">
               <a:ext uri="{FF2B5EF4-FFF2-40B4-BE49-F238E27FC236}">
-                <a16:creationId xmlns:a16="http://schemas.microsoft.com/office/drawing/2014/main" id="{C9C8F5C2-1B70-49FC-8F4E-19A477155B02}"/>
+                <a16:creationId xmlns:a16="http://schemas.microsoft.com/office/drawing/2014/main" id="{38D182A4-1546-49DA-841A-9B93727DDB0C}"/>
               </a:ext>
             </a:extLst>
           </p:cNvPr>
@@ -8314,7 +8480,7 @@
           <p:cNvPr id="5" name="">
             <a:extLst xmlns:a="http://schemas.openxmlformats.org/drawingml/2006/main">
               <a:ext uri="{FF2B5EF4-FFF2-40B4-BE49-F238E27FC236}">
-                <a16:creationId xmlns:a16="http://schemas.microsoft.com/office/drawing/2014/main" id="{EDC3F07A-08DE-4158-B7A9-6220CDB06593}"/>
+                <a16:creationId xmlns:a16="http://schemas.microsoft.com/office/drawing/2014/main" id="{A2561DDA-33CD-43C9-B0EE-B880A26F986E}"/>
               </a:ext>
             </a:extLst>
           </p:cNvPr>
@@ -8364,7 +8530,7 @@
           <p:cNvPr id="6" name="">
             <a:extLst xmlns:a="http://schemas.openxmlformats.org/drawingml/2006/main">
               <a:ext uri="{FF2B5EF4-FFF2-40B4-BE49-F238E27FC236}">
-                <a16:creationId xmlns:a16="http://schemas.microsoft.com/office/drawing/2014/main" id="{4F5DB496-C98D-4C33-AF4C-341DD66C3734}"/>
+                <a16:creationId xmlns:a16="http://schemas.microsoft.com/office/drawing/2014/main" id="{E7460D28-5108-4269-A421-CEAF8E2A9E00}"/>
               </a:ext>
             </a:extLst>
           </p:cNvPr>
@@ -8414,7 +8580,7 @@
           <p:cNvPr id="7" name="">
             <a:extLst xmlns:a="http://schemas.openxmlformats.org/drawingml/2006/main">
               <a:ext uri="{FF2B5EF4-FFF2-40B4-BE49-F238E27FC236}">
-                <a16:creationId xmlns:a16="http://schemas.microsoft.com/office/drawing/2014/main" id="{4CED350B-B0D9-45A2-B9B0-F7271D1404B6}"/>
+                <a16:creationId xmlns:a16="http://schemas.microsoft.com/office/drawing/2014/main" id="{2A326C96-D447-4B0A-93EA-39A1C4CAB966}"/>
               </a:ext>
             </a:extLst>
           </p:cNvPr>
@@ -8464,7 +8630,7 @@
           <p:cNvPr id="8" name="">
             <a:extLst xmlns:a="http://schemas.openxmlformats.org/drawingml/2006/main">
               <a:ext uri="{FF2B5EF4-FFF2-40B4-BE49-F238E27FC236}">
-                <a16:creationId xmlns:a16="http://schemas.microsoft.com/office/drawing/2014/main" id="{DCE180DF-207E-4874-B8A3-AC0CE0BB02A5}"/>
+                <a16:creationId xmlns:a16="http://schemas.microsoft.com/office/drawing/2014/main" id="{8F780CBB-02B8-4F27-BCED-7FCDC6DE4ECF}"/>
               </a:ext>
             </a:extLst>
           </p:cNvPr>
@@ -8514,7 +8680,7 @@
           <p:cNvPr id="9" name="">
             <a:extLst xmlns:a="http://schemas.openxmlformats.org/drawingml/2006/main">
               <a:ext uri="{FF2B5EF4-FFF2-40B4-BE49-F238E27FC236}">
-                <a16:creationId xmlns:a16="http://schemas.microsoft.com/office/drawing/2014/main" id="{D9F1D54B-10D2-479F-8391-185048388997}"/>
+                <a16:creationId xmlns:a16="http://schemas.microsoft.com/office/drawing/2014/main" id="{09DD8FFA-689E-4696-A9E3-7D25F8842C67}"/>
               </a:ext>
             </a:extLst>
           </p:cNvPr>
@@ -8564,7 +8730,7 @@
           <p:cNvPr id="10" name="">
             <a:extLst xmlns:a="http://schemas.openxmlformats.org/drawingml/2006/main">
               <a:ext uri="{FF2B5EF4-FFF2-40B4-BE49-F238E27FC236}">
-                <a16:creationId xmlns:a16="http://schemas.microsoft.com/office/drawing/2014/main" id="{DD592EB8-3347-4DE8-9498-1CF8A706CF36}"/>
+                <a16:creationId xmlns:a16="http://schemas.microsoft.com/office/drawing/2014/main" id="{40C226C7-D148-4997-8AC6-FDA8D74B26FB}"/>
               </a:ext>
             </a:extLst>
           </p:cNvPr>
@@ -8614,7 +8780,7 @@
           <p:cNvPr id="11" name="">
             <a:extLst xmlns:a="http://schemas.openxmlformats.org/drawingml/2006/main">
               <a:ext uri="{FF2B5EF4-FFF2-40B4-BE49-F238E27FC236}">
-                <a16:creationId xmlns:a16="http://schemas.microsoft.com/office/drawing/2014/main" id="{248ECC49-84E7-42E3-AE48-863A5D9B49FC}"/>
+                <a16:creationId xmlns:a16="http://schemas.microsoft.com/office/drawing/2014/main" id="{A517B618-4737-41A0-80B5-58908358EC6E}"/>
               </a:ext>
             </a:extLst>
           </p:cNvPr>
@@ -8664,7 +8830,7 @@
           <p:cNvPr id="12" name="">
             <a:extLst xmlns:a="http://schemas.openxmlformats.org/drawingml/2006/main">
               <a:ext uri="{FF2B5EF4-FFF2-40B4-BE49-F238E27FC236}">
-                <a16:creationId xmlns:a16="http://schemas.microsoft.com/office/drawing/2014/main" id="{6C131826-CC7E-4059-99AD-53D94AED7CEC}"/>
+                <a16:creationId xmlns:a16="http://schemas.microsoft.com/office/drawing/2014/main" id="{20819D13-BC6A-4498-B970-89590162402D}"/>
               </a:ext>
             </a:extLst>
           </p:cNvPr>
@@ -8714,7 +8880,7 @@
           <p:cNvPr id="13" name="">
             <a:extLst xmlns:a="http://schemas.openxmlformats.org/drawingml/2006/main">
               <a:ext uri="{FF2B5EF4-FFF2-40B4-BE49-F238E27FC236}">
-                <a16:creationId xmlns:a16="http://schemas.microsoft.com/office/drawing/2014/main" id="{682FC44E-2A97-4A51-B429-4BB7060AE189}"/>
+                <a16:creationId xmlns:a16="http://schemas.microsoft.com/office/drawing/2014/main" id="{A5409127-E783-4B3B-B0ED-C32B2A15DDCC}"/>
               </a:ext>
             </a:extLst>
           </p:cNvPr>
@@ -8764,7 +8930,7 @@
           <p:cNvPr id="14" name="">
             <a:extLst xmlns:a="http://schemas.openxmlformats.org/drawingml/2006/main">
               <a:ext uri="{FF2B5EF4-FFF2-40B4-BE49-F238E27FC236}">
-                <a16:creationId xmlns:a16="http://schemas.microsoft.com/office/drawing/2014/main" id="{2854837C-56DE-485C-B515-D6604B4EEA19}"/>
+                <a16:creationId xmlns:a16="http://schemas.microsoft.com/office/drawing/2014/main" id="{FCB4AA4E-B813-4B81-84C3-5064CC8EAEB9}"/>
               </a:ext>
             </a:extLst>
           </p:cNvPr>
@@ -8812,7 +8978,7 @@
     </p:spTree>
     <p:extLst>
       <p:ext uri="{BB962C8B-B14F-4D97-AF65-F5344CB8AC3E}">
-        <p14:creationId xmlns:p14="http://schemas.microsoft.com/office/powerpoint/2010/main" val="1056604863"/>
+        <p14:creationId xmlns:p14="http://schemas.microsoft.com/office/powerpoint/2010/main" val="1818233064"/>
       </p:ext>
     </p:extLst>
   </p:cSld>
@@ -8843,7 +9009,7 @@
           <p:cNvPr id="1" name="">
             <a:extLst xmlns:a="http://schemas.openxmlformats.org/drawingml/2006/main">
               <a:ext uri="{FF2B5EF4-FFF2-40B4-BE49-F238E27FC236}">
-                <a16:creationId xmlns:a16="http://schemas.microsoft.com/office/drawing/2014/main" id="{BA79D2E9-9D4A-43A7-B377-1632D599A130}"/>
+                <a16:creationId xmlns:a16="http://schemas.microsoft.com/office/drawing/2014/main" id="{7C0F5193-0252-480D-B4A9-396D53C95433}"/>
               </a:ext>
             </a:extLst>
           </p:cNvPr>
@@ -8893,7 +9059,7 @@
           <p:cNvPr id="2" name="">
             <a:extLst xmlns:a="http://schemas.openxmlformats.org/drawingml/2006/main">
               <a:ext uri="{FF2B5EF4-FFF2-40B4-BE49-F238E27FC236}">
-                <a16:creationId xmlns:a16="http://schemas.microsoft.com/office/drawing/2014/main" id="{C98100F3-3031-4A15-AE53-E5B5761972EE}"/>
+                <a16:creationId xmlns:a16="http://schemas.microsoft.com/office/drawing/2014/main" id="{8747F963-2948-4707-9AAB-0C81F942CB68}"/>
               </a:ext>
             </a:extLst>
           </p:cNvPr>
@@ -8943,7 +9109,7 @@
           <p:cNvPr id="3" name="">
             <a:extLst xmlns:a="http://schemas.openxmlformats.org/drawingml/2006/main">
               <a:ext uri="{FF2B5EF4-FFF2-40B4-BE49-F238E27FC236}">
-                <a16:creationId xmlns:a16="http://schemas.microsoft.com/office/drawing/2014/main" id="{DCC72EA7-CD1B-45B6-BD64-B206D1970C04}"/>
+                <a16:creationId xmlns:a16="http://schemas.microsoft.com/office/drawing/2014/main" id="{14FE1B3F-A0BC-42F8-B609-A87C902FE146}"/>
               </a:ext>
             </a:extLst>
           </p:cNvPr>
@@ -8976,7 +9142,7 @@
           <p:cNvPr id="4" name="">
             <a:extLst xmlns:a="http://schemas.openxmlformats.org/drawingml/2006/main">
               <a:ext uri="{FF2B5EF4-FFF2-40B4-BE49-F238E27FC236}">
-                <a16:creationId xmlns:a16="http://schemas.microsoft.com/office/drawing/2014/main" id="{D4EE5462-F50B-4C00-8CAB-8CD44CCC7E96}"/>
+                <a16:creationId xmlns:a16="http://schemas.microsoft.com/office/drawing/2014/main" id="{201A6045-6A45-4571-880C-3CA094616302}"/>
               </a:ext>
             </a:extLst>
           </p:cNvPr>
@@ -9026,7 +9192,7 @@
           <p:cNvPr id="5" name="">
             <a:extLst xmlns:a="http://schemas.openxmlformats.org/drawingml/2006/main">
               <a:ext uri="{FF2B5EF4-FFF2-40B4-BE49-F238E27FC236}">
-                <a16:creationId xmlns:a16="http://schemas.microsoft.com/office/drawing/2014/main" id="{F794D36E-0C22-4E99-9CDE-93D53DB5F980}"/>
+                <a16:creationId xmlns:a16="http://schemas.microsoft.com/office/drawing/2014/main" id="{54785B79-E7BA-4A6E-BAF1-D194E5A5DA45}"/>
               </a:ext>
             </a:extLst>
           </p:cNvPr>
@@ -9076,7 +9242,7 @@
           <p:cNvPr id="6" name="">
             <a:extLst xmlns:a="http://schemas.openxmlformats.org/drawingml/2006/main">
               <a:ext uri="{FF2B5EF4-FFF2-40B4-BE49-F238E27FC236}">
-                <a16:creationId xmlns:a16="http://schemas.microsoft.com/office/drawing/2014/main" id="{FE36CBBE-4D17-4CE7-A846-BD25966F0DD8}"/>
+                <a16:creationId xmlns:a16="http://schemas.microsoft.com/office/drawing/2014/main" id="{1CC6A8EF-B9B9-45E4-BFE0-83317355B438}"/>
               </a:ext>
             </a:extLst>
           </p:cNvPr>
@@ -9126,7 +9292,7 @@
           <p:cNvPr id="7" name="">
             <a:extLst xmlns:a="http://schemas.openxmlformats.org/drawingml/2006/main">
               <a:ext uri="{FF2B5EF4-FFF2-40B4-BE49-F238E27FC236}">
-                <a16:creationId xmlns:a16="http://schemas.microsoft.com/office/drawing/2014/main" id="{D7A68E51-2C05-42ED-8697-111D167936B8}"/>
+                <a16:creationId xmlns:a16="http://schemas.microsoft.com/office/drawing/2014/main" id="{E470DCE0-FAB2-4BF8-8918-BCF452E51F4D}"/>
               </a:ext>
             </a:extLst>
           </p:cNvPr>
@@ -9176,7 +9342,7 @@
           <p:cNvPr id="8" name="">
             <a:extLst xmlns:a="http://schemas.openxmlformats.org/drawingml/2006/main">
               <a:ext uri="{FF2B5EF4-FFF2-40B4-BE49-F238E27FC236}">
-                <a16:creationId xmlns:a16="http://schemas.microsoft.com/office/drawing/2014/main" id="{A6954B70-C95B-45A6-B007-C2F3630543C4}"/>
+                <a16:creationId xmlns:a16="http://schemas.microsoft.com/office/drawing/2014/main" id="{1BA54492-775B-4D4B-B059-4E1092CBC48F}"/>
               </a:ext>
             </a:extLst>
           </p:cNvPr>
@@ -9226,7 +9392,7 @@
           <p:cNvPr id="9" name="">
             <a:extLst xmlns:a="http://schemas.openxmlformats.org/drawingml/2006/main">
               <a:ext uri="{FF2B5EF4-FFF2-40B4-BE49-F238E27FC236}">
-                <a16:creationId xmlns:a16="http://schemas.microsoft.com/office/drawing/2014/main" id="{75C620A0-CE54-4084-B6B2-51DA7E98E27D}"/>
+                <a16:creationId xmlns:a16="http://schemas.microsoft.com/office/drawing/2014/main" id="{180920EC-7894-4B91-ACC3-3A266CE7C89B}"/>
               </a:ext>
             </a:extLst>
           </p:cNvPr>
@@ -9276,7 +9442,7 @@
           <p:cNvPr id="10" name="">
             <a:extLst xmlns:a="http://schemas.openxmlformats.org/drawingml/2006/main">
               <a:ext uri="{FF2B5EF4-FFF2-40B4-BE49-F238E27FC236}">
-                <a16:creationId xmlns:a16="http://schemas.microsoft.com/office/drawing/2014/main" id="{317A2837-D3D9-4169-A85F-92E0B1E62B8B}"/>
+                <a16:creationId xmlns:a16="http://schemas.microsoft.com/office/drawing/2014/main" id="{428A9706-4C14-4B70-97FB-0E14D6A9EBB8}"/>
               </a:ext>
             </a:extLst>
           </p:cNvPr>
@@ -9309,7 +9475,7 @@
           <p:cNvPr id="11" name="">
             <a:extLst xmlns:a="http://schemas.openxmlformats.org/drawingml/2006/main">
               <a:ext uri="{FF2B5EF4-FFF2-40B4-BE49-F238E27FC236}">
-                <a16:creationId xmlns:a16="http://schemas.microsoft.com/office/drawing/2014/main" id="{2A55D1DE-40CD-449F-A749-AE70BBB789AB}"/>
+                <a16:creationId xmlns:a16="http://schemas.microsoft.com/office/drawing/2014/main" id="{582052EE-0EE2-4B25-8341-9590BE7807DD}"/>
               </a:ext>
             </a:extLst>
           </p:cNvPr>
@@ -9359,7 +9525,7 @@
           <p:cNvPr id="12" name="">
             <a:extLst xmlns:a="http://schemas.openxmlformats.org/drawingml/2006/main">
               <a:ext uri="{FF2B5EF4-FFF2-40B4-BE49-F238E27FC236}">
-                <a16:creationId xmlns:a16="http://schemas.microsoft.com/office/drawing/2014/main" id="{1488D620-5CF9-427F-8541-3C9D9D2465ED}"/>
+                <a16:creationId xmlns:a16="http://schemas.microsoft.com/office/drawing/2014/main" id="{2D6B3F65-9525-4895-92A1-042D648B62BA}"/>
               </a:ext>
             </a:extLst>
           </p:cNvPr>
@@ -9407,7 +9573,7 @@
     </p:spTree>
     <p:extLst>
       <p:ext uri="{BB962C8B-B14F-4D97-AF65-F5344CB8AC3E}">
-        <p14:creationId xmlns:p14="http://schemas.microsoft.com/office/powerpoint/2010/main" val="2024501700"/>
+        <p14:creationId xmlns:p14="http://schemas.microsoft.com/office/powerpoint/2010/main" val="1556067604"/>
       </p:ext>
     </p:extLst>
   </p:cSld>
@@ -9438,7 +9604,7 @@
           <p:cNvPr id="1" name="">
             <a:extLst xmlns:a="http://schemas.openxmlformats.org/drawingml/2006/main">
               <a:ext uri="{FF2B5EF4-FFF2-40B4-BE49-F238E27FC236}">
-                <a16:creationId xmlns:a16="http://schemas.microsoft.com/office/drawing/2014/main" id="{A770D647-1CFD-4044-B54B-25E134FFC6E6}"/>
+                <a16:creationId xmlns:a16="http://schemas.microsoft.com/office/drawing/2014/main" id="{B5838D07-97AA-40BC-92AE-34F04CF80BDC}"/>
               </a:ext>
             </a:extLst>
           </p:cNvPr>
@@ -9488,7 +9654,7 @@
           <p:cNvPr id="2" name="">
             <a:extLst xmlns:a="http://schemas.openxmlformats.org/drawingml/2006/main">
               <a:ext uri="{FF2B5EF4-FFF2-40B4-BE49-F238E27FC236}">
-                <a16:creationId xmlns:a16="http://schemas.microsoft.com/office/drawing/2014/main" id="{69FBB758-FD4D-4DB1-BE91-B388153D8C8A}"/>
+                <a16:creationId xmlns:a16="http://schemas.microsoft.com/office/drawing/2014/main" id="{3E3F0357-4B3C-4B15-8E5B-48DF8953E4E3}"/>
               </a:ext>
             </a:extLst>
           </p:cNvPr>
@@ -9538,7 +9704,7 @@
           <p:cNvPr id="3" name="">
             <a:extLst xmlns:a="http://schemas.openxmlformats.org/drawingml/2006/main">
               <a:ext uri="{FF2B5EF4-FFF2-40B4-BE49-F238E27FC236}">
-                <a16:creationId xmlns:a16="http://schemas.microsoft.com/office/drawing/2014/main" id="{B005CFA3-BC03-46D1-9C9C-69CE6E869D97}"/>
+                <a16:creationId xmlns:a16="http://schemas.microsoft.com/office/drawing/2014/main" id="{9A4E3B85-FDA6-420C-A65C-E1D32A590730}"/>
               </a:ext>
             </a:extLst>
           </p:cNvPr>
@@ -9575,7 +9741,7 @@
           <p:nvPr/>
         </p:nvPicPr>
         <p:blipFill>
-          <a:blip xmlns:r="http://schemas.openxmlformats.org/officeDocument/2006/relationships" xmlns:a="http://schemas.openxmlformats.org/drawingml/2006/main" r:embed="Rcb0aa4bbea08452b"/>
+          <a:blip xmlns:r="http://schemas.openxmlformats.org/officeDocument/2006/relationships" xmlns:a="http://schemas.openxmlformats.org/drawingml/2006/main" r:embed="Re190ff99454c4977"/>
           <a:stretch xmlns:a="http://schemas.openxmlformats.org/drawingml/2006/main"/>
         </p:blipFill>
         <p:spPr>
@@ -9593,7 +9759,7 @@
           <p:cNvPr id="5" name="">
             <a:extLst xmlns:a="http://schemas.openxmlformats.org/drawingml/2006/main">
               <a:ext uri="{FF2B5EF4-FFF2-40B4-BE49-F238E27FC236}">
-                <a16:creationId xmlns:a16="http://schemas.microsoft.com/office/drawing/2014/main" id="{9036B87B-BC10-45DB-993B-D1E98D518427}"/>
+                <a16:creationId xmlns:a16="http://schemas.microsoft.com/office/drawing/2014/main" id="{88DC9BD3-F22A-4C65-9EB8-7511186D131E}"/>
               </a:ext>
             </a:extLst>
           </p:cNvPr>
@@ -9641,7 +9807,7 @@
     </p:spTree>
     <p:extLst>
       <p:ext uri="{BB962C8B-B14F-4D97-AF65-F5344CB8AC3E}">
-        <p14:creationId xmlns:p14="http://schemas.microsoft.com/office/powerpoint/2010/main" val="2081715827"/>
+        <p14:creationId xmlns:p14="http://schemas.microsoft.com/office/powerpoint/2010/main" val="455385943"/>
       </p:ext>
     </p:extLst>
   </p:cSld>
@@ -9672,7 +9838,7 @@
           <p:cNvPr id="1" name="">
             <a:extLst xmlns:a="http://schemas.openxmlformats.org/drawingml/2006/main">
               <a:ext uri="{FF2B5EF4-FFF2-40B4-BE49-F238E27FC236}">
-                <a16:creationId xmlns:a16="http://schemas.microsoft.com/office/drawing/2014/main" id="{A6252752-9CAD-4D6A-B80B-906048239374}"/>
+                <a16:creationId xmlns:a16="http://schemas.microsoft.com/office/drawing/2014/main" id="{777F97D5-1DC9-4BCF-842B-7ED720A12779}"/>
               </a:ext>
             </a:extLst>
           </p:cNvPr>
@@ -9722,7 +9888,7 @@
           <p:cNvPr id="2" name="">
             <a:extLst xmlns:a="http://schemas.openxmlformats.org/drawingml/2006/main">
               <a:ext uri="{FF2B5EF4-FFF2-40B4-BE49-F238E27FC236}">
-                <a16:creationId xmlns:a16="http://schemas.microsoft.com/office/drawing/2014/main" id="{902C3908-E1E5-438A-9B8C-9621431203BD}"/>
+                <a16:creationId xmlns:a16="http://schemas.microsoft.com/office/drawing/2014/main" id="{8B5F0843-F57F-4707-8811-3CE6066DB0E4}"/>
               </a:ext>
             </a:extLst>
           </p:cNvPr>
@@ -9772,7 +9938,7 @@
           <p:cNvPr id="3" name="">
             <a:extLst xmlns:a="http://schemas.openxmlformats.org/drawingml/2006/main">
               <a:ext uri="{FF2B5EF4-FFF2-40B4-BE49-F238E27FC236}">
-                <a16:creationId xmlns:a16="http://schemas.microsoft.com/office/drawing/2014/main" id="{63F370FE-C1DE-4ABE-9B88-F6B022B63EBA}"/>
+                <a16:creationId xmlns:a16="http://schemas.microsoft.com/office/drawing/2014/main" id="{F90CCC89-CBD6-432D-B470-C213E3104AF3}"/>
               </a:ext>
             </a:extLst>
           </p:cNvPr>
@@ -9809,7 +9975,7 @@
           <p:nvPr/>
         </p:nvPicPr>
         <p:blipFill>
-          <a:blip xmlns:r="http://schemas.openxmlformats.org/officeDocument/2006/relationships" xmlns:a="http://schemas.openxmlformats.org/drawingml/2006/main" r:embed="Raadc0b3714644202"/>
+          <a:blip xmlns:r="http://schemas.openxmlformats.org/officeDocument/2006/relationships" xmlns:a="http://schemas.openxmlformats.org/drawingml/2006/main" r:embed="R12f52168497e4e30"/>
           <a:stretch xmlns:a="http://schemas.openxmlformats.org/drawingml/2006/main"/>
         </p:blipFill>
         <p:spPr>
@@ -9827,7 +9993,7 @@
           <p:cNvPr id="5" name="">
             <a:extLst xmlns:a="http://schemas.openxmlformats.org/drawingml/2006/main">
               <a:ext uri="{FF2B5EF4-FFF2-40B4-BE49-F238E27FC236}">
-                <a16:creationId xmlns:a16="http://schemas.microsoft.com/office/drawing/2014/main" id="{5C33E4A1-F095-48B4-BF95-01873EAE38C0}"/>
+                <a16:creationId xmlns:a16="http://schemas.microsoft.com/office/drawing/2014/main" id="{7818F936-0E3A-43A0-AC08-A7E4CFC2C548}"/>
               </a:ext>
             </a:extLst>
           </p:cNvPr>
@@ -9860,7 +10026,7 @@
           <p:cNvPr id="6" name="">
             <a:extLst xmlns:a="http://schemas.openxmlformats.org/drawingml/2006/main">
               <a:ext uri="{FF2B5EF4-FFF2-40B4-BE49-F238E27FC236}">
-                <a16:creationId xmlns:a16="http://schemas.microsoft.com/office/drawing/2014/main" id="{54722793-4501-4E2B-AC49-9325CAFF6950}"/>
+                <a16:creationId xmlns:a16="http://schemas.microsoft.com/office/drawing/2014/main" id="{3FF26019-D3BA-4D63-965C-6A6DAD7C248B}"/>
               </a:ext>
             </a:extLst>
           </p:cNvPr>
@@ -9910,7 +10076,7 @@
           <p:cNvPr id="7" name="">
             <a:extLst xmlns:a="http://schemas.openxmlformats.org/drawingml/2006/main">
               <a:ext uri="{FF2B5EF4-FFF2-40B4-BE49-F238E27FC236}">
-                <a16:creationId xmlns:a16="http://schemas.microsoft.com/office/drawing/2014/main" id="{FA663217-C362-4825-B6E6-22126DC64776}"/>
+                <a16:creationId xmlns:a16="http://schemas.microsoft.com/office/drawing/2014/main" id="{758B6B1F-038A-4393-A165-C263225683C6}"/>
               </a:ext>
             </a:extLst>
           </p:cNvPr>
@@ -9943,7 +10109,7 @@
           <p:cNvPr id="8" name="">
             <a:extLst xmlns:a="http://schemas.openxmlformats.org/drawingml/2006/main">
               <a:ext uri="{FF2B5EF4-FFF2-40B4-BE49-F238E27FC236}">
-                <a16:creationId xmlns:a16="http://schemas.microsoft.com/office/drawing/2014/main" id="{273B2FD5-B6A3-498C-89FD-E0CCD40761E2}"/>
+                <a16:creationId xmlns:a16="http://schemas.microsoft.com/office/drawing/2014/main" id="{7F826B53-F4EC-4EA3-BB58-70D1705352FE}"/>
               </a:ext>
             </a:extLst>
           </p:cNvPr>
@@ -9993,7 +10159,7 @@
           <p:cNvPr id="9" name="">
             <a:extLst xmlns:a="http://schemas.openxmlformats.org/drawingml/2006/main">
               <a:ext uri="{FF2B5EF4-FFF2-40B4-BE49-F238E27FC236}">
-                <a16:creationId xmlns:a16="http://schemas.microsoft.com/office/drawing/2014/main" id="{4637CDB5-1162-42F8-9873-73B45DE3B762}"/>
+                <a16:creationId xmlns:a16="http://schemas.microsoft.com/office/drawing/2014/main" id="{0CC2814C-F7EB-4A4B-BA05-0596E3D09578}"/>
               </a:ext>
             </a:extLst>
           </p:cNvPr>
@@ -10026,7 +10192,7 @@
           <p:cNvPr id="10" name="">
             <a:extLst xmlns:a="http://schemas.openxmlformats.org/drawingml/2006/main">
               <a:ext uri="{FF2B5EF4-FFF2-40B4-BE49-F238E27FC236}">
-                <a16:creationId xmlns:a16="http://schemas.microsoft.com/office/drawing/2014/main" id="{E689DEB2-E85C-49D5-AEEF-903608F5CC7D}"/>
+                <a16:creationId xmlns:a16="http://schemas.microsoft.com/office/drawing/2014/main" id="{CF18C253-B93E-44D8-9CAC-075C676F36B5}"/>
               </a:ext>
             </a:extLst>
           </p:cNvPr>
@@ -10076,7 +10242,7 @@
           <p:cNvPr id="11" name="">
             <a:extLst xmlns:a="http://schemas.openxmlformats.org/drawingml/2006/main">
               <a:ext uri="{FF2B5EF4-FFF2-40B4-BE49-F238E27FC236}">
-                <a16:creationId xmlns:a16="http://schemas.microsoft.com/office/drawing/2014/main" id="{94FB85D9-3ED7-4634-9B04-7828891795CA}"/>
+                <a16:creationId xmlns:a16="http://schemas.microsoft.com/office/drawing/2014/main" id="{5972EAE8-EA61-44EB-AF6B-4868824F0AE0}"/>
               </a:ext>
             </a:extLst>
           </p:cNvPr>
@@ -10109,7 +10275,7 @@
           <p:cNvPr id="12" name="">
             <a:extLst xmlns:a="http://schemas.openxmlformats.org/drawingml/2006/main">
               <a:ext uri="{FF2B5EF4-FFF2-40B4-BE49-F238E27FC236}">
-                <a16:creationId xmlns:a16="http://schemas.microsoft.com/office/drawing/2014/main" id="{8A5E2E42-7D78-4B0A-BC73-206219243DB5}"/>
+                <a16:creationId xmlns:a16="http://schemas.microsoft.com/office/drawing/2014/main" id="{69A196F8-9233-4944-8DA5-F8F37F89AD65}"/>
               </a:ext>
             </a:extLst>
           </p:cNvPr>
@@ -10159,7 +10325,7 @@
           <p:cNvPr id="13" name="">
             <a:extLst xmlns:a="http://schemas.openxmlformats.org/drawingml/2006/main">
               <a:ext uri="{FF2B5EF4-FFF2-40B4-BE49-F238E27FC236}">
-                <a16:creationId xmlns:a16="http://schemas.microsoft.com/office/drawing/2014/main" id="{44222D68-8A0D-488A-812E-17E80E2FCDA0}"/>
+                <a16:creationId xmlns:a16="http://schemas.microsoft.com/office/drawing/2014/main" id="{4D38BC02-5EBD-47AF-BEC6-F2B5B05A5B29}"/>
               </a:ext>
             </a:extLst>
           </p:cNvPr>
@@ -10207,7 +10373,7 @@
     </p:spTree>
     <p:extLst>
       <p:ext uri="{BB962C8B-B14F-4D97-AF65-F5344CB8AC3E}">
-        <p14:creationId xmlns:p14="http://schemas.microsoft.com/office/powerpoint/2010/main" val="2056252923"/>
+        <p14:creationId xmlns:p14="http://schemas.microsoft.com/office/powerpoint/2010/main" val="508141235"/>
       </p:ext>
     </p:extLst>
   </p:cSld>
@@ -10238,7 +10404,7 @@
           <p:cNvPr id="1" name="">
             <a:extLst xmlns:a="http://schemas.openxmlformats.org/drawingml/2006/main">
               <a:ext uri="{FF2B5EF4-FFF2-40B4-BE49-F238E27FC236}">
-                <a16:creationId xmlns:a16="http://schemas.microsoft.com/office/drawing/2014/main" id="{24B97CFC-3A3E-4BC9-B296-EADD206CCE6E}"/>
+                <a16:creationId xmlns:a16="http://schemas.microsoft.com/office/drawing/2014/main" id="{9DA2CFF6-7EB5-487F-B5D4-BD5CA27E9ECC}"/>
               </a:ext>
             </a:extLst>
           </p:cNvPr>
@@ -10288,7 +10454,7 @@
           <p:cNvPr id="2" name="">
             <a:extLst xmlns:a="http://schemas.openxmlformats.org/drawingml/2006/main">
               <a:ext uri="{FF2B5EF4-FFF2-40B4-BE49-F238E27FC236}">
-                <a16:creationId xmlns:a16="http://schemas.microsoft.com/office/drawing/2014/main" id="{C0A0409F-EEEA-44F2-A714-C15ED291FBBD}"/>
+                <a16:creationId xmlns:a16="http://schemas.microsoft.com/office/drawing/2014/main" id="{BF41788E-676E-4312-8474-A7486F3530CC}"/>
               </a:ext>
             </a:extLst>
           </p:cNvPr>
@@ -10338,7 +10504,7 @@
           <p:cNvPr id="3" name="">
             <a:extLst xmlns:a="http://schemas.openxmlformats.org/drawingml/2006/main">
               <a:ext uri="{FF2B5EF4-FFF2-40B4-BE49-F238E27FC236}">
-                <a16:creationId xmlns:a16="http://schemas.microsoft.com/office/drawing/2014/main" id="{0F2E8850-7DB8-46E6-ADC5-F4E3CDDAC9DE}"/>
+                <a16:creationId xmlns:a16="http://schemas.microsoft.com/office/drawing/2014/main" id="{5AB94600-F9B3-43CC-9977-4ECA7B6BBCF6}"/>
               </a:ext>
             </a:extLst>
           </p:cNvPr>
@@ -10371,7 +10537,7 @@
           <p:cNvPr id="4" name="">
             <a:extLst xmlns:a="http://schemas.openxmlformats.org/drawingml/2006/main">
               <a:ext uri="{FF2B5EF4-FFF2-40B4-BE49-F238E27FC236}">
-                <a16:creationId xmlns:a16="http://schemas.microsoft.com/office/drawing/2014/main" id="{FE7CBC2C-B33A-45BC-973A-108A16D16473}"/>
+                <a16:creationId xmlns:a16="http://schemas.microsoft.com/office/drawing/2014/main" id="{5BADA075-8917-4F72-8FE5-D45CDEE0B6D1}"/>
               </a:ext>
             </a:extLst>
           </p:cNvPr>
@@ -10404,7 +10570,7 @@
           <p:cNvPr id="5" name="">
             <a:extLst xmlns:a="http://schemas.openxmlformats.org/drawingml/2006/main">
               <a:ext uri="{FF2B5EF4-FFF2-40B4-BE49-F238E27FC236}">
-                <a16:creationId xmlns:a16="http://schemas.microsoft.com/office/drawing/2014/main" id="{5BDAD095-4DAC-48AC-A5D0-C7A97B4E1A3B}"/>
+                <a16:creationId xmlns:a16="http://schemas.microsoft.com/office/drawing/2014/main" id="{E6F75FAE-04E6-4E93-994B-7A16FF40519E}"/>
               </a:ext>
             </a:extLst>
           </p:cNvPr>
@@ -10454,7 +10620,7 @@
           <p:cNvPr id="6" name="">
             <a:extLst xmlns:a="http://schemas.openxmlformats.org/drawingml/2006/main">
               <a:ext uri="{FF2B5EF4-FFF2-40B4-BE49-F238E27FC236}">
-                <a16:creationId xmlns:a16="http://schemas.microsoft.com/office/drawing/2014/main" id="{6AB1AE5C-4FDA-4F0F-8FD2-611BFEA74BEC}"/>
+                <a16:creationId xmlns:a16="http://schemas.microsoft.com/office/drawing/2014/main" id="{9BE243CF-95C0-470E-8ED7-1205BEEEC4C2}"/>
               </a:ext>
             </a:extLst>
           </p:cNvPr>
@@ -10504,7 +10670,7 @@
           <p:cNvPr id="7" name="">
             <a:extLst xmlns:a="http://schemas.openxmlformats.org/drawingml/2006/main">
               <a:ext uri="{FF2B5EF4-FFF2-40B4-BE49-F238E27FC236}">
-                <a16:creationId xmlns:a16="http://schemas.microsoft.com/office/drawing/2014/main" id="{081F701F-DA21-404F-ACCC-7EE3D7C16472}"/>
+                <a16:creationId xmlns:a16="http://schemas.microsoft.com/office/drawing/2014/main" id="{544EF6F9-BDAF-4F04-9C16-E254851B0F09}"/>
               </a:ext>
             </a:extLst>
           </p:cNvPr>
@@ -10554,7 +10720,7 @@
           <p:cNvPr id="8" name="">
             <a:extLst xmlns:a="http://schemas.openxmlformats.org/drawingml/2006/main">
               <a:ext uri="{FF2B5EF4-FFF2-40B4-BE49-F238E27FC236}">
-                <a16:creationId xmlns:a16="http://schemas.microsoft.com/office/drawing/2014/main" id="{5EB24579-243F-4D8D-AC95-031D378AAEBB}"/>
+                <a16:creationId xmlns:a16="http://schemas.microsoft.com/office/drawing/2014/main" id="{2A878987-654F-4FD2-A040-FD27E9A79EB2}"/>
               </a:ext>
             </a:extLst>
           </p:cNvPr>
@@ -10587,7 +10753,7 @@
           <p:cNvPr id="9" name="">
             <a:extLst xmlns:a="http://schemas.openxmlformats.org/drawingml/2006/main">
               <a:ext uri="{FF2B5EF4-FFF2-40B4-BE49-F238E27FC236}">
-                <a16:creationId xmlns:a16="http://schemas.microsoft.com/office/drawing/2014/main" id="{63EEF438-ADA5-4E6F-BA48-E45EA26EAC6C}"/>
+                <a16:creationId xmlns:a16="http://schemas.microsoft.com/office/drawing/2014/main" id="{659F7756-01F3-4801-A0DE-CEA25C52293A}"/>
               </a:ext>
             </a:extLst>
           </p:cNvPr>
@@ -10637,7 +10803,7 @@
           <p:cNvPr id="10" name="">
             <a:extLst xmlns:a="http://schemas.openxmlformats.org/drawingml/2006/main">
               <a:ext uri="{FF2B5EF4-FFF2-40B4-BE49-F238E27FC236}">
-                <a16:creationId xmlns:a16="http://schemas.microsoft.com/office/drawing/2014/main" id="{0B6135FD-2CFC-443E-B222-F5458ABB4946}"/>
+                <a16:creationId xmlns:a16="http://schemas.microsoft.com/office/drawing/2014/main" id="{ED4F3A05-E864-4770-A966-981DEA87EF7B}"/>
               </a:ext>
             </a:extLst>
           </p:cNvPr>
@@ -10670,7 +10836,7 @@
           <p:cNvPr id="11" name="">
             <a:extLst xmlns:a="http://schemas.openxmlformats.org/drawingml/2006/main">
               <a:ext uri="{FF2B5EF4-FFF2-40B4-BE49-F238E27FC236}">
-                <a16:creationId xmlns:a16="http://schemas.microsoft.com/office/drawing/2014/main" id="{69ABD169-7BF0-403D-A883-04616C401D2A}"/>
+                <a16:creationId xmlns:a16="http://schemas.microsoft.com/office/drawing/2014/main" id="{799D73D6-02DD-40F7-AFA3-DF6CEB711C71}"/>
               </a:ext>
             </a:extLst>
           </p:cNvPr>
@@ -10720,7 +10886,7 @@
           <p:cNvPr id="12" name="">
             <a:extLst xmlns:a="http://schemas.openxmlformats.org/drawingml/2006/main">
               <a:ext uri="{FF2B5EF4-FFF2-40B4-BE49-F238E27FC236}">
-                <a16:creationId xmlns:a16="http://schemas.microsoft.com/office/drawing/2014/main" id="{D0B8F65D-ACFF-4690-96F8-CC9C6079DDE4}"/>
+                <a16:creationId xmlns:a16="http://schemas.microsoft.com/office/drawing/2014/main" id="{9023CAD3-4B13-4C81-BA6B-0275C7040185}"/>
               </a:ext>
             </a:extLst>
           </p:cNvPr>
@@ -10753,7 +10919,7 @@
           <p:cNvPr id="13" name="">
             <a:extLst xmlns:a="http://schemas.openxmlformats.org/drawingml/2006/main">
               <a:ext uri="{FF2B5EF4-FFF2-40B4-BE49-F238E27FC236}">
-                <a16:creationId xmlns:a16="http://schemas.microsoft.com/office/drawing/2014/main" id="{5AEBDE11-23B3-46D8-A3FC-97493CE5643B}"/>
+                <a16:creationId xmlns:a16="http://schemas.microsoft.com/office/drawing/2014/main" id="{D0085A7D-8119-4325-9643-47BE64F042D5}"/>
               </a:ext>
             </a:extLst>
           </p:cNvPr>
@@ -10803,7 +10969,7 @@
           <p:cNvPr id="14" name="">
             <a:extLst xmlns:a="http://schemas.openxmlformats.org/drawingml/2006/main">
               <a:ext uri="{FF2B5EF4-FFF2-40B4-BE49-F238E27FC236}">
-                <a16:creationId xmlns:a16="http://schemas.microsoft.com/office/drawing/2014/main" id="{6333AF7B-7F6B-4619-853E-E2BB42066A1F}"/>
+                <a16:creationId xmlns:a16="http://schemas.microsoft.com/office/drawing/2014/main" id="{F81525DC-9989-45A2-9CD0-973EB7F8FD67}"/>
               </a:ext>
             </a:extLst>
           </p:cNvPr>
@@ -10836,7 +11002,7 @@
           <p:cNvPr id="15" name="">
             <a:extLst xmlns:a="http://schemas.openxmlformats.org/drawingml/2006/main">
               <a:ext uri="{FF2B5EF4-FFF2-40B4-BE49-F238E27FC236}">
-                <a16:creationId xmlns:a16="http://schemas.microsoft.com/office/drawing/2014/main" id="{348559E8-2625-468A-BD28-D293178E87C3}"/>
+                <a16:creationId xmlns:a16="http://schemas.microsoft.com/office/drawing/2014/main" id="{FF94FDF6-1AFC-4FAB-88E9-F3EE6392F6BE}"/>
               </a:ext>
             </a:extLst>
           </p:cNvPr>
@@ -10886,7 +11052,7 @@
           <p:cNvPr id="16" name="">
             <a:extLst xmlns:a="http://schemas.openxmlformats.org/drawingml/2006/main">
               <a:ext uri="{FF2B5EF4-FFF2-40B4-BE49-F238E27FC236}">
-                <a16:creationId xmlns:a16="http://schemas.microsoft.com/office/drawing/2014/main" id="{DC2DC48F-A318-4098-A405-5FE2536ABA6D}"/>
+                <a16:creationId xmlns:a16="http://schemas.microsoft.com/office/drawing/2014/main" id="{F55821AB-C4A3-4B8F-A7EA-70B663CACD10}"/>
               </a:ext>
             </a:extLst>
           </p:cNvPr>
@@ -10934,7 +11100,7 @@
     </p:spTree>
     <p:extLst>
       <p:ext uri="{BB962C8B-B14F-4D97-AF65-F5344CB8AC3E}">
-        <p14:creationId xmlns:p14="http://schemas.microsoft.com/office/powerpoint/2010/main" val="1631083982"/>
+        <p14:creationId xmlns:p14="http://schemas.microsoft.com/office/powerpoint/2010/main" val="459125820"/>
       </p:ext>
     </p:extLst>
   </p:cSld>

</xml_diff>

<commit_message>
Update historical LeNet results and presentation
</commit_message>
<xml_diff>
--- a/slides/LeNet5_MNIST_Final_Presentation.pptx
+++ b/slides/LeNet5_MNIST_Final_Presentation.pptx
@@ -2,25 +2,25 @@
 <file path=ppt/presentation.xml><?xml version="1.0" encoding="utf-8"?>
 <p:presentation xmlns:p="http://schemas.openxmlformats.org/presentationml/2006/main">
   <p:sldMasterIdLst>
-    <p:sldMasterId xmlns:r="http://schemas.openxmlformats.org/officeDocument/2006/relationships" id="2147483648" r:id="R10a958a769c148b8"/>
+    <p:sldMasterId xmlns:r="http://schemas.openxmlformats.org/officeDocument/2006/relationships" id="2147483648" r:id="R11f4bfb6ef7149c6"/>
   </p:sldMasterIdLst>
   <p:notesMasterIdLst>
-    <p:notesMasterId xmlns:r="http://schemas.openxmlformats.org/officeDocument/2006/relationships" r:id="R0c9d581a40404b7c"/>
+    <p:notesMasterId xmlns:r="http://schemas.openxmlformats.org/officeDocument/2006/relationships" r:id="R2c90086fe7184857"/>
   </p:notesMasterIdLst>
   <p:sldIdLst>
-    <p:sldId xmlns:r="http://schemas.openxmlformats.org/officeDocument/2006/relationships" id="256" r:id="Rec394f8fae72442d"/>
-    <p:sldId xmlns:r="http://schemas.openxmlformats.org/officeDocument/2006/relationships" id="257" r:id="R667002b794614105"/>
-    <p:sldId xmlns:r="http://schemas.openxmlformats.org/officeDocument/2006/relationships" id="258" r:id="R11b05f11f85e4ea6"/>
-    <p:sldId xmlns:r="http://schemas.openxmlformats.org/officeDocument/2006/relationships" id="259" r:id="Rdb92c9b2de4a4983"/>
-    <p:sldId xmlns:r="http://schemas.openxmlformats.org/officeDocument/2006/relationships" id="260" r:id="R61c508e92189480c"/>
-    <p:sldId xmlns:r="http://schemas.openxmlformats.org/officeDocument/2006/relationships" id="261" r:id="R275ef321836a43e1"/>
-    <p:sldId xmlns:r="http://schemas.openxmlformats.org/officeDocument/2006/relationships" id="262" r:id="R5f37e5742fa2463f"/>
-    <p:sldId xmlns:r="http://schemas.openxmlformats.org/officeDocument/2006/relationships" id="263" r:id="R5316c2e640fe4994"/>
-    <p:sldId xmlns:r="http://schemas.openxmlformats.org/officeDocument/2006/relationships" id="264" r:id="R5cd74636e71d4f88"/>
-    <p:sldId xmlns:r="http://schemas.openxmlformats.org/officeDocument/2006/relationships" id="265" r:id="R73de9f88b01244f2"/>
-    <p:sldId xmlns:r="http://schemas.openxmlformats.org/officeDocument/2006/relationships" id="266" r:id="Ra140f2dc546b4d24"/>
-    <p:sldId xmlns:r="http://schemas.openxmlformats.org/officeDocument/2006/relationships" id="267" r:id="Rc3b53cc3a80043b3"/>
-    <p:sldId xmlns:r="http://schemas.openxmlformats.org/officeDocument/2006/relationships" id="268" r:id="R9358c59c84084761"/>
+    <p:sldId xmlns:r="http://schemas.openxmlformats.org/officeDocument/2006/relationships" id="256" r:id="R35dc487279ed4315"/>
+    <p:sldId xmlns:r="http://schemas.openxmlformats.org/officeDocument/2006/relationships" id="257" r:id="R7ec74915d26d41f7"/>
+    <p:sldId xmlns:r="http://schemas.openxmlformats.org/officeDocument/2006/relationships" id="258" r:id="R3bd9d93173214da9"/>
+    <p:sldId xmlns:r="http://schemas.openxmlformats.org/officeDocument/2006/relationships" id="259" r:id="R472830e62d9f4c10"/>
+    <p:sldId xmlns:r="http://schemas.openxmlformats.org/officeDocument/2006/relationships" id="260" r:id="R4eaf20258f42467d"/>
+    <p:sldId xmlns:r="http://schemas.openxmlformats.org/officeDocument/2006/relationships" id="261" r:id="R7850409614bb4468"/>
+    <p:sldId xmlns:r="http://schemas.openxmlformats.org/officeDocument/2006/relationships" id="262" r:id="R2a2402b9870d486d"/>
+    <p:sldId xmlns:r="http://schemas.openxmlformats.org/officeDocument/2006/relationships" id="263" r:id="R3b7ffea66d0643a4"/>
+    <p:sldId xmlns:r="http://schemas.openxmlformats.org/officeDocument/2006/relationships" id="264" r:id="R17bd03368f8b4fdd"/>
+    <p:sldId xmlns:r="http://schemas.openxmlformats.org/officeDocument/2006/relationships" id="265" r:id="R11e4c8c770bf400e"/>
+    <p:sldId xmlns:r="http://schemas.openxmlformats.org/officeDocument/2006/relationships" id="266" r:id="R73a0bba2eb3e49b1"/>
+    <p:sldId xmlns:r="http://schemas.openxmlformats.org/officeDocument/2006/relationships" id="267" r:id="R3710bcfe19a6493b"/>
+    <p:sldId xmlns:r="http://schemas.openxmlformats.org/officeDocument/2006/relationships" id="268" r:id="R2ec5b36578e94441"/>
   </p:sldIdLst>
   <p:sldSz cx="12192000" cy="6858000"/>
   <p:notesSz cx="6858000" cy="9144000"/>
@@ -1405,7 +1405,7 @@
   </p:cSld>
   <p:clrMap bg1="lt1" tx1="dk1" bg2="lt2" tx2="dk2" accent1="accent1" accent2="accent2" accent3="accent3" accent4="accent4" accent5="accent5" accent6="accent6" hlink="hlink" folHlink="folHlink"/>
   <p:sldLayoutIdLst>
-    <p:sldLayoutId xmlns:r="http://schemas.openxmlformats.org/officeDocument/2006/relationships" id="2147483649" r:id="Rc256343576fa4f1b"/>
+    <p:sldLayoutId xmlns:r="http://schemas.openxmlformats.org/officeDocument/2006/relationships" id="2147483649" r:id="Ra609178ca0244ad9"/>
   </p:sldLayoutIdLst>
   <p:txStyles>
     <p:titleStyle>
@@ -1956,7 +1956,7 @@
           <p:cNvPr id="1" name="">
             <a:extLst xmlns:a="http://schemas.openxmlformats.org/drawingml/2006/main">
               <a:ext uri="{FF2B5EF4-FFF2-40B4-BE49-F238E27FC236}">
-                <a16:creationId xmlns:a16="http://schemas.microsoft.com/office/drawing/2014/main" id="{CD7432BB-FAFD-488F-B5EF-FA91C73C864E}"/>
+                <a16:creationId xmlns:a16="http://schemas.microsoft.com/office/drawing/2014/main" id="{E87364A6-4F77-43C4-8C11-1E131D8D9D69}"/>
               </a:ext>
             </a:extLst>
           </p:cNvPr>
@@ -2006,7 +2006,7 @@
           <p:cNvPr id="2" name="">
             <a:extLst xmlns:a="http://schemas.openxmlformats.org/drawingml/2006/main">
               <a:ext uri="{FF2B5EF4-FFF2-40B4-BE49-F238E27FC236}">
-                <a16:creationId xmlns:a16="http://schemas.microsoft.com/office/drawing/2014/main" id="{78EB7A2C-26E9-4EE0-8595-D70FB2191E93}"/>
+                <a16:creationId xmlns:a16="http://schemas.microsoft.com/office/drawing/2014/main" id="{93C18329-1EEE-4292-B04B-CA68045F1349}"/>
               </a:ext>
             </a:extLst>
           </p:cNvPr>
@@ -2056,7 +2056,7 @@
           <p:cNvPr id="3" name="">
             <a:extLst xmlns:a="http://schemas.openxmlformats.org/drawingml/2006/main">
               <a:ext uri="{FF2B5EF4-FFF2-40B4-BE49-F238E27FC236}">
-                <a16:creationId xmlns:a16="http://schemas.microsoft.com/office/drawing/2014/main" id="{CC424796-013C-49C5-9538-B151831C53D1}"/>
+                <a16:creationId xmlns:a16="http://schemas.microsoft.com/office/drawing/2014/main" id="{FA5EBBAC-189B-48E7-8871-FB40AC9EC386}"/>
               </a:ext>
             </a:extLst>
           </p:cNvPr>
@@ -2089,7 +2089,7 @@
           <p:cNvPr id="4" name="">
             <a:extLst xmlns:a="http://schemas.openxmlformats.org/drawingml/2006/main">
               <a:ext uri="{FF2B5EF4-FFF2-40B4-BE49-F238E27FC236}">
-                <a16:creationId xmlns:a16="http://schemas.microsoft.com/office/drawing/2014/main" id="{731CB27F-6569-4565-A119-0B104E31A74D}"/>
+                <a16:creationId xmlns:a16="http://schemas.microsoft.com/office/drawing/2014/main" id="{C6079E56-ACAB-485B-9880-AA8B375BBEB1}"/>
               </a:ext>
             </a:extLst>
           </p:cNvPr>
@@ -2129,7 +2129,7 @@
                   <a:srgbClr val="2F7D55"/>
                 </a:solidFill>
               </a:rPr>
-              <a:t>98.83%</a:t>
+              <a:t>98.87%</a:t>
             </a:r>
           </a:p>
         </p:txBody>
@@ -2139,7 +2139,7 @@
           <p:cNvPr id="5" name="">
             <a:extLst xmlns:a="http://schemas.openxmlformats.org/drawingml/2006/main">
               <a:ext uri="{FF2B5EF4-FFF2-40B4-BE49-F238E27FC236}">
-                <a16:creationId xmlns:a16="http://schemas.microsoft.com/office/drawing/2014/main" id="{FDD97C79-E101-4811-A082-9B8E258F1644}"/>
+                <a16:creationId xmlns:a16="http://schemas.microsoft.com/office/drawing/2014/main" id="{AF7E8867-AE30-4E01-94D1-DA9FE7DADA37}"/>
               </a:ext>
             </a:extLst>
           </p:cNvPr>
@@ -2189,7 +2189,7 @@
           <p:cNvPr id="6" name="">
             <a:extLst xmlns:a="http://schemas.openxmlformats.org/drawingml/2006/main">
               <a:ext uri="{FF2B5EF4-FFF2-40B4-BE49-F238E27FC236}">
-                <a16:creationId xmlns:a16="http://schemas.microsoft.com/office/drawing/2014/main" id="{30040D29-DD1C-4077-A1E8-1AA461358125}"/>
+                <a16:creationId xmlns:a16="http://schemas.microsoft.com/office/drawing/2014/main" id="{3E43531B-A7E2-482E-9A04-E455CF791B4D}"/>
               </a:ext>
             </a:extLst>
           </p:cNvPr>
@@ -2222,7 +2222,7 @@
           <p:cNvPr id="7" name="">
             <a:extLst xmlns:a="http://schemas.openxmlformats.org/drawingml/2006/main">
               <a:ext uri="{FF2B5EF4-FFF2-40B4-BE49-F238E27FC236}">
-                <a16:creationId xmlns:a16="http://schemas.microsoft.com/office/drawing/2014/main" id="{3D381DD9-0638-4BCD-AC37-86CFBF959622}"/>
+                <a16:creationId xmlns:a16="http://schemas.microsoft.com/office/drawing/2014/main" id="{D5530D17-A326-4761-AC09-09C40F6E8EB3}"/>
               </a:ext>
             </a:extLst>
           </p:cNvPr>
@@ -2262,7 +2262,7 @@
                   <a:srgbClr val="0A0A0A"/>
                 </a:solidFill>
               </a:rPr>
-              <a:t>61,706</a:t>
+              <a:t>60,000</a:t>
             </a:r>
           </a:p>
         </p:txBody>
@@ -2272,7 +2272,7 @@
           <p:cNvPr id="8" name="">
             <a:extLst xmlns:a="http://schemas.openxmlformats.org/drawingml/2006/main">
               <a:ext uri="{FF2B5EF4-FFF2-40B4-BE49-F238E27FC236}">
-                <a16:creationId xmlns:a16="http://schemas.microsoft.com/office/drawing/2014/main" id="{D296B756-7B09-4163-9336-14B521875A04}"/>
+                <a16:creationId xmlns:a16="http://schemas.microsoft.com/office/drawing/2014/main" id="{32DDEB45-28F6-4DDA-85B6-8AD43886B69F}"/>
               </a:ext>
             </a:extLst>
           </p:cNvPr>
@@ -2322,7 +2322,7 @@
           <p:cNvPr id="9" name="">
             <a:extLst xmlns:a="http://schemas.openxmlformats.org/drawingml/2006/main">
               <a:ext uri="{FF2B5EF4-FFF2-40B4-BE49-F238E27FC236}">
-                <a16:creationId xmlns:a16="http://schemas.microsoft.com/office/drawing/2014/main" id="{FD68A3CC-4661-42CC-8A42-714A4FE76779}"/>
+                <a16:creationId xmlns:a16="http://schemas.microsoft.com/office/drawing/2014/main" id="{2A988E64-EABA-4950-B151-8E39C67427E6}"/>
               </a:ext>
             </a:extLst>
           </p:cNvPr>
@@ -2355,7 +2355,7 @@
           <p:cNvPr id="10" name="">
             <a:extLst xmlns:a="http://schemas.openxmlformats.org/drawingml/2006/main">
               <a:ext uri="{FF2B5EF4-FFF2-40B4-BE49-F238E27FC236}">
-                <a16:creationId xmlns:a16="http://schemas.microsoft.com/office/drawing/2014/main" id="{915D1B19-A382-4EED-B2BF-6A6589A221E3}"/>
+                <a16:creationId xmlns:a16="http://schemas.microsoft.com/office/drawing/2014/main" id="{B4F9E9F0-BA06-49A5-9F68-0E19DC1F832F}"/>
               </a:ext>
             </a:extLst>
           </p:cNvPr>
@@ -2395,7 +2395,7 @@
                   <a:srgbClr val="2E6F9E"/>
                 </a:solidFill>
               </a:rPr>
-              <a:t>16.81s</a:t>
+              <a:t>125.94s</a:t>
             </a:r>
           </a:p>
         </p:txBody>
@@ -2405,7 +2405,7 @@
           <p:cNvPr id="11" name="">
             <a:extLst xmlns:a="http://schemas.openxmlformats.org/drawingml/2006/main">
               <a:ext uri="{FF2B5EF4-FFF2-40B4-BE49-F238E27FC236}">
-                <a16:creationId xmlns:a16="http://schemas.microsoft.com/office/drawing/2014/main" id="{6E5C1090-9605-483E-BBB7-9F82376D34D4}"/>
+                <a16:creationId xmlns:a16="http://schemas.microsoft.com/office/drawing/2014/main" id="{AB87B562-C550-41C4-A989-AE5C376F4272}"/>
               </a:ext>
             </a:extLst>
           </p:cNvPr>
@@ -2455,7 +2455,7 @@
           <p:cNvPr id="12" name="">
             <a:extLst xmlns:a="http://schemas.openxmlformats.org/drawingml/2006/main">
               <a:ext uri="{FF2B5EF4-FFF2-40B4-BE49-F238E27FC236}">
-                <a16:creationId xmlns:a16="http://schemas.microsoft.com/office/drawing/2014/main" id="{1EC4443C-D12F-40A4-B922-45A8A9AC9E18}"/>
+                <a16:creationId xmlns:a16="http://schemas.microsoft.com/office/drawing/2014/main" id="{87D550C6-89E8-4378-A88F-9E6A34E3D54F}"/>
               </a:ext>
             </a:extLst>
           </p:cNvPr>
@@ -2505,7 +2505,7 @@
           <p:cNvPr id="13" name="">
             <a:extLst xmlns:a="http://schemas.openxmlformats.org/drawingml/2006/main">
               <a:ext uri="{FF2B5EF4-FFF2-40B4-BE49-F238E27FC236}">
-                <a16:creationId xmlns:a16="http://schemas.microsoft.com/office/drawing/2014/main" id="{B0C5DEFA-DEBE-4F78-B263-95776FF530FF}"/>
+                <a16:creationId xmlns:a16="http://schemas.microsoft.com/office/drawing/2014/main" id="{5F962E72-AD5C-4155-B847-4925F35DEE9F}"/>
               </a:ext>
             </a:extLst>
           </p:cNvPr>
@@ -2553,7 +2553,7 @@
     </p:spTree>
     <p:extLst>
       <p:ext uri="{BB962C8B-B14F-4D97-AF65-F5344CB8AC3E}">
-        <p14:creationId xmlns:p14="http://schemas.microsoft.com/office/powerpoint/2010/main" val="592592796"/>
+        <p14:creationId xmlns:p14="http://schemas.microsoft.com/office/powerpoint/2010/main" val="941268152"/>
       </p:ext>
     </p:extLst>
   </p:cSld>
@@ -2584,7 +2584,7 @@
           <p:cNvPr id="1" name="">
             <a:extLst xmlns:a="http://schemas.openxmlformats.org/drawingml/2006/main">
               <a:ext uri="{FF2B5EF4-FFF2-40B4-BE49-F238E27FC236}">
-                <a16:creationId xmlns:a16="http://schemas.microsoft.com/office/drawing/2014/main" id="{5D4AA5D5-9FE0-4FF6-8171-92154E09DE02}"/>
+                <a16:creationId xmlns:a16="http://schemas.microsoft.com/office/drawing/2014/main" id="{A92FC968-1146-4A20-B4C6-CE8B729130FA}"/>
               </a:ext>
             </a:extLst>
           </p:cNvPr>
@@ -2624,7 +2624,7 @@
                   <a:srgbClr val="0A0A0A"/>
                 </a:solidFill>
               </a:rPr>
-              <a:t>We came close to the paper, but did not overclaim</a:t>
+              <a:t>We matched the historical range, but not the best run</a:t>
             </a:r>
           </a:p>
         </p:txBody>
@@ -2634,7 +2634,7 @@
           <p:cNvPr id="2" name="">
             <a:extLst xmlns:a="http://schemas.openxmlformats.org/drawingml/2006/main">
               <a:ext uri="{FF2B5EF4-FFF2-40B4-BE49-F238E27FC236}">
-                <a16:creationId xmlns:a16="http://schemas.microsoft.com/office/drawing/2014/main" id="{1F654D07-C103-4A15-B247-2326207C3016}"/>
+                <a16:creationId xmlns:a16="http://schemas.microsoft.com/office/drawing/2014/main" id="{BB55A6C3-D409-48D0-8A0E-019CAA743EAE}"/>
               </a:ext>
             </a:extLst>
           </p:cNvPr>
@@ -2674,7 +2674,7 @@
                   <a:srgbClr val="555555"/>
                 </a:solidFill>
               </a:rPr>
-              <a:t>LeCun et al. reported about 0.8% MNIST test error for LeNet-5.</a:t>
+              <a:t>LeCun et al. reported about 0.8-0.95% MNIST test error for LeNet-5.</a:t>
             </a:r>
           </a:p>
         </p:txBody>
@@ -2684,7 +2684,7 @@
           <p:cNvPr id="3" name="">
             <a:extLst xmlns:a="http://schemas.openxmlformats.org/drawingml/2006/main">
               <a:ext uri="{FF2B5EF4-FFF2-40B4-BE49-F238E27FC236}">
-                <a16:creationId xmlns:a16="http://schemas.microsoft.com/office/drawing/2014/main" id="{4F4F561E-9A59-4444-8A2A-6E782BE76668}"/>
+                <a16:creationId xmlns:a16="http://schemas.microsoft.com/office/drawing/2014/main" id="{A8DA1DBA-B763-4915-8431-F422CDDCA03A}"/>
               </a:ext>
             </a:extLst>
           </p:cNvPr>
@@ -2717,7 +2717,7 @@
           <p:cNvPr id="4" name="">
             <a:extLst xmlns:a="http://schemas.openxmlformats.org/drawingml/2006/main">
               <a:ext uri="{FF2B5EF4-FFF2-40B4-BE49-F238E27FC236}">
-                <a16:creationId xmlns:a16="http://schemas.microsoft.com/office/drawing/2014/main" id="{618564DD-61AC-4AB4-9C60-8B8F98ACD570}"/>
+                <a16:creationId xmlns:a16="http://schemas.microsoft.com/office/drawing/2014/main" id="{A7B29F52-95C6-4CD2-8697-391E96AAFF80}"/>
               </a:ext>
             </a:extLst>
           </p:cNvPr>
@@ -2750,7 +2750,7 @@
           <p:cNvPr id="5" name="">
             <a:extLst xmlns:a="http://schemas.openxmlformats.org/drawingml/2006/main">
               <a:ext uri="{FF2B5EF4-FFF2-40B4-BE49-F238E27FC236}">
-                <a16:creationId xmlns:a16="http://schemas.microsoft.com/office/drawing/2014/main" id="{F0D73012-0047-4AF1-857C-298F3F20D642}"/>
+                <a16:creationId xmlns:a16="http://schemas.microsoft.com/office/drawing/2014/main" id="{5CA7EDB4-D366-4758-BFE6-8D00325FEE7D}"/>
               </a:ext>
             </a:extLst>
           </p:cNvPr>
@@ -2790,7 +2790,7 @@
                   <a:srgbClr val="2F7D55"/>
                 </a:solidFill>
               </a:rPr>
-              <a:t>0.8%</a:t>
+              <a:t>0.8-0.95%</a:t>
             </a:r>
           </a:p>
         </p:txBody>
@@ -2800,7 +2800,7 @@
           <p:cNvPr id="6" name="">
             <a:extLst xmlns:a="http://schemas.openxmlformats.org/drawingml/2006/main">
               <a:ext uri="{FF2B5EF4-FFF2-40B4-BE49-F238E27FC236}">
-                <a16:creationId xmlns:a16="http://schemas.microsoft.com/office/drawing/2014/main" id="{A023A619-4CF7-4D24-8C1D-64908FE6F5E1}"/>
+                <a16:creationId xmlns:a16="http://schemas.microsoft.com/office/drawing/2014/main" id="{64A2CAAC-29CD-402B-824A-9B7ADFEAEAC3}"/>
               </a:ext>
             </a:extLst>
           </p:cNvPr>
@@ -2850,7 +2850,7 @@
           <p:cNvPr id="7" name="">
             <a:extLst xmlns:a="http://schemas.openxmlformats.org/drawingml/2006/main">
               <a:ext uri="{FF2B5EF4-FFF2-40B4-BE49-F238E27FC236}">
-                <a16:creationId xmlns:a16="http://schemas.microsoft.com/office/drawing/2014/main" id="{88BD807B-0D08-496F-90DF-82E909D9E01A}"/>
+                <a16:creationId xmlns:a16="http://schemas.microsoft.com/office/drawing/2014/main" id="{6BD62708-C216-4F46-AC56-F007BC2E7DCE}"/>
               </a:ext>
             </a:extLst>
           </p:cNvPr>
@@ -2883,7 +2883,7 @@
           <p:cNvPr id="8" name="">
             <a:extLst xmlns:a="http://schemas.openxmlformats.org/drawingml/2006/main">
               <a:ext uri="{FF2B5EF4-FFF2-40B4-BE49-F238E27FC236}">
-                <a16:creationId xmlns:a16="http://schemas.microsoft.com/office/drawing/2014/main" id="{FD4EA7B7-C30D-4B9C-9552-D190E855B88F}"/>
+                <a16:creationId xmlns:a16="http://schemas.microsoft.com/office/drawing/2014/main" id="{C95B4B47-79BD-488B-BAE6-347D0A54C1FD}"/>
               </a:ext>
             </a:extLst>
           </p:cNvPr>
@@ -2923,7 +2923,7 @@
                   <a:srgbClr val="FF6B35"/>
                 </a:solidFill>
               </a:rPr>
-              <a:t>1.17%</a:t>
+              <a:t>1.13%</a:t>
             </a:r>
           </a:p>
         </p:txBody>
@@ -2933,7 +2933,7 @@
           <p:cNvPr id="9" name="">
             <a:extLst xmlns:a="http://schemas.openxmlformats.org/drawingml/2006/main">
               <a:ext uri="{FF2B5EF4-FFF2-40B4-BE49-F238E27FC236}">
-                <a16:creationId xmlns:a16="http://schemas.microsoft.com/office/drawing/2014/main" id="{E75C82B8-23F3-4E18-ADA2-613E1101F2B0}"/>
+                <a16:creationId xmlns:a16="http://schemas.microsoft.com/office/drawing/2014/main" id="{4BD3DCC5-8AED-4F24-B305-F17BE59FBA16}"/>
               </a:ext>
             </a:extLst>
           </p:cNvPr>
@@ -2983,7 +2983,7 @@
           <p:cNvPr id="10" name="">
             <a:extLst xmlns:a="http://schemas.openxmlformats.org/drawingml/2006/main">
               <a:ext uri="{FF2B5EF4-FFF2-40B4-BE49-F238E27FC236}">
-                <a16:creationId xmlns:a16="http://schemas.microsoft.com/office/drawing/2014/main" id="{98313D57-2BAF-4801-BAE9-02B05F668D76}"/>
+                <a16:creationId xmlns:a16="http://schemas.microsoft.com/office/drawing/2014/main" id="{C3A320F1-5532-422C-9123-1EFC7F47EB0B}"/>
               </a:ext>
             </a:extLst>
           </p:cNvPr>
@@ -3023,7 +3023,7 @@
                   <a:srgbClr val="0A0A0A"/>
                 </a:solidFill>
               </a:rPr>
-              <a:t>Gap: 0.37 percentage points. The result is close, but not within the 0.2 percentage-point wow target.</a:t>
+              <a:t>Gap: 0.18 points vs. the 0.95% run; 0.33 points vs. the best 0.8% figure.</a:t>
             </a:r>
           </a:p>
         </p:txBody>
@@ -3033,7 +3033,7 @@
           <p:cNvPr id="11" name="">
             <a:extLst xmlns:a="http://schemas.openxmlformats.org/drawingml/2006/main">
               <a:ext uri="{FF2B5EF4-FFF2-40B4-BE49-F238E27FC236}">
-                <a16:creationId xmlns:a16="http://schemas.microsoft.com/office/drawing/2014/main" id="{6AA11D44-9575-4DAD-AE45-CB4FAE652121}"/>
+                <a16:creationId xmlns:a16="http://schemas.microsoft.com/office/drawing/2014/main" id="{6740A86E-1D0B-4A3B-921A-D99B6145BA63}"/>
               </a:ext>
             </a:extLst>
           </p:cNvPr>
@@ -3081,7 +3081,7 @@
     </p:spTree>
     <p:extLst>
       <p:ext uri="{BB962C8B-B14F-4D97-AF65-F5344CB8AC3E}">
-        <p14:creationId xmlns:p14="http://schemas.microsoft.com/office/powerpoint/2010/main" val="238525974"/>
+        <p14:creationId xmlns:p14="http://schemas.microsoft.com/office/powerpoint/2010/main" val="641630493"/>
       </p:ext>
     </p:extLst>
   </p:cSld>
@@ -3112,7 +3112,7 @@
           <p:cNvPr id="1" name="">
             <a:extLst xmlns:a="http://schemas.openxmlformats.org/drawingml/2006/main">
               <a:ext uri="{FF2B5EF4-FFF2-40B4-BE49-F238E27FC236}">
-                <a16:creationId xmlns:a16="http://schemas.microsoft.com/office/drawing/2014/main" id="{7A4FE5B1-639F-4E93-BBC3-84F2204AE5CE}"/>
+                <a16:creationId xmlns:a16="http://schemas.microsoft.com/office/drawing/2014/main" id="{B24A076D-3226-406E-9920-D8431965176C}"/>
               </a:ext>
             </a:extLst>
           </p:cNvPr>
@@ -3162,7 +3162,7 @@
           <p:cNvPr id="2" name="">
             <a:extLst xmlns:a="http://schemas.openxmlformats.org/drawingml/2006/main">
               <a:ext uri="{FF2B5EF4-FFF2-40B4-BE49-F238E27FC236}">
-                <a16:creationId xmlns:a16="http://schemas.microsoft.com/office/drawing/2014/main" id="{B86070C6-5B78-42BE-A638-170CB67D28D1}"/>
+                <a16:creationId xmlns:a16="http://schemas.microsoft.com/office/drawing/2014/main" id="{970CD50A-9B35-43FC-A2DC-E09B65B9F448}"/>
               </a:ext>
             </a:extLst>
           </p:cNvPr>
@@ -3212,7 +3212,7 @@
           <p:cNvPr id="3" name="">
             <a:extLst xmlns:a="http://schemas.openxmlformats.org/drawingml/2006/main">
               <a:ext uri="{FF2B5EF4-FFF2-40B4-BE49-F238E27FC236}">
-                <a16:creationId xmlns:a16="http://schemas.microsoft.com/office/drawing/2014/main" id="{7E73C6AC-4716-42A0-AFD2-D7242C1FFB15}"/>
+                <a16:creationId xmlns:a16="http://schemas.microsoft.com/office/drawing/2014/main" id="{45A27523-8077-46C9-8822-67E9952311A4}"/>
               </a:ext>
             </a:extLst>
           </p:cNvPr>
@@ -3245,7 +3245,7 @@
           <p:cNvPr id="4" name="">
             <a:extLst xmlns:a="http://schemas.openxmlformats.org/drawingml/2006/main">
               <a:ext uri="{FF2B5EF4-FFF2-40B4-BE49-F238E27FC236}">
-                <a16:creationId xmlns:a16="http://schemas.microsoft.com/office/drawing/2014/main" id="{5AD56D7C-5BAA-467C-AD4C-8CA06CF81334}"/>
+                <a16:creationId xmlns:a16="http://schemas.microsoft.com/office/drawing/2014/main" id="{BFBC8D50-786C-46C7-BD2B-6F59AEC858F7}"/>
               </a:ext>
             </a:extLst>
           </p:cNvPr>
@@ -3278,7 +3278,7 @@
           <p:cNvPr id="5" name="">
             <a:extLst xmlns:a="http://schemas.openxmlformats.org/drawingml/2006/main">
               <a:ext uri="{FF2B5EF4-FFF2-40B4-BE49-F238E27FC236}">
-                <a16:creationId xmlns:a16="http://schemas.microsoft.com/office/drawing/2014/main" id="{4E50C9C3-C68F-474C-875C-6DD0D72172A2}"/>
+                <a16:creationId xmlns:a16="http://schemas.microsoft.com/office/drawing/2014/main" id="{6F47A27E-844A-426F-889B-FF9515D814EF}"/>
               </a:ext>
             </a:extLst>
           </p:cNvPr>
@@ -3328,7 +3328,7 @@
           <p:cNvPr id="6" name="">
             <a:extLst xmlns:a="http://schemas.openxmlformats.org/drawingml/2006/main">
               <a:ext uri="{FF2B5EF4-FFF2-40B4-BE49-F238E27FC236}">
-                <a16:creationId xmlns:a16="http://schemas.microsoft.com/office/drawing/2014/main" id="{B3B9DB16-F9B5-41B1-8A40-E543AB150092}"/>
+                <a16:creationId xmlns:a16="http://schemas.microsoft.com/office/drawing/2014/main" id="{E109BA68-40DE-4439-8C7E-BD8178B02EC2}"/>
               </a:ext>
             </a:extLst>
           </p:cNvPr>
@@ -3446,7 +3446,7 @@
           <p:cNvPr id="7" name="">
             <a:extLst xmlns:a="http://schemas.openxmlformats.org/drawingml/2006/main">
               <a:ext uri="{FF2B5EF4-FFF2-40B4-BE49-F238E27FC236}">
-                <a16:creationId xmlns:a16="http://schemas.microsoft.com/office/drawing/2014/main" id="{615E81DA-58CD-4709-AB31-F5297FD07B92}"/>
+                <a16:creationId xmlns:a16="http://schemas.microsoft.com/office/drawing/2014/main" id="{88CEA6A4-C6D0-49F6-BA88-3D6CC80927CE}"/>
               </a:ext>
             </a:extLst>
           </p:cNvPr>
@@ -3479,7 +3479,7 @@
           <p:cNvPr id="8" name="">
             <a:extLst xmlns:a="http://schemas.openxmlformats.org/drawingml/2006/main">
               <a:ext uri="{FF2B5EF4-FFF2-40B4-BE49-F238E27FC236}">
-                <a16:creationId xmlns:a16="http://schemas.microsoft.com/office/drawing/2014/main" id="{538FE84F-A392-4736-979A-AE4B920A1994}"/>
+                <a16:creationId xmlns:a16="http://schemas.microsoft.com/office/drawing/2014/main" id="{6751807D-4C27-481A-8261-95EC6D3721DD}"/>
               </a:ext>
             </a:extLst>
           </p:cNvPr>
@@ -3529,7 +3529,7 @@
           <p:cNvPr id="9" name="">
             <a:extLst xmlns:a="http://schemas.openxmlformats.org/drawingml/2006/main">
               <a:ext uri="{FF2B5EF4-FFF2-40B4-BE49-F238E27FC236}">
-                <a16:creationId xmlns:a16="http://schemas.microsoft.com/office/drawing/2014/main" id="{3FC64E7C-84BF-4319-B710-B71BB9E9A73D}"/>
+                <a16:creationId xmlns:a16="http://schemas.microsoft.com/office/drawing/2014/main" id="{595578D0-04C1-4D22-BC89-A560EBDECD55}"/>
               </a:ext>
             </a:extLst>
           </p:cNvPr>
@@ -3569,7 +3569,7 @@
                   <a:srgbClr val="0A0A0A"/>
                 </a:solidFill>
               </a:rPr>
-              <a:t>28x28 inputs</a:t>
+              <a:t>32x32 padded inputs</a:t>
             </a:r>
           </a:p>
           <a:p xmlns:a="http://schemas.openxmlformats.org/drawingml/2006/main">
@@ -3586,7 +3586,7 @@
                   <a:srgbClr val="0A0A0A"/>
                 </a:solidFill>
               </a:rPr>
-              <a:t>Dense convolution</a:t>
+              <a:t>Partial C3 connectivity</a:t>
             </a:r>
           </a:p>
           <a:p xmlns:a="http://schemas.openxmlformats.org/drawingml/2006/main">
@@ -3603,7 +3603,7 @@
                   <a:srgbClr val="0A0A0A"/>
                 </a:solidFill>
               </a:rPr>
-              <a:t>Linear logits + cross-entropy</a:t>
+              <a:t>Fixed RBF output</a:t>
             </a:r>
           </a:p>
           <a:p xmlns:a="http://schemas.openxmlformats.org/drawingml/2006/main">
@@ -3620,7 +3620,7 @@
                   <a:srgbClr val="0A0A0A"/>
                 </a:solidFill>
               </a:rPr>
-              <a:t>Adam optimizer</a:t>
+              <a:t>MAP-style loss</a:t>
             </a:r>
           </a:p>
           <a:p xmlns:a="http://schemas.openxmlformats.org/drawingml/2006/main">
@@ -3637,7 +3637,7 @@
                   <a:srgbClr val="0A0A0A"/>
                 </a:solidFill>
               </a:rPr>
-              <a:t>No augmentation</a:t>
+              <a:t>Adam optimizer</a:t>
             </a:r>
           </a:p>
         </p:txBody>
@@ -3647,7 +3647,7 @@
           <p:cNvPr id="10" name="">
             <a:extLst xmlns:a="http://schemas.openxmlformats.org/drawingml/2006/main">
               <a:ext uri="{FF2B5EF4-FFF2-40B4-BE49-F238E27FC236}">
-                <a16:creationId xmlns:a16="http://schemas.microsoft.com/office/drawing/2014/main" id="{DECD5900-9A5B-496C-925C-3AB42EEB5375}"/>
+                <a16:creationId xmlns:a16="http://schemas.microsoft.com/office/drawing/2014/main" id="{5E896A4E-D648-4E90-970F-C99C46ECFC31}"/>
               </a:ext>
             </a:extLst>
           </p:cNvPr>
@@ -3680,7 +3680,7 @@
           <p:cNvPr id="11" name="">
             <a:extLst xmlns:a="http://schemas.openxmlformats.org/drawingml/2006/main">
               <a:ext uri="{FF2B5EF4-FFF2-40B4-BE49-F238E27FC236}">
-                <a16:creationId xmlns:a16="http://schemas.microsoft.com/office/drawing/2014/main" id="{F243C587-73FE-4234-BD09-BC812A0D21E2}"/>
+                <a16:creationId xmlns:a16="http://schemas.microsoft.com/office/drawing/2014/main" id="{32DA2B00-C203-4D5A-8269-83ED50FDBEB6}"/>
               </a:ext>
             </a:extLst>
           </p:cNvPr>
@@ -3730,7 +3730,7 @@
           <p:cNvPr id="12" name="">
             <a:extLst xmlns:a="http://schemas.openxmlformats.org/drawingml/2006/main">
               <a:ext uri="{FF2B5EF4-FFF2-40B4-BE49-F238E27FC236}">
-                <a16:creationId xmlns:a16="http://schemas.microsoft.com/office/drawing/2014/main" id="{3FC863E8-0C33-4542-9CC3-A2959A337CC9}"/>
+                <a16:creationId xmlns:a16="http://schemas.microsoft.com/office/drawing/2014/main" id="{062A0008-4F33-4FC8-A5BE-DD16FCD40FC8}"/>
               </a:ext>
             </a:extLst>
           </p:cNvPr>
@@ -3770,7 +3770,7 @@
                   <a:srgbClr val="0A0A0A"/>
                 </a:solidFill>
               </a:rPr>
-              <a:t>Simpler code</a:t>
+              <a:t>Historical architecture</a:t>
             </a:r>
           </a:p>
           <a:p xmlns:a="http://schemas.openxmlformats.org/drawingml/2006/main">
@@ -3787,7 +3787,7 @@
                   <a:srgbClr val="0A0A0A"/>
                 </a:solidFill>
               </a:rPr>
-              <a:t>Fast final run</a:t>
+              <a:t>60,000 parameters</a:t>
             </a:r>
           </a:p>
           <a:p xmlns:a="http://schemas.openxmlformats.org/drawingml/2006/main">
@@ -3804,7 +3804,7 @@
                   <a:srgbClr val="0A0A0A"/>
                 </a:solidFill>
               </a:rPr>
-              <a:t>Easy PyTorch demo</a:t>
+              <a:t>Clear comparison</a:t>
             </a:r>
           </a:p>
           <a:p xmlns:a="http://schemas.openxmlformats.org/drawingml/2006/main">
@@ -3821,7 +3821,7 @@
                   <a:srgbClr val="0A0A0A"/>
                 </a:solidFill>
               </a:rPr>
-              <a:t>Slightly higher error</a:t>
+              <a:t>Still easy to run</a:t>
             </a:r>
           </a:p>
           <a:p xmlns:a="http://schemas.openxmlformats.org/drawingml/2006/main">
@@ -3838,7 +3838,7 @@
                   <a:srgbClr val="0A0A0A"/>
                 </a:solidFill>
               </a:rPr>
-              <a:t>Clear limitations</a:t>
+              <a:t>Honest limitations</a:t>
             </a:r>
           </a:p>
         </p:txBody>
@@ -3848,7 +3848,7 @@
           <p:cNvPr id="13" name="">
             <a:extLst xmlns:a="http://schemas.openxmlformats.org/drawingml/2006/main">
               <a:ext uri="{FF2B5EF4-FFF2-40B4-BE49-F238E27FC236}">
-                <a16:creationId xmlns:a16="http://schemas.microsoft.com/office/drawing/2014/main" id="{0D33FB3D-4F09-47CA-BAF9-8A8D49131943}"/>
+                <a16:creationId xmlns:a16="http://schemas.microsoft.com/office/drawing/2014/main" id="{AA34D1E8-B2D6-49D4-B0AA-A9DFD1553D49}"/>
               </a:ext>
             </a:extLst>
           </p:cNvPr>
@@ -3896,7 +3896,7 @@
     </p:spTree>
     <p:extLst>
       <p:ext uri="{BB962C8B-B14F-4D97-AF65-F5344CB8AC3E}">
-        <p14:creationId xmlns:p14="http://schemas.microsoft.com/office/powerpoint/2010/main" val="320219404"/>
+        <p14:creationId xmlns:p14="http://schemas.microsoft.com/office/powerpoint/2010/main" val="484243888"/>
       </p:ext>
     </p:extLst>
   </p:cSld>
@@ -3927,7 +3927,7 @@
           <p:cNvPr id="1" name="">
             <a:extLst xmlns:a="http://schemas.openxmlformats.org/drawingml/2006/main">
               <a:ext uri="{FF2B5EF4-FFF2-40B4-BE49-F238E27FC236}">
-                <a16:creationId xmlns:a16="http://schemas.microsoft.com/office/drawing/2014/main" id="{FF7A541E-B94B-4C94-92DA-897FA08D0E43}"/>
+                <a16:creationId xmlns:a16="http://schemas.microsoft.com/office/drawing/2014/main" id="{C5832B9E-2778-4213-967E-B769B219C580}"/>
               </a:ext>
             </a:extLst>
           </p:cNvPr>
@@ -3977,7 +3977,7 @@
           <p:cNvPr id="2" name="">
             <a:extLst xmlns:a="http://schemas.openxmlformats.org/drawingml/2006/main">
               <a:ext uri="{FF2B5EF4-FFF2-40B4-BE49-F238E27FC236}">
-                <a16:creationId xmlns:a16="http://schemas.microsoft.com/office/drawing/2014/main" id="{8E702319-ABF2-460E-9DAE-84E306A36DE5}"/>
+                <a16:creationId xmlns:a16="http://schemas.microsoft.com/office/drawing/2014/main" id="{C96E1597-2D8C-45DF-B132-0138234500E1}"/>
               </a:ext>
             </a:extLst>
           </p:cNvPr>
@@ -4017,7 +4017,7 @@
                   <a:srgbClr val="555555"/>
                 </a:solidFill>
               </a:rPr>
-              <a:t>The modern baseline improves accuracy by 0.35 percentage points, but with a much larger model.</a:t>
+              <a:t>The modern baseline improves accuracy by 0.31 percentage points, but with a much larger model.</a:t>
             </a:r>
           </a:p>
         </p:txBody>
@@ -4027,7 +4027,7 @@
           <p:cNvPr id="3" name="">
             <a:extLst xmlns:a="http://schemas.openxmlformats.org/drawingml/2006/main">
               <a:ext uri="{FF2B5EF4-FFF2-40B4-BE49-F238E27FC236}">
-                <a16:creationId xmlns:a16="http://schemas.microsoft.com/office/drawing/2014/main" id="{BC21D88C-10A7-4A91-B3A9-6A2AFBCB3FA0}"/>
+                <a16:creationId xmlns:a16="http://schemas.microsoft.com/office/drawing/2014/main" id="{F0F137FB-1769-4F92-9CF1-BA8AAB8EEC1C}"/>
               </a:ext>
             </a:extLst>
           </p:cNvPr>
@@ -4060,7 +4060,7 @@
           <p:cNvPr id="4" name="">
             <a:extLst xmlns:a="http://schemas.openxmlformats.org/drawingml/2006/main">
               <a:ext uri="{FF2B5EF4-FFF2-40B4-BE49-F238E27FC236}">
-                <a16:creationId xmlns:a16="http://schemas.microsoft.com/office/drawing/2014/main" id="{DB202C17-7A71-4C2B-A72E-A26738641BB2}"/>
+                <a16:creationId xmlns:a16="http://schemas.microsoft.com/office/drawing/2014/main" id="{1F14917E-8F17-4A65-9D5B-80347757E8FC}"/>
               </a:ext>
             </a:extLst>
           </p:cNvPr>
@@ -4093,7 +4093,7 @@
           <p:cNvPr id="5" name="">
             <a:extLst xmlns:a="http://schemas.openxmlformats.org/drawingml/2006/main">
               <a:ext uri="{FF2B5EF4-FFF2-40B4-BE49-F238E27FC236}">
-                <a16:creationId xmlns:a16="http://schemas.microsoft.com/office/drawing/2014/main" id="{E6F67CF2-4EB1-461D-BD5A-4EBFB821FBC9}"/>
+                <a16:creationId xmlns:a16="http://schemas.microsoft.com/office/drawing/2014/main" id="{BB34BA42-B9D3-4217-8F93-BA371F016410}"/>
               </a:ext>
             </a:extLst>
           </p:cNvPr>
@@ -4143,7 +4143,7 @@
           <p:cNvPr id="6" name="">
             <a:extLst xmlns:a="http://schemas.openxmlformats.org/drawingml/2006/main">
               <a:ext uri="{FF2B5EF4-FFF2-40B4-BE49-F238E27FC236}">
-                <a16:creationId xmlns:a16="http://schemas.microsoft.com/office/drawing/2014/main" id="{A8552979-1015-4C48-A400-F6B2BCF840C0}"/>
+                <a16:creationId xmlns:a16="http://schemas.microsoft.com/office/drawing/2014/main" id="{EF256480-5F59-4C54-B105-2F0FB3E440FD}"/>
               </a:ext>
             </a:extLst>
           </p:cNvPr>
@@ -4176,7 +4176,7 @@
           <p:cNvPr id="7" name="">
             <a:extLst xmlns:a="http://schemas.openxmlformats.org/drawingml/2006/main">
               <a:ext uri="{FF2B5EF4-FFF2-40B4-BE49-F238E27FC236}">
-                <a16:creationId xmlns:a16="http://schemas.microsoft.com/office/drawing/2014/main" id="{52720059-A0F5-4496-895A-1E9DA5281168}"/>
+                <a16:creationId xmlns:a16="http://schemas.microsoft.com/office/drawing/2014/main" id="{AC8D5240-B655-44F3-8537-820052EAEFF4}"/>
               </a:ext>
             </a:extLst>
           </p:cNvPr>
@@ -4216,7 +4216,7 @@
                   <a:srgbClr val="0A0A0A"/>
                 </a:solidFill>
               </a:rPr>
-              <a:t>98.83% test accuracy</a:t>
+              <a:t>98.87% test accuracy</a:t>
             </a:r>
           </a:p>
         </p:txBody>
@@ -4226,7 +4226,7 @@
           <p:cNvPr id="8" name="">
             <a:extLst xmlns:a="http://schemas.openxmlformats.org/drawingml/2006/main">
               <a:ext uri="{FF2B5EF4-FFF2-40B4-BE49-F238E27FC236}">
-                <a16:creationId xmlns:a16="http://schemas.microsoft.com/office/drawing/2014/main" id="{BBCCEDBE-E498-43F3-9940-E174658ECEC6}"/>
+                <a16:creationId xmlns:a16="http://schemas.microsoft.com/office/drawing/2014/main" id="{18E54698-46E8-43AB-8887-F7611218FD3C}"/>
               </a:ext>
             </a:extLst>
           </p:cNvPr>
@@ -4259,7 +4259,7 @@
           <p:cNvPr id="9" name="">
             <a:extLst xmlns:a="http://schemas.openxmlformats.org/drawingml/2006/main">
               <a:ext uri="{FF2B5EF4-FFF2-40B4-BE49-F238E27FC236}">
-                <a16:creationId xmlns:a16="http://schemas.microsoft.com/office/drawing/2014/main" id="{5FB68104-FE8F-4D39-942D-495A4BFF73A3}"/>
+                <a16:creationId xmlns:a16="http://schemas.microsoft.com/office/drawing/2014/main" id="{124DD5D4-6C24-494F-9EA5-065063200821}"/>
               </a:ext>
             </a:extLst>
           </p:cNvPr>
@@ -4299,7 +4299,7 @@
                   <a:srgbClr val="0A0A0A"/>
                 </a:solidFill>
               </a:rPr>
-              <a:t>61,706 parameters</a:t>
+              <a:t>60,000 parameters</a:t>
             </a:r>
           </a:p>
         </p:txBody>
@@ -4309,7 +4309,7 @@
           <p:cNvPr id="10" name="">
             <a:extLst xmlns:a="http://schemas.openxmlformats.org/drawingml/2006/main">
               <a:ext uri="{FF2B5EF4-FFF2-40B4-BE49-F238E27FC236}">
-                <a16:creationId xmlns:a16="http://schemas.microsoft.com/office/drawing/2014/main" id="{E5C899B6-9C6E-4FA3-A8AD-7352E7BF3B7B}"/>
+                <a16:creationId xmlns:a16="http://schemas.microsoft.com/office/drawing/2014/main" id="{427F7E37-8F80-419D-A87D-B8979ECA532A}"/>
               </a:ext>
             </a:extLst>
           </p:cNvPr>
@@ -4342,7 +4342,7 @@
           <p:cNvPr id="11" name="">
             <a:extLst xmlns:a="http://schemas.openxmlformats.org/drawingml/2006/main">
               <a:ext uri="{FF2B5EF4-FFF2-40B4-BE49-F238E27FC236}">
-                <a16:creationId xmlns:a16="http://schemas.microsoft.com/office/drawing/2014/main" id="{429A4947-EBDC-4A6C-81C1-435946DB40C7}"/>
+                <a16:creationId xmlns:a16="http://schemas.microsoft.com/office/drawing/2014/main" id="{0C17F733-47F9-4389-A545-B4EA9776080F}"/>
               </a:ext>
             </a:extLst>
           </p:cNvPr>
@@ -4382,7 +4382,7 @@
                   <a:srgbClr val="0A0A0A"/>
                 </a:solidFill>
               </a:rPr>
-              <a:t>16.81 s CPU training</a:t>
+              <a:t>125.94 s CPU training</a:t>
             </a:r>
           </a:p>
         </p:txBody>
@@ -4392,7 +4392,7 @@
           <p:cNvPr id="12" name="">
             <a:extLst xmlns:a="http://schemas.openxmlformats.org/drawingml/2006/main">
               <a:ext uri="{FF2B5EF4-FFF2-40B4-BE49-F238E27FC236}">
-                <a16:creationId xmlns:a16="http://schemas.microsoft.com/office/drawing/2014/main" id="{82106F29-3D96-47C4-A825-DAAB70FF0BB8}"/>
+                <a16:creationId xmlns:a16="http://schemas.microsoft.com/office/drawing/2014/main" id="{9A8C85E5-9664-44C3-B8AA-4D815F35BE5B}"/>
               </a:ext>
             </a:extLst>
           </p:cNvPr>
@@ -4425,7 +4425,7 @@
           <p:cNvPr id="13" name="">
             <a:extLst xmlns:a="http://schemas.openxmlformats.org/drawingml/2006/main">
               <a:ext uri="{FF2B5EF4-FFF2-40B4-BE49-F238E27FC236}">
-                <a16:creationId xmlns:a16="http://schemas.microsoft.com/office/drawing/2014/main" id="{0F61CC76-CF0A-4A62-B118-68479110B40D}"/>
+                <a16:creationId xmlns:a16="http://schemas.microsoft.com/office/drawing/2014/main" id="{42572D8B-EE6B-4018-80AD-8CBCEAFEC869}"/>
               </a:ext>
             </a:extLst>
           </p:cNvPr>
@@ -4465,7 +4465,7 @@
                   <a:srgbClr val="0A0A0A"/>
                 </a:solidFill>
               </a:rPr>
-              <a:t>0.25 MB checkpoint</a:t>
+              <a:t>0.26 MB checkpoint</a:t>
             </a:r>
           </a:p>
         </p:txBody>
@@ -4475,7 +4475,7 @@
           <p:cNvPr id="14" name="">
             <a:extLst xmlns:a="http://schemas.openxmlformats.org/drawingml/2006/main">
               <a:ext uri="{FF2B5EF4-FFF2-40B4-BE49-F238E27FC236}">
-                <a16:creationId xmlns:a16="http://schemas.microsoft.com/office/drawing/2014/main" id="{F210F14B-6536-45CA-8968-D0245C4E83D7}"/>
+                <a16:creationId xmlns:a16="http://schemas.microsoft.com/office/drawing/2014/main" id="{17CAB169-FD57-4F53-AE78-7D25A9DB7BAF}"/>
               </a:ext>
             </a:extLst>
           </p:cNvPr>
@@ -4508,7 +4508,7 @@
           <p:cNvPr id="15" name="">
             <a:extLst xmlns:a="http://schemas.openxmlformats.org/drawingml/2006/main">
               <a:ext uri="{FF2B5EF4-FFF2-40B4-BE49-F238E27FC236}">
-                <a16:creationId xmlns:a16="http://schemas.microsoft.com/office/drawing/2014/main" id="{49E28945-3628-4745-A105-C8F28B09BAEC}"/>
+                <a16:creationId xmlns:a16="http://schemas.microsoft.com/office/drawing/2014/main" id="{6C59FC83-0629-4E1F-BEBE-8EB044686F9A}"/>
               </a:ext>
             </a:extLst>
           </p:cNvPr>
@@ -4558,7 +4558,7 @@
           <p:cNvPr id="16" name="">
             <a:extLst xmlns:a="http://schemas.openxmlformats.org/drawingml/2006/main">
               <a:ext uri="{FF2B5EF4-FFF2-40B4-BE49-F238E27FC236}">
-                <a16:creationId xmlns:a16="http://schemas.microsoft.com/office/drawing/2014/main" id="{AD5CED1B-21E2-4080-8CE9-14699224056A}"/>
+                <a16:creationId xmlns:a16="http://schemas.microsoft.com/office/drawing/2014/main" id="{5D51BA68-077C-4BDC-BE36-4436CBD30C43}"/>
               </a:ext>
             </a:extLst>
           </p:cNvPr>
@@ -4591,7 +4591,7 @@
           <p:cNvPr id="17" name="">
             <a:extLst xmlns:a="http://schemas.openxmlformats.org/drawingml/2006/main">
               <a:ext uri="{FF2B5EF4-FFF2-40B4-BE49-F238E27FC236}">
-                <a16:creationId xmlns:a16="http://schemas.microsoft.com/office/drawing/2014/main" id="{CDA10C8F-1FA4-4851-B39B-B229CDC9A8A1}"/>
+                <a16:creationId xmlns:a16="http://schemas.microsoft.com/office/drawing/2014/main" id="{9808AA5A-D3D2-4F48-AE85-40E53D8CF87A}"/>
               </a:ext>
             </a:extLst>
           </p:cNvPr>
@@ -4641,7 +4641,7 @@
           <p:cNvPr id="18" name="">
             <a:extLst xmlns:a="http://schemas.openxmlformats.org/drawingml/2006/main">
               <a:ext uri="{FF2B5EF4-FFF2-40B4-BE49-F238E27FC236}">
-                <a16:creationId xmlns:a16="http://schemas.microsoft.com/office/drawing/2014/main" id="{77153771-B2EA-48EC-9644-D17BEB397803}"/>
+                <a16:creationId xmlns:a16="http://schemas.microsoft.com/office/drawing/2014/main" id="{FCC39D09-4878-44C4-AAEB-16F62A4A0B37}"/>
               </a:ext>
             </a:extLst>
           </p:cNvPr>
@@ -4674,7 +4674,7 @@
           <p:cNvPr id="19" name="">
             <a:extLst xmlns:a="http://schemas.openxmlformats.org/drawingml/2006/main">
               <a:ext uri="{FF2B5EF4-FFF2-40B4-BE49-F238E27FC236}">
-                <a16:creationId xmlns:a16="http://schemas.microsoft.com/office/drawing/2014/main" id="{EAB20544-D7C7-4EA5-B975-83560F9C11F6}"/>
+                <a16:creationId xmlns:a16="http://schemas.microsoft.com/office/drawing/2014/main" id="{E2110493-B161-44CF-8D8F-962E5C3EC041}"/>
               </a:ext>
             </a:extLst>
           </p:cNvPr>
@@ -4724,7 +4724,7 @@
           <p:cNvPr id="20" name="">
             <a:extLst xmlns:a="http://schemas.openxmlformats.org/drawingml/2006/main">
               <a:ext uri="{FF2B5EF4-FFF2-40B4-BE49-F238E27FC236}">
-                <a16:creationId xmlns:a16="http://schemas.microsoft.com/office/drawing/2014/main" id="{26FB0ABC-8ED3-4515-9E3E-795715EC15C3}"/>
+                <a16:creationId xmlns:a16="http://schemas.microsoft.com/office/drawing/2014/main" id="{0B04433E-072C-43AA-80DB-D3A09B59492E}"/>
               </a:ext>
             </a:extLst>
           </p:cNvPr>
@@ -4757,7 +4757,7 @@
           <p:cNvPr id="21" name="">
             <a:extLst xmlns:a="http://schemas.openxmlformats.org/drawingml/2006/main">
               <a:ext uri="{FF2B5EF4-FFF2-40B4-BE49-F238E27FC236}">
-                <a16:creationId xmlns:a16="http://schemas.microsoft.com/office/drawing/2014/main" id="{86EE6662-A44D-4B1E-B15B-D9E439CAEFDC}"/>
+                <a16:creationId xmlns:a16="http://schemas.microsoft.com/office/drawing/2014/main" id="{0950D8EF-1E44-48B2-B066-0ACF08F1F8D8}"/>
               </a:ext>
             </a:extLst>
           </p:cNvPr>
@@ -4807,7 +4807,7 @@
           <p:cNvPr id="22" name="">
             <a:extLst xmlns:a="http://schemas.openxmlformats.org/drawingml/2006/main">
               <a:ext uri="{FF2B5EF4-FFF2-40B4-BE49-F238E27FC236}">
-                <a16:creationId xmlns:a16="http://schemas.microsoft.com/office/drawing/2014/main" id="{C36970EC-72FB-4D17-9941-E6324BEA7BFA}"/>
+                <a16:creationId xmlns:a16="http://schemas.microsoft.com/office/drawing/2014/main" id="{0E4A03FD-A512-4AD1-8691-CEC403D816F1}"/>
               </a:ext>
             </a:extLst>
           </p:cNvPr>
@@ -4840,7 +4840,7 @@
           <p:cNvPr id="23" name="">
             <a:extLst xmlns:a="http://schemas.openxmlformats.org/drawingml/2006/main">
               <a:ext uri="{FF2B5EF4-FFF2-40B4-BE49-F238E27FC236}">
-                <a16:creationId xmlns:a16="http://schemas.microsoft.com/office/drawing/2014/main" id="{38410224-A04B-42E8-BD65-D94DD269C90D}"/>
+                <a16:creationId xmlns:a16="http://schemas.microsoft.com/office/drawing/2014/main" id="{0472B349-D410-4F11-9A0E-33CB6B3559BA}"/>
               </a:ext>
             </a:extLst>
           </p:cNvPr>
@@ -4890,7 +4890,7 @@
           <p:cNvPr id="24" name="">
             <a:extLst xmlns:a="http://schemas.openxmlformats.org/drawingml/2006/main">
               <a:ext uri="{FF2B5EF4-FFF2-40B4-BE49-F238E27FC236}">
-                <a16:creationId xmlns:a16="http://schemas.microsoft.com/office/drawing/2014/main" id="{8E100381-B505-4D30-B67D-7201B209A30F}"/>
+                <a16:creationId xmlns:a16="http://schemas.microsoft.com/office/drawing/2014/main" id="{6F195012-BA52-40F4-B194-43FB85E347AD}"/>
               </a:ext>
             </a:extLst>
           </p:cNvPr>
@@ -4940,7 +4940,7 @@
           <p:cNvPr id="25" name="">
             <a:extLst xmlns:a="http://schemas.openxmlformats.org/drawingml/2006/main">
               <a:ext uri="{FF2B5EF4-FFF2-40B4-BE49-F238E27FC236}">
-                <a16:creationId xmlns:a16="http://schemas.microsoft.com/office/drawing/2014/main" id="{A2E5C6A3-8CA2-4254-B938-BC05707BF770}"/>
+                <a16:creationId xmlns:a16="http://schemas.microsoft.com/office/drawing/2014/main" id="{B0AD24CE-FC0C-4685-A93F-D30889EFB819}"/>
               </a:ext>
             </a:extLst>
           </p:cNvPr>
@@ -4988,7 +4988,7 @@
     </p:spTree>
     <p:extLst>
       <p:ext uri="{BB962C8B-B14F-4D97-AF65-F5344CB8AC3E}">
-        <p14:creationId xmlns:p14="http://schemas.microsoft.com/office/powerpoint/2010/main" val="1559928962"/>
+        <p14:creationId xmlns:p14="http://schemas.microsoft.com/office/powerpoint/2010/main" val="1540440001"/>
       </p:ext>
     </p:extLst>
   </p:cSld>
@@ -5019,7 +5019,7 @@
           <p:cNvPr id="1" name="">
             <a:extLst xmlns:a="http://schemas.openxmlformats.org/drawingml/2006/main">
               <a:ext uri="{FF2B5EF4-FFF2-40B4-BE49-F238E27FC236}">
-                <a16:creationId xmlns:a16="http://schemas.microsoft.com/office/drawing/2014/main" id="{C2E7AFEF-1FD8-4C95-932A-4DC8849393D0}"/>
+                <a16:creationId xmlns:a16="http://schemas.microsoft.com/office/drawing/2014/main" id="{0D53C451-7B55-4065-96DB-1592773ED92F}"/>
               </a:ext>
             </a:extLst>
           </p:cNvPr>
@@ -5069,7 +5069,7 @@
           <p:cNvPr id="2" name="">
             <a:extLst xmlns:a="http://schemas.openxmlformats.org/drawingml/2006/main">
               <a:ext uri="{FF2B5EF4-FFF2-40B4-BE49-F238E27FC236}">
-                <a16:creationId xmlns:a16="http://schemas.microsoft.com/office/drawing/2014/main" id="{5BEADC5B-0EC8-466D-85EB-C0C8701671D4}"/>
+                <a16:creationId xmlns:a16="http://schemas.microsoft.com/office/drawing/2014/main" id="{9AF2163D-026F-41D2-87D3-4116A7F13D62}"/>
               </a:ext>
             </a:extLst>
           </p:cNvPr>
@@ -5119,7 +5119,7 @@
           <p:cNvPr id="3" name="">
             <a:extLst xmlns:a="http://schemas.openxmlformats.org/drawingml/2006/main">
               <a:ext uri="{FF2B5EF4-FFF2-40B4-BE49-F238E27FC236}">
-                <a16:creationId xmlns:a16="http://schemas.microsoft.com/office/drawing/2014/main" id="{219AC064-DB86-488C-85BA-82029F264E69}"/>
+                <a16:creationId xmlns:a16="http://schemas.microsoft.com/office/drawing/2014/main" id="{A8BD7EC5-AA15-4D38-AB2A-F62C8183FEBE}"/>
               </a:ext>
             </a:extLst>
           </p:cNvPr>
@@ -5152,7 +5152,7 @@
           <p:cNvPr id="4" name="">
             <a:extLst xmlns:a="http://schemas.openxmlformats.org/drawingml/2006/main">
               <a:ext uri="{FF2B5EF4-FFF2-40B4-BE49-F238E27FC236}">
-                <a16:creationId xmlns:a16="http://schemas.microsoft.com/office/drawing/2014/main" id="{0749F49B-83D5-47A5-8EF0-D2B40B11A8A0}"/>
+                <a16:creationId xmlns:a16="http://schemas.microsoft.com/office/drawing/2014/main" id="{33810708-A4B5-4508-B0DD-7DCE3CB407F2}"/>
               </a:ext>
             </a:extLst>
           </p:cNvPr>
@@ -5185,7 +5185,7 @@
           <p:cNvPr id="5" name="">
             <a:extLst xmlns:a="http://schemas.openxmlformats.org/drawingml/2006/main">
               <a:ext uri="{FF2B5EF4-FFF2-40B4-BE49-F238E27FC236}">
-                <a16:creationId xmlns:a16="http://schemas.microsoft.com/office/drawing/2014/main" id="{1431D810-A177-4B44-A8A3-C8A949254FE9}"/>
+                <a16:creationId xmlns:a16="http://schemas.microsoft.com/office/drawing/2014/main" id="{86EB597F-4F24-404E-AC36-91C60FD5D1D3}"/>
               </a:ext>
             </a:extLst>
           </p:cNvPr>
@@ -5235,7 +5235,7 @@
           <p:cNvPr id="6" name="">
             <a:extLst xmlns:a="http://schemas.openxmlformats.org/drawingml/2006/main">
               <a:ext uri="{FF2B5EF4-FFF2-40B4-BE49-F238E27FC236}">
-                <a16:creationId xmlns:a16="http://schemas.microsoft.com/office/drawing/2014/main" id="{44B0357A-904F-4301-81BB-EBB797E2E01C}"/>
+                <a16:creationId xmlns:a16="http://schemas.microsoft.com/office/drawing/2014/main" id="{DBCB6A3E-05B7-454B-97D0-1B631C26D697}"/>
               </a:ext>
             </a:extLst>
           </p:cNvPr>
@@ -5268,7 +5268,7 @@
           <p:cNvPr id="7" name="">
             <a:extLst xmlns:a="http://schemas.openxmlformats.org/drawingml/2006/main">
               <a:ext uri="{FF2B5EF4-FFF2-40B4-BE49-F238E27FC236}">
-                <a16:creationId xmlns:a16="http://schemas.microsoft.com/office/drawing/2014/main" id="{EC2FB9DC-84FE-4DF1-84F4-AA26D04B478D}"/>
+                <a16:creationId xmlns:a16="http://schemas.microsoft.com/office/drawing/2014/main" id="{645FC91C-4A1E-4EF6-8518-5F292054F3BF}"/>
               </a:ext>
             </a:extLst>
           </p:cNvPr>
@@ -5318,7 +5318,7 @@
           <p:cNvPr id="8" name="">
             <a:extLst xmlns:a="http://schemas.openxmlformats.org/drawingml/2006/main">
               <a:ext uri="{FF2B5EF4-FFF2-40B4-BE49-F238E27FC236}">
-                <a16:creationId xmlns:a16="http://schemas.microsoft.com/office/drawing/2014/main" id="{009E6767-7833-4D23-8EE8-55533A059C62}"/>
+                <a16:creationId xmlns:a16="http://schemas.microsoft.com/office/drawing/2014/main" id="{B95C4B97-D9AD-4F97-A436-75F2E7C76D79}"/>
               </a:ext>
             </a:extLst>
           </p:cNvPr>
@@ -5351,7 +5351,7 @@
           <p:cNvPr id="9" name="">
             <a:extLst xmlns:a="http://schemas.openxmlformats.org/drawingml/2006/main">
               <a:ext uri="{FF2B5EF4-FFF2-40B4-BE49-F238E27FC236}">
-                <a16:creationId xmlns:a16="http://schemas.microsoft.com/office/drawing/2014/main" id="{E8037D6C-BC25-4A84-8F07-25288C6852F9}"/>
+                <a16:creationId xmlns:a16="http://schemas.microsoft.com/office/drawing/2014/main" id="{47448AED-2BA0-4C83-9A1D-3F37B8CD4F8B}"/>
               </a:ext>
             </a:extLst>
           </p:cNvPr>
@@ -5391,7 +5391,7 @@
                   <a:srgbClr val="0A0A0A"/>
                 </a:solidFill>
               </a:rPr>
-              <a:t>98.83% test accuracy with a 61,706-parameter model</a:t>
+              <a:t>98.87% test accuracy with a 60,000-parameter model</a:t>
             </a:r>
           </a:p>
         </p:txBody>
@@ -5401,7 +5401,7 @@
           <p:cNvPr id="10" name="">
             <a:extLst xmlns:a="http://schemas.openxmlformats.org/drawingml/2006/main">
               <a:ext uri="{FF2B5EF4-FFF2-40B4-BE49-F238E27FC236}">
-                <a16:creationId xmlns:a16="http://schemas.microsoft.com/office/drawing/2014/main" id="{C3A24B9A-B99F-4898-B64C-4C4EAD5A6C76}"/>
+                <a16:creationId xmlns:a16="http://schemas.microsoft.com/office/drawing/2014/main" id="{12F8D73B-3201-45F4-BF38-54597F2D0A04}"/>
               </a:ext>
             </a:extLst>
           </p:cNvPr>
@@ -5434,7 +5434,7 @@
           <p:cNvPr id="11" name="">
             <a:extLst xmlns:a="http://schemas.openxmlformats.org/drawingml/2006/main">
               <a:ext uri="{FF2B5EF4-FFF2-40B4-BE49-F238E27FC236}">
-                <a16:creationId xmlns:a16="http://schemas.microsoft.com/office/drawing/2014/main" id="{89C786DF-2A2F-4B80-8FB8-8C2FBEAEE12D}"/>
+                <a16:creationId xmlns:a16="http://schemas.microsoft.com/office/drawing/2014/main" id="{1535F61A-9902-4237-AA0B-A290858060DC}"/>
               </a:ext>
             </a:extLst>
           </p:cNvPr>
@@ -5484,7 +5484,7 @@
           <p:cNvPr id="12" name="">
             <a:extLst xmlns:a="http://schemas.openxmlformats.org/drawingml/2006/main">
               <a:ext uri="{FF2B5EF4-FFF2-40B4-BE49-F238E27FC236}">
-                <a16:creationId xmlns:a16="http://schemas.microsoft.com/office/drawing/2014/main" id="{767B6A0D-4A4B-48B9-BED3-95666AD42132}"/>
+                <a16:creationId xmlns:a16="http://schemas.microsoft.com/office/drawing/2014/main" id="{F3092926-1E3C-4406-A5AF-BC6672A72812}"/>
               </a:ext>
             </a:extLst>
           </p:cNvPr>
@@ -5517,7 +5517,7 @@
           <p:cNvPr id="13" name="">
             <a:extLst xmlns:a="http://schemas.openxmlformats.org/drawingml/2006/main">
               <a:ext uri="{FF2B5EF4-FFF2-40B4-BE49-F238E27FC236}">
-                <a16:creationId xmlns:a16="http://schemas.microsoft.com/office/drawing/2014/main" id="{00BC1A82-DF04-4963-AF8B-F291FE420C34}"/>
+                <a16:creationId xmlns:a16="http://schemas.microsoft.com/office/drawing/2014/main" id="{D51C7CEC-09DC-4F2D-88BC-8C1730E034B9}"/>
               </a:ext>
             </a:extLst>
           </p:cNvPr>
@@ -5567,7 +5567,7 @@
           <p:cNvPr id="14" name="">
             <a:extLst xmlns:a="http://schemas.openxmlformats.org/drawingml/2006/main">
               <a:ext uri="{FF2B5EF4-FFF2-40B4-BE49-F238E27FC236}">
-                <a16:creationId xmlns:a16="http://schemas.microsoft.com/office/drawing/2014/main" id="{2513A090-E1EC-47A3-9B08-66624D62F57F}"/>
+                <a16:creationId xmlns:a16="http://schemas.microsoft.com/office/drawing/2014/main" id="{BCFEDE0E-5978-4E56-AEC6-5081416037EC}"/>
               </a:ext>
             </a:extLst>
           </p:cNvPr>
@@ -5617,7 +5617,7 @@
           <p:cNvPr id="15" name="">
             <a:extLst xmlns:a="http://schemas.openxmlformats.org/drawingml/2006/main">
               <a:ext uri="{FF2B5EF4-FFF2-40B4-BE49-F238E27FC236}">
-                <a16:creationId xmlns:a16="http://schemas.microsoft.com/office/drawing/2014/main" id="{FD229A63-6E39-4001-BACC-F3458D0EAEE3}"/>
+                <a16:creationId xmlns:a16="http://schemas.microsoft.com/office/drawing/2014/main" id="{6553BD1D-5CA3-4AC0-BE77-48CE7F28296A}"/>
               </a:ext>
             </a:extLst>
           </p:cNvPr>
@@ -5665,7 +5665,7 @@
     </p:spTree>
     <p:extLst>
       <p:ext uri="{BB962C8B-B14F-4D97-AF65-F5344CB8AC3E}">
-        <p14:creationId xmlns:p14="http://schemas.microsoft.com/office/powerpoint/2010/main" val="2056925545"/>
+        <p14:creationId xmlns:p14="http://schemas.microsoft.com/office/powerpoint/2010/main" val="629193156"/>
       </p:ext>
     </p:extLst>
   </p:cSld>
@@ -5696,7 +5696,7 @@
           <p:cNvPr id="1" name="">
             <a:extLst xmlns:a="http://schemas.openxmlformats.org/drawingml/2006/main">
               <a:ext uri="{FF2B5EF4-FFF2-40B4-BE49-F238E27FC236}">
-                <a16:creationId xmlns:a16="http://schemas.microsoft.com/office/drawing/2014/main" id="{F33A78AE-2097-43A1-BC46-A736EEEBAC05}"/>
+                <a16:creationId xmlns:a16="http://schemas.microsoft.com/office/drawing/2014/main" id="{4CD13FB2-EAD0-4F91-88AE-7B70AB048FC1}"/>
               </a:ext>
             </a:extLst>
           </p:cNvPr>
@@ -5746,7 +5746,7 @@
           <p:cNvPr id="2" name="">
             <a:extLst xmlns:a="http://schemas.openxmlformats.org/drawingml/2006/main">
               <a:ext uri="{FF2B5EF4-FFF2-40B4-BE49-F238E27FC236}">
-                <a16:creationId xmlns:a16="http://schemas.microsoft.com/office/drawing/2014/main" id="{9BEC3DE7-0C34-446E-8840-9329A64DA06C}"/>
+                <a16:creationId xmlns:a16="http://schemas.microsoft.com/office/drawing/2014/main" id="{41F0CB15-A16A-467B-A022-9CD2B10269F6}"/>
               </a:ext>
             </a:extLst>
           </p:cNvPr>
@@ -5796,7 +5796,7 @@
           <p:cNvPr id="3" name="">
             <a:extLst xmlns:a="http://schemas.openxmlformats.org/drawingml/2006/main">
               <a:ext uri="{FF2B5EF4-FFF2-40B4-BE49-F238E27FC236}">
-                <a16:creationId xmlns:a16="http://schemas.microsoft.com/office/drawing/2014/main" id="{CA54C906-5801-43F4-A24E-F958F577DD9F}"/>
+                <a16:creationId xmlns:a16="http://schemas.microsoft.com/office/drawing/2014/main" id="{F6350044-9AB2-40A4-9180-9945FB277A00}"/>
               </a:ext>
             </a:extLst>
           </p:cNvPr>
@@ -5829,7 +5829,7 @@
           <p:cNvPr id="4" name="">
             <a:extLst xmlns:a="http://schemas.openxmlformats.org/drawingml/2006/main">
               <a:ext uri="{FF2B5EF4-FFF2-40B4-BE49-F238E27FC236}">
-                <a16:creationId xmlns:a16="http://schemas.microsoft.com/office/drawing/2014/main" id="{49CF4760-DD2E-4CFD-AA88-1D011CBE3E49}"/>
+                <a16:creationId xmlns:a16="http://schemas.microsoft.com/office/drawing/2014/main" id="{734A201D-EAD6-431A-9A17-8363DB6E5080}"/>
               </a:ext>
             </a:extLst>
           </p:cNvPr>
@@ -5862,7 +5862,7 @@
           <p:cNvPr id="5" name="">
             <a:extLst xmlns:a="http://schemas.openxmlformats.org/drawingml/2006/main">
               <a:ext uri="{FF2B5EF4-FFF2-40B4-BE49-F238E27FC236}">
-                <a16:creationId xmlns:a16="http://schemas.microsoft.com/office/drawing/2014/main" id="{D2605147-0DD9-492C-98BB-6A0D4785E9F5}"/>
+                <a16:creationId xmlns:a16="http://schemas.microsoft.com/office/drawing/2014/main" id="{B8480F3B-2543-422E-AC26-245E7DC72D5B}"/>
               </a:ext>
             </a:extLst>
           </p:cNvPr>
@@ -5912,7 +5912,7 @@
           <p:cNvPr id="6" name="">
             <a:extLst xmlns:a="http://schemas.openxmlformats.org/drawingml/2006/main">
               <a:ext uri="{FF2B5EF4-FFF2-40B4-BE49-F238E27FC236}">
-                <a16:creationId xmlns:a16="http://schemas.microsoft.com/office/drawing/2014/main" id="{E39A7689-9AAC-4204-8020-C609AEC7CBC6}"/>
+                <a16:creationId xmlns:a16="http://schemas.microsoft.com/office/drawing/2014/main" id="{9EBAC99C-2FA0-44E8-9258-50035E127762}"/>
               </a:ext>
             </a:extLst>
           </p:cNvPr>
@@ -5945,7 +5945,7 @@
           <p:cNvPr id="7" name="">
             <a:extLst xmlns:a="http://schemas.openxmlformats.org/drawingml/2006/main">
               <a:ext uri="{FF2B5EF4-FFF2-40B4-BE49-F238E27FC236}">
-                <a16:creationId xmlns:a16="http://schemas.microsoft.com/office/drawing/2014/main" id="{C533AB3B-D500-4D0D-AFE4-BE8C2989DF95}"/>
+                <a16:creationId xmlns:a16="http://schemas.microsoft.com/office/drawing/2014/main" id="{711DA9FD-7BFA-4EEA-B2FF-3F90090FB9FC}"/>
               </a:ext>
             </a:extLst>
           </p:cNvPr>
@@ -5995,7 +5995,7 @@
           <p:cNvPr id="8" name="">
             <a:extLst xmlns:a="http://schemas.openxmlformats.org/drawingml/2006/main">
               <a:ext uri="{FF2B5EF4-FFF2-40B4-BE49-F238E27FC236}">
-                <a16:creationId xmlns:a16="http://schemas.microsoft.com/office/drawing/2014/main" id="{62FA8D1F-A93F-419C-B1CD-1F9FFACA8172}"/>
+                <a16:creationId xmlns:a16="http://schemas.microsoft.com/office/drawing/2014/main" id="{FAB1CD53-1D52-49DE-B296-C88F1080A2E2}"/>
               </a:ext>
             </a:extLst>
           </p:cNvPr>
@@ -6028,7 +6028,7 @@
           <p:cNvPr id="9" name="">
             <a:extLst xmlns:a="http://schemas.openxmlformats.org/drawingml/2006/main">
               <a:ext uri="{FF2B5EF4-FFF2-40B4-BE49-F238E27FC236}">
-                <a16:creationId xmlns:a16="http://schemas.microsoft.com/office/drawing/2014/main" id="{18E305B7-7550-479C-BB87-7691E1AB510C}"/>
+                <a16:creationId xmlns:a16="http://schemas.microsoft.com/office/drawing/2014/main" id="{8DA5A46F-EAA9-41F8-B1FF-0E28927F44DD}"/>
               </a:ext>
             </a:extLst>
           </p:cNvPr>
@@ -6078,7 +6078,7 @@
           <p:cNvPr id="10" name="">
             <a:extLst xmlns:a="http://schemas.openxmlformats.org/drawingml/2006/main">
               <a:ext uri="{FF2B5EF4-FFF2-40B4-BE49-F238E27FC236}">
-                <a16:creationId xmlns:a16="http://schemas.microsoft.com/office/drawing/2014/main" id="{25E38790-4336-478C-9682-1F494A10CE9D}"/>
+                <a16:creationId xmlns:a16="http://schemas.microsoft.com/office/drawing/2014/main" id="{C7CB078F-F225-4475-B6C1-86F10F9AE395}"/>
               </a:ext>
             </a:extLst>
           </p:cNvPr>
@@ -6111,7 +6111,7 @@
           <p:cNvPr id="11" name="">
             <a:extLst xmlns:a="http://schemas.openxmlformats.org/drawingml/2006/main">
               <a:ext uri="{FF2B5EF4-FFF2-40B4-BE49-F238E27FC236}">
-                <a16:creationId xmlns:a16="http://schemas.microsoft.com/office/drawing/2014/main" id="{D14B8B3E-B99A-4224-9B69-BC2BD9F0251A}"/>
+                <a16:creationId xmlns:a16="http://schemas.microsoft.com/office/drawing/2014/main" id="{5EB0895B-4E24-4928-891B-E339A4911F10}"/>
               </a:ext>
             </a:extLst>
           </p:cNvPr>
@@ -6165,7 +6165,7 @@
           <p:nvPr/>
         </p:nvPicPr>
         <p:blipFill>
-          <a:blip xmlns:r="http://schemas.openxmlformats.org/officeDocument/2006/relationships" xmlns:a="http://schemas.openxmlformats.org/drawingml/2006/main" r:embed="Rec1316c08bdb4150"/>
+          <a:blip xmlns:r="http://schemas.openxmlformats.org/officeDocument/2006/relationships" xmlns:a="http://schemas.openxmlformats.org/drawingml/2006/main" r:embed="R790114bb91d44d5e"/>
           <a:stretch xmlns:a="http://schemas.openxmlformats.org/drawingml/2006/main"/>
         </p:blipFill>
         <p:spPr>
@@ -6183,7 +6183,7 @@
           <p:cNvPr id="13" name="">
             <a:extLst xmlns:a="http://schemas.openxmlformats.org/drawingml/2006/main">
               <a:ext uri="{FF2B5EF4-FFF2-40B4-BE49-F238E27FC236}">
-                <a16:creationId xmlns:a16="http://schemas.microsoft.com/office/drawing/2014/main" id="{2836325E-9853-43E7-A04B-5FC73EF3E9C9}"/>
+                <a16:creationId xmlns:a16="http://schemas.microsoft.com/office/drawing/2014/main" id="{F089168C-66EF-4472-BEAD-6D4C266B677E}"/>
               </a:ext>
             </a:extLst>
           </p:cNvPr>
@@ -6233,7 +6233,7 @@
           <p:cNvPr id="14" name="">
             <a:extLst xmlns:a="http://schemas.openxmlformats.org/drawingml/2006/main">
               <a:ext uri="{FF2B5EF4-FFF2-40B4-BE49-F238E27FC236}">
-                <a16:creationId xmlns:a16="http://schemas.microsoft.com/office/drawing/2014/main" id="{0235B807-A0E2-437D-B937-84F0F4EC2CA6}"/>
+                <a16:creationId xmlns:a16="http://schemas.microsoft.com/office/drawing/2014/main" id="{4FFA3553-8BE8-44E6-85A2-CACB6FF3B91E}"/>
               </a:ext>
             </a:extLst>
           </p:cNvPr>
@@ -6281,7 +6281,7 @@
     </p:spTree>
     <p:extLst>
       <p:ext uri="{BB962C8B-B14F-4D97-AF65-F5344CB8AC3E}">
-        <p14:creationId xmlns:p14="http://schemas.microsoft.com/office/powerpoint/2010/main" val="287931312"/>
+        <p14:creationId xmlns:p14="http://schemas.microsoft.com/office/powerpoint/2010/main" val="398276490"/>
       </p:ext>
     </p:extLst>
   </p:cSld>
@@ -6312,7 +6312,7 @@
           <p:cNvPr id="1" name="">
             <a:extLst xmlns:a="http://schemas.openxmlformats.org/drawingml/2006/main">
               <a:ext uri="{FF2B5EF4-FFF2-40B4-BE49-F238E27FC236}">
-                <a16:creationId xmlns:a16="http://schemas.microsoft.com/office/drawing/2014/main" id="{0A7544A9-2154-42B0-A3FB-AD30D73025C1}"/>
+                <a16:creationId xmlns:a16="http://schemas.microsoft.com/office/drawing/2014/main" id="{82CF6E6D-815C-410D-9A7D-E0E08F229FE5}"/>
               </a:ext>
             </a:extLst>
           </p:cNvPr>
@@ -6352,7 +6352,7 @@
                   <a:srgbClr val="0A0A0A"/>
                 </a:solidFill>
               </a:rPr>
-              <a:t>LeNet-5 is small, structured, and still instructive</a:t>
+              <a:t>LeNet-5 is small, structured, and historically specific</a:t>
             </a:r>
           </a:p>
         </p:txBody>
@@ -6362,7 +6362,7 @@
           <p:cNvPr id="2" name="">
             <a:extLst xmlns:a="http://schemas.openxmlformats.org/drawingml/2006/main">
               <a:ext uri="{FF2B5EF4-FFF2-40B4-BE49-F238E27FC236}">
-                <a16:creationId xmlns:a16="http://schemas.microsoft.com/office/drawing/2014/main" id="{050175BB-1680-44D7-9B73-9117D141B0E8}"/>
+                <a16:creationId xmlns:a16="http://schemas.microsoft.com/office/drawing/2014/main" id="{6830EF66-A8FE-4731-AD93-6EE7F0B288DA}"/>
               </a:ext>
             </a:extLst>
           </p:cNvPr>
@@ -6402,7 +6402,7 @@
                   <a:srgbClr val="555555"/>
                 </a:solidFill>
               </a:rPr>
-              <a:t>The network uses local filters, pooling, and a compact classifier instead of dense connections over all pixels.</a:t>
+              <a:t>The reproduction uses the original 32x32 input shape, partial connectivity, trainable subsampling, and RBF outputs.</a:t>
             </a:r>
           </a:p>
         </p:txBody>
@@ -6412,7 +6412,7 @@
           <p:cNvPr id="3" name="">
             <a:extLst xmlns:a="http://schemas.openxmlformats.org/drawingml/2006/main">
               <a:ext uri="{FF2B5EF4-FFF2-40B4-BE49-F238E27FC236}">
-                <a16:creationId xmlns:a16="http://schemas.microsoft.com/office/drawing/2014/main" id="{271945B6-0B6E-41B6-B82A-A880E19978B6}"/>
+                <a16:creationId xmlns:a16="http://schemas.microsoft.com/office/drawing/2014/main" id="{14395348-5C9F-440D-AF23-9AD40D9871C7}"/>
               </a:ext>
             </a:extLst>
           </p:cNvPr>
@@ -6445,7 +6445,7 @@
           <p:cNvPr id="4" name="">
             <a:extLst xmlns:a="http://schemas.openxmlformats.org/drawingml/2006/main">
               <a:ext uri="{FF2B5EF4-FFF2-40B4-BE49-F238E27FC236}">
-                <a16:creationId xmlns:a16="http://schemas.microsoft.com/office/drawing/2014/main" id="{26BA0079-8DA1-4C9A-8C5A-E45E421894E4}"/>
+                <a16:creationId xmlns:a16="http://schemas.microsoft.com/office/drawing/2014/main" id="{ABB04E2C-B52D-480E-8165-EAAFDE89A6FC}"/>
               </a:ext>
             </a:extLst>
           </p:cNvPr>
@@ -6478,7 +6478,7 @@
           <p:cNvPr id="5" name="">
             <a:extLst xmlns:a="http://schemas.openxmlformats.org/drawingml/2006/main">
               <a:ext uri="{FF2B5EF4-FFF2-40B4-BE49-F238E27FC236}">
-                <a16:creationId xmlns:a16="http://schemas.microsoft.com/office/drawing/2014/main" id="{AFD1A9B5-7EAB-4613-901B-BFFC15DFAB58}"/>
+                <a16:creationId xmlns:a16="http://schemas.microsoft.com/office/drawing/2014/main" id="{45BE52FD-68A9-43D4-9F66-5C6B169E672C}"/>
               </a:ext>
             </a:extLst>
           </p:cNvPr>
@@ -6528,7 +6528,7 @@
           <p:cNvPr id="6" name="">
             <a:extLst xmlns:a="http://schemas.openxmlformats.org/drawingml/2006/main">
               <a:ext uri="{FF2B5EF4-FFF2-40B4-BE49-F238E27FC236}">
-                <a16:creationId xmlns:a16="http://schemas.microsoft.com/office/drawing/2014/main" id="{15AFC294-EB8C-474B-A0B3-31DA6391510B}"/>
+                <a16:creationId xmlns:a16="http://schemas.microsoft.com/office/drawing/2014/main" id="{709808E4-049C-4D43-B309-CB4599AE646C}"/>
               </a:ext>
             </a:extLst>
           </p:cNvPr>
@@ -6568,7 +6568,7 @@
                   <a:srgbClr val="555555"/>
                 </a:solidFill>
               </a:rPr>
-              <a:t>1x28x28</a:t>
+              <a:t>1x32x32</a:t>
             </a:r>
           </a:p>
         </p:txBody>
@@ -6578,7 +6578,7 @@
           <p:cNvPr id="7" name="">
             <a:extLst xmlns:a="http://schemas.openxmlformats.org/drawingml/2006/main">
               <a:ext uri="{FF2B5EF4-FFF2-40B4-BE49-F238E27FC236}">
-                <a16:creationId xmlns:a16="http://schemas.microsoft.com/office/drawing/2014/main" id="{379DD60A-402B-48C9-87EA-D8816E36E6FA}"/>
+                <a16:creationId xmlns:a16="http://schemas.microsoft.com/office/drawing/2014/main" id="{84453A90-2298-488E-815F-C1EE73064DE8}"/>
               </a:ext>
             </a:extLst>
           </p:cNvPr>
@@ -6611,7 +6611,7 @@
           <p:cNvPr id="8" name="">
             <a:extLst xmlns:a="http://schemas.openxmlformats.org/drawingml/2006/main">
               <a:ext uri="{FF2B5EF4-FFF2-40B4-BE49-F238E27FC236}">
-                <a16:creationId xmlns:a16="http://schemas.microsoft.com/office/drawing/2014/main" id="{5E399983-8B59-41EF-A7B0-D16DFBBF6DAC}"/>
+                <a16:creationId xmlns:a16="http://schemas.microsoft.com/office/drawing/2014/main" id="{4C703B54-7B7B-4805-AA31-13A53865D4DB}"/>
               </a:ext>
             </a:extLst>
           </p:cNvPr>
@@ -6644,7 +6644,7 @@
           <p:cNvPr id="9" name="">
             <a:extLst xmlns:a="http://schemas.openxmlformats.org/drawingml/2006/main">
               <a:ext uri="{FF2B5EF4-FFF2-40B4-BE49-F238E27FC236}">
-                <a16:creationId xmlns:a16="http://schemas.microsoft.com/office/drawing/2014/main" id="{DA2939B3-6263-4548-8C9A-D78CA68275D1}"/>
+                <a16:creationId xmlns:a16="http://schemas.microsoft.com/office/drawing/2014/main" id="{B30F217B-BA93-4E5B-BD55-7C2FA1CF8CFB}"/>
               </a:ext>
             </a:extLst>
           </p:cNvPr>
@@ -6684,7 +6684,7 @@
                   <a:srgbClr val="0A0A0A"/>
                 </a:solidFill>
               </a:rPr>
-              <a:t>Conv</a:t>
+              <a:t>C1</a:t>
             </a:r>
           </a:p>
         </p:txBody>
@@ -6694,7 +6694,7 @@
           <p:cNvPr id="10" name="">
             <a:extLst xmlns:a="http://schemas.openxmlformats.org/drawingml/2006/main">
               <a:ext uri="{FF2B5EF4-FFF2-40B4-BE49-F238E27FC236}">
-                <a16:creationId xmlns:a16="http://schemas.microsoft.com/office/drawing/2014/main" id="{ACF59B5A-37E6-4E30-9058-3EE3631F6F4E}"/>
+                <a16:creationId xmlns:a16="http://schemas.microsoft.com/office/drawing/2014/main" id="{83756B3D-0D38-4D10-9937-A4312167A5D8}"/>
               </a:ext>
             </a:extLst>
           </p:cNvPr>
@@ -6744,7 +6744,7 @@
           <p:cNvPr id="11" name="">
             <a:extLst xmlns:a="http://schemas.openxmlformats.org/drawingml/2006/main">
               <a:ext uri="{FF2B5EF4-FFF2-40B4-BE49-F238E27FC236}">
-                <a16:creationId xmlns:a16="http://schemas.microsoft.com/office/drawing/2014/main" id="{54C73AC8-CD29-4B8A-83A1-A1A0DFA3E938}"/>
+                <a16:creationId xmlns:a16="http://schemas.microsoft.com/office/drawing/2014/main" id="{16C0F03C-365E-484D-9AAD-E2AC1BEA1E6F}"/>
               </a:ext>
             </a:extLst>
           </p:cNvPr>
@@ -6777,7 +6777,7 @@
           <p:cNvPr id="12" name="">
             <a:extLst xmlns:a="http://schemas.openxmlformats.org/drawingml/2006/main">
               <a:ext uri="{FF2B5EF4-FFF2-40B4-BE49-F238E27FC236}">
-                <a16:creationId xmlns:a16="http://schemas.microsoft.com/office/drawing/2014/main" id="{D602B239-EB56-4C85-821E-8930CE1EC1BE}"/>
+                <a16:creationId xmlns:a16="http://schemas.microsoft.com/office/drawing/2014/main" id="{800E1598-1FFF-47AA-BC19-493E3B0141CF}"/>
               </a:ext>
             </a:extLst>
           </p:cNvPr>
@@ -6810,7 +6810,7 @@
           <p:cNvPr id="13" name="">
             <a:extLst xmlns:a="http://schemas.openxmlformats.org/drawingml/2006/main">
               <a:ext uri="{FF2B5EF4-FFF2-40B4-BE49-F238E27FC236}">
-                <a16:creationId xmlns:a16="http://schemas.microsoft.com/office/drawing/2014/main" id="{8F5CF85F-D9AE-4374-9CDF-5A542F28C2F7}"/>
+                <a16:creationId xmlns:a16="http://schemas.microsoft.com/office/drawing/2014/main" id="{3E248C42-B87A-4CE9-A7C1-0FC76CCC66B4}"/>
               </a:ext>
             </a:extLst>
           </p:cNvPr>
@@ -6850,7 +6850,7 @@
                   <a:srgbClr val="0A0A0A"/>
                 </a:solidFill>
               </a:rPr>
-              <a:t>Avg pool</a:t>
+              <a:t>S2</a:t>
             </a:r>
           </a:p>
         </p:txBody>
@@ -6860,7 +6860,7 @@
           <p:cNvPr id="14" name="">
             <a:extLst xmlns:a="http://schemas.openxmlformats.org/drawingml/2006/main">
               <a:ext uri="{FF2B5EF4-FFF2-40B4-BE49-F238E27FC236}">
-                <a16:creationId xmlns:a16="http://schemas.microsoft.com/office/drawing/2014/main" id="{87685AC9-7963-4BA2-864C-29CB99029A5C}"/>
+                <a16:creationId xmlns:a16="http://schemas.microsoft.com/office/drawing/2014/main" id="{C5757108-FB4D-41F5-86F2-FFC67237D2BE}"/>
               </a:ext>
             </a:extLst>
           </p:cNvPr>
@@ -6900,7 +6900,7 @@
                   <a:srgbClr val="555555"/>
                 </a:solidFill>
               </a:rPr>
-              <a:t>2x2</a:t>
+              <a:t>trainable</a:t>
             </a:r>
           </a:p>
         </p:txBody>
@@ -6910,7 +6910,7 @@
           <p:cNvPr id="15" name="">
             <a:extLst xmlns:a="http://schemas.openxmlformats.org/drawingml/2006/main">
               <a:ext uri="{FF2B5EF4-FFF2-40B4-BE49-F238E27FC236}">
-                <a16:creationId xmlns:a16="http://schemas.microsoft.com/office/drawing/2014/main" id="{13379DD5-8744-49BE-96CC-E5A91FE0FA35}"/>
+                <a16:creationId xmlns:a16="http://schemas.microsoft.com/office/drawing/2014/main" id="{501C292D-838C-45D3-9861-DD44B64D727C}"/>
               </a:ext>
             </a:extLst>
           </p:cNvPr>
@@ -6943,7 +6943,7 @@
           <p:cNvPr id="16" name="">
             <a:extLst xmlns:a="http://schemas.openxmlformats.org/drawingml/2006/main">
               <a:ext uri="{FF2B5EF4-FFF2-40B4-BE49-F238E27FC236}">
-                <a16:creationId xmlns:a16="http://schemas.microsoft.com/office/drawing/2014/main" id="{93B7BB23-2132-4441-9047-5BB2298C11A8}"/>
+                <a16:creationId xmlns:a16="http://schemas.microsoft.com/office/drawing/2014/main" id="{DCE8CE45-AB1D-46D8-A3DC-8CE96AA9E5FC}"/>
               </a:ext>
             </a:extLst>
           </p:cNvPr>
@@ -6976,7 +6976,7 @@
           <p:cNvPr id="17" name="">
             <a:extLst xmlns:a="http://schemas.openxmlformats.org/drawingml/2006/main">
               <a:ext uri="{FF2B5EF4-FFF2-40B4-BE49-F238E27FC236}">
-                <a16:creationId xmlns:a16="http://schemas.microsoft.com/office/drawing/2014/main" id="{6B5B6C3E-6A48-44E7-82F6-4DB292663A52}"/>
+                <a16:creationId xmlns:a16="http://schemas.microsoft.com/office/drawing/2014/main" id="{D088CB8D-BDA2-48EC-950D-3CDAA51FBA3A}"/>
               </a:ext>
             </a:extLst>
           </p:cNvPr>
@@ -7016,7 +7016,7 @@
                   <a:srgbClr val="0A0A0A"/>
                 </a:solidFill>
               </a:rPr>
-              <a:t>Conv</a:t>
+              <a:t>C3</a:t>
             </a:r>
           </a:p>
         </p:txBody>
@@ -7026,7 +7026,7 @@
           <p:cNvPr id="18" name="">
             <a:extLst xmlns:a="http://schemas.openxmlformats.org/drawingml/2006/main">
               <a:ext uri="{FF2B5EF4-FFF2-40B4-BE49-F238E27FC236}">
-                <a16:creationId xmlns:a16="http://schemas.microsoft.com/office/drawing/2014/main" id="{9ECB4CB0-8FB4-4638-A2D0-3168F3F40498}"/>
+                <a16:creationId xmlns:a16="http://schemas.microsoft.com/office/drawing/2014/main" id="{9B7675C3-080A-4EF3-B1D6-D22BBF2D0CF7}"/>
               </a:ext>
             </a:extLst>
           </p:cNvPr>
@@ -7066,7 +7066,7 @@
                   <a:srgbClr val="555555"/>
                 </a:solidFill>
               </a:rPr>
-              <a:t>16 maps</a:t>
+              <a:t>partial</a:t>
             </a:r>
           </a:p>
         </p:txBody>
@@ -7076,7 +7076,7 @@
           <p:cNvPr id="19" name="">
             <a:extLst xmlns:a="http://schemas.openxmlformats.org/drawingml/2006/main">
               <a:ext uri="{FF2B5EF4-FFF2-40B4-BE49-F238E27FC236}">
-                <a16:creationId xmlns:a16="http://schemas.microsoft.com/office/drawing/2014/main" id="{94AF0872-29EF-4085-810E-37ADE79ED438}"/>
+                <a16:creationId xmlns:a16="http://schemas.microsoft.com/office/drawing/2014/main" id="{693AD2C5-9656-46EE-91D8-AD15153A7379}"/>
               </a:ext>
             </a:extLst>
           </p:cNvPr>
@@ -7109,7 +7109,7 @@
           <p:cNvPr id="20" name="">
             <a:extLst xmlns:a="http://schemas.openxmlformats.org/drawingml/2006/main">
               <a:ext uri="{FF2B5EF4-FFF2-40B4-BE49-F238E27FC236}">
-                <a16:creationId xmlns:a16="http://schemas.microsoft.com/office/drawing/2014/main" id="{434955F0-5A88-43E0-B33E-F26C74AEAA32}"/>
+                <a16:creationId xmlns:a16="http://schemas.microsoft.com/office/drawing/2014/main" id="{B317E9C2-034D-42E5-8D03-E85FB68FFA2F}"/>
               </a:ext>
             </a:extLst>
           </p:cNvPr>
@@ -7142,7 +7142,7 @@
           <p:cNvPr id="21" name="">
             <a:extLst xmlns:a="http://schemas.openxmlformats.org/drawingml/2006/main">
               <a:ext uri="{FF2B5EF4-FFF2-40B4-BE49-F238E27FC236}">
-                <a16:creationId xmlns:a16="http://schemas.microsoft.com/office/drawing/2014/main" id="{004D6947-E8BB-43F4-83E6-AAAB41847EE9}"/>
+                <a16:creationId xmlns:a16="http://schemas.microsoft.com/office/drawing/2014/main" id="{929A2337-1006-483B-B9A8-4F1ED6584E6D}"/>
               </a:ext>
             </a:extLst>
           </p:cNvPr>
@@ -7182,7 +7182,7 @@
                   <a:srgbClr val="0A0A0A"/>
                 </a:solidFill>
               </a:rPr>
-              <a:t>Avg pool</a:t>
+              <a:t>S4</a:t>
             </a:r>
           </a:p>
         </p:txBody>
@@ -7192,7 +7192,7 @@
           <p:cNvPr id="22" name="">
             <a:extLst xmlns:a="http://schemas.openxmlformats.org/drawingml/2006/main">
               <a:ext uri="{FF2B5EF4-FFF2-40B4-BE49-F238E27FC236}">
-                <a16:creationId xmlns:a16="http://schemas.microsoft.com/office/drawing/2014/main" id="{B50ECA52-7422-4EC4-9F91-92C04789466A}"/>
+                <a16:creationId xmlns:a16="http://schemas.microsoft.com/office/drawing/2014/main" id="{1A3089DC-CA6D-4432-BA66-DEB78793401E}"/>
               </a:ext>
             </a:extLst>
           </p:cNvPr>
@@ -7232,7 +7232,7 @@
                   <a:srgbClr val="555555"/>
                 </a:solidFill>
               </a:rPr>
-              <a:t>2x2</a:t>
+              <a:t>trainable</a:t>
             </a:r>
           </a:p>
         </p:txBody>
@@ -7242,7 +7242,7 @@
           <p:cNvPr id="23" name="">
             <a:extLst xmlns:a="http://schemas.openxmlformats.org/drawingml/2006/main">
               <a:ext uri="{FF2B5EF4-FFF2-40B4-BE49-F238E27FC236}">
-                <a16:creationId xmlns:a16="http://schemas.microsoft.com/office/drawing/2014/main" id="{9A533EF7-5968-4AC9-A698-12118BA6E9EC}"/>
+                <a16:creationId xmlns:a16="http://schemas.microsoft.com/office/drawing/2014/main" id="{F981AC48-0B97-4A62-AD36-D435AF1E0024}"/>
               </a:ext>
             </a:extLst>
           </p:cNvPr>
@@ -7275,7 +7275,7 @@
           <p:cNvPr id="24" name="">
             <a:extLst xmlns:a="http://schemas.openxmlformats.org/drawingml/2006/main">
               <a:ext uri="{FF2B5EF4-FFF2-40B4-BE49-F238E27FC236}">
-                <a16:creationId xmlns:a16="http://schemas.microsoft.com/office/drawing/2014/main" id="{80D3717E-CBCC-49DC-B1A5-FC8266382769}"/>
+                <a16:creationId xmlns:a16="http://schemas.microsoft.com/office/drawing/2014/main" id="{41D0AC83-C0D7-43DA-A279-363589F70935}"/>
               </a:ext>
             </a:extLst>
           </p:cNvPr>
@@ -7308,7 +7308,7 @@
           <p:cNvPr id="25" name="">
             <a:extLst xmlns:a="http://schemas.openxmlformats.org/drawingml/2006/main">
               <a:ext uri="{FF2B5EF4-FFF2-40B4-BE49-F238E27FC236}">
-                <a16:creationId xmlns:a16="http://schemas.microsoft.com/office/drawing/2014/main" id="{7B6BB8B4-A374-4D06-B43B-D139F1499607}"/>
+                <a16:creationId xmlns:a16="http://schemas.microsoft.com/office/drawing/2014/main" id="{E86C6E27-11B4-4F0E-AC3F-0F0C9A49AA05}"/>
               </a:ext>
             </a:extLst>
           </p:cNvPr>
@@ -7348,7 +7348,7 @@
                   <a:srgbClr val="0A0A0A"/>
                 </a:solidFill>
               </a:rPr>
-              <a:t>Dense</a:t>
+              <a:t>C5/F6</a:t>
             </a:r>
           </a:p>
         </p:txBody>
@@ -7358,7 +7358,7 @@
           <p:cNvPr id="26" name="">
             <a:extLst xmlns:a="http://schemas.openxmlformats.org/drawingml/2006/main">
               <a:ext uri="{FF2B5EF4-FFF2-40B4-BE49-F238E27FC236}">
-                <a16:creationId xmlns:a16="http://schemas.microsoft.com/office/drawing/2014/main" id="{F2B0B063-FF62-4B6E-8BF3-F8C35470BD00}"/>
+                <a16:creationId xmlns:a16="http://schemas.microsoft.com/office/drawing/2014/main" id="{FC6B96A2-A37D-4152-BB71-B37ACD924E41}"/>
               </a:ext>
             </a:extLst>
           </p:cNvPr>
@@ -7408,7 +7408,7 @@
           <p:cNvPr id="27" name="">
             <a:extLst xmlns:a="http://schemas.openxmlformats.org/drawingml/2006/main">
               <a:ext uri="{FF2B5EF4-FFF2-40B4-BE49-F238E27FC236}">
-                <a16:creationId xmlns:a16="http://schemas.microsoft.com/office/drawing/2014/main" id="{613D6DDA-0EF8-4F56-8EE0-19CBB7254C99}"/>
+                <a16:creationId xmlns:a16="http://schemas.microsoft.com/office/drawing/2014/main" id="{9E6D42B8-20F8-43E7-9793-241DBF338702}"/>
               </a:ext>
             </a:extLst>
           </p:cNvPr>
@@ -7441,7 +7441,7 @@
           <p:cNvPr id="28" name="">
             <a:extLst xmlns:a="http://schemas.openxmlformats.org/drawingml/2006/main">
               <a:ext uri="{FF2B5EF4-FFF2-40B4-BE49-F238E27FC236}">
-                <a16:creationId xmlns:a16="http://schemas.microsoft.com/office/drawing/2014/main" id="{D7C9D4F3-F030-4641-AEF6-27235E58BA94}"/>
+                <a16:creationId xmlns:a16="http://schemas.microsoft.com/office/drawing/2014/main" id="{DC6074B1-2C67-45E4-BF11-B94D35669BC2}"/>
               </a:ext>
             </a:extLst>
           </p:cNvPr>
@@ -7474,7 +7474,7 @@
           <p:cNvPr id="29" name="">
             <a:extLst xmlns:a="http://schemas.openxmlformats.org/drawingml/2006/main">
               <a:ext uri="{FF2B5EF4-FFF2-40B4-BE49-F238E27FC236}">
-                <a16:creationId xmlns:a16="http://schemas.microsoft.com/office/drawing/2014/main" id="{BD920FC4-487F-4501-AE9D-4A67F907814B}"/>
+                <a16:creationId xmlns:a16="http://schemas.microsoft.com/office/drawing/2014/main" id="{D26A704C-037D-4B29-9582-EA4DF3DBF3A2}"/>
               </a:ext>
             </a:extLst>
           </p:cNvPr>
@@ -7514,7 +7514,7 @@
                   <a:srgbClr val="0A0A0A"/>
                 </a:solidFill>
               </a:rPr>
-              <a:t>Output</a:t>
+              <a:t>RBF</a:t>
             </a:r>
           </a:p>
         </p:txBody>
@@ -7524,7 +7524,7 @@
           <p:cNvPr id="30" name="">
             <a:extLst xmlns:a="http://schemas.openxmlformats.org/drawingml/2006/main">
               <a:ext uri="{FF2B5EF4-FFF2-40B4-BE49-F238E27FC236}">
-                <a16:creationId xmlns:a16="http://schemas.microsoft.com/office/drawing/2014/main" id="{E244898B-0476-4A7B-A338-4356F749399A}"/>
+                <a16:creationId xmlns:a16="http://schemas.microsoft.com/office/drawing/2014/main" id="{C5400199-2A3B-47E6-B994-18C5A7BB1D6E}"/>
               </a:ext>
             </a:extLst>
           </p:cNvPr>
@@ -7564,7 +7564,7 @@
                   <a:srgbClr val="555555"/>
                 </a:solidFill>
               </a:rPr>
-              <a:t>10 digits</a:t>
+              <a:t>10 penalties</a:t>
             </a:r>
           </a:p>
         </p:txBody>
@@ -7574,7 +7574,7 @@
           <p:cNvPr id="31" name="">
             <a:extLst xmlns:a="http://schemas.openxmlformats.org/drawingml/2006/main">
               <a:ext uri="{FF2B5EF4-FFF2-40B4-BE49-F238E27FC236}">
-                <a16:creationId xmlns:a16="http://schemas.microsoft.com/office/drawing/2014/main" id="{0DADE5ED-76F1-420C-81BE-EDAFB12A4B54}"/>
+                <a16:creationId xmlns:a16="http://schemas.microsoft.com/office/drawing/2014/main" id="{F2D1D178-BE0E-47FD-92CC-6BC108D723A5}"/>
               </a:ext>
             </a:extLst>
           </p:cNvPr>
@@ -7614,7 +7614,7 @@
                   <a:srgbClr val="0A0A0A"/>
                 </a:solidFill>
               </a:rPr>
-              <a:t>Visible layer sizes follow the classic LeNet-5 shape: two convolutional stages, then 120 and 84 hidden units before the 10-way classifier.</a:t>
+              <a:t>The model has exactly 60,000 trainable parameters and returns class penalties: lower RBF distance means a better class match.</a:t>
             </a:r>
           </a:p>
         </p:txBody>
@@ -7624,7 +7624,7 @@
           <p:cNvPr id="32" name="">
             <a:extLst xmlns:a="http://schemas.openxmlformats.org/drawingml/2006/main">
               <a:ext uri="{FF2B5EF4-FFF2-40B4-BE49-F238E27FC236}">
-                <a16:creationId xmlns:a16="http://schemas.microsoft.com/office/drawing/2014/main" id="{5C908BC7-A300-4A32-BDDC-AD00630C3619}"/>
+                <a16:creationId xmlns:a16="http://schemas.microsoft.com/office/drawing/2014/main" id="{AAAD3765-9E9C-4F1E-8900-573ED132E7E7}"/>
               </a:ext>
             </a:extLst>
           </p:cNvPr>
@@ -7672,7 +7672,7 @@
     </p:spTree>
     <p:extLst>
       <p:ext uri="{BB962C8B-B14F-4D97-AF65-F5344CB8AC3E}">
-        <p14:creationId xmlns:p14="http://schemas.microsoft.com/office/powerpoint/2010/main" val="575742752"/>
+        <p14:creationId xmlns:p14="http://schemas.microsoft.com/office/powerpoint/2010/main" val="826038076"/>
       </p:ext>
     </p:extLst>
   </p:cSld>
@@ -7703,7 +7703,7 @@
           <p:cNvPr id="1" name="">
             <a:extLst xmlns:a="http://schemas.openxmlformats.org/drawingml/2006/main">
               <a:ext uri="{FF2B5EF4-FFF2-40B4-BE49-F238E27FC236}">
-                <a16:creationId xmlns:a16="http://schemas.microsoft.com/office/drawing/2014/main" id="{CE97F2F4-5823-4B13-9CC0-161415AD0117}"/>
+                <a16:creationId xmlns:a16="http://schemas.microsoft.com/office/drawing/2014/main" id="{06EFB648-178A-4DE3-8368-AB295C6BA76C}"/>
               </a:ext>
             </a:extLst>
           </p:cNvPr>
@@ -7743,7 +7743,7 @@
                   <a:srgbClr val="0A0A0A"/>
                 </a:solidFill>
               </a:rPr>
-              <a:t>We kept the historical shape but used modern training defaults</a:t>
+              <a:t>The implementation follows the historical LeNet-5 design</a:t>
             </a:r>
           </a:p>
         </p:txBody>
@@ -7753,7 +7753,7 @@
           <p:cNvPr id="2" name="">
             <a:extLst xmlns:a="http://schemas.openxmlformats.org/drawingml/2006/main">
               <a:ext uri="{FF2B5EF4-FFF2-40B4-BE49-F238E27FC236}">
-                <a16:creationId xmlns:a16="http://schemas.microsoft.com/office/drawing/2014/main" id="{FB40ED29-4893-494C-9746-454E5865CC9A}"/>
+                <a16:creationId xmlns:a16="http://schemas.microsoft.com/office/drawing/2014/main" id="{FE45D087-DE7A-4E00-A777-0E2FC01BE102}"/>
               </a:ext>
             </a:extLst>
           </p:cNvPr>
@@ -7793,7 +7793,7 @@
                   <a:srgbClr val="555555"/>
                 </a:solidFill>
               </a:rPr>
-              <a:t>The implementation is faithful as a teaching reproduction, not an exact historical reconstruction.</a:t>
+              <a:t>The main remaining difference is optimizer choice, not the architecture or output layer.</a:t>
             </a:r>
           </a:p>
         </p:txBody>
@@ -7803,7 +7803,7 @@
           <p:cNvPr id="3" name="">
             <a:extLst xmlns:a="http://schemas.openxmlformats.org/drawingml/2006/main">
               <a:ext uri="{FF2B5EF4-FFF2-40B4-BE49-F238E27FC236}">
-                <a16:creationId xmlns:a16="http://schemas.microsoft.com/office/drawing/2014/main" id="{986EF57A-6F47-482A-A88F-8323B9C430EB}"/>
+                <a16:creationId xmlns:a16="http://schemas.microsoft.com/office/drawing/2014/main" id="{1902467A-4485-43A5-91C3-D351F20F483E}"/>
               </a:ext>
             </a:extLst>
           </p:cNvPr>
@@ -7836,7 +7836,7 @@
           <p:cNvPr id="4" name="">
             <a:extLst xmlns:a="http://schemas.openxmlformats.org/drawingml/2006/main">
               <a:ext uri="{FF2B5EF4-FFF2-40B4-BE49-F238E27FC236}">
-                <a16:creationId xmlns:a16="http://schemas.microsoft.com/office/drawing/2014/main" id="{0B3CB6A1-3509-4C60-A213-2ED9D658BB17}"/>
+                <a16:creationId xmlns:a16="http://schemas.microsoft.com/office/drawing/2014/main" id="{9B688C53-13F3-4451-A269-C2F1F2D94B13}"/>
               </a:ext>
             </a:extLst>
           </p:cNvPr>
@@ -7869,7 +7869,7 @@
           <p:cNvPr id="5" name="">
             <a:extLst xmlns:a="http://schemas.openxmlformats.org/drawingml/2006/main">
               <a:ext uri="{FF2B5EF4-FFF2-40B4-BE49-F238E27FC236}">
-                <a16:creationId xmlns:a16="http://schemas.microsoft.com/office/drawing/2014/main" id="{E9EE81D0-61D7-4CA4-B876-BAD4B45BD9AC}"/>
+                <a16:creationId xmlns:a16="http://schemas.microsoft.com/office/drawing/2014/main" id="{2F4CF305-BA17-41C1-A14D-14F52022D987}"/>
               </a:ext>
             </a:extLst>
           </p:cNvPr>
@@ -7909,7 +7909,7 @@
                   <a:srgbClr val="0A0A0A"/>
                 </a:solidFill>
               </a:rPr>
-              <a:t>Kept</a:t>
+              <a:t>Architecture</a:t>
             </a:r>
           </a:p>
         </p:txBody>
@@ -7919,7 +7919,7 @@
           <p:cNvPr id="6" name="">
             <a:extLst xmlns:a="http://schemas.openxmlformats.org/drawingml/2006/main">
               <a:ext uri="{FF2B5EF4-FFF2-40B4-BE49-F238E27FC236}">
-                <a16:creationId xmlns:a16="http://schemas.microsoft.com/office/drawing/2014/main" id="{3705E05E-9EF1-4B38-BFAB-CFF173B091B1}"/>
+                <a16:creationId xmlns:a16="http://schemas.microsoft.com/office/drawing/2014/main" id="{87DF6CFC-5B2E-4937-82D6-20EA140E189E}"/>
               </a:ext>
             </a:extLst>
           </p:cNvPr>
@@ -7959,7 +7959,7 @@
                   <a:srgbClr val="0A0A0A"/>
                 </a:solidFill>
               </a:rPr>
-              <a:t>5x5 convolutions, tanh activations, average pooling, 120 and 84 hidden units</a:t>
+              <a:t>32x32 input, C1/S2/C3/S4/C5/F6 sizes, partial C3 connectivity</a:t>
             </a:r>
           </a:p>
         </p:txBody>
@@ -7969,7 +7969,7 @@
           <p:cNvPr id="7" name="">
             <a:extLst xmlns:a="http://schemas.openxmlformats.org/drawingml/2006/main">
               <a:ext uri="{FF2B5EF4-FFF2-40B4-BE49-F238E27FC236}">
-                <a16:creationId xmlns:a16="http://schemas.microsoft.com/office/drawing/2014/main" id="{71A3DB81-ACAC-4696-A6DD-7AEF67C0D416}"/>
+                <a16:creationId xmlns:a16="http://schemas.microsoft.com/office/drawing/2014/main" id="{5735E6B7-B652-43D4-910A-F4DF70BEA068}"/>
               </a:ext>
             </a:extLst>
           </p:cNvPr>
@@ -8002,7 +8002,7 @@
           <p:cNvPr id="8" name="">
             <a:extLst xmlns:a="http://schemas.openxmlformats.org/drawingml/2006/main">
               <a:ext uri="{FF2B5EF4-FFF2-40B4-BE49-F238E27FC236}">
-                <a16:creationId xmlns:a16="http://schemas.microsoft.com/office/drawing/2014/main" id="{25F837C0-8D4B-4E95-A3DE-27991C12ED3B}"/>
+                <a16:creationId xmlns:a16="http://schemas.microsoft.com/office/drawing/2014/main" id="{13CC1747-C882-407D-9F39-39946B0C31B0}"/>
               </a:ext>
             </a:extLst>
           </p:cNvPr>
@@ -8042,7 +8042,7 @@
                   <a:srgbClr val="0A0A0A"/>
                 </a:solidFill>
               </a:rPr>
-              <a:t>Changed</a:t>
+              <a:t>Output</a:t>
             </a:r>
           </a:p>
         </p:txBody>
@@ -8052,7 +8052,7 @@
           <p:cNvPr id="9" name="">
             <a:extLst xmlns:a="http://schemas.openxmlformats.org/drawingml/2006/main">
               <a:ext uri="{FF2B5EF4-FFF2-40B4-BE49-F238E27FC236}">
-                <a16:creationId xmlns:a16="http://schemas.microsoft.com/office/drawing/2014/main" id="{9E581B9B-EAB9-4FD5-8EB6-1EF8C58AF609}"/>
+                <a16:creationId xmlns:a16="http://schemas.microsoft.com/office/drawing/2014/main" id="{3B449C86-C57C-4E40-A22F-F6499056BFFB}"/>
               </a:ext>
             </a:extLst>
           </p:cNvPr>
@@ -8092,7 +8092,7 @@
                   <a:srgbClr val="0A0A0A"/>
                 </a:solidFill>
               </a:rPr>
-              <a:t>28x28 inputs, dense second convolution, linear output layer, cross-entropy loss</a:t>
+              <a:t>fixed Euclidean RBF prototypes with 84-dimensional +1/-1 targets</a:t>
             </a:r>
           </a:p>
         </p:txBody>
@@ -8102,7 +8102,7 @@
           <p:cNvPr id="10" name="">
             <a:extLst xmlns:a="http://schemas.openxmlformats.org/drawingml/2006/main">
               <a:ext uri="{FF2B5EF4-FFF2-40B4-BE49-F238E27FC236}">
-                <a16:creationId xmlns:a16="http://schemas.microsoft.com/office/drawing/2014/main" id="{4F2733FA-EA7B-4FC8-9487-1B700DB0D616}"/>
+                <a16:creationId xmlns:a16="http://schemas.microsoft.com/office/drawing/2014/main" id="{6C081B0D-67AB-488A-BB78-55FF8DB261A8}"/>
               </a:ext>
             </a:extLst>
           </p:cNvPr>
@@ -8135,7 +8135,7 @@
           <p:cNvPr id="11" name="">
             <a:extLst xmlns:a="http://schemas.openxmlformats.org/drawingml/2006/main">
               <a:ext uri="{FF2B5EF4-FFF2-40B4-BE49-F238E27FC236}">
-                <a16:creationId xmlns:a16="http://schemas.microsoft.com/office/drawing/2014/main" id="{02208B22-96EE-4969-AB59-B8AF95E16C41}"/>
+                <a16:creationId xmlns:a16="http://schemas.microsoft.com/office/drawing/2014/main" id="{DA39B7AE-736F-4CF5-83F1-560C81616630}"/>
               </a:ext>
             </a:extLst>
           </p:cNvPr>
@@ -8175,7 +8175,7 @@
                   <a:srgbClr val="0A0A0A"/>
                 </a:solidFill>
               </a:rPr>
-              <a:t>Reason</a:t>
+              <a:t>Training</a:t>
             </a:r>
           </a:p>
         </p:txBody>
@@ -8185,7 +8185,7 @@
           <p:cNvPr id="12" name="">
             <a:extLst xmlns:a="http://schemas.openxmlformats.org/drawingml/2006/main">
               <a:ext uri="{FF2B5EF4-FFF2-40B4-BE49-F238E27FC236}">
-                <a16:creationId xmlns:a16="http://schemas.microsoft.com/office/drawing/2014/main" id="{E69905EA-2650-4C10-823C-948E01439BDB}"/>
+                <a16:creationId xmlns:a16="http://schemas.microsoft.com/office/drawing/2014/main" id="{CAE8D12D-D51B-4052-BE13-0D4CB0B6CAFD}"/>
               </a:ext>
             </a:extLst>
           </p:cNvPr>
@@ -8225,7 +8225,7 @@
                   <a:srgbClr val="0A0A0A"/>
                 </a:solidFill>
               </a:rPr>
-              <a:t>Modern PyTorch conventions make the run shorter, clearer, and easier to reproduce</a:t>
+              <a:t>MAP-style penalty loss; Adam optimizer used for reproducible PyTorch training</a:t>
             </a:r>
           </a:p>
         </p:txBody>
@@ -8235,7 +8235,7 @@
           <p:cNvPr id="13" name="">
             <a:extLst xmlns:a="http://schemas.openxmlformats.org/drawingml/2006/main">
               <a:ext uri="{FF2B5EF4-FFF2-40B4-BE49-F238E27FC236}">
-                <a16:creationId xmlns:a16="http://schemas.microsoft.com/office/drawing/2014/main" id="{9BC83230-47FF-4DA8-A063-308D6EE3794F}"/>
+                <a16:creationId xmlns:a16="http://schemas.microsoft.com/office/drawing/2014/main" id="{62D76708-1CA0-4B4E-9EDA-9FAFA4BFF9A7}"/>
               </a:ext>
             </a:extLst>
           </p:cNvPr>
@@ -8283,7 +8283,7 @@
     </p:spTree>
     <p:extLst>
       <p:ext uri="{BB962C8B-B14F-4D97-AF65-F5344CB8AC3E}">
-        <p14:creationId xmlns:p14="http://schemas.microsoft.com/office/powerpoint/2010/main" val="977513746"/>
+        <p14:creationId xmlns:p14="http://schemas.microsoft.com/office/powerpoint/2010/main" val="374820961"/>
       </p:ext>
     </p:extLst>
   </p:cSld>
@@ -8314,7 +8314,7 @@
           <p:cNvPr id="1" name="">
             <a:extLst xmlns:a="http://schemas.openxmlformats.org/drawingml/2006/main">
               <a:ext uri="{FF2B5EF4-FFF2-40B4-BE49-F238E27FC236}">
-                <a16:creationId xmlns:a16="http://schemas.microsoft.com/office/drawing/2014/main" id="{706C35B1-5358-43CF-BEB3-36B875D72700}"/>
+                <a16:creationId xmlns:a16="http://schemas.microsoft.com/office/drawing/2014/main" id="{EA99EF15-561F-4585-B6FB-D5220D989E64}"/>
               </a:ext>
             </a:extLst>
           </p:cNvPr>
@@ -8364,7 +8364,7 @@
           <p:cNvPr id="2" name="">
             <a:extLst xmlns:a="http://schemas.openxmlformats.org/drawingml/2006/main">
               <a:ext uri="{FF2B5EF4-FFF2-40B4-BE49-F238E27FC236}">
-                <a16:creationId xmlns:a16="http://schemas.microsoft.com/office/drawing/2014/main" id="{C5A46C39-9223-49B8-A5B4-2C3BF39FF9A8}"/>
+                <a16:creationId xmlns:a16="http://schemas.microsoft.com/office/drawing/2014/main" id="{98882252-6BE0-4E55-893E-DF5C8EF8A937}"/>
               </a:ext>
             </a:extLst>
           </p:cNvPr>
@@ -8414,7 +8414,7 @@
           <p:cNvPr id="3" name="">
             <a:extLst xmlns:a="http://schemas.openxmlformats.org/drawingml/2006/main">
               <a:ext uri="{FF2B5EF4-FFF2-40B4-BE49-F238E27FC236}">
-                <a16:creationId xmlns:a16="http://schemas.microsoft.com/office/drawing/2014/main" id="{901F9B4A-4898-446D-BCEF-8146C9396782}"/>
+                <a16:creationId xmlns:a16="http://schemas.microsoft.com/office/drawing/2014/main" id="{733896CE-D376-4F21-B176-F58185D30507}"/>
               </a:ext>
             </a:extLst>
           </p:cNvPr>
@@ -8447,7 +8447,7 @@
           <p:cNvPr id="4" name="">
             <a:extLst xmlns:a="http://schemas.openxmlformats.org/drawingml/2006/main">
               <a:ext uri="{FF2B5EF4-FFF2-40B4-BE49-F238E27FC236}">
-                <a16:creationId xmlns:a16="http://schemas.microsoft.com/office/drawing/2014/main" id="{38D182A4-1546-49DA-841A-9B93727DDB0C}"/>
+                <a16:creationId xmlns:a16="http://schemas.microsoft.com/office/drawing/2014/main" id="{FB122D4C-F11E-4681-8C71-4E24BA1E21C6}"/>
               </a:ext>
             </a:extLst>
           </p:cNvPr>
@@ -8480,7 +8480,7 @@
           <p:cNvPr id="5" name="">
             <a:extLst xmlns:a="http://schemas.openxmlformats.org/drawingml/2006/main">
               <a:ext uri="{FF2B5EF4-FFF2-40B4-BE49-F238E27FC236}">
-                <a16:creationId xmlns:a16="http://schemas.microsoft.com/office/drawing/2014/main" id="{A2561DDA-33CD-43C9-B0EE-B880A26F986E}"/>
+                <a16:creationId xmlns:a16="http://schemas.microsoft.com/office/drawing/2014/main" id="{BF0314A8-A4A8-4C34-AFC7-EE38C0E3428B}"/>
               </a:ext>
             </a:extLst>
           </p:cNvPr>
@@ -8530,7 +8530,7 @@
           <p:cNvPr id="6" name="">
             <a:extLst xmlns:a="http://schemas.openxmlformats.org/drawingml/2006/main">
               <a:ext uri="{FF2B5EF4-FFF2-40B4-BE49-F238E27FC236}">
-                <a16:creationId xmlns:a16="http://schemas.microsoft.com/office/drawing/2014/main" id="{E7460D28-5108-4269-A421-CEAF8E2A9E00}"/>
+                <a16:creationId xmlns:a16="http://schemas.microsoft.com/office/drawing/2014/main" id="{E8F133A6-1AF3-4DB3-9306-E08A3E011C0B}"/>
               </a:ext>
             </a:extLst>
           </p:cNvPr>
@@ -8580,7 +8580,7 @@
           <p:cNvPr id="7" name="">
             <a:extLst xmlns:a="http://schemas.openxmlformats.org/drawingml/2006/main">
               <a:ext uri="{FF2B5EF4-FFF2-40B4-BE49-F238E27FC236}">
-                <a16:creationId xmlns:a16="http://schemas.microsoft.com/office/drawing/2014/main" id="{2A326C96-D447-4B0A-93EA-39A1C4CAB966}"/>
+                <a16:creationId xmlns:a16="http://schemas.microsoft.com/office/drawing/2014/main" id="{83B8AC61-3B56-4F58-8789-424F898DC5C3}"/>
               </a:ext>
             </a:extLst>
           </p:cNvPr>
@@ -8630,7 +8630,7 @@
           <p:cNvPr id="8" name="">
             <a:extLst xmlns:a="http://schemas.openxmlformats.org/drawingml/2006/main">
               <a:ext uri="{FF2B5EF4-FFF2-40B4-BE49-F238E27FC236}">
-                <a16:creationId xmlns:a16="http://schemas.microsoft.com/office/drawing/2014/main" id="{8F780CBB-02B8-4F27-BCED-7FCDC6DE4ECF}"/>
+                <a16:creationId xmlns:a16="http://schemas.microsoft.com/office/drawing/2014/main" id="{3EABE135-7C24-4511-BDCB-499F34CBD98D}"/>
               </a:ext>
             </a:extLst>
           </p:cNvPr>
@@ -8680,7 +8680,7 @@
           <p:cNvPr id="9" name="">
             <a:extLst xmlns:a="http://schemas.openxmlformats.org/drawingml/2006/main">
               <a:ext uri="{FF2B5EF4-FFF2-40B4-BE49-F238E27FC236}">
-                <a16:creationId xmlns:a16="http://schemas.microsoft.com/office/drawing/2014/main" id="{09DD8FFA-689E-4696-A9E3-7D25F8842C67}"/>
+                <a16:creationId xmlns:a16="http://schemas.microsoft.com/office/drawing/2014/main" id="{8DAB78D5-1CDE-44C4-BD6D-41CEA2C35C4D}"/>
               </a:ext>
             </a:extLst>
           </p:cNvPr>
@@ -8730,7 +8730,7 @@
           <p:cNvPr id="10" name="">
             <a:extLst xmlns:a="http://schemas.openxmlformats.org/drawingml/2006/main">
               <a:ext uri="{FF2B5EF4-FFF2-40B4-BE49-F238E27FC236}">
-                <a16:creationId xmlns:a16="http://schemas.microsoft.com/office/drawing/2014/main" id="{40C226C7-D148-4997-8AC6-FDA8D74B26FB}"/>
+                <a16:creationId xmlns:a16="http://schemas.microsoft.com/office/drawing/2014/main" id="{CA2D5BC3-B7AE-4600-9CCA-FA421BADD7B6}"/>
               </a:ext>
             </a:extLst>
           </p:cNvPr>
@@ -8780,7 +8780,7 @@
           <p:cNvPr id="11" name="">
             <a:extLst xmlns:a="http://schemas.openxmlformats.org/drawingml/2006/main">
               <a:ext uri="{FF2B5EF4-FFF2-40B4-BE49-F238E27FC236}">
-                <a16:creationId xmlns:a16="http://schemas.microsoft.com/office/drawing/2014/main" id="{A517B618-4737-41A0-80B5-58908358EC6E}"/>
+                <a16:creationId xmlns:a16="http://schemas.microsoft.com/office/drawing/2014/main" id="{AF9F219D-1696-4D75-BB6E-3138268A3D28}"/>
               </a:ext>
             </a:extLst>
           </p:cNvPr>
@@ -8830,7 +8830,7 @@
           <p:cNvPr id="12" name="">
             <a:extLst xmlns:a="http://schemas.openxmlformats.org/drawingml/2006/main">
               <a:ext uri="{FF2B5EF4-FFF2-40B4-BE49-F238E27FC236}">
-                <a16:creationId xmlns:a16="http://schemas.microsoft.com/office/drawing/2014/main" id="{20819D13-BC6A-4498-B970-89590162402D}"/>
+                <a16:creationId xmlns:a16="http://schemas.microsoft.com/office/drawing/2014/main" id="{93BAD2F5-3665-4BEF-8849-82D66FB95F09}"/>
               </a:ext>
             </a:extLst>
           </p:cNvPr>
@@ -8880,7 +8880,7 @@
           <p:cNvPr id="13" name="">
             <a:extLst xmlns:a="http://schemas.openxmlformats.org/drawingml/2006/main">
               <a:ext uri="{FF2B5EF4-FFF2-40B4-BE49-F238E27FC236}">
-                <a16:creationId xmlns:a16="http://schemas.microsoft.com/office/drawing/2014/main" id="{A5409127-E783-4B3B-B0ED-C32B2A15DDCC}"/>
+                <a16:creationId xmlns:a16="http://schemas.microsoft.com/office/drawing/2014/main" id="{8F0696F5-9671-45A2-AF71-53E7DBA0EE52}"/>
               </a:ext>
             </a:extLst>
           </p:cNvPr>
@@ -8908,19 +8908,19 @@
           <a:lstStyle xmlns:a="http://schemas.openxmlformats.org/drawingml/2006/main"/>
           <a:p xmlns:a="http://schemas.openxmlformats.org/drawingml/2006/main">
             <a:pPr algn="ctr">
-              <a:defRPr sz="1950" b="0">
-                <a:solidFill>
-                  <a:srgbClr val="0A0A0A"/>
-                </a:solidFill>
-              </a:defRPr>
-            </a:pPr>
-            <a:r>
-              <a:rPr sz="1950" b="0">
-                <a:solidFill>
-                  <a:srgbClr val="0A0A0A"/>
-                </a:solidFill>
-              </a:rPr>
-              <a:t>Optimizer: Adam | Loss: cross-entropy | Seed: 42 | Device used in final run: CPU</a:t>
+              <a:defRPr sz="1875" b="0">
+                <a:solidFill>
+                  <a:srgbClr val="0A0A0A"/>
+                </a:solidFill>
+              </a:defRPr>
+            </a:pPr>
+            <a:r>
+              <a:rPr sz="1875" b="0">
+                <a:solidFill>
+                  <a:srgbClr val="0A0A0A"/>
+                </a:solidFill>
+              </a:rPr>
+              <a:t>Optimizer: Adam | Loss: LeNet MAP-style RBF penalty | Seed: 42 | Device: CPU</a:t>
             </a:r>
           </a:p>
         </p:txBody>
@@ -8930,7 +8930,7 @@
           <p:cNvPr id="14" name="">
             <a:extLst xmlns:a="http://schemas.openxmlformats.org/drawingml/2006/main">
               <a:ext uri="{FF2B5EF4-FFF2-40B4-BE49-F238E27FC236}">
-                <a16:creationId xmlns:a16="http://schemas.microsoft.com/office/drawing/2014/main" id="{FCB4AA4E-B813-4B81-84C3-5064CC8EAEB9}"/>
+                <a16:creationId xmlns:a16="http://schemas.microsoft.com/office/drawing/2014/main" id="{11107F75-0876-47FF-9AE4-D09150123A60}"/>
               </a:ext>
             </a:extLst>
           </p:cNvPr>
@@ -8978,7 +8978,7 @@
     </p:spTree>
     <p:extLst>
       <p:ext uri="{BB962C8B-B14F-4D97-AF65-F5344CB8AC3E}">
-        <p14:creationId xmlns:p14="http://schemas.microsoft.com/office/powerpoint/2010/main" val="1818233064"/>
+        <p14:creationId xmlns:p14="http://schemas.microsoft.com/office/powerpoint/2010/main" val="1718644097"/>
       </p:ext>
     </p:extLst>
   </p:cSld>
@@ -9009,7 +9009,7 @@
           <p:cNvPr id="1" name="">
             <a:extLst xmlns:a="http://schemas.openxmlformats.org/drawingml/2006/main">
               <a:ext uri="{FF2B5EF4-FFF2-40B4-BE49-F238E27FC236}">
-                <a16:creationId xmlns:a16="http://schemas.microsoft.com/office/drawing/2014/main" id="{7C0F5193-0252-480D-B4A9-396D53C95433}"/>
+                <a16:creationId xmlns:a16="http://schemas.microsoft.com/office/drawing/2014/main" id="{8DCD96B3-14A0-44A0-98EF-F3667C663035}"/>
               </a:ext>
             </a:extLst>
           </p:cNvPr>
@@ -9059,7 +9059,7 @@
           <p:cNvPr id="2" name="">
             <a:extLst xmlns:a="http://schemas.openxmlformats.org/drawingml/2006/main">
               <a:ext uri="{FF2B5EF4-FFF2-40B4-BE49-F238E27FC236}">
-                <a16:creationId xmlns:a16="http://schemas.microsoft.com/office/drawing/2014/main" id="{8747F963-2948-4707-9AAB-0C81F942CB68}"/>
+                <a16:creationId xmlns:a16="http://schemas.microsoft.com/office/drawing/2014/main" id="{88DF1D75-2A5D-4255-B36E-18EC5429D7CB}"/>
               </a:ext>
             </a:extLst>
           </p:cNvPr>
@@ -9109,7 +9109,7 @@
           <p:cNvPr id="3" name="">
             <a:extLst xmlns:a="http://schemas.openxmlformats.org/drawingml/2006/main">
               <a:ext uri="{FF2B5EF4-FFF2-40B4-BE49-F238E27FC236}">
-                <a16:creationId xmlns:a16="http://schemas.microsoft.com/office/drawing/2014/main" id="{14FE1B3F-A0BC-42F8-B609-A87C902FE146}"/>
+                <a16:creationId xmlns:a16="http://schemas.microsoft.com/office/drawing/2014/main" id="{365A2BA7-39B2-434D-B609-4E37734A5754}"/>
               </a:ext>
             </a:extLst>
           </p:cNvPr>
@@ -9142,7 +9142,7 @@
           <p:cNvPr id="4" name="">
             <a:extLst xmlns:a="http://schemas.openxmlformats.org/drawingml/2006/main">
               <a:ext uri="{FF2B5EF4-FFF2-40B4-BE49-F238E27FC236}">
-                <a16:creationId xmlns:a16="http://schemas.microsoft.com/office/drawing/2014/main" id="{201A6045-6A45-4571-880C-3CA094616302}"/>
+                <a16:creationId xmlns:a16="http://schemas.microsoft.com/office/drawing/2014/main" id="{22AB5943-143C-4AD2-9312-CCDF95B3917D}"/>
               </a:ext>
             </a:extLst>
           </p:cNvPr>
@@ -9182,7 +9182,7 @@
                   <a:srgbClr val="2F7D55"/>
                 </a:solidFill>
               </a:rPr>
-              <a:t>98.68%</a:t>
+              <a:t>98.64%</a:t>
             </a:r>
           </a:p>
         </p:txBody>
@@ -9192,7 +9192,7 @@
           <p:cNvPr id="5" name="">
             <a:extLst xmlns:a="http://schemas.openxmlformats.org/drawingml/2006/main">
               <a:ext uri="{FF2B5EF4-FFF2-40B4-BE49-F238E27FC236}">
-                <a16:creationId xmlns:a16="http://schemas.microsoft.com/office/drawing/2014/main" id="{54785B79-E7BA-4A6E-BAF1-D194E5A5DA45}"/>
+                <a16:creationId xmlns:a16="http://schemas.microsoft.com/office/drawing/2014/main" id="{8B421B35-1530-4223-9A1F-BCCE5A63B2D3}"/>
               </a:ext>
             </a:extLst>
           </p:cNvPr>
@@ -9242,7 +9242,7 @@
           <p:cNvPr id="6" name="">
             <a:extLst xmlns:a="http://schemas.openxmlformats.org/drawingml/2006/main">
               <a:ext uri="{FF2B5EF4-FFF2-40B4-BE49-F238E27FC236}">
-                <a16:creationId xmlns:a16="http://schemas.microsoft.com/office/drawing/2014/main" id="{1CC6A8EF-B9B9-45E4-BFE0-83317355B438}"/>
+                <a16:creationId xmlns:a16="http://schemas.microsoft.com/office/drawing/2014/main" id="{E876E325-BAB1-489D-97D6-28AEE4969706}"/>
               </a:ext>
             </a:extLst>
           </p:cNvPr>
@@ -9282,7 +9282,7 @@
                   <a:srgbClr val="2F7D55"/>
                 </a:solidFill>
               </a:rPr>
-              <a:t>98.83%</a:t>
+              <a:t>98.87%</a:t>
             </a:r>
           </a:p>
         </p:txBody>
@@ -9292,7 +9292,7 @@
           <p:cNvPr id="7" name="">
             <a:extLst xmlns:a="http://schemas.openxmlformats.org/drawingml/2006/main">
               <a:ext uri="{FF2B5EF4-FFF2-40B4-BE49-F238E27FC236}">
-                <a16:creationId xmlns:a16="http://schemas.microsoft.com/office/drawing/2014/main" id="{E470DCE0-FAB2-4BF8-8918-BCF452E51F4D}"/>
+                <a16:creationId xmlns:a16="http://schemas.microsoft.com/office/drawing/2014/main" id="{5A62FC40-51EC-4365-B8B3-DDE7F2B511A6}"/>
               </a:ext>
             </a:extLst>
           </p:cNvPr>
@@ -9342,7 +9342,7 @@
           <p:cNvPr id="8" name="">
             <a:extLst xmlns:a="http://schemas.openxmlformats.org/drawingml/2006/main">
               <a:ext uri="{FF2B5EF4-FFF2-40B4-BE49-F238E27FC236}">
-                <a16:creationId xmlns:a16="http://schemas.microsoft.com/office/drawing/2014/main" id="{1BA54492-775B-4D4B-B059-4E1092CBC48F}"/>
+                <a16:creationId xmlns:a16="http://schemas.microsoft.com/office/drawing/2014/main" id="{9B50BC61-5725-44E2-94E7-775AC4478748}"/>
               </a:ext>
             </a:extLst>
           </p:cNvPr>
@@ -9382,7 +9382,7 @@
                   <a:srgbClr val="FF6B35"/>
                 </a:solidFill>
               </a:rPr>
-              <a:t>1.17%</a:t>
+              <a:t>1.13%</a:t>
             </a:r>
           </a:p>
         </p:txBody>
@@ -9392,7 +9392,7 @@
           <p:cNvPr id="9" name="">
             <a:extLst xmlns:a="http://schemas.openxmlformats.org/drawingml/2006/main">
               <a:ext uri="{FF2B5EF4-FFF2-40B4-BE49-F238E27FC236}">
-                <a16:creationId xmlns:a16="http://schemas.microsoft.com/office/drawing/2014/main" id="{180920EC-7894-4B91-ACC3-3A266CE7C89B}"/>
+                <a16:creationId xmlns:a16="http://schemas.microsoft.com/office/drawing/2014/main" id="{32B2837C-ACF5-4C4A-A13F-7E20FE44B0B6}"/>
               </a:ext>
             </a:extLst>
           </p:cNvPr>
@@ -9442,7 +9442,7 @@
           <p:cNvPr id="10" name="">
             <a:extLst xmlns:a="http://schemas.openxmlformats.org/drawingml/2006/main">
               <a:ext uri="{FF2B5EF4-FFF2-40B4-BE49-F238E27FC236}">
-                <a16:creationId xmlns:a16="http://schemas.microsoft.com/office/drawing/2014/main" id="{428A9706-4C14-4B70-97FB-0E14D6A9EBB8}"/>
+                <a16:creationId xmlns:a16="http://schemas.microsoft.com/office/drawing/2014/main" id="{821C5BCD-0B54-4F70-BB8C-61F4D1432E3D}"/>
               </a:ext>
             </a:extLst>
           </p:cNvPr>
@@ -9475,7 +9475,7 @@
           <p:cNvPr id="11" name="">
             <a:extLst xmlns:a="http://schemas.openxmlformats.org/drawingml/2006/main">
               <a:ext uri="{FF2B5EF4-FFF2-40B4-BE49-F238E27FC236}">
-                <a16:creationId xmlns:a16="http://schemas.microsoft.com/office/drawing/2014/main" id="{582052EE-0EE2-4B25-8341-9590BE7807DD}"/>
+                <a16:creationId xmlns:a16="http://schemas.microsoft.com/office/drawing/2014/main" id="{BC929E3C-309E-4AF3-8A18-F7A866D38B9C}"/>
               </a:ext>
             </a:extLst>
           </p:cNvPr>
@@ -9515,7 +9515,7 @@
                   <a:srgbClr val="0A0A0A"/>
                 </a:solidFill>
               </a:rPr>
-              <a:t>This satisfies the course feasibility constraint comfortably: the full final run trained end-to-end on CPU in 16.81 seconds.</a:t>
+              <a:t>This satisfies the course feasibility constraint comfortably: the full final run trained end-to-end on CPU in 125.94 seconds.</a:t>
             </a:r>
           </a:p>
         </p:txBody>
@@ -9525,7 +9525,7 @@
           <p:cNvPr id="12" name="">
             <a:extLst xmlns:a="http://schemas.openxmlformats.org/drawingml/2006/main">
               <a:ext uri="{FF2B5EF4-FFF2-40B4-BE49-F238E27FC236}">
-                <a16:creationId xmlns:a16="http://schemas.microsoft.com/office/drawing/2014/main" id="{2D6B3F65-9525-4895-92A1-042D648B62BA}"/>
+                <a16:creationId xmlns:a16="http://schemas.microsoft.com/office/drawing/2014/main" id="{2AB3AA5E-4C64-48B1-8A39-2F2087F7CE74}"/>
               </a:ext>
             </a:extLst>
           </p:cNvPr>
@@ -9573,7 +9573,7 @@
     </p:spTree>
     <p:extLst>
       <p:ext uri="{BB962C8B-B14F-4D97-AF65-F5344CB8AC3E}">
-        <p14:creationId xmlns:p14="http://schemas.microsoft.com/office/powerpoint/2010/main" val="1556067604"/>
+        <p14:creationId xmlns:p14="http://schemas.microsoft.com/office/powerpoint/2010/main" val="373262540"/>
       </p:ext>
     </p:extLst>
   </p:cSld>
@@ -9604,7 +9604,7 @@
           <p:cNvPr id="1" name="">
             <a:extLst xmlns:a="http://schemas.openxmlformats.org/drawingml/2006/main">
               <a:ext uri="{FF2B5EF4-FFF2-40B4-BE49-F238E27FC236}">
-                <a16:creationId xmlns:a16="http://schemas.microsoft.com/office/drawing/2014/main" id="{B5838D07-97AA-40BC-92AE-34F04CF80BDC}"/>
+                <a16:creationId xmlns:a16="http://schemas.microsoft.com/office/drawing/2014/main" id="{4FBC79F7-96E4-4C87-A8B8-DD46B3DB1A39}"/>
               </a:ext>
             </a:extLst>
           </p:cNvPr>
@@ -9644,7 +9644,7 @@
                   <a:srgbClr val="0A0A0A"/>
                 </a:solidFill>
               </a:rPr>
-              <a:t>Training is stable and mostly converged after eight epochs</a:t>
+              <a:t>Training is stable across the 20-epoch historical run</a:t>
             </a:r>
           </a:p>
         </p:txBody>
@@ -9654,7 +9654,7 @@
           <p:cNvPr id="2" name="">
             <a:extLst xmlns:a="http://schemas.openxmlformats.org/drawingml/2006/main">
               <a:ext uri="{FF2B5EF4-FFF2-40B4-BE49-F238E27FC236}">
-                <a16:creationId xmlns:a16="http://schemas.microsoft.com/office/drawing/2014/main" id="{3E3F0357-4B3C-4B15-8E5B-48DF8953E4E3}"/>
+                <a16:creationId xmlns:a16="http://schemas.microsoft.com/office/drawing/2014/main" id="{7648788D-8A8B-44E3-9303-199823FC4BD6}"/>
               </a:ext>
             </a:extLst>
           </p:cNvPr>
@@ -9694,7 +9694,7 @@
                   <a:srgbClr val="555555"/>
                 </a:solidFill>
               </a:rPr>
-              <a:t>Loss continues to improve while validation accuracy plateaus near 98.7%.</a:t>
+              <a:t>Loss continues to improve while validation accuracy plateaus near 98.6%.</a:t>
             </a:r>
           </a:p>
         </p:txBody>
@@ -9704,7 +9704,7 @@
           <p:cNvPr id="3" name="">
             <a:extLst xmlns:a="http://schemas.openxmlformats.org/drawingml/2006/main">
               <a:ext uri="{FF2B5EF4-FFF2-40B4-BE49-F238E27FC236}">
-                <a16:creationId xmlns:a16="http://schemas.microsoft.com/office/drawing/2014/main" id="{9A4E3B85-FDA6-420C-A65C-E1D32A590730}"/>
+                <a16:creationId xmlns:a16="http://schemas.microsoft.com/office/drawing/2014/main" id="{5EA91628-EABE-4258-A6A5-EECC517A2B09}"/>
               </a:ext>
             </a:extLst>
           </p:cNvPr>
@@ -9741,7 +9741,7 @@
           <p:nvPr/>
         </p:nvPicPr>
         <p:blipFill>
-          <a:blip xmlns:r="http://schemas.openxmlformats.org/officeDocument/2006/relationships" xmlns:a="http://schemas.openxmlformats.org/drawingml/2006/main" r:embed="Re190ff99454c4977"/>
+          <a:blip xmlns:r="http://schemas.openxmlformats.org/officeDocument/2006/relationships" xmlns:a="http://schemas.openxmlformats.org/drawingml/2006/main" r:embed="R1ae15f820ec6407a"/>
           <a:stretch xmlns:a="http://schemas.openxmlformats.org/drawingml/2006/main"/>
         </p:blipFill>
         <p:spPr>
@@ -9759,7 +9759,7 @@
           <p:cNvPr id="5" name="">
             <a:extLst xmlns:a="http://schemas.openxmlformats.org/drawingml/2006/main">
               <a:ext uri="{FF2B5EF4-FFF2-40B4-BE49-F238E27FC236}">
-                <a16:creationId xmlns:a16="http://schemas.microsoft.com/office/drawing/2014/main" id="{88DC9BD3-F22A-4C65-9EB8-7511186D131E}"/>
+                <a16:creationId xmlns:a16="http://schemas.microsoft.com/office/drawing/2014/main" id="{080D701E-2B59-4B3C-A2B9-48A15B99FE72}"/>
               </a:ext>
             </a:extLst>
           </p:cNvPr>
@@ -9807,7 +9807,7 @@
     </p:spTree>
     <p:extLst>
       <p:ext uri="{BB962C8B-B14F-4D97-AF65-F5344CB8AC3E}">
-        <p14:creationId xmlns:p14="http://schemas.microsoft.com/office/powerpoint/2010/main" val="455385943"/>
+        <p14:creationId xmlns:p14="http://schemas.microsoft.com/office/powerpoint/2010/main" val="1676395302"/>
       </p:ext>
     </p:extLst>
   </p:cSld>
@@ -9838,7 +9838,7 @@
           <p:cNvPr id="1" name="">
             <a:extLst xmlns:a="http://schemas.openxmlformats.org/drawingml/2006/main">
               <a:ext uri="{FF2B5EF4-FFF2-40B4-BE49-F238E27FC236}">
-                <a16:creationId xmlns:a16="http://schemas.microsoft.com/office/drawing/2014/main" id="{777F97D5-1DC9-4BCF-842B-7ED720A12779}"/>
+                <a16:creationId xmlns:a16="http://schemas.microsoft.com/office/drawing/2014/main" id="{B43A1F37-39C0-41D2-B6F1-F419B0AD9C36}"/>
               </a:ext>
             </a:extLst>
           </p:cNvPr>
@@ -9888,7 +9888,7 @@
           <p:cNvPr id="2" name="">
             <a:extLst xmlns:a="http://schemas.openxmlformats.org/drawingml/2006/main">
               <a:ext uri="{FF2B5EF4-FFF2-40B4-BE49-F238E27FC236}">
-                <a16:creationId xmlns:a16="http://schemas.microsoft.com/office/drawing/2014/main" id="{8B5F0843-F57F-4707-8811-3CE6066DB0E4}"/>
+                <a16:creationId xmlns:a16="http://schemas.microsoft.com/office/drawing/2014/main" id="{0905AF6A-38B5-44E1-9DE5-01527846BD19}"/>
               </a:ext>
             </a:extLst>
           </p:cNvPr>
@@ -9938,7 +9938,7 @@
           <p:cNvPr id="3" name="">
             <a:extLst xmlns:a="http://schemas.openxmlformats.org/drawingml/2006/main">
               <a:ext uri="{FF2B5EF4-FFF2-40B4-BE49-F238E27FC236}">
-                <a16:creationId xmlns:a16="http://schemas.microsoft.com/office/drawing/2014/main" id="{F90CCC89-CBD6-432D-B470-C213E3104AF3}"/>
+                <a16:creationId xmlns:a16="http://schemas.microsoft.com/office/drawing/2014/main" id="{76B27015-DB1B-41D9-9779-1A0CFE24219B}"/>
               </a:ext>
             </a:extLst>
           </p:cNvPr>
@@ -9975,7 +9975,7 @@
           <p:nvPr/>
         </p:nvPicPr>
         <p:blipFill>
-          <a:blip xmlns:r="http://schemas.openxmlformats.org/officeDocument/2006/relationships" xmlns:a="http://schemas.openxmlformats.org/drawingml/2006/main" r:embed="R12f52168497e4e30"/>
+          <a:blip xmlns:r="http://schemas.openxmlformats.org/officeDocument/2006/relationships" xmlns:a="http://schemas.openxmlformats.org/drawingml/2006/main" r:embed="R90344c7c46174d9e"/>
           <a:stretch xmlns:a="http://schemas.openxmlformats.org/drawingml/2006/main"/>
         </p:blipFill>
         <p:spPr>
@@ -9993,7 +9993,7 @@
           <p:cNvPr id="5" name="">
             <a:extLst xmlns:a="http://schemas.openxmlformats.org/drawingml/2006/main">
               <a:ext uri="{FF2B5EF4-FFF2-40B4-BE49-F238E27FC236}">
-                <a16:creationId xmlns:a16="http://schemas.microsoft.com/office/drawing/2014/main" id="{7818F936-0E3A-43A0-AC08-A7E4CFC2C548}"/>
+                <a16:creationId xmlns:a16="http://schemas.microsoft.com/office/drawing/2014/main" id="{184CE308-DE9F-4F13-A831-47F9A0144E6D}"/>
               </a:ext>
             </a:extLst>
           </p:cNvPr>
@@ -10026,7 +10026,7 @@
           <p:cNvPr id="6" name="">
             <a:extLst xmlns:a="http://schemas.openxmlformats.org/drawingml/2006/main">
               <a:ext uri="{FF2B5EF4-FFF2-40B4-BE49-F238E27FC236}">
-                <a16:creationId xmlns:a16="http://schemas.microsoft.com/office/drawing/2014/main" id="{3FF26019-D3BA-4D63-965C-6A6DAD7C248B}"/>
+                <a16:creationId xmlns:a16="http://schemas.microsoft.com/office/drawing/2014/main" id="{30841130-2D1F-4ACB-B97C-CF82AC4C9252}"/>
               </a:ext>
             </a:extLst>
           </p:cNvPr>
@@ -10076,7 +10076,7 @@
           <p:cNvPr id="7" name="">
             <a:extLst xmlns:a="http://schemas.openxmlformats.org/drawingml/2006/main">
               <a:ext uri="{FF2B5EF4-FFF2-40B4-BE49-F238E27FC236}">
-                <a16:creationId xmlns:a16="http://schemas.microsoft.com/office/drawing/2014/main" id="{758B6B1F-038A-4393-A165-C263225683C6}"/>
+                <a16:creationId xmlns:a16="http://schemas.microsoft.com/office/drawing/2014/main" id="{DEDB3E51-2736-49CC-82B3-20AC725D8C85}"/>
               </a:ext>
             </a:extLst>
           </p:cNvPr>
@@ -10109,7 +10109,7 @@
           <p:cNvPr id="8" name="">
             <a:extLst xmlns:a="http://schemas.openxmlformats.org/drawingml/2006/main">
               <a:ext uri="{FF2B5EF4-FFF2-40B4-BE49-F238E27FC236}">
-                <a16:creationId xmlns:a16="http://schemas.microsoft.com/office/drawing/2014/main" id="{7F826B53-F4EC-4EA3-BB58-70D1705352FE}"/>
+                <a16:creationId xmlns:a16="http://schemas.microsoft.com/office/drawing/2014/main" id="{C6D9F65A-A977-42F1-8F60-FD30F499E27E}"/>
               </a:ext>
             </a:extLst>
           </p:cNvPr>
@@ -10159,7 +10159,7 @@
           <p:cNvPr id="9" name="">
             <a:extLst xmlns:a="http://schemas.openxmlformats.org/drawingml/2006/main">
               <a:ext uri="{FF2B5EF4-FFF2-40B4-BE49-F238E27FC236}">
-                <a16:creationId xmlns:a16="http://schemas.microsoft.com/office/drawing/2014/main" id="{0CC2814C-F7EB-4A4B-BA05-0596E3D09578}"/>
+                <a16:creationId xmlns:a16="http://schemas.microsoft.com/office/drawing/2014/main" id="{6B13580D-91DA-4A6D-AD55-B5095E5A6C72}"/>
               </a:ext>
             </a:extLst>
           </p:cNvPr>
@@ -10192,7 +10192,7 @@
           <p:cNvPr id="10" name="">
             <a:extLst xmlns:a="http://schemas.openxmlformats.org/drawingml/2006/main">
               <a:ext uri="{FF2B5EF4-FFF2-40B4-BE49-F238E27FC236}">
-                <a16:creationId xmlns:a16="http://schemas.microsoft.com/office/drawing/2014/main" id="{CF18C253-B93E-44D8-9CAC-075C676F36B5}"/>
+                <a16:creationId xmlns:a16="http://schemas.microsoft.com/office/drawing/2014/main" id="{0AC2A8AE-5CBE-4066-BB8A-A1F35D42340D}"/>
               </a:ext>
             </a:extLst>
           </p:cNvPr>
@@ -10242,7 +10242,7 @@
           <p:cNvPr id="11" name="">
             <a:extLst xmlns:a="http://schemas.openxmlformats.org/drawingml/2006/main">
               <a:ext uri="{FF2B5EF4-FFF2-40B4-BE49-F238E27FC236}">
-                <a16:creationId xmlns:a16="http://schemas.microsoft.com/office/drawing/2014/main" id="{5972EAE8-EA61-44EB-AF6B-4868824F0AE0}"/>
+                <a16:creationId xmlns:a16="http://schemas.microsoft.com/office/drawing/2014/main" id="{6CC7A08B-CE77-4B7A-ADF5-501FF0DB40D0}"/>
               </a:ext>
             </a:extLst>
           </p:cNvPr>
@@ -10275,7 +10275,7 @@
           <p:cNvPr id="12" name="">
             <a:extLst xmlns:a="http://schemas.openxmlformats.org/drawingml/2006/main">
               <a:ext uri="{FF2B5EF4-FFF2-40B4-BE49-F238E27FC236}">
-                <a16:creationId xmlns:a16="http://schemas.microsoft.com/office/drawing/2014/main" id="{69A196F8-9233-4944-8DA5-F8F37F89AD65}"/>
+                <a16:creationId xmlns:a16="http://schemas.microsoft.com/office/drawing/2014/main" id="{376D502D-D7CC-441E-95E1-26062E670297}"/>
               </a:ext>
             </a:extLst>
           </p:cNvPr>
@@ -10325,7 +10325,7 @@
           <p:cNvPr id="13" name="">
             <a:extLst xmlns:a="http://schemas.openxmlformats.org/drawingml/2006/main">
               <a:ext uri="{FF2B5EF4-FFF2-40B4-BE49-F238E27FC236}">
-                <a16:creationId xmlns:a16="http://schemas.microsoft.com/office/drawing/2014/main" id="{4D38BC02-5EBD-47AF-BEC6-F2B5B05A5B29}"/>
+                <a16:creationId xmlns:a16="http://schemas.microsoft.com/office/drawing/2014/main" id="{954D5AF1-CB96-478F-829D-28E5DEDFB7D8}"/>
               </a:ext>
             </a:extLst>
           </p:cNvPr>
@@ -10373,7 +10373,7 @@
     </p:spTree>
     <p:extLst>
       <p:ext uri="{BB962C8B-B14F-4D97-AF65-F5344CB8AC3E}">
-        <p14:creationId xmlns:p14="http://schemas.microsoft.com/office/powerpoint/2010/main" val="508141235"/>
+        <p14:creationId xmlns:p14="http://schemas.microsoft.com/office/powerpoint/2010/main" val="1264319612"/>
       </p:ext>
     </p:extLst>
   </p:cSld>
@@ -10404,7 +10404,7 @@
           <p:cNvPr id="1" name="">
             <a:extLst xmlns:a="http://schemas.openxmlformats.org/drawingml/2006/main">
               <a:ext uri="{FF2B5EF4-FFF2-40B4-BE49-F238E27FC236}">
-                <a16:creationId xmlns:a16="http://schemas.microsoft.com/office/drawing/2014/main" id="{9DA2CFF6-7EB5-487F-B5D4-BD5CA27E9ECC}"/>
+                <a16:creationId xmlns:a16="http://schemas.microsoft.com/office/drawing/2014/main" id="{6BFDFC9A-7DD8-43A7-BE3C-259F50F8C147}"/>
               </a:ext>
             </a:extLst>
           </p:cNvPr>
@@ -10454,7 +10454,7 @@
           <p:cNvPr id="2" name="">
             <a:extLst xmlns:a="http://schemas.openxmlformats.org/drawingml/2006/main">
               <a:ext uri="{FF2B5EF4-FFF2-40B4-BE49-F238E27FC236}">
-                <a16:creationId xmlns:a16="http://schemas.microsoft.com/office/drawing/2014/main" id="{BF41788E-676E-4312-8474-A7486F3530CC}"/>
+                <a16:creationId xmlns:a16="http://schemas.microsoft.com/office/drawing/2014/main" id="{A7678A34-C814-48A3-912A-F8345EFD8ACC}"/>
               </a:ext>
             </a:extLst>
           </p:cNvPr>
@@ -10504,7 +10504,7 @@
           <p:cNvPr id="3" name="">
             <a:extLst xmlns:a="http://schemas.openxmlformats.org/drawingml/2006/main">
               <a:ext uri="{FF2B5EF4-FFF2-40B4-BE49-F238E27FC236}">
-                <a16:creationId xmlns:a16="http://schemas.microsoft.com/office/drawing/2014/main" id="{5AB94600-F9B3-43CC-9977-4ECA7B6BBCF6}"/>
+                <a16:creationId xmlns:a16="http://schemas.microsoft.com/office/drawing/2014/main" id="{8ADEDA7B-D915-457E-8A56-6B3A2C4972B5}"/>
               </a:ext>
             </a:extLst>
           </p:cNvPr>
@@ -10537,7 +10537,7 @@
           <p:cNvPr id="4" name="">
             <a:extLst xmlns:a="http://schemas.openxmlformats.org/drawingml/2006/main">
               <a:ext uri="{FF2B5EF4-FFF2-40B4-BE49-F238E27FC236}">
-                <a16:creationId xmlns:a16="http://schemas.microsoft.com/office/drawing/2014/main" id="{5BADA075-8917-4F72-8FE5-D45CDEE0B6D1}"/>
+                <a16:creationId xmlns:a16="http://schemas.microsoft.com/office/drawing/2014/main" id="{3FE0114F-D35F-42FE-9EA1-03150D3A4069}"/>
               </a:ext>
             </a:extLst>
           </p:cNvPr>
@@ -10570,7 +10570,7 @@
           <p:cNvPr id="5" name="">
             <a:extLst xmlns:a="http://schemas.openxmlformats.org/drawingml/2006/main">
               <a:ext uri="{FF2B5EF4-FFF2-40B4-BE49-F238E27FC236}">
-                <a16:creationId xmlns:a16="http://schemas.microsoft.com/office/drawing/2014/main" id="{E6F75FAE-04E6-4E93-994B-7A16FF40519E}"/>
+                <a16:creationId xmlns:a16="http://schemas.microsoft.com/office/drawing/2014/main" id="{96B4ED22-AEF4-4E6C-A8AD-AA2B9426B6F1}"/>
               </a:ext>
             </a:extLst>
           </p:cNvPr>
@@ -10620,7 +10620,7 @@
           <p:cNvPr id="6" name="">
             <a:extLst xmlns:a="http://schemas.openxmlformats.org/drawingml/2006/main">
               <a:ext uri="{FF2B5EF4-FFF2-40B4-BE49-F238E27FC236}">
-                <a16:creationId xmlns:a16="http://schemas.microsoft.com/office/drawing/2014/main" id="{9BE243CF-95C0-470E-8ED7-1205BEEEC4C2}"/>
+                <a16:creationId xmlns:a16="http://schemas.microsoft.com/office/drawing/2014/main" id="{8EA82739-DAE2-4BCC-B20B-81A52721BFB0}"/>
               </a:ext>
             </a:extLst>
           </p:cNvPr>
@@ -10670,7 +10670,7 @@
           <p:cNvPr id="7" name="">
             <a:extLst xmlns:a="http://schemas.openxmlformats.org/drawingml/2006/main">
               <a:ext uri="{FF2B5EF4-FFF2-40B4-BE49-F238E27FC236}">
-                <a16:creationId xmlns:a16="http://schemas.microsoft.com/office/drawing/2014/main" id="{544EF6F9-BDAF-4F04-9C16-E254851B0F09}"/>
+                <a16:creationId xmlns:a16="http://schemas.microsoft.com/office/drawing/2014/main" id="{F74AF62F-BF34-4244-824F-4EBD6D948861}"/>
               </a:ext>
             </a:extLst>
           </p:cNvPr>
@@ -10720,7 +10720,7 @@
           <p:cNvPr id="8" name="">
             <a:extLst xmlns:a="http://schemas.openxmlformats.org/drawingml/2006/main">
               <a:ext uri="{FF2B5EF4-FFF2-40B4-BE49-F238E27FC236}">
-                <a16:creationId xmlns:a16="http://schemas.microsoft.com/office/drawing/2014/main" id="{2A878987-654F-4FD2-A040-FD27E9A79EB2}"/>
+                <a16:creationId xmlns:a16="http://schemas.microsoft.com/office/drawing/2014/main" id="{5521B55A-F670-48D9-9D7E-4EE70884D413}"/>
               </a:ext>
             </a:extLst>
           </p:cNvPr>
@@ -10753,7 +10753,7 @@
           <p:cNvPr id="9" name="">
             <a:extLst xmlns:a="http://schemas.openxmlformats.org/drawingml/2006/main">
               <a:ext uri="{FF2B5EF4-FFF2-40B4-BE49-F238E27FC236}">
-                <a16:creationId xmlns:a16="http://schemas.microsoft.com/office/drawing/2014/main" id="{659F7756-01F3-4801-A0DE-CEA25C52293A}"/>
+                <a16:creationId xmlns:a16="http://schemas.microsoft.com/office/drawing/2014/main" id="{0BBDC0EB-6097-4BBD-AFA0-918AAD07B043}"/>
               </a:ext>
             </a:extLst>
           </p:cNvPr>
@@ -10803,7 +10803,7 @@
           <p:cNvPr id="10" name="">
             <a:extLst xmlns:a="http://schemas.openxmlformats.org/drawingml/2006/main">
               <a:ext uri="{FF2B5EF4-FFF2-40B4-BE49-F238E27FC236}">
-                <a16:creationId xmlns:a16="http://schemas.microsoft.com/office/drawing/2014/main" id="{ED4F3A05-E864-4770-A966-981DEA87EF7B}"/>
+                <a16:creationId xmlns:a16="http://schemas.microsoft.com/office/drawing/2014/main" id="{DA09846B-F8BF-4720-8A83-D00631357365}"/>
               </a:ext>
             </a:extLst>
           </p:cNvPr>
@@ -10836,7 +10836,7 @@
           <p:cNvPr id="11" name="">
             <a:extLst xmlns:a="http://schemas.openxmlformats.org/drawingml/2006/main">
               <a:ext uri="{FF2B5EF4-FFF2-40B4-BE49-F238E27FC236}">
-                <a16:creationId xmlns:a16="http://schemas.microsoft.com/office/drawing/2014/main" id="{799D73D6-02DD-40F7-AFA3-DF6CEB711C71}"/>
+                <a16:creationId xmlns:a16="http://schemas.microsoft.com/office/drawing/2014/main" id="{3449A7FE-3D88-44E9-B8CB-8D6E61EA4AAF}"/>
               </a:ext>
             </a:extLst>
           </p:cNvPr>
@@ -10886,7 +10886,7 @@
           <p:cNvPr id="12" name="">
             <a:extLst xmlns:a="http://schemas.openxmlformats.org/drawingml/2006/main">
               <a:ext uri="{FF2B5EF4-FFF2-40B4-BE49-F238E27FC236}">
-                <a16:creationId xmlns:a16="http://schemas.microsoft.com/office/drawing/2014/main" id="{9023CAD3-4B13-4C81-BA6B-0275C7040185}"/>
+                <a16:creationId xmlns:a16="http://schemas.microsoft.com/office/drawing/2014/main" id="{0C2D08EA-CA86-4689-AAF2-1106FCCB039E}"/>
               </a:ext>
             </a:extLst>
           </p:cNvPr>
@@ -10919,7 +10919,7 @@
           <p:cNvPr id="13" name="">
             <a:extLst xmlns:a="http://schemas.openxmlformats.org/drawingml/2006/main">
               <a:ext uri="{FF2B5EF4-FFF2-40B4-BE49-F238E27FC236}">
-                <a16:creationId xmlns:a16="http://schemas.microsoft.com/office/drawing/2014/main" id="{D0085A7D-8119-4325-9643-47BE64F042D5}"/>
+                <a16:creationId xmlns:a16="http://schemas.microsoft.com/office/drawing/2014/main" id="{7BD88823-9977-43AE-97E5-BCFB318584F6}"/>
               </a:ext>
             </a:extLst>
           </p:cNvPr>
@@ -10969,7 +10969,7 @@
           <p:cNvPr id="14" name="">
             <a:extLst xmlns:a="http://schemas.openxmlformats.org/drawingml/2006/main">
               <a:ext uri="{FF2B5EF4-FFF2-40B4-BE49-F238E27FC236}">
-                <a16:creationId xmlns:a16="http://schemas.microsoft.com/office/drawing/2014/main" id="{F81525DC-9989-45A2-9CD0-973EB7F8FD67}"/>
+                <a16:creationId xmlns:a16="http://schemas.microsoft.com/office/drawing/2014/main" id="{254A69A6-1313-4E06-90B5-25697BC334FF}"/>
               </a:ext>
             </a:extLst>
           </p:cNvPr>
@@ -11002,7 +11002,7 @@
           <p:cNvPr id="15" name="">
             <a:extLst xmlns:a="http://schemas.openxmlformats.org/drawingml/2006/main">
               <a:ext uri="{FF2B5EF4-FFF2-40B4-BE49-F238E27FC236}">
-                <a16:creationId xmlns:a16="http://schemas.microsoft.com/office/drawing/2014/main" id="{FF94FDF6-1AFC-4FAB-88E9-F3EE6392F6BE}"/>
+                <a16:creationId xmlns:a16="http://schemas.microsoft.com/office/drawing/2014/main" id="{EFB9B874-78B7-4F0F-8808-7438A4C00E12}"/>
               </a:ext>
             </a:extLst>
           </p:cNvPr>
@@ -11052,7 +11052,7 @@
           <p:cNvPr id="16" name="">
             <a:extLst xmlns:a="http://schemas.openxmlformats.org/drawingml/2006/main">
               <a:ext uri="{FF2B5EF4-FFF2-40B4-BE49-F238E27FC236}">
-                <a16:creationId xmlns:a16="http://schemas.microsoft.com/office/drawing/2014/main" id="{F55821AB-C4A3-4B8F-A7EA-70B663CACD10}"/>
+                <a16:creationId xmlns:a16="http://schemas.microsoft.com/office/drawing/2014/main" id="{6D72AF80-6D23-40F5-9B76-8D3585D9A219}"/>
               </a:ext>
             </a:extLst>
           </p:cNvPr>
@@ -11100,7 +11100,7 @@
     </p:spTree>
     <p:extLst>
       <p:ext uri="{BB962C8B-B14F-4D97-AF65-F5344CB8AC3E}">
-        <p14:creationId xmlns:p14="http://schemas.microsoft.com/office/powerpoint/2010/main" val="459125820"/>
+        <p14:creationId xmlns:p14="http://schemas.microsoft.com/office/powerpoint/2010/main" val="1650762644"/>
       </p:ext>
     </p:extLst>
   </p:cSld>

</xml_diff>

<commit_message>
Add historical SGD optimizer option
</commit_message>
<xml_diff>
--- a/slides/LeNet5_MNIST_Final_Presentation.pptx
+++ b/slides/LeNet5_MNIST_Final_Presentation.pptx
@@ -2,25 +2,25 @@
 <file path=ppt/presentation.xml><?xml version="1.0" encoding="utf-8"?>
 <p:presentation xmlns:p="http://schemas.openxmlformats.org/presentationml/2006/main">
   <p:sldMasterIdLst>
-    <p:sldMasterId xmlns:r="http://schemas.openxmlformats.org/officeDocument/2006/relationships" id="2147483648" r:id="R11f4bfb6ef7149c6"/>
+    <p:sldMasterId xmlns:r="http://schemas.openxmlformats.org/officeDocument/2006/relationships" id="2147483648" r:id="R28f2b148492549f0"/>
   </p:sldMasterIdLst>
   <p:notesMasterIdLst>
-    <p:notesMasterId xmlns:r="http://schemas.openxmlformats.org/officeDocument/2006/relationships" r:id="R2c90086fe7184857"/>
+    <p:notesMasterId xmlns:r="http://schemas.openxmlformats.org/officeDocument/2006/relationships" r:id="R84600c60c1b6401b"/>
   </p:notesMasterIdLst>
   <p:sldIdLst>
-    <p:sldId xmlns:r="http://schemas.openxmlformats.org/officeDocument/2006/relationships" id="256" r:id="R35dc487279ed4315"/>
-    <p:sldId xmlns:r="http://schemas.openxmlformats.org/officeDocument/2006/relationships" id="257" r:id="R7ec74915d26d41f7"/>
-    <p:sldId xmlns:r="http://schemas.openxmlformats.org/officeDocument/2006/relationships" id="258" r:id="R3bd9d93173214da9"/>
-    <p:sldId xmlns:r="http://schemas.openxmlformats.org/officeDocument/2006/relationships" id="259" r:id="R472830e62d9f4c10"/>
-    <p:sldId xmlns:r="http://schemas.openxmlformats.org/officeDocument/2006/relationships" id="260" r:id="R4eaf20258f42467d"/>
-    <p:sldId xmlns:r="http://schemas.openxmlformats.org/officeDocument/2006/relationships" id="261" r:id="R7850409614bb4468"/>
-    <p:sldId xmlns:r="http://schemas.openxmlformats.org/officeDocument/2006/relationships" id="262" r:id="R2a2402b9870d486d"/>
-    <p:sldId xmlns:r="http://schemas.openxmlformats.org/officeDocument/2006/relationships" id="263" r:id="R3b7ffea66d0643a4"/>
-    <p:sldId xmlns:r="http://schemas.openxmlformats.org/officeDocument/2006/relationships" id="264" r:id="R17bd03368f8b4fdd"/>
-    <p:sldId xmlns:r="http://schemas.openxmlformats.org/officeDocument/2006/relationships" id="265" r:id="R11e4c8c770bf400e"/>
-    <p:sldId xmlns:r="http://schemas.openxmlformats.org/officeDocument/2006/relationships" id="266" r:id="R73a0bba2eb3e49b1"/>
-    <p:sldId xmlns:r="http://schemas.openxmlformats.org/officeDocument/2006/relationships" id="267" r:id="R3710bcfe19a6493b"/>
-    <p:sldId xmlns:r="http://schemas.openxmlformats.org/officeDocument/2006/relationships" id="268" r:id="R2ec5b36578e94441"/>
+    <p:sldId xmlns:r="http://schemas.openxmlformats.org/officeDocument/2006/relationships" id="256" r:id="Rbfe7c70659e64e97"/>
+    <p:sldId xmlns:r="http://schemas.openxmlformats.org/officeDocument/2006/relationships" id="257" r:id="Rabbb09e037f44fbd"/>
+    <p:sldId xmlns:r="http://schemas.openxmlformats.org/officeDocument/2006/relationships" id="258" r:id="R1364b7584e7b47c7"/>
+    <p:sldId xmlns:r="http://schemas.openxmlformats.org/officeDocument/2006/relationships" id="259" r:id="R7e189e17daa3490c"/>
+    <p:sldId xmlns:r="http://schemas.openxmlformats.org/officeDocument/2006/relationships" id="260" r:id="R24d1f755b87e4a9b"/>
+    <p:sldId xmlns:r="http://schemas.openxmlformats.org/officeDocument/2006/relationships" id="261" r:id="R5b7fa15bfe444fca"/>
+    <p:sldId xmlns:r="http://schemas.openxmlformats.org/officeDocument/2006/relationships" id="262" r:id="R9ff52b6876214b60"/>
+    <p:sldId xmlns:r="http://schemas.openxmlformats.org/officeDocument/2006/relationships" id="263" r:id="Rc169af87589c4b19"/>
+    <p:sldId xmlns:r="http://schemas.openxmlformats.org/officeDocument/2006/relationships" id="264" r:id="R9dd49a8e1fe34bd3"/>
+    <p:sldId xmlns:r="http://schemas.openxmlformats.org/officeDocument/2006/relationships" id="265" r:id="R95ebbe66721343cb"/>
+    <p:sldId xmlns:r="http://schemas.openxmlformats.org/officeDocument/2006/relationships" id="266" r:id="R6ee82392785345da"/>
+    <p:sldId xmlns:r="http://schemas.openxmlformats.org/officeDocument/2006/relationships" id="267" r:id="R333fcd0897a74d9c"/>
+    <p:sldId xmlns:r="http://schemas.openxmlformats.org/officeDocument/2006/relationships" id="268" r:id="R222163604ead4d2f"/>
   </p:sldIdLst>
   <p:sldSz cx="12192000" cy="6858000"/>
   <p:notesSz cx="6858000" cy="9144000"/>
@@ -1405,7 +1405,7 @@
   </p:cSld>
   <p:clrMap bg1="lt1" tx1="dk1" bg2="lt2" tx2="dk2" accent1="accent1" accent2="accent2" accent3="accent3" accent4="accent4" accent5="accent5" accent6="accent6" hlink="hlink" folHlink="folHlink"/>
   <p:sldLayoutIdLst>
-    <p:sldLayoutId xmlns:r="http://schemas.openxmlformats.org/officeDocument/2006/relationships" id="2147483649" r:id="Ra609178ca0244ad9"/>
+    <p:sldLayoutId xmlns:r="http://schemas.openxmlformats.org/officeDocument/2006/relationships" id="2147483649" r:id="R49df1b844fd541bc"/>
   </p:sldLayoutIdLst>
   <p:txStyles>
     <p:titleStyle>
@@ -1956,7 +1956,7 @@
           <p:cNvPr id="1" name="">
             <a:extLst xmlns:a="http://schemas.openxmlformats.org/drawingml/2006/main">
               <a:ext uri="{FF2B5EF4-FFF2-40B4-BE49-F238E27FC236}">
-                <a16:creationId xmlns:a16="http://schemas.microsoft.com/office/drawing/2014/main" id="{E87364A6-4F77-43C4-8C11-1E131D8D9D69}"/>
+                <a16:creationId xmlns:a16="http://schemas.microsoft.com/office/drawing/2014/main" id="{ED080F35-2B6F-45B1-97FD-4729D31BDC16}"/>
               </a:ext>
             </a:extLst>
           </p:cNvPr>
@@ -2006,7 +2006,7 @@
           <p:cNvPr id="2" name="">
             <a:extLst xmlns:a="http://schemas.openxmlformats.org/drawingml/2006/main">
               <a:ext uri="{FF2B5EF4-FFF2-40B4-BE49-F238E27FC236}">
-                <a16:creationId xmlns:a16="http://schemas.microsoft.com/office/drawing/2014/main" id="{93C18329-1EEE-4292-B04B-CA68045F1349}"/>
+                <a16:creationId xmlns:a16="http://schemas.microsoft.com/office/drawing/2014/main" id="{E34B390B-DCF1-4A7F-89E1-D65B1AD13242}"/>
               </a:ext>
             </a:extLst>
           </p:cNvPr>
@@ -2056,7 +2056,7 @@
           <p:cNvPr id="3" name="">
             <a:extLst xmlns:a="http://schemas.openxmlformats.org/drawingml/2006/main">
               <a:ext uri="{FF2B5EF4-FFF2-40B4-BE49-F238E27FC236}">
-                <a16:creationId xmlns:a16="http://schemas.microsoft.com/office/drawing/2014/main" id="{FA5EBBAC-189B-48E7-8871-FB40AC9EC386}"/>
+                <a16:creationId xmlns:a16="http://schemas.microsoft.com/office/drawing/2014/main" id="{3840DAC2-00E6-406E-8FCA-198DF7CF40BB}"/>
               </a:ext>
             </a:extLst>
           </p:cNvPr>
@@ -2089,7 +2089,7 @@
           <p:cNvPr id="4" name="">
             <a:extLst xmlns:a="http://schemas.openxmlformats.org/drawingml/2006/main">
               <a:ext uri="{FF2B5EF4-FFF2-40B4-BE49-F238E27FC236}">
-                <a16:creationId xmlns:a16="http://schemas.microsoft.com/office/drawing/2014/main" id="{C6079E56-ACAB-485B-9880-AA8B375BBEB1}"/>
+                <a16:creationId xmlns:a16="http://schemas.microsoft.com/office/drawing/2014/main" id="{CA4F195A-71C3-458F-9183-2B5FFE88AB25}"/>
               </a:ext>
             </a:extLst>
           </p:cNvPr>
@@ -2139,7 +2139,7 @@
           <p:cNvPr id="5" name="">
             <a:extLst xmlns:a="http://schemas.openxmlformats.org/drawingml/2006/main">
               <a:ext uri="{FF2B5EF4-FFF2-40B4-BE49-F238E27FC236}">
-                <a16:creationId xmlns:a16="http://schemas.microsoft.com/office/drawing/2014/main" id="{AF7E8867-AE30-4E01-94D1-DA9FE7DADA37}"/>
+                <a16:creationId xmlns:a16="http://schemas.microsoft.com/office/drawing/2014/main" id="{C3A57328-6D05-42AB-AE93-7ED52AD4A07F}"/>
               </a:ext>
             </a:extLst>
           </p:cNvPr>
@@ -2189,7 +2189,7 @@
           <p:cNvPr id="6" name="">
             <a:extLst xmlns:a="http://schemas.openxmlformats.org/drawingml/2006/main">
               <a:ext uri="{FF2B5EF4-FFF2-40B4-BE49-F238E27FC236}">
-                <a16:creationId xmlns:a16="http://schemas.microsoft.com/office/drawing/2014/main" id="{3E43531B-A7E2-482E-9A04-E455CF791B4D}"/>
+                <a16:creationId xmlns:a16="http://schemas.microsoft.com/office/drawing/2014/main" id="{DC8DA504-2300-4732-BD33-7E86EE022970}"/>
               </a:ext>
             </a:extLst>
           </p:cNvPr>
@@ -2222,7 +2222,7 @@
           <p:cNvPr id="7" name="">
             <a:extLst xmlns:a="http://schemas.openxmlformats.org/drawingml/2006/main">
               <a:ext uri="{FF2B5EF4-FFF2-40B4-BE49-F238E27FC236}">
-                <a16:creationId xmlns:a16="http://schemas.microsoft.com/office/drawing/2014/main" id="{D5530D17-A326-4761-AC09-09C40F6E8EB3}"/>
+                <a16:creationId xmlns:a16="http://schemas.microsoft.com/office/drawing/2014/main" id="{213278C7-BEA4-44A9-A375-D7633C5F0345}"/>
               </a:ext>
             </a:extLst>
           </p:cNvPr>
@@ -2272,7 +2272,7 @@
           <p:cNvPr id="8" name="">
             <a:extLst xmlns:a="http://schemas.openxmlformats.org/drawingml/2006/main">
               <a:ext uri="{FF2B5EF4-FFF2-40B4-BE49-F238E27FC236}">
-                <a16:creationId xmlns:a16="http://schemas.microsoft.com/office/drawing/2014/main" id="{32DDEB45-28F6-4DDA-85B6-8AD43886B69F}"/>
+                <a16:creationId xmlns:a16="http://schemas.microsoft.com/office/drawing/2014/main" id="{A21C18B7-F7CC-434F-A8BC-CDC5E3210195}"/>
               </a:ext>
             </a:extLst>
           </p:cNvPr>
@@ -2322,7 +2322,7 @@
           <p:cNvPr id="9" name="">
             <a:extLst xmlns:a="http://schemas.openxmlformats.org/drawingml/2006/main">
               <a:ext uri="{FF2B5EF4-FFF2-40B4-BE49-F238E27FC236}">
-                <a16:creationId xmlns:a16="http://schemas.microsoft.com/office/drawing/2014/main" id="{2A988E64-EABA-4950-B151-8E39C67427E6}"/>
+                <a16:creationId xmlns:a16="http://schemas.microsoft.com/office/drawing/2014/main" id="{C966261E-934E-4DF1-B3A5-B48372883D9B}"/>
               </a:ext>
             </a:extLst>
           </p:cNvPr>
@@ -2355,7 +2355,7 @@
           <p:cNvPr id="10" name="">
             <a:extLst xmlns:a="http://schemas.openxmlformats.org/drawingml/2006/main">
               <a:ext uri="{FF2B5EF4-FFF2-40B4-BE49-F238E27FC236}">
-                <a16:creationId xmlns:a16="http://schemas.microsoft.com/office/drawing/2014/main" id="{B4F9E9F0-BA06-49A5-9F68-0E19DC1F832F}"/>
+                <a16:creationId xmlns:a16="http://schemas.microsoft.com/office/drawing/2014/main" id="{5EDE3426-D5A1-416D-B52C-94EC5921BA7C}"/>
               </a:ext>
             </a:extLst>
           </p:cNvPr>
@@ -2405,7 +2405,7 @@
           <p:cNvPr id="11" name="">
             <a:extLst xmlns:a="http://schemas.openxmlformats.org/drawingml/2006/main">
               <a:ext uri="{FF2B5EF4-FFF2-40B4-BE49-F238E27FC236}">
-                <a16:creationId xmlns:a16="http://schemas.microsoft.com/office/drawing/2014/main" id="{AB87B562-C550-41C4-A989-AE5C376F4272}"/>
+                <a16:creationId xmlns:a16="http://schemas.microsoft.com/office/drawing/2014/main" id="{A1271168-F9DB-4D8F-BEFA-AFCC923E9439}"/>
               </a:ext>
             </a:extLst>
           </p:cNvPr>
@@ -2455,7 +2455,7 @@
           <p:cNvPr id="12" name="">
             <a:extLst xmlns:a="http://schemas.openxmlformats.org/drawingml/2006/main">
               <a:ext uri="{FF2B5EF4-FFF2-40B4-BE49-F238E27FC236}">
-                <a16:creationId xmlns:a16="http://schemas.microsoft.com/office/drawing/2014/main" id="{87D550C6-89E8-4378-A88F-9E6A34E3D54F}"/>
+                <a16:creationId xmlns:a16="http://schemas.microsoft.com/office/drawing/2014/main" id="{83D7C80F-378D-4F11-A80D-6E44C88295E8}"/>
               </a:ext>
             </a:extLst>
           </p:cNvPr>
@@ -2505,7 +2505,7 @@
           <p:cNvPr id="13" name="">
             <a:extLst xmlns:a="http://schemas.openxmlformats.org/drawingml/2006/main">
               <a:ext uri="{FF2B5EF4-FFF2-40B4-BE49-F238E27FC236}">
-                <a16:creationId xmlns:a16="http://schemas.microsoft.com/office/drawing/2014/main" id="{5F962E72-AD5C-4155-B847-4925F35DEE9F}"/>
+                <a16:creationId xmlns:a16="http://schemas.microsoft.com/office/drawing/2014/main" id="{8ADEC20F-7733-4753-925E-E1E9BCCE77C5}"/>
               </a:ext>
             </a:extLst>
           </p:cNvPr>
@@ -2553,7 +2553,7 @@
     </p:spTree>
     <p:extLst>
       <p:ext uri="{BB962C8B-B14F-4D97-AF65-F5344CB8AC3E}">
-        <p14:creationId xmlns:p14="http://schemas.microsoft.com/office/powerpoint/2010/main" val="941268152"/>
+        <p14:creationId xmlns:p14="http://schemas.microsoft.com/office/powerpoint/2010/main" val="1711006368"/>
       </p:ext>
     </p:extLst>
   </p:cSld>
@@ -2584,7 +2584,7 @@
           <p:cNvPr id="1" name="">
             <a:extLst xmlns:a="http://schemas.openxmlformats.org/drawingml/2006/main">
               <a:ext uri="{FF2B5EF4-FFF2-40B4-BE49-F238E27FC236}">
-                <a16:creationId xmlns:a16="http://schemas.microsoft.com/office/drawing/2014/main" id="{A92FC968-1146-4A20-B4C6-CE8B729130FA}"/>
+                <a16:creationId xmlns:a16="http://schemas.microsoft.com/office/drawing/2014/main" id="{49070CBE-7E38-405F-9853-52E7B62E81F6}"/>
               </a:ext>
             </a:extLst>
           </p:cNvPr>
@@ -2634,7 +2634,7 @@
           <p:cNvPr id="2" name="">
             <a:extLst xmlns:a="http://schemas.openxmlformats.org/drawingml/2006/main">
               <a:ext uri="{FF2B5EF4-FFF2-40B4-BE49-F238E27FC236}">
-                <a16:creationId xmlns:a16="http://schemas.microsoft.com/office/drawing/2014/main" id="{BB55A6C3-D409-48D0-8A0E-019CAA743EAE}"/>
+                <a16:creationId xmlns:a16="http://schemas.microsoft.com/office/drawing/2014/main" id="{1DC2CDB5-CFFA-44F2-B22A-12C69C574E25}"/>
               </a:ext>
             </a:extLst>
           </p:cNvPr>
@@ -2684,7 +2684,7 @@
           <p:cNvPr id="3" name="">
             <a:extLst xmlns:a="http://schemas.openxmlformats.org/drawingml/2006/main">
               <a:ext uri="{FF2B5EF4-FFF2-40B4-BE49-F238E27FC236}">
-                <a16:creationId xmlns:a16="http://schemas.microsoft.com/office/drawing/2014/main" id="{A8DA1DBA-B763-4915-8431-F422CDDCA03A}"/>
+                <a16:creationId xmlns:a16="http://schemas.microsoft.com/office/drawing/2014/main" id="{BC510090-3287-47FE-8A08-3C9C59AE36F3}"/>
               </a:ext>
             </a:extLst>
           </p:cNvPr>
@@ -2717,7 +2717,7 @@
           <p:cNvPr id="4" name="">
             <a:extLst xmlns:a="http://schemas.openxmlformats.org/drawingml/2006/main">
               <a:ext uri="{FF2B5EF4-FFF2-40B4-BE49-F238E27FC236}">
-                <a16:creationId xmlns:a16="http://schemas.microsoft.com/office/drawing/2014/main" id="{A7B29F52-95C6-4CD2-8697-391E96AAFF80}"/>
+                <a16:creationId xmlns:a16="http://schemas.microsoft.com/office/drawing/2014/main" id="{2B169587-B235-42CD-A883-BF7F74BE938C}"/>
               </a:ext>
             </a:extLst>
           </p:cNvPr>
@@ -2750,7 +2750,7 @@
           <p:cNvPr id="5" name="">
             <a:extLst xmlns:a="http://schemas.openxmlformats.org/drawingml/2006/main">
               <a:ext uri="{FF2B5EF4-FFF2-40B4-BE49-F238E27FC236}">
-                <a16:creationId xmlns:a16="http://schemas.microsoft.com/office/drawing/2014/main" id="{5CA7EDB4-D366-4758-BFE6-8D00325FEE7D}"/>
+                <a16:creationId xmlns:a16="http://schemas.microsoft.com/office/drawing/2014/main" id="{F97FE66E-9B3B-4FF0-AB6D-78C3EA263CD0}"/>
               </a:ext>
             </a:extLst>
           </p:cNvPr>
@@ -2800,7 +2800,7 @@
           <p:cNvPr id="6" name="">
             <a:extLst xmlns:a="http://schemas.openxmlformats.org/drawingml/2006/main">
               <a:ext uri="{FF2B5EF4-FFF2-40B4-BE49-F238E27FC236}">
-                <a16:creationId xmlns:a16="http://schemas.microsoft.com/office/drawing/2014/main" id="{64A2CAAC-29CD-402B-824A-9B7ADFEAEAC3}"/>
+                <a16:creationId xmlns:a16="http://schemas.microsoft.com/office/drawing/2014/main" id="{6850C58D-77C7-4831-9E8E-9D750B76C0EE}"/>
               </a:ext>
             </a:extLst>
           </p:cNvPr>
@@ -2850,7 +2850,7 @@
           <p:cNvPr id="7" name="">
             <a:extLst xmlns:a="http://schemas.openxmlformats.org/drawingml/2006/main">
               <a:ext uri="{FF2B5EF4-FFF2-40B4-BE49-F238E27FC236}">
-                <a16:creationId xmlns:a16="http://schemas.microsoft.com/office/drawing/2014/main" id="{6BD62708-C216-4F46-AC56-F007BC2E7DCE}"/>
+                <a16:creationId xmlns:a16="http://schemas.microsoft.com/office/drawing/2014/main" id="{284214F9-E0C2-422A-B4DC-277A50B4E231}"/>
               </a:ext>
             </a:extLst>
           </p:cNvPr>
@@ -2883,7 +2883,7 @@
           <p:cNvPr id="8" name="">
             <a:extLst xmlns:a="http://schemas.openxmlformats.org/drawingml/2006/main">
               <a:ext uri="{FF2B5EF4-FFF2-40B4-BE49-F238E27FC236}">
-                <a16:creationId xmlns:a16="http://schemas.microsoft.com/office/drawing/2014/main" id="{C95B4B47-79BD-488B-BAE6-347D0A54C1FD}"/>
+                <a16:creationId xmlns:a16="http://schemas.microsoft.com/office/drawing/2014/main" id="{13274B6F-9444-44A2-87C9-F85C22D8BFEC}"/>
               </a:ext>
             </a:extLst>
           </p:cNvPr>
@@ -2933,7 +2933,7 @@
           <p:cNvPr id="9" name="">
             <a:extLst xmlns:a="http://schemas.openxmlformats.org/drawingml/2006/main">
               <a:ext uri="{FF2B5EF4-FFF2-40B4-BE49-F238E27FC236}">
-                <a16:creationId xmlns:a16="http://schemas.microsoft.com/office/drawing/2014/main" id="{4BD3DCC5-8AED-4F24-B305-F17BE59FBA16}"/>
+                <a16:creationId xmlns:a16="http://schemas.microsoft.com/office/drawing/2014/main" id="{D5453A87-D3B2-4C82-A229-1A0296167C25}"/>
               </a:ext>
             </a:extLst>
           </p:cNvPr>
@@ -2983,7 +2983,7 @@
           <p:cNvPr id="10" name="">
             <a:extLst xmlns:a="http://schemas.openxmlformats.org/drawingml/2006/main">
               <a:ext uri="{FF2B5EF4-FFF2-40B4-BE49-F238E27FC236}">
-                <a16:creationId xmlns:a16="http://schemas.microsoft.com/office/drawing/2014/main" id="{C3A320F1-5532-422C-9123-1EFC7F47EB0B}"/>
+                <a16:creationId xmlns:a16="http://schemas.microsoft.com/office/drawing/2014/main" id="{E6726644-165D-49C2-9CE2-A12A402B19AD}"/>
               </a:ext>
             </a:extLst>
           </p:cNvPr>
@@ -3033,7 +3033,7 @@
           <p:cNvPr id="11" name="">
             <a:extLst xmlns:a="http://schemas.openxmlformats.org/drawingml/2006/main">
               <a:ext uri="{FF2B5EF4-FFF2-40B4-BE49-F238E27FC236}">
-                <a16:creationId xmlns:a16="http://schemas.microsoft.com/office/drawing/2014/main" id="{6740A86E-1D0B-4A3B-921A-D99B6145BA63}"/>
+                <a16:creationId xmlns:a16="http://schemas.microsoft.com/office/drawing/2014/main" id="{FD01AA23-B3D2-4242-AB83-B3FB4E916CA4}"/>
               </a:ext>
             </a:extLst>
           </p:cNvPr>
@@ -3081,7 +3081,7 @@
     </p:spTree>
     <p:extLst>
       <p:ext uri="{BB962C8B-B14F-4D97-AF65-F5344CB8AC3E}">
-        <p14:creationId xmlns:p14="http://schemas.microsoft.com/office/powerpoint/2010/main" val="641630493"/>
+        <p14:creationId xmlns:p14="http://schemas.microsoft.com/office/powerpoint/2010/main" val="1701885156"/>
       </p:ext>
     </p:extLst>
   </p:cSld>
@@ -3112,7 +3112,7 @@
           <p:cNvPr id="1" name="">
             <a:extLst xmlns:a="http://schemas.openxmlformats.org/drawingml/2006/main">
               <a:ext uri="{FF2B5EF4-FFF2-40B4-BE49-F238E27FC236}">
-                <a16:creationId xmlns:a16="http://schemas.microsoft.com/office/drawing/2014/main" id="{B24A076D-3226-406E-9920-D8431965176C}"/>
+                <a16:creationId xmlns:a16="http://schemas.microsoft.com/office/drawing/2014/main" id="{95A361BB-4891-4927-9E09-97827CDA5354}"/>
               </a:ext>
             </a:extLst>
           </p:cNvPr>
@@ -3162,7 +3162,7 @@
           <p:cNvPr id="2" name="">
             <a:extLst xmlns:a="http://schemas.openxmlformats.org/drawingml/2006/main">
               <a:ext uri="{FF2B5EF4-FFF2-40B4-BE49-F238E27FC236}">
-                <a16:creationId xmlns:a16="http://schemas.microsoft.com/office/drawing/2014/main" id="{970CD50A-9B35-43FC-A2DC-E09B65B9F448}"/>
+                <a16:creationId xmlns:a16="http://schemas.microsoft.com/office/drawing/2014/main" id="{D57813DA-E3CB-4CFE-AD70-409DFA5ED583}"/>
               </a:ext>
             </a:extLst>
           </p:cNvPr>
@@ -3212,7 +3212,7 @@
           <p:cNvPr id="3" name="">
             <a:extLst xmlns:a="http://schemas.openxmlformats.org/drawingml/2006/main">
               <a:ext uri="{FF2B5EF4-FFF2-40B4-BE49-F238E27FC236}">
-                <a16:creationId xmlns:a16="http://schemas.microsoft.com/office/drawing/2014/main" id="{45A27523-8077-46C9-8822-67E9952311A4}"/>
+                <a16:creationId xmlns:a16="http://schemas.microsoft.com/office/drawing/2014/main" id="{31C57AEC-4649-419F-9C34-EAEBA09212A4}"/>
               </a:ext>
             </a:extLst>
           </p:cNvPr>
@@ -3245,7 +3245,7 @@
           <p:cNvPr id="4" name="">
             <a:extLst xmlns:a="http://schemas.openxmlformats.org/drawingml/2006/main">
               <a:ext uri="{FF2B5EF4-FFF2-40B4-BE49-F238E27FC236}">
-                <a16:creationId xmlns:a16="http://schemas.microsoft.com/office/drawing/2014/main" id="{BFBC8D50-786C-46C7-BD2B-6F59AEC858F7}"/>
+                <a16:creationId xmlns:a16="http://schemas.microsoft.com/office/drawing/2014/main" id="{01A71BAC-3864-4698-8F77-6B00E7A218DC}"/>
               </a:ext>
             </a:extLst>
           </p:cNvPr>
@@ -3278,7 +3278,7 @@
           <p:cNvPr id="5" name="">
             <a:extLst xmlns:a="http://schemas.openxmlformats.org/drawingml/2006/main">
               <a:ext uri="{FF2B5EF4-FFF2-40B4-BE49-F238E27FC236}">
-                <a16:creationId xmlns:a16="http://schemas.microsoft.com/office/drawing/2014/main" id="{6F47A27E-844A-426F-889B-FF9515D814EF}"/>
+                <a16:creationId xmlns:a16="http://schemas.microsoft.com/office/drawing/2014/main" id="{48246B29-7942-4BE8-BBFC-3D7605DB3439}"/>
               </a:ext>
             </a:extLst>
           </p:cNvPr>
@@ -3328,7 +3328,7 @@
           <p:cNvPr id="6" name="">
             <a:extLst xmlns:a="http://schemas.openxmlformats.org/drawingml/2006/main">
               <a:ext uri="{FF2B5EF4-FFF2-40B4-BE49-F238E27FC236}">
-                <a16:creationId xmlns:a16="http://schemas.microsoft.com/office/drawing/2014/main" id="{E109BA68-40DE-4439-8C7E-BD8178B02EC2}"/>
+                <a16:creationId xmlns:a16="http://schemas.microsoft.com/office/drawing/2014/main" id="{E3278730-A3C6-45CF-B5C5-35DCE84920CA}"/>
               </a:ext>
             </a:extLst>
           </p:cNvPr>
@@ -3446,7 +3446,7 @@
           <p:cNvPr id="7" name="">
             <a:extLst xmlns:a="http://schemas.openxmlformats.org/drawingml/2006/main">
               <a:ext uri="{FF2B5EF4-FFF2-40B4-BE49-F238E27FC236}">
-                <a16:creationId xmlns:a16="http://schemas.microsoft.com/office/drawing/2014/main" id="{88CEA6A4-C6D0-49F6-BA88-3D6CC80927CE}"/>
+                <a16:creationId xmlns:a16="http://schemas.microsoft.com/office/drawing/2014/main" id="{1B84DBB8-DA47-4794-ACFE-CFAF381C7838}"/>
               </a:ext>
             </a:extLst>
           </p:cNvPr>
@@ -3479,7 +3479,7 @@
           <p:cNvPr id="8" name="">
             <a:extLst xmlns:a="http://schemas.openxmlformats.org/drawingml/2006/main">
               <a:ext uri="{FF2B5EF4-FFF2-40B4-BE49-F238E27FC236}">
-                <a16:creationId xmlns:a16="http://schemas.microsoft.com/office/drawing/2014/main" id="{6751807D-4C27-481A-8261-95EC6D3721DD}"/>
+                <a16:creationId xmlns:a16="http://schemas.microsoft.com/office/drawing/2014/main" id="{19C5A1DA-69DF-47B8-9746-D84B1DA16239}"/>
               </a:ext>
             </a:extLst>
           </p:cNvPr>
@@ -3529,7 +3529,7 @@
           <p:cNvPr id="9" name="">
             <a:extLst xmlns:a="http://schemas.openxmlformats.org/drawingml/2006/main">
               <a:ext uri="{FF2B5EF4-FFF2-40B4-BE49-F238E27FC236}">
-                <a16:creationId xmlns:a16="http://schemas.microsoft.com/office/drawing/2014/main" id="{595578D0-04C1-4D22-BC89-A560EBDECD55}"/>
+                <a16:creationId xmlns:a16="http://schemas.microsoft.com/office/drawing/2014/main" id="{82219990-111F-4562-9A3E-9ED13818BFCD}"/>
               </a:ext>
             </a:extLst>
           </p:cNvPr>
@@ -3637,7 +3637,7 @@
                   <a:srgbClr val="0A0A0A"/>
                 </a:solidFill>
               </a:rPr>
-              <a:t>Adam optimizer</a:t>
+              <a:t>SGD optimizer prepared</a:t>
             </a:r>
           </a:p>
         </p:txBody>
@@ -3647,7 +3647,7 @@
           <p:cNvPr id="10" name="">
             <a:extLst xmlns:a="http://schemas.openxmlformats.org/drawingml/2006/main">
               <a:ext uri="{FF2B5EF4-FFF2-40B4-BE49-F238E27FC236}">
-                <a16:creationId xmlns:a16="http://schemas.microsoft.com/office/drawing/2014/main" id="{5E896A4E-D648-4E90-970F-C99C46ECFC31}"/>
+                <a16:creationId xmlns:a16="http://schemas.microsoft.com/office/drawing/2014/main" id="{856BD36C-CD3C-4AC6-92CE-F9C684FC591A}"/>
               </a:ext>
             </a:extLst>
           </p:cNvPr>
@@ -3680,7 +3680,7 @@
           <p:cNvPr id="11" name="">
             <a:extLst xmlns:a="http://schemas.openxmlformats.org/drawingml/2006/main">
               <a:ext uri="{FF2B5EF4-FFF2-40B4-BE49-F238E27FC236}">
-                <a16:creationId xmlns:a16="http://schemas.microsoft.com/office/drawing/2014/main" id="{32DA2B00-C203-4D5A-8269-83ED50FDBEB6}"/>
+                <a16:creationId xmlns:a16="http://schemas.microsoft.com/office/drawing/2014/main" id="{B5E01909-1E4F-4A79-BB31-7E5C6DB4E816}"/>
               </a:ext>
             </a:extLst>
           </p:cNvPr>
@@ -3730,7 +3730,7 @@
           <p:cNvPr id="12" name="">
             <a:extLst xmlns:a="http://schemas.openxmlformats.org/drawingml/2006/main">
               <a:ext uri="{FF2B5EF4-FFF2-40B4-BE49-F238E27FC236}">
-                <a16:creationId xmlns:a16="http://schemas.microsoft.com/office/drawing/2014/main" id="{062A0008-4F33-4FC8-A5BE-DD16FCD40FC8}"/>
+                <a16:creationId xmlns:a16="http://schemas.microsoft.com/office/drawing/2014/main" id="{E3F9BC20-11FE-437E-87CA-E745148AC7A4}"/>
               </a:ext>
             </a:extLst>
           </p:cNvPr>
@@ -3848,7 +3848,7 @@
           <p:cNvPr id="13" name="">
             <a:extLst xmlns:a="http://schemas.openxmlformats.org/drawingml/2006/main">
               <a:ext uri="{FF2B5EF4-FFF2-40B4-BE49-F238E27FC236}">
-                <a16:creationId xmlns:a16="http://schemas.microsoft.com/office/drawing/2014/main" id="{AA34D1E8-B2D6-49D4-B0AA-A9DFD1553D49}"/>
+                <a16:creationId xmlns:a16="http://schemas.microsoft.com/office/drawing/2014/main" id="{4213A667-F85A-4E4A-A5BB-F348174DD7C8}"/>
               </a:ext>
             </a:extLst>
           </p:cNvPr>
@@ -3896,7 +3896,7 @@
     </p:spTree>
     <p:extLst>
       <p:ext uri="{BB962C8B-B14F-4D97-AF65-F5344CB8AC3E}">
-        <p14:creationId xmlns:p14="http://schemas.microsoft.com/office/powerpoint/2010/main" val="484243888"/>
+        <p14:creationId xmlns:p14="http://schemas.microsoft.com/office/powerpoint/2010/main" val="766558727"/>
       </p:ext>
     </p:extLst>
   </p:cSld>
@@ -3927,7 +3927,7 @@
           <p:cNvPr id="1" name="">
             <a:extLst xmlns:a="http://schemas.openxmlformats.org/drawingml/2006/main">
               <a:ext uri="{FF2B5EF4-FFF2-40B4-BE49-F238E27FC236}">
-                <a16:creationId xmlns:a16="http://schemas.microsoft.com/office/drawing/2014/main" id="{C5832B9E-2778-4213-967E-B769B219C580}"/>
+                <a16:creationId xmlns:a16="http://schemas.microsoft.com/office/drawing/2014/main" id="{E5E4FFE5-7E43-4E2F-A75F-C129D5B84EBD}"/>
               </a:ext>
             </a:extLst>
           </p:cNvPr>
@@ -3977,7 +3977,7 @@
           <p:cNvPr id="2" name="">
             <a:extLst xmlns:a="http://schemas.openxmlformats.org/drawingml/2006/main">
               <a:ext uri="{FF2B5EF4-FFF2-40B4-BE49-F238E27FC236}">
-                <a16:creationId xmlns:a16="http://schemas.microsoft.com/office/drawing/2014/main" id="{C96E1597-2D8C-45DF-B132-0138234500E1}"/>
+                <a16:creationId xmlns:a16="http://schemas.microsoft.com/office/drawing/2014/main" id="{4DB2B9CC-37DD-4C57-A0DF-2CA92CCE2201}"/>
               </a:ext>
             </a:extLst>
           </p:cNvPr>
@@ -4027,7 +4027,7 @@
           <p:cNvPr id="3" name="">
             <a:extLst xmlns:a="http://schemas.openxmlformats.org/drawingml/2006/main">
               <a:ext uri="{FF2B5EF4-FFF2-40B4-BE49-F238E27FC236}">
-                <a16:creationId xmlns:a16="http://schemas.microsoft.com/office/drawing/2014/main" id="{F0F137FB-1769-4F92-9CF1-BA8AAB8EEC1C}"/>
+                <a16:creationId xmlns:a16="http://schemas.microsoft.com/office/drawing/2014/main" id="{2274B44D-B3BD-48CD-9494-0A6B6E84FEE0}"/>
               </a:ext>
             </a:extLst>
           </p:cNvPr>
@@ -4060,7 +4060,7 @@
           <p:cNvPr id="4" name="">
             <a:extLst xmlns:a="http://schemas.openxmlformats.org/drawingml/2006/main">
               <a:ext uri="{FF2B5EF4-FFF2-40B4-BE49-F238E27FC236}">
-                <a16:creationId xmlns:a16="http://schemas.microsoft.com/office/drawing/2014/main" id="{1F14917E-8F17-4A65-9D5B-80347757E8FC}"/>
+                <a16:creationId xmlns:a16="http://schemas.microsoft.com/office/drawing/2014/main" id="{761F091B-E493-4CD9-9622-BD0D63AE1868}"/>
               </a:ext>
             </a:extLst>
           </p:cNvPr>
@@ -4093,7 +4093,7 @@
           <p:cNvPr id="5" name="">
             <a:extLst xmlns:a="http://schemas.openxmlformats.org/drawingml/2006/main">
               <a:ext uri="{FF2B5EF4-FFF2-40B4-BE49-F238E27FC236}">
-                <a16:creationId xmlns:a16="http://schemas.microsoft.com/office/drawing/2014/main" id="{BB34BA42-B9D3-4217-8F93-BA371F016410}"/>
+                <a16:creationId xmlns:a16="http://schemas.microsoft.com/office/drawing/2014/main" id="{4FABDA21-B811-4E2F-AE80-35E7DB2C9ACE}"/>
               </a:ext>
             </a:extLst>
           </p:cNvPr>
@@ -4143,7 +4143,7 @@
           <p:cNvPr id="6" name="">
             <a:extLst xmlns:a="http://schemas.openxmlformats.org/drawingml/2006/main">
               <a:ext uri="{FF2B5EF4-FFF2-40B4-BE49-F238E27FC236}">
-                <a16:creationId xmlns:a16="http://schemas.microsoft.com/office/drawing/2014/main" id="{EF256480-5F59-4C54-B105-2F0FB3E440FD}"/>
+                <a16:creationId xmlns:a16="http://schemas.microsoft.com/office/drawing/2014/main" id="{DFC89F69-BB0C-400E-BD94-5F625742C60D}"/>
               </a:ext>
             </a:extLst>
           </p:cNvPr>
@@ -4176,7 +4176,7 @@
           <p:cNvPr id="7" name="">
             <a:extLst xmlns:a="http://schemas.openxmlformats.org/drawingml/2006/main">
               <a:ext uri="{FF2B5EF4-FFF2-40B4-BE49-F238E27FC236}">
-                <a16:creationId xmlns:a16="http://schemas.microsoft.com/office/drawing/2014/main" id="{AC8D5240-B655-44F3-8537-820052EAEFF4}"/>
+                <a16:creationId xmlns:a16="http://schemas.microsoft.com/office/drawing/2014/main" id="{DD75D3B3-2E20-4A7B-A6FD-3B5129379305}"/>
               </a:ext>
             </a:extLst>
           </p:cNvPr>
@@ -4226,7 +4226,7 @@
           <p:cNvPr id="8" name="">
             <a:extLst xmlns:a="http://schemas.openxmlformats.org/drawingml/2006/main">
               <a:ext uri="{FF2B5EF4-FFF2-40B4-BE49-F238E27FC236}">
-                <a16:creationId xmlns:a16="http://schemas.microsoft.com/office/drawing/2014/main" id="{18E54698-46E8-43AB-8887-F7611218FD3C}"/>
+                <a16:creationId xmlns:a16="http://schemas.microsoft.com/office/drawing/2014/main" id="{8C6272A7-1124-4034-8768-63EAB74B7D66}"/>
               </a:ext>
             </a:extLst>
           </p:cNvPr>
@@ -4259,7 +4259,7 @@
           <p:cNvPr id="9" name="">
             <a:extLst xmlns:a="http://schemas.openxmlformats.org/drawingml/2006/main">
               <a:ext uri="{FF2B5EF4-FFF2-40B4-BE49-F238E27FC236}">
-                <a16:creationId xmlns:a16="http://schemas.microsoft.com/office/drawing/2014/main" id="{124DD5D4-6C24-494F-9EA5-065063200821}"/>
+                <a16:creationId xmlns:a16="http://schemas.microsoft.com/office/drawing/2014/main" id="{19F07C06-6466-4DB6-84D7-1F41382BF1EE}"/>
               </a:ext>
             </a:extLst>
           </p:cNvPr>
@@ -4309,7 +4309,7 @@
           <p:cNvPr id="10" name="">
             <a:extLst xmlns:a="http://schemas.openxmlformats.org/drawingml/2006/main">
               <a:ext uri="{FF2B5EF4-FFF2-40B4-BE49-F238E27FC236}">
-                <a16:creationId xmlns:a16="http://schemas.microsoft.com/office/drawing/2014/main" id="{427F7E37-8F80-419D-A87D-B8979ECA532A}"/>
+                <a16:creationId xmlns:a16="http://schemas.microsoft.com/office/drawing/2014/main" id="{122A5551-C25C-4489-948B-C36918557AEB}"/>
               </a:ext>
             </a:extLst>
           </p:cNvPr>
@@ -4342,7 +4342,7 @@
           <p:cNvPr id="11" name="">
             <a:extLst xmlns:a="http://schemas.openxmlformats.org/drawingml/2006/main">
               <a:ext uri="{FF2B5EF4-FFF2-40B4-BE49-F238E27FC236}">
-                <a16:creationId xmlns:a16="http://schemas.microsoft.com/office/drawing/2014/main" id="{0C17F733-47F9-4389-A545-B4EA9776080F}"/>
+                <a16:creationId xmlns:a16="http://schemas.microsoft.com/office/drawing/2014/main" id="{7A8999EB-0AB8-47CD-A9BB-455634C4DA77}"/>
               </a:ext>
             </a:extLst>
           </p:cNvPr>
@@ -4392,7 +4392,7 @@
           <p:cNvPr id="12" name="">
             <a:extLst xmlns:a="http://schemas.openxmlformats.org/drawingml/2006/main">
               <a:ext uri="{FF2B5EF4-FFF2-40B4-BE49-F238E27FC236}">
-                <a16:creationId xmlns:a16="http://schemas.microsoft.com/office/drawing/2014/main" id="{9A8C85E5-9664-44C3-B8AA-4D815F35BE5B}"/>
+                <a16:creationId xmlns:a16="http://schemas.microsoft.com/office/drawing/2014/main" id="{858EED2F-83D6-4DF9-A829-E419395BAD35}"/>
               </a:ext>
             </a:extLst>
           </p:cNvPr>
@@ -4425,7 +4425,7 @@
           <p:cNvPr id="13" name="">
             <a:extLst xmlns:a="http://schemas.openxmlformats.org/drawingml/2006/main">
               <a:ext uri="{FF2B5EF4-FFF2-40B4-BE49-F238E27FC236}">
-                <a16:creationId xmlns:a16="http://schemas.microsoft.com/office/drawing/2014/main" id="{42572D8B-EE6B-4018-80AD-8CBCEAFEC869}"/>
+                <a16:creationId xmlns:a16="http://schemas.microsoft.com/office/drawing/2014/main" id="{3CD77C47-9456-4852-BE15-C1C9BE695CE2}"/>
               </a:ext>
             </a:extLst>
           </p:cNvPr>
@@ -4475,7 +4475,7 @@
           <p:cNvPr id="14" name="">
             <a:extLst xmlns:a="http://schemas.openxmlformats.org/drawingml/2006/main">
               <a:ext uri="{FF2B5EF4-FFF2-40B4-BE49-F238E27FC236}">
-                <a16:creationId xmlns:a16="http://schemas.microsoft.com/office/drawing/2014/main" id="{17CAB169-FD57-4F53-AE78-7D25A9DB7BAF}"/>
+                <a16:creationId xmlns:a16="http://schemas.microsoft.com/office/drawing/2014/main" id="{5D0455B9-F903-4702-BCD0-76D970BBD654}"/>
               </a:ext>
             </a:extLst>
           </p:cNvPr>
@@ -4508,7 +4508,7 @@
           <p:cNvPr id="15" name="">
             <a:extLst xmlns:a="http://schemas.openxmlformats.org/drawingml/2006/main">
               <a:ext uri="{FF2B5EF4-FFF2-40B4-BE49-F238E27FC236}">
-                <a16:creationId xmlns:a16="http://schemas.microsoft.com/office/drawing/2014/main" id="{6C59FC83-0629-4E1F-BEBE-8EB044686F9A}"/>
+                <a16:creationId xmlns:a16="http://schemas.microsoft.com/office/drawing/2014/main" id="{3A925996-4CD8-40C9-AC7A-CEBA439C71B0}"/>
               </a:ext>
             </a:extLst>
           </p:cNvPr>
@@ -4558,7 +4558,7 @@
           <p:cNvPr id="16" name="">
             <a:extLst xmlns:a="http://schemas.openxmlformats.org/drawingml/2006/main">
               <a:ext uri="{FF2B5EF4-FFF2-40B4-BE49-F238E27FC236}">
-                <a16:creationId xmlns:a16="http://schemas.microsoft.com/office/drawing/2014/main" id="{5D51BA68-077C-4BDC-BE36-4436CBD30C43}"/>
+                <a16:creationId xmlns:a16="http://schemas.microsoft.com/office/drawing/2014/main" id="{CE7C8E28-2C94-4C37-A4DA-46176C8F09D0}"/>
               </a:ext>
             </a:extLst>
           </p:cNvPr>
@@ -4591,7 +4591,7 @@
           <p:cNvPr id="17" name="">
             <a:extLst xmlns:a="http://schemas.openxmlformats.org/drawingml/2006/main">
               <a:ext uri="{FF2B5EF4-FFF2-40B4-BE49-F238E27FC236}">
-                <a16:creationId xmlns:a16="http://schemas.microsoft.com/office/drawing/2014/main" id="{9808AA5A-D3D2-4F48-AE85-40E53D8CF87A}"/>
+                <a16:creationId xmlns:a16="http://schemas.microsoft.com/office/drawing/2014/main" id="{CF5F008A-2C47-42DA-B556-FAA083C1C8C7}"/>
               </a:ext>
             </a:extLst>
           </p:cNvPr>
@@ -4641,7 +4641,7 @@
           <p:cNvPr id="18" name="">
             <a:extLst xmlns:a="http://schemas.openxmlformats.org/drawingml/2006/main">
               <a:ext uri="{FF2B5EF4-FFF2-40B4-BE49-F238E27FC236}">
-                <a16:creationId xmlns:a16="http://schemas.microsoft.com/office/drawing/2014/main" id="{FCC39D09-4878-44C4-AAEB-16F62A4A0B37}"/>
+                <a16:creationId xmlns:a16="http://schemas.microsoft.com/office/drawing/2014/main" id="{BA9E0330-C7E8-4260-A4E7-411A917E0687}"/>
               </a:ext>
             </a:extLst>
           </p:cNvPr>
@@ -4674,7 +4674,7 @@
           <p:cNvPr id="19" name="">
             <a:extLst xmlns:a="http://schemas.openxmlformats.org/drawingml/2006/main">
               <a:ext uri="{FF2B5EF4-FFF2-40B4-BE49-F238E27FC236}">
-                <a16:creationId xmlns:a16="http://schemas.microsoft.com/office/drawing/2014/main" id="{E2110493-B161-44CF-8D8F-962E5C3EC041}"/>
+                <a16:creationId xmlns:a16="http://schemas.microsoft.com/office/drawing/2014/main" id="{64718E46-F2AF-49FF-8B4E-FC81F7BA70EB}"/>
               </a:ext>
             </a:extLst>
           </p:cNvPr>
@@ -4724,7 +4724,7 @@
           <p:cNvPr id="20" name="">
             <a:extLst xmlns:a="http://schemas.openxmlformats.org/drawingml/2006/main">
               <a:ext uri="{FF2B5EF4-FFF2-40B4-BE49-F238E27FC236}">
-                <a16:creationId xmlns:a16="http://schemas.microsoft.com/office/drawing/2014/main" id="{0B04433E-072C-43AA-80DB-D3A09B59492E}"/>
+                <a16:creationId xmlns:a16="http://schemas.microsoft.com/office/drawing/2014/main" id="{002964B9-3D84-42F7-BFD9-61D220D365A3}"/>
               </a:ext>
             </a:extLst>
           </p:cNvPr>
@@ -4757,7 +4757,7 @@
           <p:cNvPr id="21" name="">
             <a:extLst xmlns:a="http://schemas.openxmlformats.org/drawingml/2006/main">
               <a:ext uri="{FF2B5EF4-FFF2-40B4-BE49-F238E27FC236}">
-                <a16:creationId xmlns:a16="http://schemas.microsoft.com/office/drawing/2014/main" id="{0950D8EF-1E44-48B2-B066-0ACF08F1F8D8}"/>
+                <a16:creationId xmlns:a16="http://schemas.microsoft.com/office/drawing/2014/main" id="{4D56383E-F51A-49AC-A299-7396406BDBF5}"/>
               </a:ext>
             </a:extLst>
           </p:cNvPr>
@@ -4807,7 +4807,7 @@
           <p:cNvPr id="22" name="">
             <a:extLst xmlns:a="http://schemas.openxmlformats.org/drawingml/2006/main">
               <a:ext uri="{FF2B5EF4-FFF2-40B4-BE49-F238E27FC236}">
-                <a16:creationId xmlns:a16="http://schemas.microsoft.com/office/drawing/2014/main" id="{0E4A03FD-A512-4AD1-8691-CEC403D816F1}"/>
+                <a16:creationId xmlns:a16="http://schemas.microsoft.com/office/drawing/2014/main" id="{156E972D-C279-4B62-A5AA-A66D9FFB4853}"/>
               </a:ext>
             </a:extLst>
           </p:cNvPr>
@@ -4840,7 +4840,7 @@
           <p:cNvPr id="23" name="">
             <a:extLst xmlns:a="http://schemas.openxmlformats.org/drawingml/2006/main">
               <a:ext uri="{FF2B5EF4-FFF2-40B4-BE49-F238E27FC236}">
-                <a16:creationId xmlns:a16="http://schemas.microsoft.com/office/drawing/2014/main" id="{0472B349-D410-4F11-9A0E-33CB6B3559BA}"/>
+                <a16:creationId xmlns:a16="http://schemas.microsoft.com/office/drawing/2014/main" id="{574C4049-9339-4E21-9219-29AF71C1EE9E}"/>
               </a:ext>
             </a:extLst>
           </p:cNvPr>
@@ -4890,7 +4890,7 @@
           <p:cNvPr id="24" name="">
             <a:extLst xmlns:a="http://schemas.openxmlformats.org/drawingml/2006/main">
               <a:ext uri="{FF2B5EF4-FFF2-40B4-BE49-F238E27FC236}">
-                <a16:creationId xmlns:a16="http://schemas.microsoft.com/office/drawing/2014/main" id="{6F195012-BA52-40F4-B194-43FB85E347AD}"/>
+                <a16:creationId xmlns:a16="http://schemas.microsoft.com/office/drawing/2014/main" id="{0E5E4A15-EB58-45D5-A766-7D4D2B46B802}"/>
               </a:ext>
             </a:extLst>
           </p:cNvPr>
@@ -4940,7 +4940,7 @@
           <p:cNvPr id="25" name="">
             <a:extLst xmlns:a="http://schemas.openxmlformats.org/drawingml/2006/main">
               <a:ext uri="{FF2B5EF4-FFF2-40B4-BE49-F238E27FC236}">
-                <a16:creationId xmlns:a16="http://schemas.microsoft.com/office/drawing/2014/main" id="{B0AD24CE-FC0C-4685-A93F-D30889EFB819}"/>
+                <a16:creationId xmlns:a16="http://schemas.microsoft.com/office/drawing/2014/main" id="{2361F555-CE5A-4767-A6AA-B6F79DE17186}"/>
               </a:ext>
             </a:extLst>
           </p:cNvPr>
@@ -4988,7 +4988,7 @@
     </p:spTree>
     <p:extLst>
       <p:ext uri="{BB962C8B-B14F-4D97-AF65-F5344CB8AC3E}">
-        <p14:creationId xmlns:p14="http://schemas.microsoft.com/office/powerpoint/2010/main" val="1540440001"/>
+        <p14:creationId xmlns:p14="http://schemas.microsoft.com/office/powerpoint/2010/main" val="466413989"/>
       </p:ext>
     </p:extLst>
   </p:cSld>
@@ -5019,7 +5019,7 @@
           <p:cNvPr id="1" name="">
             <a:extLst xmlns:a="http://schemas.openxmlformats.org/drawingml/2006/main">
               <a:ext uri="{FF2B5EF4-FFF2-40B4-BE49-F238E27FC236}">
-                <a16:creationId xmlns:a16="http://schemas.microsoft.com/office/drawing/2014/main" id="{0D53C451-7B55-4065-96DB-1592773ED92F}"/>
+                <a16:creationId xmlns:a16="http://schemas.microsoft.com/office/drawing/2014/main" id="{2274C7EE-2D13-4CE6-A13B-261C4CFEB160}"/>
               </a:ext>
             </a:extLst>
           </p:cNvPr>
@@ -5069,7 +5069,7 @@
           <p:cNvPr id="2" name="">
             <a:extLst xmlns:a="http://schemas.openxmlformats.org/drawingml/2006/main">
               <a:ext uri="{FF2B5EF4-FFF2-40B4-BE49-F238E27FC236}">
-                <a16:creationId xmlns:a16="http://schemas.microsoft.com/office/drawing/2014/main" id="{9AF2163D-026F-41D2-87D3-4116A7F13D62}"/>
+                <a16:creationId xmlns:a16="http://schemas.microsoft.com/office/drawing/2014/main" id="{5DF47208-E1D9-4372-88F1-B227DB468C66}"/>
               </a:ext>
             </a:extLst>
           </p:cNvPr>
@@ -5119,7 +5119,7 @@
           <p:cNvPr id="3" name="">
             <a:extLst xmlns:a="http://schemas.openxmlformats.org/drawingml/2006/main">
               <a:ext uri="{FF2B5EF4-FFF2-40B4-BE49-F238E27FC236}">
-                <a16:creationId xmlns:a16="http://schemas.microsoft.com/office/drawing/2014/main" id="{A8BD7EC5-AA15-4D38-AB2A-F62C8183FEBE}"/>
+                <a16:creationId xmlns:a16="http://schemas.microsoft.com/office/drawing/2014/main" id="{137FB368-7BA8-4C87-941A-836D6DB89F88}"/>
               </a:ext>
             </a:extLst>
           </p:cNvPr>
@@ -5152,7 +5152,7 @@
           <p:cNvPr id="4" name="">
             <a:extLst xmlns:a="http://schemas.openxmlformats.org/drawingml/2006/main">
               <a:ext uri="{FF2B5EF4-FFF2-40B4-BE49-F238E27FC236}">
-                <a16:creationId xmlns:a16="http://schemas.microsoft.com/office/drawing/2014/main" id="{33810708-A4B5-4508-B0DD-7DCE3CB407F2}"/>
+                <a16:creationId xmlns:a16="http://schemas.microsoft.com/office/drawing/2014/main" id="{7B4FC8FF-A900-4372-9DAE-F082632C8183}"/>
               </a:ext>
             </a:extLst>
           </p:cNvPr>
@@ -5185,7 +5185,7 @@
           <p:cNvPr id="5" name="">
             <a:extLst xmlns:a="http://schemas.openxmlformats.org/drawingml/2006/main">
               <a:ext uri="{FF2B5EF4-FFF2-40B4-BE49-F238E27FC236}">
-                <a16:creationId xmlns:a16="http://schemas.microsoft.com/office/drawing/2014/main" id="{86EB597F-4F24-404E-AC36-91C60FD5D1D3}"/>
+                <a16:creationId xmlns:a16="http://schemas.microsoft.com/office/drawing/2014/main" id="{650096BB-03AD-472E-9EF2-4A26986E1762}"/>
               </a:ext>
             </a:extLst>
           </p:cNvPr>
@@ -5235,7 +5235,7 @@
           <p:cNvPr id="6" name="">
             <a:extLst xmlns:a="http://schemas.openxmlformats.org/drawingml/2006/main">
               <a:ext uri="{FF2B5EF4-FFF2-40B4-BE49-F238E27FC236}">
-                <a16:creationId xmlns:a16="http://schemas.microsoft.com/office/drawing/2014/main" id="{DBCB6A3E-05B7-454B-97D0-1B631C26D697}"/>
+                <a16:creationId xmlns:a16="http://schemas.microsoft.com/office/drawing/2014/main" id="{D43835FE-5CF0-4408-A2AA-041CF8650659}"/>
               </a:ext>
             </a:extLst>
           </p:cNvPr>
@@ -5268,7 +5268,7 @@
           <p:cNvPr id="7" name="">
             <a:extLst xmlns:a="http://schemas.openxmlformats.org/drawingml/2006/main">
               <a:ext uri="{FF2B5EF4-FFF2-40B4-BE49-F238E27FC236}">
-                <a16:creationId xmlns:a16="http://schemas.microsoft.com/office/drawing/2014/main" id="{645FC91C-4A1E-4EF6-8518-5F292054F3BF}"/>
+                <a16:creationId xmlns:a16="http://schemas.microsoft.com/office/drawing/2014/main" id="{664DC630-2F12-4E94-BBF8-803A47FC3E42}"/>
               </a:ext>
             </a:extLst>
           </p:cNvPr>
@@ -5318,7 +5318,7 @@
           <p:cNvPr id="8" name="">
             <a:extLst xmlns:a="http://schemas.openxmlformats.org/drawingml/2006/main">
               <a:ext uri="{FF2B5EF4-FFF2-40B4-BE49-F238E27FC236}">
-                <a16:creationId xmlns:a16="http://schemas.microsoft.com/office/drawing/2014/main" id="{B95C4B97-D9AD-4F97-A436-75F2E7C76D79}"/>
+                <a16:creationId xmlns:a16="http://schemas.microsoft.com/office/drawing/2014/main" id="{76FDE3A4-6F6A-4257-8ABF-334FCEEC5976}"/>
               </a:ext>
             </a:extLst>
           </p:cNvPr>
@@ -5351,7 +5351,7 @@
           <p:cNvPr id="9" name="">
             <a:extLst xmlns:a="http://schemas.openxmlformats.org/drawingml/2006/main">
               <a:ext uri="{FF2B5EF4-FFF2-40B4-BE49-F238E27FC236}">
-                <a16:creationId xmlns:a16="http://schemas.microsoft.com/office/drawing/2014/main" id="{47448AED-2BA0-4C83-9A1D-3F37B8CD4F8B}"/>
+                <a16:creationId xmlns:a16="http://schemas.microsoft.com/office/drawing/2014/main" id="{364B77F3-D025-48AB-B491-0EB450C70762}"/>
               </a:ext>
             </a:extLst>
           </p:cNvPr>
@@ -5401,7 +5401,7 @@
           <p:cNvPr id="10" name="">
             <a:extLst xmlns:a="http://schemas.openxmlformats.org/drawingml/2006/main">
               <a:ext uri="{FF2B5EF4-FFF2-40B4-BE49-F238E27FC236}">
-                <a16:creationId xmlns:a16="http://schemas.microsoft.com/office/drawing/2014/main" id="{12F8D73B-3201-45F4-BF38-54597F2D0A04}"/>
+                <a16:creationId xmlns:a16="http://schemas.microsoft.com/office/drawing/2014/main" id="{999C9592-71BA-437A-A490-FB3A3ED7B2A1}"/>
               </a:ext>
             </a:extLst>
           </p:cNvPr>
@@ -5434,7 +5434,7 @@
           <p:cNvPr id="11" name="">
             <a:extLst xmlns:a="http://schemas.openxmlformats.org/drawingml/2006/main">
               <a:ext uri="{FF2B5EF4-FFF2-40B4-BE49-F238E27FC236}">
-                <a16:creationId xmlns:a16="http://schemas.microsoft.com/office/drawing/2014/main" id="{1535F61A-9902-4237-AA0B-A290858060DC}"/>
+                <a16:creationId xmlns:a16="http://schemas.microsoft.com/office/drawing/2014/main" id="{F8C1FC57-CB88-4658-AF46-DA50AD0E1386}"/>
               </a:ext>
             </a:extLst>
           </p:cNvPr>
@@ -5484,7 +5484,7 @@
           <p:cNvPr id="12" name="">
             <a:extLst xmlns:a="http://schemas.openxmlformats.org/drawingml/2006/main">
               <a:ext uri="{FF2B5EF4-FFF2-40B4-BE49-F238E27FC236}">
-                <a16:creationId xmlns:a16="http://schemas.microsoft.com/office/drawing/2014/main" id="{F3092926-1E3C-4406-A5AF-BC6672A72812}"/>
+                <a16:creationId xmlns:a16="http://schemas.microsoft.com/office/drawing/2014/main" id="{44526C1F-A5C0-46EC-ACEF-E2662D6D9830}"/>
               </a:ext>
             </a:extLst>
           </p:cNvPr>
@@ -5517,7 +5517,7 @@
           <p:cNvPr id="13" name="">
             <a:extLst xmlns:a="http://schemas.openxmlformats.org/drawingml/2006/main">
               <a:ext uri="{FF2B5EF4-FFF2-40B4-BE49-F238E27FC236}">
-                <a16:creationId xmlns:a16="http://schemas.microsoft.com/office/drawing/2014/main" id="{D51C7CEC-09DC-4F2D-88BC-8C1730E034B9}"/>
+                <a16:creationId xmlns:a16="http://schemas.microsoft.com/office/drawing/2014/main" id="{E1A5AB41-64B6-4C29-8C20-CAF35ECA0311}"/>
               </a:ext>
             </a:extLst>
           </p:cNvPr>
@@ -5567,7 +5567,7 @@
           <p:cNvPr id="14" name="">
             <a:extLst xmlns:a="http://schemas.openxmlformats.org/drawingml/2006/main">
               <a:ext uri="{FF2B5EF4-FFF2-40B4-BE49-F238E27FC236}">
-                <a16:creationId xmlns:a16="http://schemas.microsoft.com/office/drawing/2014/main" id="{BCFEDE0E-5978-4E56-AEC6-5081416037EC}"/>
+                <a16:creationId xmlns:a16="http://schemas.microsoft.com/office/drawing/2014/main" id="{B53B04CD-67F4-4B87-AAAD-BF149B7BD9A9}"/>
               </a:ext>
             </a:extLst>
           </p:cNvPr>
@@ -5617,7 +5617,7 @@
           <p:cNvPr id="15" name="">
             <a:extLst xmlns:a="http://schemas.openxmlformats.org/drawingml/2006/main">
               <a:ext uri="{FF2B5EF4-FFF2-40B4-BE49-F238E27FC236}">
-                <a16:creationId xmlns:a16="http://schemas.microsoft.com/office/drawing/2014/main" id="{6553BD1D-5CA3-4AC0-BE77-48CE7F28296A}"/>
+                <a16:creationId xmlns:a16="http://schemas.microsoft.com/office/drawing/2014/main" id="{17FFF173-1EAF-459F-8C46-5BB5CA1FA998}"/>
               </a:ext>
             </a:extLst>
           </p:cNvPr>
@@ -5665,7 +5665,7 @@
     </p:spTree>
     <p:extLst>
       <p:ext uri="{BB962C8B-B14F-4D97-AF65-F5344CB8AC3E}">
-        <p14:creationId xmlns:p14="http://schemas.microsoft.com/office/powerpoint/2010/main" val="629193156"/>
+        <p14:creationId xmlns:p14="http://schemas.microsoft.com/office/powerpoint/2010/main" val="352314948"/>
       </p:ext>
     </p:extLst>
   </p:cSld>
@@ -5696,7 +5696,7 @@
           <p:cNvPr id="1" name="">
             <a:extLst xmlns:a="http://schemas.openxmlformats.org/drawingml/2006/main">
               <a:ext uri="{FF2B5EF4-FFF2-40B4-BE49-F238E27FC236}">
-                <a16:creationId xmlns:a16="http://schemas.microsoft.com/office/drawing/2014/main" id="{4CD13FB2-EAD0-4F91-88AE-7B70AB048FC1}"/>
+                <a16:creationId xmlns:a16="http://schemas.microsoft.com/office/drawing/2014/main" id="{0599D13B-14DA-4A37-AEED-EAC4B29CB500}"/>
               </a:ext>
             </a:extLst>
           </p:cNvPr>
@@ -5746,7 +5746,7 @@
           <p:cNvPr id="2" name="">
             <a:extLst xmlns:a="http://schemas.openxmlformats.org/drawingml/2006/main">
               <a:ext uri="{FF2B5EF4-FFF2-40B4-BE49-F238E27FC236}">
-                <a16:creationId xmlns:a16="http://schemas.microsoft.com/office/drawing/2014/main" id="{41F0CB15-A16A-467B-A022-9CD2B10269F6}"/>
+                <a16:creationId xmlns:a16="http://schemas.microsoft.com/office/drawing/2014/main" id="{90E12A8E-25FA-4F0A-95E2-25C86BC1DA7F}"/>
               </a:ext>
             </a:extLst>
           </p:cNvPr>
@@ -5796,7 +5796,7 @@
           <p:cNvPr id="3" name="">
             <a:extLst xmlns:a="http://schemas.openxmlformats.org/drawingml/2006/main">
               <a:ext uri="{FF2B5EF4-FFF2-40B4-BE49-F238E27FC236}">
-                <a16:creationId xmlns:a16="http://schemas.microsoft.com/office/drawing/2014/main" id="{F6350044-9AB2-40A4-9180-9945FB277A00}"/>
+                <a16:creationId xmlns:a16="http://schemas.microsoft.com/office/drawing/2014/main" id="{52D9CC9F-BF1C-4EB9-8954-921BC1F8A121}"/>
               </a:ext>
             </a:extLst>
           </p:cNvPr>
@@ -5829,7 +5829,7 @@
           <p:cNvPr id="4" name="">
             <a:extLst xmlns:a="http://schemas.openxmlformats.org/drawingml/2006/main">
               <a:ext uri="{FF2B5EF4-FFF2-40B4-BE49-F238E27FC236}">
-                <a16:creationId xmlns:a16="http://schemas.microsoft.com/office/drawing/2014/main" id="{734A201D-EAD6-431A-9A17-8363DB6E5080}"/>
+                <a16:creationId xmlns:a16="http://schemas.microsoft.com/office/drawing/2014/main" id="{0C245319-541C-4684-9A14-84CD0F83658B}"/>
               </a:ext>
             </a:extLst>
           </p:cNvPr>
@@ -5862,7 +5862,7 @@
           <p:cNvPr id="5" name="">
             <a:extLst xmlns:a="http://schemas.openxmlformats.org/drawingml/2006/main">
               <a:ext uri="{FF2B5EF4-FFF2-40B4-BE49-F238E27FC236}">
-                <a16:creationId xmlns:a16="http://schemas.microsoft.com/office/drawing/2014/main" id="{B8480F3B-2543-422E-AC26-245E7DC72D5B}"/>
+                <a16:creationId xmlns:a16="http://schemas.microsoft.com/office/drawing/2014/main" id="{B7CD8CEF-6735-497C-A93D-CB127234ADED}"/>
               </a:ext>
             </a:extLst>
           </p:cNvPr>
@@ -5912,7 +5912,7 @@
           <p:cNvPr id="6" name="">
             <a:extLst xmlns:a="http://schemas.openxmlformats.org/drawingml/2006/main">
               <a:ext uri="{FF2B5EF4-FFF2-40B4-BE49-F238E27FC236}">
-                <a16:creationId xmlns:a16="http://schemas.microsoft.com/office/drawing/2014/main" id="{9EBAC99C-2FA0-44E8-9258-50035E127762}"/>
+                <a16:creationId xmlns:a16="http://schemas.microsoft.com/office/drawing/2014/main" id="{A4AACCFF-679D-4090-8DC8-931A22E3BED4}"/>
               </a:ext>
             </a:extLst>
           </p:cNvPr>
@@ -5945,7 +5945,7 @@
           <p:cNvPr id="7" name="">
             <a:extLst xmlns:a="http://schemas.openxmlformats.org/drawingml/2006/main">
               <a:ext uri="{FF2B5EF4-FFF2-40B4-BE49-F238E27FC236}">
-                <a16:creationId xmlns:a16="http://schemas.microsoft.com/office/drawing/2014/main" id="{711DA9FD-7BFA-4EEA-B2FF-3F90090FB9FC}"/>
+                <a16:creationId xmlns:a16="http://schemas.microsoft.com/office/drawing/2014/main" id="{39053E4C-D0D9-4F88-9C0C-71FD0C29C93B}"/>
               </a:ext>
             </a:extLst>
           </p:cNvPr>
@@ -5995,7 +5995,7 @@
           <p:cNvPr id="8" name="">
             <a:extLst xmlns:a="http://schemas.openxmlformats.org/drawingml/2006/main">
               <a:ext uri="{FF2B5EF4-FFF2-40B4-BE49-F238E27FC236}">
-                <a16:creationId xmlns:a16="http://schemas.microsoft.com/office/drawing/2014/main" id="{FAB1CD53-1D52-49DE-B296-C88F1080A2E2}"/>
+                <a16:creationId xmlns:a16="http://schemas.microsoft.com/office/drawing/2014/main" id="{68007B92-68CF-48A7-B4B2-6749E95B4C59}"/>
               </a:ext>
             </a:extLst>
           </p:cNvPr>
@@ -6028,7 +6028,7 @@
           <p:cNvPr id="9" name="">
             <a:extLst xmlns:a="http://schemas.openxmlformats.org/drawingml/2006/main">
               <a:ext uri="{FF2B5EF4-FFF2-40B4-BE49-F238E27FC236}">
-                <a16:creationId xmlns:a16="http://schemas.microsoft.com/office/drawing/2014/main" id="{8DA5A46F-EAA9-41F8-B1FF-0E28927F44DD}"/>
+                <a16:creationId xmlns:a16="http://schemas.microsoft.com/office/drawing/2014/main" id="{9E02E60D-5574-41E1-90E6-F80E5FE9187A}"/>
               </a:ext>
             </a:extLst>
           </p:cNvPr>
@@ -6078,7 +6078,7 @@
           <p:cNvPr id="10" name="">
             <a:extLst xmlns:a="http://schemas.openxmlformats.org/drawingml/2006/main">
               <a:ext uri="{FF2B5EF4-FFF2-40B4-BE49-F238E27FC236}">
-                <a16:creationId xmlns:a16="http://schemas.microsoft.com/office/drawing/2014/main" id="{C7CB078F-F225-4475-B6C1-86F10F9AE395}"/>
+                <a16:creationId xmlns:a16="http://schemas.microsoft.com/office/drawing/2014/main" id="{269B075E-019B-4216-8579-EC904A4C6D02}"/>
               </a:ext>
             </a:extLst>
           </p:cNvPr>
@@ -6111,7 +6111,7 @@
           <p:cNvPr id="11" name="">
             <a:extLst xmlns:a="http://schemas.openxmlformats.org/drawingml/2006/main">
               <a:ext uri="{FF2B5EF4-FFF2-40B4-BE49-F238E27FC236}">
-                <a16:creationId xmlns:a16="http://schemas.microsoft.com/office/drawing/2014/main" id="{5EB0895B-4E24-4928-891B-E339A4911F10}"/>
+                <a16:creationId xmlns:a16="http://schemas.microsoft.com/office/drawing/2014/main" id="{D30A0EB6-6B6E-4451-9FD9-9AE007B27D77}"/>
               </a:ext>
             </a:extLst>
           </p:cNvPr>
@@ -6165,7 +6165,7 @@
           <p:nvPr/>
         </p:nvPicPr>
         <p:blipFill>
-          <a:blip xmlns:r="http://schemas.openxmlformats.org/officeDocument/2006/relationships" xmlns:a="http://schemas.openxmlformats.org/drawingml/2006/main" r:embed="R790114bb91d44d5e"/>
+          <a:blip xmlns:r="http://schemas.openxmlformats.org/officeDocument/2006/relationships" xmlns:a="http://schemas.openxmlformats.org/drawingml/2006/main" r:embed="R26e14d1ea1e74d68"/>
           <a:stretch xmlns:a="http://schemas.openxmlformats.org/drawingml/2006/main"/>
         </p:blipFill>
         <p:spPr>
@@ -6183,7 +6183,7 @@
           <p:cNvPr id="13" name="">
             <a:extLst xmlns:a="http://schemas.openxmlformats.org/drawingml/2006/main">
               <a:ext uri="{FF2B5EF4-FFF2-40B4-BE49-F238E27FC236}">
-                <a16:creationId xmlns:a16="http://schemas.microsoft.com/office/drawing/2014/main" id="{F089168C-66EF-4472-BEAD-6D4C266B677E}"/>
+                <a16:creationId xmlns:a16="http://schemas.microsoft.com/office/drawing/2014/main" id="{3A86B53A-6807-44ED-89DA-36CD4AE33BB1}"/>
               </a:ext>
             </a:extLst>
           </p:cNvPr>
@@ -6233,7 +6233,7 @@
           <p:cNvPr id="14" name="">
             <a:extLst xmlns:a="http://schemas.openxmlformats.org/drawingml/2006/main">
               <a:ext uri="{FF2B5EF4-FFF2-40B4-BE49-F238E27FC236}">
-                <a16:creationId xmlns:a16="http://schemas.microsoft.com/office/drawing/2014/main" id="{4FFA3553-8BE8-44E6-85A2-CACB6FF3B91E}"/>
+                <a16:creationId xmlns:a16="http://schemas.microsoft.com/office/drawing/2014/main" id="{677415ED-1B68-4EA5-BC13-130B303F174C}"/>
               </a:ext>
             </a:extLst>
           </p:cNvPr>
@@ -6281,7 +6281,7 @@
     </p:spTree>
     <p:extLst>
       <p:ext uri="{BB962C8B-B14F-4D97-AF65-F5344CB8AC3E}">
-        <p14:creationId xmlns:p14="http://schemas.microsoft.com/office/powerpoint/2010/main" val="398276490"/>
+        <p14:creationId xmlns:p14="http://schemas.microsoft.com/office/powerpoint/2010/main" val="1186170306"/>
       </p:ext>
     </p:extLst>
   </p:cSld>
@@ -6312,7 +6312,7 @@
           <p:cNvPr id="1" name="">
             <a:extLst xmlns:a="http://schemas.openxmlformats.org/drawingml/2006/main">
               <a:ext uri="{FF2B5EF4-FFF2-40B4-BE49-F238E27FC236}">
-                <a16:creationId xmlns:a16="http://schemas.microsoft.com/office/drawing/2014/main" id="{82CF6E6D-815C-410D-9A7D-E0E08F229FE5}"/>
+                <a16:creationId xmlns:a16="http://schemas.microsoft.com/office/drawing/2014/main" id="{79DCD635-4F54-4EBF-AC3D-77C238315807}"/>
               </a:ext>
             </a:extLst>
           </p:cNvPr>
@@ -6362,7 +6362,7 @@
           <p:cNvPr id="2" name="">
             <a:extLst xmlns:a="http://schemas.openxmlformats.org/drawingml/2006/main">
               <a:ext uri="{FF2B5EF4-FFF2-40B4-BE49-F238E27FC236}">
-                <a16:creationId xmlns:a16="http://schemas.microsoft.com/office/drawing/2014/main" id="{6830EF66-A8FE-4731-AD93-6EE7F0B288DA}"/>
+                <a16:creationId xmlns:a16="http://schemas.microsoft.com/office/drawing/2014/main" id="{775AD001-BB9B-49DC-90A5-AA9DC0B47D31}"/>
               </a:ext>
             </a:extLst>
           </p:cNvPr>
@@ -6412,7 +6412,7 @@
           <p:cNvPr id="3" name="">
             <a:extLst xmlns:a="http://schemas.openxmlformats.org/drawingml/2006/main">
               <a:ext uri="{FF2B5EF4-FFF2-40B4-BE49-F238E27FC236}">
-                <a16:creationId xmlns:a16="http://schemas.microsoft.com/office/drawing/2014/main" id="{14395348-5C9F-440D-AF23-9AD40D9871C7}"/>
+                <a16:creationId xmlns:a16="http://schemas.microsoft.com/office/drawing/2014/main" id="{1F0053BC-52AF-407C-91B4-DAF5CAC3D171}"/>
               </a:ext>
             </a:extLst>
           </p:cNvPr>
@@ -6445,7 +6445,7 @@
           <p:cNvPr id="4" name="">
             <a:extLst xmlns:a="http://schemas.openxmlformats.org/drawingml/2006/main">
               <a:ext uri="{FF2B5EF4-FFF2-40B4-BE49-F238E27FC236}">
-                <a16:creationId xmlns:a16="http://schemas.microsoft.com/office/drawing/2014/main" id="{ABB04E2C-B52D-480E-8165-EAAFDE89A6FC}"/>
+                <a16:creationId xmlns:a16="http://schemas.microsoft.com/office/drawing/2014/main" id="{D8C5855B-83FB-4369-AD6A-EB37FC6D73A8}"/>
               </a:ext>
             </a:extLst>
           </p:cNvPr>
@@ -6478,7 +6478,7 @@
           <p:cNvPr id="5" name="">
             <a:extLst xmlns:a="http://schemas.openxmlformats.org/drawingml/2006/main">
               <a:ext uri="{FF2B5EF4-FFF2-40B4-BE49-F238E27FC236}">
-                <a16:creationId xmlns:a16="http://schemas.microsoft.com/office/drawing/2014/main" id="{45BE52FD-68A9-43D4-9F66-5C6B169E672C}"/>
+                <a16:creationId xmlns:a16="http://schemas.microsoft.com/office/drawing/2014/main" id="{B7A031D7-251F-46EB-9C32-AC31E2994F52}"/>
               </a:ext>
             </a:extLst>
           </p:cNvPr>
@@ -6528,7 +6528,7 @@
           <p:cNvPr id="6" name="">
             <a:extLst xmlns:a="http://schemas.openxmlformats.org/drawingml/2006/main">
               <a:ext uri="{FF2B5EF4-FFF2-40B4-BE49-F238E27FC236}">
-                <a16:creationId xmlns:a16="http://schemas.microsoft.com/office/drawing/2014/main" id="{709808E4-049C-4D43-B309-CB4599AE646C}"/>
+                <a16:creationId xmlns:a16="http://schemas.microsoft.com/office/drawing/2014/main" id="{E8CC0EDD-E7C9-48C1-88A1-1D94484514D9}"/>
               </a:ext>
             </a:extLst>
           </p:cNvPr>
@@ -6578,7 +6578,7 @@
           <p:cNvPr id="7" name="">
             <a:extLst xmlns:a="http://schemas.openxmlformats.org/drawingml/2006/main">
               <a:ext uri="{FF2B5EF4-FFF2-40B4-BE49-F238E27FC236}">
-                <a16:creationId xmlns:a16="http://schemas.microsoft.com/office/drawing/2014/main" id="{84453A90-2298-488E-815F-C1EE73064DE8}"/>
+                <a16:creationId xmlns:a16="http://schemas.microsoft.com/office/drawing/2014/main" id="{2572EFDD-BE1F-476D-BFF5-8E3E86FF7DCC}"/>
               </a:ext>
             </a:extLst>
           </p:cNvPr>
@@ -6611,7 +6611,7 @@
           <p:cNvPr id="8" name="">
             <a:extLst xmlns:a="http://schemas.openxmlformats.org/drawingml/2006/main">
               <a:ext uri="{FF2B5EF4-FFF2-40B4-BE49-F238E27FC236}">
-                <a16:creationId xmlns:a16="http://schemas.microsoft.com/office/drawing/2014/main" id="{4C703B54-7B7B-4805-AA31-13A53865D4DB}"/>
+                <a16:creationId xmlns:a16="http://schemas.microsoft.com/office/drawing/2014/main" id="{43AB9BC5-7A2B-4702-ACBD-646EEE2389ED}"/>
               </a:ext>
             </a:extLst>
           </p:cNvPr>
@@ -6644,7 +6644,7 @@
           <p:cNvPr id="9" name="">
             <a:extLst xmlns:a="http://schemas.openxmlformats.org/drawingml/2006/main">
               <a:ext uri="{FF2B5EF4-FFF2-40B4-BE49-F238E27FC236}">
-                <a16:creationId xmlns:a16="http://schemas.microsoft.com/office/drawing/2014/main" id="{B30F217B-BA93-4E5B-BD55-7C2FA1CF8CFB}"/>
+                <a16:creationId xmlns:a16="http://schemas.microsoft.com/office/drawing/2014/main" id="{1CB3AD18-6725-4300-A84A-DF0B39D291DF}"/>
               </a:ext>
             </a:extLst>
           </p:cNvPr>
@@ -6694,7 +6694,7 @@
           <p:cNvPr id="10" name="">
             <a:extLst xmlns:a="http://schemas.openxmlformats.org/drawingml/2006/main">
               <a:ext uri="{FF2B5EF4-FFF2-40B4-BE49-F238E27FC236}">
-                <a16:creationId xmlns:a16="http://schemas.microsoft.com/office/drawing/2014/main" id="{83756B3D-0D38-4D10-9937-A4312167A5D8}"/>
+                <a16:creationId xmlns:a16="http://schemas.microsoft.com/office/drawing/2014/main" id="{5D58CFD9-F069-48C1-B8B9-74F4286AC1CC}"/>
               </a:ext>
             </a:extLst>
           </p:cNvPr>
@@ -6744,7 +6744,7 @@
           <p:cNvPr id="11" name="">
             <a:extLst xmlns:a="http://schemas.openxmlformats.org/drawingml/2006/main">
               <a:ext uri="{FF2B5EF4-FFF2-40B4-BE49-F238E27FC236}">
-                <a16:creationId xmlns:a16="http://schemas.microsoft.com/office/drawing/2014/main" id="{16C0F03C-365E-484D-9AAD-E2AC1BEA1E6F}"/>
+                <a16:creationId xmlns:a16="http://schemas.microsoft.com/office/drawing/2014/main" id="{5548847C-0290-4AE5-A807-F5784C8F4CC5}"/>
               </a:ext>
             </a:extLst>
           </p:cNvPr>
@@ -6777,7 +6777,7 @@
           <p:cNvPr id="12" name="">
             <a:extLst xmlns:a="http://schemas.openxmlformats.org/drawingml/2006/main">
               <a:ext uri="{FF2B5EF4-FFF2-40B4-BE49-F238E27FC236}">
-                <a16:creationId xmlns:a16="http://schemas.microsoft.com/office/drawing/2014/main" id="{800E1598-1FFF-47AA-BC19-493E3B0141CF}"/>
+                <a16:creationId xmlns:a16="http://schemas.microsoft.com/office/drawing/2014/main" id="{BD9164D8-5FED-4024-BCD0-E1C6506622BD}"/>
               </a:ext>
             </a:extLst>
           </p:cNvPr>
@@ -6810,7 +6810,7 @@
           <p:cNvPr id="13" name="">
             <a:extLst xmlns:a="http://schemas.openxmlformats.org/drawingml/2006/main">
               <a:ext uri="{FF2B5EF4-FFF2-40B4-BE49-F238E27FC236}">
-                <a16:creationId xmlns:a16="http://schemas.microsoft.com/office/drawing/2014/main" id="{3E248C42-B87A-4CE9-A7C1-0FC76CCC66B4}"/>
+                <a16:creationId xmlns:a16="http://schemas.microsoft.com/office/drawing/2014/main" id="{F85B1E11-38DC-4F01-9812-869A24D23D55}"/>
               </a:ext>
             </a:extLst>
           </p:cNvPr>
@@ -6860,7 +6860,7 @@
           <p:cNvPr id="14" name="">
             <a:extLst xmlns:a="http://schemas.openxmlformats.org/drawingml/2006/main">
               <a:ext uri="{FF2B5EF4-FFF2-40B4-BE49-F238E27FC236}">
-                <a16:creationId xmlns:a16="http://schemas.microsoft.com/office/drawing/2014/main" id="{C5757108-FB4D-41F5-86F2-FFC67237D2BE}"/>
+                <a16:creationId xmlns:a16="http://schemas.microsoft.com/office/drawing/2014/main" id="{480E8316-C898-4331-A48D-1282BF8554CE}"/>
               </a:ext>
             </a:extLst>
           </p:cNvPr>
@@ -6910,7 +6910,7 @@
           <p:cNvPr id="15" name="">
             <a:extLst xmlns:a="http://schemas.openxmlformats.org/drawingml/2006/main">
               <a:ext uri="{FF2B5EF4-FFF2-40B4-BE49-F238E27FC236}">
-                <a16:creationId xmlns:a16="http://schemas.microsoft.com/office/drawing/2014/main" id="{501C292D-838C-45D3-9861-DD44B64D727C}"/>
+                <a16:creationId xmlns:a16="http://schemas.microsoft.com/office/drawing/2014/main" id="{3385C681-8A0C-4E3E-9F3C-F3AC8F3A00B8}"/>
               </a:ext>
             </a:extLst>
           </p:cNvPr>
@@ -6943,7 +6943,7 @@
           <p:cNvPr id="16" name="">
             <a:extLst xmlns:a="http://schemas.openxmlformats.org/drawingml/2006/main">
               <a:ext uri="{FF2B5EF4-FFF2-40B4-BE49-F238E27FC236}">
-                <a16:creationId xmlns:a16="http://schemas.microsoft.com/office/drawing/2014/main" id="{DCE8CE45-AB1D-46D8-A3DC-8CE96AA9E5FC}"/>
+                <a16:creationId xmlns:a16="http://schemas.microsoft.com/office/drawing/2014/main" id="{F2B8CFC8-1940-430A-B7CE-5B1413AB44FE}"/>
               </a:ext>
             </a:extLst>
           </p:cNvPr>
@@ -6976,7 +6976,7 @@
           <p:cNvPr id="17" name="">
             <a:extLst xmlns:a="http://schemas.openxmlformats.org/drawingml/2006/main">
               <a:ext uri="{FF2B5EF4-FFF2-40B4-BE49-F238E27FC236}">
-                <a16:creationId xmlns:a16="http://schemas.microsoft.com/office/drawing/2014/main" id="{D088CB8D-BDA2-48EC-950D-3CDAA51FBA3A}"/>
+                <a16:creationId xmlns:a16="http://schemas.microsoft.com/office/drawing/2014/main" id="{1582BDDB-59F9-48A8-87AC-3D77EBCA0C5B}"/>
               </a:ext>
             </a:extLst>
           </p:cNvPr>
@@ -7026,7 +7026,7 @@
           <p:cNvPr id="18" name="">
             <a:extLst xmlns:a="http://schemas.openxmlformats.org/drawingml/2006/main">
               <a:ext uri="{FF2B5EF4-FFF2-40B4-BE49-F238E27FC236}">
-                <a16:creationId xmlns:a16="http://schemas.microsoft.com/office/drawing/2014/main" id="{9B7675C3-080A-4EF3-B1D6-D22BBF2D0CF7}"/>
+                <a16:creationId xmlns:a16="http://schemas.microsoft.com/office/drawing/2014/main" id="{65293460-59B8-42BE-844E-196DE445533E}"/>
               </a:ext>
             </a:extLst>
           </p:cNvPr>
@@ -7076,7 +7076,7 @@
           <p:cNvPr id="19" name="">
             <a:extLst xmlns:a="http://schemas.openxmlformats.org/drawingml/2006/main">
               <a:ext uri="{FF2B5EF4-FFF2-40B4-BE49-F238E27FC236}">
-                <a16:creationId xmlns:a16="http://schemas.microsoft.com/office/drawing/2014/main" id="{693AD2C5-9656-46EE-91D8-AD15153A7379}"/>
+                <a16:creationId xmlns:a16="http://schemas.microsoft.com/office/drawing/2014/main" id="{95777CE9-BCF4-4B54-A454-299872DF4CE7}"/>
               </a:ext>
             </a:extLst>
           </p:cNvPr>
@@ -7109,7 +7109,7 @@
           <p:cNvPr id="20" name="">
             <a:extLst xmlns:a="http://schemas.openxmlformats.org/drawingml/2006/main">
               <a:ext uri="{FF2B5EF4-FFF2-40B4-BE49-F238E27FC236}">
-                <a16:creationId xmlns:a16="http://schemas.microsoft.com/office/drawing/2014/main" id="{B317E9C2-034D-42E5-8D03-E85FB68FFA2F}"/>
+                <a16:creationId xmlns:a16="http://schemas.microsoft.com/office/drawing/2014/main" id="{BC883743-4E34-4013-B25C-D037BB9FEEAB}"/>
               </a:ext>
             </a:extLst>
           </p:cNvPr>
@@ -7142,7 +7142,7 @@
           <p:cNvPr id="21" name="">
             <a:extLst xmlns:a="http://schemas.openxmlformats.org/drawingml/2006/main">
               <a:ext uri="{FF2B5EF4-FFF2-40B4-BE49-F238E27FC236}">
-                <a16:creationId xmlns:a16="http://schemas.microsoft.com/office/drawing/2014/main" id="{929A2337-1006-483B-B9A8-4F1ED6584E6D}"/>
+                <a16:creationId xmlns:a16="http://schemas.microsoft.com/office/drawing/2014/main" id="{01705005-C725-48F4-8015-13164A253284}"/>
               </a:ext>
             </a:extLst>
           </p:cNvPr>
@@ -7192,7 +7192,7 @@
           <p:cNvPr id="22" name="">
             <a:extLst xmlns:a="http://schemas.openxmlformats.org/drawingml/2006/main">
               <a:ext uri="{FF2B5EF4-FFF2-40B4-BE49-F238E27FC236}">
-                <a16:creationId xmlns:a16="http://schemas.microsoft.com/office/drawing/2014/main" id="{1A3089DC-CA6D-4432-BA66-DEB78793401E}"/>
+                <a16:creationId xmlns:a16="http://schemas.microsoft.com/office/drawing/2014/main" id="{80ABB77E-49DB-4686-80FF-72EEF2D04B54}"/>
               </a:ext>
             </a:extLst>
           </p:cNvPr>
@@ -7242,7 +7242,7 @@
           <p:cNvPr id="23" name="">
             <a:extLst xmlns:a="http://schemas.openxmlformats.org/drawingml/2006/main">
               <a:ext uri="{FF2B5EF4-FFF2-40B4-BE49-F238E27FC236}">
-                <a16:creationId xmlns:a16="http://schemas.microsoft.com/office/drawing/2014/main" id="{F981AC48-0B97-4A62-AD36-D435AF1E0024}"/>
+                <a16:creationId xmlns:a16="http://schemas.microsoft.com/office/drawing/2014/main" id="{9CD7B891-BF2F-42ED-AF40-FCBEC4089744}"/>
               </a:ext>
             </a:extLst>
           </p:cNvPr>
@@ -7275,7 +7275,7 @@
           <p:cNvPr id="24" name="">
             <a:extLst xmlns:a="http://schemas.openxmlformats.org/drawingml/2006/main">
               <a:ext uri="{FF2B5EF4-FFF2-40B4-BE49-F238E27FC236}">
-                <a16:creationId xmlns:a16="http://schemas.microsoft.com/office/drawing/2014/main" id="{41D0AC83-C0D7-43DA-A279-363589F70935}"/>
+                <a16:creationId xmlns:a16="http://schemas.microsoft.com/office/drawing/2014/main" id="{CB094005-D770-4B92-B0AF-38F999C13E15}"/>
               </a:ext>
             </a:extLst>
           </p:cNvPr>
@@ -7308,7 +7308,7 @@
           <p:cNvPr id="25" name="">
             <a:extLst xmlns:a="http://schemas.openxmlformats.org/drawingml/2006/main">
               <a:ext uri="{FF2B5EF4-FFF2-40B4-BE49-F238E27FC236}">
-                <a16:creationId xmlns:a16="http://schemas.microsoft.com/office/drawing/2014/main" id="{E86C6E27-11B4-4F0E-AC3F-0F0C9A49AA05}"/>
+                <a16:creationId xmlns:a16="http://schemas.microsoft.com/office/drawing/2014/main" id="{1BB59805-1328-45F6-B679-0B878B6DC62F}"/>
               </a:ext>
             </a:extLst>
           </p:cNvPr>
@@ -7358,7 +7358,7 @@
           <p:cNvPr id="26" name="">
             <a:extLst xmlns:a="http://schemas.openxmlformats.org/drawingml/2006/main">
               <a:ext uri="{FF2B5EF4-FFF2-40B4-BE49-F238E27FC236}">
-                <a16:creationId xmlns:a16="http://schemas.microsoft.com/office/drawing/2014/main" id="{FC6B96A2-A37D-4152-BB71-B37ACD924E41}"/>
+                <a16:creationId xmlns:a16="http://schemas.microsoft.com/office/drawing/2014/main" id="{9522A0FD-2130-4666-926A-A1D0B89ED241}"/>
               </a:ext>
             </a:extLst>
           </p:cNvPr>
@@ -7408,7 +7408,7 @@
           <p:cNvPr id="27" name="">
             <a:extLst xmlns:a="http://schemas.openxmlformats.org/drawingml/2006/main">
               <a:ext uri="{FF2B5EF4-FFF2-40B4-BE49-F238E27FC236}">
-                <a16:creationId xmlns:a16="http://schemas.microsoft.com/office/drawing/2014/main" id="{9E6D42B8-20F8-43E7-9793-241DBF338702}"/>
+                <a16:creationId xmlns:a16="http://schemas.microsoft.com/office/drawing/2014/main" id="{7DDC6D23-5F74-48A1-82C0-4689C2E5DF6A}"/>
               </a:ext>
             </a:extLst>
           </p:cNvPr>
@@ -7441,7 +7441,7 @@
           <p:cNvPr id="28" name="">
             <a:extLst xmlns:a="http://schemas.openxmlformats.org/drawingml/2006/main">
               <a:ext uri="{FF2B5EF4-FFF2-40B4-BE49-F238E27FC236}">
-                <a16:creationId xmlns:a16="http://schemas.microsoft.com/office/drawing/2014/main" id="{DC6074B1-2C67-45E4-BF11-B94D35669BC2}"/>
+                <a16:creationId xmlns:a16="http://schemas.microsoft.com/office/drawing/2014/main" id="{BE79ADA5-2485-45DA-8C08-F84C66B71073}"/>
               </a:ext>
             </a:extLst>
           </p:cNvPr>
@@ -7474,7 +7474,7 @@
           <p:cNvPr id="29" name="">
             <a:extLst xmlns:a="http://schemas.openxmlformats.org/drawingml/2006/main">
               <a:ext uri="{FF2B5EF4-FFF2-40B4-BE49-F238E27FC236}">
-                <a16:creationId xmlns:a16="http://schemas.microsoft.com/office/drawing/2014/main" id="{D26A704C-037D-4B29-9582-EA4DF3DBF3A2}"/>
+                <a16:creationId xmlns:a16="http://schemas.microsoft.com/office/drawing/2014/main" id="{A9BA43C3-A346-41AB-92AC-C0D93AA8BC27}"/>
               </a:ext>
             </a:extLst>
           </p:cNvPr>
@@ -7524,7 +7524,7 @@
           <p:cNvPr id="30" name="">
             <a:extLst xmlns:a="http://schemas.openxmlformats.org/drawingml/2006/main">
               <a:ext uri="{FF2B5EF4-FFF2-40B4-BE49-F238E27FC236}">
-                <a16:creationId xmlns:a16="http://schemas.microsoft.com/office/drawing/2014/main" id="{C5400199-2A3B-47E6-B994-18C5A7BB1D6E}"/>
+                <a16:creationId xmlns:a16="http://schemas.microsoft.com/office/drawing/2014/main" id="{1611CF27-9B51-4B76-AF1F-681463705F32}"/>
               </a:ext>
             </a:extLst>
           </p:cNvPr>
@@ -7574,7 +7574,7 @@
           <p:cNvPr id="31" name="">
             <a:extLst xmlns:a="http://schemas.openxmlformats.org/drawingml/2006/main">
               <a:ext uri="{FF2B5EF4-FFF2-40B4-BE49-F238E27FC236}">
-                <a16:creationId xmlns:a16="http://schemas.microsoft.com/office/drawing/2014/main" id="{F2D1D178-BE0E-47FD-92CC-6BC108D723A5}"/>
+                <a16:creationId xmlns:a16="http://schemas.microsoft.com/office/drawing/2014/main" id="{0A8578ED-3C57-4D8C-8034-0643B0C76609}"/>
               </a:ext>
             </a:extLst>
           </p:cNvPr>
@@ -7624,7 +7624,7 @@
           <p:cNvPr id="32" name="">
             <a:extLst xmlns:a="http://schemas.openxmlformats.org/drawingml/2006/main">
               <a:ext uri="{FF2B5EF4-FFF2-40B4-BE49-F238E27FC236}">
-                <a16:creationId xmlns:a16="http://schemas.microsoft.com/office/drawing/2014/main" id="{AAAD3765-9E9C-4F1E-8900-573ED132E7E7}"/>
+                <a16:creationId xmlns:a16="http://schemas.microsoft.com/office/drawing/2014/main" id="{725E2109-071D-484C-AAF2-C02B17DD5668}"/>
               </a:ext>
             </a:extLst>
           </p:cNvPr>
@@ -7672,7 +7672,7 @@
     </p:spTree>
     <p:extLst>
       <p:ext uri="{BB962C8B-B14F-4D97-AF65-F5344CB8AC3E}">
-        <p14:creationId xmlns:p14="http://schemas.microsoft.com/office/powerpoint/2010/main" val="826038076"/>
+        <p14:creationId xmlns:p14="http://schemas.microsoft.com/office/powerpoint/2010/main" val="1029392955"/>
       </p:ext>
     </p:extLst>
   </p:cSld>
@@ -7703,7 +7703,7 @@
           <p:cNvPr id="1" name="">
             <a:extLst xmlns:a="http://schemas.openxmlformats.org/drawingml/2006/main">
               <a:ext uri="{FF2B5EF4-FFF2-40B4-BE49-F238E27FC236}">
-                <a16:creationId xmlns:a16="http://schemas.microsoft.com/office/drawing/2014/main" id="{06EFB648-178A-4DE3-8368-AB295C6BA76C}"/>
+                <a16:creationId xmlns:a16="http://schemas.microsoft.com/office/drawing/2014/main" id="{96A8E7E3-4D86-4E7F-9332-929F9C03EA2C}"/>
               </a:ext>
             </a:extLst>
           </p:cNvPr>
@@ -7753,7 +7753,7 @@
           <p:cNvPr id="2" name="">
             <a:extLst xmlns:a="http://schemas.openxmlformats.org/drawingml/2006/main">
               <a:ext uri="{FF2B5EF4-FFF2-40B4-BE49-F238E27FC236}">
-                <a16:creationId xmlns:a16="http://schemas.microsoft.com/office/drawing/2014/main" id="{FE45D087-DE7A-4E00-A777-0E2FC01BE102}"/>
+                <a16:creationId xmlns:a16="http://schemas.microsoft.com/office/drawing/2014/main" id="{8CFF872F-3988-499A-9E63-13EE1E1FDD2E}"/>
               </a:ext>
             </a:extLst>
           </p:cNvPr>
@@ -7803,7 +7803,7 @@
           <p:cNvPr id="3" name="">
             <a:extLst xmlns:a="http://schemas.openxmlformats.org/drawingml/2006/main">
               <a:ext uri="{FF2B5EF4-FFF2-40B4-BE49-F238E27FC236}">
-                <a16:creationId xmlns:a16="http://schemas.microsoft.com/office/drawing/2014/main" id="{1902467A-4485-43A5-91C3-D351F20F483E}"/>
+                <a16:creationId xmlns:a16="http://schemas.microsoft.com/office/drawing/2014/main" id="{EC16DC21-60DD-474F-9F34-97972CB920D2}"/>
               </a:ext>
             </a:extLst>
           </p:cNvPr>
@@ -7836,7 +7836,7 @@
           <p:cNvPr id="4" name="">
             <a:extLst xmlns:a="http://schemas.openxmlformats.org/drawingml/2006/main">
               <a:ext uri="{FF2B5EF4-FFF2-40B4-BE49-F238E27FC236}">
-                <a16:creationId xmlns:a16="http://schemas.microsoft.com/office/drawing/2014/main" id="{9B688C53-13F3-4451-A269-C2F1F2D94B13}"/>
+                <a16:creationId xmlns:a16="http://schemas.microsoft.com/office/drawing/2014/main" id="{D54CB843-1DA5-43C2-ABD4-C926ECA027F9}"/>
               </a:ext>
             </a:extLst>
           </p:cNvPr>
@@ -7869,7 +7869,7 @@
           <p:cNvPr id="5" name="">
             <a:extLst xmlns:a="http://schemas.openxmlformats.org/drawingml/2006/main">
               <a:ext uri="{FF2B5EF4-FFF2-40B4-BE49-F238E27FC236}">
-                <a16:creationId xmlns:a16="http://schemas.microsoft.com/office/drawing/2014/main" id="{2F4CF305-BA17-41C1-A14D-14F52022D987}"/>
+                <a16:creationId xmlns:a16="http://schemas.microsoft.com/office/drawing/2014/main" id="{A30FEA00-8424-4EA3-8F5D-336FA1EFBF94}"/>
               </a:ext>
             </a:extLst>
           </p:cNvPr>
@@ -7919,7 +7919,7 @@
           <p:cNvPr id="6" name="">
             <a:extLst xmlns:a="http://schemas.openxmlformats.org/drawingml/2006/main">
               <a:ext uri="{FF2B5EF4-FFF2-40B4-BE49-F238E27FC236}">
-                <a16:creationId xmlns:a16="http://schemas.microsoft.com/office/drawing/2014/main" id="{87DF6CFC-5B2E-4937-82D6-20EA140E189E}"/>
+                <a16:creationId xmlns:a16="http://schemas.microsoft.com/office/drawing/2014/main" id="{DA1B916D-96E5-4681-ACD0-EB40F92240DD}"/>
               </a:ext>
             </a:extLst>
           </p:cNvPr>
@@ -7969,7 +7969,7 @@
           <p:cNvPr id="7" name="">
             <a:extLst xmlns:a="http://schemas.openxmlformats.org/drawingml/2006/main">
               <a:ext uri="{FF2B5EF4-FFF2-40B4-BE49-F238E27FC236}">
-                <a16:creationId xmlns:a16="http://schemas.microsoft.com/office/drawing/2014/main" id="{5735E6B7-B652-43D4-910A-F4DF70BEA068}"/>
+                <a16:creationId xmlns:a16="http://schemas.microsoft.com/office/drawing/2014/main" id="{77E92ABB-DD17-4003-8CB3-3355B63F669D}"/>
               </a:ext>
             </a:extLst>
           </p:cNvPr>
@@ -8002,7 +8002,7 @@
           <p:cNvPr id="8" name="">
             <a:extLst xmlns:a="http://schemas.openxmlformats.org/drawingml/2006/main">
               <a:ext uri="{FF2B5EF4-FFF2-40B4-BE49-F238E27FC236}">
-                <a16:creationId xmlns:a16="http://schemas.microsoft.com/office/drawing/2014/main" id="{13CC1747-C882-407D-9F39-39946B0C31B0}"/>
+                <a16:creationId xmlns:a16="http://schemas.microsoft.com/office/drawing/2014/main" id="{A0188926-FDCE-486B-BB97-4E66C9DA87BB}"/>
               </a:ext>
             </a:extLst>
           </p:cNvPr>
@@ -8052,7 +8052,7 @@
           <p:cNvPr id="9" name="">
             <a:extLst xmlns:a="http://schemas.openxmlformats.org/drawingml/2006/main">
               <a:ext uri="{FF2B5EF4-FFF2-40B4-BE49-F238E27FC236}">
-                <a16:creationId xmlns:a16="http://schemas.microsoft.com/office/drawing/2014/main" id="{3B449C86-C57C-4E40-A22F-F6499056BFFB}"/>
+                <a16:creationId xmlns:a16="http://schemas.microsoft.com/office/drawing/2014/main" id="{D03DD63E-09EC-4990-94A2-93C3744BC297}"/>
               </a:ext>
             </a:extLst>
           </p:cNvPr>
@@ -8102,7 +8102,7 @@
           <p:cNvPr id="10" name="">
             <a:extLst xmlns:a="http://schemas.openxmlformats.org/drawingml/2006/main">
               <a:ext uri="{FF2B5EF4-FFF2-40B4-BE49-F238E27FC236}">
-                <a16:creationId xmlns:a16="http://schemas.microsoft.com/office/drawing/2014/main" id="{6C081B0D-67AB-488A-BB78-55FF8DB261A8}"/>
+                <a16:creationId xmlns:a16="http://schemas.microsoft.com/office/drawing/2014/main" id="{EAAE7BD3-1FB9-4FD3-B746-A4A5BEFBD9B5}"/>
               </a:ext>
             </a:extLst>
           </p:cNvPr>
@@ -8135,7 +8135,7 @@
           <p:cNvPr id="11" name="">
             <a:extLst xmlns:a="http://schemas.openxmlformats.org/drawingml/2006/main">
               <a:ext uri="{FF2B5EF4-FFF2-40B4-BE49-F238E27FC236}">
-                <a16:creationId xmlns:a16="http://schemas.microsoft.com/office/drawing/2014/main" id="{DA39B7AE-736F-4CF5-83F1-560C81616630}"/>
+                <a16:creationId xmlns:a16="http://schemas.microsoft.com/office/drawing/2014/main" id="{D8D65972-C86F-4EDF-A2B8-ADF50B261D5B}"/>
               </a:ext>
             </a:extLst>
           </p:cNvPr>
@@ -8185,7 +8185,7 @@
           <p:cNvPr id="12" name="">
             <a:extLst xmlns:a="http://schemas.openxmlformats.org/drawingml/2006/main">
               <a:ext uri="{FF2B5EF4-FFF2-40B4-BE49-F238E27FC236}">
-                <a16:creationId xmlns:a16="http://schemas.microsoft.com/office/drawing/2014/main" id="{CAE8D12D-D51B-4052-BE13-0D4CB0B6CAFD}"/>
+                <a16:creationId xmlns:a16="http://schemas.microsoft.com/office/drawing/2014/main" id="{98DA5CB3-FF03-4706-8100-311614275A78}"/>
               </a:ext>
             </a:extLst>
           </p:cNvPr>
@@ -8225,7 +8225,7 @@
                   <a:srgbClr val="0A0A0A"/>
                 </a:solidFill>
               </a:rPr>
-              <a:t>MAP-style penalty loss; Adam optimizer used for reproducible PyTorch training</a:t>
+              <a:t>MAP-style penalty loss; Adam completed run; SGD prepared as closer historical rerun</a:t>
             </a:r>
           </a:p>
         </p:txBody>
@@ -8235,7 +8235,7 @@
           <p:cNvPr id="13" name="">
             <a:extLst xmlns:a="http://schemas.openxmlformats.org/drawingml/2006/main">
               <a:ext uri="{FF2B5EF4-FFF2-40B4-BE49-F238E27FC236}">
-                <a16:creationId xmlns:a16="http://schemas.microsoft.com/office/drawing/2014/main" id="{62D76708-1CA0-4B4E-9EDA-9FAFA4BFF9A7}"/>
+                <a16:creationId xmlns:a16="http://schemas.microsoft.com/office/drawing/2014/main" id="{E6220B4A-DE51-4616-A8DE-6B56444EC56C}"/>
               </a:ext>
             </a:extLst>
           </p:cNvPr>
@@ -8283,7 +8283,7 @@
     </p:spTree>
     <p:extLst>
       <p:ext uri="{BB962C8B-B14F-4D97-AF65-F5344CB8AC3E}">
-        <p14:creationId xmlns:p14="http://schemas.microsoft.com/office/powerpoint/2010/main" val="374820961"/>
+        <p14:creationId xmlns:p14="http://schemas.microsoft.com/office/powerpoint/2010/main" val="159554276"/>
       </p:ext>
     </p:extLst>
   </p:cSld>
@@ -8314,7 +8314,7 @@
           <p:cNvPr id="1" name="">
             <a:extLst xmlns:a="http://schemas.openxmlformats.org/drawingml/2006/main">
               <a:ext uri="{FF2B5EF4-FFF2-40B4-BE49-F238E27FC236}">
-                <a16:creationId xmlns:a16="http://schemas.microsoft.com/office/drawing/2014/main" id="{EA99EF15-561F-4585-B6FB-D5220D989E64}"/>
+                <a16:creationId xmlns:a16="http://schemas.microsoft.com/office/drawing/2014/main" id="{1942FAC5-6A45-4942-9560-A7163FF8B892}"/>
               </a:ext>
             </a:extLst>
           </p:cNvPr>
@@ -8364,7 +8364,7 @@
           <p:cNvPr id="2" name="">
             <a:extLst xmlns:a="http://schemas.openxmlformats.org/drawingml/2006/main">
               <a:ext uri="{FF2B5EF4-FFF2-40B4-BE49-F238E27FC236}">
-                <a16:creationId xmlns:a16="http://schemas.microsoft.com/office/drawing/2014/main" id="{98882252-6BE0-4E55-893E-DF5C8EF8A937}"/>
+                <a16:creationId xmlns:a16="http://schemas.microsoft.com/office/drawing/2014/main" id="{BD6449AF-8043-41BD-AAAA-068CB2CC8241}"/>
               </a:ext>
             </a:extLst>
           </p:cNvPr>
@@ -8414,7 +8414,7 @@
           <p:cNvPr id="3" name="">
             <a:extLst xmlns:a="http://schemas.openxmlformats.org/drawingml/2006/main">
               <a:ext uri="{FF2B5EF4-FFF2-40B4-BE49-F238E27FC236}">
-                <a16:creationId xmlns:a16="http://schemas.microsoft.com/office/drawing/2014/main" id="{733896CE-D376-4F21-B176-F58185D30507}"/>
+                <a16:creationId xmlns:a16="http://schemas.microsoft.com/office/drawing/2014/main" id="{228386C0-2A04-441A-81DC-2F33F17F8CEA}"/>
               </a:ext>
             </a:extLst>
           </p:cNvPr>
@@ -8447,7 +8447,7 @@
           <p:cNvPr id="4" name="">
             <a:extLst xmlns:a="http://schemas.openxmlformats.org/drawingml/2006/main">
               <a:ext uri="{FF2B5EF4-FFF2-40B4-BE49-F238E27FC236}">
-                <a16:creationId xmlns:a16="http://schemas.microsoft.com/office/drawing/2014/main" id="{FB122D4C-F11E-4681-8C71-4E24BA1E21C6}"/>
+                <a16:creationId xmlns:a16="http://schemas.microsoft.com/office/drawing/2014/main" id="{668EE266-D94E-4090-8FFF-9959F0EFFBA4}"/>
               </a:ext>
             </a:extLst>
           </p:cNvPr>
@@ -8480,7 +8480,7 @@
           <p:cNvPr id="5" name="">
             <a:extLst xmlns:a="http://schemas.openxmlformats.org/drawingml/2006/main">
               <a:ext uri="{FF2B5EF4-FFF2-40B4-BE49-F238E27FC236}">
-                <a16:creationId xmlns:a16="http://schemas.microsoft.com/office/drawing/2014/main" id="{BF0314A8-A4A8-4C34-AFC7-EE38C0E3428B}"/>
+                <a16:creationId xmlns:a16="http://schemas.microsoft.com/office/drawing/2014/main" id="{44C580A4-0275-40B9-A0B4-A84F526E83BC}"/>
               </a:ext>
             </a:extLst>
           </p:cNvPr>
@@ -8530,7 +8530,7 @@
           <p:cNvPr id="6" name="">
             <a:extLst xmlns:a="http://schemas.openxmlformats.org/drawingml/2006/main">
               <a:ext uri="{FF2B5EF4-FFF2-40B4-BE49-F238E27FC236}">
-                <a16:creationId xmlns:a16="http://schemas.microsoft.com/office/drawing/2014/main" id="{E8F133A6-1AF3-4DB3-9306-E08A3E011C0B}"/>
+                <a16:creationId xmlns:a16="http://schemas.microsoft.com/office/drawing/2014/main" id="{37C17FB3-3CEE-4CD9-8D8B-9F3072687657}"/>
               </a:ext>
             </a:extLst>
           </p:cNvPr>
@@ -8580,7 +8580,7 @@
           <p:cNvPr id="7" name="">
             <a:extLst xmlns:a="http://schemas.openxmlformats.org/drawingml/2006/main">
               <a:ext uri="{FF2B5EF4-FFF2-40B4-BE49-F238E27FC236}">
-                <a16:creationId xmlns:a16="http://schemas.microsoft.com/office/drawing/2014/main" id="{83B8AC61-3B56-4F58-8789-424F898DC5C3}"/>
+                <a16:creationId xmlns:a16="http://schemas.microsoft.com/office/drawing/2014/main" id="{1175A0A4-841D-46D9-8F3E-3DD05D90D87F}"/>
               </a:ext>
             </a:extLst>
           </p:cNvPr>
@@ -8630,7 +8630,7 @@
           <p:cNvPr id="8" name="">
             <a:extLst xmlns:a="http://schemas.openxmlformats.org/drawingml/2006/main">
               <a:ext uri="{FF2B5EF4-FFF2-40B4-BE49-F238E27FC236}">
-                <a16:creationId xmlns:a16="http://schemas.microsoft.com/office/drawing/2014/main" id="{3EABE135-7C24-4511-BDCB-499F34CBD98D}"/>
+                <a16:creationId xmlns:a16="http://schemas.microsoft.com/office/drawing/2014/main" id="{C0E27237-20ED-42BE-A15D-FA279D52F6E6}"/>
               </a:ext>
             </a:extLst>
           </p:cNvPr>
@@ -8680,7 +8680,7 @@
           <p:cNvPr id="9" name="">
             <a:extLst xmlns:a="http://schemas.openxmlformats.org/drawingml/2006/main">
               <a:ext uri="{FF2B5EF4-FFF2-40B4-BE49-F238E27FC236}">
-                <a16:creationId xmlns:a16="http://schemas.microsoft.com/office/drawing/2014/main" id="{8DAB78D5-1CDE-44C4-BD6D-41CEA2C35C4D}"/>
+                <a16:creationId xmlns:a16="http://schemas.microsoft.com/office/drawing/2014/main" id="{77D9D92D-869E-445C-AAD3-286D8095B023}"/>
               </a:ext>
             </a:extLst>
           </p:cNvPr>
@@ -8730,7 +8730,7 @@
           <p:cNvPr id="10" name="">
             <a:extLst xmlns:a="http://schemas.openxmlformats.org/drawingml/2006/main">
               <a:ext uri="{FF2B5EF4-FFF2-40B4-BE49-F238E27FC236}">
-                <a16:creationId xmlns:a16="http://schemas.microsoft.com/office/drawing/2014/main" id="{CA2D5BC3-B7AE-4600-9CCA-FA421BADD7B6}"/>
+                <a16:creationId xmlns:a16="http://schemas.microsoft.com/office/drawing/2014/main" id="{D84B89EB-7913-4FF0-8EDD-EEF9A6BE7928}"/>
               </a:ext>
             </a:extLst>
           </p:cNvPr>
@@ -8780,7 +8780,7 @@
           <p:cNvPr id="11" name="">
             <a:extLst xmlns:a="http://schemas.openxmlformats.org/drawingml/2006/main">
               <a:ext uri="{FF2B5EF4-FFF2-40B4-BE49-F238E27FC236}">
-                <a16:creationId xmlns:a16="http://schemas.microsoft.com/office/drawing/2014/main" id="{AF9F219D-1696-4D75-BB6E-3138268A3D28}"/>
+                <a16:creationId xmlns:a16="http://schemas.microsoft.com/office/drawing/2014/main" id="{5EA9121D-C92D-4397-94AE-79366BBC3918}"/>
               </a:ext>
             </a:extLst>
           </p:cNvPr>
@@ -8830,7 +8830,7 @@
           <p:cNvPr id="12" name="">
             <a:extLst xmlns:a="http://schemas.openxmlformats.org/drawingml/2006/main">
               <a:ext uri="{FF2B5EF4-FFF2-40B4-BE49-F238E27FC236}">
-                <a16:creationId xmlns:a16="http://schemas.microsoft.com/office/drawing/2014/main" id="{93BAD2F5-3665-4BEF-8849-82D66FB95F09}"/>
+                <a16:creationId xmlns:a16="http://schemas.microsoft.com/office/drawing/2014/main" id="{4DFF586A-9796-4A4D-9ACA-062F64D32C12}"/>
               </a:ext>
             </a:extLst>
           </p:cNvPr>
@@ -8880,7 +8880,7 @@
           <p:cNvPr id="13" name="">
             <a:extLst xmlns:a="http://schemas.openxmlformats.org/drawingml/2006/main">
               <a:ext uri="{FF2B5EF4-FFF2-40B4-BE49-F238E27FC236}">
-                <a16:creationId xmlns:a16="http://schemas.microsoft.com/office/drawing/2014/main" id="{8F0696F5-9671-45A2-AF71-53E7DBA0EE52}"/>
+                <a16:creationId xmlns:a16="http://schemas.microsoft.com/office/drawing/2014/main" id="{CE458CD8-B163-4EA0-8268-759B45F82AD6}"/>
               </a:ext>
             </a:extLst>
           </p:cNvPr>
@@ -8908,19 +8908,19 @@
           <a:lstStyle xmlns:a="http://schemas.openxmlformats.org/drawingml/2006/main"/>
           <a:p xmlns:a="http://schemas.openxmlformats.org/drawingml/2006/main">
             <a:pPr algn="ctr">
-              <a:defRPr sz="1875" b="0">
-                <a:solidFill>
-                  <a:srgbClr val="0A0A0A"/>
-                </a:solidFill>
-              </a:defRPr>
-            </a:pPr>
-            <a:r>
-              <a:rPr sz="1875" b="0">
-                <a:solidFill>
-                  <a:srgbClr val="0A0A0A"/>
-                </a:solidFill>
-              </a:rPr>
-              <a:t>Optimizer: Adam | Loss: LeNet MAP-style RBF penalty | Seed: 42 | Device: CPU</a:t>
+              <a:defRPr sz="1800" b="0">
+                <a:solidFill>
+                  <a:srgbClr val="0A0A0A"/>
+                </a:solidFill>
+              </a:defRPr>
+            </a:pPr>
+            <a:r>
+              <a:rPr sz="1800" b="0">
+                <a:solidFill>
+                  <a:srgbClr val="0A0A0A"/>
+                </a:solidFill>
+              </a:rPr>
+              <a:t>Optimizer: Adam result, SGD rerun prepared | Loss: LeNet MAP-style RBF penalty | Seed: 42 | Device: CPU</a:t>
             </a:r>
           </a:p>
         </p:txBody>
@@ -8930,7 +8930,7 @@
           <p:cNvPr id="14" name="">
             <a:extLst xmlns:a="http://schemas.openxmlformats.org/drawingml/2006/main">
               <a:ext uri="{FF2B5EF4-FFF2-40B4-BE49-F238E27FC236}">
-                <a16:creationId xmlns:a16="http://schemas.microsoft.com/office/drawing/2014/main" id="{11107F75-0876-47FF-9AE4-D09150123A60}"/>
+                <a16:creationId xmlns:a16="http://schemas.microsoft.com/office/drawing/2014/main" id="{8E6FC627-0474-482F-9787-AE727161197E}"/>
               </a:ext>
             </a:extLst>
           </p:cNvPr>
@@ -8978,7 +8978,7 @@
     </p:spTree>
     <p:extLst>
       <p:ext uri="{BB962C8B-B14F-4D97-AF65-F5344CB8AC3E}">
-        <p14:creationId xmlns:p14="http://schemas.microsoft.com/office/powerpoint/2010/main" val="1718644097"/>
+        <p14:creationId xmlns:p14="http://schemas.microsoft.com/office/powerpoint/2010/main" val="182845564"/>
       </p:ext>
     </p:extLst>
   </p:cSld>
@@ -9009,7 +9009,7 @@
           <p:cNvPr id="1" name="">
             <a:extLst xmlns:a="http://schemas.openxmlformats.org/drawingml/2006/main">
               <a:ext uri="{FF2B5EF4-FFF2-40B4-BE49-F238E27FC236}">
-                <a16:creationId xmlns:a16="http://schemas.microsoft.com/office/drawing/2014/main" id="{8DCD96B3-14A0-44A0-98EF-F3667C663035}"/>
+                <a16:creationId xmlns:a16="http://schemas.microsoft.com/office/drawing/2014/main" id="{D02AE548-7DAB-49B2-91F5-03DE903789A8}"/>
               </a:ext>
             </a:extLst>
           </p:cNvPr>
@@ -9059,7 +9059,7 @@
           <p:cNvPr id="2" name="">
             <a:extLst xmlns:a="http://schemas.openxmlformats.org/drawingml/2006/main">
               <a:ext uri="{FF2B5EF4-FFF2-40B4-BE49-F238E27FC236}">
-                <a16:creationId xmlns:a16="http://schemas.microsoft.com/office/drawing/2014/main" id="{88DF1D75-2A5D-4255-B36E-18EC5429D7CB}"/>
+                <a16:creationId xmlns:a16="http://schemas.microsoft.com/office/drawing/2014/main" id="{577F6FD2-153F-4198-AD32-2FB4B7595EB4}"/>
               </a:ext>
             </a:extLst>
           </p:cNvPr>
@@ -9109,7 +9109,7 @@
           <p:cNvPr id="3" name="">
             <a:extLst xmlns:a="http://schemas.openxmlformats.org/drawingml/2006/main">
               <a:ext uri="{FF2B5EF4-FFF2-40B4-BE49-F238E27FC236}">
-                <a16:creationId xmlns:a16="http://schemas.microsoft.com/office/drawing/2014/main" id="{365A2BA7-39B2-434D-B609-4E37734A5754}"/>
+                <a16:creationId xmlns:a16="http://schemas.microsoft.com/office/drawing/2014/main" id="{633E66A4-AB53-4BFF-83A2-08ADE0B107BD}"/>
               </a:ext>
             </a:extLst>
           </p:cNvPr>
@@ -9142,7 +9142,7 @@
           <p:cNvPr id="4" name="">
             <a:extLst xmlns:a="http://schemas.openxmlformats.org/drawingml/2006/main">
               <a:ext uri="{FF2B5EF4-FFF2-40B4-BE49-F238E27FC236}">
-                <a16:creationId xmlns:a16="http://schemas.microsoft.com/office/drawing/2014/main" id="{22AB5943-143C-4AD2-9312-CCDF95B3917D}"/>
+                <a16:creationId xmlns:a16="http://schemas.microsoft.com/office/drawing/2014/main" id="{383056B5-21F9-425A-946D-9C17F0AD4EE3}"/>
               </a:ext>
             </a:extLst>
           </p:cNvPr>
@@ -9192,7 +9192,7 @@
           <p:cNvPr id="5" name="">
             <a:extLst xmlns:a="http://schemas.openxmlformats.org/drawingml/2006/main">
               <a:ext uri="{FF2B5EF4-FFF2-40B4-BE49-F238E27FC236}">
-                <a16:creationId xmlns:a16="http://schemas.microsoft.com/office/drawing/2014/main" id="{8B421B35-1530-4223-9A1F-BCCE5A63B2D3}"/>
+                <a16:creationId xmlns:a16="http://schemas.microsoft.com/office/drawing/2014/main" id="{8E1D4636-22E7-4E68-9A78-C6DDBEE02CD0}"/>
               </a:ext>
             </a:extLst>
           </p:cNvPr>
@@ -9242,7 +9242,7 @@
           <p:cNvPr id="6" name="">
             <a:extLst xmlns:a="http://schemas.openxmlformats.org/drawingml/2006/main">
               <a:ext uri="{FF2B5EF4-FFF2-40B4-BE49-F238E27FC236}">
-                <a16:creationId xmlns:a16="http://schemas.microsoft.com/office/drawing/2014/main" id="{E876E325-BAB1-489D-97D6-28AEE4969706}"/>
+                <a16:creationId xmlns:a16="http://schemas.microsoft.com/office/drawing/2014/main" id="{8A13E67E-D4C2-47A9-970B-4B058BA6B5E0}"/>
               </a:ext>
             </a:extLst>
           </p:cNvPr>
@@ -9292,7 +9292,7 @@
           <p:cNvPr id="7" name="">
             <a:extLst xmlns:a="http://schemas.openxmlformats.org/drawingml/2006/main">
               <a:ext uri="{FF2B5EF4-FFF2-40B4-BE49-F238E27FC236}">
-                <a16:creationId xmlns:a16="http://schemas.microsoft.com/office/drawing/2014/main" id="{5A62FC40-51EC-4365-B8B3-DDE7F2B511A6}"/>
+                <a16:creationId xmlns:a16="http://schemas.microsoft.com/office/drawing/2014/main" id="{6FBF675B-2B96-4757-8B2A-551ADA33FA2C}"/>
               </a:ext>
             </a:extLst>
           </p:cNvPr>
@@ -9342,7 +9342,7 @@
           <p:cNvPr id="8" name="">
             <a:extLst xmlns:a="http://schemas.openxmlformats.org/drawingml/2006/main">
               <a:ext uri="{FF2B5EF4-FFF2-40B4-BE49-F238E27FC236}">
-                <a16:creationId xmlns:a16="http://schemas.microsoft.com/office/drawing/2014/main" id="{9B50BC61-5725-44E2-94E7-775AC4478748}"/>
+                <a16:creationId xmlns:a16="http://schemas.microsoft.com/office/drawing/2014/main" id="{0A4159AC-33DA-4BCF-9757-F7DE8AD73D5F}"/>
               </a:ext>
             </a:extLst>
           </p:cNvPr>
@@ -9392,7 +9392,7 @@
           <p:cNvPr id="9" name="">
             <a:extLst xmlns:a="http://schemas.openxmlformats.org/drawingml/2006/main">
               <a:ext uri="{FF2B5EF4-FFF2-40B4-BE49-F238E27FC236}">
-                <a16:creationId xmlns:a16="http://schemas.microsoft.com/office/drawing/2014/main" id="{32B2837C-ACF5-4C4A-A13F-7E20FE44B0B6}"/>
+                <a16:creationId xmlns:a16="http://schemas.microsoft.com/office/drawing/2014/main" id="{DBDD1BEF-D8EF-45EB-9EE0-8DEFBB4D014A}"/>
               </a:ext>
             </a:extLst>
           </p:cNvPr>
@@ -9442,7 +9442,7 @@
           <p:cNvPr id="10" name="">
             <a:extLst xmlns:a="http://schemas.openxmlformats.org/drawingml/2006/main">
               <a:ext uri="{FF2B5EF4-FFF2-40B4-BE49-F238E27FC236}">
-                <a16:creationId xmlns:a16="http://schemas.microsoft.com/office/drawing/2014/main" id="{821C5BCD-0B54-4F70-BB8C-61F4D1432E3D}"/>
+                <a16:creationId xmlns:a16="http://schemas.microsoft.com/office/drawing/2014/main" id="{C80125B9-B395-44E4-9B5D-C94494502CC0}"/>
               </a:ext>
             </a:extLst>
           </p:cNvPr>
@@ -9475,7 +9475,7 @@
           <p:cNvPr id="11" name="">
             <a:extLst xmlns:a="http://schemas.openxmlformats.org/drawingml/2006/main">
               <a:ext uri="{FF2B5EF4-FFF2-40B4-BE49-F238E27FC236}">
-                <a16:creationId xmlns:a16="http://schemas.microsoft.com/office/drawing/2014/main" id="{BC929E3C-309E-4AF3-8A18-F7A866D38B9C}"/>
+                <a16:creationId xmlns:a16="http://schemas.microsoft.com/office/drawing/2014/main" id="{42E61FD3-81B2-41EC-AAC7-DD006F0F1C3B}"/>
               </a:ext>
             </a:extLst>
           </p:cNvPr>
@@ -9525,7 +9525,7 @@
           <p:cNvPr id="12" name="">
             <a:extLst xmlns:a="http://schemas.openxmlformats.org/drawingml/2006/main">
               <a:ext uri="{FF2B5EF4-FFF2-40B4-BE49-F238E27FC236}">
-                <a16:creationId xmlns:a16="http://schemas.microsoft.com/office/drawing/2014/main" id="{2AB3AA5E-4C64-48B1-8A39-2F2087F7CE74}"/>
+                <a16:creationId xmlns:a16="http://schemas.microsoft.com/office/drawing/2014/main" id="{F1647747-759B-464C-A885-681EDA32A318}"/>
               </a:ext>
             </a:extLst>
           </p:cNvPr>
@@ -9573,7 +9573,7 @@
     </p:spTree>
     <p:extLst>
       <p:ext uri="{BB962C8B-B14F-4D97-AF65-F5344CB8AC3E}">
-        <p14:creationId xmlns:p14="http://schemas.microsoft.com/office/powerpoint/2010/main" val="373262540"/>
+        <p14:creationId xmlns:p14="http://schemas.microsoft.com/office/powerpoint/2010/main" val="235139866"/>
       </p:ext>
     </p:extLst>
   </p:cSld>
@@ -9604,7 +9604,7 @@
           <p:cNvPr id="1" name="">
             <a:extLst xmlns:a="http://schemas.openxmlformats.org/drawingml/2006/main">
               <a:ext uri="{FF2B5EF4-FFF2-40B4-BE49-F238E27FC236}">
-                <a16:creationId xmlns:a16="http://schemas.microsoft.com/office/drawing/2014/main" id="{4FBC79F7-96E4-4C87-A8B8-DD46B3DB1A39}"/>
+                <a16:creationId xmlns:a16="http://schemas.microsoft.com/office/drawing/2014/main" id="{9270DA0E-030A-419A-9232-9614110D0312}"/>
               </a:ext>
             </a:extLst>
           </p:cNvPr>
@@ -9654,7 +9654,7 @@
           <p:cNvPr id="2" name="">
             <a:extLst xmlns:a="http://schemas.openxmlformats.org/drawingml/2006/main">
               <a:ext uri="{FF2B5EF4-FFF2-40B4-BE49-F238E27FC236}">
-                <a16:creationId xmlns:a16="http://schemas.microsoft.com/office/drawing/2014/main" id="{7648788D-8A8B-44E3-9303-199823FC4BD6}"/>
+                <a16:creationId xmlns:a16="http://schemas.microsoft.com/office/drawing/2014/main" id="{7F21737F-F844-4531-962A-2B97F29F02D9}"/>
               </a:ext>
             </a:extLst>
           </p:cNvPr>
@@ -9704,7 +9704,7 @@
           <p:cNvPr id="3" name="">
             <a:extLst xmlns:a="http://schemas.openxmlformats.org/drawingml/2006/main">
               <a:ext uri="{FF2B5EF4-FFF2-40B4-BE49-F238E27FC236}">
-                <a16:creationId xmlns:a16="http://schemas.microsoft.com/office/drawing/2014/main" id="{5EA91628-EABE-4258-A6A5-EECC517A2B09}"/>
+                <a16:creationId xmlns:a16="http://schemas.microsoft.com/office/drawing/2014/main" id="{BD6EA4C7-4813-458E-B1C7-A06B6B2B8CB5}"/>
               </a:ext>
             </a:extLst>
           </p:cNvPr>
@@ -9741,7 +9741,7 @@
           <p:nvPr/>
         </p:nvPicPr>
         <p:blipFill>
-          <a:blip xmlns:r="http://schemas.openxmlformats.org/officeDocument/2006/relationships" xmlns:a="http://schemas.openxmlformats.org/drawingml/2006/main" r:embed="R1ae15f820ec6407a"/>
+          <a:blip xmlns:r="http://schemas.openxmlformats.org/officeDocument/2006/relationships" xmlns:a="http://schemas.openxmlformats.org/drawingml/2006/main" r:embed="R8b83caf3ff80428e"/>
           <a:stretch xmlns:a="http://schemas.openxmlformats.org/drawingml/2006/main"/>
         </p:blipFill>
         <p:spPr>
@@ -9759,7 +9759,7 @@
           <p:cNvPr id="5" name="">
             <a:extLst xmlns:a="http://schemas.openxmlformats.org/drawingml/2006/main">
               <a:ext uri="{FF2B5EF4-FFF2-40B4-BE49-F238E27FC236}">
-                <a16:creationId xmlns:a16="http://schemas.microsoft.com/office/drawing/2014/main" id="{080D701E-2B59-4B3C-A2B9-48A15B99FE72}"/>
+                <a16:creationId xmlns:a16="http://schemas.microsoft.com/office/drawing/2014/main" id="{A1E88064-EC1C-4E4B-BE6B-53B7B441899A}"/>
               </a:ext>
             </a:extLst>
           </p:cNvPr>
@@ -9807,7 +9807,7 @@
     </p:spTree>
     <p:extLst>
       <p:ext uri="{BB962C8B-B14F-4D97-AF65-F5344CB8AC3E}">
-        <p14:creationId xmlns:p14="http://schemas.microsoft.com/office/powerpoint/2010/main" val="1676395302"/>
+        <p14:creationId xmlns:p14="http://schemas.microsoft.com/office/powerpoint/2010/main" val="1002924157"/>
       </p:ext>
     </p:extLst>
   </p:cSld>
@@ -9838,7 +9838,7 @@
           <p:cNvPr id="1" name="">
             <a:extLst xmlns:a="http://schemas.openxmlformats.org/drawingml/2006/main">
               <a:ext uri="{FF2B5EF4-FFF2-40B4-BE49-F238E27FC236}">
-                <a16:creationId xmlns:a16="http://schemas.microsoft.com/office/drawing/2014/main" id="{B43A1F37-39C0-41D2-B6F1-F419B0AD9C36}"/>
+                <a16:creationId xmlns:a16="http://schemas.microsoft.com/office/drawing/2014/main" id="{5B75A699-1223-4C26-A092-9732F9137CB2}"/>
               </a:ext>
             </a:extLst>
           </p:cNvPr>
@@ -9888,7 +9888,7 @@
           <p:cNvPr id="2" name="">
             <a:extLst xmlns:a="http://schemas.openxmlformats.org/drawingml/2006/main">
               <a:ext uri="{FF2B5EF4-FFF2-40B4-BE49-F238E27FC236}">
-                <a16:creationId xmlns:a16="http://schemas.microsoft.com/office/drawing/2014/main" id="{0905AF6A-38B5-44E1-9DE5-01527846BD19}"/>
+                <a16:creationId xmlns:a16="http://schemas.microsoft.com/office/drawing/2014/main" id="{7B8E2C9B-CCD7-4786-B398-3443427BC619}"/>
               </a:ext>
             </a:extLst>
           </p:cNvPr>
@@ -9938,7 +9938,7 @@
           <p:cNvPr id="3" name="">
             <a:extLst xmlns:a="http://schemas.openxmlformats.org/drawingml/2006/main">
               <a:ext uri="{FF2B5EF4-FFF2-40B4-BE49-F238E27FC236}">
-                <a16:creationId xmlns:a16="http://schemas.microsoft.com/office/drawing/2014/main" id="{76B27015-DB1B-41D9-9779-1A0CFE24219B}"/>
+                <a16:creationId xmlns:a16="http://schemas.microsoft.com/office/drawing/2014/main" id="{E9280F71-F600-4403-A69A-D02E66CF06F9}"/>
               </a:ext>
             </a:extLst>
           </p:cNvPr>
@@ -9975,7 +9975,7 @@
           <p:nvPr/>
         </p:nvPicPr>
         <p:blipFill>
-          <a:blip xmlns:r="http://schemas.openxmlformats.org/officeDocument/2006/relationships" xmlns:a="http://schemas.openxmlformats.org/drawingml/2006/main" r:embed="R90344c7c46174d9e"/>
+          <a:blip xmlns:r="http://schemas.openxmlformats.org/officeDocument/2006/relationships" xmlns:a="http://schemas.openxmlformats.org/drawingml/2006/main" r:embed="R9dbffcd1b67b4bcf"/>
           <a:stretch xmlns:a="http://schemas.openxmlformats.org/drawingml/2006/main"/>
         </p:blipFill>
         <p:spPr>
@@ -9993,7 +9993,7 @@
           <p:cNvPr id="5" name="">
             <a:extLst xmlns:a="http://schemas.openxmlformats.org/drawingml/2006/main">
               <a:ext uri="{FF2B5EF4-FFF2-40B4-BE49-F238E27FC236}">
-                <a16:creationId xmlns:a16="http://schemas.microsoft.com/office/drawing/2014/main" id="{184CE308-DE9F-4F13-A831-47F9A0144E6D}"/>
+                <a16:creationId xmlns:a16="http://schemas.microsoft.com/office/drawing/2014/main" id="{20464BB6-9334-455D-B677-BF1254C53DC8}"/>
               </a:ext>
             </a:extLst>
           </p:cNvPr>
@@ -10026,7 +10026,7 @@
           <p:cNvPr id="6" name="">
             <a:extLst xmlns:a="http://schemas.openxmlformats.org/drawingml/2006/main">
               <a:ext uri="{FF2B5EF4-FFF2-40B4-BE49-F238E27FC236}">
-                <a16:creationId xmlns:a16="http://schemas.microsoft.com/office/drawing/2014/main" id="{30841130-2D1F-4ACB-B97C-CF82AC4C9252}"/>
+                <a16:creationId xmlns:a16="http://schemas.microsoft.com/office/drawing/2014/main" id="{AFA24D8A-A96E-49C0-BABB-1B9851EC5312}"/>
               </a:ext>
             </a:extLst>
           </p:cNvPr>
@@ -10076,7 +10076,7 @@
           <p:cNvPr id="7" name="">
             <a:extLst xmlns:a="http://schemas.openxmlformats.org/drawingml/2006/main">
               <a:ext uri="{FF2B5EF4-FFF2-40B4-BE49-F238E27FC236}">
-                <a16:creationId xmlns:a16="http://schemas.microsoft.com/office/drawing/2014/main" id="{DEDB3E51-2736-49CC-82B3-20AC725D8C85}"/>
+                <a16:creationId xmlns:a16="http://schemas.microsoft.com/office/drawing/2014/main" id="{BDA813EF-654A-4AF9-9DBB-D8C10D845DC0}"/>
               </a:ext>
             </a:extLst>
           </p:cNvPr>
@@ -10109,7 +10109,7 @@
           <p:cNvPr id="8" name="">
             <a:extLst xmlns:a="http://schemas.openxmlformats.org/drawingml/2006/main">
               <a:ext uri="{FF2B5EF4-FFF2-40B4-BE49-F238E27FC236}">
-                <a16:creationId xmlns:a16="http://schemas.microsoft.com/office/drawing/2014/main" id="{C6D9F65A-A977-42F1-8F60-FD30F499E27E}"/>
+                <a16:creationId xmlns:a16="http://schemas.microsoft.com/office/drawing/2014/main" id="{E85DEF96-A218-4FC1-9570-C2F6821AAB19}"/>
               </a:ext>
             </a:extLst>
           </p:cNvPr>
@@ -10159,7 +10159,7 @@
           <p:cNvPr id="9" name="">
             <a:extLst xmlns:a="http://schemas.openxmlformats.org/drawingml/2006/main">
               <a:ext uri="{FF2B5EF4-FFF2-40B4-BE49-F238E27FC236}">
-                <a16:creationId xmlns:a16="http://schemas.microsoft.com/office/drawing/2014/main" id="{6B13580D-91DA-4A6D-AD55-B5095E5A6C72}"/>
+                <a16:creationId xmlns:a16="http://schemas.microsoft.com/office/drawing/2014/main" id="{ACE1D274-D66F-4D04-BAFA-0D51D875BC87}"/>
               </a:ext>
             </a:extLst>
           </p:cNvPr>
@@ -10192,7 +10192,7 @@
           <p:cNvPr id="10" name="">
             <a:extLst xmlns:a="http://schemas.openxmlformats.org/drawingml/2006/main">
               <a:ext uri="{FF2B5EF4-FFF2-40B4-BE49-F238E27FC236}">
-                <a16:creationId xmlns:a16="http://schemas.microsoft.com/office/drawing/2014/main" id="{0AC2A8AE-5CBE-4066-BB8A-A1F35D42340D}"/>
+                <a16:creationId xmlns:a16="http://schemas.microsoft.com/office/drawing/2014/main" id="{C29C5F8B-0DE7-4E18-AF69-3167F10C4C51}"/>
               </a:ext>
             </a:extLst>
           </p:cNvPr>
@@ -10242,7 +10242,7 @@
           <p:cNvPr id="11" name="">
             <a:extLst xmlns:a="http://schemas.openxmlformats.org/drawingml/2006/main">
               <a:ext uri="{FF2B5EF4-FFF2-40B4-BE49-F238E27FC236}">
-                <a16:creationId xmlns:a16="http://schemas.microsoft.com/office/drawing/2014/main" id="{6CC7A08B-CE77-4B7A-ADF5-501FF0DB40D0}"/>
+                <a16:creationId xmlns:a16="http://schemas.microsoft.com/office/drawing/2014/main" id="{F7A6E7BD-8EC6-4BFD-833C-FB78F40F1DF8}"/>
               </a:ext>
             </a:extLst>
           </p:cNvPr>
@@ -10275,7 +10275,7 @@
           <p:cNvPr id="12" name="">
             <a:extLst xmlns:a="http://schemas.openxmlformats.org/drawingml/2006/main">
               <a:ext uri="{FF2B5EF4-FFF2-40B4-BE49-F238E27FC236}">
-                <a16:creationId xmlns:a16="http://schemas.microsoft.com/office/drawing/2014/main" id="{376D502D-D7CC-441E-95E1-26062E670297}"/>
+                <a16:creationId xmlns:a16="http://schemas.microsoft.com/office/drawing/2014/main" id="{83ABA25B-8509-4B67-98FF-4A8597E87DCB}"/>
               </a:ext>
             </a:extLst>
           </p:cNvPr>
@@ -10325,7 +10325,7 @@
           <p:cNvPr id="13" name="">
             <a:extLst xmlns:a="http://schemas.openxmlformats.org/drawingml/2006/main">
               <a:ext uri="{FF2B5EF4-FFF2-40B4-BE49-F238E27FC236}">
-                <a16:creationId xmlns:a16="http://schemas.microsoft.com/office/drawing/2014/main" id="{954D5AF1-CB96-478F-829D-28E5DEDFB7D8}"/>
+                <a16:creationId xmlns:a16="http://schemas.microsoft.com/office/drawing/2014/main" id="{D3B08F06-5F07-4FBA-B85C-D78A99D02B7F}"/>
               </a:ext>
             </a:extLst>
           </p:cNvPr>
@@ -10373,7 +10373,7 @@
     </p:spTree>
     <p:extLst>
       <p:ext uri="{BB962C8B-B14F-4D97-AF65-F5344CB8AC3E}">
-        <p14:creationId xmlns:p14="http://schemas.microsoft.com/office/powerpoint/2010/main" val="1264319612"/>
+        <p14:creationId xmlns:p14="http://schemas.microsoft.com/office/powerpoint/2010/main" val="1559035857"/>
       </p:ext>
     </p:extLst>
   </p:cSld>
@@ -10404,7 +10404,7 @@
           <p:cNvPr id="1" name="">
             <a:extLst xmlns:a="http://schemas.openxmlformats.org/drawingml/2006/main">
               <a:ext uri="{FF2B5EF4-FFF2-40B4-BE49-F238E27FC236}">
-                <a16:creationId xmlns:a16="http://schemas.microsoft.com/office/drawing/2014/main" id="{6BFDFC9A-7DD8-43A7-BE3C-259F50F8C147}"/>
+                <a16:creationId xmlns:a16="http://schemas.microsoft.com/office/drawing/2014/main" id="{56950F0C-C03A-46D1-9050-F5451F18B41C}"/>
               </a:ext>
             </a:extLst>
           </p:cNvPr>
@@ -10454,7 +10454,7 @@
           <p:cNvPr id="2" name="">
             <a:extLst xmlns:a="http://schemas.openxmlformats.org/drawingml/2006/main">
               <a:ext uri="{FF2B5EF4-FFF2-40B4-BE49-F238E27FC236}">
-                <a16:creationId xmlns:a16="http://schemas.microsoft.com/office/drawing/2014/main" id="{A7678A34-C814-48A3-912A-F8345EFD8ACC}"/>
+                <a16:creationId xmlns:a16="http://schemas.microsoft.com/office/drawing/2014/main" id="{6A234DB8-5515-4222-B5E8-F8AB1D72C367}"/>
               </a:ext>
             </a:extLst>
           </p:cNvPr>
@@ -10504,7 +10504,7 @@
           <p:cNvPr id="3" name="">
             <a:extLst xmlns:a="http://schemas.openxmlformats.org/drawingml/2006/main">
               <a:ext uri="{FF2B5EF4-FFF2-40B4-BE49-F238E27FC236}">
-                <a16:creationId xmlns:a16="http://schemas.microsoft.com/office/drawing/2014/main" id="{8ADEDA7B-D915-457E-8A56-6B3A2C4972B5}"/>
+                <a16:creationId xmlns:a16="http://schemas.microsoft.com/office/drawing/2014/main" id="{67AFD7F9-0F4B-465B-82F2-5B375FBE134E}"/>
               </a:ext>
             </a:extLst>
           </p:cNvPr>
@@ -10537,7 +10537,7 @@
           <p:cNvPr id="4" name="">
             <a:extLst xmlns:a="http://schemas.openxmlformats.org/drawingml/2006/main">
               <a:ext uri="{FF2B5EF4-FFF2-40B4-BE49-F238E27FC236}">
-                <a16:creationId xmlns:a16="http://schemas.microsoft.com/office/drawing/2014/main" id="{3FE0114F-D35F-42FE-9EA1-03150D3A4069}"/>
+                <a16:creationId xmlns:a16="http://schemas.microsoft.com/office/drawing/2014/main" id="{944DCF53-152D-41AB-A0DB-A037E17D87EF}"/>
               </a:ext>
             </a:extLst>
           </p:cNvPr>
@@ -10570,7 +10570,7 @@
           <p:cNvPr id="5" name="">
             <a:extLst xmlns:a="http://schemas.openxmlformats.org/drawingml/2006/main">
               <a:ext uri="{FF2B5EF4-FFF2-40B4-BE49-F238E27FC236}">
-                <a16:creationId xmlns:a16="http://schemas.microsoft.com/office/drawing/2014/main" id="{96B4ED22-AEF4-4E6C-A8AD-AA2B9426B6F1}"/>
+                <a16:creationId xmlns:a16="http://schemas.microsoft.com/office/drawing/2014/main" id="{22A17C11-F257-4B98-8D90-FF9369077A5A}"/>
               </a:ext>
             </a:extLst>
           </p:cNvPr>
@@ -10620,7 +10620,7 @@
           <p:cNvPr id="6" name="">
             <a:extLst xmlns:a="http://schemas.openxmlformats.org/drawingml/2006/main">
               <a:ext uri="{FF2B5EF4-FFF2-40B4-BE49-F238E27FC236}">
-                <a16:creationId xmlns:a16="http://schemas.microsoft.com/office/drawing/2014/main" id="{8EA82739-DAE2-4BCC-B20B-81A52721BFB0}"/>
+                <a16:creationId xmlns:a16="http://schemas.microsoft.com/office/drawing/2014/main" id="{A0100592-00C1-4AA9-8B1E-DA2F69ED4473}"/>
               </a:ext>
             </a:extLst>
           </p:cNvPr>
@@ -10670,7 +10670,7 @@
           <p:cNvPr id="7" name="">
             <a:extLst xmlns:a="http://schemas.openxmlformats.org/drawingml/2006/main">
               <a:ext uri="{FF2B5EF4-FFF2-40B4-BE49-F238E27FC236}">
-                <a16:creationId xmlns:a16="http://schemas.microsoft.com/office/drawing/2014/main" id="{F74AF62F-BF34-4244-824F-4EBD6D948861}"/>
+                <a16:creationId xmlns:a16="http://schemas.microsoft.com/office/drawing/2014/main" id="{36CDB05A-6765-45A0-8698-CA64E5D85749}"/>
               </a:ext>
             </a:extLst>
           </p:cNvPr>
@@ -10720,7 +10720,7 @@
           <p:cNvPr id="8" name="">
             <a:extLst xmlns:a="http://schemas.openxmlformats.org/drawingml/2006/main">
               <a:ext uri="{FF2B5EF4-FFF2-40B4-BE49-F238E27FC236}">
-                <a16:creationId xmlns:a16="http://schemas.microsoft.com/office/drawing/2014/main" id="{5521B55A-F670-48D9-9D7E-4EE70884D413}"/>
+                <a16:creationId xmlns:a16="http://schemas.microsoft.com/office/drawing/2014/main" id="{A07C87BA-2A45-428B-9FA1-BEA10EA35F04}"/>
               </a:ext>
             </a:extLst>
           </p:cNvPr>
@@ -10753,7 +10753,7 @@
           <p:cNvPr id="9" name="">
             <a:extLst xmlns:a="http://schemas.openxmlformats.org/drawingml/2006/main">
               <a:ext uri="{FF2B5EF4-FFF2-40B4-BE49-F238E27FC236}">
-                <a16:creationId xmlns:a16="http://schemas.microsoft.com/office/drawing/2014/main" id="{0BBDC0EB-6097-4BBD-AFA0-918AAD07B043}"/>
+                <a16:creationId xmlns:a16="http://schemas.microsoft.com/office/drawing/2014/main" id="{267207E1-87E5-4C2C-915F-333BD93A197E}"/>
               </a:ext>
             </a:extLst>
           </p:cNvPr>
@@ -10803,7 +10803,7 @@
           <p:cNvPr id="10" name="">
             <a:extLst xmlns:a="http://schemas.openxmlformats.org/drawingml/2006/main">
               <a:ext uri="{FF2B5EF4-FFF2-40B4-BE49-F238E27FC236}">
-                <a16:creationId xmlns:a16="http://schemas.microsoft.com/office/drawing/2014/main" id="{DA09846B-F8BF-4720-8A83-D00631357365}"/>
+                <a16:creationId xmlns:a16="http://schemas.microsoft.com/office/drawing/2014/main" id="{72078780-01B3-4FAD-9B99-1DFBFCBBF9AB}"/>
               </a:ext>
             </a:extLst>
           </p:cNvPr>
@@ -10836,7 +10836,7 @@
           <p:cNvPr id="11" name="">
             <a:extLst xmlns:a="http://schemas.openxmlformats.org/drawingml/2006/main">
               <a:ext uri="{FF2B5EF4-FFF2-40B4-BE49-F238E27FC236}">
-                <a16:creationId xmlns:a16="http://schemas.microsoft.com/office/drawing/2014/main" id="{3449A7FE-3D88-44E9-B8CB-8D6E61EA4AAF}"/>
+                <a16:creationId xmlns:a16="http://schemas.microsoft.com/office/drawing/2014/main" id="{16729542-58A9-4D3D-9E6A-34DA5C9F0944}"/>
               </a:ext>
             </a:extLst>
           </p:cNvPr>
@@ -10886,7 +10886,7 @@
           <p:cNvPr id="12" name="">
             <a:extLst xmlns:a="http://schemas.openxmlformats.org/drawingml/2006/main">
               <a:ext uri="{FF2B5EF4-FFF2-40B4-BE49-F238E27FC236}">
-                <a16:creationId xmlns:a16="http://schemas.microsoft.com/office/drawing/2014/main" id="{0C2D08EA-CA86-4689-AAF2-1106FCCB039E}"/>
+                <a16:creationId xmlns:a16="http://schemas.microsoft.com/office/drawing/2014/main" id="{9F6D94B8-96DD-49FA-9BB1-82CBCC8B1987}"/>
               </a:ext>
             </a:extLst>
           </p:cNvPr>
@@ -10919,7 +10919,7 @@
           <p:cNvPr id="13" name="">
             <a:extLst xmlns:a="http://schemas.openxmlformats.org/drawingml/2006/main">
               <a:ext uri="{FF2B5EF4-FFF2-40B4-BE49-F238E27FC236}">
-                <a16:creationId xmlns:a16="http://schemas.microsoft.com/office/drawing/2014/main" id="{7BD88823-9977-43AE-97E5-BCFB318584F6}"/>
+                <a16:creationId xmlns:a16="http://schemas.microsoft.com/office/drawing/2014/main" id="{5B1FCE37-A260-4929-AA91-ABA2580D78C7}"/>
               </a:ext>
             </a:extLst>
           </p:cNvPr>
@@ -10969,7 +10969,7 @@
           <p:cNvPr id="14" name="">
             <a:extLst xmlns:a="http://schemas.openxmlformats.org/drawingml/2006/main">
               <a:ext uri="{FF2B5EF4-FFF2-40B4-BE49-F238E27FC236}">
-                <a16:creationId xmlns:a16="http://schemas.microsoft.com/office/drawing/2014/main" id="{254A69A6-1313-4E06-90B5-25697BC334FF}"/>
+                <a16:creationId xmlns:a16="http://schemas.microsoft.com/office/drawing/2014/main" id="{D81C5F14-6478-4ABE-89F1-AF8F3983F199}"/>
               </a:ext>
             </a:extLst>
           </p:cNvPr>
@@ -11002,7 +11002,7 @@
           <p:cNvPr id="15" name="">
             <a:extLst xmlns:a="http://schemas.openxmlformats.org/drawingml/2006/main">
               <a:ext uri="{FF2B5EF4-FFF2-40B4-BE49-F238E27FC236}">
-                <a16:creationId xmlns:a16="http://schemas.microsoft.com/office/drawing/2014/main" id="{EFB9B874-78B7-4F0F-8808-7438A4C00E12}"/>
+                <a16:creationId xmlns:a16="http://schemas.microsoft.com/office/drawing/2014/main" id="{A75EE2AA-6CBB-440B-BCFA-2A2514977D42}"/>
               </a:ext>
             </a:extLst>
           </p:cNvPr>
@@ -11052,7 +11052,7 @@
           <p:cNvPr id="16" name="">
             <a:extLst xmlns:a="http://schemas.openxmlformats.org/drawingml/2006/main">
               <a:ext uri="{FF2B5EF4-FFF2-40B4-BE49-F238E27FC236}">
-                <a16:creationId xmlns:a16="http://schemas.microsoft.com/office/drawing/2014/main" id="{6D72AF80-6D23-40F5-9B76-8D3585D9A219}"/>
+                <a16:creationId xmlns:a16="http://schemas.microsoft.com/office/drawing/2014/main" id="{FAEED0E8-BC38-4BF6-88B3-23C2B446BFAB}"/>
               </a:ext>
             </a:extLst>
           </p:cNvPr>
@@ -11100,7 +11100,7 @@
     </p:spTree>
     <p:extLst>
       <p:ext uri="{BB962C8B-B14F-4D97-AF65-F5344CB8AC3E}">
-        <p14:creationId xmlns:p14="http://schemas.microsoft.com/office/powerpoint/2010/main" val="1650762644"/>
+        <p14:creationId xmlns:p14="http://schemas.microsoft.com/office/powerpoint/2010/main" val="1260328791"/>
       </p:ext>
     </p:extLst>
   </p:cSld>

</xml_diff>

<commit_message>
Clarify optimizer wording in presentation
</commit_message>
<xml_diff>
--- a/slides/LeNet5_MNIST_Final_Presentation.pptx
+++ b/slides/LeNet5_MNIST_Final_Presentation.pptx
@@ -2,25 +2,25 @@
 <file path=ppt/presentation.xml><?xml version="1.0" encoding="utf-8"?>
 <p:presentation xmlns:p="http://schemas.openxmlformats.org/presentationml/2006/main">
   <p:sldMasterIdLst>
-    <p:sldMasterId xmlns:r="http://schemas.openxmlformats.org/officeDocument/2006/relationships" id="2147483648" r:id="R28f2b148492549f0"/>
+    <p:sldMasterId xmlns:r="http://schemas.openxmlformats.org/officeDocument/2006/relationships" id="2147483648" r:id="Rcd4979a7c3f64364"/>
   </p:sldMasterIdLst>
   <p:notesMasterIdLst>
-    <p:notesMasterId xmlns:r="http://schemas.openxmlformats.org/officeDocument/2006/relationships" r:id="R84600c60c1b6401b"/>
+    <p:notesMasterId xmlns:r="http://schemas.openxmlformats.org/officeDocument/2006/relationships" r:id="R2ba900624dc04c4f"/>
   </p:notesMasterIdLst>
   <p:sldIdLst>
-    <p:sldId xmlns:r="http://schemas.openxmlformats.org/officeDocument/2006/relationships" id="256" r:id="Rbfe7c70659e64e97"/>
-    <p:sldId xmlns:r="http://schemas.openxmlformats.org/officeDocument/2006/relationships" id="257" r:id="Rabbb09e037f44fbd"/>
-    <p:sldId xmlns:r="http://schemas.openxmlformats.org/officeDocument/2006/relationships" id="258" r:id="R1364b7584e7b47c7"/>
-    <p:sldId xmlns:r="http://schemas.openxmlformats.org/officeDocument/2006/relationships" id="259" r:id="R7e189e17daa3490c"/>
-    <p:sldId xmlns:r="http://schemas.openxmlformats.org/officeDocument/2006/relationships" id="260" r:id="R24d1f755b87e4a9b"/>
-    <p:sldId xmlns:r="http://schemas.openxmlformats.org/officeDocument/2006/relationships" id="261" r:id="R5b7fa15bfe444fca"/>
-    <p:sldId xmlns:r="http://schemas.openxmlformats.org/officeDocument/2006/relationships" id="262" r:id="R9ff52b6876214b60"/>
-    <p:sldId xmlns:r="http://schemas.openxmlformats.org/officeDocument/2006/relationships" id="263" r:id="Rc169af87589c4b19"/>
-    <p:sldId xmlns:r="http://schemas.openxmlformats.org/officeDocument/2006/relationships" id="264" r:id="R9dd49a8e1fe34bd3"/>
-    <p:sldId xmlns:r="http://schemas.openxmlformats.org/officeDocument/2006/relationships" id="265" r:id="R95ebbe66721343cb"/>
-    <p:sldId xmlns:r="http://schemas.openxmlformats.org/officeDocument/2006/relationships" id="266" r:id="R6ee82392785345da"/>
-    <p:sldId xmlns:r="http://schemas.openxmlformats.org/officeDocument/2006/relationships" id="267" r:id="R333fcd0897a74d9c"/>
-    <p:sldId xmlns:r="http://schemas.openxmlformats.org/officeDocument/2006/relationships" id="268" r:id="R222163604ead4d2f"/>
+    <p:sldId xmlns:r="http://schemas.openxmlformats.org/officeDocument/2006/relationships" id="256" r:id="Rffccf592ce7f466e"/>
+    <p:sldId xmlns:r="http://schemas.openxmlformats.org/officeDocument/2006/relationships" id="257" r:id="R6a317b29fe914a08"/>
+    <p:sldId xmlns:r="http://schemas.openxmlformats.org/officeDocument/2006/relationships" id="258" r:id="R6833c4514d0e4f48"/>
+    <p:sldId xmlns:r="http://schemas.openxmlformats.org/officeDocument/2006/relationships" id="259" r:id="R3293c5352e724922"/>
+    <p:sldId xmlns:r="http://schemas.openxmlformats.org/officeDocument/2006/relationships" id="260" r:id="R91ecd9758a504d5e"/>
+    <p:sldId xmlns:r="http://schemas.openxmlformats.org/officeDocument/2006/relationships" id="261" r:id="R6c5d5488cf2b453f"/>
+    <p:sldId xmlns:r="http://schemas.openxmlformats.org/officeDocument/2006/relationships" id="262" r:id="R76b0ad92bf6647bc"/>
+    <p:sldId xmlns:r="http://schemas.openxmlformats.org/officeDocument/2006/relationships" id="263" r:id="R328e0ce72b6b4c07"/>
+    <p:sldId xmlns:r="http://schemas.openxmlformats.org/officeDocument/2006/relationships" id="264" r:id="R6e1d617449e3449d"/>
+    <p:sldId xmlns:r="http://schemas.openxmlformats.org/officeDocument/2006/relationships" id="265" r:id="R607c677f4f4e4797"/>
+    <p:sldId xmlns:r="http://schemas.openxmlformats.org/officeDocument/2006/relationships" id="266" r:id="R0ad80cbd5cf44bd7"/>
+    <p:sldId xmlns:r="http://schemas.openxmlformats.org/officeDocument/2006/relationships" id="267" r:id="Rab5c5287a8ac474c"/>
+    <p:sldId xmlns:r="http://schemas.openxmlformats.org/officeDocument/2006/relationships" id="268" r:id="R789801b788ab4896"/>
   </p:sldIdLst>
   <p:sldSz cx="12192000" cy="6858000"/>
   <p:notesSz cx="6858000" cy="9144000"/>
@@ -1405,7 +1405,7 @@
   </p:cSld>
   <p:clrMap bg1="lt1" tx1="dk1" bg2="lt2" tx2="dk2" accent1="accent1" accent2="accent2" accent3="accent3" accent4="accent4" accent5="accent5" accent6="accent6" hlink="hlink" folHlink="folHlink"/>
   <p:sldLayoutIdLst>
-    <p:sldLayoutId xmlns:r="http://schemas.openxmlformats.org/officeDocument/2006/relationships" id="2147483649" r:id="R49df1b844fd541bc"/>
+    <p:sldLayoutId xmlns:r="http://schemas.openxmlformats.org/officeDocument/2006/relationships" id="2147483649" r:id="Rf6ad2f5db80a4f02"/>
   </p:sldLayoutIdLst>
   <p:txStyles>
     <p:titleStyle>
@@ -1956,7 +1956,7 @@
           <p:cNvPr id="1" name="">
             <a:extLst xmlns:a="http://schemas.openxmlformats.org/drawingml/2006/main">
               <a:ext uri="{FF2B5EF4-FFF2-40B4-BE49-F238E27FC236}">
-                <a16:creationId xmlns:a16="http://schemas.microsoft.com/office/drawing/2014/main" id="{ED080F35-2B6F-45B1-97FD-4729D31BDC16}"/>
+                <a16:creationId xmlns:a16="http://schemas.microsoft.com/office/drawing/2014/main" id="{2C26B09A-0E7B-4643-81D6-1C588A0DEA1B}"/>
               </a:ext>
             </a:extLst>
           </p:cNvPr>
@@ -2006,7 +2006,7 @@
           <p:cNvPr id="2" name="">
             <a:extLst xmlns:a="http://schemas.openxmlformats.org/drawingml/2006/main">
               <a:ext uri="{FF2B5EF4-FFF2-40B4-BE49-F238E27FC236}">
-                <a16:creationId xmlns:a16="http://schemas.microsoft.com/office/drawing/2014/main" id="{E34B390B-DCF1-4A7F-89E1-D65B1AD13242}"/>
+                <a16:creationId xmlns:a16="http://schemas.microsoft.com/office/drawing/2014/main" id="{B9114B7A-74BA-4249-BF2D-283503F11793}"/>
               </a:ext>
             </a:extLst>
           </p:cNvPr>
@@ -2056,7 +2056,7 @@
           <p:cNvPr id="3" name="">
             <a:extLst xmlns:a="http://schemas.openxmlformats.org/drawingml/2006/main">
               <a:ext uri="{FF2B5EF4-FFF2-40B4-BE49-F238E27FC236}">
-                <a16:creationId xmlns:a16="http://schemas.microsoft.com/office/drawing/2014/main" id="{3840DAC2-00E6-406E-8FCA-198DF7CF40BB}"/>
+                <a16:creationId xmlns:a16="http://schemas.microsoft.com/office/drawing/2014/main" id="{26E22012-B88F-4200-9EFE-6F087FFB9CC7}"/>
               </a:ext>
             </a:extLst>
           </p:cNvPr>
@@ -2089,7 +2089,7 @@
           <p:cNvPr id="4" name="">
             <a:extLst xmlns:a="http://schemas.openxmlformats.org/drawingml/2006/main">
               <a:ext uri="{FF2B5EF4-FFF2-40B4-BE49-F238E27FC236}">
-                <a16:creationId xmlns:a16="http://schemas.microsoft.com/office/drawing/2014/main" id="{CA4F195A-71C3-458F-9183-2B5FFE88AB25}"/>
+                <a16:creationId xmlns:a16="http://schemas.microsoft.com/office/drawing/2014/main" id="{D6121D51-C186-4B12-82BC-B9518DBD0CA6}"/>
               </a:ext>
             </a:extLst>
           </p:cNvPr>
@@ -2139,7 +2139,7 @@
           <p:cNvPr id="5" name="">
             <a:extLst xmlns:a="http://schemas.openxmlformats.org/drawingml/2006/main">
               <a:ext uri="{FF2B5EF4-FFF2-40B4-BE49-F238E27FC236}">
-                <a16:creationId xmlns:a16="http://schemas.microsoft.com/office/drawing/2014/main" id="{C3A57328-6D05-42AB-AE93-7ED52AD4A07F}"/>
+                <a16:creationId xmlns:a16="http://schemas.microsoft.com/office/drawing/2014/main" id="{AF061C78-C956-4AD1-B322-8BECF9BD8ED9}"/>
               </a:ext>
             </a:extLst>
           </p:cNvPr>
@@ -2189,7 +2189,7 @@
           <p:cNvPr id="6" name="">
             <a:extLst xmlns:a="http://schemas.openxmlformats.org/drawingml/2006/main">
               <a:ext uri="{FF2B5EF4-FFF2-40B4-BE49-F238E27FC236}">
-                <a16:creationId xmlns:a16="http://schemas.microsoft.com/office/drawing/2014/main" id="{DC8DA504-2300-4732-BD33-7E86EE022970}"/>
+                <a16:creationId xmlns:a16="http://schemas.microsoft.com/office/drawing/2014/main" id="{2E307607-206E-4DE6-9236-86ECA2A27F60}"/>
               </a:ext>
             </a:extLst>
           </p:cNvPr>
@@ -2222,7 +2222,7 @@
           <p:cNvPr id="7" name="">
             <a:extLst xmlns:a="http://schemas.openxmlformats.org/drawingml/2006/main">
               <a:ext uri="{FF2B5EF4-FFF2-40B4-BE49-F238E27FC236}">
-                <a16:creationId xmlns:a16="http://schemas.microsoft.com/office/drawing/2014/main" id="{213278C7-BEA4-44A9-A375-D7633C5F0345}"/>
+                <a16:creationId xmlns:a16="http://schemas.microsoft.com/office/drawing/2014/main" id="{E88D3C03-3FAE-40C9-BC86-BA051AC3D674}"/>
               </a:ext>
             </a:extLst>
           </p:cNvPr>
@@ -2272,7 +2272,7 @@
           <p:cNvPr id="8" name="">
             <a:extLst xmlns:a="http://schemas.openxmlformats.org/drawingml/2006/main">
               <a:ext uri="{FF2B5EF4-FFF2-40B4-BE49-F238E27FC236}">
-                <a16:creationId xmlns:a16="http://schemas.microsoft.com/office/drawing/2014/main" id="{A21C18B7-F7CC-434F-A8BC-CDC5E3210195}"/>
+                <a16:creationId xmlns:a16="http://schemas.microsoft.com/office/drawing/2014/main" id="{A4A2FE1C-55BE-41C3-A523-BEE51AE0BBC9}"/>
               </a:ext>
             </a:extLst>
           </p:cNvPr>
@@ -2322,7 +2322,7 @@
           <p:cNvPr id="9" name="">
             <a:extLst xmlns:a="http://schemas.openxmlformats.org/drawingml/2006/main">
               <a:ext uri="{FF2B5EF4-FFF2-40B4-BE49-F238E27FC236}">
-                <a16:creationId xmlns:a16="http://schemas.microsoft.com/office/drawing/2014/main" id="{C966261E-934E-4DF1-B3A5-B48372883D9B}"/>
+                <a16:creationId xmlns:a16="http://schemas.microsoft.com/office/drawing/2014/main" id="{7BB4E7EB-7B06-40E6-B744-D6585B5847B7}"/>
               </a:ext>
             </a:extLst>
           </p:cNvPr>
@@ -2355,7 +2355,7 @@
           <p:cNvPr id="10" name="">
             <a:extLst xmlns:a="http://schemas.openxmlformats.org/drawingml/2006/main">
               <a:ext uri="{FF2B5EF4-FFF2-40B4-BE49-F238E27FC236}">
-                <a16:creationId xmlns:a16="http://schemas.microsoft.com/office/drawing/2014/main" id="{5EDE3426-D5A1-416D-B52C-94EC5921BA7C}"/>
+                <a16:creationId xmlns:a16="http://schemas.microsoft.com/office/drawing/2014/main" id="{2F211E83-7A00-4F67-BC42-991F8834E2D0}"/>
               </a:ext>
             </a:extLst>
           </p:cNvPr>
@@ -2405,7 +2405,7 @@
           <p:cNvPr id="11" name="">
             <a:extLst xmlns:a="http://schemas.openxmlformats.org/drawingml/2006/main">
               <a:ext uri="{FF2B5EF4-FFF2-40B4-BE49-F238E27FC236}">
-                <a16:creationId xmlns:a16="http://schemas.microsoft.com/office/drawing/2014/main" id="{A1271168-F9DB-4D8F-BEFA-AFCC923E9439}"/>
+                <a16:creationId xmlns:a16="http://schemas.microsoft.com/office/drawing/2014/main" id="{0032D59F-510A-4327-BCA7-371302626939}"/>
               </a:ext>
             </a:extLst>
           </p:cNvPr>
@@ -2455,7 +2455,7 @@
           <p:cNvPr id="12" name="">
             <a:extLst xmlns:a="http://schemas.openxmlformats.org/drawingml/2006/main">
               <a:ext uri="{FF2B5EF4-FFF2-40B4-BE49-F238E27FC236}">
-                <a16:creationId xmlns:a16="http://schemas.microsoft.com/office/drawing/2014/main" id="{83D7C80F-378D-4F11-A80D-6E44C88295E8}"/>
+                <a16:creationId xmlns:a16="http://schemas.microsoft.com/office/drawing/2014/main" id="{9CB6A0E4-108D-4E5A-86BF-D79A91B8A67C}"/>
               </a:ext>
             </a:extLst>
           </p:cNvPr>
@@ -2505,7 +2505,7 @@
           <p:cNvPr id="13" name="">
             <a:extLst xmlns:a="http://schemas.openxmlformats.org/drawingml/2006/main">
               <a:ext uri="{FF2B5EF4-FFF2-40B4-BE49-F238E27FC236}">
-                <a16:creationId xmlns:a16="http://schemas.microsoft.com/office/drawing/2014/main" id="{8ADEC20F-7733-4753-925E-E1E9BCCE77C5}"/>
+                <a16:creationId xmlns:a16="http://schemas.microsoft.com/office/drawing/2014/main" id="{EC6D4EE0-864E-46A0-BC05-C4F9016E09CB}"/>
               </a:ext>
             </a:extLst>
           </p:cNvPr>
@@ -2553,7 +2553,7 @@
     </p:spTree>
     <p:extLst>
       <p:ext uri="{BB962C8B-B14F-4D97-AF65-F5344CB8AC3E}">
-        <p14:creationId xmlns:p14="http://schemas.microsoft.com/office/powerpoint/2010/main" val="1711006368"/>
+        <p14:creationId xmlns:p14="http://schemas.microsoft.com/office/powerpoint/2010/main" val="251972631"/>
       </p:ext>
     </p:extLst>
   </p:cSld>
@@ -2584,7 +2584,7 @@
           <p:cNvPr id="1" name="">
             <a:extLst xmlns:a="http://schemas.openxmlformats.org/drawingml/2006/main">
               <a:ext uri="{FF2B5EF4-FFF2-40B4-BE49-F238E27FC236}">
-                <a16:creationId xmlns:a16="http://schemas.microsoft.com/office/drawing/2014/main" id="{49070CBE-7E38-405F-9853-52E7B62E81F6}"/>
+                <a16:creationId xmlns:a16="http://schemas.microsoft.com/office/drawing/2014/main" id="{665C7C6F-8DDD-44DF-8D00-C116226015FE}"/>
               </a:ext>
             </a:extLst>
           </p:cNvPr>
@@ -2634,7 +2634,7 @@
           <p:cNvPr id="2" name="">
             <a:extLst xmlns:a="http://schemas.openxmlformats.org/drawingml/2006/main">
               <a:ext uri="{FF2B5EF4-FFF2-40B4-BE49-F238E27FC236}">
-                <a16:creationId xmlns:a16="http://schemas.microsoft.com/office/drawing/2014/main" id="{1DC2CDB5-CFFA-44F2-B22A-12C69C574E25}"/>
+                <a16:creationId xmlns:a16="http://schemas.microsoft.com/office/drawing/2014/main" id="{1C98EFEA-5FB4-4D1C-96C5-459A39C6432C}"/>
               </a:ext>
             </a:extLst>
           </p:cNvPr>
@@ -2684,7 +2684,7 @@
           <p:cNvPr id="3" name="">
             <a:extLst xmlns:a="http://schemas.openxmlformats.org/drawingml/2006/main">
               <a:ext uri="{FF2B5EF4-FFF2-40B4-BE49-F238E27FC236}">
-                <a16:creationId xmlns:a16="http://schemas.microsoft.com/office/drawing/2014/main" id="{BC510090-3287-47FE-8A08-3C9C59AE36F3}"/>
+                <a16:creationId xmlns:a16="http://schemas.microsoft.com/office/drawing/2014/main" id="{5970DAA3-F426-4744-9ADF-566CA71B1CD0}"/>
               </a:ext>
             </a:extLst>
           </p:cNvPr>
@@ -2717,7 +2717,7 @@
           <p:cNvPr id="4" name="">
             <a:extLst xmlns:a="http://schemas.openxmlformats.org/drawingml/2006/main">
               <a:ext uri="{FF2B5EF4-FFF2-40B4-BE49-F238E27FC236}">
-                <a16:creationId xmlns:a16="http://schemas.microsoft.com/office/drawing/2014/main" id="{2B169587-B235-42CD-A883-BF7F74BE938C}"/>
+                <a16:creationId xmlns:a16="http://schemas.microsoft.com/office/drawing/2014/main" id="{FD6B8BC6-AF97-4698-AC65-9B1831A26DAB}"/>
               </a:ext>
             </a:extLst>
           </p:cNvPr>
@@ -2750,7 +2750,7 @@
           <p:cNvPr id="5" name="">
             <a:extLst xmlns:a="http://schemas.openxmlformats.org/drawingml/2006/main">
               <a:ext uri="{FF2B5EF4-FFF2-40B4-BE49-F238E27FC236}">
-                <a16:creationId xmlns:a16="http://schemas.microsoft.com/office/drawing/2014/main" id="{F97FE66E-9B3B-4FF0-AB6D-78C3EA263CD0}"/>
+                <a16:creationId xmlns:a16="http://schemas.microsoft.com/office/drawing/2014/main" id="{7AF39683-8AC3-43AC-A950-0EFBAC1B98E9}"/>
               </a:ext>
             </a:extLst>
           </p:cNvPr>
@@ -2800,7 +2800,7 @@
           <p:cNvPr id="6" name="">
             <a:extLst xmlns:a="http://schemas.openxmlformats.org/drawingml/2006/main">
               <a:ext uri="{FF2B5EF4-FFF2-40B4-BE49-F238E27FC236}">
-                <a16:creationId xmlns:a16="http://schemas.microsoft.com/office/drawing/2014/main" id="{6850C58D-77C7-4831-9E8E-9D750B76C0EE}"/>
+                <a16:creationId xmlns:a16="http://schemas.microsoft.com/office/drawing/2014/main" id="{8CE7323D-F5B9-48ED-932C-713FE486572C}"/>
               </a:ext>
             </a:extLst>
           </p:cNvPr>
@@ -2850,7 +2850,7 @@
           <p:cNvPr id="7" name="">
             <a:extLst xmlns:a="http://schemas.openxmlformats.org/drawingml/2006/main">
               <a:ext uri="{FF2B5EF4-FFF2-40B4-BE49-F238E27FC236}">
-                <a16:creationId xmlns:a16="http://schemas.microsoft.com/office/drawing/2014/main" id="{284214F9-E0C2-422A-B4DC-277A50B4E231}"/>
+                <a16:creationId xmlns:a16="http://schemas.microsoft.com/office/drawing/2014/main" id="{78C6A461-1B58-4114-8178-2C1A2ECE2BAC}"/>
               </a:ext>
             </a:extLst>
           </p:cNvPr>
@@ -2883,7 +2883,7 @@
           <p:cNvPr id="8" name="">
             <a:extLst xmlns:a="http://schemas.openxmlformats.org/drawingml/2006/main">
               <a:ext uri="{FF2B5EF4-FFF2-40B4-BE49-F238E27FC236}">
-                <a16:creationId xmlns:a16="http://schemas.microsoft.com/office/drawing/2014/main" id="{13274B6F-9444-44A2-87C9-F85C22D8BFEC}"/>
+                <a16:creationId xmlns:a16="http://schemas.microsoft.com/office/drawing/2014/main" id="{33A2BFC3-61F1-4A34-A611-67C8F1B8EB17}"/>
               </a:ext>
             </a:extLst>
           </p:cNvPr>
@@ -2933,7 +2933,7 @@
           <p:cNvPr id="9" name="">
             <a:extLst xmlns:a="http://schemas.openxmlformats.org/drawingml/2006/main">
               <a:ext uri="{FF2B5EF4-FFF2-40B4-BE49-F238E27FC236}">
-                <a16:creationId xmlns:a16="http://schemas.microsoft.com/office/drawing/2014/main" id="{D5453A87-D3B2-4C82-A229-1A0296167C25}"/>
+                <a16:creationId xmlns:a16="http://schemas.microsoft.com/office/drawing/2014/main" id="{95F79315-233C-4198-9E5B-4EEB2617AD3A}"/>
               </a:ext>
             </a:extLst>
           </p:cNvPr>
@@ -2983,7 +2983,7 @@
           <p:cNvPr id="10" name="">
             <a:extLst xmlns:a="http://schemas.openxmlformats.org/drawingml/2006/main">
               <a:ext uri="{FF2B5EF4-FFF2-40B4-BE49-F238E27FC236}">
-                <a16:creationId xmlns:a16="http://schemas.microsoft.com/office/drawing/2014/main" id="{E6726644-165D-49C2-9CE2-A12A402B19AD}"/>
+                <a16:creationId xmlns:a16="http://schemas.microsoft.com/office/drawing/2014/main" id="{61EF3891-5E2E-4408-9955-32A5E14D379D}"/>
               </a:ext>
             </a:extLst>
           </p:cNvPr>
@@ -3033,7 +3033,7 @@
           <p:cNvPr id="11" name="">
             <a:extLst xmlns:a="http://schemas.openxmlformats.org/drawingml/2006/main">
               <a:ext uri="{FF2B5EF4-FFF2-40B4-BE49-F238E27FC236}">
-                <a16:creationId xmlns:a16="http://schemas.microsoft.com/office/drawing/2014/main" id="{FD01AA23-B3D2-4242-AB83-B3FB4E916CA4}"/>
+                <a16:creationId xmlns:a16="http://schemas.microsoft.com/office/drawing/2014/main" id="{9B59F5CE-BAD1-475D-BA5D-CE65210B7201}"/>
               </a:ext>
             </a:extLst>
           </p:cNvPr>
@@ -3081,7 +3081,7 @@
     </p:spTree>
     <p:extLst>
       <p:ext uri="{BB962C8B-B14F-4D97-AF65-F5344CB8AC3E}">
-        <p14:creationId xmlns:p14="http://schemas.microsoft.com/office/powerpoint/2010/main" val="1701885156"/>
+        <p14:creationId xmlns:p14="http://schemas.microsoft.com/office/powerpoint/2010/main" val="860592620"/>
       </p:ext>
     </p:extLst>
   </p:cSld>
@@ -3112,7 +3112,7 @@
           <p:cNvPr id="1" name="">
             <a:extLst xmlns:a="http://schemas.openxmlformats.org/drawingml/2006/main">
               <a:ext uri="{FF2B5EF4-FFF2-40B4-BE49-F238E27FC236}">
-                <a16:creationId xmlns:a16="http://schemas.microsoft.com/office/drawing/2014/main" id="{95A361BB-4891-4927-9E09-97827CDA5354}"/>
+                <a16:creationId xmlns:a16="http://schemas.microsoft.com/office/drawing/2014/main" id="{798244A6-A04A-42BF-96A1-6C85B4AC0358}"/>
               </a:ext>
             </a:extLst>
           </p:cNvPr>
@@ -3162,7 +3162,7 @@
           <p:cNvPr id="2" name="">
             <a:extLst xmlns:a="http://schemas.openxmlformats.org/drawingml/2006/main">
               <a:ext uri="{FF2B5EF4-FFF2-40B4-BE49-F238E27FC236}">
-                <a16:creationId xmlns:a16="http://schemas.microsoft.com/office/drawing/2014/main" id="{D57813DA-E3CB-4CFE-AD70-409DFA5ED583}"/>
+                <a16:creationId xmlns:a16="http://schemas.microsoft.com/office/drawing/2014/main" id="{722FAF71-347D-4CC3-AC60-A35C8B870F0C}"/>
               </a:ext>
             </a:extLst>
           </p:cNvPr>
@@ -3212,7 +3212,7 @@
           <p:cNvPr id="3" name="">
             <a:extLst xmlns:a="http://schemas.openxmlformats.org/drawingml/2006/main">
               <a:ext uri="{FF2B5EF4-FFF2-40B4-BE49-F238E27FC236}">
-                <a16:creationId xmlns:a16="http://schemas.microsoft.com/office/drawing/2014/main" id="{31C57AEC-4649-419F-9C34-EAEBA09212A4}"/>
+                <a16:creationId xmlns:a16="http://schemas.microsoft.com/office/drawing/2014/main" id="{3967F073-83E0-42D9-8BF3-8E1FFF2BE47F}"/>
               </a:ext>
             </a:extLst>
           </p:cNvPr>
@@ -3245,7 +3245,7 @@
           <p:cNvPr id="4" name="">
             <a:extLst xmlns:a="http://schemas.openxmlformats.org/drawingml/2006/main">
               <a:ext uri="{FF2B5EF4-FFF2-40B4-BE49-F238E27FC236}">
-                <a16:creationId xmlns:a16="http://schemas.microsoft.com/office/drawing/2014/main" id="{01A71BAC-3864-4698-8F77-6B00E7A218DC}"/>
+                <a16:creationId xmlns:a16="http://schemas.microsoft.com/office/drawing/2014/main" id="{07C92B6C-DC3C-4480-B0DE-952A75461641}"/>
               </a:ext>
             </a:extLst>
           </p:cNvPr>
@@ -3278,7 +3278,7 @@
           <p:cNvPr id="5" name="">
             <a:extLst xmlns:a="http://schemas.openxmlformats.org/drawingml/2006/main">
               <a:ext uri="{FF2B5EF4-FFF2-40B4-BE49-F238E27FC236}">
-                <a16:creationId xmlns:a16="http://schemas.microsoft.com/office/drawing/2014/main" id="{48246B29-7942-4BE8-BBFC-3D7605DB3439}"/>
+                <a16:creationId xmlns:a16="http://schemas.microsoft.com/office/drawing/2014/main" id="{C730E067-E262-47D2-A784-6A6A163F8043}"/>
               </a:ext>
             </a:extLst>
           </p:cNvPr>
@@ -3328,7 +3328,7 @@
           <p:cNvPr id="6" name="">
             <a:extLst xmlns:a="http://schemas.openxmlformats.org/drawingml/2006/main">
               <a:ext uri="{FF2B5EF4-FFF2-40B4-BE49-F238E27FC236}">
-                <a16:creationId xmlns:a16="http://schemas.microsoft.com/office/drawing/2014/main" id="{E3278730-A3C6-45CF-B5C5-35DCE84920CA}"/>
+                <a16:creationId xmlns:a16="http://schemas.microsoft.com/office/drawing/2014/main" id="{D591CDD3-C6EB-4176-BAD0-12605E0DCCA6}"/>
               </a:ext>
             </a:extLst>
           </p:cNvPr>
@@ -3446,7 +3446,7 @@
           <p:cNvPr id="7" name="">
             <a:extLst xmlns:a="http://schemas.openxmlformats.org/drawingml/2006/main">
               <a:ext uri="{FF2B5EF4-FFF2-40B4-BE49-F238E27FC236}">
-                <a16:creationId xmlns:a16="http://schemas.microsoft.com/office/drawing/2014/main" id="{1B84DBB8-DA47-4794-ACFE-CFAF381C7838}"/>
+                <a16:creationId xmlns:a16="http://schemas.microsoft.com/office/drawing/2014/main" id="{ED7A00FF-F0C3-47E5-96F3-8E7F2F17C2C7}"/>
               </a:ext>
             </a:extLst>
           </p:cNvPr>
@@ -3479,7 +3479,7 @@
           <p:cNvPr id="8" name="">
             <a:extLst xmlns:a="http://schemas.openxmlformats.org/drawingml/2006/main">
               <a:ext uri="{FF2B5EF4-FFF2-40B4-BE49-F238E27FC236}">
-                <a16:creationId xmlns:a16="http://schemas.microsoft.com/office/drawing/2014/main" id="{19C5A1DA-69DF-47B8-9746-D84B1DA16239}"/>
+                <a16:creationId xmlns:a16="http://schemas.microsoft.com/office/drawing/2014/main" id="{8624BFA6-9CD7-48F8-BBCC-70DA86A379BD}"/>
               </a:ext>
             </a:extLst>
           </p:cNvPr>
@@ -3529,7 +3529,7 @@
           <p:cNvPr id="9" name="">
             <a:extLst xmlns:a="http://schemas.openxmlformats.org/drawingml/2006/main">
               <a:ext uri="{FF2B5EF4-FFF2-40B4-BE49-F238E27FC236}">
-                <a16:creationId xmlns:a16="http://schemas.microsoft.com/office/drawing/2014/main" id="{82219990-111F-4562-9A3E-9ED13818BFCD}"/>
+                <a16:creationId xmlns:a16="http://schemas.microsoft.com/office/drawing/2014/main" id="{28856264-2A83-4F42-9170-B017DED84260}"/>
               </a:ext>
             </a:extLst>
           </p:cNvPr>
@@ -3637,7 +3637,7 @@
                   <a:srgbClr val="0A0A0A"/>
                 </a:solidFill>
               </a:rPr>
-              <a:t>SGD optimizer prepared</a:t>
+              <a:t>Adam result; SGD supported</a:t>
             </a:r>
           </a:p>
         </p:txBody>
@@ -3647,7 +3647,7 @@
           <p:cNvPr id="10" name="">
             <a:extLst xmlns:a="http://schemas.openxmlformats.org/drawingml/2006/main">
               <a:ext uri="{FF2B5EF4-FFF2-40B4-BE49-F238E27FC236}">
-                <a16:creationId xmlns:a16="http://schemas.microsoft.com/office/drawing/2014/main" id="{856BD36C-CD3C-4AC6-92CE-F9C684FC591A}"/>
+                <a16:creationId xmlns:a16="http://schemas.microsoft.com/office/drawing/2014/main" id="{24A47521-12A5-409E-977D-ECD9833DA506}"/>
               </a:ext>
             </a:extLst>
           </p:cNvPr>
@@ -3680,7 +3680,7 @@
           <p:cNvPr id="11" name="">
             <a:extLst xmlns:a="http://schemas.openxmlformats.org/drawingml/2006/main">
               <a:ext uri="{FF2B5EF4-FFF2-40B4-BE49-F238E27FC236}">
-                <a16:creationId xmlns:a16="http://schemas.microsoft.com/office/drawing/2014/main" id="{B5E01909-1E4F-4A79-BB31-7E5C6DB4E816}"/>
+                <a16:creationId xmlns:a16="http://schemas.microsoft.com/office/drawing/2014/main" id="{C17FFA07-F97C-4E57-8F2D-471B9A6C2A83}"/>
               </a:ext>
             </a:extLst>
           </p:cNvPr>
@@ -3730,7 +3730,7 @@
           <p:cNvPr id="12" name="">
             <a:extLst xmlns:a="http://schemas.openxmlformats.org/drawingml/2006/main">
               <a:ext uri="{FF2B5EF4-FFF2-40B4-BE49-F238E27FC236}">
-                <a16:creationId xmlns:a16="http://schemas.microsoft.com/office/drawing/2014/main" id="{E3F9BC20-11FE-437E-87CA-E745148AC7A4}"/>
+                <a16:creationId xmlns:a16="http://schemas.microsoft.com/office/drawing/2014/main" id="{0452F4CE-BDF2-4B0B-9A66-1ED7CDEF2A08}"/>
               </a:ext>
             </a:extLst>
           </p:cNvPr>
@@ -3848,7 +3848,7 @@
           <p:cNvPr id="13" name="">
             <a:extLst xmlns:a="http://schemas.openxmlformats.org/drawingml/2006/main">
               <a:ext uri="{FF2B5EF4-FFF2-40B4-BE49-F238E27FC236}">
-                <a16:creationId xmlns:a16="http://schemas.microsoft.com/office/drawing/2014/main" id="{4213A667-F85A-4E4A-A5BB-F348174DD7C8}"/>
+                <a16:creationId xmlns:a16="http://schemas.microsoft.com/office/drawing/2014/main" id="{577D9DD4-F826-4993-81EE-E3B47A05A4CB}"/>
               </a:ext>
             </a:extLst>
           </p:cNvPr>
@@ -3896,7 +3896,7 @@
     </p:spTree>
     <p:extLst>
       <p:ext uri="{BB962C8B-B14F-4D97-AF65-F5344CB8AC3E}">
-        <p14:creationId xmlns:p14="http://schemas.microsoft.com/office/powerpoint/2010/main" val="766558727"/>
+        <p14:creationId xmlns:p14="http://schemas.microsoft.com/office/powerpoint/2010/main" val="242096155"/>
       </p:ext>
     </p:extLst>
   </p:cSld>
@@ -3927,7 +3927,7 @@
           <p:cNvPr id="1" name="">
             <a:extLst xmlns:a="http://schemas.openxmlformats.org/drawingml/2006/main">
               <a:ext uri="{FF2B5EF4-FFF2-40B4-BE49-F238E27FC236}">
-                <a16:creationId xmlns:a16="http://schemas.microsoft.com/office/drawing/2014/main" id="{E5E4FFE5-7E43-4E2F-A75F-C129D5B84EBD}"/>
+                <a16:creationId xmlns:a16="http://schemas.microsoft.com/office/drawing/2014/main" id="{2E275A6F-5CC1-4A1B-8413-C3051E103178}"/>
               </a:ext>
             </a:extLst>
           </p:cNvPr>
@@ -3977,7 +3977,7 @@
           <p:cNvPr id="2" name="">
             <a:extLst xmlns:a="http://schemas.openxmlformats.org/drawingml/2006/main">
               <a:ext uri="{FF2B5EF4-FFF2-40B4-BE49-F238E27FC236}">
-                <a16:creationId xmlns:a16="http://schemas.microsoft.com/office/drawing/2014/main" id="{4DB2B9CC-37DD-4C57-A0DF-2CA92CCE2201}"/>
+                <a16:creationId xmlns:a16="http://schemas.microsoft.com/office/drawing/2014/main" id="{1F1C1198-1A93-4BF3-9D68-F3C22B71F611}"/>
               </a:ext>
             </a:extLst>
           </p:cNvPr>
@@ -4027,7 +4027,7 @@
           <p:cNvPr id="3" name="">
             <a:extLst xmlns:a="http://schemas.openxmlformats.org/drawingml/2006/main">
               <a:ext uri="{FF2B5EF4-FFF2-40B4-BE49-F238E27FC236}">
-                <a16:creationId xmlns:a16="http://schemas.microsoft.com/office/drawing/2014/main" id="{2274B44D-B3BD-48CD-9494-0A6B6E84FEE0}"/>
+                <a16:creationId xmlns:a16="http://schemas.microsoft.com/office/drawing/2014/main" id="{0957888C-FDA6-4236-9EDB-75A671B348BC}"/>
               </a:ext>
             </a:extLst>
           </p:cNvPr>
@@ -4060,7 +4060,7 @@
           <p:cNvPr id="4" name="">
             <a:extLst xmlns:a="http://schemas.openxmlformats.org/drawingml/2006/main">
               <a:ext uri="{FF2B5EF4-FFF2-40B4-BE49-F238E27FC236}">
-                <a16:creationId xmlns:a16="http://schemas.microsoft.com/office/drawing/2014/main" id="{761F091B-E493-4CD9-9622-BD0D63AE1868}"/>
+                <a16:creationId xmlns:a16="http://schemas.microsoft.com/office/drawing/2014/main" id="{527C75CB-E362-4EE5-A9C9-FF5910B99676}"/>
               </a:ext>
             </a:extLst>
           </p:cNvPr>
@@ -4093,7 +4093,7 @@
           <p:cNvPr id="5" name="">
             <a:extLst xmlns:a="http://schemas.openxmlformats.org/drawingml/2006/main">
               <a:ext uri="{FF2B5EF4-FFF2-40B4-BE49-F238E27FC236}">
-                <a16:creationId xmlns:a16="http://schemas.microsoft.com/office/drawing/2014/main" id="{4FABDA21-B811-4E2F-AE80-35E7DB2C9ACE}"/>
+                <a16:creationId xmlns:a16="http://schemas.microsoft.com/office/drawing/2014/main" id="{CCD78826-C2A1-4FCC-BF50-540EA9EE67D8}"/>
               </a:ext>
             </a:extLst>
           </p:cNvPr>
@@ -4143,7 +4143,7 @@
           <p:cNvPr id="6" name="">
             <a:extLst xmlns:a="http://schemas.openxmlformats.org/drawingml/2006/main">
               <a:ext uri="{FF2B5EF4-FFF2-40B4-BE49-F238E27FC236}">
-                <a16:creationId xmlns:a16="http://schemas.microsoft.com/office/drawing/2014/main" id="{DFC89F69-BB0C-400E-BD94-5F625742C60D}"/>
+                <a16:creationId xmlns:a16="http://schemas.microsoft.com/office/drawing/2014/main" id="{764030BC-7220-451C-9B4C-EB46CA12253E}"/>
               </a:ext>
             </a:extLst>
           </p:cNvPr>
@@ -4176,7 +4176,7 @@
           <p:cNvPr id="7" name="">
             <a:extLst xmlns:a="http://schemas.openxmlformats.org/drawingml/2006/main">
               <a:ext uri="{FF2B5EF4-FFF2-40B4-BE49-F238E27FC236}">
-                <a16:creationId xmlns:a16="http://schemas.microsoft.com/office/drawing/2014/main" id="{DD75D3B3-2E20-4A7B-A6FD-3B5129379305}"/>
+                <a16:creationId xmlns:a16="http://schemas.microsoft.com/office/drawing/2014/main" id="{5BE07D7C-5D36-42AA-8A66-F5BBFB73728F}"/>
               </a:ext>
             </a:extLst>
           </p:cNvPr>
@@ -4226,7 +4226,7 @@
           <p:cNvPr id="8" name="">
             <a:extLst xmlns:a="http://schemas.openxmlformats.org/drawingml/2006/main">
               <a:ext uri="{FF2B5EF4-FFF2-40B4-BE49-F238E27FC236}">
-                <a16:creationId xmlns:a16="http://schemas.microsoft.com/office/drawing/2014/main" id="{8C6272A7-1124-4034-8768-63EAB74B7D66}"/>
+                <a16:creationId xmlns:a16="http://schemas.microsoft.com/office/drawing/2014/main" id="{364DD274-8E79-459C-A535-FCBE48880BD8}"/>
               </a:ext>
             </a:extLst>
           </p:cNvPr>
@@ -4259,7 +4259,7 @@
           <p:cNvPr id="9" name="">
             <a:extLst xmlns:a="http://schemas.openxmlformats.org/drawingml/2006/main">
               <a:ext uri="{FF2B5EF4-FFF2-40B4-BE49-F238E27FC236}">
-                <a16:creationId xmlns:a16="http://schemas.microsoft.com/office/drawing/2014/main" id="{19F07C06-6466-4DB6-84D7-1F41382BF1EE}"/>
+                <a16:creationId xmlns:a16="http://schemas.microsoft.com/office/drawing/2014/main" id="{73A2BEB2-BD49-43EF-A221-C18C7CC53F31}"/>
               </a:ext>
             </a:extLst>
           </p:cNvPr>
@@ -4309,7 +4309,7 @@
           <p:cNvPr id="10" name="">
             <a:extLst xmlns:a="http://schemas.openxmlformats.org/drawingml/2006/main">
               <a:ext uri="{FF2B5EF4-FFF2-40B4-BE49-F238E27FC236}">
-                <a16:creationId xmlns:a16="http://schemas.microsoft.com/office/drawing/2014/main" id="{122A5551-C25C-4489-948B-C36918557AEB}"/>
+                <a16:creationId xmlns:a16="http://schemas.microsoft.com/office/drawing/2014/main" id="{31B77F78-5AD2-451B-99B3-0B1C18507F5C}"/>
               </a:ext>
             </a:extLst>
           </p:cNvPr>
@@ -4342,7 +4342,7 @@
           <p:cNvPr id="11" name="">
             <a:extLst xmlns:a="http://schemas.openxmlformats.org/drawingml/2006/main">
               <a:ext uri="{FF2B5EF4-FFF2-40B4-BE49-F238E27FC236}">
-                <a16:creationId xmlns:a16="http://schemas.microsoft.com/office/drawing/2014/main" id="{7A8999EB-0AB8-47CD-A9BB-455634C4DA77}"/>
+                <a16:creationId xmlns:a16="http://schemas.microsoft.com/office/drawing/2014/main" id="{AC4F52C6-0606-4C47-A61F-2A4A5961AD32}"/>
               </a:ext>
             </a:extLst>
           </p:cNvPr>
@@ -4392,7 +4392,7 @@
           <p:cNvPr id="12" name="">
             <a:extLst xmlns:a="http://schemas.openxmlformats.org/drawingml/2006/main">
               <a:ext uri="{FF2B5EF4-FFF2-40B4-BE49-F238E27FC236}">
-                <a16:creationId xmlns:a16="http://schemas.microsoft.com/office/drawing/2014/main" id="{858EED2F-83D6-4DF9-A829-E419395BAD35}"/>
+                <a16:creationId xmlns:a16="http://schemas.microsoft.com/office/drawing/2014/main" id="{85B40ED0-1C1D-4977-8345-857FE51035E3}"/>
               </a:ext>
             </a:extLst>
           </p:cNvPr>
@@ -4425,7 +4425,7 @@
           <p:cNvPr id="13" name="">
             <a:extLst xmlns:a="http://schemas.openxmlformats.org/drawingml/2006/main">
               <a:ext uri="{FF2B5EF4-FFF2-40B4-BE49-F238E27FC236}">
-                <a16:creationId xmlns:a16="http://schemas.microsoft.com/office/drawing/2014/main" id="{3CD77C47-9456-4852-BE15-C1C9BE695CE2}"/>
+                <a16:creationId xmlns:a16="http://schemas.microsoft.com/office/drawing/2014/main" id="{BC72134D-E36A-4864-943F-6FD8741486B8}"/>
               </a:ext>
             </a:extLst>
           </p:cNvPr>
@@ -4475,7 +4475,7 @@
           <p:cNvPr id="14" name="">
             <a:extLst xmlns:a="http://schemas.openxmlformats.org/drawingml/2006/main">
               <a:ext uri="{FF2B5EF4-FFF2-40B4-BE49-F238E27FC236}">
-                <a16:creationId xmlns:a16="http://schemas.microsoft.com/office/drawing/2014/main" id="{5D0455B9-F903-4702-BCD0-76D970BBD654}"/>
+                <a16:creationId xmlns:a16="http://schemas.microsoft.com/office/drawing/2014/main" id="{EE410F56-DAFC-4CA1-A2CB-538C82DFF578}"/>
               </a:ext>
             </a:extLst>
           </p:cNvPr>
@@ -4508,7 +4508,7 @@
           <p:cNvPr id="15" name="">
             <a:extLst xmlns:a="http://schemas.openxmlformats.org/drawingml/2006/main">
               <a:ext uri="{FF2B5EF4-FFF2-40B4-BE49-F238E27FC236}">
-                <a16:creationId xmlns:a16="http://schemas.microsoft.com/office/drawing/2014/main" id="{3A925996-4CD8-40C9-AC7A-CEBA439C71B0}"/>
+                <a16:creationId xmlns:a16="http://schemas.microsoft.com/office/drawing/2014/main" id="{F98CD30A-DBD5-4651-8159-32D7BAE6A149}"/>
               </a:ext>
             </a:extLst>
           </p:cNvPr>
@@ -4558,7 +4558,7 @@
           <p:cNvPr id="16" name="">
             <a:extLst xmlns:a="http://schemas.openxmlformats.org/drawingml/2006/main">
               <a:ext uri="{FF2B5EF4-FFF2-40B4-BE49-F238E27FC236}">
-                <a16:creationId xmlns:a16="http://schemas.microsoft.com/office/drawing/2014/main" id="{CE7C8E28-2C94-4C37-A4DA-46176C8F09D0}"/>
+                <a16:creationId xmlns:a16="http://schemas.microsoft.com/office/drawing/2014/main" id="{93207ECB-CE81-43B7-9D1A-0305C4E8D178}"/>
               </a:ext>
             </a:extLst>
           </p:cNvPr>
@@ -4591,7 +4591,7 @@
           <p:cNvPr id="17" name="">
             <a:extLst xmlns:a="http://schemas.openxmlformats.org/drawingml/2006/main">
               <a:ext uri="{FF2B5EF4-FFF2-40B4-BE49-F238E27FC236}">
-                <a16:creationId xmlns:a16="http://schemas.microsoft.com/office/drawing/2014/main" id="{CF5F008A-2C47-42DA-B556-FAA083C1C8C7}"/>
+                <a16:creationId xmlns:a16="http://schemas.microsoft.com/office/drawing/2014/main" id="{1AAD8549-08A3-48AA-8059-9E45EB7C5D5B}"/>
               </a:ext>
             </a:extLst>
           </p:cNvPr>
@@ -4641,7 +4641,7 @@
           <p:cNvPr id="18" name="">
             <a:extLst xmlns:a="http://schemas.openxmlformats.org/drawingml/2006/main">
               <a:ext uri="{FF2B5EF4-FFF2-40B4-BE49-F238E27FC236}">
-                <a16:creationId xmlns:a16="http://schemas.microsoft.com/office/drawing/2014/main" id="{BA9E0330-C7E8-4260-A4E7-411A917E0687}"/>
+                <a16:creationId xmlns:a16="http://schemas.microsoft.com/office/drawing/2014/main" id="{0CFBB6D0-A7BF-4B03-B0F8-FF7009AF5523}"/>
               </a:ext>
             </a:extLst>
           </p:cNvPr>
@@ -4674,7 +4674,7 @@
           <p:cNvPr id="19" name="">
             <a:extLst xmlns:a="http://schemas.openxmlformats.org/drawingml/2006/main">
               <a:ext uri="{FF2B5EF4-FFF2-40B4-BE49-F238E27FC236}">
-                <a16:creationId xmlns:a16="http://schemas.microsoft.com/office/drawing/2014/main" id="{64718E46-F2AF-49FF-8B4E-FC81F7BA70EB}"/>
+                <a16:creationId xmlns:a16="http://schemas.microsoft.com/office/drawing/2014/main" id="{D5F10026-699F-4A0F-BF64-0C64BA613AA3}"/>
               </a:ext>
             </a:extLst>
           </p:cNvPr>
@@ -4724,7 +4724,7 @@
           <p:cNvPr id="20" name="">
             <a:extLst xmlns:a="http://schemas.openxmlformats.org/drawingml/2006/main">
               <a:ext uri="{FF2B5EF4-FFF2-40B4-BE49-F238E27FC236}">
-                <a16:creationId xmlns:a16="http://schemas.microsoft.com/office/drawing/2014/main" id="{002964B9-3D84-42F7-BFD9-61D220D365A3}"/>
+                <a16:creationId xmlns:a16="http://schemas.microsoft.com/office/drawing/2014/main" id="{B950CC75-4676-4817-AB79-A0D7AB91F87C}"/>
               </a:ext>
             </a:extLst>
           </p:cNvPr>
@@ -4757,7 +4757,7 @@
           <p:cNvPr id="21" name="">
             <a:extLst xmlns:a="http://schemas.openxmlformats.org/drawingml/2006/main">
               <a:ext uri="{FF2B5EF4-FFF2-40B4-BE49-F238E27FC236}">
-                <a16:creationId xmlns:a16="http://schemas.microsoft.com/office/drawing/2014/main" id="{4D56383E-F51A-49AC-A299-7396406BDBF5}"/>
+                <a16:creationId xmlns:a16="http://schemas.microsoft.com/office/drawing/2014/main" id="{5E9FF7F1-7DF9-4FCC-B1B6-4009D37B3E77}"/>
               </a:ext>
             </a:extLst>
           </p:cNvPr>
@@ -4807,7 +4807,7 @@
           <p:cNvPr id="22" name="">
             <a:extLst xmlns:a="http://schemas.openxmlformats.org/drawingml/2006/main">
               <a:ext uri="{FF2B5EF4-FFF2-40B4-BE49-F238E27FC236}">
-                <a16:creationId xmlns:a16="http://schemas.microsoft.com/office/drawing/2014/main" id="{156E972D-C279-4B62-A5AA-A66D9FFB4853}"/>
+                <a16:creationId xmlns:a16="http://schemas.microsoft.com/office/drawing/2014/main" id="{71E743D3-3C2E-464C-82B3-1C95B9418C09}"/>
               </a:ext>
             </a:extLst>
           </p:cNvPr>
@@ -4840,7 +4840,7 @@
           <p:cNvPr id="23" name="">
             <a:extLst xmlns:a="http://schemas.openxmlformats.org/drawingml/2006/main">
               <a:ext uri="{FF2B5EF4-FFF2-40B4-BE49-F238E27FC236}">
-                <a16:creationId xmlns:a16="http://schemas.microsoft.com/office/drawing/2014/main" id="{574C4049-9339-4E21-9219-29AF71C1EE9E}"/>
+                <a16:creationId xmlns:a16="http://schemas.microsoft.com/office/drawing/2014/main" id="{0CDDCE8F-0016-47CB-BFB0-F7B6D5D295FC}"/>
               </a:ext>
             </a:extLst>
           </p:cNvPr>
@@ -4890,7 +4890,7 @@
           <p:cNvPr id="24" name="">
             <a:extLst xmlns:a="http://schemas.openxmlformats.org/drawingml/2006/main">
               <a:ext uri="{FF2B5EF4-FFF2-40B4-BE49-F238E27FC236}">
-                <a16:creationId xmlns:a16="http://schemas.microsoft.com/office/drawing/2014/main" id="{0E5E4A15-EB58-45D5-A766-7D4D2B46B802}"/>
+                <a16:creationId xmlns:a16="http://schemas.microsoft.com/office/drawing/2014/main" id="{93A5F77F-FFDD-4B8A-AE98-66942F191712}"/>
               </a:ext>
             </a:extLst>
           </p:cNvPr>
@@ -4940,7 +4940,7 @@
           <p:cNvPr id="25" name="">
             <a:extLst xmlns:a="http://schemas.openxmlformats.org/drawingml/2006/main">
               <a:ext uri="{FF2B5EF4-FFF2-40B4-BE49-F238E27FC236}">
-                <a16:creationId xmlns:a16="http://schemas.microsoft.com/office/drawing/2014/main" id="{2361F555-CE5A-4767-A6AA-B6F79DE17186}"/>
+                <a16:creationId xmlns:a16="http://schemas.microsoft.com/office/drawing/2014/main" id="{D53F4412-B56D-490A-8F9B-A02701E7DADA}"/>
               </a:ext>
             </a:extLst>
           </p:cNvPr>
@@ -4988,7 +4988,7 @@
     </p:spTree>
     <p:extLst>
       <p:ext uri="{BB962C8B-B14F-4D97-AF65-F5344CB8AC3E}">
-        <p14:creationId xmlns:p14="http://schemas.microsoft.com/office/powerpoint/2010/main" val="466413989"/>
+        <p14:creationId xmlns:p14="http://schemas.microsoft.com/office/powerpoint/2010/main" val="1077361145"/>
       </p:ext>
     </p:extLst>
   </p:cSld>
@@ -5019,7 +5019,7 @@
           <p:cNvPr id="1" name="">
             <a:extLst xmlns:a="http://schemas.openxmlformats.org/drawingml/2006/main">
               <a:ext uri="{FF2B5EF4-FFF2-40B4-BE49-F238E27FC236}">
-                <a16:creationId xmlns:a16="http://schemas.microsoft.com/office/drawing/2014/main" id="{2274C7EE-2D13-4CE6-A13B-261C4CFEB160}"/>
+                <a16:creationId xmlns:a16="http://schemas.microsoft.com/office/drawing/2014/main" id="{1C1135CB-5634-4119-8A18-CE8DCDC4E80C}"/>
               </a:ext>
             </a:extLst>
           </p:cNvPr>
@@ -5069,7 +5069,7 @@
           <p:cNvPr id="2" name="">
             <a:extLst xmlns:a="http://schemas.openxmlformats.org/drawingml/2006/main">
               <a:ext uri="{FF2B5EF4-FFF2-40B4-BE49-F238E27FC236}">
-                <a16:creationId xmlns:a16="http://schemas.microsoft.com/office/drawing/2014/main" id="{5DF47208-E1D9-4372-88F1-B227DB468C66}"/>
+                <a16:creationId xmlns:a16="http://schemas.microsoft.com/office/drawing/2014/main" id="{89CEE908-091A-4600-BF31-800257419621}"/>
               </a:ext>
             </a:extLst>
           </p:cNvPr>
@@ -5119,7 +5119,7 @@
           <p:cNvPr id="3" name="">
             <a:extLst xmlns:a="http://schemas.openxmlformats.org/drawingml/2006/main">
               <a:ext uri="{FF2B5EF4-FFF2-40B4-BE49-F238E27FC236}">
-                <a16:creationId xmlns:a16="http://schemas.microsoft.com/office/drawing/2014/main" id="{137FB368-7BA8-4C87-941A-836D6DB89F88}"/>
+                <a16:creationId xmlns:a16="http://schemas.microsoft.com/office/drawing/2014/main" id="{A16B1ED5-C2D7-4D89-97AC-01C4DBDCCBB5}"/>
               </a:ext>
             </a:extLst>
           </p:cNvPr>
@@ -5152,7 +5152,7 @@
           <p:cNvPr id="4" name="">
             <a:extLst xmlns:a="http://schemas.openxmlformats.org/drawingml/2006/main">
               <a:ext uri="{FF2B5EF4-FFF2-40B4-BE49-F238E27FC236}">
-                <a16:creationId xmlns:a16="http://schemas.microsoft.com/office/drawing/2014/main" id="{7B4FC8FF-A900-4372-9DAE-F082632C8183}"/>
+                <a16:creationId xmlns:a16="http://schemas.microsoft.com/office/drawing/2014/main" id="{ACF8A811-C84F-4DEB-A1AD-E53874BC97B9}"/>
               </a:ext>
             </a:extLst>
           </p:cNvPr>
@@ -5185,7 +5185,7 @@
           <p:cNvPr id="5" name="">
             <a:extLst xmlns:a="http://schemas.openxmlformats.org/drawingml/2006/main">
               <a:ext uri="{FF2B5EF4-FFF2-40B4-BE49-F238E27FC236}">
-                <a16:creationId xmlns:a16="http://schemas.microsoft.com/office/drawing/2014/main" id="{650096BB-03AD-472E-9EF2-4A26986E1762}"/>
+                <a16:creationId xmlns:a16="http://schemas.microsoft.com/office/drawing/2014/main" id="{3AF042C6-C81B-43C5-B1FC-AFC8E5E41BE7}"/>
               </a:ext>
             </a:extLst>
           </p:cNvPr>
@@ -5235,7 +5235,7 @@
           <p:cNvPr id="6" name="">
             <a:extLst xmlns:a="http://schemas.openxmlformats.org/drawingml/2006/main">
               <a:ext uri="{FF2B5EF4-FFF2-40B4-BE49-F238E27FC236}">
-                <a16:creationId xmlns:a16="http://schemas.microsoft.com/office/drawing/2014/main" id="{D43835FE-5CF0-4408-A2AA-041CF8650659}"/>
+                <a16:creationId xmlns:a16="http://schemas.microsoft.com/office/drawing/2014/main" id="{A7D453D5-6226-47B6-81F1-E62F6C1F51CB}"/>
               </a:ext>
             </a:extLst>
           </p:cNvPr>
@@ -5268,7 +5268,7 @@
           <p:cNvPr id="7" name="">
             <a:extLst xmlns:a="http://schemas.openxmlformats.org/drawingml/2006/main">
               <a:ext uri="{FF2B5EF4-FFF2-40B4-BE49-F238E27FC236}">
-                <a16:creationId xmlns:a16="http://schemas.microsoft.com/office/drawing/2014/main" id="{664DC630-2F12-4E94-BBF8-803A47FC3E42}"/>
+                <a16:creationId xmlns:a16="http://schemas.microsoft.com/office/drawing/2014/main" id="{B2A61A75-6941-4CB2-A2DE-992AAEB9F8F7}"/>
               </a:ext>
             </a:extLst>
           </p:cNvPr>
@@ -5318,7 +5318,7 @@
           <p:cNvPr id="8" name="">
             <a:extLst xmlns:a="http://schemas.openxmlformats.org/drawingml/2006/main">
               <a:ext uri="{FF2B5EF4-FFF2-40B4-BE49-F238E27FC236}">
-                <a16:creationId xmlns:a16="http://schemas.microsoft.com/office/drawing/2014/main" id="{76FDE3A4-6F6A-4257-8ABF-334FCEEC5976}"/>
+                <a16:creationId xmlns:a16="http://schemas.microsoft.com/office/drawing/2014/main" id="{64F2C538-F11E-4541-807A-5CA3DC55922D}"/>
               </a:ext>
             </a:extLst>
           </p:cNvPr>
@@ -5351,7 +5351,7 @@
           <p:cNvPr id="9" name="">
             <a:extLst xmlns:a="http://schemas.openxmlformats.org/drawingml/2006/main">
               <a:ext uri="{FF2B5EF4-FFF2-40B4-BE49-F238E27FC236}">
-                <a16:creationId xmlns:a16="http://schemas.microsoft.com/office/drawing/2014/main" id="{364B77F3-D025-48AB-B491-0EB450C70762}"/>
+                <a16:creationId xmlns:a16="http://schemas.microsoft.com/office/drawing/2014/main" id="{453ECAE7-AEA8-482A-AC73-F791F6A0D0E3}"/>
               </a:ext>
             </a:extLst>
           </p:cNvPr>
@@ -5401,7 +5401,7 @@
           <p:cNvPr id="10" name="">
             <a:extLst xmlns:a="http://schemas.openxmlformats.org/drawingml/2006/main">
               <a:ext uri="{FF2B5EF4-FFF2-40B4-BE49-F238E27FC236}">
-                <a16:creationId xmlns:a16="http://schemas.microsoft.com/office/drawing/2014/main" id="{999C9592-71BA-437A-A490-FB3A3ED7B2A1}"/>
+                <a16:creationId xmlns:a16="http://schemas.microsoft.com/office/drawing/2014/main" id="{BCCFF0EB-B04D-4DA7-8772-93476A7AF4D8}"/>
               </a:ext>
             </a:extLst>
           </p:cNvPr>
@@ -5434,7 +5434,7 @@
           <p:cNvPr id="11" name="">
             <a:extLst xmlns:a="http://schemas.openxmlformats.org/drawingml/2006/main">
               <a:ext uri="{FF2B5EF4-FFF2-40B4-BE49-F238E27FC236}">
-                <a16:creationId xmlns:a16="http://schemas.microsoft.com/office/drawing/2014/main" id="{F8C1FC57-CB88-4658-AF46-DA50AD0E1386}"/>
+                <a16:creationId xmlns:a16="http://schemas.microsoft.com/office/drawing/2014/main" id="{DC341159-56AC-4AE1-88DA-A72C3E317D1B}"/>
               </a:ext>
             </a:extLst>
           </p:cNvPr>
@@ -5484,7 +5484,7 @@
           <p:cNvPr id="12" name="">
             <a:extLst xmlns:a="http://schemas.openxmlformats.org/drawingml/2006/main">
               <a:ext uri="{FF2B5EF4-FFF2-40B4-BE49-F238E27FC236}">
-                <a16:creationId xmlns:a16="http://schemas.microsoft.com/office/drawing/2014/main" id="{44526C1F-A5C0-46EC-ACEF-E2662D6D9830}"/>
+                <a16:creationId xmlns:a16="http://schemas.microsoft.com/office/drawing/2014/main" id="{CA9025FF-455B-4949-9C48-7E1764577963}"/>
               </a:ext>
             </a:extLst>
           </p:cNvPr>
@@ -5517,7 +5517,7 @@
           <p:cNvPr id="13" name="">
             <a:extLst xmlns:a="http://schemas.openxmlformats.org/drawingml/2006/main">
               <a:ext uri="{FF2B5EF4-FFF2-40B4-BE49-F238E27FC236}">
-                <a16:creationId xmlns:a16="http://schemas.microsoft.com/office/drawing/2014/main" id="{E1A5AB41-64B6-4C29-8C20-CAF35ECA0311}"/>
+                <a16:creationId xmlns:a16="http://schemas.microsoft.com/office/drawing/2014/main" id="{B00F03F6-017D-4423-A43B-7A1646623189}"/>
               </a:ext>
             </a:extLst>
           </p:cNvPr>
@@ -5567,7 +5567,7 @@
           <p:cNvPr id="14" name="">
             <a:extLst xmlns:a="http://schemas.openxmlformats.org/drawingml/2006/main">
               <a:ext uri="{FF2B5EF4-FFF2-40B4-BE49-F238E27FC236}">
-                <a16:creationId xmlns:a16="http://schemas.microsoft.com/office/drawing/2014/main" id="{B53B04CD-67F4-4B87-AAAD-BF149B7BD9A9}"/>
+                <a16:creationId xmlns:a16="http://schemas.microsoft.com/office/drawing/2014/main" id="{4B1242DE-5059-429F-A364-EA6A712B2DFB}"/>
               </a:ext>
             </a:extLst>
           </p:cNvPr>
@@ -5617,7 +5617,7 @@
           <p:cNvPr id="15" name="">
             <a:extLst xmlns:a="http://schemas.openxmlformats.org/drawingml/2006/main">
               <a:ext uri="{FF2B5EF4-FFF2-40B4-BE49-F238E27FC236}">
-                <a16:creationId xmlns:a16="http://schemas.microsoft.com/office/drawing/2014/main" id="{17FFF173-1EAF-459F-8C46-5BB5CA1FA998}"/>
+                <a16:creationId xmlns:a16="http://schemas.microsoft.com/office/drawing/2014/main" id="{51C51542-4532-42D2-B695-CBC528A6DF44}"/>
               </a:ext>
             </a:extLst>
           </p:cNvPr>
@@ -5665,7 +5665,7 @@
     </p:spTree>
     <p:extLst>
       <p:ext uri="{BB962C8B-B14F-4D97-AF65-F5344CB8AC3E}">
-        <p14:creationId xmlns:p14="http://schemas.microsoft.com/office/powerpoint/2010/main" val="352314948"/>
+        <p14:creationId xmlns:p14="http://schemas.microsoft.com/office/powerpoint/2010/main" val="1772253007"/>
       </p:ext>
     </p:extLst>
   </p:cSld>
@@ -5696,7 +5696,7 @@
           <p:cNvPr id="1" name="">
             <a:extLst xmlns:a="http://schemas.openxmlformats.org/drawingml/2006/main">
               <a:ext uri="{FF2B5EF4-FFF2-40B4-BE49-F238E27FC236}">
-                <a16:creationId xmlns:a16="http://schemas.microsoft.com/office/drawing/2014/main" id="{0599D13B-14DA-4A37-AEED-EAC4B29CB500}"/>
+                <a16:creationId xmlns:a16="http://schemas.microsoft.com/office/drawing/2014/main" id="{A504B32C-622C-4770-9A7C-6B6237936A66}"/>
               </a:ext>
             </a:extLst>
           </p:cNvPr>
@@ -5746,7 +5746,7 @@
           <p:cNvPr id="2" name="">
             <a:extLst xmlns:a="http://schemas.openxmlformats.org/drawingml/2006/main">
               <a:ext uri="{FF2B5EF4-FFF2-40B4-BE49-F238E27FC236}">
-                <a16:creationId xmlns:a16="http://schemas.microsoft.com/office/drawing/2014/main" id="{90E12A8E-25FA-4F0A-95E2-25C86BC1DA7F}"/>
+                <a16:creationId xmlns:a16="http://schemas.microsoft.com/office/drawing/2014/main" id="{4AC11851-3633-44CF-8E12-3940C4E06147}"/>
               </a:ext>
             </a:extLst>
           </p:cNvPr>
@@ -5796,7 +5796,7 @@
           <p:cNvPr id="3" name="">
             <a:extLst xmlns:a="http://schemas.openxmlformats.org/drawingml/2006/main">
               <a:ext uri="{FF2B5EF4-FFF2-40B4-BE49-F238E27FC236}">
-                <a16:creationId xmlns:a16="http://schemas.microsoft.com/office/drawing/2014/main" id="{52D9CC9F-BF1C-4EB9-8954-921BC1F8A121}"/>
+                <a16:creationId xmlns:a16="http://schemas.microsoft.com/office/drawing/2014/main" id="{5B93393A-E01B-4B54-93C6-1C34E112A545}"/>
               </a:ext>
             </a:extLst>
           </p:cNvPr>
@@ -5829,7 +5829,7 @@
           <p:cNvPr id="4" name="">
             <a:extLst xmlns:a="http://schemas.openxmlformats.org/drawingml/2006/main">
               <a:ext uri="{FF2B5EF4-FFF2-40B4-BE49-F238E27FC236}">
-                <a16:creationId xmlns:a16="http://schemas.microsoft.com/office/drawing/2014/main" id="{0C245319-541C-4684-9A14-84CD0F83658B}"/>
+                <a16:creationId xmlns:a16="http://schemas.microsoft.com/office/drawing/2014/main" id="{A5A4C8D5-73D8-4DE2-B3DA-4907B71A5738}"/>
               </a:ext>
             </a:extLst>
           </p:cNvPr>
@@ -5862,7 +5862,7 @@
           <p:cNvPr id="5" name="">
             <a:extLst xmlns:a="http://schemas.openxmlformats.org/drawingml/2006/main">
               <a:ext uri="{FF2B5EF4-FFF2-40B4-BE49-F238E27FC236}">
-                <a16:creationId xmlns:a16="http://schemas.microsoft.com/office/drawing/2014/main" id="{B7CD8CEF-6735-497C-A93D-CB127234ADED}"/>
+                <a16:creationId xmlns:a16="http://schemas.microsoft.com/office/drawing/2014/main" id="{D660CD91-DF74-49F2-85B1-307EEECC0134}"/>
               </a:ext>
             </a:extLst>
           </p:cNvPr>
@@ -5912,7 +5912,7 @@
           <p:cNvPr id="6" name="">
             <a:extLst xmlns:a="http://schemas.openxmlformats.org/drawingml/2006/main">
               <a:ext uri="{FF2B5EF4-FFF2-40B4-BE49-F238E27FC236}">
-                <a16:creationId xmlns:a16="http://schemas.microsoft.com/office/drawing/2014/main" id="{A4AACCFF-679D-4090-8DC8-931A22E3BED4}"/>
+                <a16:creationId xmlns:a16="http://schemas.microsoft.com/office/drawing/2014/main" id="{C91DF3C3-9F54-4719-A480-377754D390F5}"/>
               </a:ext>
             </a:extLst>
           </p:cNvPr>
@@ -5945,7 +5945,7 @@
           <p:cNvPr id="7" name="">
             <a:extLst xmlns:a="http://schemas.openxmlformats.org/drawingml/2006/main">
               <a:ext uri="{FF2B5EF4-FFF2-40B4-BE49-F238E27FC236}">
-                <a16:creationId xmlns:a16="http://schemas.microsoft.com/office/drawing/2014/main" id="{39053E4C-D0D9-4F88-9C0C-71FD0C29C93B}"/>
+                <a16:creationId xmlns:a16="http://schemas.microsoft.com/office/drawing/2014/main" id="{849268B3-B1A5-4CEF-AEB4-DC7C4E323A51}"/>
               </a:ext>
             </a:extLst>
           </p:cNvPr>
@@ -5995,7 +5995,7 @@
           <p:cNvPr id="8" name="">
             <a:extLst xmlns:a="http://schemas.openxmlformats.org/drawingml/2006/main">
               <a:ext uri="{FF2B5EF4-FFF2-40B4-BE49-F238E27FC236}">
-                <a16:creationId xmlns:a16="http://schemas.microsoft.com/office/drawing/2014/main" id="{68007B92-68CF-48A7-B4B2-6749E95B4C59}"/>
+                <a16:creationId xmlns:a16="http://schemas.microsoft.com/office/drawing/2014/main" id="{ACBA89A7-618B-4E01-95E5-9005F246770B}"/>
               </a:ext>
             </a:extLst>
           </p:cNvPr>
@@ -6028,7 +6028,7 @@
           <p:cNvPr id="9" name="">
             <a:extLst xmlns:a="http://schemas.openxmlformats.org/drawingml/2006/main">
               <a:ext uri="{FF2B5EF4-FFF2-40B4-BE49-F238E27FC236}">
-                <a16:creationId xmlns:a16="http://schemas.microsoft.com/office/drawing/2014/main" id="{9E02E60D-5574-41E1-90E6-F80E5FE9187A}"/>
+                <a16:creationId xmlns:a16="http://schemas.microsoft.com/office/drawing/2014/main" id="{81CF574D-17A3-4A73-801A-E8D218E0BA9B}"/>
               </a:ext>
             </a:extLst>
           </p:cNvPr>
@@ -6078,7 +6078,7 @@
           <p:cNvPr id="10" name="">
             <a:extLst xmlns:a="http://schemas.openxmlformats.org/drawingml/2006/main">
               <a:ext uri="{FF2B5EF4-FFF2-40B4-BE49-F238E27FC236}">
-                <a16:creationId xmlns:a16="http://schemas.microsoft.com/office/drawing/2014/main" id="{269B075E-019B-4216-8579-EC904A4C6D02}"/>
+                <a16:creationId xmlns:a16="http://schemas.microsoft.com/office/drawing/2014/main" id="{27690935-4662-4118-B0C8-1942D9EA7225}"/>
               </a:ext>
             </a:extLst>
           </p:cNvPr>
@@ -6111,7 +6111,7 @@
           <p:cNvPr id="11" name="">
             <a:extLst xmlns:a="http://schemas.openxmlformats.org/drawingml/2006/main">
               <a:ext uri="{FF2B5EF4-FFF2-40B4-BE49-F238E27FC236}">
-                <a16:creationId xmlns:a16="http://schemas.microsoft.com/office/drawing/2014/main" id="{D30A0EB6-6B6E-4451-9FD9-9AE007B27D77}"/>
+                <a16:creationId xmlns:a16="http://schemas.microsoft.com/office/drawing/2014/main" id="{3E28D604-903E-4191-9A02-8125AEE52CD0}"/>
               </a:ext>
             </a:extLst>
           </p:cNvPr>
@@ -6165,7 +6165,7 @@
           <p:nvPr/>
         </p:nvPicPr>
         <p:blipFill>
-          <a:blip xmlns:r="http://schemas.openxmlformats.org/officeDocument/2006/relationships" xmlns:a="http://schemas.openxmlformats.org/drawingml/2006/main" r:embed="R26e14d1ea1e74d68"/>
+          <a:blip xmlns:r="http://schemas.openxmlformats.org/officeDocument/2006/relationships" xmlns:a="http://schemas.openxmlformats.org/drawingml/2006/main" r:embed="Ref0b4ec996a9481c"/>
           <a:stretch xmlns:a="http://schemas.openxmlformats.org/drawingml/2006/main"/>
         </p:blipFill>
         <p:spPr>
@@ -6183,7 +6183,7 @@
           <p:cNvPr id="13" name="">
             <a:extLst xmlns:a="http://schemas.openxmlformats.org/drawingml/2006/main">
               <a:ext uri="{FF2B5EF4-FFF2-40B4-BE49-F238E27FC236}">
-                <a16:creationId xmlns:a16="http://schemas.microsoft.com/office/drawing/2014/main" id="{3A86B53A-6807-44ED-89DA-36CD4AE33BB1}"/>
+                <a16:creationId xmlns:a16="http://schemas.microsoft.com/office/drawing/2014/main" id="{B8C1CCD1-5948-4910-B271-60A4E6F80EFC}"/>
               </a:ext>
             </a:extLst>
           </p:cNvPr>
@@ -6233,7 +6233,7 @@
           <p:cNvPr id="14" name="">
             <a:extLst xmlns:a="http://schemas.openxmlformats.org/drawingml/2006/main">
               <a:ext uri="{FF2B5EF4-FFF2-40B4-BE49-F238E27FC236}">
-                <a16:creationId xmlns:a16="http://schemas.microsoft.com/office/drawing/2014/main" id="{677415ED-1B68-4EA5-BC13-130B303F174C}"/>
+                <a16:creationId xmlns:a16="http://schemas.microsoft.com/office/drawing/2014/main" id="{56295CE2-BA1B-49A3-9785-79011FFA75A1}"/>
               </a:ext>
             </a:extLst>
           </p:cNvPr>
@@ -6281,7 +6281,7 @@
     </p:spTree>
     <p:extLst>
       <p:ext uri="{BB962C8B-B14F-4D97-AF65-F5344CB8AC3E}">
-        <p14:creationId xmlns:p14="http://schemas.microsoft.com/office/powerpoint/2010/main" val="1186170306"/>
+        <p14:creationId xmlns:p14="http://schemas.microsoft.com/office/powerpoint/2010/main" val="1590223493"/>
       </p:ext>
     </p:extLst>
   </p:cSld>
@@ -6312,7 +6312,7 @@
           <p:cNvPr id="1" name="">
             <a:extLst xmlns:a="http://schemas.openxmlformats.org/drawingml/2006/main">
               <a:ext uri="{FF2B5EF4-FFF2-40B4-BE49-F238E27FC236}">
-                <a16:creationId xmlns:a16="http://schemas.microsoft.com/office/drawing/2014/main" id="{79DCD635-4F54-4EBF-AC3D-77C238315807}"/>
+                <a16:creationId xmlns:a16="http://schemas.microsoft.com/office/drawing/2014/main" id="{E5623ED2-C49B-4DB5-98BB-174B3314943C}"/>
               </a:ext>
             </a:extLst>
           </p:cNvPr>
@@ -6362,7 +6362,7 @@
           <p:cNvPr id="2" name="">
             <a:extLst xmlns:a="http://schemas.openxmlformats.org/drawingml/2006/main">
               <a:ext uri="{FF2B5EF4-FFF2-40B4-BE49-F238E27FC236}">
-                <a16:creationId xmlns:a16="http://schemas.microsoft.com/office/drawing/2014/main" id="{775AD001-BB9B-49DC-90A5-AA9DC0B47D31}"/>
+                <a16:creationId xmlns:a16="http://schemas.microsoft.com/office/drawing/2014/main" id="{25287261-3B36-4FD5-902B-8D7A975E6902}"/>
               </a:ext>
             </a:extLst>
           </p:cNvPr>
@@ -6412,7 +6412,7 @@
           <p:cNvPr id="3" name="">
             <a:extLst xmlns:a="http://schemas.openxmlformats.org/drawingml/2006/main">
               <a:ext uri="{FF2B5EF4-FFF2-40B4-BE49-F238E27FC236}">
-                <a16:creationId xmlns:a16="http://schemas.microsoft.com/office/drawing/2014/main" id="{1F0053BC-52AF-407C-91B4-DAF5CAC3D171}"/>
+                <a16:creationId xmlns:a16="http://schemas.microsoft.com/office/drawing/2014/main" id="{38F076A5-19EF-445F-8307-A3AF20327F89}"/>
               </a:ext>
             </a:extLst>
           </p:cNvPr>
@@ -6445,7 +6445,7 @@
           <p:cNvPr id="4" name="">
             <a:extLst xmlns:a="http://schemas.openxmlformats.org/drawingml/2006/main">
               <a:ext uri="{FF2B5EF4-FFF2-40B4-BE49-F238E27FC236}">
-                <a16:creationId xmlns:a16="http://schemas.microsoft.com/office/drawing/2014/main" id="{D8C5855B-83FB-4369-AD6A-EB37FC6D73A8}"/>
+                <a16:creationId xmlns:a16="http://schemas.microsoft.com/office/drawing/2014/main" id="{14FD60B0-4EBA-4035-907F-0BECEB93BE2F}"/>
               </a:ext>
             </a:extLst>
           </p:cNvPr>
@@ -6478,7 +6478,7 @@
           <p:cNvPr id="5" name="">
             <a:extLst xmlns:a="http://schemas.openxmlformats.org/drawingml/2006/main">
               <a:ext uri="{FF2B5EF4-FFF2-40B4-BE49-F238E27FC236}">
-                <a16:creationId xmlns:a16="http://schemas.microsoft.com/office/drawing/2014/main" id="{B7A031D7-251F-46EB-9C32-AC31E2994F52}"/>
+                <a16:creationId xmlns:a16="http://schemas.microsoft.com/office/drawing/2014/main" id="{CC066EB0-4FBF-4BAE-A610-E2BDB98CF149}"/>
               </a:ext>
             </a:extLst>
           </p:cNvPr>
@@ -6528,7 +6528,7 @@
           <p:cNvPr id="6" name="">
             <a:extLst xmlns:a="http://schemas.openxmlformats.org/drawingml/2006/main">
               <a:ext uri="{FF2B5EF4-FFF2-40B4-BE49-F238E27FC236}">
-                <a16:creationId xmlns:a16="http://schemas.microsoft.com/office/drawing/2014/main" id="{E8CC0EDD-E7C9-48C1-88A1-1D94484514D9}"/>
+                <a16:creationId xmlns:a16="http://schemas.microsoft.com/office/drawing/2014/main" id="{9E8EC982-46B7-4BA8-B33B-32E3570A6116}"/>
               </a:ext>
             </a:extLst>
           </p:cNvPr>
@@ -6578,7 +6578,7 @@
           <p:cNvPr id="7" name="">
             <a:extLst xmlns:a="http://schemas.openxmlformats.org/drawingml/2006/main">
               <a:ext uri="{FF2B5EF4-FFF2-40B4-BE49-F238E27FC236}">
-                <a16:creationId xmlns:a16="http://schemas.microsoft.com/office/drawing/2014/main" id="{2572EFDD-BE1F-476D-BFF5-8E3E86FF7DCC}"/>
+                <a16:creationId xmlns:a16="http://schemas.microsoft.com/office/drawing/2014/main" id="{6644F5D1-9C37-47F3-8CE6-7FDAFD448E69}"/>
               </a:ext>
             </a:extLst>
           </p:cNvPr>
@@ -6611,7 +6611,7 @@
           <p:cNvPr id="8" name="">
             <a:extLst xmlns:a="http://schemas.openxmlformats.org/drawingml/2006/main">
               <a:ext uri="{FF2B5EF4-FFF2-40B4-BE49-F238E27FC236}">
-                <a16:creationId xmlns:a16="http://schemas.microsoft.com/office/drawing/2014/main" id="{43AB9BC5-7A2B-4702-ACBD-646EEE2389ED}"/>
+                <a16:creationId xmlns:a16="http://schemas.microsoft.com/office/drawing/2014/main" id="{4BEC02FE-76F9-448A-A21A-1805D50719EC}"/>
               </a:ext>
             </a:extLst>
           </p:cNvPr>
@@ -6644,7 +6644,7 @@
           <p:cNvPr id="9" name="">
             <a:extLst xmlns:a="http://schemas.openxmlformats.org/drawingml/2006/main">
               <a:ext uri="{FF2B5EF4-FFF2-40B4-BE49-F238E27FC236}">
-                <a16:creationId xmlns:a16="http://schemas.microsoft.com/office/drawing/2014/main" id="{1CB3AD18-6725-4300-A84A-DF0B39D291DF}"/>
+                <a16:creationId xmlns:a16="http://schemas.microsoft.com/office/drawing/2014/main" id="{10FF7F12-67A8-4ADB-99FC-2CDBF5AC7ABE}"/>
               </a:ext>
             </a:extLst>
           </p:cNvPr>
@@ -6694,7 +6694,7 @@
           <p:cNvPr id="10" name="">
             <a:extLst xmlns:a="http://schemas.openxmlformats.org/drawingml/2006/main">
               <a:ext uri="{FF2B5EF4-FFF2-40B4-BE49-F238E27FC236}">
-                <a16:creationId xmlns:a16="http://schemas.microsoft.com/office/drawing/2014/main" id="{5D58CFD9-F069-48C1-B8B9-74F4286AC1CC}"/>
+                <a16:creationId xmlns:a16="http://schemas.microsoft.com/office/drawing/2014/main" id="{0608FA7F-4400-4A84-B425-C7B5F3046500}"/>
               </a:ext>
             </a:extLst>
           </p:cNvPr>
@@ -6744,7 +6744,7 @@
           <p:cNvPr id="11" name="">
             <a:extLst xmlns:a="http://schemas.openxmlformats.org/drawingml/2006/main">
               <a:ext uri="{FF2B5EF4-FFF2-40B4-BE49-F238E27FC236}">
-                <a16:creationId xmlns:a16="http://schemas.microsoft.com/office/drawing/2014/main" id="{5548847C-0290-4AE5-A807-F5784C8F4CC5}"/>
+                <a16:creationId xmlns:a16="http://schemas.microsoft.com/office/drawing/2014/main" id="{ABD4A0F0-65C7-4F50-BDB0-08EF099A78A7}"/>
               </a:ext>
             </a:extLst>
           </p:cNvPr>
@@ -6777,7 +6777,7 @@
           <p:cNvPr id="12" name="">
             <a:extLst xmlns:a="http://schemas.openxmlformats.org/drawingml/2006/main">
               <a:ext uri="{FF2B5EF4-FFF2-40B4-BE49-F238E27FC236}">
-                <a16:creationId xmlns:a16="http://schemas.microsoft.com/office/drawing/2014/main" id="{BD9164D8-5FED-4024-BCD0-E1C6506622BD}"/>
+                <a16:creationId xmlns:a16="http://schemas.microsoft.com/office/drawing/2014/main" id="{1CEB6E74-B55E-435D-8284-4A62666FF426}"/>
               </a:ext>
             </a:extLst>
           </p:cNvPr>
@@ -6810,7 +6810,7 @@
           <p:cNvPr id="13" name="">
             <a:extLst xmlns:a="http://schemas.openxmlformats.org/drawingml/2006/main">
               <a:ext uri="{FF2B5EF4-FFF2-40B4-BE49-F238E27FC236}">
-                <a16:creationId xmlns:a16="http://schemas.microsoft.com/office/drawing/2014/main" id="{F85B1E11-38DC-4F01-9812-869A24D23D55}"/>
+                <a16:creationId xmlns:a16="http://schemas.microsoft.com/office/drawing/2014/main" id="{B1D043D8-1964-486C-9CFD-8ED860650283}"/>
               </a:ext>
             </a:extLst>
           </p:cNvPr>
@@ -6860,7 +6860,7 @@
           <p:cNvPr id="14" name="">
             <a:extLst xmlns:a="http://schemas.openxmlformats.org/drawingml/2006/main">
               <a:ext uri="{FF2B5EF4-FFF2-40B4-BE49-F238E27FC236}">
-                <a16:creationId xmlns:a16="http://schemas.microsoft.com/office/drawing/2014/main" id="{480E8316-C898-4331-A48D-1282BF8554CE}"/>
+                <a16:creationId xmlns:a16="http://schemas.microsoft.com/office/drawing/2014/main" id="{2064693C-F4F8-47F5-924E-4ACB3694EB67}"/>
               </a:ext>
             </a:extLst>
           </p:cNvPr>
@@ -6910,7 +6910,7 @@
           <p:cNvPr id="15" name="">
             <a:extLst xmlns:a="http://schemas.openxmlformats.org/drawingml/2006/main">
               <a:ext uri="{FF2B5EF4-FFF2-40B4-BE49-F238E27FC236}">
-                <a16:creationId xmlns:a16="http://schemas.microsoft.com/office/drawing/2014/main" id="{3385C681-8A0C-4E3E-9F3C-F3AC8F3A00B8}"/>
+                <a16:creationId xmlns:a16="http://schemas.microsoft.com/office/drawing/2014/main" id="{381FAAFE-9676-4240-AB39-5C7AAF964B15}"/>
               </a:ext>
             </a:extLst>
           </p:cNvPr>
@@ -6943,7 +6943,7 @@
           <p:cNvPr id="16" name="">
             <a:extLst xmlns:a="http://schemas.openxmlformats.org/drawingml/2006/main">
               <a:ext uri="{FF2B5EF4-FFF2-40B4-BE49-F238E27FC236}">
-                <a16:creationId xmlns:a16="http://schemas.microsoft.com/office/drawing/2014/main" id="{F2B8CFC8-1940-430A-B7CE-5B1413AB44FE}"/>
+                <a16:creationId xmlns:a16="http://schemas.microsoft.com/office/drawing/2014/main" id="{A4C193F9-D788-4B1E-A637-1521041E4267}"/>
               </a:ext>
             </a:extLst>
           </p:cNvPr>
@@ -6976,7 +6976,7 @@
           <p:cNvPr id="17" name="">
             <a:extLst xmlns:a="http://schemas.openxmlformats.org/drawingml/2006/main">
               <a:ext uri="{FF2B5EF4-FFF2-40B4-BE49-F238E27FC236}">
-                <a16:creationId xmlns:a16="http://schemas.microsoft.com/office/drawing/2014/main" id="{1582BDDB-59F9-48A8-87AC-3D77EBCA0C5B}"/>
+                <a16:creationId xmlns:a16="http://schemas.microsoft.com/office/drawing/2014/main" id="{C654F1EF-4E19-4565-8C4E-79FA23ECD9BE}"/>
               </a:ext>
             </a:extLst>
           </p:cNvPr>
@@ -7026,7 +7026,7 @@
           <p:cNvPr id="18" name="">
             <a:extLst xmlns:a="http://schemas.openxmlformats.org/drawingml/2006/main">
               <a:ext uri="{FF2B5EF4-FFF2-40B4-BE49-F238E27FC236}">
-                <a16:creationId xmlns:a16="http://schemas.microsoft.com/office/drawing/2014/main" id="{65293460-59B8-42BE-844E-196DE445533E}"/>
+                <a16:creationId xmlns:a16="http://schemas.microsoft.com/office/drawing/2014/main" id="{8C900086-CCFD-4AC3-946F-4E29A8154189}"/>
               </a:ext>
             </a:extLst>
           </p:cNvPr>
@@ -7076,7 +7076,7 @@
           <p:cNvPr id="19" name="">
             <a:extLst xmlns:a="http://schemas.openxmlformats.org/drawingml/2006/main">
               <a:ext uri="{FF2B5EF4-FFF2-40B4-BE49-F238E27FC236}">
-                <a16:creationId xmlns:a16="http://schemas.microsoft.com/office/drawing/2014/main" id="{95777CE9-BCF4-4B54-A454-299872DF4CE7}"/>
+                <a16:creationId xmlns:a16="http://schemas.microsoft.com/office/drawing/2014/main" id="{D9B91F5B-E85A-4C7B-9866-52854BE7C4B8}"/>
               </a:ext>
             </a:extLst>
           </p:cNvPr>
@@ -7109,7 +7109,7 @@
           <p:cNvPr id="20" name="">
             <a:extLst xmlns:a="http://schemas.openxmlformats.org/drawingml/2006/main">
               <a:ext uri="{FF2B5EF4-FFF2-40B4-BE49-F238E27FC236}">
-                <a16:creationId xmlns:a16="http://schemas.microsoft.com/office/drawing/2014/main" id="{BC883743-4E34-4013-B25C-D037BB9FEEAB}"/>
+                <a16:creationId xmlns:a16="http://schemas.microsoft.com/office/drawing/2014/main" id="{B9D74AD8-F41E-4E9F-BB4C-9E7DE728040D}"/>
               </a:ext>
             </a:extLst>
           </p:cNvPr>
@@ -7142,7 +7142,7 @@
           <p:cNvPr id="21" name="">
             <a:extLst xmlns:a="http://schemas.openxmlformats.org/drawingml/2006/main">
               <a:ext uri="{FF2B5EF4-FFF2-40B4-BE49-F238E27FC236}">
-                <a16:creationId xmlns:a16="http://schemas.microsoft.com/office/drawing/2014/main" id="{01705005-C725-48F4-8015-13164A253284}"/>
+                <a16:creationId xmlns:a16="http://schemas.microsoft.com/office/drawing/2014/main" id="{3DCDBACB-0899-45DA-9BD8-CBCD0CEB0C79}"/>
               </a:ext>
             </a:extLst>
           </p:cNvPr>
@@ -7192,7 +7192,7 @@
           <p:cNvPr id="22" name="">
             <a:extLst xmlns:a="http://schemas.openxmlformats.org/drawingml/2006/main">
               <a:ext uri="{FF2B5EF4-FFF2-40B4-BE49-F238E27FC236}">
-                <a16:creationId xmlns:a16="http://schemas.microsoft.com/office/drawing/2014/main" id="{80ABB77E-49DB-4686-80FF-72EEF2D04B54}"/>
+                <a16:creationId xmlns:a16="http://schemas.microsoft.com/office/drawing/2014/main" id="{6CFCBDD2-C5C6-4F7E-9807-7BEEC405AAC3}"/>
               </a:ext>
             </a:extLst>
           </p:cNvPr>
@@ -7242,7 +7242,7 @@
           <p:cNvPr id="23" name="">
             <a:extLst xmlns:a="http://schemas.openxmlformats.org/drawingml/2006/main">
               <a:ext uri="{FF2B5EF4-FFF2-40B4-BE49-F238E27FC236}">
-                <a16:creationId xmlns:a16="http://schemas.microsoft.com/office/drawing/2014/main" id="{9CD7B891-BF2F-42ED-AF40-FCBEC4089744}"/>
+                <a16:creationId xmlns:a16="http://schemas.microsoft.com/office/drawing/2014/main" id="{E2A59551-180E-4D7F-AAA6-255210E5695F}"/>
               </a:ext>
             </a:extLst>
           </p:cNvPr>
@@ -7275,7 +7275,7 @@
           <p:cNvPr id="24" name="">
             <a:extLst xmlns:a="http://schemas.openxmlformats.org/drawingml/2006/main">
               <a:ext uri="{FF2B5EF4-FFF2-40B4-BE49-F238E27FC236}">
-                <a16:creationId xmlns:a16="http://schemas.microsoft.com/office/drawing/2014/main" id="{CB094005-D770-4B92-B0AF-38F999C13E15}"/>
+                <a16:creationId xmlns:a16="http://schemas.microsoft.com/office/drawing/2014/main" id="{592B2EAD-23BE-4FB7-88DC-BB59B295967C}"/>
               </a:ext>
             </a:extLst>
           </p:cNvPr>
@@ -7308,7 +7308,7 @@
           <p:cNvPr id="25" name="">
             <a:extLst xmlns:a="http://schemas.openxmlformats.org/drawingml/2006/main">
               <a:ext uri="{FF2B5EF4-FFF2-40B4-BE49-F238E27FC236}">
-                <a16:creationId xmlns:a16="http://schemas.microsoft.com/office/drawing/2014/main" id="{1BB59805-1328-45F6-B679-0B878B6DC62F}"/>
+                <a16:creationId xmlns:a16="http://schemas.microsoft.com/office/drawing/2014/main" id="{7CBDB100-9FF7-4362-92E6-B93C0B7115D7}"/>
               </a:ext>
             </a:extLst>
           </p:cNvPr>
@@ -7358,7 +7358,7 @@
           <p:cNvPr id="26" name="">
             <a:extLst xmlns:a="http://schemas.openxmlformats.org/drawingml/2006/main">
               <a:ext uri="{FF2B5EF4-FFF2-40B4-BE49-F238E27FC236}">
-                <a16:creationId xmlns:a16="http://schemas.microsoft.com/office/drawing/2014/main" id="{9522A0FD-2130-4666-926A-A1D0B89ED241}"/>
+                <a16:creationId xmlns:a16="http://schemas.microsoft.com/office/drawing/2014/main" id="{31654CFA-3AB4-4D58-AF44-CC2F21832CBC}"/>
               </a:ext>
             </a:extLst>
           </p:cNvPr>
@@ -7408,7 +7408,7 @@
           <p:cNvPr id="27" name="">
             <a:extLst xmlns:a="http://schemas.openxmlformats.org/drawingml/2006/main">
               <a:ext uri="{FF2B5EF4-FFF2-40B4-BE49-F238E27FC236}">
-                <a16:creationId xmlns:a16="http://schemas.microsoft.com/office/drawing/2014/main" id="{7DDC6D23-5F74-48A1-82C0-4689C2E5DF6A}"/>
+                <a16:creationId xmlns:a16="http://schemas.microsoft.com/office/drawing/2014/main" id="{7FE089E5-B51E-4A03-884C-2A93105C30B0}"/>
               </a:ext>
             </a:extLst>
           </p:cNvPr>
@@ -7441,7 +7441,7 @@
           <p:cNvPr id="28" name="">
             <a:extLst xmlns:a="http://schemas.openxmlformats.org/drawingml/2006/main">
               <a:ext uri="{FF2B5EF4-FFF2-40B4-BE49-F238E27FC236}">
-                <a16:creationId xmlns:a16="http://schemas.microsoft.com/office/drawing/2014/main" id="{BE79ADA5-2485-45DA-8C08-F84C66B71073}"/>
+                <a16:creationId xmlns:a16="http://schemas.microsoft.com/office/drawing/2014/main" id="{84C4707B-BEC7-4172-9A9D-A3A5E483DFF8}"/>
               </a:ext>
             </a:extLst>
           </p:cNvPr>
@@ -7474,7 +7474,7 @@
           <p:cNvPr id="29" name="">
             <a:extLst xmlns:a="http://schemas.openxmlformats.org/drawingml/2006/main">
               <a:ext uri="{FF2B5EF4-FFF2-40B4-BE49-F238E27FC236}">
-                <a16:creationId xmlns:a16="http://schemas.microsoft.com/office/drawing/2014/main" id="{A9BA43C3-A346-41AB-92AC-C0D93AA8BC27}"/>
+                <a16:creationId xmlns:a16="http://schemas.microsoft.com/office/drawing/2014/main" id="{E9ECD5E0-10DB-476D-8DC2-800A4E34F4F4}"/>
               </a:ext>
             </a:extLst>
           </p:cNvPr>
@@ -7524,7 +7524,7 @@
           <p:cNvPr id="30" name="">
             <a:extLst xmlns:a="http://schemas.openxmlformats.org/drawingml/2006/main">
               <a:ext uri="{FF2B5EF4-FFF2-40B4-BE49-F238E27FC236}">
-                <a16:creationId xmlns:a16="http://schemas.microsoft.com/office/drawing/2014/main" id="{1611CF27-9B51-4B76-AF1F-681463705F32}"/>
+                <a16:creationId xmlns:a16="http://schemas.microsoft.com/office/drawing/2014/main" id="{A21E47FD-88C1-4514-ACFB-37DDE6BC78B5}"/>
               </a:ext>
             </a:extLst>
           </p:cNvPr>
@@ -7574,7 +7574,7 @@
           <p:cNvPr id="31" name="">
             <a:extLst xmlns:a="http://schemas.openxmlformats.org/drawingml/2006/main">
               <a:ext uri="{FF2B5EF4-FFF2-40B4-BE49-F238E27FC236}">
-                <a16:creationId xmlns:a16="http://schemas.microsoft.com/office/drawing/2014/main" id="{0A8578ED-3C57-4D8C-8034-0643B0C76609}"/>
+                <a16:creationId xmlns:a16="http://schemas.microsoft.com/office/drawing/2014/main" id="{F6AF695F-D2B8-4177-A17C-754E0B158C03}"/>
               </a:ext>
             </a:extLst>
           </p:cNvPr>
@@ -7624,7 +7624,7 @@
           <p:cNvPr id="32" name="">
             <a:extLst xmlns:a="http://schemas.openxmlformats.org/drawingml/2006/main">
               <a:ext uri="{FF2B5EF4-FFF2-40B4-BE49-F238E27FC236}">
-                <a16:creationId xmlns:a16="http://schemas.microsoft.com/office/drawing/2014/main" id="{725E2109-071D-484C-AAF2-C02B17DD5668}"/>
+                <a16:creationId xmlns:a16="http://schemas.microsoft.com/office/drawing/2014/main" id="{9794340A-D8AB-44CE-B7F2-A3F1E62A2806}"/>
               </a:ext>
             </a:extLst>
           </p:cNvPr>
@@ -7672,7 +7672,7 @@
     </p:spTree>
     <p:extLst>
       <p:ext uri="{BB962C8B-B14F-4D97-AF65-F5344CB8AC3E}">
-        <p14:creationId xmlns:p14="http://schemas.microsoft.com/office/powerpoint/2010/main" val="1029392955"/>
+        <p14:creationId xmlns:p14="http://schemas.microsoft.com/office/powerpoint/2010/main" val="1732660588"/>
       </p:ext>
     </p:extLst>
   </p:cSld>
@@ -7703,7 +7703,7 @@
           <p:cNvPr id="1" name="">
             <a:extLst xmlns:a="http://schemas.openxmlformats.org/drawingml/2006/main">
               <a:ext uri="{FF2B5EF4-FFF2-40B4-BE49-F238E27FC236}">
-                <a16:creationId xmlns:a16="http://schemas.microsoft.com/office/drawing/2014/main" id="{96A8E7E3-4D86-4E7F-9332-929F9C03EA2C}"/>
+                <a16:creationId xmlns:a16="http://schemas.microsoft.com/office/drawing/2014/main" id="{8B19AEC3-0881-4219-B43E-9EF7FAD63216}"/>
               </a:ext>
             </a:extLst>
           </p:cNvPr>
@@ -7753,7 +7753,7 @@
           <p:cNvPr id="2" name="">
             <a:extLst xmlns:a="http://schemas.openxmlformats.org/drawingml/2006/main">
               <a:ext uri="{FF2B5EF4-FFF2-40B4-BE49-F238E27FC236}">
-                <a16:creationId xmlns:a16="http://schemas.microsoft.com/office/drawing/2014/main" id="{8CFF872F-3988-499A-9E63-13EE1E1FDD2E}"/>
+                <a16:creationId xmlns:a16="http://schemas.microsoft.com/office/drawing/2014/main" id="{E3E2F8B5-27A1-4AC0-9F09-FACB2D3E0A8D}"/>
               </a:ext>
             </a:extLst>
           </p:cNvPr>
@@ -7803,7 +7803,7 @@
           <p:cNvPr id="3" name="">
             <a:extLst xmlns:a="http://schemas.openxmlformats.org/drawingml/2006/main">
               <a:ext uri="{FF2B5EF4-FFF2-40B4-BE49-F238E27FC236}">
-                <a16:creationId xmlns:a16="http://schemas.microsoft.com/office/drawing/2014/main" id="{EC16DC21-60DD-474F-9F34-97972CB920D2}"/>
+                <a16:creationId xmlns:a16="http://schemas.microsoft.com/office/drawing/2014/main" id="{1815335C-0728-423A-B52C-65F73AFCD3F9}"/>
               </a:ext>
             </a:extLst>
           </p:cNvPr>
@@ -7836,7 +7836,7 @@
           <p:cNvPr id="4" name="">
             <a:extLst xmlns:a="http://schemas.openxmlformats.org/drawingml/2006/main">
               <a:ext uri="{FF2B5EF4-FFF2-40B4-BE49-F238E27FC236}">
-                <a16:creationId xmlns:a16="http://schemas.microsoft.com/office/drawing/2014/main" id="{D54CB843-1DA5-43C2-ABD4-C926ECA027F9}"/>
+                <a16:creationId xmlns:a16="http://schemas.microsoft.com/office/drawing/2014/main" id="{731E59D0-D3EF-4E91-A20D-426E8AB9FAA6}"/>
               </a:ext>
             </a:extLst>
           </p:cNvPr>
@@ -7869,7 +7869,7 @@
           <p:cNvPr id="5" name="">
             <a:extLst xmlns:a="http://schemas.openxmlformats.org/drawingml/2006/main">
               <a:ext uri="{FF2B5EF4-FFF2-40B4-BE49-F238E27FC236}">
-                <a16:creationId xmlns:a16="http://schemas.microsoft.com/office/drawing/2014/main" id="{A30FEA00-8424-4EA3-8F5D-336FA1EFBF94}"/>
+                <a16:creationId xmlns:a16="http://schemas.microsoft.com/office/drawing/2014/main" id="{A8D55C09-65A3-45BB-A4E6-9B20D84CF309}"/>
               </a:ext>
             </a:extLst>
           </p:cNvPr>
@@ -7919,7 +7919,7 @@
           <p:cNvPr id="6" name="">
             <a:extLst xmlns:a="http://schemas.openxmlformats.org/drawingml/2006/main">
               <a:ext uri="{FF2B5EF4-FFF2-40B4-BE49-F238E27FC236}">
-                <a16:creationId xmlns:a16="http://schemas.microsoft.com/office/drawing/2014/main" id="{DA1B916D-96E5-4681-ACD0-EB40F92240DD}"/>
+                <a16:creationId xmlns:a16="http://schemas.microsoft.com/office/drawing/2014/main" id="{91F50D13-898A-4D99-BE7D-ECAF8E0BF1C0}"/>
               </a:ext>
             </a:extLst>
           </p:cNvPr>
@@ -7969,7 +7969,7 @@
           <p:cNvPr id="7" name="">
             <a:extLst xmlns:a="http://schemas.openxmlformats.org/drawingml/2006/main">
               <a:ext uri="{FF2B5EF4-FFF2-40B4-BE49-F238E27FC236}">
-                <a16:creationId xmlns:a16="http://schemas.microsoft.com/office/drawing/2014/main" id="{77E92ABB-DD17-4003-8CB3-3355B63F669D}"/>
+                <a16:creationId xmlns:a16="http://schemas.microsoft.com/office/drawing/2014/main" id="{CC054030-A260-4BCC-9709-9BA9AA386289}"/>
               </a:ext>
             </a:extLst>
           </p:cNvPr>
@@ -8002,7 +8002,7 @@
           <p:cNvPr id="8" name="">
             <a:extLst xmlns:a="http://schemas.openxmlformats.org/drawingml/2006/main">
               <a:ext uri="{FF2B5EF4-FFF2-40B4-BE49-F238E27FC236}">
-                <a16:creationId xmlns:a16="http://schemas.microsoft.com/office/drawing/2014/main" id="{A0188926-FDCE-486B-BB97-4E66C9DA87BB}"/>
+                <a16:creationId xmlns:a16="http://schemas.microsoft.com/office/drawing/2014/main" id="{30FCADA8-6C31-4F11-B490-1C0B7D02DC32}"/>
               </a:ext>
             </a:extLst>
           </p:cNvPr>
@@ -8052,7 +8052,7 @@
           <p:cNvPr id="9" name="">
             <a:extLst xmlns:a="http://schemas.openxmlformats.org/drawingml/2006/main">
               <a:ext uri="{FF2B5EF4-FFF2-40B4-BE49-F238E27FC236}">
-                <a16:creationId xmlns:a16="http://schemas.microsoft.com/office/drawing/2014/main" id="{D03DD63E-09EC-4990-94A2-93C3744BC297}"/>
+                <a16:creationId xmlns:a16="http://schemas.microsoft.com/office/drawing/2014/main" id="{1902A976-E904-4ECC-8B77-164C2E3808D2}"/>
               </a:ext>
             </a:extLst>
           </p:cNvPr>
@@ -8102,7 +8102,7 @@
           <p:cNvPr id="10" name="">
             <a:extLst xmlns:a="http://schemas.openxmlformats.org/drawingml/2006/main">
               <a:ext uri="{FF2B5EF4-FFF2-40B4-BE49-F238E27FC236}">
-                <a16:creationId xmlns:a16="http://schemas.microsoft.com/office/drawing/2014/main" id="{EAAE7BD3-1FB9-4FD3-B746-A4A5BEFBD9B5}"/>
+                <a16:creationId xmlns:a16="http://schemas.microsoft.com/office/drawing/2014/main" id="{1B4CBE26-4716-4986-B7D0-37D77EA7B6C5}"/>
               </a:ext>
             </a:extLst>
           </p:cNvPr>
@@ -8135,7 +8135,7 @@
           <p:cNvPr id="11" name="">
             <a:extLst xmlns:a="http://schemas.openxmlformats.org/drawingml/2006/main">
               <a:ext uri="{FF2B5EF4-FFF2-40B4-BE49-F238E27FC236}">
-                <a16:creationId xmlns:a16="http://schemas.microsoft.com/office/drawing/2014/main" id="{D8D65972-C86F-4EDF-A2B8-ADF50B261D5B}"/>
+                <a16:creationId xmlns:a16="http://schemas.microsoft.com/office/drawing/2014/main" id="{25C98B8D-DDD4-43EF-9767-F46DA8D13433}"/>
               </a:ext>
             </a:extLst>
           </p:cNvPr>
@@ -8185,7 +8185,7 @@
           <p:cNvPr id="12" name="">
             <a:extLst xmlns:a="http://schemas.openxmlformats.org/drawingml/2006/main">
               <a:ext uri="{FF2B5EF4-FFF2-40B4-BE49-F238E27FC236}">
-                <a16:creationId xmlns:a16="http://schemas.microsoft.com/office/drawing/2014/main" id="{98DA5CB3-FF03-4706-8100-311614275A78}"/>
+                <a16:creationId xmlns:a16="http://schemas.microsoft.com/office/drawing/2014/main" id="{114CBA08-F55F-4906-97A3-46325457C57C}"/>
               </a:ext>
             </a:extLst>
           </p:cNvPr>
@@ -8225,7 +8225,7 @@
                   <a:srgbClr val="0A0A0A"/>
                 </a:solidFill>
               </a:rPr>
-              <a:t>MAP-style penalty loss; Adam completed run; SGD prepared as closer historical rerun</a:t>
+              <a:t>MAP-style penalty loss; Adam completed result; SGD supported for closer historical rerun</a:t>
             </a:r>
           </a:p>
         </p:txBody>
@@ -8235,7 +8235,7 @@
           <p:cNvPr id="13" name="">
             <a:extLst xmlns:a="http://schemas.openxmlformats.org/drawingml/2006/main">
               <a:ext uri="{FF2B5EF4-FFF2-40B4-BE49-F238E27FC236}">
-                <a16:creationId xmlns:a16="http://schemas.microsoft.com/office/drawing/2014/main" id="{E6220B4A-DE51-4616-A8DE-6B56444EC56C}"/>
+                <a16:creationId xmlns:a16="http://schemas.microsoft.com/office/drawing/2014/main" id="{BA0BC6FB-C000-4730-BF7A-664F35972CA3}"/>
               </a:ext>
             </a:extLst>
           </p:cNvPr>
@@ -8283,7 +8283,7 @@
     </p:spTree>
     <p:extLst>
       <p:ext uri="{BB962C8B-B14F-4D97-AF65-F5344CB8AC3E}">
-        <p14:creationId xmlns:p14="http://schemas.microsoft.com/office/powerpoint/2010/main" val="159554276"/>
+        <p14:creationId xmlns:p14="http://schemas.microsoft.com/office/powerpoint/2010/main" val="1908269455"/>
       </p:ext>
     </p:extLst>
   </p:cSld>
@@ -8314,7 +8314,7 @@
           <p:cNvPr id="1" name="">
             <a:extLst xmlns:a="http://schemas.openxmlformats.org/drawingml/2006/main">
               <a:ext uri="{FF2B5EF4-FFF2-40B4-BE49-F238E27FC236}">
-                <a16:creationId xmlns:a16="http://schemas.microsoft.com/office/drawing/2014/main" id="{1942FAC5-6A45-4942-9560-A7163FF8B892}"/>
+                <a16:creationId xmlns:a16="http://schemas.microsoft.com/office/drawing/2014/main" id="{7D9E8CA6-D9E8-48C7-955D-E44913108327}"/>
               </a:ext>
             </a:extLst>
           </p:cNvPr>
@@ -8364,7 +8364,7 @@
           <p:cNvPr id="2" name="">
             <a:extLst xmlns:a="http://schemas.openxmlformats.org/drawingml/2006/main">
               <a:ext uri="{FF2B5EF4-FFF2-40B4-BE49-F238E27FC236}">
-                <a16:creationId xmlns:a16="http://schemas.microsoft.com/office/drawing/2014/main" id="{BD6449AF-8043-41BD-AAAA-068CB2CC8241}"/>
+                <a16:creationId xmlns:a16="http://schemas.microsoft.com/office/drawing/2014/main" id="{CBED76CF-5ED5-4208-9442-4864973E72F2}"/>
               </a:ext>
             </a:extLst>
           </p:cNvPr>
@@ -8414,7 +8414,7 @@
           <p:cNvPr id="3" name="">
             <a:extLst xmlns:a="http://schemas.openxmlformats.org/drawingml/2006/main">
               <a:ext uri="{FF2B5EF4-FFF2-40B4-BE49-F238E27FC236}">
-                <a16:creationId xmlns:a16="http://schemas.microsoft.com/office/drawing/2014/main" id="{228386C0-2A04-441A-81DC-2F33F17F8CEA}"/>
+                <a16:creationId xmlns:a16="http://schemas.microsoft.com/office/drawing/2014/main" id="{D5D024E8-EB15-4B05-800C-4CC9D01C6381}"/>
               </a:ext>
             </a:extLst>
           </p:cNvPr>
@@ -8447,7 +8447,7 @@
           <p:cNvPr id="4" name="">
             <a:extLst xmlns:a="http://schemas.openxmlformats.org/drawingml/2006/main">
               <a:ext uri="{FF2B5EF4-FFF2-40B4-BE49-F238E27FC236}">
-                <a16:creationId xmlns:a16="http://schemas.microsoft.com/office/drawing/2014/main" id="{668EE266-D94E-4090-8FFF-9959F0EFFBA4}"/>
+                <a16:creationId xmlns:a16="http://schemas.microsoft.com/office/drawing/2014/main" id="{33AEC8EF-9A8D-473B-8D1B-6CB8200B1E4C}"/>
               </a:ext>
             </a:extLst>
           </p:cNvPr>
@@ -8480,7 +8480,7 @@
           <p:cNvPr id="5" name="">
             <a:extLst xmlns:a="http://schemas.openxmlformats.org/drawingml/2006/main">
               <a:ext uri="{FF2B5EF4-FFF2-40B4-BE49-F238E27FC236}">
-                <a16:creationId xmlns:a16="http://schemas.microsoft.com/office/drawing/2014/main" id="{44C580A4-0275-40B9-A0B4-A84F526E83BC}"/>
+                <a16:creationId xmlns:a16="http://schemas.microsoft.com/office/drawing/2014/main" id="{DA316D26-6116-4CE7-B1B7-82F69D6932A7}"/>
               </a:ext>
             </a:extLst>
           </p:cNvPr>
@@ -8530,7 +8530,7 @@
           <p:cNvPr id="6" name="">
             <a:extLst xmlns:a="http://schemas.openxmlformats.org/drawingml/2006/main">
               <a:ext uri="{FF2B5EF4-FFF2-40B4-BE49-F238E27FC236}">
-                <a16:creationId xmlns:a16="http://schemas.microsoft.com/office/drawing/2014/main" id="{37C17FB3-3CEE-4CD9-8D8B-9F3072687657}"/>
+                <a16:creationId xmlns:a16="http://schemas.microsoft.com/office/drawing/2014/main" id="{1CD9CC1A-A40E-4FF5-9BCB-B60D307A06BD}"/>
               </a:ext>
             </a:extLst>
           </p:cNvPr>
@@ -8580,7 +8580,7 @@
           <p:cNvPr id="7" name="">
             <a:extLst xmlns:a="http://schemas.openxmlformats.org/drawingml/2006/main">
               <a:ext uri="{FF2B5EF4-FFF2-40B4-BE49-F238E27FC236}">
-                <a16:creationId xmlns:a16="http://schemas.microsoft.com/office/drawing/2014/main" id="{1175A0A4-841D-46D9-8F3E-3DD05D90D87F}"/>
+                <a16:creationId xmlns:a16="http://schemas.microsoft.com/office/drawing/2014/main" id="{5DFEEFA4-1A79-4274-A9EF-CCD0434D7DA9}"/>
               </a:ext>
             </a:extLst>
           </p:cNvPr>
@@ -8630,7 +8630,7 @@
           <p:cNvPr id="8" name="">
             <a:extLst xmlns:a="http://schemas.openxmlformats.org/drawingml/2006/main">
               <a:ext uri="{FF2B5EF4-FFF2-40B4-BE49-F238E27FC236}">
-                <a16:creationId xmlns:a16="http://schemas.microsoft.com/office/drawing/2014/main" id="{C0E27237-20ED-42BE-A15D-FA279D52F6E6}"/>
+                <a16:creationId xmlns:a16="http://schemas.microsoft.com/office/drawing/2014/main" id="{E8F45190-235B-472E-AF6B-1ADE12FF06B8}"/>
               </a:ext>
             </a:extLst>
           </p:cNvPr>
@@ -8680,7 +8680,7 @@
           <p:cNvPr id="9" name="">
             <a:extLst xmlns:a="http://schemas.openxmlformats.org/drawingml/2006/main">
               <a:ext uri="{FF2B5EF4-FFF2-40B4-BE49-F238E27FC236}">
-                <a16:creationId xmlns:a16="http://schemas.microsoft.com/office/drawing/2014/main" id="{77D9D92D-869E-445C-AAD3-286D8095B023}"/>
+                <a16:creationId xmlns:a16="http://schemas.microsoft.com/office/drawing/2014/main" id="{E3D6FACA-D3AD-45C7-844A-378ACB492BDE}"/>
               </a:ext>
             </a:extLst>
           </p:cNvPr>
@@ -8730,7 +8730,7 @@
           <p:cNvPr id="10" name="">
             <a:extLst xmlns:a="http://schemas.openxmlformats.org/drawingml/2006/main">
               <a:ext uri="{FF2B5EF4-FFF2-40B4-BE49-F238E27FC236}">
-                <a16:creationId xmlns:a16="http://schemas.microsoft.com/office/drawing/2014/main" id="{D84B89EB-7913-4FF0-8EDD-EEF9A6BE7928}"/>
+                <a16:creationId xmlns:a16="http://schemas.microsoft.com/office/drawing/2014/main" id="{D5CE373F-3749-4D63-874C-A7746EE13AB5}"/>
               </a:ext>
             </a:extLst>
           </p:cNvPr>
@@ -8780,7 +8780,7 @@
           <p:cNvPr id="11" name="">
             <a:extLst xmlns:a="http://schemas.openxmlformats.org/drawingml/2006/main">
               <a:ext uri="{FF2B5EF4-FFF2-40B4-BE49-F238E27FC236}">
-                <a16:creationId xmlns:a16="http://schemas.microsoft.com/office/drawing/2014/main" id="{5EA9121D-C92D-4397-94AE-79366BBC3918}"/>
+                <a16:creationId xmlns:a16="http://schemas.microsoft.com/office/drawing/2014/main" id="{F3106066-8026-4A97-BB84-3D78D454EDBC}"/>
               </a:ext>
             </a:extLst>
           </p:cNvPr>
@@ -8830,7 +8830,7 @@
           <p:cNvPr id="12" name="">
             <a:extLst xmlns:a="http://schemas.openxmlformats.org/drawingml/2006/main">
               <a:ext uri="{FF2B5EF4-FFF2-40B4-BE49-F238E27FC236}">
-                <a16:creationId xmlns:a16="http://schemas.microsoft.com/office/drawing/2014/main" id="{4DFF586A-9796-4A4D-9ACA-062F64D32C12}"/>
+                <a16:creationId xmlns:a16="http://schemas.microsoft.com/office/drawing/2014/main" id="{DF6DF340-C851-422F-AFE8-605363E6BB7D}"/>
               </a:ext>
             </a:extLst>
           </p:cNvPr>
@@ -8880,7 +8880,7 @@
           <p:cNvPr id="13" name="">
             <a:extLst xmlns:a="http://schemas.openxmlformats.org/drawingml/2006/main">
               <a:ext uri="{FF2B5EF4-FFF2-40B4-BE49-F238E27FC236}">
-                <a16:creationId xmlns:a16="http://schemas.microsoft.com/office/drawing/2014/main" id="{CE458CD8-B163-4EA0-8268-759B45F82AD6}"/>
+                <a16:creationId xmlns:a16="http://schemas.microsoft.com/office/drawing/2014/main" id="{F48ACB5F-EF44-4358-B4D6-40664016731A}"/>
               </a:ext>
             </a:extLst>
           </p:cNvPr>
@@ -8920,7 +8920,7 @@
                   <a:srgbClr val="0A0A0A"/>
                 </a:solidFill>
               </a:rPr>
-              <a:t>Optimizer: Adam result, SGD rerun prepared | Loss: LeNet MAP-style RBF penalty | Seed: 42 | Device: CPU</a:t>
+              <a:t>Optimizer: Adam result; SGD supported | Loss: LeNet MAP-style RBF penalty | Seed: 42 | Device: CPU</a:t>
             </a:r>
           </a:p>
         </p:txBody>
@@ -8930,7 +8930,7 @@
           <p:cNvPr id="14" name="">
             <a:extLst xmlns:a="http://schemas.openxmlformats.org/drawingml/2006/main">
               <a:ext uri="{FF2B5EF4-FFF2-40B4-BE49-F238E27FC236}">
-                <a16:creationId xmlns:a16="http://schemas.microsoft.com/office/drawing/2014/main" id="{8E6FC627-0474-482F-9787-AE727161197E}"/>
+                <a16:creationId xmlns:a16="http://schemas.microsoft.com/office/drawing/2014/main" id="{01B041E6-F537-4C3A-A997-E611F997E5FF}"/>
               </a:ext>
             </a:extLst>
           </p:cNvPr>
@@ -8978,7 +8978,7 @@
     </p:spTree>
     <p:extLst>
       <p:ext uri="{BB962C8B-B14F-4D97-AF65-F5344CB8AC3E}">
-        <p14:creationId xmlns:p14="http://schemas.microsoft.com/office/powerpoint/2010/main" val="182845564"/>
+        <p14:creationId xmlns:p14="http://schemas.microsoft.com/office/powerpoint/2010/main" val="208282933"/>
       </p:ext>
     </p:extLst>
   </p:cSld>
@@ -9009,7 +9009,7 @@
           <p:cNvPr id="1" name="">
             <a:extLst xmlns:a="http://schemas.openxmlformats.org/drawingml/2006/main">
               <a:ext uri="{FF2B5EF4-FFF2-40B4-BE49-F238E27FC236}">
-                <a16:creationId xmlns:a16="http://schemas.microsoft.com/office/drawing/2014/main" id="{D02AE548-7DAB-49B2-91F5-03DE903789A8}"/>
+                <a16:creationId xmlns:a16="http://schemas.microsoft.com/office/drawing/2014/main" id="{5FABFE36-501D-411D-8976-4F1763310E04}"/>
               </a:ext>
             </a:extLst>
           </p:cNvPr>
@@ -9059,7 +9059,7 @@
           <p:cNvPr id="2" name="">
             <a:extLst xmlns:a="http://schemas.openxmlformats.org/drawingml/2006/main">
               <a:ext uri="{FF2B5EF4-FFF2-40B4-BE49-F238E27FC236}">
-                <a16:creationId xmlns:a16="http://schemas.microsoft.com/office/drawing/2014/main" id="{577F6FD2-153F-4198-AD32-2FB4B7595EB4}"/>
+                <a16:creationId xmlns:a16="http://schemas.microsoft.com/office/drawing/2014/main" id="{CFE83838-EB07-4009-861A-F83D3410B6C4}"/>
               </a:ext>
             </a:extLst>
           </p:cNvPr>
@@ -9109,7 +9109,7 @@
           <p:cNvPr id="3" name="">
             <a:extLst xmlns:a="http://schemas.openxmlformats.org/drawingml/2006/main">
               <a:ext uri="{FF2B5EF4-FFF2-40B4-BE49-F238E27FC236}">
-                <a16:creationId xmlns:a16="http://schemas.microsoft.com/office/drawing/2014/main" id="{633E66A4-AB53-4BFF-83A2-08ADE0B107BD}"/>
+                <a16:creationId xmlns:a16="http://schemas.microsoft.com/office/drawing/2014/main" id="{6948A324-EF3A-4BB0-8498-ABA9C6C4F682}"/>
               </a:ext>
             </a:extLst>
           </p:cNvPr>
@@ -9142,7 +9142,7 @@
           <p:cNvPr id="4" name="">
             <a:extLst xmlns:a="http://schemas.openxmlformats.org/drawingml/2006/main">
               <a:ext uri="{FF2B5EF4-FFF2-40B4-BE49-F238E27FC236}">
-                <a16:creationId xmlns:a16="http://schemas.microsoft.com/office/drawing/2014/main" id="{383056B5-21F9-425A-946D-9C17F0AD4EE3}"/>
+                <a16:creationId xmlns:a16="http://schemas.microsoft.com/office/drawing/2014/main" id="{4F7A3BCF-8D4B-42CD-99DB-0F210C7952FB}"/>
               </a:ext>
             </a:extLst>
           </p:cNvPr>
@@ -9192,7 +9192,7 @@
           <p:cNvPr id="5" name="">
             <a:extLst xmlns:a="http://schemas.openxmlformats.org/drawingml/2006/main">
               <a:ext uri="{FF2B5EF4-FFF2-40B4-BE49-F238E27FC236}">
-                <a16:creationId xmlns:a16="http://schemas.microsoft.com/office/drawing/2014/main" id="{8E1D4636-22E7-4E68-9A78-C6DDBEE02CD0}"/>
+                <a16:creationId xmlns:a16="http://schemas.microsoft.com/office/drawing/2014/main" id="{52AC0E5D-3043-4C15-86B2-94BA3E16E25C}"/>
               </a:ext>
             </a:extLst>
           </p:cNvPr>
@@ -9242,7 +9242,7 @@
           <p:cNvPr id="6" name="">
             <a:extLst xmlns:a="http://schemas.openxmlformats.org/drawingml/2006/main">
               <a:ext uri="{FF2B5EF4-FFF2-40B4-BE49-F238E27FC236}">
-                <a16:creationId xmlns:a16="http://schemas.microsoft.com/office/drawing/2014/main" id="{8A13E67E-D4C2-47A9-970B-4B058BA6B5E0}"/>
+                <a16:creationId xmlns:a16="http://schemas.microsoft.com/office/drawing/2014/main" id="{FFBB2A5F-E113-4164-A9C7-A0845C4DE9AF}"/>
               </a:ext>
             </a:extLst>
           </p:cNvPr>
@@ -9292,7 +9292,7 @@
           <p:cNvPr id="7" name="">
             <a:extLst xmlns:a="http://schemas.openxmlformats.org/drawingml/2006/main">
               <a:ext uri="{FF2B5EF4-FFF2-40B4-BE49-F238E27FC236}">
-                <a16:creationId xmlns:a16="http://schemas.microsoft.com/office/drawing/2014/main" id="{6FBF675B-2B96-4757-8B2A-551ADA33FA2C}"/>
+                <a16:creationId xmlns:a16="http://schemas.microsoft.com/office/drawing/2014/main" id="{577BF3D4-A45D-4C12-B910-92E375B2BCE8}"/>
               </a:ext>
             </a:extLst>
           </p:cNvPr>
@@ -9342,7 +9342,7 @@
           <p:cNvPr id="8" name="">
             <a:extLst xmlns:a="http://schemas.openxmlformats.org/drawingml/2006/main">
               <a:ext uri="{FF2B5EF4-FFF2-40B4-BE49-F238E27FC236}">
-                <a16:creationId xmlns:a16="http://schemas.microsoft.com/office/drawing/2014/main" id="{0A4159AC-33DA-4BCF-9757-F7DE8AD73D5F}"/>
+                <a16:creationId xmlns:a16="http://schemas.microsoft.com/office/drawing/2014/main" id="{D7FDA5E2-DF36-4131-A654-055821DB64C1}"/>
               </a:ext>
             </a:extLst>
           </p:cNvPr>
@@ -9392,7 +9392,7 @@
           <p:cNvPr id="9" name="">
             <a:extLst xmlns:a="http://schemas.openxmlformats.org/drawingml/2006/main">
               <a:ext uri="{FF2B5EF4-FFF2-40B4-BE49-F238E27FC236}">
-                <a16:creationId xmlns:a16="http://schemas.microsoft.com/office/drawing/2014/main" id="{DBDD1BEF-D8EF-45EB-9EE0-8DEFBB4D014A}"/>
+                <a16:creationId xmlns:a16="http://schemas.microsoft.com/office/drawing/2014/main" id="{E6B9F277-9CAF-46D7-BD12-1D3CA8DB600B}"/>
               </a:ext>
             </a:extLst>
           </p:cNvPr>
@@ -9442,7 +9442,7 @@
           <p:cNvPr id="10" name="">
             <a:extLst xmlns:a="http://schemas.openxmlformats.org/drawingml/2006/main">
               <a:ext uri="{FF2B5EF4-FFF2-40B4-BE49-F238E27FC236}">
-                <a16:creationId xmlns:a16="http://schemas.microsoft.com/office/drawing/2014/main" id="{C80125B9-B395-44E4-9B5D-C94494502CC0}"/>
+                <a16:creationId xmlns:a16="http://schemas.microsoft.com/office/drawing/2014/main" id="{BDC93E29-C2DA-4F12-BA73-C4F39B9FA2BA}"/>
               </a:ext>
             </a:extLst>
           </p:cNvPr>
@@ -9475,7 +9475,7 @@
           <p:cNvPr id="11" name="">
             <a:extLst xmlns:a="http://schemas.openxmlformats.org/drawingml/2006/main">
               <a:ext uri="{FF2B5EF4-FFF2-40B4-BE49-F238E27FC236}">
-                <a16:creationId xmlns:a16="http://schemas.microsoft.com/office/drawing/2014/main" id="{42E61FD3-81B2-41EC-AAC7-DD006F0F1C3B}"/>
+                <a16:creationId xmlns:a16="http://schemas.microsoft.com/office/drawing/2014/main" id="{89810343-FCA0-4542-9EF5-897A9ECA939E}"/>
               </a:ext>
             </a:extLst>
           </p:cNvPr>
@@ -9525,7 +9525,7 @@
           <p:cNvPr id="12" name="">
             <a:extLst xmlns:a="http://schemas.openxmlformats.org/drawingml/2006/main">
               <a:ext uri="{FF2B5EF4-FFF2-40B4-BE49-F238E27FC236}">
-                <a16:creationId xmlns:a16="http://schemas.microsoft.com/office/drawing/2014/main" id="{F1647747-759B-464C-A885-681EDA32A318}"/>
+                <a16:creationId xmlns:a16="http://schemas.microsoft.com/office/drawing/2014/main" id="{198C2209-CE01-4DA7-B34A-8A73CEBFCEC4}"/>
               </a:ext>
             </a:extLst>
           </p:cNvPr>
@@ -9573,7 +9573,7 @@
     </p:spTree>
     <p:extLst>
       <p:ext uri="{BB962C8B-B14F-4D97-AF65-F5344CB8AC3E}">
-        <p14:creationId xmlns:p14="http://schemas.microsoft.com/office/powerpoint/2010/main" val="235139866"/>
+        <p14:creationId xmlns:p14="http://schemas.microsoft.com/office/powerpoint/2010/main" val="973438351"/>
       </p:ext>
     </p:extLst>
   </p:cSld>
@@ -9604,7 +9604,7 @@
           <p:cNvPr id="1" name="">
             <a:extLst xmlns:a="http://schemas.openxmlformats.org/drawingml/2006/main">
               <a:ext uri="{FF2B5EF4-FFF2-40B4-BE49-F238E27FC236}">
-                <a16:creationId xmlns:a16="http://schemas.microsoft.com/office/drawing/2014/main" id="{9270DA0E-030A-419A-9232-9614110D0312}"/>
+                <a16:creationId xmlns:a16="http://schemas.microsoft.com/office/drawing/2014/main" id="{3B66E118-496A-4045-B711-5A5AD4522397}"/>
               </a:ext>
             </a:extLst>
           </p:cNvPr>
@@ -9654,7 +9654,7 @@
           <p:cNvPr id="2" name="">
             <a:extLst xmlns:a="http://schemas.openxmlformats.org/drawingml/2006/main">
               <a:ext uri="{FF2B5EF4-FFF2-40B4-BE49-F238E27FC236}">
-                <a16:creationId xmlns:a16="http://schemas.microsoft.com/office/drawing/2014/main" id="{7F21737F-F844-4531-962A-2B97F29F02D9}"/>
+                <a16:creationId xmlns:a16="http://schemas.microsoft.com/office/drawing/2014/main" id="{FF691265-004B-49A4-804C-440DEEE1C8F9}"/>
               </a:ext>
             </a:extLst>
           </p:cNvPr>
@@ -9704,7 +9704,7 @@
           <p:cNvPr id="3" name="">
             <a:extLst xmlns:a="http://schemas.openxmlformats.org/drawingml/2006/main">
               <a:ext uri="{FF2B5EF4-FFF2-40B4-BE49-F238E27FC236}">
-                <a16:creationId xmlns:a16="http://schemas.microsoft.com/office/drawing/2014/main" id="{BD6EA4C7-4813-458E-B1C7-A06B6B2B8CB5}"/>
+                <a16:creationId xmlns:a16="http://schemas.microsoft.com/office/drawing/2014/main" id="{39B06AA2-477A-4CC2-BE4D-3740F820EC8D}"/>
               </a:ext>
             </a:extLst>
           </p:cNvPr>
@@ -9741,7 +9741,7 @@
           <p:nvPr/>
         </p:nvPicPr>
         <p:blipFill>
-          <a:blip xmlns:r="http://schemas.openxmlformats.org/officeDocument/2006/relationships" xmlns:a="http://schemas.openxmlformats.org/drawingml/2006/main" r:embed="R8b83caf3ff80428e"/>
+          <a:blip xmlns:r="http://schemas.openxmlformats.org/officeDocument/2006/relationships" xmlns:a="http://schemas.openxmlformats.org/drawingml/2006/main" r:embed="Rf7dc9ed16d174dc2"/>
           <a:stretch xmlns:a="http://schemas.openxmlformats.org/drawingml/2006/main"/>
         </p:blipFill>
         <p:spPr>
@@ -9759,7 +9759,7 @@
           <p:cNvPr id="5" name="">
             <a:extLst xmlns:a="http://schemas.openxmlformats.org/drawingml/2006/main">
               <a:ext uri="{FF2B5EF4-FFF2-40B4-BE49-F238E27FC236}">
-                <a16:creationId xmlns:a16="http://schemas.microsoft.com/office/drawing/2014/main" id="{A1E88064-EC1C-4E4B-BE6B-53B7B441899A}"/>
+                <a16:creationId xmlns:a16="http://schemas.microsoft.com/office/drawing/2014/main" id="{DC879DC2-533D-4932-BABF-6176E24EF00C}"/>
               </a:ext>
             </a:extLst>
           </p:cNvPr>
@@ -9807,7 +9807,7 @@
     </p:spTree>
     <p:extLst>
       <p:ext uri="{BB962C8B-B14F-4D97-AF65-F5344CB8AC3E}">
-        <p14:creationId xmlns:p14="http://schemas.microsoft.com/office/powerpoint/2010/main" val="1002924157"/>
+        <p14:creationId xmlns:p14="http://schemas.microsoft.com/office/powerpoint/2010/main" val="1851885999"/>
       </p:ext>
     </p:extLst>
   </p:cSld>
@@ -9838,7 +9838,7 @@
           <p:cNvPr id="1" name="">
             <a:extLst xmlns:a="http://schemas.openxmlformats.org/drawingml/2006/main">
               <a:ext uri="{FF2B5EF4-FFF2-40B4-BE49-F238E27FC236}">
-                <a16:creationId xmlns:a16="http://schemas.microsoft.com/office/drawing/2014/main" id="{5B75A699-1223-4C26-A092-9732F9137CB2}"/>
+                <a16:creationId xmlns:a16="http://schemas.microsoft.com/office/drawing/2014/main" id="{3082260A-5D95-40C9-91EA-F82FB0BEAB1F}"/>
               </a:ext>
             </a:extLst>
           </p:cNvPr>
@@ -9888,7 +9888,7 @@
           <p:cNvPr id="2" name="">
             <a:extLst xmlns:a="http://schemas.openxmlformats.org/drawingml/2006/main">
               <a:ext uri="{FF2B5EF4-FFF2-40B4-BE49-F238E27FC236}">
-                <a16:creationId xmlns:a16="http://schemas.microsoft.com/office/drawing/2014/main" id="{7B8E2C9B-CCD7-4786-B398-3443427BC619}"/>
+                <a16:creationId xmlns:a16="http://schemas.microsoft.com/office/drawing/2014/main" id="{BAC2C035-D5F1-401A-9744-EF9C794B07A4}"/>
               </a:ext>
             </a:extLst>
           </p:cNvPr>
@@ -9938,7 +9938,7 @@
           <p:cNvPr id="3" name="">
             <a:extLst xmlns:a="http://schemas.openxmlformats.org/drawingml/2006/main">
               <a:ext uri="{FF2B5EF4-FFF2-40B4-BE49-F238E27FC236}">
-                <a16:creationId xmlns:a16="http://schemas.microsoft.com/office/drawing/2014/main" id="{E9280F71-F600-4403-A69A-D02E66CF06F9}"/>
+                <a16:creationId xmlns:a16="http://schemas.microsoft.com/office/drawing/2014/main" id="{E43FA927-3FD2-499D-8465-6CEED9D9E7B2}"/>
               </a:ext>
             </a:extLst>
           </p:cNvPr>
@@ -9975,7 +9975,7 @@
           <p:nvPr/>
         </p:nvPicPr>
         <p:blipFill>
-          <a:blip xmlns:r="http://schemas.openxmlformats.org/officeDocument/2006/relationships" xmlns:a="http://schemas.openxmlformats.org/drawingml/2006/main" r:embed="R9dbffcd1b67b4bcf"/>
+          <a:blip xmlns:r="http://schemas.openxmlformats.org/officeDocument/2006/relationships" xmlns:a="http://schemas.openxmlformats.org/drawingml/2006/main" r:embed="Rd191008085dd402d"/>
           <a:stretch xmlns:a="http://schemas.openxmlformats.org/drawingml/2006/main"/>
         </p:blipFill>
         <p:spPr>
@@ -9993,7 +9993,7 @@
           <p:cNvPr id="5" name="">
             <a:extLst xmlns:a="http://schemas.openxmlformats.org/drawingml/2006/main">
               <a:ext uri="{FF2B5EF4-FFF2-40B4-BE49-F238E27FC236}">
-                <a16:creationId xmlns:a16="http://schemas.microsoft.com/office/drawing/2014/main" id="{20464BB6-9334-455D-B677-BF1254C53DC8}"/>
+                <a16:creationId xmlns:a16="http://schemas.microsoft.com/office/drawing/2014/main" id="{330E2E1E-E15E-43A9-A8C2-FF6E02520F13}"/>
               </a:ext>
             </a:extLst>
           </p:cNvPr>
@@ -10026,7 +10026,7 @@
           <p:cNvPr id="6" name="">
             <a:extLst xmlns:a="http://schemas.openxmlformats.org/drawingml/2006/main">
               <a:ext uri="{FF2B5EF4-FFF2-40B4-BE49-F238E27FC236}">
-                <a16:creationId xmlns:a16="http://schemas.microsoft.com/office/drawing/2014/main" id="{AFA24D8A-A96E-49C0-BABB-1B9851EC5312}"/>
+                <a16:creationId xmlns:a16="http://schemas.microsoft.com/office/drawing/2014/main" id="{60FE9CC6-2A23-47D8-A848-F77AD987387C}"/>
               </a:ext>
             </a:extLst>
           </p:cNvPr>
@@ -10076,7 +10076,7 @@
           <p:cNvPr id="7" name="">
             <a:extLst xmlns:a="http://schemas.openxmlformats.org/drawingml/2006/main">
               <a:ext uri="{FF2B5EF4-FFF2-40B4-BE49-F238E27FC236}">
-                <a16:creationId xmlns:a16="http://schemas.microsoft.com/office/drawing/2014/main" id="{BDA813EF-654A-4AF9-9DBB-D8C10D845DC0}"/>
+                <a16:creationId xmlns:a16="http://schemas.microsoft.com/office/drawing/2014/main" id="{1913A72A-4F38-44D7-8785-F785DCDD60C8}"/>
               </a:ext>
             </a:extLst>
           </p:cNvPr>
@@ -10109,7 +10109,7 @@
           <p:cNvPr id="8" name="">
             <a:extLst xmlns:a="http://schemas.openxmlformats.org/drawingml/2006/main">
               <a:ext uri="{FF2B5EF4-FFF2-40B4-BE49-F238E27FC236}">
-                <a16:creationId xmlns:a16="http://schemas.microsoft.com/office/drawing/2014/main" id="{E85DEF96-A218-4FC1-9570-C2F6821AAB19}"/>
+                <a16:creationId xmlns:a16="http://schemas.microsoft.com/office/drawing/2014/main" id="{F77EECBC-C69B-46BB-B94F-97857EA474BD}"/>
               </a:ext>
             </a:extLst>
           </p:cNvPr>
@@ -10159,7 +10159,7 @@
           <p:cNvPr id="9" name="">
             <a:extLst xmlns:a="http://schemas.openxmlformats.org/drawingml/2006/main">
               <a:ext uri="{FF2B5EF4-FFF2-40B4-BE49-F238E27FC236}">
-                <a16:creationId xmlns:a16="http://schemas.microsoft.com/office/drawing/2014/main" id="{ACE1D274-D66F-4D04-BAFA-0D51D875BC87}"/>
+                <a16:creationId xmlns:a16="http://schemas.microsoft.com/office/drawing/2014/main" id="{B0B3F447-E978-46DE-AA85-86DA35AACEAC}"/>
               </a:ext>
             </a:extLst>
           </p:cNvPr>
@@ -10192,7 +10192,7 @@
           <p:cNvPr id="10" name="">
             <a:extLst xmlns:a="http://schemas.openxmlformats.org/drawingml/2006/main">
               <a:ext uri="{FF2B5EF4-FFF2-40B4-BE49-F238E27FC236}">
-                <a16:creationId xmlns:a16="http://schemas.microsoft.com/office/drawing/2014/main" id="{C29C5F8B-0DE7-4E18-AF69-3167F10C4C51}"/>
+                <a16:creationId xmlns:a16="http://schemas.microsoft.com/office/drawing/2014/main" id="{5980D4E1-AB6A-427B-96A6-352F614CA05C}"/>
               </a:ext>
             </a:extLst>
           </p:cNvPr>
@@ -10242,7 +10242,7 @@
           <p:cNvPr id="11" name="">
             <a:extLst xmlns:a="http://schemas.openxmlformats.org/drawingml/2006/main">
               <a:ext uri="{FF2B5EF4-FFF2-40B4-BE49-F238E27FC236}">
-                <a16:creationId xmlns:a16="http://schemas.microsoft.com/office/drawing/2014/main" id="{F7A6E7BD-8EC6-4BFD-833C-FB78F40F1DF8}"/>
+                <a16:creationId xmlns:a16="http://schemas.microsoft.com/office/drawing/2014/main" id="{DBED8D17-4FE2-4CE3-BC72-A89D2AC2CB0C}"/>
               </a:ext>
             </a:extLst>
           </p:cNvPr>
@@ -10275,7 +10275,7 @@
           <p:cNvPr id="12" name="">
             <a:extLst xmlns:a="http://schemas.openxmlformats.org/drawingml/2006/main">
               <a:ext uri="{FF2B5EF4-FFF2-40B4-BE49-F238E27FC236}">
-                <a16:creationId xmlns:a16="http://schemas.microsoft.com/office/drawing/2014/main" id="{83ABA25B-8509-4B67-98FF-4A8597E87DCB}"/>
+                <a16:creationId xmlns:a16="http://schemas.microsoft.com/office/drawing/2014/main" id="{E97DE3A3-D7B5-4749-B12D-FEC424B83D79}"/>
               </a:ext>
             </a:extLst>
           </p:cNvPr>
@@ -10325,7 +10325,7 @@
           <p:cNvPr id="13" name="">
             <a:extLst xmlns:a="http://schemas.openxmlformats.org/drawingml/2006/main">
               <a:ext uri="{FF2B5EF4-FFF2-40B4-BE49-F238E27FC236}">
-                <a16:creationId xmlns:a16="http://schemas.microsoft.com/office/drawing/2014/main" id="{D3B08F06-5F07-4FBA-B85C-D78A99D02B7F}"/>
+                <a16:creationId xmlns:a16="http://schemas.microsoft.com/office/drawing/2014/main" id="{F4075885-4304-4581-B0F1-48A113107253}"/>
               </a:ext>
             </a:extLst>
           </p:cNvPr>
@@ -10373,7 +10373,7 @@
     </p:spTree>
     <p:extLst>
       <p:ext uri="{BB962C8B-B14F-4D97-AF65-F5344CB8AC3E}">
-        <p14:creationId xmlns:p14="http://schemas.microsoft.com/office/powerpoint/2010/main" val="1559035857"/>
+        <p14:creationId xmlns:p14="http://schemas.microsoft.com/office/powerpoint/2010/main" val="1969399617"/>
       </p:ext>
     </p:extLst>
   </p:cSld>
@@ -10404,7 +10404,7 @@
           <p:cNvPr id="1" name="">
             <a:extLst xmlns:a="http://schemas.openxmlformats.org/drawingml/2006/main">
               <a:ext uri="{FF2B5EF4-FFF2-40B4-BE49-F238E27FC236}">
-                <a16:creationId xmlns:a16="http://schemas.microsoft.com/office/drawing/2014/main" id="{56950F0C-C03A-46D1-9050-F5451F18B41C}"/>
+                <a16:creationId xmlns:a16="http://schemas.microsoft.com/office/drawing/2014/main" id="{143373AD-0629-4F48-8449-35D3A7772259}"/>
               </a:ext>
             </a:extLst>
           </p:cNvPr>
@@ -10454,7 +10454,7 @@
           <p:cNvPr id="2" name="">
             <a:extLst xmlns:a="http://schemas.openxmlformats.org/drawingml/2006/main">
               <a:ext uri="{FF2B5EF4-FFF2-40B4-BE49-F238E27FC236}">
-                <a16:creationId xmlns:a16="http://schemas.microsoft.com/office/drawing/2014/main" id="{6A234DB8-5515-4222-B5E8-F8AB1D72C367}"/>
+                <a16:creationId xmlns:a16="http://schemas.microsoft.com/office/drawing/2014/main" id="{841B2469-B9E7-428C-A374-5948C227F7B7}"/>
               </a:ext>
             </a:extLst>
           </p:cNvPr>
@@ -10504,7 +10504,7 @@
           <p:cNvPr id="3" name="">
             <a:extLst xmlns:a="http://schemas.openxmlformats.org/drawingml/2006/main">
               <a:ext uri="{FF2B5EF4-FFF2-40B4-BE49-F238E27FC236}">
-                <a16:creationId xmlns:a16="http://schemas.microsoft.com/office/drawing/2014/main" id="{67AFD7F9-0F4B-465B-82F2-5B375FBE134E}"/>
+                <a16:creationId xmlns:a16="http://schemas.microsoft.com/office/drawing/2014/main" id="{5A6ADCDC-8E40-4035-8C0E-C16779D7549F}"/>
               </a:ext>
             </a:extLst>
           </p:cNvPr>
@@ -10537,7 +10537,7 @@
           <p:cNvPr id="4" name="">
             <a:extLst xmlns:a="http://schemas.openxmlformats.org/drawingml/2006/main">
               <a:ext uri="{FF2B5EF4-FFF2-40B4-BE49-F238E27FC236}">
-                <a16:creationId xmlns:a16="http://schemas.microsoft.com/office/drawing/2014/main" id="{944DCF53-152D-41AB-A0DB-A037E17D87EF}"/>
+                <a16:creationId xmlns:a16="http://schemas.microsoft.com/office/drawing/2014/main" id="{0611232D-42DC-4468-ACC8-78D2D0EC5A07}"/>
               </a:ext>
             </a:extLst>
           </p:cNvPr>
@@ -10570,7 +10570,7 @@
           <p:cNvPr id="5" name="">
             <a:extLst xmlns:a="http://schemas.openxmlformats.org/drawingml/2006/main">
               <a:ext uri="{FF2B5EF4-FFF2-40B4-BE49-F238E27FC236}">
-                <a16:creationId xmlns:a16="http://schemas.microsoft.com/office/drawing/2014/main" id="{22A17C11-F257-4B98-8D90-FF9369077A5A}"/>
+                <a16:creationId xmlns:a16="http://schemas.microsoft.com/office/drawing/2014/main" id="{7173DA1A-2C12-4DA9-B673-624606CE1B94}"/>
               </a:ext>
             </a:extLst>
           </p:cNvPr>
@@ -10620,7 +10620,7 @@
           <p:cNvPr id="6" name="">
             <a:extLst xmlns:a="http://schemas.openxmlformats.org/drawingml/2006/main">
               <a:ext uri="{FF2B5EF4-FFF2-40B4-BE49-F238E27FC236}">
-                <a16:creationId xmlns:a16="http://schemas.microsoft.com/office/drawing/2014/main" id="{A0100592-00C1-4AA9-8B1E-DA2F69ED4473}"/>
+                <a16:creationId xmlns:a16="http://schemas.microsoft.com/office/drawing/2014/main" id="{A55C0850-2B98-4915-8348-27232C1DB213}"/>
               </a:ext>
             </a:extLst>
           </p:cNvPr>
@@ -10670,7 +10670,7 @@
           <p:cNvPr id="7" name="">
             <a:extLst xmlns:a="http://schemas.openxmlformats.org/drawingml/2006/main">
               <a:ext uri="{FF2B5EF4-FFF2-40B4-BE49-F238E27FC236}">
-                <a16:creationId xmlns:a16="http://schemas.microsoft.com/office/drawing/2014/main" id="{36CDB05A-6765-45A0-8698-CA64E5D85749}"/>
+                <a16:creationId xmlns:a16="http://schemas.microsoft.com/office/drawing/2014/main" id="{692BB5D2-8836-4DD2-A06D-7DCFA4B072B6}"/>
               </a:ext>
             </a:extLst>
           </p:cNvPr>
@@ -10720,7 +10720,7 @@
           <p:cNvPr id="8" name="">
             <a:extLst xmlns:a="http://schemas.openxmlformats.org/drawingml/2006/main">
               <a:ext uri="{FF2B5EF4-FFF2-40B4-BE49-F238E27FC236}">
-                <a16:creationId xmlns:a16="http://schemas.microsoft.com/office/drawing/2014/main" id="{A07C87BA-2A45-428B-9FA1-BEA10EA35F04}"/>
+                <a16:creationId xmlns:a16="http://schemas.microsoft.com/office/drawing/2014/main" id="{98A3B8BD-04F8-4B21-80C1-A61C81BEF06F}"/>
               </a:ext>
             </a:extLst>
           </p:cNvPr>
@@ -10753,7 +10753,7 @@
           <p:cNvPr id="9" name="">
             <a:extLst xmlns:a="http://schemas.openxmlformats.org/drawingml/2006/main">
               <a:ext uri="{FF2B5EF4-FFF2-40B4-BE49-F238E27FC236}">
-                <a16:creationId xmlns:a16="http://schemas.microsoft.com/office/drawing/2014/main" id="{267207E1-87E5-4C2C-915F-333BD93A197E}"/>
+                <a16:creationId xmlns:a16="http://schemas.microsoft.com/office/drawing/2014/main" id="{0196DAF6-6395-4C07-987C-16CC5DCDFEFF}"/>
               </a:ext>
             </a:extLst>
           </p:cNvPr>
@@ -10803,7 +10803,7 @@
           <p:cNvPr id="10" name="">
             <a:extLst xmlns:a="http://schemas.openxmlformats.org/drawingml/2006/main">
               <a:ext uri="{FF2B5EF4-FFF2-40B4-BE49-F238E27FC236}">
-                <a16:creationId xmlns:a16="http://schemas.microsoft.com/office/drawing/2014/main" id="{72078780-01B3-4FAD-9B99-1DFBFCBBF9AB}"/>
+                <a16:creationId xmlns:a16="http://schemas.microsoft.com/office/drawing/2014/main" id="{8D49B61C-3B1F-43E7-897D-9F4198E1DECA}"/>
               </a:ext>
             </a:extLst>
           </p:cNvPr>
@@ -10836,7 +10836,7 @@
           <p:cNvPr id="11" name="">
             <a:extLst xmlns:a="http://schemas.openxmlformats.org/drawingml/2006/main">
               <a:ext uri="{FF2B5EF4-FFF2-40B4-BE49-F238E27FC236}">
-                <a16:creationId xmlns:a16="http://schemas.microsoft.com/office/drawing/2014/main" id="{16729542-58A9-4D3D-9E6A-34DA5C9F0944}"/>
+                <a16:creationId xmlns:a16="http://schemas.microsoft.com/office/drawing/2014/main" id="{E0630391-C40F-4335-9C89-F6A14A842C19}"/>
               </a:ext>
             </a:extLst>
           </p:cNvPr>
@@ -10886,7 +10886,7 @@
           <p:cNvPr id="12" name="">
             <a:extLst xmlns:a="http://schemas.openxmlformats.org/drawingml/2006/main">
               <a:ext uri="{FF2B5EF4-FFF2-40B4-BE49-F238E27FC236}">
-                <a16:creationId xmlns:a16="http://schemas.microsoft.com/office/drawing/2014/main" id="{9F6D94B8-96DD-49FA-9BB1-82CBCC8B1987}"/>
+                <a16:creationId xmlns:a16="http://schemas.microsoft.com/office/drawing/2014/main" id="{8BCA6D06-9D67-4CD4-AA4B-78A28141F6C5}"/>
               </a:ext>
             </a:extLst>
           </p:cNvPr>
@@ -10919,7 +10919,7 @@
           <p:cNvPr id="13" name="">
             <a:extLst xmlns:a="http://schemas.openxmlformats.org/drawingml/2006/main">
               <a:ext uri="{FF2B5EF4-FFF2-40B4-BE49-F238E27FC236}">
-                <a16:creationId xmlns:a16="http://schemas.microsoft.com/office/drawing/2014/main" id="{5B1FCE37-A260-4929-AA91-ABA2580D78C7}"/>
+                <a16:creationId xmlns:a16="http://schemas.microsoft.com/office/drawing/2014/main" id="{A344062C-CB6C-4711-B4D6-FCAAA3F80CDD}"/>
               </a:ext>
             </a:extLst>
           </p:cNvPr>
@@ -10969,7 +10969,7 @@
           <p:cNvPr id="14" name="">
             <a:extLst xmlns:a="http://schemas.openxmlformats.org/drawingml/2006/main">
               <a:ext uri="{FF2B5EF4-FFF2-40B4-BE49-F238E27FC236}">
-                <a16:creationId xmlns:a16="http://schemas.microsoft.com/office/drawing/2014/main" id="{D81C5F14-6478-4ABE-89F1-AF8F3983F199}"/>
+                <a16:creationId xmlns:a16="http://schemas.microsoft.com/office/drawing/2014/main" id="{0EA00035-8D6C-4165-9967-9D18DE8403B6}"/>
               </a:ext>
             </a:extLst>
           </p:cNvPr>
@@ -11002,7 +11002,7 @@
           <p:cNvPr id="15" name="">
             <a:extLst xmlns:a="http://schemas.openxmlformats.org/drawingml/2006/main">
               <a:ext uri="{FF2B5EF4-FFF2-40B4-BE49-F238E27FC236}">
-                <a16:creationId xmlns:a16="http://schemas.microsoft.com/office/drawing/2014/main" id="{A75EE2AA-6CBB-440B-BCFA-2A2514977D42}"/>
+                <a16:creationId xmlns:a16="http://schemas.microsoft.com/office/drawing/2014/main" id="{6778701E-B091-45AB-8779-BBEA9BD89CF4}"/>
               </a:ext>
             </a:extLst>
           </p:cNvPr>
@@ -11052,7 +11052,7 @@
           <p:cNvPr id="16" name="">
             <a:extLst xmlns:a="http://schemas.openxmlformats.org/drawingml/2006/main">
               <a:ext uri="{FF2B5EF4-FFF2-40B4-BE49-F238E27FC236}">
-                <a16:creationId xmlns:a16="http://schemas.microsoft.com/office/drawing/2014/main" id="{FAEED0E8-BC38-4BF6-88B3-23C2B446BFAB}"/>
+                <a16:creationId xmlns:a16="http://schemas.microsoft.com/office/drawing/2014/main" id="{A57A615C-5E72-439A-B046-8E49B9045EA1}"/>
               </a:ext>
             </a:extLst>
           </p:cNvPr>
@@ -11100,7 +11100,7 @@
     </p:spTree>
     <p:extLst>
       <p:ext uri="{BB962C8B-B14F-4D97-AF65-F5344CB8AC3E}">
-        <p14:creationId xmlns:p14="http://schemas.microsoft.com/office/powerpoint/2010/main" val="1260328791"/>
+        <p14:creationId xmlns:p14="http://schemas.microsoft.com/office/powerpoint/2010/main" val="817684311"/>
       </p:ext>
     </p:extLst>
   </p:cSld>

</xml_diff>

<commit_message>
Update materials for SGD LeNet results
</commit_message>
<xml_diff>
--- a/slides/LeNet5_MNIST_Final_Presentation.pptx
+++ b/slides/LeNet5_MNIST_Final_Presentation.pptx
@@ -2,25 +2,25 @@
 <file path=ppt/presentation.xml><?xml version="1.0" encoding="utf-8"?>
 <p:presentation xmlns:p="http://schemas.openxmlformats.org/presentationml/2006/main">
   <p:sldMasterIdLst>
-    <p:sldMasterId xmlns:r="http://schemas.openxmlformats.org/officeDocument/2006/relationships" id="2147483648" r:id="Rcd4979a7c3f64364"/>
+    <p:sldMasterId xmlns:r="http://schemas.openxmlformats.org/officeDocument/2006/relationships" id="2147483648" r:id="R1b4be83743a84d9c"/>
   </p:sldMasterIdLst>
   <p:notesMasterIdLst>
-    <p:notesMasterId xmlns:r="http://schemas.openxmlformats.org/officeDocument/2006/relationships" r:id="R2ba900624dc04c4f"/>
+    <p:notesMasterId xmlns:r="http://schemas.openxmlformats.org/officeDocument/2006/relationships" r:id="R2a8891ad96c6412f"/>
   </p:notesMasterIdLst>
   <p:sldIdLst>
-    <p:sldId xmlns:r="http://schemas.openxmlformats.org/officeDocument/2006/relationships" id="256" r:id="Rffccf592ce7f466e"/>
-    <p:sldId xmlns:r="http://schemas.openxmlformats.org/officeDocument/2006/relationships" id="257" r:id="R6a317b29fe914a08"/>
-    <p:sldId xmlns:r="http://schemas.openxmlformats.org/officeDocument/2006/relationships" id="258" r:id="R6833c4514d0e4f48"/>
-    <p:sldId xmlns:r="http://schemas.openxmlformats.org/officeDocument/2006/relationships" id="259" r:id="R3293c5352e724922"/>
-    <p:sldId xmlns:r="http://schemas.openxmlformats.org/officeDocument/2006/relationships" id="260" r:id="R91ecd9758a504d5e"/>
-    <p:sldId xmlns:r="http://schemas.openxmlformats.org/officeDocument/2006/relationships" id="261" r:id="R6c5d5488cf2b453f"/>
-    <p:sldId xmlns:r="http://schemas.openxmlformats.org/officeDocument/2006/relationships" id="262" r:id="R76b0ad92bf6647bc"/>
-    <p:sldId xmlns:r="http://schemas.openxmlformats.org/officeDocument/2006/relationships" id="263" r:id="R328e0ce72b6b4c07"/>
-    <p:sldId xmlns:r="http://schemas.openxmlformats.org/officeDocument/2006/relationships" id="264" r:id="R6e1d617449e3449d"/>
-    <p:sldId xmlns:r="http://schemas.openxmlformats.org/officeDocument/2006/relationships" id="265" r:id="R607c677f4f4e4797"/>
-    <p:sldId xmlns:r="http://schemas.openxmlformats.org/officeDocument/2006/relationships" id="266" r:id="R0ad80cbd5cf44bd7"/>
-    <p:sldId xmlns:r="http://schemas.openxmlformats.org/officeDocument/2006/relationships" id="267" r:id="Rab5c5287a8ac474c"/>
-    <p:sldId xmlns:r="http://schemas.openxmlformats.org/officeDocument/2006/relationships" id="268" r:id="R789801b788ab4896"/>
+    <p:sldId xmlns:r="http://schemas.openxmlformats.org/officeDocument/2006/relationships" id="256" r:id="R48a233222f6549d6"/>
+    <p:sldId xmlns:r="http://schemas.openxmlformats.org/officeDocument/2006/relationships" id="257" r:id="Rc845cdb4d9f2409f"/>
+    <p:sldId xmlns:r="http://schemas.openxmlformats.org/officeDocument/2006/relationships" id="258" r:id="Rdee7e1f128434a65"/>
+    <p:sldId xmlns:r="http://schemas.openxmlformats.org/officeDocument/2006/relationships" id="259" r:id="R499b28b0f7ea4678"/>
+    <p:sldId xmlns:r="http://schemas.openxmlformats.org/officeDocument/2006/relationships" id="260" r:id="Rc695cc1dba824bd0"/>
+    <p:sldId xmlns:r="http://schemas.openxmlformats.org/officeDocument/2006/relationships" id="261" r:id="Ra611f41b7eb44ed2"/>
+    <p:sldId xmlns:r="http://schemas.openxmlformats.org/officeDocument/2006/relationships" id="262" r:id="R0fb6bc3952db460c"/>
+    <p:sldId xmlns:r="http://schemas.openxmlformats.org/officeDocument/2006/relationships" id="263" r:id="R06b90373136a4f4c"/>
+    <p:sldId xmlns:r="http://schemas.openxmlformats.org/officeDocument/2006/relationships" id="264" r:id="R7a07ccf2cc1d4c27"/>
+    <p:sldId xmlns:r="http://schemas.openxmlformats.org/officeDocument/2006/relationships" id="265" r:id="Rdab061456d424eff"/>
+    <p:sldId xmlns:r="http://schemas.openxmlformats.org/officeDocument/2006/relationships" id="266" r:id="R11683f00db684dd6"/>
+    <p:sldId xmlns:r="http://schemas.openxmlformats.org/officeDocument/2006/relationships" id="267" r:id="R0192d9c563e64ded"/>
+    <p:sldId xmlns:r="http://schemas.openxmlformats.org/officeDocument/2006/relationships" id="268" r:id="R783e912518b24de0"/>
   </p:sldIdLst>
   <p:sldSz cx="12192000" cy="6858000"/>
   <p:notesSz cx="6858000" cy="9144000"/>
@@ -1405,7 +1405,7 @@
   </p:cSld>
   <p:clrMap bg1="lt1" tx1="dk1" bg2="lt2" tx2="dk2" accent1="accent1" accent2="accent2" accent3="accent3" accent4="accent4" accent5="accent5" accent6="accent6" hlink="hlink" folHlink="folHlink"/>
   <p:sldLayoutIdLst>
-    <p:sldLayoutId xmlns:r="http://schemas.openxmlformats.org/officeDocument/2006/relationships" id="2147483649" r:id="Rf6ad2f5db80a4f02"/>
+    <p:sldLayoutId xmlns:r="http://schemas.openxmlformats.org/officeDocument/2006/relationships" id="2147483649" r:id="R2355aa324b2f4277"/>
   </p:sldLayoutIdLst>
   <p:txStyles>
     <p:titleStyle>
@@ -1956,7 +1956,7 @@
           <p:cNvPr id="1" name="">
             <a:extLst xmlns:a="http://schemas.openxmlformats.org/drawingml/2006/main">
               <a:ext uri="{FF2B5EF4-FFF2-40B4-BE49-F238E27FC236}">
-                <a16:creationId xmlns:a16="http://schemas.microsoft.com/office/drawing/2014/main" id="{2C26B09A-0E7B-4643-81D6-1C588A0DEA1B}"/>
+                <a16:creationId xmlns:a16="http://schemas.microsoft.com/office/drawing/2014/main" id="{66B5C443-4AE2-4F78-9E06-ED0858D79A93}"/>
               </a:ext>
             </a:extLst>
           </p:cNvPr>
@@ -2006,7 +2006,7 @@
           <p:cNvPr id="2" name="">
             <a:extLst xmlns:a="http://schemas.openxmlformats.org/drawingml/2006/main">
               <a:ext uri="{FF2B5EF4-FFF2-40B4-BE49-F238E27FC236}">
-                <a16:creationId xmlns:a16="http://schemas.microsoft.com/office/drawing/2014/main" id="{B9114B7A-74BA-4249-BF2D-283503F11793}"/>
+                <a16:creationId xmlns:a16="http://schemas.microsoft.com/office/drawing/2014/main" id="{0AC8188E-2BB5-4DF7-AD29-B1CAE177EDA1}"/>
               </a:ext>
             </a:extLst>
           </p:cNvPr>
@@ -2056,7 +2056,7 @@
           <p:cNvPr id="3" name="">
             <a:extLst xmlns:a="http://schemas.openxmlformats.org/drawingml/2006/main">
               <a:ext uri="{FF2B5EF4-FFF2-40B4-BE49-F238E27FC236}">
-                <a16:creationId xmlns:a16="http://schemas.microsoft.com/office/drawing/2014/main" id="{26E22012-B88F-4200-9EFE-6F087FFB9CC7}"/>
+                <a16:creationId xmlns:a16="http://schemas.microsoft.com/office/drawing/2014/main" id="{4EBB2298-F11A-48F4-BC71-8CBBE9FCB8C5}"/>
               </a:ext>
             </a:extLst>
           </p:cNvPr>
@@ -2089,7 +2089,7 @@
           <p:cNvPr id="4" name="">
             <a:extLst xmlns:a="http://schemas.openxmlformats.org/drawingml/2006/main">
               <a:ext uri="{FF2B5EF4-FFF2-40B4-BE49-F238E27FC236}">
-                <a16:creationId xmlns:a16="http://schemas.microsoft.com/office/drawing/2014/main" id="{D6121D51-C186-4B12-82BC-B9518DBD0CA6}"/>
+                <a16:creationId xmlns:a16="http://schemas.microsoft.com/office/drawing/2014/main" id="{FA4A12F1-4A25-443F-A864-6B01BE5845B7}"/>
               </a:ext>
             </a:extLst>
           </p:cNvPr>
@@ -2129,7 +2129,7 @@
                   <a:srgbClr val="2F7D55"/>
                 </a:solidFill>
               </a:rPr>
-              <a:t>98.87%</a:t>
+              <a:t>98.93%</a:t>
             </a:r>
           </a:p>
         </p:txBody>
@@ -2139,7 +2139,7 @@
           <p:cNvPr id="5" name="">
             <a:extLst xmlns:a="http://schemas.openxmlformats.org/drawingml/2006/main">
               <a:ext uri="{FF2B5EF4-FFF2-40B4-BE49-F238E27FC236}">
-                <a16:creationId xmlns:a16="http://schemas.microsoft.com/office/drawing/2014/main" id="{AF061C78-C956-4AD1-B322-8BECF9BD8ED9}"/>
+                <a16:creationId xmlns:a16="http://schemas.microsoft.com/office/drawing/2014/main" id="{92F6F346-EAD7-4F22-A78B-3544B977D680}"/>
               </a:ext>
             </a:extLst>
           </p:cNvPr>
@@ -2189,7 +2189,7 @@
           <p:cNvPr id="6" name="">
             <a:extLst xmlns:a="http://schemas.openxmlformats.org/drawingml/2006/main">
               <a:ext uri="{FF2B5EF4-FFF2-40B4-BE49-F238E27FC236}">
-                <a16:creationId xmlns:a16="http://schemas.microsoft.com/office/drawing/2014/main" id="{2E307607-206E-4DE6-9236-86ECA2A27F60}"/>
+                <a16:creationId xmlns:a16="http://schemas.microsoft.com/office/drawing/2014/main" id="{F2A5EFEA-C25B-49F1-BA65-AEC636ADA36A}"/>
               </a:ext>
             </a:extLst>
           </p:cNvPr>
@@ -2222,7 +2222,7 @@
           <p:cNvPr id="7" name="">
             <a:extLst xmlns:a="http://schemas.openxmlformats.org/drawingml/2006/main">
               <a:ext uri="{FF2B5EF4-FFF2-40B4-BE49-F238E27FC236}">
-                <a16:creationId xmlns:a16="http://schemas.microsoft.com/office/drawing/2014/main" id="{E88D3C03-3FAE-40C9-BC86-BA051AC3D674}"/>
+                <a16:creationId xmlns:a16="http://schemas.microsoft.com/office/drawing/2014/main" id="{C7BE7466-CBBF-4027-B880-E3A0ED4B285E}"/>
               </a:ext>
             </a:extLst>
           </p:cNvPr>
@@ -2272,7 +2272,7 @@
           <p:cNvPr id="8" name="">
             <a:extLst xmlns:a="http://schemas.openxmlformats.org/drawingml/2006/main">
               <a:ext uri="{FF2B5EF4-FFF2-40B4-BE49-F238E27FC236}">
-                <a16:creationId xmlns:a16="http://schemas.microsoft.com/office/drawing/2014/main" id="{A4A2FE1C-55BE-41C3-A523-BEE51AE0BBC9}"/>
+                <a16:creationId xmlns:a16="http://schemas.microsoft.com/office/drawing/2014/main" id="{00727B85-7C31-4ACC-8A06-3DD3ED92B4D4}"/>
               </a:ext>
             </a:extLst>
           </p:cNvPr>
@@ -2322,7 +2322,7 @@
           <p:cNvPr id="9" name="">
             <a:extLst xmlns:a="http://schemas.openxmlformats.org/drawingml/2006/main">
               <a:ext uri="{FF2B5EF4-FFF2-40B4-BE49-F238E27FC236}">
-                <a16:creationId xmlns:a16="http://schemas.microsoft.com/office/drawing/2014/main" id="{7BB4E7EB-7B06-40E6-B744-D6585B5847B7}"/>
+                <a16:creationId xmlns:a16="http://schemas.microsoft.com/office/drawing/2014/main" id="{6D82D887-0BC9-450D-A82C-E9946A7E85EA}"/>
               </a:ext>
             </a:extLst>
           </p:cNvPr>
@@ -2355,7 +2355,7 @@
           <p:cNvPr id="10" name="">
             <a:extLst xmlns:a="http://schemas.openxmlformats.org/drawingml/2006/main">
               <a:ext uri="{FF2B5EF4-FFF2-40B4-BE49-F238E27FC236}">
-                <a16:creationId xmlns:a16="http://schemas.microsoft.com/office/drawing/2014/main" id="{2F211E83-7A00-4F67-BC42-991F8834E2D0}"/>
+                <a16:creationId xmlns:a16="http://schemas.microsoft.com/office/drawing/2014/main" id="{1E8C4BD1-B920-403E-BADD-77E3D223C0E1}"/>
               </a:ext>
             </a:extLst>
           </p:cNvPr>
@@ -2395,7 +2395,7 @@
                   <a:srgbClr val="2E6F9E"/>
                 </a:solidFill>
               </a:rPr>
-              <a:t>125.94s</a:t>
+              <a:t>146.91s</a:t>
             </a:r>
           </a:p>
         </p:txBody>
@@ -2405,7 +2405,7 @@
           <p:cNvPr id="11" name="">
             <a:extLst xmlns:a="http://schemas.openxmlformats.org/drawingml/2006/main">
               <a:ext uri="{FF2B5EF4-FFF2-40B4-BE49-F238E27FC236}">
-                <a16:creationId xmlns:a16="http://schemas.microsoft.com/office/drawing/2014/main" id="{0032D59F-510A-4327-BCA7-371302626939}"/>
+                <a16:creationId xmlns:a16="http://schemas.microsoft.com/office/drawing/2014/main" id="{098D4D8A-EEB1-4F7D-9152-3FC0668F8408}"/>
               </a:ext>
             </a:extLst>
           </p:cNvPr>
@@ -2455,7 +2455,7 @@
           <p:cNvPr id="12" name="">
             <a:extLst xmlns:a="http://schemas.openxmlformats.org/drawingml/2006/main">
               <a:ext uri="{FF2B5EF4-FFF2-40B4-BE49-F238E27FC236}">
-                <a16:creationId xmlns:a16="http://schemas.microsoft.com/office/drawing/2014/main" id="{9CB6A0E4-108D-4E5A-86BF-D79A91B8A67C}"/>
+                <a16:creationId xmlns:a16="http://schemas.microsoft.com/office/drawing/2014/main" id="{9A0AC92F-B60C-4F1A-B33A-6FF1AE7521E3}"/>
               </a:ext>
             </a:extLst>
           </p:cNvPr>
@@ -2505,7 +2505,7 @@
           <p:cNvPr id="13" name="">
             <a:extLst xmlns:a="http://schemas.openxmlformats.org/drawingml/2006/main">
               <a:ext uri="{FF2B5EF4-FFF2-40B4-BE49-F238E27FC236}">
-                <a16:creationId xmlns:a16="http://schemas.microsoft.com/office/drawing/2014/main" id="{EC6D4EE0-864E-46A0-BC05-C4F9016E09CB}"/>
+                <a16:creationId xmlns:a16="http://schemas.microsoft.com/office/drawing/2014/main" id="{7F8D6156-A1A1-40EC-A4C7-D44C0ABCFBAF}"/>
               </a:ext>
             </a:extLst>
           </p:cNvPr>
@@ -2553,7 +2553,7 @@
     </p:spTree>
     <p:extLst>
       <p:ext uri="{BB962C8B-B14F-4D97-AF65-F5344CB8AC3E}">
-        <p14:creationId xmlns:p14="http://schemas.microsoft.com/office/powerpoint/2010/main" val="251972631"/>
+        <p14:creationId xmlns:p14="http://schemas.microsoft.com/office/powerpoint/2010/main" val="740152545"/>
       </p:ext>
     </p:extLst>
   </p:cSld>
@@ -2584,7 +2584,7 @@
           <p:cNvPr id="1" name="">
             <a:extLst xmlns:a="http://schemas.openxmlformats.org/drawingml/2006/main">
               <a:ext uri="{FF2B5EF4-FFF2-40B4-BE49-F238E27FC236}">
-                <a16:creationId xmlns:a16="http://schemas.microsoft.com/office/drawing/2014/main" id="{665C7C6F-8DDD-44DF-8D00-C116226015FE}"/>
+                <a16:creationId xmlns:a16="http://schemas.microsoft.com/office/drawing/2014/main" id="{A06C4526-E3B4-4FBE-A612-77457D80EE6B}"/>
               </a:ext>
             </a:extLst>
           </p:cNvPr>
@@ -2634,7 +2634,7 @@
           <p:cNvPr id="2" name="">
             <a:extLst xmlns:a="http://schemas.openxmlformats.org/drawingml/2006/main">
               <a:ext uri="{FF2B5EF4-FFF2-40B4-BE49-F238E27FC236}">
-                <a16:creationId xmlns:a16="http://schemas.microsoft.com/office/drawing/2014/main" id="{1C98EFEA-5FB4-4D1C-96C5-459A39C6432C}"/>
+                <a16:creationId xmlns:a16="http://schemas.microsoft.com/office/drawing/2014/main" id="{7E2FB678-D5D1-46F5-B239-DB47785C34D8}"/>
               </a:ext>
             </a:extLst>
           </p:cNvPr>
@@ -2684,7 +2684,7 @@
           <p:cNvPr id="3" name="">
             <a:extLst xmlns:a="http://schemas.openxmlformats.org/drawingml/2006/main">
               <a:ext uri="{FF2B5EF4-FFF2-40B4-BE49-F238E27FC236}">
-                <a16:creationId xmlns:a16="http://schemas.microsoft.com/office/drawing/2014/main" id="{5970DAA3-F426-4744-9ADF-566CA71B1CD0}"/>
+                <a16:creationId xmlns:a16="http://schemas.microsoft.com/office/drawing/2014/main" id="{65A5E2AD-A784-4157-BC16-6CACB8D8F408}"/>
               </a:ext>
             </a:extLst>
           </p:cNvPr>
@@ -2717,7 +2717,7 @@
           <p:cNvPr id="4" name="">
             <a:extLst xmlns:a="http://schemas.openxmlformats.org/drawingml/2006/main">
               <a:ext uri="{FF2B5EF4-FFF2-40B4-BE49-F238E27FC236}">
-                <a16:creationId xmlns:a16="http://schemas.microsoft.com/office/drawing/2014/main" id="{FD6B8BC6-AF97-4698-AC65-9B1831A26DAB}"/>
+                <a16:creationId xmlns:a16="http://schemas.microsoft.com/office/drawing/2014/main" id="{192C24AB-C9BF-4F13-B227-ADB923DBC6F8}"/>
               </a:ext>
             </a:extLst>
           </p:cNvPr>
@@ -2750,7 +2750,7 @@
           <p:cNvPr id="5" name="">
             <a:extLst xmlns:a="http://schemas.openxmlformats.org/drawingml/2006/main">
               <a:ext uri="{FF2B5EF4-FFF2-40B4-BE49-F238E27FC236}">
-                <a16:creationId xmlns:a16="http://schemas.microsoft.com/office/drawing/2014/main" id="{7AF39683-8AC3-43AC-A950-0EFBAC1B98E9}"/>
+                <a16:creationId xmlns:a16="http://schemas.microsoft.com/office/drawing/2014/main" id="{F0F2CDCE-E068-4873-B612-0D1CBD8D1953}"/>
               </a:ext>
             </a:extLst>
           </p:cNvPr>
@@ -2800,7 +2800,7 @@
           <p:cNvPr id="6" name="">
             <a:extLst xmlns:a="http://schemas.openxmlformats.org/drawingml/2006/main">
               <a:ext uri="{FF2B5EF4-FFF2-40B4-BE49-F238E27FC236}">
-                <a16:creationId xmlns:a16="http://schemas.microsoft.com/office/drawing/2014/main" id="{8CE7323D-F5B9-48ED-932C-713FE486572C}"/>
+                <a16:creationId xmlns:a16="http://schemas.microsoft.com/office/drawing/2014/main" id="{08EFDAED-46D3-4758-B379-C0CA12B7BA53}"/>
               </a:ext>
             </a:extLst>
           </p:cNvPr>
@@ -2850,7 +2850,7 @@
           <p:cNvPr id="7" name="">
             <a:extLst xmlns:a="http://schemas.openxmlformats.org/drawingml/2006/main">
               <a:ext uri="{FF2B5EF4-FFF2-40B4-BE49-F238E27FC236}">
-                <a16:creationId xmlns:a16="http://schemas.microsoft.com/office/drawing/2014/main" id="{78C6A461-1B58-4114-8178-2C1A2ECE2BAC}"/>
+                <a16:creationId xmlns:a16="http://schemas.microsoft.com/office/drawing/2014/main" id="{8A5B465D-7B25-46A5-B578-DF17A060C943}"/>
               </a:ext>
             </a:extLst>
           </p:cNvPr>
@@ -2883,7 +2883,7 @@
           <p:cNvPr id="8" name="">
             <a:extLst xmlns:a="http://schemas.openxmlformats.org/drawingml/2006/main">
               <a:ext uri="{FF2B5EF4-FFF2-40B4-BE49-F238E27FC236}">
-                <a16:creationId xmlns:a16="http://schemas.microsoft.com/office/drawing/2014/main" id="{33A2BFC3-61F1-4A34-A611-67C8F1B8EB17}"/>
+                <a16:creationId xmlns:a16="http://schemas.microsoft.com/office/drawing/2014/main" id="{AE352E1C-9352-4AF4-A93E-1BE9341DF730}"/>
               </a:ext>
             </a:extLst>
           </p:cNvPr>
@@ -2923,7 +2923,7 @@
                   <a:srgbClr val="FF6B35"/>
                 </a:solidFill>
               </a:rPr>
-              <a:t>1.13%</a:t>
+              <a:t>1.07%</a:t>
             </a:r>
           </a:p>
         </p:txBody>
@@ -2933,7 +2933,7 @@
           <p:cNvPr id="9" name="">
             <a:extLst xmlns:a="http://schemas.openxmlformats.org/drawingml/2006/main">
               <a:ext uri="{FF2B5EF4-FFF2-40B4-BE49-F238E27FC236}">
-                <a16:creationId xmlns:a16="http://schemas.microsoft.com/office/drawing/2014/main" id="{95F79315-233C-4198-9E5B-4EEB2617AD3A}"/>
+                <a16:creationId xmlns:a16="http://schemas.microsoft.com/office/drawing/2014/main" id="{FB039DAB-DBA7-4896-B6D4-8B880F13981C}"/>
               </a:ext>
             </a:extLst>
           </p:cNvPr>
@@ -2983,7 +2983,7 @@
           <p:cNvPr id="10" name="">
             <a:extLst xmlns:a="http://schemas.openxmlformats.org/drawingml/2006/main">
               <a:ext uri="{FF2B5EF4-FFF2-40B4-BE49-F238E27FC236}">
-                <a16:creationId xmlns:a16="http://schemas.microsoft.com/office/drawing/2014/main" id="{61EF3891-5E2E-4408-9955-32A5E14D379D}"/>
+                <a16:creationId xmlns:a16="http://schemas.microsoft.com/office/drawing/2014/main" id="{DD943C97-0DC0-4E6A-8E2B-7914E79B5A92}"/>
               </a:ext>
             </a:extLst>
           </p:cNvPr>
@@ -3023,7 +3023,7 @@
                   <a:srgbClr val="0A0A0A"/>
                 </a:solidFill>
               </a:rPr>
-              <a:t>Gap: 0.18 points vs. the 0.95% run; 0.33 points vs. the best 0.8% figure.</a:t>
+              <a:t>Gap: 0.12 points vs. the 0.95% run; 0.27 points vs. the best 0.8% figure.</a:t>
             </a:r>
           </a:p>
         </p:txBody>
@@ -3033,7 +3033,7 @@
           <p:cNvPr id="11" name="">
             <a:extLst xmlns:a="http://schemas.openxmlformats.org/drawingml/2006/main">
               <a:ext uri="{FF2B5EF4-FFF2-40B4-BE49-F238E27FC236}">
-                <a16:creationId xmlns:a16="http://schemas.microsoft.com/office/drawing/2014/main" id="{9B59F5CE-BAD1-475D-BA5D-CE65210B7201}"/>
+                <a16:creationId xmlns:a16="http://schemas.microsoft.com/office/drawing/2014/main" id="{B5020156-9285-45A9-8D42-230C2EF0202B}"/>
               </a:ext>
             </a:extLst>
           </p:cNvPr>
@@ -3081,7 +3081,7 @@
     </p:spTree>
     <p:extLst>
       <p:ext uri="{BB962C8B-B14F-4D97-AF65-F5344CB8AC3E}">
-        <p14:creationId xmlns:p14="http://schemas.microsoft.com/office/powerpoint/2010/main" val="860592620"/>
+        <p14:creationId xmlns:p14="http://schemas.microsoft.com/office/powerpoint/2010/main" val="623579722"/>
       </p:ext>
     </p:extLst>
   </p:cSld>
@@ -3112,7 +3112,7 @@
           <p:cNvPr id="1" name="">
             <a:extLst xmlns:a="http://schemas.openxmlformats.org/drawingml/2006/main">
               <a:ext uri="{FF2B5EF4-FFF2-40B4-BE49-F238E27FC236}">
-                <a16:creationId xmlns:a16="http://schemas.microsoft.com/office/drawing/2014/main" id="{798244A6-A04A-42BF-96A1-6C85B4AC0358}"/>
+                <a16:creationId xmlns:a16="http://schemas.microsoft.com/office/drawing/2014/main" id="{30B3D687-A6BE-44FD-9E1E-522AD058E273}"/>
               </a:ext>
             </a:extLst>
           </p:cNvPr>
@@ -3162,7 +3162,7 @@
           <p:cNvPr id="2" name="">
             <a:extLst xmlns:a="http://schemas.openxmlformats.org/drawingml/2006/main">
               <a:ext uri="{FF2B5EF4-FFF2-40B4-BE49-F238E27FC236}">
-                <a16:creationId xmlns:a16="http://schemas.microsoft.com/office/drawing/2014/main" id="{722FAF71-347D-4CC3-AC60-A35C8B870F0C}"/>
+                <a16:creationId xmlns:a16="http://schemas.microsoft.com/office/drawing/2014/main" id="{FB2F31C4-71AC-48C8-84A1-52CB335633E5}"/>
               </a:ext>
             </a:extLst>
           </p:cNvPr>
@@ -3212,7 +3212,7 @@
           <p:cNvPr id="3" name="">
             <a:extLst xmlns:a="http://schemas.openxmlformats.org/drawingml/2006/main">
               <a:ext uri="{FF2B5EF4-FFF2-40B4-BE49-F238E27FC236}">
-                <a16:creationId xmlns:a16="http://schemas.microsoft.com/office/drawing/2014/main" id="{3967F073-83E0-42D9-8BF3-8E1FFF2BE47F}"/>
+                <a16:creationId xmlns:a16="http://schemas.microsoft.com/office/drawing/2014/main" id="{1AB71BDE-1AAD-497C-AFEF-F39267906EC0}"/>
               </a:ext>
             </a:extLst>
           </p:cNvPr>
@@ -3245,7 +3245,7 @@
           <p:cNvPr id="4" name="">
             <a:extLst xmlns:a="http://schemas.openxmlformats.org/drawingml/2006/main">
               <a:ext uri="{FF2B5EF4-FFF2-40B4-BE49-F238E27FC236}">
-                <a16:creationId xmlns:a16="http://schemas.microsoft.com/office/drawing/2014/main" id="{07C92B6C-DC3C-4480-B0DE-952A75461641}"/>
+                <a16:creationId xmlns:a16="http://schemas.microsoft.com/office/drawing/2014/main" id="{EC7946BD-0A7F-4477-B4B7-E39861862990}"/>
               </a:ext>
             </a:extLst>
           </p:cNvPr>
@@ -3278,7 +3278,7 @@
           <p:cNvPr id="5" name="">
             <a:extLst xmlns:a="http://schemas.openxmlformats.org/drawingml/2006/main">
               <a:ext uri="{FF2B5EF4-FFF2-40B4-BE49-F238E27FC236}">
-                <a16:creationId xmlns:a16="http://schemas.microsoft.com/office/drawing/2014/main" id="{C730E067-E262-47D2-A784-6A6A163F8043}"/>
+                <a16:creationId xmlns:a16="http://schemas.microsoft.com/office/drawing/2014/main" id="{BC07B2B0-C49F-4EE6-92E4-6004D02C3189}"/>
               </a:ext>
             </a:extLst>
           </p:cNvPr>
@@ -3328,7 +3328,7 @@
           <p:cNvPr id="6" name="">
             <a:extLst xmlns:a="http://schemas.openxmlformats.org/drawingml/2006/main">
               <a:ext uri="{FF2B5EF4-FFF2-40B4-BE49-F238E27FC236}">
-                <a16:creationId xmlns:a16="http://schemas.microsoft.com/office/drawing/2014/main" id="{D591CDD3-C6EB-4176-BAD0-12605E0DCCA6}"/>
+                <a16:creationId xmlns:a16="http://schemas.microsoft.com/office/drawing/2014/main" id="{D07861C2-5FE0-4EFD-9983-440F2CDC87C3}"/>
               </a:ext>
             </a:extLst>
           </p:cNvPr>
@@ -3446,7 +3446,7 @@
           <p:cNvPr id="7" name="">
             <a:extLst xmlns:a="http://schemas.openxmlformats.org/drawingml/2006/main">
               <a:ext uri="{FF2B5EF4-FFF2-40B4-BE49-F238E27FC236}">
-                <a16:creationId xmlns:a16="http://schemas.microsoft.com/office/drawing/2014/main" id="{ED7A00FF-F0C3-47E5-96F3-8E7F2F17C2C7}"/>
+                <a16:creationId xmlns:a16="http://schemas.microsoft.com/office/drawing/2014/main" id="{C3DCC377-AAB5-4E48-962D-29230FE83CCE}"/>
               </a:ext>
             </a:extLst>
           </p:cNvPr>
@@ -3479,7 +3479,7 @@
           <p:cNvPr id="8" name="">
             <a:extLst xmlns:a="http://schemas.openxmlformats.org/drawingml/2006/main">
               <a:ext uri="{FF2B5EF4-FFF2-40B4-BE49-F238E27FC236}">
-                <a16:creationId xmlns:a16="http://schemas.microsoft.com/office/drawing/2014/main" id="{8624BFA6-9CD7-48F8-BBCC-70DA86A379BD}"/>
+                <a16:creationId xmlns:a16="http://schemas.microsoft.com/office/drawing/2014/main" id="{01EEC4E4-CC5B-47DD-B922-B6981A1B5424}"/>
               </a:ext>
             </a:extLst>
           </p:cNvPr>
@@ -3529,7 +3529,7 @@
           <p:cNvPr id="9" name="">
             <a:extLst xmlns:a="http://schemas.openxmlformats.org/drawingml/2006/main">
               <a:ext uri="{FF2B5EF4-FFF2-40B4-BE49-F238E27FC236}">
-                <a16:creationId xmlns:a16="http://schemas.microsoft.com/office/drawing/2014/main" id="{28856264-2A83-4F42-9170-B017DED84260}"/>
+                <a16:creationId xmlns:a16="http://schemas.microsoft.com/office/drawing/2014/main" id="{9555914E-642E-447C-9D3D-C39FBD3E4869}"/>
               </a:ext>
             </a:extLst>
           </p:cNvPr>
@@ -3637,7 +3637,7 @@
                   <a:srgbClr val="0A0A0A"/>
                 </a:solidFill>
               </a:rPr>
-              <a:t>Adam result; SGD supported</a:t>
+              <a:t>SGD optimizer</a:t>
             </a:r>
           </a:p>
         </p:txBody>
@@ -3647,7 +3647,7 @@
           <p:cNvPr id="10" name="">
             <a:extLst xmlns:a="http://schemas.openxmlformats.org/drawingml/2006/main">
               <a:ext uri="{FF2B5EF4-FFF2-40B4-BE49-F238E27FC236}">
-                <a16:creationId xmlns:a16="http://schemas.microsoft.com/office/drawing/2014/main" id="{24A47521-12A5-409E-977D-ECD9833DA506}"/>
+                <a16:creationId xmlns:a16="http://schemas.microsoft.com/office/drawing/2014/main" id="{D645269D-B497-4DC4-B5A6-70079E5AC109}"/>
               </a:ext>
             </a:extLst>
           </p:cNvPr>
@@ -3680,7 +3680,7 @@
           <p:cNvPr id="11" name="">
             <a:extLst xmlns:a="http://schemas.openxmlformats.org/drawingml/2006/main">
               <a:ext uri="{FF2B5EF4-FFF2-40B4-BE49-F238E27FC236}">
-                <a16:creationId xmlns:a16="http://schemas.microsoft.com/office/drawing/2014/main" id="{C17FFA07-F97C-4E57-8F2D-471B9A6C2A83}"/>
+                <a16:creationId xmlns:a16="http://schemas.microsoft.com/office/drawing/2014/main" id="{08625DAF-B13B-4183-AD75-CF3FA309C277}"/>
               </a:ext>
             </a:extLst>
           </p:cNvPr>
@@ -3730,7 +3730,7 @@
           <p:cNvPr id="12" name="">
             <a:extLst xmlns:a="http://schemas.openxmlformats.org/drawingml/2006/main">
               <a:ext uri="{FF2B5EF4-FFF2-40B4-BE49-F238E27FC236}">
-                <a16:creationId xmlns:a16="http://schemas.microsoft.com/office/drawing/2014/main" id="{0452F4CE-BDF2-4B0B-9A66-1ED7CDEF2A08}"/>
+                <a16:creationId xmlns:a16="http://schemas.microsoft.com/office/drawing/2014/main" id="{00C8D9DF-653F-4A19-82BE-AD1329F05FB5}"/>
               </a:ext>
             </a:extLst>
           </p:cNvPr>
@@ -3848,7 +3848,7 @@
           <p:cNvPr id="13" name="">
             <a:extLst xmlns:a="http://schemas.openxmlformats.org/drawingml/2006/main">
               <a:ext uri="{FF2B5EF4-FFF2-40B4-BE49-F238E27FC236}">
-                <a16:creationId xmlns:a16="http://schemas.microsoft.com/office/drawing/2014/main" id="{577D9DD4-F826-4993-81EE-E3B47A05A4CB}"/>
+                <a16:creationId xmlns:a16="http://schemas.microsoft.com/office/drawing/2014/main" id="{1AB42C13-6E58-4828-9FA9-5434EA2819C8}"/>
               </a:ext>
             </a:extLst>
           </p:cNvPr>
@@ -3896,7 +3896,7 @@
     </p:spTree>
     <p:extLst>
       <p:ext uri="{BB962C8B-B14F-4D97-AF65-F5344CB8AC3E}">
-        <p14:creationId xmlns:p14="http://schemas.microsoft.com/office/powerpoint/2010/main" val="242096155"/>
+        <p14:creationId xmlns:p14="http://schemas.microsoft.com/office/powerpoint/2010/main" val="275613371"/>
       </p:ext>
     </p:extLst>
   </p:cSld>
@@ -3927,7 +3927,7 @@
           <p:cNvPr id="1" name="">
             <a:extLst xmlns:a="http://schemas.openxmlformats.org/drawingml/2006/main">
               <a:ext uri="{FF2B5EF4-FFF2-40B4-BE49-F238E27FC236}">
-                <a16:creationId xmlns:a16="http://schemas.microsoft.com/office/drawing/2014/main" id="{2E275A6F-5CC1-4A1B-8413-C3051E103178}"/>
+                <a16:creationId xmlns:a16="http://schemas.microsoft.com/office/drawing/2014/main" id="{9D3E83AC-2D57-4C60-B1B3-4957C655A5E0}"/>
               </a:ext>
             </a:extLst>
           </p:cNvPr>
@@ -3977,7 +3977,7 @@
           <p:cNvPr id="2" name="">
             <a:extLst xmlns:a="http://schemas.openxmlformats.org/drawingml/2006/main">
               <a:ext uri="{FF2B5EF4-FFF2-40B4-BE49-F238E27FC236}">
-                <a16:creationId xmlns:a16="http://schemas.microsoft.com/office/drawing/2014/main" id="{1F1C1198-1A93-4BF3-9D68-F3C22B71F611}"/>
+                <a16:creationId xmlns:a16="http://schemas.microsoft.com/office/drawing/2014/main" id="{087D74DC-9080-40C5-A82C-E04AF02CEA0E}"/>
               </a:ext>
             </a:extLst>
           </p:cNvPr>
@@ -4017,7 +4017,7 @@
                   <a:srgbClr val="555555"/>
                 </a:solidFill>
               </a:rPr>
-              <a:t>The modern baseline improves accuracy by 0.31 percentage points, but with a much larger model.</a:t>
+              <a:t>The modern baseline improves accuracy by 0.25 percentage points, but with a much larger model.</a:t>
             </a:r>
           </a:p>
         </p:txBody>
@@ -4027,7 +4027,7 @@
           <p:cNvPr id="3" name="">
             <a:extLst xmlns:a="http://schemas.openxmlformats.org/drawingml/2006/main">
               <a:ext uri="{FF2B5EF4-FFF2-40B4-BE49-F238E27FC236}">
-                <a16:creationId xmlns:a16="http://schemas.microsoft.com/office/drawing/2014/main" id="{0957888C-FDA6-4236-9EDB-75A671B348BC}"/>
+                <a16:creationId xmlns:a16="http://schemas.microsoft.com/office/drawing/2014/main" id="{EFAA81D4-10D7-4727-A1B6-02431C329058}"/>
               </a:ext>
             </a:extLst>
           </p:cNvPr>
@@ -4060,7 +4060,7 @@
           <p:cNvPr id="4" name="">
             <a:extLst xmlns:a="http://schemas.openxmlformats.org/drawingml/2006/main">
               <a:ext uri="{FF2B5EF4-FFF2-40B4-BE49-F238E27FC236}">
-                <a16:creationId xmlns:a16="http://schemas.microsoft.com/office/drawing/2014/main" id="{527C75CB-E362-4EE5-A9C9-FF5910B99676}"/>
+                <a16:creationId xmlns:a16="http://schemas.microsoft.com/office/drawing/2014/main" id="{D59BC182-64CE-47C6-BE26-47B67CF43225}"/>
               </a:ext>
             </a:extLst>
           </p:cNvPr>
@@ -4093,7 +4093,7 @@
           <p:cNvPr id="5" name="">
             <a:extLst xmlns:a="http://schemas.openxmlformats.org/drawingml/2006/main">
               <a:ext uri="{FF2B5EF4-FFF2-40B4-BE49-F238E27FC236}">
-                <a16:creationId xmlns:a16="http://schemas.microsoft.com/office/drawing/2014/main" id="{CCD78826-C2A1-4FCC-BF50-540EA9EE67D8}"/>
+                <a16:creationId xmlns:a16="http://schemas.microsoft.com/office/drawing/2014/main" id="{4775DD47-A5FE-4D02-8F76-D67A01767DD1}"/>
               </a:ext>
             </a:extLst>
           </p:cNvPr>
@@ -4143,7 +4143,7 @@
           <p:cNvPr id="6" name="">
             <a:extLst xmlns:a="http://schemas.openxmlformats.org/drawingml/2006/main">
               <a:ext uri="{FF2B5EF4-FFF2-40B4-BE49-F238E27FC236}">
-                <a16:creationId xmlns:a16="http://schemas.microsoft.com/office/drawing/2014/main" id="{764030BC-7220-451C-9B4C-EB46CA12253E}"/>
+                <a16:creationId xmlns:a16="http://schemas.microsoft.com/office/drawing/2014/main" id="{AC2334AE-E47C-49D0-B9D4-3C1509FE5BB9}"/>
               </a:ext>
             </a:extLst>
           </p:cNvPr>
@@ -4176,7 +4176,7 @@
           <p:cNvPr id="7" name="">
             <a:extLst xmlns:a="http://schemas.openxmlformats.org/drawingml/2006/main">
               <a:ext uri="{FF2B5EF4-FFF2-40B4-BE49-F238E27FC236}">
-                <a16:creationId xmlns:a16="http://schemas.microsoft.com/office/drawing/2014/main" id="{5BE07D7C-5D36-42AA-8A66-F5BBFB73728F}"/>
+                <a16:creationId xmlns:a16="http://schemas.microsoft.com/office/drawing/2014/main" id="{957F5BFD-D2E4-452E-960B-38DA7D1AB720}"/>
               </a:ext>
             </a:extLst>
           </p:cNvPr>
@@ -4216,7 +4216,7 @@
                   <a:srgbClr val="0A0A0A"/>
                 </a:solidFill>
               </a:rPr>
-              <a:t>98.87% test accuracy</a:t>
+              <a:t>98.93% test accuracy</a:t>
             </a:r>
           </a:p>
         </p:txBody>
@@ -4226,7 +4226,7 @@
           <p:cNvPr id="8" name="">
             <a:extLst xmlns:a="http://schemas.openxmlformats.org/drawingml/2006/main">
               <a:ext uri="{FF2B5EF4-FFF2-40B4-BE49-F238E27FC236}">
-                <a16:creationId xmlns:a16="http://schemas.microsoft.com/office/drawing/2014/main" id="{364DD274-8E79-459C-A535-FCBE48880BD8}"/>
+                <a16:creationId xmlns:a16="http://schemas.microsoft.com/office/drawing/2014/main" id="{F3ACA60C-8C8F-442A-8AC8-A79C7A2EF196}"/>
               </a:ext>
             </a:extLst>
           </p:cNvPr>
@@ -4259,7 +4259,7 @@
           <p:cNvPr id="9" name="">
             <a:extLst xmlns:a="http://schemas.openxmlformats.org/drawingml/2006/main">
               <a:ext uri="{FF2B5EF4-FFF2-40B4-BE49-F238E27FC236}">
-                <a16:creationId xmlns:a16="http://schemas.microsoft.com/office/drawing/2014/main" id="{73A2BEB2-BD49-43EF-A221-C18C7CC53F31}"/>
+                <a16:creationId xmlns:a16="http://schemas.microsoft.com/office/drawing/2014/main" id="{74209925-B405-4763-AB31-90D356C2ECB7}"/>
               </a:ext>
             </a:extLst>
           </p:cNvPr>
@@ -4309,7 +4309,7 @@
           <p:cNvPr id="10" name="">
             <a:extLst xmlns:a="http://schemas.openxmlformats.org/drawingml/2006/main">
               <a:ext uri="{FF2B5EF4-FFF2-40B4-BE49-F238E27FC236}">
-                <a16:creationId xmlns:a16="http://schemas.microsoft.com/office/drawing/2014/main" id="{31B77F78-5AD2-451B-99B3-0B1C18507F5C}"/>
+                <a16:creationId xmlns:a16="http://schemas.microsoft.com/office/drawing/2014/main" id="{8AA09307-514E-4D76-8736-2C8901AF9795}"/>
               </a:ext>
             </a:extLst>
           </p:cNvPr>
@@ -4342,7 +4342,7 @@
           <p:cNvPr id="11" name="">
             <a:extLst xmlns:a="http://schemas.openxmlformats.org/drawingml/2006/main">
               <a:ext uri="{FF2B5EF4-FFF2-40B4-BE49-F238E27FC236}">
-                <a16:creationId xmlns:a16="http://schemas.microsoft.com/office/drawing/2014/main" id="{AC4F52C6-0606-4C47-A61F-2A4A5961AD32}"/>
+                <a16:creationId xmlns:a16="http://schemas.microsoft.com/office/drawing/2014/main" id="{4720AA17-9D27-4984-B7BA-8902D11C47FA}"/>
               </a:ext>
             </a:extLst>
           </p:cNvPr>
@@ -4382,7 +4382,7 @@
                   <a:srgbClr val="0A0A0A"/>
                 </a:solidFill>
               </a:rPr>
-              <a:t>125.94 s CPU training</a:t>
+              <a:t>146.91 s CPU training</a:t>
             </a:r>
           </a:p>
         </p:txBody>
@@ -4392,7 +4392,7 @@
           <p:cNvPr id="12" name="">
             <a:extLst xmlns:a="http://schemas.openxmlformats.org/drawingml/2006/main">
               <a:ext uri="{FF2B5EF4-FFF2-40B4-BE49-F238E27FC236}">
-                <a16:creationId xmlns:a16="http://schemas.microsoft.com/office/drawing/2014/main" id="{85B40ED0-1C1D-4977-8345-857FE51035E3}"/>
+                <a16:creationId xmlns:a16="http://schemas.microsoft.com/office/drawing/2014/main" id="{5DD195C8-18C9-4715-BFCC-8B28671E8E02}"/>
               </a:ext>
             </a:extLst>
           </p:cNvPr>
@@ -4425,7 +4425,7 @@
           <p:cNvPr id="13" name="">
             <a:extLst xmlns:a="http://schemas.openxmlformats.org/drawingml/2006/main">
               <a:ext uri="{FF2B5EF4-FFF2-40B4-BE49-F238E27FC236}">
-                <a16:creationId xmlns:a16="http://schemas.microsoft.com/office/drawing/2014/main" id="{BC72134D-E36A-4864-943F-6FD8741486B8}"/>
+                <a16:creationId xmlns:a16="http://schemas.microsoft.com/office/drawing/2014/main" id="{E03E10D7-7E28-46AF-8CB5-417FE73E978B}"/>
               </a:ext>
             </a:extLst>
           </p:cNvPr>
@@ -4475,7 +4475,7 @@
           <p:cNvPr id="14" name="">
             <a:extLst xmlns:a="http://schemas.openxmlformats.org/drawingml/2006/main">
               <a:ext uri="{FF2B5EF4-FFF2-40B4-BE49-F238E27FC236}">
-                <a16:creationId xmlns:a16="http://schemas.microsoft.com/office/drawing/2014/main" id="{EE410F56-DAFC-4CA1-A2CB-538C82DFF578}"/>
+                <a16:creationId xmlns:a16="http://schemas.microsoft.com/office/drawing/2014/main" id="{0D16EEDE-62F5-4ECC-A38A-ED01650ED052}"/>
               </a:ext>
             </a:extLst>
           </p:cNvPr>
@@ -4508,7 +4508,7 @@
           <p:cNvPr id="15" name="">
             <a:extLst xmlns:a="http://schemas.openxmlformats.org/drawingml/2006/main">
               <a:ext uri="{FF2B5EF4-FFF2-40B4-BE49-F238E27FC236}">
-                <a16:creationId xmlns:a16="http://schemas.microsoft.com/office/drawing/2014/main" id="{F98CD30A-DBD5-4651-8159-32D7BAE6A149}"/>
+                <a16:creationId xmlns:a16="http://schemas.microsoft.com/office/drawing/2014/main" id="{96EC03CD-DDE6-4C4C-ADEA-C23E85E41F59}"/>
               </a:ext>
             </a:extLst>
           </p:cNvPr>
@@ -4558,7 +4558,7 @@
           <p:cNvPr id="16" name="">
             <a:extLst xmlns:a="http://schemas.openxmlformats.org/drawingml/2006/main">
               <a:ext uri="{FF2B5EF4-FFF2-40B4-BE49-F238E27FC236}">
-                <a16:creationId xmlns:a16="http://schemas.microsoft.com/office/drawing/2014/main" id="{93207ECB-CE81-43B7-9D1A-0305C4E8D178}"/>
+                <a16:creationId xmlns:a16="http://schemas.microsoft.com/office/drawing/2014/main" id="{681B6A21-2A17-41CA-A2E8-48924D089C9C}"/>
               </a:ext>
             </a:extLst>
           </p:cNvPr>
@@ -4591,7 +4591,7 @@
           <p:cNvPr id="17" name="">
             <a:extLst xmlns:a="http://schemas.openxmlformats.org/drawingml/2006/main">
               <a:ext uri="{FF2B5EF4-FFF2-40B4-BE49-F238E27FC236}">
-                <a16:creationId xmlns:a16="http://schemas.microsoft.com/office/drawing/2014/main" id="{1AAD8549-08A3-48AA-8059-9E45EB7C5D5B}"/>
+                <a16:creationId xmlns:a16="http://schemas.microsoft.com/office/drawing/2014/main" id="{3DACB1EB-16E1-40DB-967F-825F000E0C57}"/>
               </a:ext>
             </a:extLst>
           </p:cNvPr>
@@ -4641,7 +4641,7 @@
           <p:cNvPr id="18" name="">
             <a:extLst xmlns:a="http://schemas.openxmlformats.org/drawingml/2006/main">
               <a:ext uri="{FF2B5EF4-FFF2-40B4-BE49-F238E27FC236}">
-                <a16:creationId xmlns:a16="http://schemas.microsoft.com/office/drawing/2014/main" id="{0CFBB6D0-A7BF-4B03-B0F8-FF7009AF5523}"/>
+                <a16:creationId xmlns:a16="http://schemas.microsoft.com/office/drawing/2014/main" id="{4E402E58-E7F1-4F59-BA92-C687A6014D00}"/>
               </a:ext>
             </a:extLst>
           </p:cNvPr>
@@ -4674,7 +4674,7 @@
           <p:cNvPr id="19" name="">
             <a:extLst xmlns:a="http://schemas.openxmlformats.org/drawingml/2006/main">
               <a:ext uri="{FF2B5EF4-FFF2-40B4-BE49-F238E27FC236}">
-                <a16:creationId xmlns:a16="http://schemas.microsoft.com/office/drawing/2014/main" id="{D5F10026-699F-4A0F-BF64-0C64BA613AA3}"/>
+                <a16:creationId xmlns:a16="http://schemas.microsoft.com/office/drawing/2014/main" id="{9787C725-7CD8-4A54-9CA8-C43B904972CF}"/>
               </a:ext>
             </a:extLst>
           </p:cNvPr>
@@ -4724,7 +4724,7 @@
           <p:cNvPr id="20" name="">
             <a:extLst xmlns:a="http://schemas.openxmlformats.org/drawingml/2006/main">
               <a:ext uri="{FF2B5EF4-FFF2-40B4-BE49-F238E27FC236}">
-                <a16:creationId xmlns:a16="http://schemas.microsoft.com/office/drawing/2014/main" id="{B950CC75-4676-4817-AB79-A0D7AB91F87C}"/>
+                <a16:creationId xmlns:a16="http://schemas.microsoft.com/office/drawing/2014/main" id="{D233D795-5204-44D1-82C9-A18987728878}"/>
               </a:ext>
             </a:extLst>
           </p:cNvPr>
@@ -4757,7 +4757,7 @@
           <p:cNvPr id="21" name="">
             <a:extLst xmlns:a="http://schemas.openxmlformats.org/drawingml/2006/main">
               <a:ext uri="{FF2B5EF4-FFF2-40B4-BE49-F238E27FC236}">
-                <a16:creationId xmlns:a16="http://schemas.microsoft.com/office/drawing/2014/main" id="{5E9FF7F1-7DF9-4FCC-B1B6-4009D37B3E77}"/>
+                <a16:creationId xmlns:a16="http://schemas.microsoft.com/office/drawing/2014/main" id="{867322E8-A922-4C4B-9E42-3DCDCFA60DE2}"/>
               </a:ext>
             </a:extLst>
           </p:cNvPr>
@@ -4807,7 +4807,7 @@
           <p:cNvPr id="22" name="">
             <a:extLst xmlns:a="http://schemas.openxmlformats.org/drawingml/2006/main">
               <a:ext uri="{FF2B5EF4-FFF2-40B4-BE49-F238E27FC236}">
-                <a16:creationId xmlns:a16="http://schemas.microsoft.com/office/drawing/2014/main" id="{71E743D3-3C2E-464C-82B3-1C95B9418C09}"/>
+                <a16:creationId xmlns:a16="http://schemas.microsoft.com/office/drawing/2014/main" id="{3592786C-A778-443D-B7D2-2A029D84ABF3}"/>
               </a:ext>
             </a:extLst>
           </p:cNvPr>
@@ -4840,7 +4840,7 @@
           <p:cNvPr id="23" name="">
             <a:extLst xmlns:a="http://schemas.openxmlformats.org/drawingml/2006/main">
               <a:ext uri="{FF2B5EF4-FFF2-40B4-BE49-F238E27FC236}">
-                <a16:creationId xmlns:a16="http://schemas.microsoft.com/office/drawing/2014/main" id="{0CDDCE8F-0016-47CB-BFB0-F7B6D5D295FC}"/>
+                <a16:creationId xmlns:a16="http://schemas.microsoft.com/office/drawing/2014/main" id="{F3A8AC7F-4174-4F8C-902B-9DFE0B0BE192}"/>
               </a:ext>
             </a:extLst>
           </p:cNvPr>
@@ -4890,7 +4890,7 @@
           <p:cNvPr id="24" name="">
             <a:extLst xmlns:a="http://schemas.openxmlformats.org/drawingml/2006/main">
               <a:ext uri="{FF2B5EF4-FFF2-40B4-BE49-F238E27FC236}">
-                <a16:creationId xmlns:a16="http://schemas.microsoft.com/office/drawing/2014/main" id="{93A5F77F-FFDD-4B8A-AE98-66942F191712}"/>
+                <a16:creationId xmlns:a16="http://schemas.microsoft.com/office/drawing/2014/main" id="{43F62758-7AF6-440B-A08B-45A2BC07A78C}"/>
               </a:ext>
             </a:extLst>
           </p:cNvPr>
@@ -4940,7 +4940,7 @@
           <p:cNvPr id="25" name="">
             <a:extLst xmlns:a="http://schemas.openxmlformats.org/drawingml/2006/main">
               <a:ext uri="{FF2B5EF4-FFF2-40B4-BE49-F238E27FC236}">
-                <a16:creationId xmlns:a16="http://schemas.microsoft.com/office/drawing/2014/main" id="{D53F4412-B56D-490A-8F9B-A02701E7DADA}"/>
+                <a16:creationId xmlns:a16="http://schemas.microsoft.com/office/drawing/2014/main" id="{7BCDE536-D6C5-4C79-A0AE-94EA1588BCF0}"/>
               </a:ext>
             </a:extLst>
           </p:cNvPr>
@@ -4988,7 +4988,7 @@
     </p:spTree>
     <p:extLst>
       <p:ext uri="{BB962C8B-B14F-4D97-AF65-F5344CB8AC3E}">
-        <p14:creationId xmlns:p14="http://schemas.microsoft.com/office/powerpoint/2010/main" val="1077361145"/>
+        <p14:creationId xmlns:p14="http://schemas.microsoft.com/office/powerpoint/2010/main" val="332153932"/>
       </p:ext>
     </p:extLst>
   </p:cSld>
@@ -5019,7 +5019,7 @@
           <p:cNvPr id="1" name="">
             <a:extLst xmlns:a="http://schemas.openxmlformats.org/drawingml/2006/main">
               <a:ext uri="{FF2B5EF4-FFF2-40B4-BE49-F238E27FC236}">
-                <a16:creationId xmlns:a16="http://schemas.microsoft.com/office/drawing/2014/main" id="{1C1135CB-5634-4119-8A18-CE8DCDC4E80C}"/>
+                <a16:creationId xmlns:a16="http://schemas.microsoft.com/office/drawing/2014/main" id="{0500C45B-E01A-410E-B273-A52F08F63158}"/>
               </a:ext>
             </a:extLst>
           </p:cNvPr>
@@ -5069,7 +5069,7 @@
           <p:cNvPr id="2" name="">
             <a:extLst xmlns:a="http://schemas.openxmlformats.org/drawingml/2006/main">
               <a:ext uri="{FF2B5EF4-FFF2-40B4-BE49-F238E27FC236}">
-                <a16:creationId xmlns:a16="http://schemas.microsoft.com/office/drawing/2014/main" id="{89CEE908-091A-4600-BF31-800257419621}"/>
+                <a16:creationId xmlns:a16="http://schemas.microsoft.com/office/drawing/2014/main" id="{41627071-8BC1-48A6-A5A0-4B4E01BAB83D}"/>
               </a:ext>
             </a:extLst>
           </p:cNvPr>
@@ -5119,7 +5119,7 @@
           <p:cNvPr id="3" name="">
             <a:extLst xmlns:a="http://schemas.openxmlformats.org/drawingml/2006/main">
               <a:ext uri="{FF2B5EF4-FFF2-40B4-BE49-F238E27FC236}">
-                <a16:creationId xmlns:a16="http://schemas.microsoft.com/office/drawing/2014/main" id="{A16B1ED5-C2D7-4D89-97AC-01C4DBDCCBB5}"/>
+                <a16:creationId xmlns:a16="http://schemas.microsoft.com/office/drawing/2014/main" id="{6C928733-FDEA-4B7D-968C-951D8B34B704}"/>
               </a:ext>
             </a:extLst>
           </p:cNvPr>
@@ -5152,7 +5152,7 @@
           <p:cNvPr id="4" name="">
             <a:extLst xmlns:a="http://schemas.openxmlformats.org/drawingml/2006/main">
               <a:ext uri="{FF2B5EF4-FFF2-40B4-BE49-F238E27FC236}">
-                <a16:creationId xmlns:a16="http://schemas.microsoft.com/office/drawing/2014/main" id="{ACF8A811-C84F-4DEB-A1AD-E53874BC97B9}"/>
+                <a16:creationId xmlns:a16="http://schemas.microsoft.com/office/drawing/2014/main" id="{249A297B-EBA3-4C44-BB07-FB1E99371D36}"/>
               </a:ext>
             </a:extLst>
           </p:cNvPr>
@@ -5185,7 +5185,7 @@
           <p:cNvPr id="5" name="">
             <a:extLst xmlns:a="http://schemas.openxmlformats.org/drawingml/2006/main">
               <a:ext uri="{FF2B5EF4-FFF2-40B4-BE49-F238E27FC236}">
-                <a16:creationId xmlns:a16="http://schemas.microsoft.com/office/drawing/2014/main" id="{3AF042C6-C81B-43C5-B1FC-AFC8E5E41BE7}"/>
+                <a16:creationId xmlns:a16="http://schemas.microsoft.com/office/drawing/2014/main" id="{0A196632-A67F-45E6-BD00-81AABD49B6D8}"/>
               </a:ext>
             </a:extLst>
           </p:cNvPr>
@@ -5235,7 +5235,7 @@
           <p:cNvPr id="6" name="">
             <a:extLst xmlns:a="http://schemas.openxmlformats.org/drawingml/2006/main">
               <a:ext uri="{FF2B5EF4-FFF2-40B4-BE49-F238E27FC236}">
-                <a16:creationId xmlns:a16="http://schemas.microsoft.com/office/drawing/2014/main" id="{A7D453D5-6226-47B6-81F1-E62F6C1F51CB}"/>
+                <a16:creationId xmlns:a16="http://schemas.microsoft.com/office/drawing/2014/main" id="{29A72930-059A-49E1-BC2F-2593672C436E}"/>
               </a:ext>
             </a:extLst>
           </p:cNvPr>
@@ -5268,7 +5268,7 @@
           <p:cNvPr id="7" name="">
             <a:extLst xmlns:a="http://schemas.openxmlformats.org/drawingml/2006/main">
               <a:ext uri="{FF2B5EF4-FFF2-40B4-BE49-F238E27FC236}">
-                <a16:creationId xmlns:a16="http://schemas.microsoft.com/office/drawing/2014/main" id="{B2A61A75-6941-4CB2-A2DE-992AAEB9F8F7}"/>
+                <a16:creationId xmlns:a16="http://schemas.microsoft.com/office/drawing/2014/main" id="{2CA2B0CF-2487-402B-8081-BABA5E3CAD4A}"/>
               </a:ext>
             </a:extLst>
           </p:cNvPr>
@@ -5318,7 +5318,7 @@
           <p:cNvPr id="8" name="">
             <a:extLst xmlns:a="http://schemas.openxmlformats.org/drawingml/2006/main">
               <a:ext uri="{FF2B5EF4-FFF2-40B4-BE49-F238E27FC236}">
-                <a16:creationId xmlns:a16="http://schemas.microsoft.com/office/drawing/2014/main" id="{64F2C538-F11E-4541-807A-5CA3DC55922D}"/>
+                <a16:creationId xmlns:a16="http://schemas.microsoft.com/office/drawing/2014/main" id="{32460C6B-D66C-4593-AE0B-07C5593092FC}"/>
               </a:ext>
             </a:extLst>
           </p:cNvPr>
@@ -5351,7 +5351,7 @@
           <p:cNvPr id="9" name="">
             <a:extLst xmlns:a="http://schemas.openxmlformats.org/drawingml/2006/main">
               <a:ext uri="{FF2B5EF4-FFF2-40B4-BE49-F238E27FC236}">
-                <a16:creationId xmlns:a16="http://schemas.microsoft.com/office/drawing/2014/main" id="{453ECAE7-AEA8-482A-AC73-F791F6A0D0E3}"/>
+                <a16:creationId xmlns:a16="http://schemas.microsoft.com/office/drawing/2014/main" id="{23D3029D-1F73-4F05-9BC7-72CEFEFBED71}"/>
               </a:ext>
             </a:extLst>
           </p:cNvPr>
@@ -5391,7 +5391,7 @@
                   <a:srgbClr val="0A0A0A"/>
                 </a:solidFill>
               </a:rPr>
-              <a:t>98.87% test accuracy with a 60,000-parameter model</a:t>
+              <a:t>98.93% test accuracy with a 60,000-parameter model</a:t>
             </a:r>
           </a:p>
         </p:txBody>
@@ -5401,7 +5401,7 @@
           <p:cNvPr id="10" name="">
             <a:extLst xmlns:a="http://schemas.openxmlformats.org/drawingml/2006/main">
               <a:ext uri="{FF2B5EF4-FFF2-40B4-BE49-F238E27FC236}">
-                <a16:creationId xmlns:a16="http://schemas.microsoft.com/office/drawing/2014/main" id="{BCCFF0EB-B04D-4DA7-8772-93476A7AF4D8}"/>
+                <a16:creationId xmlns:a16="http://schemas.microsoft.com/office/drawing/2014/main" id="{85ACE096-66BE-4ADF-81C5-C07ECD6B5ACF}"/>
               </a:ext>
             </a:extLst>
           </p:cNvPr>
@@ -5434,7 +5434,7 @@
           <p:cNvPr id="11" name="">
             <a:extLst xmlns:a="http://schemas.openxmlformats.org/drawingml/2006/main">
               <a:ext uri="{FF2B5EF4-FFF2-40B4-BE49-F238E27FC236}">
-                <a16:creationId xmlns:a16="http://schemas.microsoft.com/office/drawing/2014/main" id="{DC341159-56AC-4AE1-88DA-A72C3E317D1B}"/>
+                <a16:creationId xmlns:a16="http://schemas.microsoft.com/office/drawing/2014/main" id="{3D9EF8BE-4C46-4D3F-AE05-1C8D7E0E499E}"/>
               </a:ext>
             </a:extLst>
           </p:cNvPr>
@@ -5484,7 +5484,7 @@
           <p:cNvPr id="12" name="">
             <a:extLst xmlns:a="http://schemas.openxmlformats.org/drawingml/2006/main">
               <a:ext uri="{FF2B5EF4-FFF2-40B4-BE49-F238E27FC236}">
-                <a16:creationId xmlns:a16="http://schemas.microsoft.com/office/drawing/2014/main" id="{CA9025FF-455B-4949-9C48-7E1764577963}"/>
+                <a16:creationId xmlns:a16="http://schemas.microsoft.com/office/drawing/2014/main" id="{665AB46A-BA3F-4535-8F29-A4CE1888C20C}"/>
               </a:ext>
             </a:extLst>
           </p:cNvPr>
@@ -5517,7 +5517,7 @@
           <p:cNvPr id="13" name="">
             <a:extLst xmlns:a="http://schemas.openxmlformats.org/drawingml/2006/main">
               <a:ext uri="{FF2B5EF4-FFF2-40B4-BE49-F238E27FC236}">
-                <a16:creationId xmlns:a16="http://schemas.microsoft.com/office/drawing/2014/main" id="{B00F03F6-017D-4423-A43B-7A1646623189}"/>
+                <a16:creationId xmlns:a16="http://schemas.microsoft.com/office/drawing/2014/main" id="{34A31A3D-D306-4FBA-9651-57AB43B3D781}"/>
               </a:ext>
             </a:extLst>
           </p:cNvPr>
@@ -5567,7 +5567,7 @@
           <p:cNvPr id="14" name="">
             <a:extLst xmlns:a="http://schemas.openxmlformats.org/drawingml/2006/main">
               <a:ext uri="{FF2B5EF4-FFF2-40B4-BE49-F238E27FC236}">
-                <a16:creationId xmlns:a16="http://schemas.microsoft.com/office/drawing/2014/main" id="{4B1242DE-5059-429F-A364-EA6A712B2DFB}"/>
+                <a16:creationId xmlns:a16="http://schemas.microsoft.com/office/drawing/2014/main" id="{DC724D56-097C-46DA-91B0-11D03346913E}"/>
               </a:ext>
             </a:extLst>
           </p:cNvPr>
@@ -5617,7 +5617,7 @@
           <p:cNvPr id="15" name="">
             <a:extLst xmlns:a="http://schemas.openxmlformats.org/drawingml/2006/main">
               <a:ext uri="{FF2B5EF4-FFF2-40B4-BE49-F238E27FC236}">
-                <a16:creationId xmlns:a16="http://schemas.microsoft.com/office/drawing/2014/main" id="{51C51542-4532-42D2-B695-CBC528A6DF44}"/>
+                <a16:creationId xmlns:a16="http://schemas.microsoft.com/office/drawing/2014/main" id="{06630066-84A7-43CA-84E3-1AE6BD0103B9}"/>
               </a:ext>
             </a:extLst>
           </p:cNvPr>
@@ -5665,7 +5665,7 @@
     </p:spTree>
     <p:extLst>
       <p:ext uri="{BB962C8B-B14F-4D97-AF65-F5344CB8AC3E}">
-        <p14:creationId xmlns:p14="http://schemas.microsoft.com/office/powerpoint/2010/main" val="1772253007"/>
+        <p14:creationId xmlns:p14="http://schemas.microsoft.com/office/powerpoint/2010/main" val="2013942006"/>
       </p:ext>
     </p:extLst>
   </p:cSld>
@@ -5696,7 +5696,7 @@
           <p:cNvPr id="1" name="">
             <a:extLst xmlns:a="http://schemas.openxmlformats.org/drawingml/2006/main">
               <a:ext uri="{FF2B5EF4-FFF2-40B4-BE49-F238E27FC236}">
-                <a16:creationId xmlns:a16="http://schemas.microsoft.com/office/drawing/2014/main" id="{A504B32C-622C-4770-9A7C-6B6237936A66}"/>
+                <a16:creationId xmlns:a16="http://schemas.microsoft.com/office/drawing/2014/main" id="{1ACD6E3B-EF58-4482-9F6B-56DD2AB3FC09}"/>
               </a:ext>
             </a:extLst>
           </p:cNvPr>
@@ -5746,7 +5746,7 @@
           <p:cNvPr id="2" name="">
             <a:extLst xmlns:a="http://schemas.openxmlformats.org/drawingml/2006/main">
               <a:ext uri="{FF2B5EF4-FFF2-40B4-BE49-F238E27FC236}">
-                <a16:creationId xmlns:a16="http://schemas.microsoft.com/office/drawing/2014/main" id="{4AC11851-3633-44CF-8E12-3940C4E06147}"/>
+                <a16:creationId xmlns:a16="http://schemas.microsoft.com/office/drawing/2014/main" id="{FF096714-4C04-4160-BAF8-D65058B556DD}"/>
               </a:ext>
             </a:extLst>
           </p:cNvPr>
@@ -5796,7 +5796,7 @@
           <p:cNvPr id="3" name="">
             <a:extLst xmlns:a="http://schemas.openxmlformats.org/drawingml/2006/main">
               <a:ext uri="{FF2B5EF4-FFF2-40B4-BE49-F238E27FC236}">
-                <a16:creationId xmlns:a16="http://schemas.microsoft.com/office/drawing/2014/main" id="{5B93393A-E01B-4B54-93C6-1C34E112A545}"/>
+                <a16:creationId xmlns:a16="http://schemas.microsoft.com/office/drawing/2014/main" id="{4E5F6BAA-8317-4F35-BEDB-8C8B00285B7E}"/>
               </a:ext>
             </a:extLst>
           </p:cNvPr>
@@ -5829,7 +5829,7 @@
           <p:cNvPr id="4" name="">
             <a:extLst xmlns:a="http://schemas.openxmlformats.org/drawingml/2006/main">
               <a:ext uri="{FF2B5EF4-FFF2-40B4-BE49-F238E27FC236}">
-                <a16:creationId xmlns:a16="http://schemas.microsoft.com/office/drawing/2014/main" id="{A5A4C8D5-73D8-4DE2-B3DA-4907B71A5738}"/>
+                <a16:creationId xmlns:a16="http://schemas.microsoft.com/office/drawing/2014/main" id="{CDD0DAF8-7827-48A4-B31F-596422FB80B5}"/>
               </a:ext>
             </a:extLst>
           </p:cNvPr>
@@ -5862,7 +5862,7 @@
           <p:cNvPr id="5" name="">
             <a:extLst xmlns:a="http://schemas.openxmlformats.org/drawingml/2006/main">
               <a:ext uri="{FF2B5EF4-FFF2-40B4-BE49-F238E27FC236}">
-                <a16:creationId xmlns:a16="http://schemas.microsoft.com/office/drawing/2014/main" id="{D660CD91-DF74-49F2-85B1-307EEECC0134}"/>
+                <a16:creationId xmlns:a16="http://schemas.microsoft.com/office/drawing/2014/main" id="{EBCAF3EA-DE99-41EB-BD23-1256F3C367B7}"/>
               </a:ext>
             </a:extLst>
           </p:cNvPr>
@@ -5912,7 +5912,7 @@
           <p:cNvPr id="6" name="">
             <a:extLst xmlns:a="http://schemas.openxmlformats.org/drawingml/2006/main">
               <a:ext uri="{FF2B5EF4-FFF2-40B4-BE49-F238E27FC236}">
-                <a16:creationId xmlns:a16="http://schemas.microsoft.com/office/drawing/2014/main" id="{C91DF3C3-9F54-4719-A480-377754D390F5}"/>
+                <a16:creationId xmlns:a16="http://schemas.microsoft.com/office/drawing/2014/main" id="{0EA79EDA-DA50-435F-B2C4-82915C7011BA}"/>
               </a:ext>
             </a:extLst>
           </p:cNvPr>
@@ -5945,7 +5945,7 @@
           <p:cNvPr id="7" name="">
             <a:extLst xmlns:a="http://schemas.openxmlformats.org/drawingml/2006/main">
               <a:ext uri="{FF2B5EF4-FFF2-40B4-BE49-F238E27FC236}">
-                <a16:creationId xmlns:a16="http://schemas.microsoft.com/office/drawing/2014/main" id="{849268B3-B1A5-4CEF-AEB4-DC7C4E323A51}"/>
+                <a16:creationId xmlns:a16="http://schemas.microsoft.com/office/drawing/2014/main" id="{3522C0F4-FEA9-48B6-AD80-2D18EAD1D16F}"/>
               </a:ext>
             </a:extLst>
           </p:cNvPr>
@@ -5995,7 +5995,7 @@
           <p:cNvPr id="8" name="">
             <a:extLst xmlns:a="http://schemas.openxmlformats.org/drawingml/2006/main">
               <a:ext uri="{FF2B5EF4-FFF2-40B4-BE49-F238E27FC236}">
-                <a16:creationId xmlns:a16="http://schemas.microsoft.com/office/drawing/2014/main" id="{ACBA89A7-618B-4E01-95E5-9005F246770B}"/>
+                <a16:creationId xmlns:a16="http://schemas.microsoft.com/office/drawing/2014/main" id="{65405129-A226-4E32-AB83-1C0E7B334AF5}"/>
               </a:ext>
             </a:extLst>
           </p:cNvPr>
@@ -6028,7 +6028,7 @@
           <p:cNvPr id="9" name="">
             <a:extLst xmlns:a="http://schemas.openxmlformats.org/drawingml/2006/main">
               <a:ext uri="{FF2B5EF4-FFF2-40B4-BE49-F238E27FC236}">
-                <a16:creationId xmlns:a16="http://schemas.microsoft.com/office/drawing/2014/main" id="{81CF574D-17A3-4A73-801A-E8D218E0BA9B}"/>
+                <a16:creationId xmlns:a16="http://schemas.microsoft.com/office/drawing/2014/main" id="{1B873006-9BDB-48E6-87A4-8A1E89F1941A}"/>
               </a:ext>
             </a:extLst>
           </p:cNvPr>
@@ -6078,7 +6078,7 @@
           <p:cNvPr id="10" name="">
             <a:extLst xmlns:a="http://schemas.openxmlformats.org/drawingml/2006/main">
               <a:ext uri="{FF2B5EF4-FFF2-40B4-BE49-F238E27FC236}">
-                <a16:creationId xmlns:a16="http://schemas.microsoft.com/office/drawing/2014/main" id="{27690935-4662-4118-B0C8-1942D9EA7225}"/>
+                <a16:creationId xmlns:a16="http://schemas.microsoft.com/office/drawing/2014/main" id="{8650D5B4-1DCF-4568-8EB6-DE40419EF2FB}"/>
               </a:ext>
             </a:extLst>
           </p:cNvPr>
@@ -6111,7 +6111,7 @@
           <p:cNvPr id="11" name="">
             <a:extLst xmlns:a="http://schemas.openxmlformats.org/drawingml/2006/main">
               <a:ext uri="{FF2B5EF4-FFF2-40B4-BE49-F238E27FC236}">
-                <a16:creationId xmlns:a16="http://schemas.microsoft.com/office/drawing/2014/main" id="{3E28D604-903E-4191-9A02-8125AEE52CD0}"/>
+                <a16:creationId xmlns:a16="http://schemas.microsoft.com/office/drawing/2014/main" id="{1C20B585-907E-40C7-AED9-F9F06C1F43E4}"/>
               </a:ext>
             </a:extLst>
           </p:cNvPr>
@@ -6165,7 +6165,7 @@
           <p:nvPr/>
         </p:nvPicPr>
         <p:blipFill>
-          <a:blip xmlns:r="http://schemas.openxmlformats.org/officeDocument/2006/relationships" xmlns:a="http://schemas.openxmlformats.org/drawingml/2006/main" r:embed="Ref0b4ec996a9481c"/>
+          <a:blip xmlns:r="http://schemas.openxmlformats.org/officeDocument/2006/relationships" xmlns:a="http://schemas.openxmlformats.org/drawingml/2006/main" r:embed="R1a8b6b8d6c634a50"/>
           <a:stretch xmlns:a="http://schemas.openxmlformats.org/drawingml/2006/main"/>
         </p:blipFill>
         <p:spPr>
@@ -6183,7 +6183,7 @@
           <p:cNvPr id="13" name="">
             <a:extLst xmlns:a="http://schemas.openxmlformats.org/drawingml/2006/main">
               <a:ext uri="{FF2B5EF4-FFF2-40B4-BE49-F238E27FC236}">
-                <a16:creationId xmlns:a16="http://schemas.microsoft.com/office/drawing/2014/main" id="{B8C1CCD1-5948-4910-B271-60A4E6F80EFC}"/>
+                <a16:creationId xmlns:a16="http://schemas.microsoft.com/office/drawing/2014/main" id="{EB94882E-AC34-4506-ACC6-8DA6294A234B}"/>
               </a:ext>
             </a:extLst>
           </p:cNvPr>
@@ -6233,7 +6233,7 @@
           <p:cNvPr id="14" name="">
             <a:extLst xmlns:a="http://schemas.openxmlformats.org/drawingml/2006/main">
               <a:ext uri="{FF2B5EF4-FFF2-40B4-BE49-F238E27FC236}">
-                <a16:creationId xmlns:a16="http://schemas.microsoft.com/office/drawing/2014/main" id="{56295CE2-BA1B-49A3-9785-79011FFA75A1}"/>
+                <a16:creationId xmlns:a16="http://schemas.microsoft.com/office/drawing/2014/main" id="{24E97B22-7439-428C-9D3B-E1885F8CA558}"/>
               </a:ext>
             </a:extLst>
           </p:cNvPr>
@@ -6281,7 +6281,7 @@
     </p:spTree>
     <p:extLst>
       <p:ext uri="{BB962C8B-B14F-4D97-AF65-F5344CB8AC3E}">
-        <p14:creationId xmlns:p14="http://schemas.microsoft.com/office/powerpoint/2010/main" val="1590223493"/>
+        <p14:creationId xmlns:p14="http://schemas.microsoft.com/office/powerpoint/2010/main" val="271070764"/>
       </p:ext>
     </p:extLst>
   </p:cSld>
@@ -6312,7 +6312,7 @@
           <p:cNvPr id="1" name="">
             <a:extLst xmlns:a="http://schemas.openxmlformats.org/drawingml/2006/main">
               <a:ext uri="{FF2B5EF4-FFF2-40B4-BE49-F238E27FC236}">
-                <a16:creationId xmlns:a16="http://schemas.microsoft.com/office/drawing/2014/main" id="{E5623ED2-C49B-4DB5-98BB-174B3314943C}"/>
+                <a16:creationId xmlns:a16="http://schemas.microsoft.com/office/drawing/2014/main" id="{8ACEE669-6C4C-481A-9A96-989908EBCB43}"/>
               </a:ext>
             </a:extLst>
           </p:cNvPr>
@@ -6362,7 +6362,7 @@
           <p:cNvPr id="2" name="">
             <a:extLst xmlns:a="http://schemas.openxmlformats.org/drawingml/2006/main">
               <a:ext uri="{FF2B5EF4-FFF2-40B4-BE49-F238E27FC236}">
-                <a16:creationId xmlns:a16="http://schemas.microsoft.com/office/drawing/2014/main" id="{25287261-3B36-4FD5-902B-8D7A975E6902}"/>
+                <a16:creationId xmlns:a16="http://schemas.microsoft.com/office/drawing/2014/main" id="{73948F16-FD6E-4884-A15D-EDBB321B0CB2}"/>
               </a:ext>
             </a:extLst>
           </p:cNvPr>
@@ -6412,7 +6412,7 @@
           <p:cNvPr id="3" name="">
             <a:extLst xmlns:a="http://schemas.openxmlformats.org/drawingml/2006/main">
               <a:ext uri="{FF2B5EF4-FFF2-40B4-BE49-F238E27FC236}">
-                <a16:creationId xmlns:a16="http://schemas.microsoft.com/office/drawing/2014/main" id="{38F076A5-19EF-445F-8307-A3AF20327F89}"/>
+                <a16:creationId xmlns:a16="http://schemas.microsoft.com/office/drawing/2014/main" id="{AE94D9BA-2900-4990-9F04-4795CB0D9234}"/>
               </a:ext>
             </a:extLst>
           </p:cNvPr>
@@ -6445,7 +6445,7 @@
           <p:cNvPr id="4" name="">
             <a:extLst xmlns:a="http://schemas.openxmlformats.org/drawingml/2006/main">
               <a:ext uri="{FF2B5EF4-FFF2-40B4-BE49-F238E27FC236}">
-                <a16:creationId xmlns:a16="http://schemas.microsoft.com/office/drawing/2014/main" id="{14FD60B0-4EBA-4035-907F-0BECEB93BE2F}"/>
+                <a16:creationId xmlns:a16="http://schemas.microsoft.com/office/drawing/2014/main" id="{2B01DE54-A54A-4038-96A6-3281A9CA9C97}"/>
               </a:ext>
             </a:extLst>
           </p:cNvPr>
@@ -6478,7 +6478,7 @@
           <p:cNvPr id="5" name="">
             <a:extLst xmlns:a="http://schemas.openxmlformats.org/drawingml/2006/main">
               <a:ext uri="{FF2B5EF4-FFF2-40B4-BE49-F238E27FC236}">
-                <a16:creationId xmlns:a16="http://schemas.microsoft.com/office/drawing/2014/main" id="{CC066EB0-4FBF-4BAE-A610-E2BDB98CF149}"/>
+                <a16:creationId xmlns:a16="http://schemas.microsoft.com/office/drawing/2014/main" id="{7AC3DE1F-B6CA-4698-9327-213F872FF75D}"/>
               </a:ext>
             </a:extLst>
           </p:cNvPr>
@@ -6528,7 +6528,7 @@
           <p:cNvPr id="6" name="">
             <a:extLst xmlns:a="http://schemas.openxmlformats.org/drawingml/2006/main">
               <a:ext uri="{FF2B5EF4-FFF2-40B4-BE49-F238E27FC236}">
-                <a16:creationId xmlns:a16="http://schemas.microsoft.com/office/drawing/2014/main" id="{9E8EC982-46B7-4BA8-B33B-32E3570A6116}"/>
+                <a16:creationId xmlns:a16="http://schemas.microsoft.com/office/drawing/2014/main" id="{BCB68CDF-AD26-4F62-AA8F-3C833FAC747C}"/>
               </a:ext>
             </a:extLst>
           </p:cNvPr>
@@ -6578,7 +6578,7 @@
           <p:cNvPr id="7" name="">
             <a:extLst xmlns:a="http://schemas.openxmlformats.org/drawingml/2006/main">
               <a:ext uri="{FF2B5EF4-FFF2-40B4-BE49-F238E27FC236}">
-                <a16:creationId xmlns:a16="http://schemas.microsoft.com/office/drawing/2014/main" id="{6644F5D1-9C37-47F3-8CE6-7FDAFD448E69}"/>
+                <a16:creationId xmlns:a16="http://schemas.microsoft.com/office/drawing/2014/main" id="{9746F65D-45DF-49AD-89A9-63071C9481D0}"/>
               </a:ext>
             </a:extLst>
           </p:cNvPr>
@@ -6611,7 +6611,7 @@
           <p:cNvPr id="8" name="">
             <a:extLst xmlns:a="http://schemas.openxmlformats.org/drawingml/2006/main">
               <a:ext uri="{FF2B5EF4-FFF2-40B4-BE49-F238E27FC236}">
-                <a16:creationId xmlns:a16="http://schemas.microsoft.com/office/drawing/2014/main" id="{4BEC02FE-76F9-448A-A21A-1805D50719EC}"/>
+                <a16:creationId xmlns:a16="http://schemas.microsoft.com/office/drawing/2014/main" id="{4F01C2C6-1247-4C30-8225-895B6021E452}"/>
               </a:ext>
             </a:extLst>
           </p:cNvPr>
@@ -6644,7 +6644,7 @@
           <p:cNvPr id="9" name="">
             <a:extLst xmlns:a="http://schemas.openxmlformats.org/drawingml/2006/main">
               <a:ext uri="{FF2B5EF4-FFF2-40B4-BE49-F238E27FC236}">
-                <a16:creationId xmlns:a16="http://schemas.microsoft.com/office/drawing/2014/main" id="{10FF7F12-67A8-4ADB-99FC-2CDBF5AC7ABE}"/>
+                <a16:creationId xmlns:a16="http://schemas.microsoft.com/office/drawing/2014/main" id="{2E505C04-AA78-4392-BED1-A9736B86D29A}"/>
               </a:ext>
             </a:extLst>
           </p:cNvPr>
@@ -6694,7 +6694,7 @@
           <p:cNvPr id="10" name="">
             <a:extLst xmlns:a="http://schemas.openxmlformats.org/drawingml/2006/main">
               <a:ext uri="{FF2B5EF4-FFF2-40B4-BE49-F238E27FC236}">
-                <a16:creationId xmlns:a16="http://schemas.microsoft.com/office/drawing/2014/main" id="{0608FA7F-4400-4A84-B425-C7B5F3046500}"/>
+                <a16:creationId xmlns:a16="http://schemas.microsoft.com/office/drawing/2014/main" id="{CCC4000C-B640-49E3-A8A4-204C65E53DD1}"/>
               </a:ext>
             </a:extLst>
           </p:cNvPr>
@@ -6744,7 +6744,7 @@
           <p:cNvPr id="11" name="">
             <a:extLst xmlns:a="http://schemas.openxmlformats.org/drawingml/2006/main">
               <a:ext uri="{FF2B5EF4-FFF2-40B4-BE49-F238E27FC236}">
-                <a16:creationId xmlns:a16="http://schemas.microsoft.com/office/drawing/2014/main" id="{ABD4A0F0-65C7-4F50-BDB0-08EF099A78A7}"/>
+                <a16:creationId xmlns:a16="http://schemas.microsoft.com/office/drawing/2014/main" id="{969CBBF2-5B65-451F-B2EB-977EB89B7DFE}"/>
               </a:ext>
             </a:extLst>
           </p:cNvPr>
@@ -6777,7 +6777,7 @@
           <p:cNvPr id="12" name="">
             <a:extLst xmlns:a="http://schemas.openxmlformats.org/drawingml/2006/main">
               <a:ext uri="{FF2B5EF4-FFF2-40B4-BE49-F238E27FC236}">
-                <a16:creationId xmlns:a16="http://schemas.microsoft.com/office/drawing/2014/main" id="{1CEB6E74-B55E-435D-8284-4A62666FF426}"/>
+                <a16:creationId xmlns:a16="http://schemas.microsoft.com/office/drawing/2014/main" id="{26167132-DF12-4BBE-B419-5174A93A57A7}"/>
               </a:ext>
             </a:extLst>
           </p:cNvPr>
@@ -6810,7 +6810,7 @@
           <p:cNvPr id="13" name="">
             <a:extLst xmlns:a="http://schemas.openxmlformats.org/drawingml/2006/main">
               <a:ext uri="{FF2B5EF4-FFF2-40B4-BE49-F238E27FC236}">
-                <a16:creationId xmlns:a16="http://schemas.microsoft.com/office/drawing/2014/main" id="{B1D043D8-1964-486C-9CFD-8ED860650283}"/>
+                <a16:creationId xmlns:a16="http://schemas.microsoft.com/office/drawing/2014/main" id="{8882D869-BA8D-4888-A2AB-F9F441810A73}"/>
               </a:ext>
             </a:extLst>
           </p:cNvPr>
@@ -6860,7 +6860,7 @@
           <p:cNvPr id="14" name="">
             <a:extLst xmlns:a="http://schemas.openxmlformats.org/drawingml/2006/main">
               <a:ext uri="{FF2B5EF4-FFF2-40B4-BE49-F238E27FC236}">
-                <a16:creationId xmlns:a16="http://schemas.microsoft.com/office/drawing/2014/main" id="{2064693C-F4F8-47F5-924E-4ACB3694EB67}"/>
+                <a16:creationId xmlns:a16="http://schemas.microsoft.com/office/drawing/2014/main" id="{A5B98FB9-30F6-4553-8050-1DFA45580459}"/>
               </a:ext>
             </a:extLst>
           </p:cNvPr>
@@ -6910,7 +6910,7 @@
           <p:cNvPr id="15" name="">
             <a:extLst xmlns:a="http://schemas.openxmlformats.org/drawingml/2006/main">
               <a:ext uri="{FF2B5EF4-FFF2-40B4-BE49-F238E27FC236}">
-                <a16:creationId xmlns:a16="http://schemas.microsoft.com/office/drawing/2014/main" id="{381FAAFE-9676-4240-AB39-5C7AAF964B15}"/>
+                <a16:creationId xmlns:a16="http://schemas.microsoft.com/office/drawing/2014/main" id="{A3A202B4-399C-476D-8E40-D393637E5BFE}"/>
               </a:ext>
             </a:extLst>
           </p:cNvPr>
@@ -6943,7 +6943,7 @@
           <p:cNvPr id="16" name="">
             <a:extLst xmlns:a="http://schemas.openxmlformats.org/drawingml/2006/main">
               <a:ext uri="{FF2B5EF4-FFF2-40B4-BE49-F238E27FC236}">
-                <a16:creationId xmlns:a16="http://schemas.microsoft.com/office/drawing/2014/main" id="{A4C193F9-D788-4B1E-A637-1521041E4267}"/>
+                <a16:creationId xmlns:a16="http://schemas.microsoft.com/office/drawing/2014/main" id="{FD557F58-91AF-47C0-B38C-DBB6BDA00558}"/>
               </a:ext>
             </a:extLst>
           </p:cNvPr>
@@ -6976,7 +6976,7 @@
           <p:cNvPr id="17" name="">
             <a:extLst xmlns:a="http://schemas.openxmlformats.org/drawingml/2006/main">
               <a:ext uri="{FF2B5EF4-FFF2-40B4-BE49-F238E27FC236}">
-                <a16:creationId xmlns:a16="http://schemas.microsoft.com/office/drawing/2014/main" id="{C654F1EF-4E19-4565-8C4E-79FA23ECD9BE}"/>
+                <a16:creationId xmlns:a16="http://schemas.microsoft.com/office/drawing/2014/main" id="{D0B6FE04-5E8D-4EF9-9D63-449EC3B14FB0}"/>
               </a:ext>
             </a:extLst>
           </p:cNvPr>
@@ -7026,7 +7026,7 @@
           <p:cNvPr id="18" name="">
             <a:extLst xmlns:a="http://schemas.openxmlformats.org/drawingml/2006/main">
               <a:ext uri="{FF2B5EF4-FFF2-40B4-BE49-F238E27FC236}">
-                <a16:creationId xmlns:a16="http://schemas.microsoft.com/office/drawing/2014/main" id="{8C900086-CCFD-4AC3-946F-4E29A8154189}"/>
+                <a16:creationId xmlns:a16="http://schemas.microsoft.com/office/drawing/2014/main" id="{624ABD45-BB4E-4F74-9CBD-E09653ADF6E5}"/>
               </a:ext>
             </a:extLst>
           </p:cNvPr>
@@ -7076,7 +7076,7 @@
           <p:cNvPr id="19" name="">
             <a:extLst xmlns:a="http://schemas.openxmlformats.org/drawingml/2006/main">
               <a:ext uri="{FF2B5EF4-FFF2-40B4-BE49-F238E27FC236}">
-                <a16:creationId xmlns:a16="http://schemas.microsoft.com/office/drawing/2014/main" id="{D9B91F5B-E85A-4C7B-9866-52854BE7C4B8}"/>
+                <a16:creationId xmlns:a16="http://schemas.microsoft.com/office/drawing/2014/main" id="{D082829D-2442-4F19-93A8-FD7C44D14840}"/>
               </a:ext>
             </a:extLst>
           </p:cNvPr>
@@ -7109,7 +7109,7 @@
           <p:cNvPr id="20" name="">
             <a:extLst xmlns:a="http://schemas.openxmlformats.org/drawingml/2006/main">
               <a:ext uri="{FF2B5EF4-FFF2-40B4-BE49-F238E27FC236}">
-                <a16:creationId xmlns:a16="http://schemas.microsoft.com/office/drawing/2014/main" id="{B9D74AD8-F41E-4E9F-BB4C-9E7DE728040D}"/>
+                <a16:creationId xmlns:a16="http://schemas.microsoft.com/office/drawing/2014/main" id="{F69344F8-E35F-4916-A036-27ECF1943326}"/>
               </a:ext>
             </a:extLst>
           </p:cNvPr>
@@ -7142,7 +7142,7 @@
           <p:cNvPr id="21" name="">
             <a:extLst xmlns:a="http://schemas.openxmlformats.org/drawingml/2006/main">
               <a:ext uri="{FF2B5EF4-FFF2-40B4-BE49-F238E27FC236}">
-                <a16:creationId xmlns:a16="http://schemas.microsoft.com/office/drawing/2014/main" id="{3DCDBACB-0899-45DA-9BD8-CBCD0CEB0C79}"/>
+                <a16:creationId xmlns:a16="http://schemas.microsoft.com/office/drawing/2014/main" id="{08C1C04A-63B4-4F04-86F6-298724167184}"/>
               </a:ext>
             </a:extLst>
           </p:cNvPr>
@@ -7192,7 +7192,7 @@
           <p:cNvPr id="22" name="">
             <a:extLst xmlns:a="http://schemas.openxmlformats.org/drawingml/2006/main">
               <a:ext uri="{FF2B5EF4-FFF2-40B4-BE49-F238E27FC236}">
-                <a16:creationId xmlns:a16="http://schemas.microsoft.com/office/drawing/2014/main" id="{6CFCBDD2-C5C6-4F7E-9807-7BEEC405AAC3}"/>
+                <a16:creationId xmlns:a16="http://schemas.microsoft.com/office/drawing/2014/main" id="{CC24582B-D0DB-4998-A141-F0C5B14E590F}"/>
               </a:ext>
             </a:extLst>
           </p:cNvPr>
@@ -7242,7 +7242,7 @@
           <p:cNvPr id="23" name="">
             <a:extLst xmlns:a="http://schemas.openxmlformats.org/drawingml/2006/main">
               <a:ext uri="{FF2B5EF4-FFF2-40B4-BE49-F238E27FC236}">
-                <a16:creationId xmlns:a16="http://schemas.microsoft.com/office/drawing/2014/main" id="{E2A59551-180E-4D7F-AAA6-255210E5695F}"/>
+                <a16:creationId xmlns:a16="http://schemas.microsoft.com/office/drawing/2014/main" id="{6027637E-E272-4CA6-95D5-4DE11AEBFC9F}"/>
               </a:ext>
             </a:extLst>
           </p:cNvPr>
@@ -7275,7 +7275,7 @@
           <p:cNvPr id="24" name="">
             <a:extLst xmlns:a="http://schemas.openxmlformats.org/drawingml/2006/main">
               <a:ext uri="{FF2B5EF4-FFF2-40B4-BE49-F238E27FC236}">
-                <a16:creationId xmlns:a16="http://schemas.microsoft.com/office/drawing/2014/main" id="{592B2EAD-23BE-4FB7-88DC-BB59B295967C}"/>
+                <a16:creationId xmlns:a16="http://schemas.microsoft.com/office/drawing/2014/main" id="{9262638D-3AFC-49D7-A053-DC658E6864CB}"/>
               </a:ext>
             </a:extLst>
           </p:cNvPr>
@@ -7308,7 +7308,7 @@
           <p:cNvPr id="25" name="">
             <a:extLst xmlns:a="http://schemas.openxmlformats.org/drawingml/2006/main">
               <a:ext uri="{FF2B5EF4-FFF2-40B4-BE49-F238E27FC236}">
-                <a16:creationId xmlns:a16="http://schemas.microsoft.com/office/drawing/2014/main" id="{7CBDB100-9FF7-4362-92E6-B93C0B7115D7}"/>
+                <a16:creationId xmlns:a16="http://schemas.microsoft.com/office/drawing/2014/main" id="{75BFE1A1-EED2-4DC5-92DB-DEAF983EBFDD}"/>
               </a:ext>
             </a:extLst>
           </p:cNvPr>
@@ -7358,7 +7358,7 @@
           <p:cNvPr id="26" name="">
             <a:extLst xmlns:a="http://schemas.openxmlformats.org/drawingml/2006/main">
               <a:ext uri="{FF2B5EF4-FFF2-40B4-BE49-F238E27FC236}">
-                <a16:creationId xmlns:a16="http://schemas.microsoft.com/office/drawing/2014/main" id="{31654CFA-3AB4-4D58-AF44-CC2F21832CBC}"/>
+                <a16:creationId xmlns:a16="http://schemas.microsoft.com/office/drawing/2014/main" id="{1ECE6795-28B7-4F2C-9453-4F049E170E87}"/>
               </a:ext>
             </a:extLst>
           </p:cNvPr>
@@ -7408,7 +7408,7 @@
           <p:cNvPr id="27" name="">
             <a:extLst xmlns:a="http://schemas.openxmlformats.org/drawingml/2006/main">
               <a:ext uri="{FF2B5EF4-FFF2-40B4-BE49-F238E27FC236}">
-                <a16:creationId xmlns:a16="http://schemas.microsoft.com/office/drawing/2014/main" id="{7FE089E5-B51E-4A03-884C-2A93105C30B0}"/>
+                <a16:creationId xmlns:a16="http://schemas.microsoft.com/office/drawing/2014/main" id="{0404AB88-4BC7-46F1-8FFB-C09482506AA0}"/>
               </a:ext>
             </a:extLst>
           </p:cNvPr>
@@ -7441,7 +7441,7 @@
           <p:cNvPr id="28" name="">
             <a:extLst xmlns:a="http://schemas.openxmlformats.org/drawingml/2006/main">
               <a:ext uri="{FF2B5EF4-FFF2-40B4-BE49-F238E27FC236}">
-                <a16:creationId xmlns:a16="http://schemas.microsoft.com/office/drawing/2014/main" id="{84C4707B-BEC7-4172-9A9D-A3A5E483DFF8}"/>
+                <a16:creationId xmlns:a16="http://schemas.microsoft.com/office/drawing/2014/main" id="{C9CC6201-E23B-418D-8B09-2B6B7E65959F}"/>
               </a:ext>
             </a:extLst>
           </p:cNvPr>
@@ -7474,7 +7474,7 @@
           <p:cNvPr id="29" name="">
             <a:extLst xmlns:a="http://schemas.openxmlformats.org/drawingml/2006/main">
               <a:ext uri="{FF2B5EF4-FFF2-40B4-BE49-F238E27FC236}">
-                <a16:creationId xmlns:a16="http://schemas.microsoft.com/office/drawing/2014/main" id="{E9ECD5E0-10DB-476D-8DC2-800A4E34F4F4}"/>
+                <a16:creationId xmlns:a16="http://schemas.microsoft.com/office/drawing/2014/main" id="{D7DEF0B6-3D04-49DC-A5D7-30830E982D4B}"/>
               </a:ext>
             </a:extLst>
           </p:cNvPr>
@@ -7524,7 +7524,7 @@
           <p:cNvPr id="30" name="">
             <a:extLst xmlns:a="http://schemas.openxmlformats.org/drawingml/2006/main">
               <a:ext uri="{FF2B5EF4-FFF2-40B4-BE49-F238E27FC236}">
-                <a16:creationId xmlns:a16="http://schemas.microsoft.com/office/drawing/2014/main" id="{A21E47FD-88C1-4514-ACFB-37DDE6BC78B5}"/>
+                <a16:creationId xmlns:a16="http://schemas.microsoft.com/office/drawing/2014/main" id="{2BA7E32E-0C67-42F0-A67F-AB52C4F1014E}"/>
               </a:ext>
             </a:extLst>
           </p:cNvPr>
@@ -7574,7 +7574,7 @@
           <p:cNvPr id="31" name="">
             <a:extLst xmlns:a="http://schemas.openxmlformats.org/drawingml/2006/main">
               <a:ext uri="{FF2B5EF4-FFF2-40B4-BE49-F238E27FC236}">
-                <a16:creationId xmlns:a16="http://schemas.microsoft.com/office/drawing/2014/main" id="{F6AF695F-D2B8-4177-A17C-754E0B158C03}"/>
+                <a16:creationId xmlns:a16="http://schemas.microsoft.com/office/drawing/2014/main" id="{0859FBC9-17FD-47AE-B172-FB1BF9ADF133}"/>
               </a:ext>
             </a:extLst>
           </p:cNvPr>
@@ -7624,7 +7624,7 @@
           <p:cNvPr id="32" name="">
             <a:extLst xmlns:a="http://schemas.openxmlformats.org/drawingml/2006/main">
               <a:ext uri="{FF2B5EF4-FFF2-40B4-BE49-F238E27FC236}">
-                <a16:creationId xmlns:a16="http://schemas.microsoft.com/office/drawing/2014/main" id="{9794340A-D8AB-44CE-B7F2-A3F1E62A2806}"/>
+                <a16:creationId xmlns:a16="http://schemas.microsoft.com/office/drawing/2014/main" id="{9A93BDC4-73D0-4A2B-A49B-5BD13B841F90}"/>
               </a:ext>
             </a:extLst>
           </p:cNvPr>
@@ -7672,7 +7672,7 @@
     </p:spTree>
     <p:extLst>
       <p:ext uri="{BB962C8B-B14F-4D97-AF65-F5344CB8AC3E}">
-        <p14:creationId xmlns:p14="http://schemas.microsoft.com/office/powerpoint/2010/main" val="1732660588"/>
+        <p14:creationId xmlns:p14="http://schemas.microsoft.com/office/powerpoint/2010/main" val="2127310724"/>
       </p:ext>
     </p:extLst>
   </p:cSld>
@@ -7703,7 +7703,7 @@
           <p:cNvPr id="1" name="">
             <a:extLst xmlns:a="http://schemas.openxmlformats.org/drawingml/2006/main">
               <a:ext uri="{FF2B5EF4-FFF2-40B4-BE49-F238E27FC236}">
-                <a16:creationId xmlns:a16="http://schemas.microsoft.com/office/drawing/2014/main" id="{8B19AEC3-0881-4219-B43E-9EF7FAD63216}"/>
+                <a16:creationId xmlns:a16="http://schemas.microsoft.com/office/drawing/2014/main" id="{AB39AF5B-7B33-4E81-AD4B-8F5D1A22ADAE}"/>
               </a:ext>
             </a:extLst>
           </p:cNvPr>
@@ -7753,7 +7753,7 @@
           <p:cNvPr id="2" name="">
             <a:extLst xmlns:a="http://schemas.openxmlformats.org/drawingml/2006/main">
               <a:ext uri="{FF2B5EF4-FFF2-40B4-BE49-F238E27FC236}">
-                <a16:creationId xmlns:a16="http://schemas.microsoft.com/office/drawing/2014/main" id="{E3E2F8B5-27A1-4AC0-9F09-FACB2D3E0A8D}"/>
+                <a16:creationId xmlns:a16="http://schemas.microsoft.com/office/drawing/2014/main" id="{06C0D899-3381-4718-B0B1-CB9CCF18CB12}"/>
               </a:ext>
             </a:extLst>
           </p:cNvPr>
@@ -7803,7 +7803,7 @@
           <p:cNvPr id="3" name="">
             <a:extLst xmlns:a="http://schemas.openxmlformats.org/drawingml/2006/main">
               <a:ext uri="{FF2B5EF4-FFF2-40B4-BE49-F238E27FC236}">
-                <a16:creationId xmlns:a16="http://schemas.microsoft.com/office/drawing/2014/main" id="{1815335C-0728-423A-B52C-65F73AFCD3F9}"/>
+                <a16:creationId xmlns:a16="http://schemas.microsoft.com/office/drawing/2014/main" id="{C14DB8DB-7D6D-46DE-ADCF-773B8C7D5FFF}"/>
               </a:ext>
             </a:extLst>
           </p:cNvPr>
@@ -7836,7 +7836,7 @@
           <p:cNvPr id="4" name="">
             <a:extLst xmlns:a="http://schemas.openxmlformats.org/drawingml/2006/main">
               <a:ext uri="{FF2B5EF4-FFF2-40B4-BE49-F238E27FC236}">
-                <a16:creationId xmlns:a16="http://schemas.microsoft.com/office/drawing/2014/main" id="{731E59D0-D3EF-4E91-A20D-426E8AB9FAA6}"/>
+                <a16:creationId xmlns:a16="http://schemas.microsoft.com/office/drawing/2014/main" id="{42E81BFD-B181-47A2-9BE7-FD3BD262D05C}"/>
               </a:ext>
             </a:extLst>
           </p:cNvPr>
@@ -7869,7 +7869,7 @@
           <p:cNvPr id="5" name="">
             <a:extLst xmlns:a="http://schemas.openxmlformats.org/drawingml/2006/main">
               <a:ext uri="{FF2B5EF4-FFF2-40B4-BE49-F238E27FC236}">
-                <a16:creationId xmlns:a16="http://schemas.microsoft.com/office/drawing/2014/main" id="{A8D55C09-65A3-45BB-A4E6-9B20D84CF309}"/>
+                <a16:creationId xmlns:a16="http://schemas.microsoft.com/office/drawing/2014/main" id="{A827F69D-22BC-4409-AC2C-ABEB48384844}"/>
               </a:ext>
             </a:extLst>
           </p:cNvPr>
@@ -7919,7 +7919,7 @@
           <p:cNvPr id="6" name="">
             <a:extLst xmlns:a="http://schemas.openxmlformats.org/drawingml/2006/main">
               <a:ext uri="{FF2B5EF4-FFF2-40B4-BE49-F238E27FC236}">
-                <a16:creationId xmlns:a16="http://schemas.microsoft.com/office/drawing/2014/main" id="{91F50D13-898A-4D99-BE7D-ECAF8E0BF1C0}"/>
+                <a16:creationId xmlns:a16="http://schemas.microsoft.com/office/drawing/2014/main" id="{D9EB83D3-1BA5-4948-93A1-A48D2915D6D8}"/>
               </a:ext>
             </a:extLst>
           </p:cNvPr>
@@ -7969,7 +7969,7 @@
           <p:cNvPr id="7" name="">
             <a:extLst xmlns:a="http://schemas.openxmlformats.org/drawingml/2006/main">
               <a:ext uri="{FF2B5EF4-FFF2-40B4-BE49-F238E27FC236}">
-                <a16:creationId xmlns:a16="http://schemas.microsoft.com/office/drawing/2014/main" id="{CC054030-A260-4BCC-9709-9BA9AA386289}"/>
+                <a16:creationId xmlns:a16="http://schemas.microsoft.com/office/drawing/2014/main" id="{7AE3E591-2D84-41F2-A0F8-3FE5A3CE32D3}"/>
               </a:ext>
             </a:extLst>
           </p:cNvPr>
@@ -8002,7 +8002,7 @@
           <p:cNvPr id="8" name="">
             <a:extLst xmlns:a="http://schemas.openxmlformats.org/drawingml/2006/main">
               <a:ext uri="{FF2B5EF4-FFF2-40B4-BE49-F238E27FC236}">
-                <a16:creationId xmlns:a16="http://schemas.microsoft.com/office/drawing/2014/main" id="{30FCADA8-6C31-4F11-B490-1C0B7D02DC32}"/>
+                <a16:creationId xmlns:a16="http://schemas.microsoft.com/office/drawing/2014/main" id="{1CEEFAE1-78C1-4138-99B2-408A55969B53}"/>
               </a:ext>
             </a:extLst>
           </p:cNvPr>
@@ -8052,7 +8052,7 @@
           <p:cNvPr id="9" name="">
             <a:extLst xmlns:a="http://schemas.openxmlformats.org/drawingml/2006/main">
               <a:ext uri="{FF2B5EF4-FFF2-40B4-BE49-F238E27FC236}">
-                <a16:creationId xmlns:a16="http://schemas.microsoft.com/office/drawing/2014/main" id="{1902A976-E904-4ECC-8B77-164C2E3808D2}"/>
+                <a16:creationId xmlns:a16="http://schemas.microsoft.com/office/drawing/2014/main" id="{3DC666C7-02F4-45B4-88C3-C69832492418}"/>
               </a:ext>
             </a:extLst>
           </p:cNvPr>
@@ -8102,7 +8102,7 @@
           <p:cNvPr id="10" name="">
             <a:extLst xmlns:a="http://schemas.openxmlformats.org/drawingml/2006/main">
               <a:ext uri="{FF2B5EF4-FFF2-40B4-BE49-F238E27FC236}">
-                <a16:creationId xmlns:a16="http://schemas.microsoft.com/office/drawing/2014/main" id="{1B4CBE26-4716-4986-B7D0-37D77EA7B6C5}"/>
+                <a16:creationId xmlns:a16="http://schemas.microsoft.com/office/drawing/2014/main" id="{CBBE910D-4030-43B9-8703-1421A5DB464E}"/>
               </a:ext>
             </a:extLst>
           </p:cNvPr>
@@ -8135,7 +8135,7 @@
           <p:cNvPr id="11" name="">
             <a:extLst xmlns:a="http://schemas.openxmlformats.org/drawingml/2006/main">
               <a:ext uri="{FF2B5EF4-FFF2-40B4-BE49-F238E27FC236}">
-                <a16:creationId xmlns:a16="http://schemas.microsoft.com/office/drawing/2014/main" id="{25C98B8D-DDD4-43EF-9767-F46DA8D13433}"/>
+                <a16:creationId xmlns:a16="http://schemas.microsoft.com/office/drawing/2014/main" id="{0EBC95DE-B1F0-44F8-B6F1-269A3580CE73}"/>
               </a:ext>
             </a:extLst>
           </p:cNvPr>
@@ -8185,7 +8185,7 @@
           <p:cNvPr id="12" name="">
             <a:extLst xmlns:a="http://schemas.openxmlformats.org/drawingml/2006/main">
               <a:ext uri="{FF2B5EF4-FFF2-40B4-BE49-F238E27FC236}">
-                <a16:creationId xmlns:a16="http://schemas.microsoft.com/office/drawing/2014/main" id="{114CBA08-F55F-4906-97A3-46325457C57C}"/>
+                <a16:creationId xmlns:a16="http://schemas.microsoft.com/office/drawing/2014/main" id="{16452E6F-A615-4AE5-8BF2-661D6C5ED9EC}"/>
               </a:ext>
             </a:extLst>
           </p:cNvPr>
@@ -8225,7 +8225,7 @@
                   <a:srgbClr val="0A0A0A"/>
                 </a:solidFill>
               </a:rPr>
-              <a:t>MAP-style penalty loss; Adam completed result; SGD supported for closer historical rerun</a:t>
+              <a:t>MAP-style penalty loss; SGD optimizer with learning rate 0.01</a:t>
             </a:r>
           </a:p>
         </p:txBody>
@@ -8235,7 +8235,7 @@
           <p:cNvPr id="13" name="">
             <a:extLst xmlns:a="http://schemas.openxmlformats.org/drawingml/2006/main">
               <a:ext uri="{FF2B5EF4-FFF2-40B4-BE49-F238E27FC236}">
-                <a16:creationId xmlns:a16="http://schemas.microsoft.com/office/drawing/2014/main" id="{BA0BC6FB-C000-4730-BF7A-664F35972CA3}"/>
+                <a16:creationId xmlns:a16="http://schemas.microsoft.com/office/drawing/2014/main" id="{4EA17F86-9D8F-4B8A-A078-E694EA884F50}"/>
               </a:ext>
             </a:extLst>
           </p:cNvPr>
@@ -8283,7 +8283,7 @@
     </p:spTree>
     <p:extLst>
       <p:ext uri="{BB962C8B-B14F-4D97-AF65-F5344CB8AC3E}">
-        <p14:creationId xmlns:p14="http://schemas.microsoft.com/office/powerpoint/2010/main" val="1908269455"/>
+        <p14:creationId xmlns:p14="http://schemas.microsoft.com/office/powerpoint/2010/main" val="425005295"/>
       </p:ext>
     </p:extLst>
   </p:cSld>
@@ -8314,7 +8314,7 @@
           <p:cNvPr id="1" name="">
             <a:extLst xmlns:a="http://schemas.openxmlformats.org/drawingml/2006/main">
               <a:ext uri="{FF2B5EF4-FFF2-40B4-BE49-F238E27FC236}">
-                <a16:creationId xmlns:a16="http://schemas.microsoft.com/office/drawing/2014/main" id="{7D9E8CA6-D9E8-48C7-955D-E44913108327}"/>
+                <a16:creationId xmlns:a16="http://schemas.microsoft.com/office/drawing/2014/main" id="{3953EE8D-40B2-45AD-B24C-C60C2DF94043}"/>
               </a:ext>
             </a:extLst>
           </p:cNvPr>
@@ -8364,7 +8364,7 @@
           <p:cNvPr id="2" name="">
             <a:extLst xmlns:a="http://schemas.openxmlformats.org/drawingml/2006/main">
               <a:ext uri="{FF2B5EF4-FFF2-40B4-BE49-F238E27FC236}">
-                <a16:creationId xmlns:a16="http://schemas.microsoft.com/office/drawing/2014/main" id="{CBED76CF-5ED5-4208-9442-4864973E72F2}"/>
+                <a16:creationId xmlns:a16="http://schemas.microsoft.com/office/drawing/2014/main" id="{5F803A8C-E98A-4C60-9542-91512724B216}"/>
               </a:ext>
             </a:extLst>
           </p:cNvPr>
@@ -8414,7 +8414,7 @@
           <p:cNvPr id="3" name="">
             <a:extLst xmlns:a="http://schemas.openxmlformats.org/drawingml/2006/main">
               <a:ext uri="{FF2B5EF4-FFF2-40B4-BE49-F238E27FC236}">
-                <a16:creationId xmlns:a16="http://schemas.microsoft.com/office/drawing/2014/main" id="{D5D024E8-EB15-4B05-800C-4CC9D01C6381}"/>
+                <a16:creationId xmlns:a16="http://schemas.microsoft.com/office/drawing/2014/main" id="{E1FE6FE5-B059-4952-927A-7A1E1C2B3B31}"/>
               </a:ext>
             </a:extLst>
           </p:cNvPr>
@@ -8447,7 +8447,7 @@
           <p:cNvPr id="4" name="">
             <a:extLst xmlns:a="http://schemas.openxmlformats.org/drawingml/2006/main">
               <a:ext uri="{FF2B5EF4-FFF2-40B4-BE49-F238E27FC236}">
-                <a16:creationId xmlns:a16="http://schemas.microsoft.com/office/drawing/2014/main" id="{33AEC8EF-9A8D-473B-8D1B-6CB8200B1E4C}"/>
+                <a16:creationId xmlns:a16="http://schemas.microsoft.com/office/drawing/2014/main" id="{E987FBF3-F4C8-4415-A417-CAF6E5781BB4}"/>
               </a:ext>
             </a:extLst>
           </p:cNvPr>
@@ -8480,7 +8480,7 @@
           <p:cNvPr id="5" name="">
             <a:extLst xmlns:a="http://schemas.openxmlformats.org/drawingml/2006/main">
               <a:ext uri="{FF2B5EF4-FFF2-40B4-BE49-F238E27FC236}">
-                <a16:creationId xmlns:a16="http://schemas.microsoft.com/office/drawing/2014/main" id="{DA316D26-6116-4CE7-B1B7-82F69D6932A7}"/>
+                <a16:creationId xmlns:a16="http://schemas.microsoft.com/office/drawing/2014/main" id="{E32E236F-196A-4EBC-9BCC-DA804D19C0FA}"/>
               </a:ext>
             </a:extLst>
           </p:cNvPr>
@@ -8520,7 +8520,7 @@
                   <a:srgbClr val="0A0A0A"/>
                 </a:solidFill>
               </a:rPr>
-              <a:t>8</a:t>
+              <a:t>20</a:t>
             </a:r>
           </a:p>
         </p:txBody>
@@ -8530,7 +8530,7 @@
           <p:cNvPr id="6" name="">
             <a:extLst xmlns:a="http://schemas.openxmlformats.org/drawingml/2006/main">
               <a:ext uri="{FF2B5EF4-FFF2-40B4-BE49-F238E27FC236}">
-                <a16:creationId xmlns:a16="http://schemas.microsoft.com/office/drawing/2014/main" id="{1CD9CC1A-A40E-4FF5-9BCB-B60D307A06BD}"/>
+                <a16:creationId xmlns:a16="http://schemas.microsoft.com/office/drawing/2014/main" id="{95821FA5-CE7E-44B7-8593-06E00F71EAD6}"/>
               </a:ext>
             </a:extLst>
           </p:cNvPr>
@@ -8580,7 +8580,7 @@
           <p:cNvPr id="7" name="">
             <a:extLst xmlns:a="http://schemas.openxmlformats.org/drawingml/2006/main">
               <a:ext uri="{FF2B5EF4-FFF2-40B4-BE49-F238E27FC236}">
-                <a16:creationId xmlns:a16="http://schemas.microsoft.com/office/drawing/2014/main" id="{5DFEEFA4-1A79-4274-A9EF-CCD0434D7DA9}"/>
+                <a16:creationId xmlns:a16="http://schemas.microsoft.com/office/drawing/2014/main" id="{D993A810-3FBB-40C5-95D4-445298DEF027}"/>
               </a:ext>
             </a:extLst>
           </p:cNvPr>
@@ -8630,7 +8630,7 @@
           <p:cNvPr id="8" name="">
             <a:extLst xmlns:a="http://schemas.openxmlformats.org/drawingml/2006/main">
               <a:ext uri="{FF2B5EF4-FFF2-40B4-BE49-F238E27FC236}">
-                <a16:creationId xmlns:a16="http://schemas.microsoft.com/office/drawing/2014/main" id="{E8F45190-235B-472E-AF6B-1ADE12FF06B8}"/>
+                <a16:creationId xmlns:a16="http://schemas.microsoft.com/office/drawing/2014/main" id="{D691E43C-BFAB-4E64-AEC8-BEBF6999C72F}"/>
               </a:ext>
             </a:extLst>
           </p:cNvPr>
@@ -8680,7 +8680,7 @@
           <p:cNvPr id="9" name="">
             <a:extLst xmlns:a="http://schemas.openxmlformats.org/drawingml/2006/main">
               <a:ext uri="{FF2B5EF4-FFF2-40B4-BE49-F238E27FC236}">
-                <a16:creationId xmlns:a16="http://schemas.microsoft.com/office/drawing/2014/main" id="{E3D6FACA-D3AD-45C7-844A-378ACB492BDE}"/>
+                <a16:creationId xmlns:a16="http://schemas.microsoft.com/office/drawing/2014/main" id="{E56FC0EF-DD84-4C77-8C8B-30FFDAACA5F1}"/>
               </a:ext>
             </a:extLst>
           </p:cNvPr>
@@ -8720,7 +8720,7 @@
                   <a:srgbClr val="0A0A0A"/>
                 </a:solidFill>
               </a:rPr>
-              <a:t>0.001</a:t>
+              <a:t>0.01</a:t>
             </a:r>
           </a:p>
         </p:txBody>
@@ -8730,7 +8730,7 @@
           <p:cNvPr id="10" name="">
             <a:extLst xmlns:a="http://schemas.openxmlformats.org/drawingml/2006/main">
               <a:ext uri="{FF2B5EF4-FFF2-40B4-BE49-F238E27FC236}">
-                <a16:creationId xmlns:a16="http://schemas.microsoft.com/office/drawing/2014/main" id="{D5CE373F-3749-4D63-874C-A7746EE13AB5}"/>
+                <a16:creationId xmlns:a16="http://schemas.microsoft.com/office/drawing/2014/main" id="{9097E8D3-7D75-4CD7-AF96-EFDE620AB146}"/>
               </a:ext>
             </a:extLst>
           </p:cNvPr>
@@ -8780,7 +8780,7 @@
           <p:cNvPr id="11" name="">
             <a:extLst xmlns:a="http://schemas.openxmlformats.org/drawingml/2006/main">
               <a:ext uri="{FF2B5EF4-FFF2-40B4-BE49-F238E27FC236}">
-                <a16:creationId xmlns:a16="http://schemas.microsoft.com/office/drawing/2014/main" id="{F3106066-8026-4A97-BB84-3D78D454EDBC}"/>
+                <a16:creationId xmlns:a16="http://schemas.microsoft.com/office/drawing/2014/main" id="{AD95E808-9B9D-4614-BE71-170592ED1A82}"/>
               </a:ext>
             </a:extLst>
           </p:cNvPr>
@@ -8830,7 +8830,7 @@
           <p:cNvPr id="12" name="">
             <a:extLst xmlns:a="http://schemas.openxmlformats.org/drawingml/2006/main">
               <a:ext uri="{FF2B5EF4-FFF2-40B4-BE49-F238E27FC236}">
-                <a16:creationId xmlns:a16="http://schemas.microsoft.com/office/drawing/2014/main" id="{DF6DF340-C851-422F-AFE8-605363E6BB7D}"/>
+                <a16:creationId xmlns:a16="http://schemas.microsoft.com/office/drawing/2014/main" id="{43F22685-6016-463E-9E82-7733E483D87C}"/>
               </a:ext>
             </a:extLst>
           </p:cNvPr>
@@ -8880,7 +8880,7 @@
           <p:cNvPr id="13" name="">
             <a:extLst xmlns:a="http://schemas.openxmlformats.org/drawingml/2006/main">
               <a:ext uri="{FF2B5EF4-FFF2-40B4-BE49-F238E27FC236}">
-                <a16:creationId xmlns:a16="http://schemas.microsoft.com/office/drawing/2014/main" id="{F48ACB5F-EF44-4358-B4D6-40664016731A}"/>
+                <a16:creationId xmlns:a16="http://schemas.microsoft.com/office/drawing/2014/main" id="{7DDCC121-B4FD-4DB4-9F09-A8DE5EDE32BB}"/>
               </a:ext>
             </a:extLst>
           </p:cNvPr>
@@ -8920,7 +8920,7 @@
                   <a:srgbClr val="0A0A0A"/>
                 </a:solidFill>
               </a:rPr>
-              <a:t>Optimizer: Adam result; SGD supported | Loss: LeNet MAP-style RBF penalty | Seed: 42 | Device: CPU</a:t>
+              <a:t>Optimizer: SGD | Loss: LeNet MAP-style RBF penalty | Seed: 42 | Device: CPU</a:t>
             </a:r>
           </a:p>
         </p:txBody>
@@ -8930,7 +8930,7 @@
           <p:cNvPr id="14" name="">
             <a:extLst xmlns:a="http://schemas.openxmlformats.org/drawingml/2006/main">
               <a:ext uri="{FF2B5EF4-FFF2-40B4-BE49-F238E27FC236}">
-                <a16:creationId xmlns:a16="http://schemas.microsoft.com/office/drawing/2014/main" id="{01B041E6-F537-4C3A-A997-E611F997E5FF}"/>
+                <a16:creationId xmlns:a16="http://schemas.microsoft.com/office/drawing/2014/main" id="{00EC6764-1F89-4344-810A-84DE355FDFCA}"/>
               </a:ext>
             </a:extLst>
           </p:cNvPr>
@@ -8978,7 +8978,7 @@
     </p:spTree>
     <p:extLst>
       <p:ext uri="{BB962C8B-B14F-4D97-AF65-F5344CB8AC3E}">
-        <p14:creationId xmlns:p14="http://schemas.microsoft.com/office/powerpoint/2010/main" val="208282933"/>
+        <p14:creationId xmlns:p14="http://schemas.microsoft.com/office/powerpoint/2010/main" val="265735120"/>
       </p:ext>
     </p:extLst>
   </p:cSld>
@@ -9009,7 +9009,7 @@
           <p:cNvPr id="1" name="">
             <a:extLst xmlns:a="http://schemas.openxmlformats.org/drawingml/2006/main">
               <a:ext uri="{FF2B5EF4-FFF2-40B4-BE49-F238E27FC236}">
-                <a16:creationId xmlns:a16="http://schemas.microsoft.com/office/drawing/2014/main" id="{5FABFE36-501D-411D-8976-4F1763310E04}"/>
+                <a16:creationId xmlns:a16="http://schemas.microsoft.com/office/drawing/2014/main" id="{322975A5-BCA8-42B3-8056-12F4C39F65A0}"/>
               </a:ext>
             </a:extLst>
           </p:cNvPr>
@@ -9059,7 +9059,7 @@
           <p:cNvPr id="2" name="">
             <a:extLst xmlns:a="http://schemas.openxmlformats.org/drawingml/2006/main">
               <a:ext uri="{FF2B5EF4-FFF2-40B4-BE49-F238E27FC236}">
-                <a16:creationId xmlns:a16="http://schemas.microsoft.com/office/drawing/2014/main" id="{CFE83838-EB07-4009-861A-F83D3410B6C4}"/>
+                <a16:creationId xmlns:a16="http://schemas.microsoft.com/office/drawing/2014/main" id="{210969FF-40DC-4267-A76E-ECF233BF0BD7}"/>
               </a:ext>
             </a:extLst>
           </p:cNvPr>
@@ -9109,7 +9109,7 @@
           <p:cNvPr id="3" name="">
             <a:extLst xmlns:a="http://schemas.openxmlformats.org/drawingml/2006/main">
               <a:ext uri="{FF2B5EF4-FFF2-40B4-BE49-F238E27FC236}">
-                <a16:creationId xmlns:a16="http://schemas.microsoft.com/office/drawing/2014/main" id="{6948A324-EF3A-4BB0-8498-ABA9C6C4F682}"/>
+                <a16:creationId xmlns:a16="http://schemas.microsoft.com/office/drawing/2014/main" id="{FD04312E-225B-4496-A7AD-F39B2069EEA0}"/>
               </a:ext>
             </a:extLst>
           </p:cNvPr>
@@ -9142,7 +9142,7 @@
           <p:cNvPr id="4" name="">
             <a:extLst xmlns:a="http://schemas.openxmlformats.org/drawingml/2006/main">
               <a:ext uri="{FF2B5EF4-FFF2-40B4-BE49-F238E27FC236}">
-                <a16:creationId xmlns:a16="http://schemas.microsoft.com/office/drawing/2014/main" id="{4F7A3BCF-8D4B-42CD-99DB-0F210C7952FB}"/>
+                <a16:creationId xmlns:a16="http://schemas.microsoft.com/office/drawing/2014/main" id="{6387D99C-21A8-4C7B-A1EC-73A2E4EA8095}"/>
               </a:ext>
             </a:extLst>
           </p:cNvPr>
@@ -9182,7 +9182,7 @@
                   <a:srgbClr val="2F7D55"/>
                 </a:solidFill>
               </a:rPr>
-              <a:t>98.64%</a:t>
+              <a:t>98.94%</a:t>
             </a:r>
           </a:p>
         </p:txBody>
@@ -9192,7 +9192,7 @@
           <p:cNvPr id="5" name="">
             <a:extLst xmlns:a="http://schemas.openxmlformats.org/drawingml/2006/main">
               <a:ext uri="{FF2B5EF4-FFF2-40B4-BE49-F238E27FC236}">
-                <a16:creationId xmlns:a16="http://schemas.microsoft.com/office/drawing/2014/main" id="{52AC0E5D-3043-4C15-86B2-94BA3E16E25C}"/>
+                <a16:creationId xmlns:a16="http://schemas.microsoft.com/office/drawing/2014/main" id="{D7AC9903-3D16-4D71-B27B-9DE059712DA7}"/>
               </a:ext>
             </a:extLst>
           </p:cNvPr>
@@ -9242,7 +9242,7 @@
           <p:cNvPr id="6" name="">
             <a:extLst xmlns:a="http://schemas.openxmlformats.org/drawingml/2006/main">
               <a:ext uri="{FF2B5EF4-FFF2-40B4-BE49-F238E27FC236}">
-                <a16:creationId xmlns:a16="http://schemas.microsoft.com/office/drawing/2014/main" id="{FFBB2A5F-E113-4164-A9C7-A0845C4DE9AF}"/>
+                <a16:creationId xmlns:a16="http://schemas.microsoft.com/office/drawing/2014/main" id="{1DB7A864-AA95-40F3-9958-F9C8FA9ED0D0}"/>
               </a:ext>
             </a:extLst>
           </p:cNvPr>
@@ -9282,7 +9282,7 @@
                   <a:srgbClr val="2F7D55"/>
                 </a:solidFill>
               </a:rPr>
-              <a:t>98.87%</a:t>
+              <a:t>98.93%</a:t>
             </a:r>
           </a:p>
         </p:txBody>
@@ -9292,7 +9292,7 @@
           <p:cNvPr id="7" name="">
             <a:extLst xmlns:a="http://schemas.openxmlformats.org/drawingml/2006/main">
               <a:ext uri="{FF2B5EF4-FFF2-40B4-BE49-F238E27FC236}">
-                <a16:creationId xmlns:a16="http://schemas.microsoft.com/office/drawing/2014/main" id="{577BF3D4-A45D-4C12-B910-92E375B2BCE8}"/>
+                <a16:creationId xmlns:a16="http://schemas.microsoft.com/office/drawing/2014/main" id="{4332872A-2ED4-4C11-9DCE-B4DAEA3E5B94}"/>
               </a:ext>
             </a:extLst>
           </p:cNvPr>
@@ -9342,7 +9342,7 @@
           <p:cNvPr id="8" name="">
             <a:extLst xmlns:a="http://schemas.openxmlformats.org/drawingml/2006/main">
               <a:ext uri="{FF2B5EF4-FFF2-40B4-BE49-F238E27FC236}">
-                <a16:creationId xmlns:a16="http://schemas.microsoft.com/office/drawing/2014/main" id="{D7FDA5E2-DF36-4131-A654-055821DB64C1}"/>
+                <a16:creationId xmlns:a16="http://schemas.microsoft.com/office/drawing/2014/main" id="{4120471C-A234-4F49-B36D-E33D3E98CD1A}"/>
               </a:ext>
             </a:extLst>
           </p:cNvPr>
@@ -9382,7 +9382,7 @@
                   <a:srgbClr val="FF6B35"/>
                 </a:solidFill>
               </a:rPr>
-              <a:t>1.13%</a:t>
+              <a:t>1.07%</a:t>
             </a:r>
           </a:p>
         </p:txBody>
@@ -9392,7 +9392,7 @@
           <p:cNvPr id="9" name="">
             <a:extLst xmlns:a="http://schemas.openxmlformats.org/drawingml/2006/main">
               <a:ext uri="{FF2B5EF4-FFF2-40B4-BE49-F238E27FC236}">
-                <a16:creationId xmlns:a16="http://schemas.microsoft.com/office/drawing/2014/main" id="{E6B9F277-9CAF-46D7-BD12-1D3CA8DB600B}"/>
+                <a16:creationId xmlns:a16="http://schemas.microsoft.com/office/drawing/2014/main" id="{7A2B3F70-AEC1-47F5-8736-545B1958A1DB}"/>
               </a:ext>
             </a:extLst>
           </p:cNvPr>
@@ -9442,7 +9442,7 @@
           <p:cNvPr id="10" name="">
             <a:extLst xmlns:a="http://schemas.openxmlformats.org/drawingml/2006/main">
               <a:ext uri="{FF2B5EF4-FFF2-40B4-BE49-F238E27FC236}">
-                <a16:creationId xmlns:a16="http://schemas.microsoft.com/office/drawing/2014/main" id="{BDC93E29-C2DA-4F12-BA73-C4F39B9FA2BA}"/>
+                <a16:creationId xmlns:a16="http://schemas.microsoft.com/office/drawing/2014/main" id="{8604737C-89CB-4D3F-A2D0-6B7711948127}"/>
               </a:ext>
             </a:extLst>
           </p:cNvPr>
@@ -9475,7 +9475,7 @@
           <p:cNvPr id="11" name="">
             <a:extLst xmlns:a="http://schemas.openxmlformats.org/drawingml/2006/main">
               <a:ext uri="{FF2B5EF4-FFF2-40B4-BE49-F238E27FC236}">
-                <a16:creationId xmlns:a16="http://schemas.microsoft.com/office/drawing/2014/main" id="{89810343-FCA0-4542-9EF5-897A9ECA939E}"/>
+                <a16:creationId xmlns:a16="http://schemas.microsoft.com/office/drawing/2014/main" id="{CE4E5798-27F7-4504-AA0A-C7F64B448BCA}"/>
               </a:ext>
             </a:extLst>
           </p:cNvPr>
@@ -9515,7 +9515,7 @@
                   <a:srgbClr val="0A0A0A"/>
                 </a:solidFill>
               </a:rPr>
-              <a:t>This satisfies the course feasibility constraint comfortably: the full final run trained end-to-end on CPU in 125.94 seconds.</a:t>
+              <a:t>This satisfies the course feasibility constraint comfortably: the full final run trained end-to-end on CPU in 146.91 seconds.</a:t>
             </a:r>
           </a:p>
         </p:txBody>
@@ -9525,7 +9525,7 @@
           <p:cNvPr id="12" name="">
             <a:extLst xmlns:a="http://schemas.openxmlformats.org/drawingml/2006/main">
               <a:ext uri="{FF2B5EF4-FFF2-40B4-BE49-F238E27FC236}">
-                <a16:creationId xmlns:a16="http://schemas.microsoft.com/office/drawing/2014/main" id="{198C2209-CE01-4DA7-B34A-8A73CEBFCEC4}"/>
+                <a16:creationId xmlns:a16="http://schemas.microsoft.com/office/drawing/2014/main" id="{C26C66F3-4E7E-4C94-9D3E-9EE1FFEAABD7}"/>
               </a:ext>
             </a:extLst>
           </p:cNvPr>
@@ -9573,7 +9573,7 @@
     </p:spTree>
     <p:extLst>
       <p:ext uri="{BB962C8B-B14F-4D97-AF65-F5344CB8AC3E}">
-        <p14:creationId xmlns:p14="http://schemas.microsoft.com/office/powerpoint/2010/main" val="973438351"/>
+        <p14:creationId xmlns:p14="http://schemas.microsoft.com/office/powerpoint/2010/main" val="83881764"/>
       </p:ext>
     </p:extLst>
   </p:cSld>
@@ -9604,7 +9604,7 @@
           <p:cNvPr id="1" name="">
             <a:extLst xmlns:a="http://schemas.openxmlformats.org/drawingml/2006/main">
               <a:ext uri="{FF2B5EF4-FFF2-40B4-BE49-F238E27FC236}">
-                <a16:creationId xmlns:a16="http://schemas.microsoft.com/office/drawing/2014/main" id="{3B66E118-496A-4045-B711-5A5AD4522397}"/>
+                <a16:creationId xmlns:a16="http://schemas.microsoft.com/office/drawing/2014/main" id="{28E470D8-EA95-4DD1-873B-43443913BA08}"/>
               </a:ext>
             </a:extLst>
           </p:cNvPr>
@@ -9654,7 +9654,7 @@
           <p:cNvPr id="2" name="">
             <a:extLst xmlns:a="http://schemas.openxmlformats.org/drawingml/2006/main">
               <a:ext uri="{FF2B5EF4-FFF2-40B4-BE49-F238E27FC236}">
-                <a16:creationId xmlns:a16="http://schemas.microsoft.com/office/drawing/2014/main" id="{FF691265-004B-49A4-804C-440DEEE1C8F9}"/>
+                <a16:creationId xmlns:a16="http://schemas.microsoft.com/office/drawing/2014/main" id="{95D0F830-B805-4B25-85FB-131420E24EB2}"/>
               </a:ext>
             </a:extLst>
           </p:cNvPr>
@@ -9704,7 +9704,7 @@
           <p:cNvPr id="3" name="">
             <a:extLst xmlns:a="http://schemas.openxmlformats.org/drawingml/2006/main">
               <a:ext uri="{FF2B5EF4-FFF2-40B4-BE49-F238E27FC236}">
-                <a16:creationId xmlns:a16="http://schemas.microsoft.com/office/drawing/2014/main" id="{39B06AA2-477A-4CC2-BE4D-3740F820EC8D}"/>
+                <a16:creationId xmlns:a16="http://schemas.microsoft.com/office/drawing/2014/main" id="{081CDB2E-8904-400F-AECD-946D51B626E8}"/>
               </a:ext>
             </a:extLst>
           </p:cNvPr>
@@ -9741,7 +9741,7 @@
           <p:nvPr/>
         </p:nvPicPr>
         <p:blipFill>
-          <a:blip xmlns:r="http://schemas.openxmlformats.org/officeDocument/2006/relationships" xmlns:a="http://schemas.openxmlformats.org/drawingml/2006/main" r:embed="Rf7dc9ed16d174dc2"/>
+          <a:blip xmlns:r="http://schemas.openxmlformats.org/officeDocument/2006/relationships" xmlns:a="http://schemas.openxmlformats.org/drawingml/2006/main" r:embed="R7c0086cf51e543e8"/>
           <a:stretch xmlns:a="http://schemas.openxmlformats.org/drawingml/2006/main"/>
         </p:blipFill>
         <p:spPr>
@@ -9759,7 +9759,7 @@
           <p:cNvPr id="5" name="">
             <a:extLst xmlns:a="http://schemas.openxmlformats.org/drawingml/2006/main">
               <a:ext uri="{FF2B5EF4-FFF2-40B4-BE49-F238E27FC236}">
-                <a16:creationId xmlns:a16="http://schemas.microsoft.com/office/drawing/2014/main" id="{DC879DC2-533D-4932-BABF-6176E24EF00C}"/>
+                <a16:creationId xmlns:a16="http://schemas.microsoft.com/office/drawing/2014/main" id="{14E621DB-1553-4765-8D3C-6A7C708C9845}"/>
               </a:ext>
             </a:extLst>
           </p:cNvPr>
@@ -9807,7 +9807,7 @@
     </p:spTree>
     <p:extLst>
       <p:ext uri="{BB962C8B-B14F-4D97-AF65-F5344CB8AC3E}">
-        <p14:creationId xmlns:p14="http://schemas.microsoft.com/office/powerpoint/2010/main" val="1851885999"/>
+        <p14:creationId xmlns:p14="http://schemas.microsoft.com/office/powerpoint/2010/main" val="1685535965"/>
       </p:ext>
     </p:extLst>
   </p:cSld>
@@ -9838,7 +9838,7 @@
           <p:cNvPr id="1" name="">
             <a:extLst xmlns:a="http://schemas.openxmlformats.org/drawingml/2006/main">
               <a:ext uri="{FF2B5EF4-FFF2-40B4-BE49-F238E27FC236}">
-                <a16:creationId xmlns:a16="http://schemas.microsoft.com/office/drawing/2014/main" id="{3082260A-5D95-40C9-91EA-F82FB0BEAB1F}"/>
+                <a16:creationId xmlns:a16="http://schemas.microsoft.com/office/drawing/2014/main" id="{0F2988BF-DBA8-4712-BD36-0952FA7CF310}"/>
               </a:ext>
             </a:extLst>
           </p:cNvPr>
@@ -9888,7 +9888,7 @@
           <p:cNvPr id="2" name="">
             <a:extLst xmlns:a="http://schemas.openxmlformats.org/drawingml/2006/main">
               <a:ext uri="{FF2B5EF4-FFF2-40B4-BE49-F238E27FC236}">
-                <a16:creationId xmlns:a16="http://schemas.microsoft.com/office/drawing/2014/main" id="{BAC2C035-D5F1-401A-9744-EF9C794B07A4}"/>
+                <a16:creationId xmlns:a16="http://schemas.microsoft.com/office/drawing/2014/main" id="{914DAF91-66DC-42CF-A528-033B3FA33877}"/>
               </a:ext>
             </a:extLst>
           </p:cNvPr>
@@ -9938,7 +9938,7 @@
           <p:cNvPr id="3" name="">
             <a:extLst xmlns:a="http://schemas.openxmlformats.org/drawingml/2006/main">
               <a:ext uri="{FF2B5EF4-FFF2-40B4-BE49-F238E27FC236}">
-                <a16:creationId xmlns:a16="http://schemas.microsoft.com/office/drawing/2014/main" id="{E43FA927-3FD2-499D-8465-6CEED9D9E7B2}"/>
+                <a16:creationId xmlns:a16="http://schemas.microsoft.com/office/drawing/2014/main" id="{CE74D53A-F87C-4769-8C02-F2BE7D5E23E4}"/>
               </a:ext>
             </a:extLst>
           </p:cNvPr>
@@ -9975,7 +9975,7 @@
           <p:nvPr/>
         </p:nvPicPr>
         <p:blipFill>
-          <a:blip xmlns:r="http://schemas.openxmlformats.org/officeDocument/2006/relationships" xmlns:a="http://schemas.openxmlformats.org/drawingml/2006/main" r:embed="Rd191008085dd402d"/>
+          <a:blip xmlns:r="http://schemas.openxmlformats.org/officeDocument/2006/relationships" xmlns:a="http://schemas.openxmlformats.org/drawingml/2006/main" r:embed="Rdf287c1335ad43ed"/>
           <a:stretch xmlns:a="http://schemas.openxmlformats.org/drawingml/2006/main"/>
         </p:blipFill>
         <p:spPr>
@@ -9993,7 +9993,7 @@
           <p:cNvPr id="5" name="">
             <a:extLst xmlns:a="http://schemas.openxmlformats.org/drawingml/2006/main">
               <a:ext uri="{FF2B5EF4-FFF2-40B4-BE49-F238E27FC236}">
-                <a16:creationId xmlns:a16="http://schemas.microsoft.com/office/drawing/2014/main" id="{330E2E1E-E15E-43A9-A8C2-FF6E02520F13}"/>
+                <a16:creationId xmlns:a16="http://schemas.microsoft.com/office/drawing/2014/main" id="{12C2A5A7-1640-4229-AF76-22F99F7E8F7E}"/>
               </a:ext>
             </a:extLst>
           </p:cNvPr>
@@ -10026,7 +10026,7 @@
           <p:cNvPr id="6" name="">
             <a:extLst xmlns:a="http://schemas.openxmlformats.org/drawingml/2006/main">
               <a:ext uri="{FF2B5EF4-FFF2-40B4-BE49-F238E27FC236}">
-                <a16:creationId xmlns:a16="http://schemas.microsoft.com/office/drawing/2014/main" id="{60FE9CC6-2A23-47D8-A848-F77AD987387C}"/>
+                <a16:creationId xmlns:a16="http://schemas.microsoft.com/office/drawing/2014/main" id="{C9768837-8B52-4C89-87A1-5A7944607457}"/>
               </a:ext>
             </a:extLst>
           </p:cNvPr>
@@ -10076,7 +10076,7 @@
           <p:cNvPr id="7" name="">
             <a:extLst xmlns:a="http://schemas.openxmlformats.org/drawingml/2006/main">
               <a:ext uri="{FF2B5EF4-FFF2-40B4-BE49-F238E27FC236}">
-                <a16:creationId xmlns:a16="http://schemas.microsoft.com/office/drawing/2014/main" id="{1913A72A-4F38-44D7-8785-F785DCDD60C8}"/>
+                <a16:creationId xmlns:a16="http://schemas.microsoft.com/office/drawing/2014/main" id="{5D007601-ABAF-4791-BC88-4D062F39CD21}"/>
               </a:ext>
             </a:extLst>
           </p:cNvPr>
@@ -10109,7 +10109,7 @@
           <p:cNvPr id="8" name="">
             <a:extLst xmlns:a="http://schemas.openxmlformats.org/drawingml/2006/main">
               <a:ext uri="{FF2B5EF4-FFF2-40B4-BE49-F238E27FC236}">
-                <a16:creationId xmlns:a16="http://schemas.microsoft.com/office/drawing/2014/main" id="{F77EECBC-C69B-46BB-B94F-97857EA474BD}"/>
+                <a16:creationId xmlns:a16="http://schemas.microsoft.com/office/drawing/2014/main" id="{931B15FF-8E61-493E-9695-4AC65E226580}"/>
               </a:ext>
             </a:extLst>
           </p:cNvPr>
@@ -10159,7 +10159,7 @@
           <p:cNvPr id="9" name="">
             <a:extLst xmlns:a="http://schemas.openxmlformats.org/drawingml/2006/main">
               <a:ext uri="{FF2B5EF4-FFF2-40B4-BE49-F238E27FC236}">
-                <a16:creationId xmlns:a16="http://schemas.microsoft.com/office/drawing/2014/main" id="{B0B3F447-E978-46DE-AA85-86DA35AACEAC}"/>
+                <a16:creationId xmlns:a16="http://schemas.microsoft.com/office/drawing/2014/main" id="{F2773D0B-10F9-4ED1-9BF8-DC5F8A8E8B8E}"/>
               </a:ext>
             </a:extLst>
           </p:cNvPr>
@@ -10192,7 +10192,7 @@
           <p:cNvPr id="10" name="">
             <a:extLst xmlns:a="http://schemas.openxmlformats.org/drawingml/2006/main">
               <a:ext uri="{FF2B5EF4-FFF2-40B4-BE49-F238E27FC236}">
-                <a16:creationId xmlns:a16="http://schemas.microsoft.com/office/drawing/2014/main" id="{5980D4E1-AB6A-427B-96A6-352F614CA05C}"/>
+                <a16:creationId xmlns:a16="http://schemas.microsoft.com/office/drawing/2014/main" id="{43540587-D4AD-4164-9B35-F1C9B3CE84B1}"/>
               </a:ext>
             </a:extLst>
           </p:cNvPr>
@@ -10242,7 +10242,7 @@
           <p:cNvPr id="11" name="">
             <a:extLst xmlns:a="http://schemas.openxmlformats.org/drawingml/2006/main">
               <a:ext uri="{FF2B5EF4-FFF2-40B4-BE49-F238E27FC236}">
-                <a16:creationId xmlns:a16="http://schemas.microsoft.com/office/drawing/2014/main" id="{DBED8D17-4FE2-4CE3-BC72-A89D2AC2CB0C}"/>
+                <a16:creationId xmlns:a16="http://schemas.microsoft.com/office/drawing/2014/main" id="{4D591401-8FB8-4A92-A010-509F45EDD617}"/>
               </a:ext>
             </a:extLst>
           </p:cNvPr>
@@ -10275,7 +10275,7 @@
           <p:cNvPr id="12" name="">
             <a:extLst xmlns:a="http://schemas.openxmlformats.org/drawingml/2006/main">
               <a:ext uri="{FF2B5EF4-FFF2-40B4-BE49-F238E27FC236}">
-                <a16:creationId xmlns:a16="http://schemas.microsoft.com/office/drawing/2014/main" id="{E97DE3A3-D7B5-4749-B12D-FEC424B83D79}"/>
+                <a16:creationId xmlns:a16="http://schemas.microsoft.com/office/drawing/2014/main" id="{DA92291C-51B2-4A55-B7A8-1BFBE9806334}"/>
               </a:ext>
             </a:extLst>
           </p:cNvPr>
@@ -10325,7 +10325,7 @@
           <p:cNvPr id="13" name="">
             <a:extLst xmlns:a="http://schemas.openxmlformats.org/drawingml/2006/main">
               <a:ext uri="{FF2B5EF4-FFF2-40B4-BE49-F238E27FC236}">
-                <a16:creationId xmlns:a16="http://schemas.microsoft.com/office/drawing/2014/main" id="{F4075885-4304-4581-B0F1-48A113107253}"/>
+                <a16:creationId xmlns:a16="http://schemas.microsoft.com/office/drawing/2014/main" id="{DD499C0A-EA39-4F8A-A366-3A16C472B3B1}"/>
               </a:ext>
             </a:extLst>
           </p:cNvPr>
@@ -10373,7 +10373,7 @@
     </p:spTree>
     <p:extLst>
       <p:ext uri="{BB962C8B-B14F-4D97-AF65-F5344CB8AC3E}">
-        <p14:creationId xmlns:p14="http://schemas.microsoft.com/office/powerpoint/2010/main" val="1969399617"/>
+        <p14:creationId xmlns:p14="http://schemas.microsoft.com/office/powerpoint/2010/main" val="1758097167"/>
       </p:ext>
     </p:extLst>
   </p:cSld>
@@ -10404,7 +10404,7 @@
           <p:cNvPr id="1" name="">
             <a:extLst xmlns:a="http://schemas.openxmlformats.org/drawingml/2006/main">
               <a:ext uri="{FF2B5EF4-FFF2-40B4-BE49-F238E27FC236}">
-                <a16:creationId xmlns:a16="http://schemas.microsoft.com/office/drawing/2014/main" id="{143373AD-0629-4F48-8449-35D3A7772259}"/>
+                <a16:creationId xmlns:a16="http://schemas.microsoft.com/office/drawing/2014/main" id="{F086239B-8E6B-4E77-8754-7941C2E922CD}"/>
               </a:ext>
             </a:extLst>
           </p:cNvPr>
@@ -10454,7 +10454,7 @@
           <p:cNvPr id="2" name="">
             <a:extLst xmlns:a="http://schemas.openxmlformats.org/drawingml/2006/main">
               <a:ext uri="{FF2B5EF4-FFF2-40B4-BE49-F238E27FC236}">
-                <a16:creationId xmlns:a16="http://schemas.microsoft.com/office/drawing/2014/main" id="{841B2469-B9E7-428C-A374-5948C227F7B7}"/>
+                <a16:creationId xmlns:a16="http://schemas.microsoft.com/office/drawing/2014/main" id="{50F01845-C27E-4F84-BDCE-74D17D751CBA}"/>
               </a:ext>
             </a:extLst>
           </p:cNvPr>
@@ -10504,7 +10504,7 @@
           <p:cNvPr id="3" name="">
             <a:extLst xmlns:a="http://schemas.openxmlformats.org/drawingml/2006/main">
               <a:ext uri="{FF2B5EF4-FFF2-40B4-BE49-F238E27FC236}">
-                <a16:creationId xmlns:a16="http://schemas.microsoft.com/office/drawing/2014/main" id="{5A6ADCDC-8E40-4035-8C0E-C16779D7549F}"/>
+                <a16:creationId xmlns:a16="http://schemas.microsoft.com/office/drawing/2014/main" id="{2AFF044A-95EF-44C3-92A3-B7F06B780486}"/>
               </a:ext>
             </a:extLst>
           </p:cNvPr>
@@ -10537,7 +10537,7 @@
           <p:cNvPr id="4" name="">
             <a:extLst xmlns:a="http://schemas.openxmlformats.org/drawingml/2006/main">
               <a:ext uri="{FF2B5EF4-FFF2-40B4-BE49-F238E27FC236}">
-                <a16:creationId xmlns:a16="http://schemas.microsoft.com/office/drawing/2014/main" id="{0611232D-42DC-4468-ACC8-78D2D0EC5A07}"/>
+                <a16:creationId xmlns:a16="http://schemas.microsoft.com/office/drawing/2014/main" id="{16568D73-AAFD-440D-A3FE-D19042F0B925}"/>
               </a:ext>
             </a:extLst>
           </p:cNvPr>
@@ -10570,7 +10570,7 @@
           <p:cNvPr id="5" name="">
             <a:extLst xmlns:a="http://schemas.openxmlformats.org/drawingml/2006/main">
               <a:ext uri="{FF2B5EF4-FFF2-40B4-BE49-F238E27FC236}">
-                <a16:creationId xmlns:a16="http://schemas.microsoft.com/office/drawing/2014/main" id="{7173DA1A-2C12-4DA9-B673-624606CE1B94}"/>
+                <a16:creationId xmlns:a16="http://schemas.microsoft.com/office/drawing/2014/main" id="{00265C0C-CB28-4E71-B2C6-3F2220E7CCF7}"/>
               </a:ext>
             </a:extLst>
           </p:cNvPr>
@@ -10620,7 +10620,7 @@
           <p:cNvPr id="6" name="">
             <a:extLst xmlns:a="http://schemas.openxmlformats.org/drawingml/2006/main">
               <a:ext uri="{FF2B5EF4-FFF2-40B4-BE49-F238E27FC236}">
-                <a16:creationId xmlns:a16="http://schemas.microsoft.com/office/drawing/2014/main" id="{A55C0850-2B98-4915-8348-27232C1DB213}"/>
+                <a16:creationId xmlns:a16="http://schemas.microsoft.com/office/drawing/2014/main" id="{D2065B1A-A96D-4AD2-A602-A87A63EE36D9}"/>
               </a:ext>
             </a:extLst>
           </p:cNvPr>
@@ -10670,7 +10670,7 @@
           <p:cNvPr id="7" name="">
             <a:extLst xmlns:a="http://schemas.openxmlformats.org/drawingml/2006/main">
               <a:ext uri="{FF2B5EF4-FFF2-40B4-BE49-F238E27FC236}">
-                <a16:creationId xmlns:a16="http://schemas.microsoft.com/office/drawing/2014/main" id="{692BB5D2-8836-4DD2-A06D-7DCFA4B072B6}"/>
+                <a16:creationId xmlns:a16="http://schemas.microsoft.com/office/drawing/2014/main" id="{D4446BD5-C3A1-4B54-BA5A-1753986F1C72}"/>
               </a:ext>
             </a:extLst>
           </p:cNvPr>
@@ -10720,7 +10720,7 @@
           <p:cNvPr id="8" name="">
             <a:extLst xmlns:a="http://schemas.openxmlformats.org/drawingml/2006/main">
               <a:ext uri="{FF2B5EF4-FFF2-40B4-BE49-F238E27FC236}">
-                <a16:creationId xmlns:a16="http://schemas.microsoft.com/office/drawing/2014/main" id="{98A3B8BD-04F8-4B21-80C1-A61C81BEF06F}"/>
+                <a16:creationId xmlns:a16="http://schemas.microsoft.com/office/drawing/2014/main" id="{C6CA1AEA-9512-4081-95A5-430C6B490283}"/>
               </a:ext>
             </a:extLst>
           </p:cNvPr>
@@ -10753,7 +10753,7 @@
           <p:cNvPr id="9" name="">
             <a:extLst xmlns:a="http://schemas.openxmlformats.org/drawingml/2006/main">
               <a:ext uri="{FF2B5EF4-FFF2-40B4-BE49-F238E27FC236}">
-                <a16:creationId xmlns:a16="http://schemas.microsoft.com/office/drawing/2014/main" id="{0196DAF6-6395-4C07-987C-16CC5DCDFEFF}"/>
+                <a16:creationId xmlns:a16="http://schemas.microsoft.com/office/drawing/2014/main" id="{1B078229-FD51-489E-94FD-83D4A54566BA}"/>
               </a:ext>
             </a:extLst>
           </p:cNvPr>
@@ -10803,7 +10803,7 @@
           <p:cNvPr id="10" name="">
             <a:extLst xmlns:a="http://schemas.openxmlformats.org/drawingml/2006/main">
               <a:ext uri="{FF2B5EF4-FFF2-40B4-BE49-F238E27FC236}">
-                <a16:creationId xmlns:a16="http://schemas.microsoft.com/office/drawing/2014/main" id="{8D49B61C-3B1F-43E7-897D-9F4198E1DECA}"/>
+                <a16:creationId xmlns:a16="http://schemas.microsoft.com/office/drawing/2014/main" id="{A2BB7955-9761-477B-B5A7-6805A2F8C4F0}"/>
               </a:ext>
             </a:extLst>
           </p:cNvPr>
@@ -10836,7 +10836,7 @@
           <p:cNvPr id="11" name="">
             <a:extLst xmlns:a="http://schemas.openxmlformats.org/drawingml/2006/main">
               <a:ext uri="{FF2B5EF4-FFF2-40B4-BE49-F238E27FC236}">
-                <a16:creationId xmlns:a16="http://schemas.microsoft.com/office/drawing/2014/main" id="{E0630391-C40F-4335-9C89-F6A14A842C19}"/>
+                <a16:creationId xmlns:a16="http://schemas.microsoft.com/office/drawing/2014/main" id="{8FECCB66-5510-4393-9B32-6EFEF2468140}"/>
               </a:ext>
             </a:extLst>
           </p:cNvPr>
@@ -10886,7 +10886,7 @@
           <p:cNvPr id="12" name="">
             <a:extLst xmlns:a="http://schemas.openxmlformats.org/drawingml/2006/main">
               <a:ext uri="{FF2B5EF4-FFF2-40B4-BE49-F238E27FC236}">
-                <a16:creationId xmlns:a16="http://schemas.microsoft.com/office/drawing/2014/main" id="{8BCA6D06-9D67-4CD4-AA4B-78A28141F6C5}"/>
+                <a16:creationId xmlns:a16="http://schemas.microsoft.com/office/drawing/2014/main" id="{735D1A0C-A8E3-4EA8-8E76-B0E44DA101FD}"/>
               </a:ext>
             </a:extLst>
           </p:cNvPr>
@@ -10919,7 +10919,7 @@
           <p:cNvPr id="13" name="">
             <a:extLst xmlns:a="http://schemas.openxmlformats.org/drawingml/2006/main">
               <a:ext uri="{FF2B5EF4-FFF2-40B4-BE49-F238E27FC236}">
-                <a16:creationId xmlns:a16="http://schemas.microsoft.com/office/drawing/2014/main" id="{A344062C-CB6C-4711-B4D6-FCAAA3F80CDD}"/>
+                <a16:creationId xmlns:a16="http://schemas.microsoft.com/office/drawing/2014/main" id="{BE9F96FB-19D3-43BA-9FB4-36E43D9C879B}"/>
               </a:ext>
             </a:extLst>
           </p:cNvPr>
@@ -10969,7 +10969,7 @@
           <p:cNvPr id="14" name="">
             <a:extLst xmlns:a="http://schemas.openxmlformats.org/drawingml/2006/main">
               <a:ext uri="{FF2B5EF4-FFF2-40B4-BE49-F238E27FC236}">
-                <a16:creationId xmlns:a16="http://schemas.microsoft.com/office/drawing/2014/main" id="{0EA00035-8D6C-4165-9967-9D18DE8403B6}"/>
+                <a16:creationId xmlns:a16="http://schemas.microsoft.com/office/drawing/2014/main" id="{9EDFE978-053C-4270-8DE5-DE13FBDFF16D}"/>
               </a:ext>
             </a:extLst>
           </p:cNvPr>
@@ -11002,7 +11002,7 @@
           <p:cNvPr id="15" name="">
             <a:extLst xmlns:a="http://schemas.openxmlformats.org/drawingml/2006/main">
               <a:ext uri="{FF2B5EF4-FFF2-40B4-BE49-F238E27FC236}">
-                <a16:creationId xmlns:a16="http://schemas.microsoft.com/office/drawing/2014/main" id="{6778701E-B091-45AB-8779-BBEA9BD89CF4}"/>
+                <a16:creationId xmlns:a16="http://schemas.microsoft.com/office/drawing/2014/main" id="{B9D8E54D-2A5A-4329-8BED-7927ACAAF037}"/>
               </a:ext>
             </a:extLst>
           </p:cNvPr>
@@ -11052,7 +11052,7 @@
           <p:cNvPr id="16" name="">
             <a:extLst xmlns:a="http://schemas.openxmlformats.org/drawingml/2006/main">
               <a:ext uri="{FF2B5EF4-FFF2-40B4-BE49-F238E27FC236}">
-                <a16:creationId xmlns:a16="http://schemas.microsoft.com/office/drawing/2014/main" id="{A57A615C-5E72-439A-B046-8E49B9045EA1}"/>
+                <a16:creationId xmlns:a16="http://schemas.microsoft.com/office/drawing/2014/main" id="{E82B016D-CFC9-4FC1-8B13-96829823703A}"/>
               </a:ext>
             </a:extLst>
           </p:cNvPr>
@@ -11100,7 +11100,7 @@
     </p:spTree>
     <p:extLst>
       <p:ext uri="{BB962C8B-B14F-4D97-AF65-F5344CB8AC3E}">
-        <p14:creationId xmlns:p14="http://schemas.microsoft.com/office/powerpoint/2010/main" val="817684311"/>
+        <p14:creationId xmlns:p14="http://schemas.microsoft.com/office/powerpoint/2010/main" val="1755761607"/>
       </p:ext>
     </p:extLst>
   </p:cSld>

</xml_diff>